<commit_message>
docs: rebuild final defense deck
</commit_message>
<xml_diff>
--- a/output/presentation/gridguard-khartoum-defense.pptx
+++ b/output/presentation/gridguard-khartoum-defense.pptx
@@ -201,7 +201,7 @@
             </a:lvl1pPr>
           </a:lstStyle>
           <a:p>
-            <a:fld id="{E5BC9F3C-F1A4-4EFD-87B5-9B87CE447CCC}" type="datetimeFigureOut">
+            <a:fld id="{E1E73821-90AC-44F2-90FB-25C32752FA9F}" type="datetimeFigureOut">
               <a:rPr lang="en-US" smtClean="0"/>
               <a:t>8/15/2026</a:t>
             </a:fld>
@@ -359,7 +359,7 @@
             </a:lvl1pPr>
           </a:lstStyle>
           <a:p>
-            <a:fld id="{42F327ED-D5CA-4DDC-A923-53307636CE6D}" type="slidenum">
+            <a:fld id="{93C4D004-1548-4EB6-8774-9EB7120B6AF5}" type="slidenum">
               <a:rPr lang="en-US" smtClean="0"/>
               <a:t>‹#›</a:t>
             </a:fld>
@@ -370,7 +370,7 @@
     </p:spTree>
     <p:extLst>
       <p:ext uri="{BB962C8B-B14F-4D97-AF65-F5344CB8AC3E}">
-        <p14:creationId xmlns:p14="http://schemas.microsoft.com/office/powerpoint/2010/main" val="3772615148"/>
+        <p14:creationId xmlns:p14="http://schemas.microsoft.com/office/powerpoint/2010/main" val="3962194915"/>
       </p:ext>
     </p:extLst>
   </p:cSld>
@@ -563,7 +563,7 @@
           <a:bodyPr/>
           <a:lstStyle/>
           <a:p>
-            <a:fld id="{42F327ED-D5CA-4DDC-A923-53307636CE6D}" type="slidenum">
+            <a:fld id="{93C4D004-1548-4EB6-8774-9EB7120B6AF5}" type="slidenum">
               <a:rPr lang="en-US" smtClean="0"/>
               <a:t>1</a:t>
             </a:fld>
@@ -574,7 +574,7 @@
     </p:spTree>
     <p:extLst>
       <p:ext uri="{BB962C8B-B14F-4D97-AF65-F5344CB8AC3E}">
-        <p14:creationId xmlns:p14="http://schemas.microsoft.com/office/powerpoint/2010/main" val="938657457"/>
+        <p14:creationId xmlns:p14="http://schemas.microsoft.com/office/powerpoint/2010/main" val="3170253303"/>
       </p:ext>
     </p:extLst>
   </p:cSld>
@@ -677,7 +677,7 @@
           <a:bodyPr/>
           <a:lstStyle/>
           <a:p>
-            <a:fld id="{42F327ED-D5CA-4DDC-A923-53307636CE6D}" type="slidenum">
+            <a:fld id="{93C4D004-1548-4EB6-8774-9EB7120B6AF5}" type="slidenum">
               <a:rPr lang="en-US" smtClean="0"/>
               <a:t>10</a:t>
             </a:fld>
@@ -688,7 +688,7 @@
     </p:spTree>
     <p:extLst>
       <p:ext uri="{BB962C8B-B14F-4D97-AF65-F5344CB8AC3E}">
-        <p14:creationId xmlns:p14="http://schemas.microsoft.com/office/powerpoint/2010/main" val="1952542418"/>
+        <p14:creationId xmlns:p14="http://schemas.microsoft.com/office/powerpoint/2010/main" val="3752831687"/>
       </p:ext>
     </p:extLst>
   </p:cSld>
@@ -791,7 +791,7 @@
           <a:bodyPr/>
           <a:lstStyle/>
           <a:p>
-            <a:fld id="{42F327ED-D5CA-4DDC-A923-53307636CE6D}" type="slidenum">
+            <a:fld id="{93C4D004-1548-4EB6-8774-9EB7120B6AF5}" type="slidenum">
               <a:rPr lang="en-US" smtClean="0"/>
               <a:t>11</a:t>
             </a:fld>
@@ -802,7 +802,7 @@
     </p:spTree>
     <p:extLst>
       <p:ext uri="{BB962C8B-B14F-4D97-AF65-F5344CB8AC3E}">
-        <p14:creationId xmlns:p14="http://schemas.microsoft.com/office/powerpoint/2010/main" val="1066904376"/>
+        <p14:creationId xmlns:p14="http://schemas.microsoft.com/office/powerpoint/2010/main" val="2802638319"/>
       </p:ext>
     </p:extLst>
   </p:cSld>
@@ -905,7 +905,7 @@
           <a:bodyPr/>
           <a:lstStyle/>
           <a:p>
-            <a:fld id="{42F327ED-D5CA-4DDC-A923-53307636CE6D}" type="slidenum">
+            <a:fld id="{93C4D004-1548-4EB6-8774-9EB7120B6AF5}" type="slidenum">
               <a:rPr lang="en-US" smtClean="0"/>
               <a:t>12</a:t>
             </a:fld>
@@ -916,7 +916,7 @@
     </p:spTree>
     <p:extLst>
       <p:ext uri="{BB962C8B-B14F-4D97-AF65-F5344CB8AC3E}">
-        <p14:creationId xmlns:p14="http://schemas.microsoft.com/office/powerpoint/2010/main" val="1463370610"/>
+        <p14:creationId xmlns:p14="http://schemas.microsoft.com/office/powerpoint/2010/main" val="1319429176"/>
       </p:ext>
     </p:extLst>
   </p:cSld>
@@ -972,7 +972,7 @@
           <a:p>
             <a:r>
               <a:rPr lang="en-US"/>
-              <a:t>Frame the problem as constrained allocation, not a claim that the simulator models the full electrical network. The schematic provides presentation context only.</a:t>
+              <a:t>Frame the problem as constrained allocation, not a claim that the simulator models the full electrical network. The administrative boundaries provide presentation context only.</a:t>
             </a:r>
           </a:p>
           <a:p>
@@ -1019,7 +1019,7 @@
           <a:bodyPr/>
           <a:lstStyle/>
           <a:p>
-            <a:fld id="{42F327ED-D5CA-4DDC-A923-53307636CE6D}" type="slidenum">
+            <a:fld id="{93C4D004-1548-4EB6-8774-9EB7120B6AF5}" type="slidenum">
               <a:rPr lang="en-US" smtClean="0"/>
               <a:t>2</a:t>
             </a:fld>
@@ -1030,7 +1030,7 @@
     </p:spTree>
     <p:extLst>
       <p:ext uri="{BB962C8B-B14F-4D97-AF65-F5344CB8AC3E}">
-        <p14:creationId xmlns:p14="http://schemas.microsoft.com/office/powerpoint/2010/main" val="4093435578"/>
+        <p14:creationId xmlns:p14="http://schemas.microsoft.com/office/powerpoint/2010/main" val="3051992"/>
       </p:ext>
     </p:extLst>
   </p:cSld>
@@ -1133,7 +1133,7 @@
           <a:bodyPr/>
           <a:lstStyle/>
           <a:p>
-            <a:fld id="{42F327ED-D5CA-4DDC-A923-53307636CE6D}" type="slidenum">
+            <a:fld id="{93C4D004-1548-4EB6-8774-9EB7120B6AF5}" type="slidenum">
               <a:rPr lang="en-US" smtClean="0"/>
               <a:t>3</a:t>
             </a:fld>
@@ -1144,7 +1144,7 @@
     </p:spTree>
     <p:extLst>
       <p:ext uri="{BB962C8B-B14F-4D97-AF65-F5344CB8AC3E}">
-        <p14:creationId xmlns:p14="http://schemas.microsoft.com/office/powerpoint/2010/main" val="1301691956"/>
+        <p14:creationId xmlns:p14="http://schemas.microsoft.com/office/powerpoint/2010/main" val="1482732293"/>
       </p:ext>
     </p:extLst>
   </p:cSld>
@@ -1247,7 +1247,7 @@
           <a:bodyPr/>
           <a:lstStyle/>
           <a:p>
-            <a:fld id="{42F327ED-D5CA-4DDC-A923-53307636CE6D}" type="slidenum">
+            <a:fld id="{93C4D004-1548-4EB6-8774-9EB7120B6AF5}" type="slidenum">
               <a:rPr lang="en-US" smtClean="0"/>
               <a:t>4</a:t>
             </a:fld>
@@ -1258,7 +1258,7 @@
     </p:spTree>
     <p:extLst>
       <p:ext uri="{BB962C8B-B14F-4D97-AF65-F5344CB8AC3E}">
-        <p14:creationId xmlns:p14="http://schemas.microsoft.com/office/powerpoint/2010/main" val="1102416185"/>
+        <p14:creationId xmlns:p14="http://schemas.microsoft.com/office/powerpoint/2010/main" val="2387347565"/>
       </p:ext>
     </p:extLst>
   </p:cSld>
@@ -1361,7 +1361,7 @@
           <a:bodyPr/>
           <a:lstStyle/>
           <a:p>
-            <a:fld id="{42F327ED-D5CA-4DDC-A923-53307636CE6D}" type="slidenum">
+            <a:fld id="{93C4D004-1548-4EB6-8774-9EB7120B6AF5}" type="slidenum">
               <a:rPr lang="en-US" smtClean="0"/>
               <a:t>5</a:t>
             </a:fld>
@@ -1372,7 +1372,7 @@
     </p:spTree>
     <p:extLst>
       <p:ext uri="{BB962C8B-B14F-4D97-AF65-F5344CB8AC3E}">
-        <p14:creationId xmlns:p14="http://schemas.microsoft.com/office/powerpoint/2010/main" val="1253334134"/>
+        <p14:creationId xmlns:p14="http://schemas.microsoft.com/office/powerpoint/2010/main" val="1259643484"/>
       </p:ext>
     </p:extLst>
   </p:cSld>
@@ -1475,7 +1475,7 @@
           <a:bodyPr/>
           <a:lstStyle/>
           <a:p>
-            <a:fld id="{42F327ED-D5CA-4DDC-A923-53307636CE6D}" type="slidenum">
+            <a:fld id="{93C4D004-1548-4EB6-8774-9EB7120B6AF5}" type="slidenum">
               <a:rPr lang="en-US" smtClean="0"/>
               <a:t>6</a:t>
             </a:fld>
@@ -1486,7 +1486,7 @@
     </p:spTree>
     <p:extLst>
       <p:ext uri="{BB962C8B-B14F-4D97-AF65-F5344CB8AC3E}">
-        <p14:creationId xmlns:p14="http://schemas.microsoft.com/office/powerpoint/2010/main" val="977524514"/>
+        <p14:creationId xmlns:p14="http://schemas.microsoft.com/office/powerpoint/2010/main" val="4047169919"/>
       </p:ext>
     </p:extLst>
   </p:cSld>
@@ -1589,7 +1589,7 @@
           <a:bodyPr/>
           <a:lstStyle/>
           <a:p>
-            <a:fld id="{42F327ED-D5CA-4DDC-A923-53307636CE6D}" type="slidenum">
+            <a:fld id="{93C4D004-1548-4EB6-8774-9EB7120B6AF5}" type="slidenum">
               <a:rPr lang="en-US" smtClean="0"/>
               <a:t>7</a:t>
             </a:fld>
@@ -1600,7 +1600,7 @@
     </p:spTree>
     <p:extLst>
       <p:ext uri="{BB962C8B-B14F-4D97-AF65-F5344CB8AC3E}">
-        <p14:creationId xmlns:p14="http://schemas.microsoft.com/office/powerpoint/2010/main" val="1350789148"/>
+        <p14:creationId xmlns:p14="http://schemas.microsoft.com/office/powerpoint/2010/main" val="4155239300"/>
       </p:ext>
     </p:extLst>
   </p:cSld>
@@ -1703,7 +1703,7 @@
           <a:bodyPr/>
           <a:lstStyle/>
           <a:p>
-            <a:fld id="{42F327ED-D5CA-4DDC-A923-53307636CE6D}" type="slidenum">
+            <a:fld id="{93C4D004-1548-4EB6-8774-9EB7120B6AF5}" type="slidenum">
               <a:rPr lang="en-US" smtClean="0"/>
               <a:t>8</a:t>
             </a:fld>
@@ -1714,7 +1714,7 @@
     </p:spTree>
     <p:extLst>
       <p:ext uri="{BB962C8B-B14F-4D97-AF65-F5344CB8AC3E}">
-        <p14:creationId xmlns:p14="http://schemas.microsoft.com/office/powerpoint/2010/main" val="3002232095"/>
+        <p14:creationId xmlns:p14="http://schemas.microsoft.com/office/powerpoint/2010/main" val="3078306783"/>
       </p:ext>
     </p:extLst>
   </p:cSld>
@@ -1823,7 +1823,7 @@
           <a:bodyPr/>
           <a:lstStyle/>
           <a:p>
-            <a:fld id="{42F327ED-D5CA-4DDC-A923-53307636CE6D}" type="slidenum">
+            <a:fld id="{93C4D004-1548-4EB6-8774-9EB7120B6AF5}" type="slidenum">
               <a:rPr lang="en-US" smtClean="0"/>
               <a:t>9</a:t>
             </a:fld>
@@ -1834,7 +1834,7 @@
     </p:spTree>
     <p:extLst>
       <p:ext uri="{BB962C8B-B14F-4D97-AF65-F5344CB8AC3E}">
-        <p14:creationId xmlns:p14="http://schemas.microsoft.com/office/powerpoint/2010/main" val="381475348"/>
+        <p14:creationId xmlns:p14="http://schemas.microsoft.com/office/powerpoint/2010/main" val="259827226"/>
       </p:ext>
     </p:extLst>
   </p:cSld>
@@ -1866,7 +1866,7 @@
           <p:cNvPr id="2" name="Title 1">
             <a:extLst>
               <a:ext uri="{FF2B5EF4-FFF2-40B4-BE49-F238E27FC236}">
-                <a16:creationId xmlns:a16="http://schemas.microsoft.com/office/drawing/2014/main" id="{7DE16C23-9643-9461-BA6D-DE93861A1004}"/>
+                <a16:creationId xmlns:a16="http://schemas.microsoft.com/office/drawing/2014/main" id="{E94DAAEE-3E9B-BB37-A52D-F0382C4AE3B5}"/>
               </a:ext>
             </a:extLst>
           </p:cNvPr>
@@ -1903,7 +1903,7 @@
           <p:cNvPr id="3" name="Subtitle 2">
             <a:extLst>
               <a:ext uri="{FF2B5EF4-FFF2-40B4-BE49-F238E27FC236}">
-                <a16:creationId xmlns:a16="http://schemas.microsoft.com/office/drawing/2014/main" id="{192EE971-8694-5190-94E5-FF530560C112}"/>
+                <a16:creationId xmlns:a16="http://schemas.microsoft.com/office/drawing/2014/main" id="{B04E5F6D-EB39-2D57-4647-001E25F344FD}"/>
               </a:ext>
             </a:extLst>
           </p:cNvPr>
@@ -1973,7 +1973,7 @@
           <p:cNvPr id="4" name="Date Placeholder 3">
             <a:extLst>
               <a:ext uri="{FF2B5EF4-FFF2-40B4-BE49-F238E27FC236}">
-                <a16:creationId xmlns:a16="http://schemas.microsoft.com/office/drawing/2014/main" id="{20597989-C180-39CA-9A0B-1D2D9123927E}"/>
+                <a16:creationId xmlns:a16="http://schemas.microsoft.com/office/drawing/2014/main" id="{117D7803-071E-F93E-A23C-5CAA299518D3}"/>
               </a:ext>
             </a:extLst>
           </p:cNvPr>
@@ -1989,7 +1989,7 @@
           <a:bodyPr/>
           <a:lstStyle/>
           <a:p>
-            <a:fld id="{44D40E14-F31D-43C6-995C-1BC509075025}" type="datetimeFigureOut">
+            <a:fld id="{DE1BE91F-0B33-40E3-9AB7-59DD5EB738EA}" type="datetimeFigureOut">
               <a:rPr lang="en-US" smtClean="0"/>
               <a:t>8/15/2026</a:t>
             </a:fld>
@@ -2002,7 +2002,7 @@
           <p:cNvPr id="5" name="Footer Placeholder 4">
             <a:extLst>
               <a:ext uri="{FF2B5EF4-FFF2-40B4-BE49-F238E27FC236}">
-                <a16:creationId xmlns:a16="http://schemas.microsoft.com/office/drawing/2014/main" id="{A16FC105-F4CE-6A12-66AC-5B7A7AED3DFA}"/>
+                <a16:creationId xmlns:a16="http://schemas.microsoft.com/office/drawing/2014/main" id="{77DD6AA3-A34E-AB6D-3758-F9D9FDBEBBE7}"/>
               </a:ext>
             </a:extLst>
           </p:cNvPr>
@@ -2027,7 +2027,7 @@
           <p:cNvPr id="6" name="Slide Number Placeholder 5">
             <a:extLst>
               <a:ext uri="{FF2B5EF4-FFF2-40B4-BE49-F238E27FC236}">
-                <a16:creationId xmlns:a16="http://schemas.microsoft.com/office/drawing/2014/main" id="{059C6001-FC28-8388-319C-55C12070D669}"/>
+                <a16:creationId xmlns:a16="http://schemas.microsoft.com/office/drawing/2014/main" id="{38AF3683-6EF1-6E13-16E2-1BB82485F724}"/>
               </a:ext>
             </a:extLst>
           </p:cNvPr>
@@ -2043,7 +2043,7 @@
           <a:bodyPr/>
           <a:lstStyle/>
           <a:p>
-            <a:fld id="{A21E5D25-B7F4-4053-A13F-9DB9FA4E435A}" type="slidenum">
+            <a:fld id="{EEB070CA-7418-40FB-A3DF-DA5FA69D9337}" type="slidenum">
               <a:rPr lang="en-US" smtClean="0"/>
               <a:t>‹#›</a:t>
             </a:fld>
@@ -2054,7 +2054,7 @@
     </p:spTree>
     <p:extLst>
       <p:ext uri="{BB962C8B-B14F-4D97-AF65-F5344CB8AC3E}">
-        <p14:creationId xmlns:p14="http://schemas.microsoft.com/office/powerpoint/2010/main" val="2673610725"/>
+        <p14:creationId xmlns:p14="http://schemas.microsoft.com/office/powerpoint/2010/main" val="3196435322"/>
       </p:ext>
     </p:extLst>
   </p:cSld>
@@ -2086,7 +2086,7 @@
           <p:cNvPr id="2" name="Title 1">
             <a:extLst>
               <a:ext uri="{FF2B5EF4-FFF2-40B4-BE49-F238E27FC236}">
-                <a16:creationId xmlns:a16="http://schemas.microsoft.com/office/drawing/2014/main" id="{2EB28B19-8A9F-1622-DC28-7C0364C17C5C}"/>
+                <a16:creationId xmlns:a16="http://schemas.microsoft.com/office/drawing/2014/main" id="{7B328D76-3546-EDC5-8E8F-592AC36006AE}"/>
               </a:ext>
             </a:extLst>
           </p:cNvPr>
@@ -2114,7 +2114,7 @@
           <p:cNvPr id="3" name="Vertical Text Placeholder 2">
             <a:extLst>
               <a:ext uri="{FF2B5EF4-FFF2-40B4-BE49-F238E27FC236}">
-                <a16:creationId xmlns:a16="http://schemas.microsoft.com/office/drawing/2014/main" id="{6BE6FDD3-0D57-36A8-C9A4-24C46B90A937}"/>
+                <a16:creationId xmlns:a16="http://schemas.microsoft.com/office/drawing/2014/main" id="{AB138E54-191D-B7A5-F2B7-5A50FA240E2B}"/>
               </a:ext>
             </a:extLst>
           </p:cNvPr>
@@ -2171,7 +2171,7 @@
           <p:cNvPr id="4" name="Date Placeholder 3">
             <a:extLst>
               <a:ext uri="{FF2B5EF4-FFF2-40B4-BE49-F238E27FC236}">
-                <a16:creationId xmlns:a16="http://schemas.microsoft.com/office/drawing/2014/main" id="{15D4ED4F-4B1C-7C3B-6431-5E842453FFD3}"/>
+                <a16:creationId xmlns:a16="http://schemas.microsoft.com/office/drawing/2014/main" id="{ECCE0410-E761-38DB-DA91-B3A6A1E4D348}"/>
               </a:ext>
             </a:extLst>
           </p:cNvPr>
@@ -2187,7 +2187,7 @@
           <a:bodyPr/>
           <a:lstStyle/>
           <a:p>
-            <a:fld id="{44D40E14-F31D-43C6-995C-1BC509075025}" type="datetimeFigureOut">
+            <a:fld id="{DE1BE91F-0B33-40E3-9AB7-59DD5EB738EA}" type="datetimeFigureOut">
               <a:rPr lang="en-US" smtClean="0"/>
               <a:t>8/15/2026</a:t>
             </a:fld>
@@ -2200,7 +2200,7 @@
           <p:cNvPr id="5" name="Footer Placeholder 4">
             <a:extLst>
               <a:ext uri="{FF2B5EF4-FFF2-40B4-BE49-F238E27FC236}">
-                <a16:creationId xmlns:a16="http://schemas.microsoft.com/office/drawing/2014/main" id="{96BC3C62-23BF-5387-9AEC-961C59DD1D9A}"/>
+                <a16:creationId xmlns:a16="http://schemas.microsoft.com/office/drawing/2014/main" id="{C746E832-CF7A-8F7F-462B-CDA9BFBD9895}"/>
               </a:ext>
             </a:extLst>
           </p:cNvPr>
@@ -2225,7 +2225,7 @@
           <p:cNvPr id="6" name="Slide Number Placeholder 5">
             <a:extLst>
               <a:ext uri="{FF2B5EF4-FFF2-40B4-BE49-F238E27FC236}">
-                <a16:creationId xmlns:a16="http://schemas.microsoft.com/office/drawing/2014/main" id="{DD0EA171-E297-2B98-BC20-253F14597AAD}"/>
+                <a16:creationId xmlns:a16="http://schemas.microsoft.com/office/drawing/2014/main" id="{8C2F5E47-533F-DCF6-7FFB-03E48CF5648D}"/>
               </a:ext>
             </a:extLst>
           </p:cNvPr>
@@ -2241,7 +2241,7 @@
           <a:bodyPr/>
           <a:lstStyle/>
           <a:p>
-            <a:fld id="{A21E5D25-B7F4-4053-A13F-9DB9FA4E435A}" type="slidenum">
+            <a:fld id="{EEB070CA-7418-40FB-A3DF-DA5FA69D9337}" type="slidenum">
               <a:rPr lang="en-US" smtClean="0"/>
               <a:t>‹#›</a:t>
             </a:fld>
@@ -2252,7 +2252,7 @@
     </p:spTree>
     <p:extLst>
       <p:ext uri="{BB962C8B-B14F-4D97-AF65-F5344CB8AC3E}">
-        <p14:creationId xmlns:p14="http://schemas.microsoft.com/office/powerpoint/2010/main" val="146698803"/>
+        <p14:creationId xmlns:p14="http://schemas.microsoft.com/office/powerpoint/2010/main" val="1493148300"/>
       </p:ext>
     </p:extLst>
   </p:cSld>
@@ -2284,7 +2284,7 @@
           <p:cNvPr id="2" name="Vertical Title 1">
             <a:extLst>
               <a:ext uri="{FF2B5EF4-FFF2-40B4-BE49-F238E27FC236}">
-                <a16:creationId xmlns:a16="http://schemas.microsoft.com/office/drawing/2014/main" id="{7C233E37-FD7F-5821-1B09-77DC9262C731}"/>
+                <a16:creationId xmlns:a16="http://schemas.microsoft.com/office/drawing/2014/main" id="{129A2B0F-F6DF-3734-B15E-E0B3A5C6092E}"/>
               </a:ext>
             </a:extLst>
           </p:cNvPr>
@@ -2317,7 +2317,7 @@
           <p:cNvPr id="3" name="Vertical Text Placeholder 2">
             <a:extLst>
               <a:ext uri="{FF2B5EF4-FFF2-40B4-BE49-F238E27FC236}">
-                <a16:creationId xmlns:a16="http://schemas.microsoft.com/office/drawing/2014/main" id="{D979C689-DB8B-5E64-EBEF-B02D8B6CEA15}"/>
+                <a16:creationId xmlns:a16="http://schemas.microsoft.com/office/drawing/2014/main" id="{BF48718A-88DF-4F9F-415F-0C7EF53CE7D4}"/>
               </a:ext>
             </a:extLst>
           </p:cNvPr>
@@ -2379,7 +2379,7 @@
           <p:cNvPr id="4" name="Date Placeholder 3">
             <a:extLst>
               <a:ext uri="{FF2B5EF4-FFF2-40B4-BE49-F238E27FC236}">
-                <a16:creationId xmlns:a16="http://schemas.microsoft.com/office/drawing/2014/main" id="{D189F440-0068-C593-28F5-EB66AEEC7A64}"/>
+                <a16:creationId xmlns:a16="http://schemas.microsoft.com/office/drawing/2014/main" id="{E48856A5-CA89-9A96-3DD3-10BC8FCB6627}"/>
               </a:ext>
             </a:extLst>
           </p:cNvPr>
@@ -2395,7 +2395,7 @@
           <a:bodyPr/>
           <a:lstStyle/>
           <a:p>
-            <a:fld id="{44D40E14-F31D-43C6-995C-1BC509075025}" type="datetimeFigureOut">
+            <a:fld id="{DE1BE91F-0B33-40E3-9AB7-59DD5EB738EA}" type="datetimeFigureOut">
               <a:rPr lang="en-US" smtClean="0"/>
               <a:t>8/15/2026</a:t>
             </a:fld>
@@ -2408,7 +2408,7 @@
           <p:cNvPr id="5" name="Footer Placeholder 4">
             <a:extLst>
               <a:ext uri="{FF2B5EF4-FFF2-40B4-BE49-F238E27FC236}">
-                <a16:creationId xmlns:a16="http://schemas.microsoft.com/office/drawing/2014/main" id="{B8C9E9D3-ABB3-79E8-CC0E-887A1801A984}"/>
+                <a16:creationId xmlns:a16="http://schemas.microsoft.com/office/drawing/2014/main" id="{84757B04-8A3D-0C8B-CA06-675AE2BBD87A}"/>
               </a:ext>
             </a:extLst>
           </p:cNvPr>
@@ -2433,7 +2433,7 @@
           <p:cNvPr id="6" name="Slide Number Placeholder 5">
             <a:extLst>
               <a:ext uri="{FF2B5EF4-FFF2-40B4-BE49-F238E27FC236}">
-                <a16:creationId xmlns:a16="http://schemas.microsoft.com/office/drawing/2014/main" id="{A9DEE742-4155-C204-B6EF-003F7C8D0799}"/>
+                <a16:creationId xmlns:a16="http://schemas.microsoft.com/office/drawing/2014/main" id="{16EF372E-6AAC-216B-FF9B-69264C40E031}"/>
               </a:ext>
             </a:extLst>
           </p:cNvPr>
@@ -2449,7 +2449,7 @@
           <a:bodyPr/>
           <a:lstStyle/>
           <a:p>
-            <a:fld id="{A21E5D25-B7F4-4053-A13F-9DB9FA4E435A}" type="slidenum">
+            <a:fld id="{EEB070CA-7418-40FB-A3DF-DA5FA69D9337}" type="slidenum">
               <a:rPr lang="en-US" smtClean="0"/>
               <a:t>‹#›</a:t>
             </a:fld>
@@ -2460,7 +2460,7 @@
     </p:spTree>
     <p:extLst>
       <p:ext uri="{BB962C8B-B14F-4D97-AF65-F5344CB8AC3E}">
-        <p14:creationId xmlns:p14="http://schemas.microsoft.com/office/powerpoint/2010/main" val="4220687256"/>
+        <p14:creationId xmlns:p14="http://schemas.microsoft.com/office/powerpoint/2010/main" val="346683214"/>
       </p:ext>
     </p:extLst>
   </p:cSld>
@@ -2492,7 +2492,7 @@
           <p:cNvPr id="2" name="Title 1">
             <a:extLst>
               <a:ext uri="{FF2B5EF4-FFF2-40B4-BE49-F238E27FC236}">
-                <a16:creationId xmlns:a16="http://schemas.microsoft.com/office/drawing/2014/main" id="{438C9838-B091-2EFD-C08E-1CEBD4C7E254}"/>
+                <a16:creationId xmlns:a16="http://schemas.microsoft.com/office/drawing/2014/main" id="{0238E199-E062-8A9C-F134-135835D5207D}"/>
               </a:ext>
             </a:extLst>
           </p:cNvPr>
@@ -2520,7 +2520,7 @@
           <p:cNvPr id="3" name="Content Placeholder 2">
             <a:extLst>
               <a:ext uri="{FF2B5EF4-FFF2-40B4-BE49-F238E27FC236}">
-                <a16:creationId xmlns:a16="http://schemas.microsoft.com/office/drawing/2014/main" id="{0E2A7DA3-8F13-147F-8AF3-A2A06DECE6FD}"/>
+                <a16:creationId xmlns:a16="http://schemas.microsoft.com/office/drawing/2014/main" id="{B5C51FDA-9584-0188-FA69-ED43D99D28DB}"/>
               </a:ext>
             </a:extLst>
           </p:cNvPr>
@@ -2577,7 +2577,7 @@
           <p:cNvPr id="4" name="Date Placeholder 3">
             <a:extLst>
               <a:ext uri="{FF2B5EF4-FFF2-40B4-BE49-F238E27FC236}">
-                <a16:creationId xmlns:a16="http://schemas.microsoft.com/office/drawing/2014/main" id="{0669052F-BB8D-54ED-2C33-A4D162E08EF5}"/>
+                <a16:creationId xmlns:a16="http://schemas.microsoft.com/office/drawing/2014/main" id="{560791EB-24E5-1545-91FA-1648BA93172E}"/>
               </a:ext>
             </a:extLst>
           </p:cNvPr>
@@ -2593,7 +2593,7 @@
           <a:bodyPr/>
           <a:lstStyle/>
           <a:p>
-            <a:fld id="{44D40E14-F31D-43C6-995C-1BC509075025}" type="datetimeFigureOut">
+            <a:fld id="{DE1BE91F-0B33-40E3-9AB7-59DD5EB738EA}" type="datetimeFigureOut">
               <a:rPr lang="en-US" smtClean="0"/>
               <a:t>8/15/2026</a:t>
             </a:fld>
@@ -2606,7 +2606,7 @@
           <p:cNvPr id="5" name="Footer Placeholder 4">
             <a:extLst>
               <a:ext uri="{FF2B5EF4-FFF2-40B4-BE49-F238E27FC236}">
-                <a16:creationId xmlns:a16="http://schemas.microsoft.com/office/drawing/2014/main" id="{89EAC5F3-0813-17BD-F4A7-3123EF74E0AC}"/>
+                <a16:creationId xmlns:a16="http://schemas.microsoft.com/office/drawing/2014/main" id="{74ABAFFD-DBD5-74CE-9FAA-011E900F3994}"/>
               </a:ext>
             </a:extLst>
           </p:cNvPr>
@@ -2631,7 +2631,7 @@
           <p:cNvPr id="6" name="Slide Number Placeholder 5">
             <a:extLst>
               <a:ext uri="{FF2B5EF4-FFF2-40B4-BE49-F238E27FC236}">
-                <a16:creationId xmlns:a16="http://schemas.microsoft.com/office/drawing/2014/main" id="{1E011E0C-457A-76FE-F023-15A1545A6AA6}"/>
+                <a16:creationId xmlns:a16="http://schemas.microsoft.com/office/drawing/2014/main" id="{86097B2B-2B0A-9F5A-8631-1B43883DD8FC}"/>
               </a:ext>
             </a:extLst>
           </p:cNvPr>
@@ -2647,7 +2647,7 @@
           <a:bodyPr/>
           <a:lstStyle/>
           <a:p>
-            <a:fld id="{A21E5D25-B7F4-4053-A13F-9DB9FA4E435A}" type="slidenum">
+            <a:fld id="{EEB070CA-7418-40FB-A3DF-DA5FA69D9337}" type="slidenum">
               <a:rPr lang="en-US" smtClean="0"/>
               <a:t>‹#›</a:t>
             </a:fld>
@@ -2658,7 +2658,7 @@
     </p:spTree>
     <p:extLst>
       <p:ext uri="{BB962C8B-B14F-4D97-AF65-F5344CB8AC3E}">
-        <p14:creationId xmlns:p14="http://schemas.microsoft.com/office/powerpoint/2010/main" val="3209732419"/>
+        <p14:creationId xmlns:p14="http://schemas.microsoft.com/office/powerpoint/2010/main" val="1731971133"/>
       </p:ext>
     </p:extLst>
   </p:cSld>
@@ -2690,7 +2690,7 @@
           <p:cNvPr id="2" name="Title 1">
             <a:extLst>
               <a:ext uri="{FF2B5EF4-FFF2-40B4-BE49-F238E27FC236}">
-                <a16:creationId xmlns:a16="http://schemas.microsoft.com/office/drawing/2014/main" id="{929A2EEF-AA17-4475-24D7-552E4A2D23A4}"/>
+                <a16:creationId xmlns:a16="http://schemas.microsoft.com/office/drawing/2014/main" id="{2BAF1943-81A3-F055-43D1-16E8A17DA039}"/>
               </a:ext>
             </a:extLst>
           </p:cNvPr>
@@ -2727,7 +2727,7 @@
           <p:cNvPr id="3" name="Text Placeholder 2">
             <a:extLst>
               <a:ext uri="{FF2B5EF4-FFF2-40B4-BE49-F238E27FC236}">
-                <a16:creationId xmlns:a16="http://schemas.microsoft.com/office/drawing/2014/main" id="{28764158-780B-9115-4AB1-0FCB7446A9E6}"/>
+                <a16:creationId xmlns:a16="http://schemas.microsoft.com/office/drawing/2014/main" id="{AFAF6550-3A59-98A1-7976-BBBB8CDE62B8}"/>
               </a:ext>
             </a:extLst>
           </p:cNvPr>
@@ -2852,7 +2852,7 @@
           <p:cNvPr id="4" name="Date Placeholder 3">
             <a:extLst>
               <a:ext uri="{FF2B5EF4-FFF2-40B4-BE49-F238E27FC236}">
-                <a16:creationId xmlns:a16="http://schemas.microsoft.com/office/drawing/2014/main" id="{9259CA4A-ACDD-87A7-77E5-15ECA0A1F29E}"/>
+                <a16:creationId xmlns:a16="http://schemas.microsoft.com/office/drawing/2014/main" id="{4298A350-ED5B-A1DC-4E88-907F10EB12EF}"/>
               </a:ext>
             </a:extLst>
           </p:cNvPr>
@@ -2868,7 +2868,7 @@
           <a:bodyPr/>
           <a:lstStyle/>
           <a:p>
-            <a:fld id="{44D40E14-F31D-43C6-995C-1BC509075025}" type="datetimeFigureOut">
+            <a:fld id="{DE1BE91F-0B33-40E3-9AB7-59DD5EB738EA}" type="datetimeFigureOut">
               <a:rPr lang="en-US" smtClean="0"/>
               <a:t>8/15/2026</a:t>
             </a:fld>
@@ -2881,7 +2881,7 @@
           <p:cNvPr id="5" name="Footer Placeholder 4">
             <a:extLst>
               <a:ext uri="{FF2B5EF4-FFF2-40B4-BE49-F238E27FC236}">
-                <a16:creationId xmlns:a16="http://schemas.microsoft.com/office/drawing/2014/main" id="{213ABC56-A8F8-3970-D320-3E90941EAEBB}"/>
+                <a16:creationId xmlns:a16="http://schemas.microsoft.com/office/drawing/2014/main" id="{B937E87E-D5D2-91F4-44D5-A2B20D40A21F}"/>
               </a:ext>
             </a:extLst>
           </p:cNvPr>
@@ -2906,7 +2906,7 @@
           <p:cNvPr id="6" name="Slide Number Placeholder 5">
             <a:extLst>
               <a:ext uri="{FF2B5EF4-FFF2-40B4-BE49-F238E27FC236}">
-                <a16:creationId xmlns:a16="http://schemas.microsoft.com/office/drawing/2014/main" id="{8706CF03-3328-29CD-49A6-73C57304B02D}"/>
+                <a16:creationId xmlns:a16="http://schemas.microsoft.com/office/drawing/2014/main" id="{A5E15C73-32A9-A9DF-67D7-76070000FDC5}"/>
               </a:ext>
             </a:extLst>
           </p:cNvPr>
@@ -2922,7 +2922,7 @@
           <a:bodyPr/>
           <a:lstStyle/>
           <a:p>
-            <a:fld id="{A21E5D25-B7F4-4053-A13F-9DB9FA4E435A}" type="slidenum">
+            <a:fld id="{EEB070CA-7418-40FB-A3DF-DA5FA69D9337}" type="slidenum">
               <a:rPr lang="en-US" smtClean="0"/>
               <a:t>‹#›</a:t>
             </a:fld>
@@ -2933,7 +2933,7 @@
     </p:spTree>
     <p:extLst>
       <p:ext uri="{BB962C8B-B14F-4D97-AF65-F5344CB8AC3E}">
-        <p14:creationId xmlns:p14="http://schemas.microsoft.com/office/powerpoint/2010/main" val="2464071237"/>
+        <p14:creationId xmlns:p14="http://schemas.microsoft.com/office/powerpoint/2010/main" val="1849153947"/>
       </p:ext>
     </p:extLst>
   </p:cSld>
@@ -2965,7 +2965,7 @@
           <p:cNvPr id="2" name="Title 1">
             <a:extLst>
               <a:ext uri="{FF2B5EF4-FFF2-40B4-BE49-F238E27FC236}">
-                <a16:creationId xmlns:a16="http://schemas.microsoft.com/office/drawing/2014/main" id="{F368DBF7-0371-93B2-8616-7E833E155E82}"/>
+                <a16:creationId xmlns:a16="http://schemas.microsoft.com/office/drawing/2014/main" id="{05AB6C5F-F9AE-CC56-2093-749A04B71E34}"/>
               </a:ext>
             </a:extLst>
           </p:cNvPr>
@@ -2993,7 +2993,7 @@
           <p:cNvPr id="3" name="Content Placeholder 2">
             <a:extLst>
               <a:ext uri="{FF2B5EF4-FFF2-40B4-BE49-F238E27FC236}">
-                <a16:creationId xmlns:a16="http://schemas.microsoft.com/office/drawing/2014/main" id="{9FA1B33B-7BE1-CA47-571E-F10156C48D4C}"/>
+                <a16:creationId xmlns:a16="http://schemas.microsoft.com/office/drawing/2014/main" id="{BD3E599D-78CE-10BE-E0EA-397FE19EEA5B}"/>
               </a:ext>
             </a:extLst>
           </p:cNvPr>
@@ -3055,7 +3055,7 @@
           <p:cNvPr id="4" name="Content Placeholder 3">
             <a:extLst>
               <a:ext uri="{FF2B5EF4-FFF2-40B4-BE49-F238E27FC236}">
-                <a16:creationId xmlns:a16="http://schemas.microsoft.com/office/drawing/2014/main" id="{6DBB7A76-19AE-061A-C95C-4972402F0985}"/>
+                <a16:creationId xmlns:a16="http://schemas.microsoft.com/office/drawing/2014/main" id="{30D96FF3-6657-F29C-E3F7-41EC90F9255C}"/>
               </a:ext>
             </a:extLst>
           </p:cNvPr>
@@ -3117,7 +3117,7 @@
           <p:cNvPr id="5" name="Date Placeholder 4">
             <a:extLst>
               <a:ext uri="{FF2B5EF4-FFF2-40B4-BE49-F238E27FC236}">
-                <a16:creationId xmlns:a16="http://schemas.microsoft.com/office/drawing/2014/main" id="{AFC68B55-A253-0DA2-A54B-24B365A7C308}"/>
+                <a16:creationId xmlns:a16="http://schemas.microsoft.com/office/drawing/2014/main" id="{A3BE3AED-2EB9-9349-0DA8-915CDCE08442}"/>
               </a:ext>
             </a:extLst>
           </p:cNvPr>
@@ -3133,7 +3133,7 @@
           <a:bodyPr/>
           <a:lstStyle/>
           <a:p>
-            <a:fld id="{44D40E14-F31D-43C6-995C-1BC509075025}" type="datetimeFigureOut">
+            <a:fld id="{DE1BE91F-0B33-40E3-9AB7-59DD5EB738EA}" type="datetimeFigureOut">
               <a:rPr lang="en-US" smtClean="0"/>
               <a:t>8/15/2026</a:t>
             </a:fld>
@@ -3146,7 +3146,7 @@
           <p:cNvPr id="6" name="Footer Placeholder 5">
             <a:extLst>
               <a:ext uri="{FF2B5EF4-FFF2-40B4-BE49-F238E27FC236}">
-                <a16:creationId xmlns:a16="http://schemas.microsoft.com/office/drawing/2014/main" id="{A021A31E-E466-1F5A-9715-370EF6A9D1E5}"/>
+                <a16:creationId xmlns:a16="http://schemas.microsoft.com/office/drawing/2014/main" id="{364F876E-E322-636E-5C5F-EA50B9FD3C12}"/>
               </a:ext>
             </a:extLst>
           </p:cNvPr>
@@ -3171,7 +3171,7 @@
           <p:cNvPr id="7" name="Slide Number Placeholder 6">
             <a:extLst>
               <a:ext uri="{FF2B5EF4-FFF2-40B4-BE49-F238E27FC236}">
-                <a16:creationId xmlns:a16="http://schemas.microsoft.com/office/drawing/2014/main" id="{328E7A7F-EC53-84C5-7D82-7DC4C31339CD}"/>
+                <a16:creationId xmlns:a16="http://schemas.microsoft.com/office/drawing/2014/main" id="{CF9DFB29-7513-C527-8001-B1D76A3660BD}"/>
               </a:ext>
             </a:extLst>
           </p:cNvPr>
@@ -3187,7 +3187,7 @@
           <a:bodyPr/>
           <a:lstStyle/>
           <a:p>
-            <a:fld id="{A21E5D25-B7F4-4053-A13F-9DB9FA4E435A}" type="slidenum">
+            <a:fld id="{EEB070CA-7418-40FB-A3DF-DA5FA69D9337}" type="slidenum">
               <a:rPr lang="en-US" smtClean="0"/>
               <a:t>‹#›</a:t>
             </a:fld>
@@ -3198,7 +3198,7 @@
     </p:spTree>
     <p:extLst>
       <p:ext uri="{BB962C8B-B14F-4D97-AF65-F5344CB8AC3E}">
-        <p14:creationId xmlns:p14="http://schemas.microsoft.com/office/powerpoint/2010/main" val="1433593039"/>
+        <p14:creationId xmlns:p14="http://schemas.microsoft.com/office/powerpoint/2010/main" val="2070295310"/>
       </p:ext>
     </p:extLst>
   </p:cSld>
@@ -3230,7 +3230,7 @@
           <p:cNvPr id="2" name="Title 1">
             <a:extLst>
               <a:ext uri="{FF2B5EF4-FFF2-40B4-BE49-F238E27FC236}">
-                <a16:creationId xmlns:a16="http://schemas.microsoft.com/office/drawing/2014/main" id="{29D129CF-5222-2BD2-3E9F-FEB20951A36D}"/>
+                <a16:creationId xmlns:a16="http://schemas.microsoft.com/office/drawing/2014/main" id="{D6829E6B-A725-098E-7944-54A3FD6C30D0}"/>
               </a:ext>
             </a:extLst>
           </p:cNvPr>
@@ -3263,7 +3263,7 @@
           <p:cNvPr id="3" name="Text Placeholder 2">
             <a:extLst>
               <a:ext uri="{FF2B5EF4-FFF2-40B4-BE49-F238E27FC236}">
-                <a16:creationId xmlns:a16="http://schemas.microsoft.com/office/drawing/2014/main" id="{B2A56D36-96C5-35A0-1185-C5C713B013CE}"/>
+                <a16:creationId xmlns:a16="http://schemas.microsoft.com/office/drawing/2014/main" id="{77F49D69-1BAD-281E-03DF-55B2BC033D4C}"/>
               </a:ext>
             </a:extLst>
           </p:cNvPr>
@@ -3334,7 +3334,7 @@
           <p:cNvPr id="4" name="Content Placeholder 3">
             <a:extLst>
               <a:ext uri="{FF2B5EF4-FFF2-40B4-BE49-F238E27FC236}">
-                <a16:creationId xmlns:a16="http://schemas.microsoft.com/office/drawing/2014/main" id="{7E568DC1-D186-F226-2924-BFBFDF634833}"/>
+                <a16:creationId xmlns:a16="http://schemas.microsoft.com/office/drawing/2014/main" id="{FA96CA9A-CB5C-503C-DBD1-2534F3B58179}"/>
               </a:ext>
             </a:extLst>
           </p:cNvPr>
@@ -3396,7 +3396,7 @@
           <p:cNvPr id="5" name="Text Placeholder 4">
             <a:extLst>
               <a:ext uri="{FF2B5EF4-FFF2-40B4-BE49-F238E27FC236}">
-                <a16:creationId xmlns:a16="http://schemas.microsoft.com/office/drawing/2014/main" id="{10CD4BDD-7F7E-BF8B-5B2B-D8D7924A177F}"/>
+                <a16:creationId xmlns:a16="http://schemas.microsoft.com/office/drawing/2014/main" id="{D2526DD7-D78E-BF91-57B3-05A935A043EA}"/>
               </a:ext>
             </a:extLst>
           </p:cNvPr>
@@ -3467,7 +3467,7 @@
           <p:cNvPr id="6" name="Content Placeholder 5">
             <a:extLst>
               <a:ext uri="{FF2B5EF4-FFF2-40B4-BE49-F238E27FC236}">
-                <a16:creationId xmlns:a16="http://schemas.microsoft.com/office/drawing/2014/main" id="{7B248202-59F1-59E4-FF4F-D3B28FE6ED1F}"/>
+                <a16:creationId xmlns:a16="http://schemas.microsoft.com/office/drawing/2014/main" id="{11340AB6-2E4B-5F7A-B197-FDB9E66B0744}"/>
               </a:ext>
             </a:extLst>
           </p:cNvPr>
@@ -3529,7 +3529,7 @@
           <p:cNvPr id="7" name="Date Placeholder 6">
             <a:extLst>
               <a:ext uri="{FF2B5EF4-FFF2-40B4-BE49-F238E27FC236}">
-                <a16:creationId xmlns:a16="http://schemas.microsoft.com/office/drawing/2014/main" id="{6D5BCCBD-5709-0622-8EC2-F44A30F6B2E8}"/>
+                <a16:creationId xmlns:a16="http://schemas.microsoft.com/office/drawing/2014/main" id="{382FBAD6-ED8B-1FCA-9D41-AB213ADBE40E}"/>
               </a:ext>
             </a:extLst>
           </p:cNvPr>
@@ -3545,7 +3545,7 @@
           <a:bodyPr/>
           <a:lstStyle/>
           <a:p>
-            <a:fld id="{44D40E14-F31D-43C6-995C-1BC509075025}" type="datetimeFigureOut">
+            <a:fld id="{DE1BE91F-0B33-40E3-9AB7-59DD5EB738EA}" type="datetimeFigureOut">
               <a:rPr lang="en-US" smtClean="0"/>
               <a:t>8/15/2026</a:t>
             </a:fld>
@@ -3558,7 +3558,7 @@
           <p:cNvPr id="8" name="Footer Placeholder 7">
             <a:extLst>
               <a:ext uri="{FF2B5EF4-FFF2-40B4-BE49-F238E27FC236}">
-                <a16:creationId xmlns:a16="http://schemas.microsoft.com/office/drawing/2014/main" id="{B9493D7B-67E9-4FA9-A5C9-4B51D3FCE2D0}"/>
+                <a16:creationId xmlns:a16="http://schemas.microsoft.com/office/drawing/2014/main" id="{0700C233-FDC4-4616-3D3C-EE4F5EA979E7}"/>
               </a:ext>
             </a:extLst>
           </p:cNvPr>
@@ -3583,7 +3583,7 @@
           <p:cNvPr id="9" name="Slide Number Placeholder 8">
             <a:extLst>
               <a:ext uri="{FF2B5EF4-FFF2-40B4-BE49-F238E27FC236}">
-                <a16:creationId xmlns:a16="http://schemas.microsoft.com/office/drawing/2014/main" id="{6E072FD0-8FAC-3376-1800-751A5C2C0D6D}"/>
+                <a16:creationId xmlns:a16="http://schemas.microsoft.com/office/drawing/2014/main" id="{61116872-C58F-D7C7-1E5B-6DF77A051CBF}"/>
               </a:ext>
             </a:extLst>
           </p:cNvPr>
@@ -3599,7 +3599,7 @@
           <a:bodyPr/>
           <a:lstStyle/>
           <a:p>
-            <a:fld id="{A21E5D25-B7F4-4053-A13F-9DB9FA4E435A}" type="slidenum">
+            <a:fld id="{EEB070CA-7418-40FB-A3DF-DA5FA69D9337}" type="slidenum">
               <a:rPr lang="en-US" smtClean="0"/>
               <a:t>‹#›</a:t>
             </a:fld>
@@ -3610,7 +3610,7 @@
     </p:spTree>
     <p:extLst>
       <p:ext uri="{BB962C8B-B14F-4D97-AF65-F5344CB8AC3E}">
-        <p14:creationId xmlns:p14="http://schemas.microsoft.com/office/powerpoint/2010/main" val="3405371225"/>
+        <p14:creationId xmlns:p14="http://schemas.microsoft.com/office/powerpoint/2010/main" val="1203760067"/>
       </p:ext>
     </p:extLst>
   </p:cSld>
@@ -3642,7 +3642,7 @@
           <p:cNvPr id="2" name="Title 1">
             <a:extLst>
               <a:ext uri="{FF2B5EF4-FFF2-40B4-BE49-F238E27FC236}">
-                <a16:creationId xmlns:a16="http://schemas.microsoft.com/office/drawing/2014/main" id="{EFFDE31C-6AEA-24D8-A76D-3778C7CC11B5}"/>
+                <a16:creationId xmlns:a16="http://schemas.microsoft.com/office/drawing/2014/main" id="{8CF4F633-AFBF-D3F6-67F5-44DC4446B978}"/>
               </a:ext>
             </a:extLst>
           </p:cNvPr>
@@ -3670,7 +3670,7 @@
           <p:cNvPr id="3" name="Date Placeholder 2">
             <a:extLst>
               <a:ext uri="{FF2B5EF4-FFF2-40B4-BE49-F238E27FC236}">
-                <a16:creationId xmlns:a16="http://schemas.microsoft.com/office/drawing/2014/main" id="{A335C6B9-6846-8DD9-32F6-D582E755F0B1}"/>
+                <a16:creationId xmlns:a16="http://schemas.microsoft.com/office/drawing/2014/main" id="{DB7791E1-B1C6-54AF-B01B-C09F8CDC4348}"/>
               </a:ext>
             </a:extLst>
           </p:cNvPr>
@@ -3686,7 +3686,7 @@
           <a:bodyPr/>
           <a:lstStyle/>
           <a:p>
-            <a:fld id="{44D40E14-F31D-43C6-995C-1BC509075025}" type="datetimeFigureOut">
+            <a:fld id="{DE1BE91F-0B33-40E3-9AB7-59DD5EB738EA}" type="datetimeFigureOut">
               <a:rPr lang="en-US" smtClean="0"/>
               <a:t>8/15/2026</a:t>
             </a:fld>
@@ -3699,7 +3699,7 @@
           <p:cNvPr id="4" name="Footer Placeholder 3">
             <a:extLst>
               <a:ext uri="{FF2B5EF4-FFF2-40B4-BE49-F238E27FC236}">
-                <a16:creationId xmlns:a16="http://schemas.microsoft.com/office/drawing/2014/main" id="{796D2BB1-C5C4-50B5-71C8-A8F517C69D64}"/>
+                <a16:creationId xmlns:a16="http://schemas.microsoft.com/office/drawing/2014/main" id="{AD1468B4-72BE-1322-B487-703B4ACFBB5F}"/>
               </a:ext>
             </a:extLst>
           </p:cNvPr>
@@ -3724,7 +3724,7 @@
           <p:cNvPr id="5" name="Slide Number Placeholder 4">
             <a:extLst>
               <a:ext uri="{FF2B5EF4-FFF2-40B4-BE49-F238E27FC236}">
-                <a16:creationId xmlns:a16="http://schemas.microsoft.com/office/drawing/2014/main" id="{E551140E-744F-121F-5C5B-5DF60EB91814}"/>
+                <a16:creationId xmlns:a16="http://schemas.microsoft.com/office/drawing/2014/main" id="{DE09E034-2AD4-03D3-DA91-41A218DE504B}"/>
               </a:ext>
             </a:extLst>
           </p:cNvPr>
@@ -3740,7 +3740,7 @@
           <a:bodyPr/>
           <a:lstStyle/>
           <a:p>
-            <a:fld id="{A21E5D25-B7F4-4053-A13F-9DB9FA4E435A}" type="slidenum">
+            <a:fld id="{EEB070CA-7418-40FB-A3DF-DA5FA69D9337}" type="slidenum">
               <a:rPr lang="en-US" smtClean="0"/>
               <a:t>‹#›</a:t>
             </a:fld>
@@ -3751,7 +3751,7 @@
     </p:spTree>
     <p:extLst>
       <p:ext uri="{BB962C8B-B14F-4D97-AF65-F5344CB8AC3E}">
-        <p14:creationId xmlns:p14="http://schemas.microsoft.com/office/powerpoint/2010/main" val="2886566329"/>
+        <p14:creationId xmlns:p14="http://schemas.microsoft.com/office/powerpoint/2010/main" val="2497450178"/>
       </p:ext>
     </p:extLst>
   </p:cSld>
@@ -3783,7 +3783,7 @@
           <p:cNvPr id="2" name="Date Placeholder 1">
             <a:extLst>
               <a:ext uri="{FF2B5EF4-FFF2-40B4-BE49-F238E27FC236}">
-                <a16:creationId xmlns:a16="http://schemas.microsoft.com/office/drawing/2014/main" id="{F48FAF91-F67E-BB0B-E196-960C3189D4AD}"/>
+                <a16:creationId xmlns:a16="http://schemas.microsoft.com/office/drawing/2014/main" id="{78078799-3D60-4ABE-2EC2-B8E62DEF9A7E}"/>
               </a:ext>
             </a:extLst>
           </p:cNvPr>
@@ -3799,7 +3799,7 @@
           <a:bodyPr/>
           <a:lstStyle/>
           <a:p>
-            <a:fld id="{44D40E14-F31D-43C6-995C-1BC509075025}" type="datetimeFigureOut">
+            <a:fld id="{DE1BE91F-0B33-40E3-9AB7-59DD5EB738EA}" type="datetimeFigureOut">
               <a:rPr lang="en-US" smtClean="0"/>
               <a:t>8/15/2026</a:t>
             </a:fld>
@@ -3812,7 +3812,7 @@
           <p:cNvPr id="3" name="Footer Placeholder 2">
             <a:extLst>
               <a:ext uri="{FF2B5EF4-FFF2-40B4-BE49-F238E27FC236}">
-                <a16:creationId xmlns:a16="http://schemas.microsoft.com/office/drawing/2014/main" id="{1D9DAD9C-5700-F60B-97F2-9B83B191909F}"/>
+                <a16:creationId xmlns:a16="http://schemas.microsoft.com/office/drawing/2014/main" id="{019F668F-BF32-531F-3938-39543FE7861F}"/>
               </a:ext>
             </a:extLst>
           </p:cNvPr>
@@ -3837,7 +3837,7 @@
           <p:cNvPr id="4" name="Slide Number Placeholder 3">
             <a:extLst>
               <a:ext uri="{FF2B5EF4-FFF2-40B4-BE49-F238E27FC236}">
-                <a16:creationId xmlns:a16="http://schemas.microsoft.com/office/drawing/2014/main" id="{053673A2-8FF1-ED4C-EE13-0BD844C2B01D}"/>
+                <a16:creationId xmlns:a16="http://schemas.microsoft.com/office/drawing/2014/main" id="{D11BA146-112B-A4CD-9245-07A1748AB13D}"/>
               </a:ext>
             </a:extLst>
           </p:cNvPr>
@@ -3853,7 +3853,7 @@
           <a:bodyPr/>
           <a:lstStyle/>
           <a:p>
-            <a:fld id="{A21E5D25-B7F4-4053-A13F-9DB9FA4E435A}" type="slidenum">
+            <a:fld id="{EEB070CA-7418-40FB-A3DF-DA5FA69D9337}" type="slidenum">
               <a:rPr lang="en-US" smtClean="0"/>
               <a:t>‹#›</a:t>
             </a:fld>
@@ -3864,7 +3864,7 @@
     </p:spTree>
     <p:extLst>
       <p:ext uri="{BB962C8B-B14F-4D97-AF65-F5344CB8AC3E}">
-        <p14:creationId xmlns:p14="http://schemas.microsoft.com/office/powerpoint/2010/main" val="1588852953"/>
+        <p14:creationId xmlns:p14="http://schemas.microsoft.com/office/powerpoint/2010/main" val="920970074"/>
       </p:ext>
     </p:extLst>
   </p:cSld>
@@ -3896,7 +3896,7 @@
           <p:cNvPr id="2" name="Title 1">
             <a:extLst>
               <a:ext uri="{FF2B5EF4-FFF2-40B4-BE49-F238E27FC236}">
-                <a16:creationId xmlns:a16="http://schemas.microsoft.com/office/drawing/2014/main" id="{BA28A156-5C2E-544E-1185-4EBE4852DEDD}"/>
+                <a16:creationId xmlns:a16="http://schemas.microsoft.com/office/drawing/2014/main" id="{78DB354D-0C18-6B6A-8C79-E57224BBFCFD}"/>
               </a:ext>
             </a:extLst>
           </p:cNvPr>
@@ -3933,7 +3933,7 @@
           <p:cNvPr id="3" name="Content Placeholder 2">
             <a:extLst>
               <a:ext uri="{FF2B5EF4-FFF2-40B4-BE49-F238E27FC236}">
-                <a16:creationId xmlns:a16="http://schemas.microsoft.com/office/drawing/2014/main" id="{1E1C1986-1020-03D6-D32F-BF22FB699AC3}"/>
+                <a16:creationId xmlns:a16="http://schemas.microsoft.com/office/drawing/2014/main" id="{96E2670D-AB54-E499-3975-1103A75E3ACF}"/>
               </a:ext>
             </a:extLst>
           </p:cNvPr>
@@ -4023,7 +4023,7 @@
           <p:cNvPr id="4" name="Text Placeholder 3">
             <a:extLst>
               <a:ext uri="{FF2B5EF4-FFF2-40B4-BE49-F238E27FC236}">
-                <a16:creationId xmlns:a16="http://schemas.microsoft.com/office/drawing/2014/main" id="{7EC97EBE-E556-F45E-C5CF-9FC5077A056A}"/>
+                <a16:creationId xmlns:a16="http://schemas.microsoft.com/office/drawing/2014/main" id="{2B72B1D3-53CE-8E9C-25A1-4019DE405AD4}"/>
               </a:ext>
             </a:extLst>
           </p:cNvPr>
@@ -4094,7 +4094,7 @@
           <p:cNvPr id="5" name="Date Placeholder 4">
             <a:extLst>
               <a:ext uri="{FF2B5EF4-FFF2-40B4-BE49-F238E27FC236}">
-                <a16:creationId xmlns:a16="http://schemas.microsoft.com/office/drawing/2014/main" id="{7C3C9ED4-3852-60DC-6870-E23D31E55F39}"/>
+                <a16:creationId xmlns:a16="http://schemas.microsoft.com/office/drawing/2014/main" id="{68432C4C-2988-4089-711A-51A338565967}"/>
               </a:ext>
             </a:extLst>
           </p:cNvPr>
@@ -4110,7 +4110,7 @@
           <a:bodyPr/>
           <a:lstStyle/>
           <a:p>
-            <a:fld id="{44D40E14-F31D-43C6-995C-1BC509075025}" type="datetimeFigureOut">
+            <a:fld id="{DE1BE91F-0B33-40E3-9AB7-59DD5EB738EA}" type="datetimeFigureOut">
               <a:rPr lang="en-US" smtClean="0"/>
               <a:t>8/15/2026</a:t>
             </a:fld>
@@ -4123,7 +4123,7 @@
           <p:cNvPr id="6" name="Footer Placeholder 5">
             <a:extLst>
               <a:ext uri="{FF2B5EF4-FFF2-40B4-BE49-F238E27FC236}">
-                <a16:creationId xmlns:a16="http://schemas.microsoft.com/office/drawing/2014/main" id="{044A3E90-9B20-61C5-1D03-0F5F3EA66D71}"/>
+                <a16:creationId xmlns:a16="http://schemas.microsoft.com/office/drawing/2014/main" id="{973893D7-7517-2111-ED2A-4B0521C70FEC}"/>
               </a:ext>
             </a:extLst>
           </p:cNvPr>
@@ -4148,7 +4148,7 @@
           <p:cNvPr id="7" name="Slide Number Placeholder 6">
             <a:extLst>
               <a:ext uri="{FF2B5EF4-FFF2-40B4-BE49-F238E27FC236}">
-                <a16:creationId xmlns:a16="http://schemas.microsoft.com/office/drawing/2014/main" id="{950A840F-8A91-E144-F4C0-C2368CD9CB23}"/>
+                <a16:creationId xmlns:a16="http://schemas.microsoft.com/office/drawing/2014/main" id="{2318B82D-FD69-52AA-4FBE-6B4A30E82ED3}"/>
               </a:ext>
             </a:extLst>
           </p:cNvPr>
@@ -4164,7 +4164,7 @@
           <a:bodyPr/>
           <a:lstStyle/>
           <a:p>
-            <a:fld id="{A21E5D25-B7F4-4053-A13F-9DB9FA4E435A}" type="slidenum">
+            <a:fld id="{EEB070CA-7418-40FB-A3DF-DA5FA69D9337}" type="slidenum">
               <a:rPr lang="en-US" smtClean="0"/>
               <a:t>‹#›</a:t>
             </a:fld>
@@ -4175,7 +4175,7 @@
     </p:spTree>
     <p:extLst>
       <p:ext uri="{BB962C8B-B14F-4D97-AF65-F5344CB8AC3E}">
-        <p14:creationId xmlns:p14="http://schemas.microsoft.com/office/powerpoint/2010/main" val="2002599679"/>
+        <p14:creationId xmlns:p14="http://schemas.microsoft.com/office/powerpoint/2010/main" val="3347414568"/>
       </p:ext>
     </p:extLst>
   </p:cSld>
@@ -4207,7 +4207,7 @@
           <p:cNvPr id="2" name="Title 1">
             <a:extLst>
               <a:ext uri="{FF2B5EF4-FFF2-40B4-BE49-F238E27FC236}">
-                <a16:creationId xmlns:a16="http://schemas.microsoft.com/office/drawing/2014/main" id="{D9966835-9678-AD8C-A464-CB2DD42357A0}"/>
+                <a16:creationId xmlns:a16="http://schemas.microsoft.com/office/drawing/2014/main" id="{F36A91CA-1E9D-5F82-AD39-43C457A44DEF}"/>
               </a:ext>
             </a:extLst>
           </p:cNvPr>
@@ -4244,7 +4244,7 @@
           <p:cNvPr id="3" name="Picture Placeholder 2">
             <a:extLst>
               <a:ext uri="{FF2B5EF4-FFF2-40B4-BE49-F238E27FC236}">
-                <a16:creationId xmlns:a16="http://schemas.microsoft.com/office/drawing/2014/main" id="{ED687246-61D8-3F9C-797E-B7CA4095E850}"/>
+                <a16:creationId xmlns:a16="http://schemas.microsoft.com/office/drawing/2014/main" id="{99DA0E6B-B7BF-5A84-34BB-7A42F2923C53}"/>
               </a:ext>
             </a:extLst>
           </p:cNvPr>
@@ -4311,7 +4311,7 @@
           <p:cNvPr id="4" name="Text Placeholder 3">
             <a:extLst>
               <a:ext uri="{FF2B5EF4-FFF2-40B4-BE49-F238E27FC236}">
-                <a16:creationId xmlns:a16="http://schemas.microsoft.com/office/drawing/2014/main" id="{98AF75BC-C79E-DAED-19D2-AB6F2B1DD353}"/>
+                <a16:creationId xmlns:a16="http://schemas.microsoft.com/office/drawing/2014/main" id="{86ED0628-9918-1AE5-9F8F-E9810733247B}"/>
               </a:ext>
             </a:extLst>
           </p:cNvPr>
@@ -4382,7 +4382,7 @@
           <p:cNvPr id="5" name="Date Placeholder 4">
             <a:extLst>
               <a:ext uri="{FF2B5EF4-FFF2-40B4-BE49-F238E27FC236}">
-                <a16:creationId xmlns:a16="http://schemas.microsoft.com/office/drawing/2014/main" id="{7D3951E9-D8E2-5320-FEA5-B4829A806A63}"/>
+                <a16:creationId xmlns:a16="http://schemas.microsoft.com/office/drawing/2014/main" id="{7D979557-F30A-556A-482E-F681DB9C1260}"/>
               </a:ext>
             </a:extLst>
           </p:cNvPr>
@@ -4398,7 +4398,7 @@
           <a:bodyPr/>
           <a:lstStyle/>
           <a:p>
-            <a:fld id="{44D40E14-F31D-43C6-995C-1BC509075025}" type="datetimeFigureOut">
+            <a:fld id="{DE1BE91F-0B33-40E3-9AB7-59DD5EB738EA}" type="datetimeFigureOut">
               <a:rPr lang="en-US" smtClean="0"/>
               <a:t>8/15/2026</a:t>
             </a:fld>
@@ -4411,7 +4411,7 @@
           <p:cNvPr id="6" name="Footer Placeholder 5">
             <a:extLst>
               <a:ext uri="{FF2B5EF4-FFF2-40B4-BE49-F238E27FC236}">
-                <a16:creationId xmlns:a16="http://schemas.microsoft.com/office/drawing/2014/main" id="{DA978F8E-8172-E770-82DE-9E8F48C54943}"/>
+                <a16:creationId xmlns:a16="http://schemas.microsoft.com/office/drawing/2014/main" id="{FD799918-85EF-D6D2-51CF-CF9E27EE2B7B}"/>
               </a:ext>
             </a:extLst>
           </p:cNvPr>
@@ -4436,7 +4436,7 @@
           <p:cNvPr id="7" name="Slide Number Placeholder 6">
             <a:extLst>
               <a:ext uri="{FF2B5EF4-FFF2-40B4-BE49-F238E27FC236}">
-                <a16:creationId xmlns:a16="http://schemas.microsoft.com/office/drawing/2014/main" id="{DD8F07F7-A410-3D5E-42EF-B05BED02E701}"/>
+                <a16:creationId xmlns:a16="http://schemas.microsoft.com/office/drawing/2014/main" id="{9E6D0E57-EE10-5A61-C391-DB147A468A10}"/>
               </a:ext>
             </a:extLst>
           </p:cNvPr>
@@ -4452,7 +4452,7 @@
           <a:bodyPr/>
           <a:lstStyle/>
           <a:p>
-            <a:fld id="{A21E5D25-B7F4-4053-A13F-9DB9FA4E435A}" type="slidenum">
+            <a:fld id="{EEB070CA-7418-40FB-A3DF-DA5FA69D9337}" type="slidenum">
               <a:rPr lang="en-US" smtClean="0"/>
               <a:t>‹#›</a:t>
             </a:fld>
@@ -4463,7 +4463,7 @@
     </p:spTree>
     <p:extLst>
       <p:ext uri="{BB962C8B-B14F-4D97-AF65-F5344CB8AC3E}">
-        <p14:creationId xmlns:p14="http://schemas.microsoft.com/office/powerpoint/2010/main" val="2347154210"/>
+        <p14:creationId xmlns:p14="http://schemas.microsoft.com/office/powerpoint/2010/main" val="2148722627"/>
       </p:ext>
     </p:extLst>
   </p:cSld>
@@ -4500,7 +4500,7 @@
           <p:cNvPr id="2" name="Title Placeholder 1">
             <a:extLst>
               <a:ext uri="{FF2B5EF4-FFF2-40B4-BE49-F238E27FC236}">
-                <a16:creationId xmlns:a16="http://schemas.microsoft.com/office/drawing/2014/main" id="{694C5C90-8D1C-73FF-2EEA-019FC288E6E5}"/>
+                <a16:creationId xmlns:a16="http://schemas.microsoft.com/office/drawing/2014/main" id="{6491C26D-97FC-7022-5C19-432C70F0108A}"/>
               </a:ext>
             </a:extLst>
           </p:cNvPr>
@@ -4538,7 +4538,7 @@
           <p:cNvPr id="3" name="Text Placeholder 2">
             <a:extLst>
               <a:ext uri="{FF2B5EF4-FFF2-40B4-BE49-F238E27FC236}">
-                <a16:creationId xmlns:a16="http://schemas.microsoft.com/office/drawing/2014/main" id="{F83CA712-3147-533D-E78E-E07AA75C217D}"/>
+                <a16:creationId xmlns:a16="http://schemas.microsoft.com/office/drawing/2014/main" id="{95EFE0FC-4BD5-0980-DFD0-4E5049E9D3C4}"/>
               </a:ext>
             </a:extLst>
           </p:cNvPr>
@@ -4605,7 +4605,7 @@
           <p:cNvPr id="4" name="Date Placeholder 3">
             <a:extLst>
               <a:ext uri="{FF2B5EF4-FFF2-40B4-BE49-F238E27FC236}">
-                <a16:creationId xmlns:a16="http://schemas.microsoft.com/office/drawing/2014/main" id="{A05422BB-C9A8-1E24-47C2-C37AFD148BE7}"/>
+                <a16:creationId xmlns:a16="http://schemas.microsoft.com/office/drawing/2014/main" id="{E6B889C0-0D15-92D6-2F1A-E1CA8C8EC770}"/>
               </a:ext>
             </a:extLst>
           </p:cNvPr>
@@ -4639,7 +4639,7 @@
             </a:lvl1pPr>
           </a:lstStyle>
           <a:p>
-            <a:fld id="{44D40E14-F31D-43C6-995C-1BC509075025}" type="datetimeFigureOut">
+            <a:fld id="{DE1BE91F-0B33-40E3-9AB7-59DD5EB738EA}" type="datetimeFigureOut">
               <a:rPr lang="en-US" smtClean="0"/>
               <a:t>8/15/2026</a:t>
             </a:fld>
@@ -4652,7 +4652,7 @@
           <p:cNvPr id="5" name="Footer Placeholder 4">
             <a:extLst>
               <a:ext uri="{FF2B5EF4-FFF2-40B4-BE49-F238E27FC236}">
-                <a16:creationId xmlns:a16="http://schemas.microsoft.com/office/drawing/2014/main" id="{16B1AE81-5D5D-662F-04A0-4EF7F4F99BE4}"/>
+                <a16:creationId xmlns:a16="http://schemas.microsoft.com/office/drawing/2014/main" id="{2D8CE66F-225A-7B3B-AB46-6E665AABC5AA}"/>
               </a:ext>
             </a:extLst>
           </p:cNvPr>
@@ -4695,7 +4695,7 @@
           <p:cNvPr id="6" name="Slide Number Placeholder 5">
             <a:extLst>
               <a:ext uri="{FF2B5EF4-FFF2-40B4-BE49-F238E27FC236}">
-                <a16:creationId xmlns:a16="http://schemas.microsoft.com/office/drawing/2014/main" id="{A6916197-58BD-DA75-B9FC-7E309B3E020B}"/>
+                <a16:creationId xmlns:a16="http://schemas.microsoft.com/office/drawing/2014/main" id="{B29F52F7-083C-4556-D6CA-C8C7A0AE9DDF}"/>
               </a:ext>
             </a:extLst>
           </p:cNvPr>
@@ -4729,7 +4729,7 @@
             </a:lvl1pPr>
           </a:lstStyle>
           <a:p>
-            <a:fld id="{A21E5D25-B7F4-4053-A13F-9DB9FA4E435A}" type="slidenum">
+            <a:fld id="{EEB070CA-7418-40FB-A3DF-DA5FA69D9337}" type="slidenum">
               <a:rPr lang="en-US" smtClean="0"/>
               <a:t>‹#›</a:t>
             </a:fld>
@@ -4740,7 +4740,7 @@
     </p:spTree>
     <p:extLst>
       <p:ext uri="{BB962C8B-B14F-4D97-AF65-F5344CB8AC3E}">
-        <p14:creationId xmlns:p14="http://schemas.microsoft.com/office/powerpoint/2010/main" val="3531066433"/>
+        <p14:creationId xmlns:p14="http://schemas.microsoft.com/office/powerpoint/2010/main" val="671844042"/>
       </p:ext>
     </p:extLst>
   </p:cSld>
@@ -5071,7 +5071,7 @@
           <p:cNvPr id="2" name="TextBox 1">
             <a:extLst>
               <a:ext uri="{FF2B5EF4-FFF2-40B4-BE49-F238E27FC236}">
-                <a16:creationId xmlns:a16="http://schemas.microsoft.com/office/drawing/2014/main" id="{84A67AE0-F72F-8558-4E75-E8462C0461CC}"/>
+                <a16:creationId xmlns:a16="http://schemas.microsoft.com/office/drawing/2014/main" id="{296D2EE9-A263-E515-2ED0-D7C73479BD3F}"/>
               </a:ext>
             </a:extLst>
           </p:cNvPr>
@@ -5095,7 +5095,7 @@
           <a:lstStyle/>
           <a:p>
             <a:r>
-              <a:rPr lang="en-US" sz="1500" b="1">
+              <a:rPr lang="en-US" sz="1600" b="1">
                 <a:solidFill>
                   <a:srgbClr val="3FC6AC"/>
                 </a:solidFill>
@@ -5111,7 +5111,7 @@
           <p:cNvPr id="3" name="TextBox 2">
             <a:extLst>
               <a:ext uri="{FF2B5EF4-FFF2-40B4-BE49-F238E27FC236}">
-                <a16:creationId xmlns:a16="http://schemas.microsoft.com/office/drawing/2014/main" id="{75A08EC4-6338-4E98-61BE-3E5E5B45D6E9}"/>
+                <a16:creationId xmlns:a16="http://schemas.microsoft.com/office/drawing/2014/main" id="{46FFECFC-5877-44D0-EA3B-0DE2E3027AAA}"/>
               </a:ext>
             </a:extLst>
           </p:cNvPr>
@@ -5151,7 +5151,7 @@
           <p:cNvPr id="4" name="TextBox 3">
             <a:extLst>
               <a:ext uri="{FF2B5EF4-FFF2-40B4-BE49-F238E27FC236}">
-                <a16:creationId xmlns:a16="http://schemas.microsoft.com/office/drawing/2014/main" id="{A779D696-23C3-A986-1200-06D1D57416FD}"/>
+                <a16:creationId xmlns:a16="http://schemas.microsoft.com/office/drawing/2014/main" id="{31BD2267-F486-066B-2BA9-AC93D3105C4D}"/>
               </a:ext>
             </a:extLst>
           </p:cNvPr>
@@ -5191,7 +5191,7 @@
           <p:cNvPr id="5" name="Straight Connector 4">
             <a:extLst>
               <a:ext uri="{FF2B5EF4-FFF2-40B4-BE49-F238E27FC236}">
-                <a16:creationId xmlns:a16="http://schemas.microsoft.com/office/drawing/2014/main" id="{B2B55A0D-D29A-D85E-F11C-07300031EDBA}"/>
+                <a16:creationId xmlns:a16="http://schemas.microsoft.com/office/drawing/2014/main" id="{D3FCC5EA-B765-D47A-848E-B0CB529DC40D}"/>
               </a:ext>
             </a:extLst>
           </p:cNvPr>
@@ -5232,7 +5232,7 @@
           <p:cNvPr id="6" name="TextBox 5">
             <a:extLst>
               <a:ext uri="{FF2B5EF4-FFF2-40B4-BE49-F238E27FC236}">
-                <a16:creationId xmlns:a16="http://schemas.microsoft.com/office/drawing/2014/main" id="{EB1D76A6-73F8-2D7F-3DAD-1E9E0E3CE147}"/>
+                <a16:creationId xmlns:a16="http://schemas.microsoft.com/office/drawing/2014/main" id="{AFE57C32-7965-2D0E-7BC4-E7853A7EAC96}"/>
               </a:ext>
             </a:extLst>
           </p:cNvPr>
@@ -5278,7 +5278,7 @@
           <p:cNvPr id="7" name="TextBox 6">
             <a:extLst>
               <a:ext uri="{FF2B5EF4-FFF2-40B4-BE49-F238E27FC236}">
-                <a16:creationId xmlns:a16="http://schemas.microsoft.com/office/drawing/2014/main" id="{2CE30246-A059-3BAD-85FC-24A0DFC8F072}"/>
+                <a16:creationId xmlns:a16="http://schemas.microsoft.com/office/drawing/2014/main" id="{7462C42C-174D-5530-75D9-86A51692B864}"/>
               </a:ext>
             </a:extLst>
           </p:cNvPr>
@@ -5318,7 +5318,7 @@
           <p:cNvPr id="8" name="TextBox 7">
             <a:extLst>
               <a:ext uri="{FF2B5EF4-FFF2-40B4-BE49-F238E27FC236}">
-                <a16:creationId xmlns:a16="http://schemas.microsoft.com/office/drawing/2014/main" id="{F3D056BF-6D15-4AF3-FBEE-F2BE8A0F7C6E}"/>
+                <a16:creationId xmlns:a16="http://schemas.microsoft.com/office/drawing/2014/main" id="{7106E705-CAB0-BEF2-66A1-2D81715797A0}"/>
               </a:ext>
             </a:extLst>
           </p:cNvPr>
@@ -5358,7 +5358,7 @@
           <p:cNvPr id="9" name="TextBox 8">
             <a:extLst>
               <a:ext uri="{FF2B5EF4-FFF2-40B4-BE49-F238E27FC236}">
-                <a16:creationId xmlns:a16="http://schemas.microsoft.com/office/drawing/2014/main" id="{2091D893-E68F-40B1-ED80-40306703AE22}"/>
+                <a16:creationId xmlns:a16="http://schemas.microsoft.com/office/drawing/2014/main" id="{80C3D356-3CD7-095F-E0A9-DADB64B42C38}"/>
               </a:ext>
             </a:extLst>
           </p:cNvPr>
@@ -5367,8 +5367,8 @@
         </p:nvSpPr>
         <p:spPr>
           <a:xfrm>
-            <a:off x="762000" y="5994400"/>
-            <a:ext cx="5588000" cy="254000"/>
+            <a:off x="762000" y="5968999"/>
+            <a:ext cx="6096000" cy="304800"/>
           </a:xfrm>
           <a:prstGeom prst="rect">
             <a:avLst/>
@@ -5382,7 +5382,7 @@
           <a:lstStyle/>
           <a:p>
             <a:r>
-              <a:rPr lang="en-US" sz="1300">
+              <a:rPr lang="en-US" sz="1600">
                 <a:solidFill>
                   <a:srgbClr val="83939D"/>
                 </a:solidFill>
@@ -5396,7 +5396,7 @@
     </p:spTree>
     <p:extLst>
       <p:ext uri="{BB962C8B-B14F-4D97-AF65-F5344CB8AC3E}">
-        <p14:creationId xmlns:p14="http://schemas.microsoft.com/office/powerpoint/2010/main" val="1185960324"/>
+        <p14:creationId xmlns:p14="http://schemas.microsoft.com/office/powerpoint/2010/main" val="2979189529"/>
       </p:ext>
     </p:extLst>
   </p:cSld>
@@ -5436,7 +5436,7 @@
           <p:cNvPr id="2" name="TextBox 1">
             <a:extLst>
               <a:ext uri="{FF2B5EF4-FFF2-40B4-BE49-F238E27FC236}">
-                <a16:creationId xmlns:a16="http://schemas.microsoft.com/office/drawing/2014/main" id="{1620ED68-AF2E-739E-DA60-F3855E038C4B}"/>
+                <a16:creationId xmlns:a16="http://schemas.microsoft.com/office/drawing/2014/main" id="{155D0907-D779-2C12-20F4-60267C0D47DD}"/>
               </a:ext>
             </a:extLst>
           </p:cNvPr>
@@ -5445,8 +5445,8 @@
         </p:nvSpPr>
         <p:spPr>
           <a:xfrm>
-            <a:off x="609600" y="254000"/>
-            <a:ext cx="3429000" cy="228600"/>
+            <a:off x="609600" y="228599"/>
+            <a:ext cx="3810000" cy="279400"/>
           </a:xfrm>
           <a:prstGeom prst="rect">
             <a:avLst/>
@@ -5460,7 +5460,7 @@
           <a:lstStyle/>
           <a:p>
             <a:r>
-              <a:rPr lang="en-US" sz="1100" b="1">
+              <a:rPr lang="en-US" sz="1600" b="1">
                 <a:solidFill>
                   <a:srgbClr val="83939D"/>
                 </a:solidFill>
@@ -5476,7 +5476,7 @@
           <p:cNvPr id="3" name="Straight Connector 2">
             <a:extLst>
               <a:ext uri="{FF2B5EF4-FFF2-40B4-BE49-F238E27FC236}">
-                <a16:creationId xmlns:a16="http://schemas.microsoft.com/office/drawing/2014/main" id="{1E858626-3F3A-044B-9707-3BD028B72A3D}"/>
+                <a16:creationId xmlns:a16="http://schemas.microsoft.com/office/drawing/2014/main" id="{114A0704-C1C0-4662-C455-C4B432EAB103}"/>
               </a:ext>
             </a:extLst>
           </p:cNvPr>
@@ -5517,7 +5517,7 @@
           <p:cNvPr id="4" name="TextBox 3">
             <a:extLst>
               <a:ext uri="{FF2B5EF4-FFF2-40B4-BE49-F238E27FC236}">
-                <a16:creationId xmlns:a16="http://schemas.microsoft.com/office/drawing/2014/main" id="{74113A65-AB60-1AE4-5339-CA2E034F3F2B}"/>
+                <a16:creationId xmlns:a16="http://schemas.microsoft.com/office/drawing/2014/main" id="{44D5DEA8-42C8-6754-6247-CDA83118FE40}"/>
               </a:ext>
             </a:extLst>
           </p:cNvPr>
@@ -5526,8 +5526,8 @@
         </p:nvSpPr>
         <p:spPr>
           <a:xfrm>
-            <a:off x="11201400" y="6451600"/>
-            <a:ext cx="381000" cy="203200"/>
+            <a:off x="11150600" y="6388099"/>
+            <a:ext cx="431800" cy="279400"/>
           </a:xfrm>
           <a:prstGeom prst="rect">
             <a:avLst/>
@@ -5542,7 +5542,7 @@
           <a:p>
             <a:pPr algn="r"/>
             <a:r>
-              <a:rPr lang="en-US" sz="1000">
+              <a:rPr lang="en-US" sz="1600">
                 <a:solidFill>
                   <a:srgbClr val="83939D"/>
                 </a:solidFill>
@@ -5558,7 +5558,7 @@
           <p:cNvPr id="5" name="TextBox 4">
             <a:extLst>
               <a:ext uri="{FF2B5EF4-FFF2-40B4-BE49-F238E27FC236}">
-                <a16:creationId xmlns:a16="http://schemas.microsoft.com/office/drawing/2014/main" id="{E20E7D01-80BC-31E2-66F7-327FB358FE53}"/>
+                <a16:creationId xmlns:a16="http://schemas.microsoft.com/office/drawing/2014/main" id="{058663C1-D072-488A-8798-F97CD484E323}"/>
               </a:ext>
             </a:extLst>
           </p:cNvPr>
@@ -5567,8 +5567,8 @@
         </p:nvSpPr>
         <p:spPr>
           <a:xfrm>
-            <a:off x="609600" y="6438900"/>
-            <a:ext cx="3556000" cy="203200"/>
+            <a:off x="609600" y="6388099"/>
+            <a:ext cx="4064000" cy="279400"/>
           </a:xfrm>
           <a:prstGeom prst="rect">
             <a:avLst/>
@@ -5582,7 +5582,7 @@
           <a:lstStyle/>
           <a:p>
             <a:r>
-              <a:rPr lang="en-US" sz="900">
+              <a:rPr lang="en-US" sz="1600">
                 <a:solidFill>
                   <a:srgbClr val="83939D"/>
                 </a:solidFill>
@@ -5598,7 +5598,7 @@
           <p:cNvPr id="6" name="TextBox 5">
             <a:extLst>
               <a:ext uri="{FF2B5EF4-FFF2-40B4-BE49-F238E27FC236}">
-                <a16:creationId xmlns:a16="http://schemas.microsoft.com/office/drawing/2014/main" id="{FF84049B-0F95-4BAF-49D0-035C7CBAF0F8}"/>
+                <a16:creationId xmlns:a16="http://schemas.microsoft.com/office/drawing/2014/main" id="{B7A54890-6AE6-CCF4-ECE5-9D953AD7C698}"/>
               </a:ext>
             </a:extLst>
           </p:cNvPr>
@@ -5638,7 +5638,7 @@
           <p:cNvPr id="7" name="TextBox 6">
             <a:extLst>
               <a:ext uri="{FF2B5EF4-FFF2-40B4-BE49-F238E27FC236}">
-                <a16:creationId xmlns:a16="http://schemas.microsoft.com/office/drawing/2014/main" id="{F305A028-5F56-9A57-49F4-BD7E6E18C739}"/>
+                <a16:creationId xmlns:a16="http://schemas.microsoft.com/office/drawing/2014/main" id="{B3D081DA-8AA4-1DBA-8635-85E3AB4018A7}"/>
               </a:ext>
             </a:extLst>
           </p:cNvPr>
@@ -5678,7 +5678,7 @@
           <p:cNvPr id="8" name="TextBox 7">
             <a:extLst>
               <a:ext uri="{FF2B5EF4-FFF2-40B4-BE49-F238E27FC236}">
-                <a16:creationId xmlns:a16="http://schemas.microsoft.com/office/drawing/2014/main" id="{09108827-5B6B-5D78-01E5-E56927A9B885}"/>
+                <a16:creationId xmlns:a16="http://schemas.microsoft.com/office/drawing/2014/main" id="{EAACBDE9-5E3C-CCAA-49EC-83C5AB98DF6B}"/>
               </a:ext>
             </a:extLst>
           </p:cNvPr>
@@ -5719,7 +5719,7 @@
           <p:cNvPr id="9" name="TextBox 8">
             <a:extLst>
               <a:ext uri="{FF2B5EF4-FFF2-40B4-BE49-F238E27FC236}">
-                <a16:creationId xmlns:a16="http://schemas.microsoft.com/office/drawing/2014/main" id="{FA1CF9EC-5FAB-A3AA-14F3-39BBAFD674B0}"/>
+                <a16:creationId xmlns:a16="http://schemas.microsoft.com/office/drawing/2014/main" id="{BBD9DE0B-A577-36C9-8A5A-B463D7EB338A}"/>
               </a:ext>
             </a:extLst>
           </p:cNvPr>
@@ -5759,7 +5759,7 @@
           <p:cNvPr id="10" name="Straight Connector 9">
             <a:extLst>
               <a:ext uri="{FF2B5EF4-FFF2-40B4-BE49-F238E27FC236}">
-                <a16:creationId xmlns:a16="http://schemas.microsoft.com/office/drawing/2014/main" id="{2ECDFF4C-12E8-FBA2-1B98-2D355241D546}"/>
+                <a16:creationId xmlns:a16="http://schemas.microsoft.com/office/drawing/2014/main" id="{34B99281-7F7D-101D-B073-DCABD8053168}"/>
               </a:ext>
             </a:extLst>
           </p:cNvPr>
@@ -5800,7 +5800,7 @@
           <p:cNvPr id="11" name="TextBox 10">
             <a:extLst>
               <a:ext uri="{FF2B5EF4-FFF2-40B4-BE49-F238E27FC236}">
-                <a16:creationId xmlns:a16="http://schemas.microsoft.com/office/drawing/2014/main" id="{ECFBDD96-6F53-2807-219D-2ADFED214E9D}"/>
+                <a16:creationId xmlns:a16="http://schemas.microsoft.com/office/drawing/2014/main" id="{8D59026D-80D4-775A-33DD-9D1BC1EAC60C}"/>
               </a:ext>
             </a:extLst>
           </p:cNvPr>
@@ -5809,8 +5809,8 @@
         </p:nvSpPr>
         <p:spPr>
           <a:xfrm>
-            <a:off x="5295900" y="3784599"/>
-            <a:ext cx="660400" cy="279400"/>
+            <a:off x="5295900" y="3771899"/>
+            <a:ext cx="736600" cy="304800"/>
           </a:xfrm>
           <a:prstGeom prst="rect">
             <a:avLst/>
@@ -5824,7 +5824,7 @@
           <a:lstStyle/>
           <a:p>
             <a:r>
-              <a:rPr lang="en-US" sz="1500" b="1">
+              <a:rPr lang="en-US" sz="1600" b="1">
                 <a:solidFill>
                   <a:srgbClr val="3FC6AC"/>
                 </a:solidFill>
@@ -5840,7 +5840,7 @@
           <p:cNvPr id="12" name="TextBox 11">
             <a:extLst>
               <a:ext uri="{FF2B5EF4-FFF2-40B4-BE49-F238E27FC236}">
-                <a16:creationId xmlns:a16="http://schemas.microsoft.com/office/drawing/2014/main" id="{16449469-E641-3050-0F4D-271FF55CCB0C}"/>
+                <a16:creationId xmlns:a16="http://schemas.microsoft.com/office/drawing/2014/main" id="{5A2FB663-ABD4-BA46-B987-4F7A16003450}"/>
               </a:ext>
             </a:extLst>
           </p:cNvPr>
@@ -5880,7 +5880,7 @@
           <p:cNvPr id="13" name="Straight Connector 12">
             <a:extLst>
               <a:ext uri="{FF2B5EF4-FFF2-40B4-BE49-F238E27FC236}">
-                <a16:creationId xmlns:a16="http://schemas.microsoft.com/office/drawing/2014/main" id="{F41BDE25-3A27-9086-7E59-68BEC842AA52}"/>
+                <a16:creationId xmlns:a16="http://schemas.microsoft.com/office/drawing/2014/main" id="{8664BABF-A090-BE0F-FEF0-B46C9CC27048}"/>
               </a:ext>
             </a:extLst>
           </p:cNvPr>
@@ -5921,7 +5921,7 @@
           <p:cNvPr id="14" name="TextBox 13">
             <a:extLst>
               <a:ext uri="{FF2B5EF4-FFF2-40B4-BE49-F238E27FC236}">
-                <a16:creationId xmlns:a16="http://schemas.microsoft.com/office/drawing/2014/main" id="{95F90245-C976-FA57-E0B5-B5661BEC4A94}"/>
+                <a16:creationId xmlns:a16="http://schemas.microsoft.com/office/drawing/2014/main" id="{55377C3F-A10B-2592-63D7-D62B0301AE4E}"/>
               </a:ext>
             </a:extLst>
           </p:cNvPr>
@@ -5930,8 +5930,8 @@
         </p:nvSpPr>
         <p:spPr>
           <a:xfrm>
-            <a:off x="5295900" y="4178299"/>
-            <a:ext cx="660400" cy="279400"/>
+            <a:off x="5295900" y="4165599"/>
+            <a:ext cx="736600" cy="304800"/>
           </a:xfrm>
           <a:prstGeom prst="rect">
             <a:avLst/>
@@ -5945,7 +5945,7 @@
           <a:lstStyle/>
           <a:p>
             <a:r>
-              <a:rPr lang="en-US" sz="1500" b="1">
+              <a:rPr lang="en-US" sz="1600" b="1">
                 <a:solidFill>
                   <a:srgbClr val="3FC6AC"/>
                 </a:solidFill>
@@ -5961,7 +5961,7 @@
           <p:cNvPr id="15" name="TextBox 14">
             <a:extLst>
               <a:ext uri="{FF2B5EF4-FFF2-40B4-BE49-F238E27FC236}">
-                <a16:creationId xmlns:a16="http://schemas.microsoft.com/office/drawing/2014/main" id="{2B57619C-3BA0-E0CF-44C4-5B1C17CC1F1B}"/>
+                <a16:creationId xmlns:a16="http://schemas.microsoft.com/office/drawing/2014/main" id="{615FE6EA-B1E7-AA7E-3DAC-EAF0D22E7BEC}"/>
               </a:ext>
             </a:extLst>
           </p:cNvPr>
@@ -6001,7 +6001,7 @@
           <p:cNvPr id="16" name="Straight Connector 15">
             <a:extLst>
               <a:ext uri="{FF2B5EF4-FFF2-40B4-BE49-F238E27FC236}">
-                <a16:creationId xmlns:a16="http://schemas.microsoft.com/office/drawing/2014/main" id="{5347C39B-99F6-5FB9-FA28-13EAFB788948}"/>
+                <a16:creationId xmlns:a16="http://schemas.microsoft.com/office/drawing/2014/main" id="{FBF13143-D15C-1549-C498-EC53C744E703}"/>
               </a:ext>
             </a:extLst>
           </p:cNvPr>
@@ -6042,7 +6042,7 @@
           <p:cNvPr id="17" name="TextBox 16">
             <a:extLst>
               <a:ext uri="{FF2B5EF4-FFF2-40B4-BE49-F238E27FC236}">
-                <a16:creationId xmlns:a16="http://schemas.microsoft.com/office/drawing/2014/main" id="{2DAF3405-178A-053C-CAB1-358BF42FD3E6}"/>
+                <a16:creationId xmlns:a16="http://schemas.microsoft.com/office/drawing/2014/main" id="{A26D3635-45C6-F110-BBB6-623027F7E0A1}"/>
               </a:ext>
             </a:extLst>
           </p:cNvPr>
@@ -6051,8 +6051,8 @@
         </p:nvSpPr>
         <p:spPr>
           <a:xfrm>
-            <a:off x="5295900" y="4571999"/>
-            <a:ext cx="660400" cy="279400"/>
+            <a:off x="5295900" y="4559299"/>
+            <a:ext cx="736600" cy="304800"/>
           </a:xfrm>
           <a:prstGeom prst="rect">
             <a:avLst/>
@@ -6066,7 +6066,7 @@
           <a:lstStyle/>
           <a:p>
             <a:r>
-              <a:rPr lang="en-US" sz="1500" b="1">
+              <a:rPr lang="en-US" sz="1600" b="1">
                 <a:solidFill>
                   <a:srgbClr val="3FC6AC"/>
                 </a:solidFill>
@@ -6082,7 +6082,7 @@
           <p:cNvPr id="18" name="TextBox 17">
             <a:extLst>
               <a:ext uri="{FF2B5EF4-FFF2-40B4-BE49-F238E27FC236}">
-                <a16:creationId xmlns:a16="http://schemas.microsoft.com/office/drawing/2014/main" id="{EB9CF5CC-9F17-DDA1-6512-E1869017435F}"/>
+                <a16:creationId xmlns:a16="http://schemas.microsoft.com/office/drawing/2014/main" id="{315BFECA-CE9B-2AF6-7E25-DEFE009FCF39}"/>
               </a:ext>
             </a:extLst>
           </p:cNvPr>
@@ -6122,7 +6122,7 @@
           <p:cNvPr id="19" name="Straight Connector 18">
             <a:extLst>
               <a:ext uri="{FF2B5EF4-FFF2-40B4-BE49-F238E27FC236}">
-                <a16:creationId xmlns:a16="http://schemas.microsoft.com/office/drawing/2014/main" id="{80D408CE-1D2C-C3C1-83B2-579F9C819106}"/>
+                <a16:creationId xmlns:a16="http://schemas.microsoft.com/office/drawing/2014/main" id="{3DA0A2A4-D566-D896-D541-C48548FE70FC}"/>
               </a:ext>
             </a:extLst>
           </p:cNvPr>
@@ -6163,7 +6163,7 @@
           <p:cNvPr id="20" name="TextBox 19">
             <a:extLst>
               <a:ext uri="{FF2B5EF4-FFF2-40B4-BE49-F238E27FC236}">
-                <a16:creationId xmlns:a16="http://schemas.microsoft.com/office/drawing/2014/main" id="{0EDC0CDC-9224-2907-6E92-6629E875F954}"/>
+                <a16:creationId xmlns:a16="http://schemas.microsoft.com/office/drawing/2014/main" id="{9B9658C7-ACD3-3D4E-6094-B67A79D42E9F}"/>
               </a:ext>
             </a:extLst>
           </p:cNvPr>
@@ -6172,8 +6172,8 @@
         </p:nvSpPr>
         <p:spPr>
           <a:xfrm>
-            <a:off x="5295900" y="4965699"/>
-            <a:ext cx="660400" cy="279400"/>
+            <a:off x="5295900" y="4952999"/>
+            <a:ext cx="736600" cy="304800"/>
           </a:xfrm>
           <a:prstGeom prst="rect">
             <a:avLst/>
@@ -6187,7 +6187,7 @@
           <a:lstStyle/>
           <a:p>
             <a:r>
-              <a:rPr lang="en-US" sz="1500" b="1">
+              <a:rPr lang="en-US" sz="1600" b="1">
                 <a:solidFill>
                   <a:srgbClr val="3FC6AC"/>
                 </a:solidFill>
@@ -6203,7 +6203,7 @@
           <p:cNvPr id="21" name="TextBox 20">
             <a:extLst>
               <a:ext uri="{FF2B5EF4-FFF2-40B4-BE49-F238E27FC236}">
-                <a16:creationId xmlns:a16="http://schemas.microsoft.com/office/drawing/2014/main" id="{8D3FA1C6-9B77-141C-9947-F36CC9AFA6BA}"/>
+                <a16:creationId xmlns:a16="http://schemas.microsoft.com/office/drawing/2014/main" id="{7D1C3FD6-40C1-D0F7-1C98-FAAF9AB5BF05}"/>
               </a:ext>
             </a:extLst>
           </p:cNvPr>
@@ -6243,7 +6243,7 @@
           <p:cNvPr id="22" name="Straight Connector 21">
             <a:extLst>
               <a:ext uri="{FF2B5EF4-FFF2-40B4-BE49-F238E27FC236}">
-                <a16:creationId xmlns:a16="http://schemas.microsoft.com/office/drawing/2014/main" id="{5914CC23-5135-F1C1-CF6F-A1C99E8846B4}"/>
+                <a16:creationId xmlns:a16="http://schemas.microsoft.com/office/drawing/2014/main" id="{33AE1862-049F-5C22-E745-EA2D28051F1D}"/>
               </a:ext>
             </a:extLst>
           </p:cNvPr>
@@ -6284,7 +6284,7 @@
           <p:cNvPr id="23" name="TextBox 22">
             <a:extLst>
               <a:ext uri="{FF2B5EF4-FFF2-40B4-BE49-F238E27FC236}">
-                <a16:creationId xmlns:a16="http://schemas.microsoft.com/office/drawing/2014/main" id="{401C9805-3348-C8AF-1E2B-F20FEC9E057B}"/>
+                <a16:creationId xmlns:a16="http://schemas.microsoft.com/office/drawing/2014/main" id="{70F28CCA-06FC-4FB1-D253-E07B2F4867BE}"/>
               </a:ext>
             </a:extLst>
           </p:cNvPr>
@@ -6293,8 +6293,8 @@
         </p:nvSpPr>
         <p:spPr>
           <a:xfrm>
-            <a:off x="5295900" y="5359399"/>
-            <a:ext cx="660400" cy="279400"/>
+            <a:off x="5295900" y="5346699"/>
+            <a:ext cx="736600" cy="304800"/>
           </a:xfrm>
           <a:prstGeom prst="rect">
             <a:avLst/>
@@ -6308,7 +6308,7 @@
           <a:lstStyle/>
           <a:p>
             <a:r>
-              <a:rPr lang="en-US" sz="1500" b="1">
+              <a:rPr lang="en-US" sz="1600" b="1">
                 <a:solidFill>
                   <a:srgbClr val="3FC6AC"/>
                 </a:solidFill>
@@ -6324,7 +6324,7 @@
           <p:cNvPr id="24" name="TextBox 23">
             <a:extLst>
               <a:ext uri="{FF2B5EF4-FFF2-40B4-BE49-F238E27FC236}">
-                <a16:creationId xmlns:a16="http://schemas.microsoft.com/office/drawing/2014/main" id="{69C8AEBB-F716-13FA-32D4-3F5EE60CD55D}"/>
+                <a16:creationId xmlns:a16="http://schemas.microsoft.com/office/drawing/2014/main" id="{CE8B7AED-52DF-DDFD-04E8-10C06B78EBFD}"/>
               </a:ext>
             </a:extLst>
           </p:cNvPr>
@@ -6364,7 +6364,7 @@
           <p:cNvPr id="25" name="Straight Connector 24">
             <a:extLst>
               <a:ext uri="{FF2B5EF4-FFF2-40B4-BE49-F238E27FC236}">
-                <a16:creationId xmlns:a16="http://schemas.microsoft.com/office/drawing/2014/main" id="{54562770-B688-8E02-C619-D576F7244BE3}"/>
+                <a16:creationId xmlns:a16="http://schemas.microsoft.com/office/drawing/2014/main" id="{8A72D621-0E44-DE86-0B67-42D9E482BD9E}"/>
               </a:ext>
             </a:extLst>
           </p:cNvPr>
@@ -6405,7 +6405,7 @@
           <p:cNvPr id="26" name="TextBox 25">
             <a:extLst>
               <a:ext uri="{FF2B5EF4-FFF2-40B4-BE49-F238E27FC236}">
-                <a16:creationId xmlns:a16="http://schemas.microsoft.com/office/drawing/2014/main" id="{FAB2FDB9-F223-D9D1-9131-47508BB62EFA}"/>
+                <a16:creationId xmlns:a16="http://schemas.microsoft.com/office/drawing/2014/main" id="{C127DEFC-6A84-4E9B-6DB0-340103CC35A1}"/>
               </a:ext>
             </a:extLst>
           </p:cNvPr>
@@ -6414,8 +6414,8 @@
         </p:nvSpPr>
         <p:spPr>
           <a:xfrm>
-            <a:off x="5295900" y="5753099"/>
-            <a:ext cx="660400" cy="279400"/>
+            <a:off x="5295900" y="5740399"/>
+            <a:ext cx="736600" cy="304800"/>
           </a:xfrm>
           <a:prstGeom prst="rect">
             <a:avLst/>
@@ -6429,7 +6429,7 @@
           <a:lstStyle/>
           <a:p>
             <a:r>
-              <a:rPr lang="en-US" sz="1500" b="1">
+              <a:rPr lang="en-US" sz="1600" b="1">
                 <a:solidFill>
                   <a:srgbClr val="3FC6AC"/>
                 </a:solidFill>
@@ -6445,7 +6445,7 @@
           <p:cNvPr id="27" name="Straight Connector 26">
             <a:extLst>
               <a:ext uri="{FF2B5EF4-FFF2-40B4-BE49-F238E27FC236}">
-                <a16:creationId xmlns:a16="http://schemas.microsoft.com/office/drawing/2014/main" id="{25AC55BC-82FD-8773-61F0-8D906DE03F2A}"/>
+                <a16:creationId xmlns:a16="http://schemas.microsoft.com/office/drawing/2014/main" id="{60EE363C-6D75-A564-77EF-ED4FCF5E487C}"/>
               </a:ext>
             </a:extLst>
           </p:cNvPr>
@@ -6486,7 +6486,7 @@
           <p:cNvPr id="28" name="TextBox 27">
             <a:extLst>
               <a:ext uri="{FF2B5EF4-FFF2-40B4-BE49-F238E27FC236}">
-                <a16:creationId xmlns:a16="http://schemas.microsoft.com/office/drawing/2014/main" id="{3CD64220-4E5C-8135-4660-C7EC5EB0819A}"/>
+                <a16:creationId xmlns:a16="http://schemas.microsoft.com/office/drawing/2014/main" id="{5466BCB5-90B9-2BE2-58FD-69FE262FF540}"/>
               </a:ext>
             </a:extLst>
           </p:cNvPr>
@@ -6526,7 +6526,7 @@
           <p:cNvPr id="29" name="TextBox 28">
             <a:extLst>
               <a:ext uri="{FF2B5EF4-FFF2-40B4-BE49-F238E27FC236}">
-                <a16:creationId xmlns:a16="http://schemas.microsoft.com/office/drawing/2014/main" id="{14FF8D5D-5B73-E878-2501-56FD039E70D9}"/>
+                <a16:creationId xmlns:a16="http://schemas.microsoft.com/office/drawing/2014/main" id="{7C654439-B0B8-3114-CDAF-6B167F3527D3}"/>
               </a:ext>
             </a:extLst>
           </p:cNvPr>
@@ -6566,7 +6566,7 @@
           <p:cNvPr id="30" name="TextBox 29">
             <a:extLst>
               <a:ext uri="{FF2B5EF4-FFF2-40B4-BE49-F238E27FC236}">
-                <a16:creationId xmlns:a16="http://schemas.microsoft.com/office/drawing/2014/main" id="{E8C99786-3901-404C-7E4E-47CA7CB63A98}"/>
+                <a16:creationId xmlns:a16="http://schemas.microsoft.com/office/drawing/2014/main" id="{6FAFC9BE-7E7D-4C01-A88A-D559BAF69440}"/>
               </a:ext>
             </a:extLst>
           </p:cNvPr>
@@ -6607,7 +6607,7 @@
           <p:cNvPr id="31" name="TextBox 30">
             <a:extLst>
               <a:ext uri="{FF2B5EF4-FFF2-40B4-BE49-F238E27FC236}">
-                <a16:creationId xmlns:a16="http://schemas.microsoft.com/office/drawing/2014/main" id="{47D89C19-7974-A3B1-E939-D04D46B3C49A}"/>
+                <a16:creationId xmlns:a16="http://schemas.microsoft.com/office/drawing/2014/main" id="{3BE5E485-FB62-77E7-08F4-A0710C772FC3}"/>
               </a:ext>
             </a:extLst>
           </p:cNvPr>
@@ -6647,7 +6647,7 @@
           <p:cNvPr id="32" name="TextBox 31">
             <a:extLst>
               <a:ext uri="{FF2B5EF4-FFF2-40B4-BE49-F238E27FC236}">
-                <a16:creationId xmlns:a16="http://schemas.microsoft.com/office/drawing/2014/main" id="{619D4A6B-DBD1-A004-A6E2-77B05646D727}"/>
+                <a16:creationId xmlns:a16="http://schemas.microsoft.com/office/drawing/2014/main" id="{0B903B98-12A2-E49D-7DC5-C21A2CD3B69D}"/>
               </a:ext>
             </a:extLst>
           </p:cNvPr>
@@ -6687,7 +6687,7 @@
           <p:cNvPr id="33" name="TextBox 32">
             <a:extLst>
               <a:ext uri="{FF2B5EF4-FFF2-40B4-BE49-F238E27FC236}">
-                <a16:creationId xmlns:a16="http://schemas.microsoft.com/office/drawing/2014/main" id="{29B8012B-A560-A476-6C97-798B43B671F9}"/>
+                <a16:creationId xmlns:a16="http://schemas.microsoft.com/office/drawing/2014/main" id="{6EE72CC5-5930-04D2-CB15-F51C5B40111A}"/>
               </a:ext>
             </a:extLst>
           </p:cNvPr>
@@ -6726,7 +6726,7 @@
     </p:spTree>
     <p:extLst>
       <p:ext uri="{BB962C8B-B14F-4D97-AF65-F5344CB8AC3E}">
-        <p14:creationId xmlns:p14="http://schemas.microsoft.com/office/powerpoint/2010/main" val="2135830995"/>
+        <p14:creationId xmlns:p14="http://schemas.microsoft.com/office/powerpoint/2010/main" val="291847361"/>
       </p:ext>
     </p:extLst>
   </p:cSld>
@@ -6766,7 +6766,7 @@
           <p:cNvPr id="2" name="TextBox 1">
             <a:extLst>
               <a:ext uri="{FF2B5EF4-FFF2-40B4-BE49-F238E27FC236}">
-                <a16:creationId xmlns:a16="http://schemas.microsoft.com/office/drawing/2014/main" id="{BC7B691A-03A9-F6FB-1365-ED639D248F94}"/>
+                <a16:creationId xmlns:a16="http://schemas.microsoft.com/office/drawing/2014/main" id="{9E558A67-5693-8C83-3617-262C2378FBC2}"/>
               </a:ext>
             </a:extLst>
           </p:cNvPr>
@@ -6775,8 +6775,8 @@
         </p:nvSpPr>
         <p:spPr>
           <a:xfrm>
-            <a:off x="609600" y="254000"/>
-            <a:ext cx="3429000" cy="228600"/>
+            <a:off x="609600" y="228599"/>
+            <a:ext cx="3810000" cy="279400"/>
           </a:xfrm>
           <a:prstGeom prst="rect">
             <a:avLst/>
@@ -6790,7 +6790,7 @@
           <a:lstStyle/>
           <a:p>
             <a:r>
-              <a:rPr lang="en-US" sz="1100" b="1">
+              <a:rPr lang="en-US" sz="1600" b="1">
                 <a:solidFill>
                   <a:srgbClr val="60727D"/>
                 </a:solidFill>
@@ -6806,7 +6806,7 @@
           <p:cNvPr id="3" name="Straight Connector 2">
             <a:extLst>
               <a:ext uri="{FF2B5EF4-FFF2-40B4-BE49-F238E27FC236}">
-                <a16:creationId xmlns:a16="http://schemas.microsoft.com/office/drawing/2014/main" id="{AC98C779-D963-CCDA-3A16-0E670192BE59}"/>
+                <a16:creationId xmlns:a16="http://schemas.microsoft.com/office/drawing/2014/main" id="{3FAC0B94-1BB4-F793-3855-26427F974971}"/>
               </a:ext>
             </a:extLst>
           </p:cNvPr>
@@ -6847,7 +6847,7 @@
           <p:cNvPr id="4" name="TextBox 3">
             <a:extLst>
               <a:ext uri="{FF2B5EF4-FFF2-40B4-BE49-F238E27FC236}">
-                <a16:creationId xmlns:a16="http://schemas.microsoft.com/office/drawing/2014/main" id="{4B73F239-DDBC-D103-108B-C269AEB271B4}"/>
+                <a16:creationId xmlns:a16="http://schemas.microsoft.com/office/drawing/2014/main" id="{ADAC40E1-84DF-5078-347E-BC83A0EBE1CC}"/>
               </a:ext>
             </a:extLst>
           </p:cNvPr>
@@ -6856,8 +6856,8 @@
         </p:nvSpPr>
         <p:spPr>
           <a:xfrm>
-            <a:off x="11201400" y="6451600"/>
-            <a:ext cx="381000" cy="203200"/>
+            <a:off x="11150600" y="6388099"/>
+            <a:ext cx="431800" cy="279400"/>
           </a:xfrm>
           <a:prstGeom prst="rect">
             <a:avLst/>
@@ -6872,7 +6872,7 @@
           <a:p>
             <a:pPr algn="r"/>
             <a:r>
-              <a:rPr lang="en-US" sz="1000">
+              <a:rPr lang="en-US" sz="1600">
                 <a:solidFill>
                   <a:srgbClr val="60727D"/>
                 </a:solidFill>
@@ -6888,7 +6888,7 @@
           <p:cNvPr id="5" name="TextBox 4">
             <a:extLst>
               <a:ext uri="{FF2B5EF4-FFF2-40B4-BE49-F238E27FC236}">
-                <a16:creationId xmlns:a16="http://schemas.microsoft.com/office/drawing/2014/main" id="{061AAE8D-B4DA-541D-7690-AD1B62CF2E09}"/>
+                <a16:creationId xmlns:a16="http://schemas.microsoft.com/office/drawing/2014/main" id="{7B0CCED8-2A10-8A69-02BB-FA94A2151076}"/>
               </a:ext>
             </a:extLst>
           </p:cNvPr>
@@ -6897,8 +6897,8 @@
         </p:nvSpPr>
         <p:spPr>
           <a:xfrm>
-            <a:off x="609600" y="6438900"/>
-            <a:ext cx="3556000" cy="203200"/>
+            <a:off x="609600" y="6388099"/>
+            <a:ext cx="4064000" cy="279400"/>
           </a:xfrm>
           <a:prstGeom prst="rect">
             <a:avLst/>
@@ -6912,7 +6912,7 @@
           <a:lstStyle/>
           <a:p>
             <a:r>
-              <a:rPr lang="en-US" sz="900">
+              <a:rPr lang="en-US" sz="1600">
                 <a:solidFill>
                   <a:srgbClr val="60727D"/>
                 </a:solidFill>
@@ -6928,7 +6928,7 @@
           <p:cNvPr id="6" name="TextBox 5">
             <a:extLst>
               <a:ext uri="{FF2B5EF4-FFF2-40B4-BE49-F238E27FC236}">
-                <a16:creationId xmlns:a16="http://schemas.microsoft.com/office/drawing/2014/main" id="{078B26EE-AF9A-1A04-CF18-7522162CE813}"/>
+                <a16:creationId xmlns:a16="http://schemas.microsoft.com/office/drawing/2014/main" id="{A88B0003-F7B8-D4F6-F84D-9432CA674C38}"/>
               </a:ext>
             </a:extLst>
           </p:cNvPr>
@@ -6968,7 +6968,7 @@
           <p:cNvPr id="7" name="TextBox 6">
             <a:extLst>
               <a:ext uri="{FF2B5EF4-FFF2-40B4-BE49-F238E27FC236}">
-                <a16:creationId xmlns:a16="http://schemas.microsoft.com/office/drawing/2014/main" id="{7BBDA627-D2A4-7285-EA90-F320FB6603A2}"/>
+                <a16:creationId xmlns:a16="http://schemas.microsoft.com/office/drawing/2014/main" id="{764E48B9-5BC7-1F55-2176-312231AF15C3}"/>
               </a:ext>
             </a:extLst>
           </p:cNvPr>
@@ -7008,7 +7008,7 @@
           <p:cNvPr id="8" name="Straight Connector 7">
             <a:extLst>
               <a:ext uri="{FF2B5EF4-FFF2-40B4-BE49-F238E27FC236}">
-                <a16:creationId xmlns:a16="http://schemas.microsoft.com/office/drawing/2014/main" id="{05A00AE5-04F7-B361-3991-662494EB304E}"/>
+                <a16:creationId xmlns:a16="http://schemas.microsoft.com/office/drawing/2014/main" id="{FACBCEF3-BE77-F20E-CB6C-D526FF8377E8}"/>
               </a:ext>
             </a:extLst>
           </p:cNvPr>
@@ -7049,7 +7049,7 @@
           <p:cNvPr id="9" name="TextBox 8">
             <a:extLst>
               <a:ext uri="{FF2B5EF4-FFF2-40B4-BE49-F238E27FC236}">
-                <a16:creationId xmlns:a16="http://schemas.microsoft.com/office/drawing/2014/main" id="{8FFBF142-4CB1-5755-2F3B-EE55A7791162}"/>
+                <a16:creationId xmlns:a16="http://schemas.microsoft.com/office/drawing/2014/main" id="{04D20D56-5F95-254F-AD9F-91C0815F7D67}"/>
               </a:ext>
             </a:extLst>
           </p:cNvPr>
@@ -7089,7 +7089,7 @@
           <p:cNvPr id="10" name="Straight Connector 9">
             <a:extLst>
               <a:ext uri="{FF2B5EF4-FFF2-40B4-BE49-F238E27FC236}">
-                <a16:creationId xmlns:a16="http://schemas.microsoft.com/office/drawing/2014/main" id="{6F47FFBD-33FA-340F-691C-8081A5215795}"/>
+                <a16:creationId xmlns:a16="http://schemas.microsoft.com/office/drawing/2014/main" id="{32439760-72E9-6996-9F20-AD28BF2C5AD3}"/>
               </a:ext>
             </a:extLst>
           </p:cNvPr>
@@ -7130,7 +7130,7 @@
           <p:cNvPr id="11" name="TextBox 10">
             <a:extLst>
               <a:ext uri="{FF2B5EF4-FFF2-40B4-BE49-F238E27FC236}">
-                <a16:creationId xmlns:a16="http://schemas.microsoft.com/office/drawing/2014/main" id="{3EE46EF4-3ECA-EA1A-0090-C152F0DCF267}"/>
+                <a16:creationId xmlns:a16="http://schemas.microsoft.com/office/drawing/2014/main" id="{90E8BFC8-41B8-8410-C8F9-8EDE007729EB}"/>
               </a:ext>
             </a:extLst>
           </p:cNvPr>
@@ -7170,7 +7170,7 @@
           <p:cNvPr id="12" name="Straight Connector 11">
             <a:extLst>
               <a:ext uri="{FF2B5EF4-FFF2-40B4-BE49-F238E27FC236}">
-                <a16:creationId xmlns:a16="http://schemas.microsoft.com/office/drawing/2014/main" id="{396B8432-AD68-7F7D-B32B-37CB751CF230}"/>
+                <a16:creationId xmlns:a16="http://schemas.microsoft.com/office/drawing/2014/main" id="{9F32613E-BA28-AE26-3F94-02B1A90EB50F}"/>
               </a:ext>
             </a:extLst>
           </p:cNvPr>
@@ -7211,7 +7211,7 @@
           <p:cNvPr id="13" name="TextBox 12">
             <a:extLst>
               <a:ext uri="{FF2B5EF4-FFF2-40B4-BE49-F238E27FC236}">
-                <a16:creationId xmlns:a16="http://schemas.microsoft.com/office/drawing/2014/main" id="{4CC128BF-5F97-1961-1BA4-A2FA798CE480}"/>
+                <a16:creationId xmlns:a16="http://schemas.microsoft.com/office/drawing/2014/main" id="{494720C1-96A1-0F5C-2F7D-878462C5819F}"/>
               </a:ext>
             </a:extLst>
           </p:cNvPr>
@@ -7251,7 +7251,7 @@
           <p:cNvPr id="14" name="Straight Connector 13">
             <a:extLst>
               <a:ext uri="{FF2B5EF4-FFF2-40B4-BE49-F238E27FC236}">
-                <a16:creationId xmlns:a16="http://schemas.microsoft.com/office/drawing/2014/main" id="{AA566AAC-1ABC-CB1E-F8C8-64A5744D529E}"/>
+                <a16:creationId xmlns:a16="http://schemas.microsoft.com/office/drawing/2014/main" id="{985043AC-6159-77E6-9BEF-59055F984F1A}"/>
               </a:ext>
             </a:extLst>
           </p:cNvPr>
@@ -7292,7 +7292,7 @@
           <p:cNvPr id="15" name="TextBox 14">
             <a:extLst>
               <a:ext uri="{FF2B5EF4-FFF2-40B4-BE49-F238E27FC236}">
-                <a16:creationId xmlns:a16="http://schemas.microsoft.com/office/drawing/2014/main" id="{B4EBF083-5C3C-07B9-F770-489107C7A69C}"/>
+                <a16:creationId xmlns:a16="http://schemas.microsoft.com/office/drawing/2014/main" id="{61E2B3A0-5DCF-2B99-5BA4-608B6190308B}"/>
               </a:ext>
             </a:extLst>
           </p:cNvPr>
@@ -7332,7 +7332,7 @@
           <p:cNvPr id="16" name="TextBox 15">
             <a:extLst>
               <a:ext uri="{FF2B5EF4-FFF2-40B4-BE49-F238E27FC236}">
-                <a16:creationId xmlns:a16="http://schemas.microsoft.com/office/drawing/2014/main" id="{F140F58F-794B-6848-3BE8-6FD86052E4C8}"/>
+                <a16:creationId xmlns:a16="http://schemas.microsoft.com/office/drawing/2014/main" id="{B90CB958-598B-E4E2-5EAA-335AD85E0B12}"/>
               </a:ext>
             </a:extLst>
           </p:cNvPr>
@@ -7372,7 +7372,7 @@
           <p:cNvPr id="17" name="Straight Connector 16">
             <a:extLst>
               <a:ext uri="{FF2B5EF4-FFF2-40B4-BE49-F238E27FC236}">
-                <a16:creationId xmlns:a16="http://schemas.microsoft.com/office/drawing/2014/main" id="{85011A04-8933-D9DD-F37D-05FE02BB8DB3}"/>
+                <a16:creationId xmlns:a16="http://schemas.microsoft.com/office/drawing/2014/main" id="{03983D9D-3548-A698-0247-D1789C6487E3}"/>
               </a:ext>
             </a:extLst>
           </p:cNvPr>
@@ -7413,7 +7413,7 @@
           <p:cNvPr id="18" name="TextBox 17">
             <a:extLst>
               <a:ext uri="{FF2B5EF4-FFF2-40B4-BE49-F238E27FC236}">
-                <a16:creationId xmlns:a16="http://schemas.microsoft.com/office/drawing/2014/main" id="{313721C0-75C2-3852-5E56-6E49D6BB8E8E}"/>
+                <a16:creationId xmlns:a16="http://schemas.microsoft.com/office/drawing/2014/main" id="{36CDA73D-6714-6C01-1EDE-09B8848BD4E6}"/>
               </a:ext>
             </a:extLst>
           </p:cNvPr>
@@ -7453,7 +7453,7 @@
           <p:cNvPr id="19" name="Straight Connector 18">
             <a:extLst>
               <a:ext uri="{FF2B5EF4-FFF2-40B4-BE49-F238E27FC236}">
-                <a16:creationId xmlns:a16="http://schemas.microsoft.com/office/drawing/2014/main" id="{D9D5AAE5-EFB0-ED5F-B3C0-2D609BE249AF}"/>
+                <a16:creationId xmlns:a16="http://schemas.microsoft.com/office/drawing/2014/main" id="{183E4812-D731-BA0B-FFDB-1ED593CA4700}"/>
               </a:ext>
             </a:extLst>
           </p:cNvPr>
@@ -7494,7 +7494,7 @@
           <p:cNvPr id="20" name="TextBox 19">
             <a:extLst>
               <a:ext uri="{FF2B5EF4-FFF2-40B4-BE49-F238E27FC236}">
-                <a16:creationId xmlns:a16="http://schemas.microsoft.com/office/drawing/2014/main" id="{C02F42F4-688D-EF85-6F98-7DFBD222BBFC}"/>
+                <a16:creationId xmlns:a16="http://schemas.microsoft.com/office/drawing/2014/main" id="{79003E27-79FE-19C7-8970-51341F78ACDD}"/>
               </a:ext>
             </a:extLst>
           </p:cNvPr>
@@ -7534,7 +7534,7 @@
           <p:cNvPr id="21" name="Straight Connector 20">
             <a:extLst>
               <a:ext uri="{FF2B5EF4-FFF2-40B4-BE49-F238E27FC236}">
-                <a16:creationId xmlns:a16="http://schemas.microsoft.com/office/drawing/2014/main" id="{1AE12262-1889-165F-59A5-C9A5B48FB8EA}"/>
+                <a16:creationId xmlns:a16="http://schemas.microsoft.com/office/drawing/2014/main" id="{6FD92DEE-94C5-C2B4-5F99-029A254E6678}"/>
               </a:ext>
             </a:extLst>
           </p:cNvPr>
@@ -7575,7 +7575,7 @@
           <p:cNvPr id="22" name="TextBox 21">
             <a:extLst>
               <a:ext uri="{FF2B5EF4-FFF2-40B4-BE49-F238E27FC236}">
-                <a16:creationId xmlns:a16="http://schemas.microsoft.com/office/drawing/2014/main" id="{1E1B502F-BEE2-A910-E456-EEC51F6E2B1F}"/>
+                <a16:creationId xmlns:a16="http://schemas.microsoft.com/office/drawing/2014/main" id="{A86E4106-EDF7-B2B0-E22F-9F0EB9CBCA89}"/>
               </a:ext>
             </a:extLst>
           </p:cNvPr>
@@ -7615,7 +7615,7 @@
           <p:cNvPr id="23" name="Straight Connector 22">
             <a:extLst>
               <a:ext uri="{FF2B5EF4-FFF2-40B4-BE49-F238E27FC236}">
-                <a16:creationId xmlns:a16="http://schemas.microsoft.com/office/drawing/2014/main" id="{079F7078-D090-C6A3-BDA2-EB5F514F1727}"/>
+                <a16:creationId xmlns:a16="http://schemas.microsoft.com/office/drawing/2014/main" id="{B377F573-9C29-85CB-9BF5-C7FA13010681}"/>
               </a:ext>
             </a:extLst>
           </p:cNvPr>
@@ -7656,7 +7656,7 @@
           <p:cNvPr id="24" name="TextBox 23">
             <a:extLst>
               <a:ext uri="{FF2B5EF4-FFF2-40B4-BE49-F238E27FC236}">
-                <a16:creationId xmlns:a16="http://schemas.microsoft.com/office/drawing/2014/main" id="{97044B76-4FF9-51E2-D4B6-8B972E1671D5}"/>
+                <a16:creationId xmlns:a16="http://schemas.microsoft.com/office/drawing/2014/main" id="{05229ED5-C617-EF6E-1612-8356F96A8A88}"/>
               </a:ext>
             </a:extLst>
           </p:cNvPr>
@@ -7696,7 +7696,7 @@
           <p:cNvPr id="25" name="Rectangle: Rounded Corners 24">
             <a:extLst>
               <a:ext uri="{FF2B5EF4-FFF2-40B4-BE49-F238E27FC236}">
-                <a16:creationId xmlns:a16="http://schemas.microsoft.com/office/drawing/2014/main" id="{F0233C2E-30D2-522E-23F9-A6E78998C709}"/>
+                <a16:creationId xmlns:a16="http://schemas.microsoft.com/office/drawing/2014/main" id="{25A98BF7-C48F-55F5-45FA-93B1C2C99750}"/>
               </a:ext>
             </a:extLst>
           </p:cNvPr>
@@ -7750,7 +7750,7 @@
           <p:cNvPr id="26" name="TextBox 25">
             <a:extLst>
               <a:ext uri="{FF2B5EF4-FFF2-40B4-BE49-F238E27FC236}">
-                <a16:creationId xmlns:a16="http://schemas.microsoft.com/office/drawing/2014/main" id="{90AD40CE-873F-A6BA-00A3-36401F399361}"/>
+                <a16:creationId xmlns:a16="http://schemas.microsoft.com/office/drawing/2014/main" id="{BB3AC5E7-6CCB-2A37-BC19-0D7E01EAE6AC}"/>
               </a:ext>
             </a:extLst>
           </p:cNvPr>
@@ -7789,7 +7789,7 @@
     </p:spTree>
     <p:extLst>
       <p:ext uri="{BB962C8B-B14F-4D97-AF65-F5344CB8AC3E}">
-        <p14:creationId xmlns:p14="http://schemas.microsoft.com/office/powerpoint/2010/main" val="1461081389"/>
+        <p14:creationId xmlns:p14="http://schemas.microsoft.com/office/powerpoint/2010/main" val="77113399"/>
       </p:ext>
     </p:extLst>
   </p:cSld>
@@ -7829,7 +7829,7 @@
           <p:cNvPr id="2" name="TextBox 1">
             <a:extLst>
               <a:ext uri="{FF2B5EF4-FFF2-40B4-BE49-F238E27FC236}">
-                <a16:creationId xmlns:a16="http://schemas.microsoft.com/office/drawing/2014/main" id="{497EF040-F414-9D96-3AF2-B92BB15CCB02}"/>
+                <a16:creationId xmlns:a16="http://schemas.microsoft.com/office/drawing/2014/main" id="{58F48797-9127-F10A-99CB-64F15F6043E9}"/>
               </a:ext>
             </a:extLst>
           </p:cNvPr>
@@ -7838,8 +7838,8 @@
         </p:nvSpPr>
         <p:spPr>
           <a:xfrm>
-            <a:off x="609600" y="254000"/>
-            <a:ext cx="3429000" cy="228600"/>
+            <a:off x="609600" y="228599"/>
+            <a:ext cx="3810000" cy="279400"/>
           </a:xfrm>
           <a:prstGeom prst="rect">
             <a:avLst/>
@@ -7853,7 +7853,7 @@
           <a:lstStyle/>
           <a:p>
             <a:r>
-              <a:rPr lang="en-US" sz="1100" b="1">
+              <a:rPr lang="en-US" sz="1600" b="1">
                 <a:solidFill>
                   <a:srgbClr val="83939D"/>
                 </a:solidFill>
@@ -7869,7 +7869,7 @@
           <p:cNvPr id="3" name="Straight Connector 2">
             <a:extLst>
               <a:ext uri="{FF2B5EF4-FFF2-40B4-BE49-F238E27FC236}">
-                <a16:creationId xmlns:a16="http://schemas.microsoft.com/office/drawing/2014/main" id="{CB71AF5D-51FF-9ABA-0ABF-2079C8A56E51}"/>
+                <a16:creationId xmlns:a16="http://schemas.microsoft.com/office/drawing/2014/main" id="{7ED41298-0A47-5E82-C231-A08BA1E10D0C}"/>
               </a:ext>
             </a:extLst>
           </p:cNvPr>
@@ -7910,7 +7910,7 @@
           <p:cNvPr id="4" name="TextBox 3">
             <a:extLst>
               <a:ext uri="{FF2B5EF4-FFF2-40B4-BE49-F238E27FC236}">
-                <a16:creationId xmlns:a16="http://schemas.microsoft.com/office/drawing/2014/main" id="{3B7E11F5-726A-7521-0AFC-CD263E74A371}"/>
+                <a16:creationId xmlns:a16="http://schemas.microsoft.com/office/drawing/2014/main" id="{AFC80180-8E95-1B7F-0175-5FF06B7B23DE}"/>
               </a:ext>
             </a:extLst>
           </p:cNvPr>
@@ -7919,8 +7919,8 @@
         </p:nvSpPr>
         <p:spPr>
           <a:xfrm>
-            <a:off x="11201400" y="6451600"/>
-            <a:ext cx="381000" cy="203200"/>
+            <a:off x="11150600" y="6388099"/>
+            <a:ext cx="431800" cy="279400"/>
           </a:xfrm>
           <a:prstGeom prst="rect">
             <a:avLst/>
@@ -7935,7 +7935,7 @@
           <a:p>
             <a:pPr algn="r"/>
             <a:r>
-              <a:rPr lang="en-US" sz="1000">
+              <a:rPr lang="en-US" sz="1600">
                 <a:solidFill>
                   <a:srgbClr val="83939D"/>
                 </a:solidFill>
@@ -7951,7 +7951,7 @@
           <p:cNvPr id="5" name="TextBox 4">
             <a:extLst>
               <a:ext uri="{FF2B5EF4-FFF2-40B4-BE49-F238E27FC236}">
-                <a16:creationId xmlns:a16="http://schemas.microsoft.com/office/drawing/2014/main" id="{EC12ACED-7E33-7C46-B533-D809CE513468}"/>
+                <a16:creationId xmlns:a16="http://schemas.microsoft.com/office/drawing/2014/main" id="{ED024158-A47A-6B98-2F66-03591E2B39DE}"/>
               </a:ext>
             </a:extLst>
           </p:cNvPr>
@@ -7960,8 +7960,8 @@
         </p:nvSpPr>
         <p:spPr>
           <a:xfrm>
-            <a:off x="609600" y="6438900"/>
-            <a:ext cx="3556000" cy="203200"/>
+            <a:off x="609600" y="6388099"/>
+            <a:ext cx="4064000" cy="279400"/>
           </a:xfrm>
           <a:prstGeom prst="rect">
             <a:avLst/>
@@ -7975,7 +7975,7 @@
           <a:lstStyle/>
           <a:p>
             <a:r>
-              <a:rPr lang="en-US" sz="900">
+              <a:rPr lang="en-US" sz="1600">
                 <a:solidFill>
                   <a:srgbClr val="83939D"/>
                 </a:solidFill>
@@ -7991,7 +7991,7 @@
           <p:cNvPr id="6" name="TextBox 5">
             <a:extLst>
               <a:ext uri="{FF2B5EF4-FFF2-40B4-BE49-F238E27FC236}">
-                <a16:creationId xmlns:a16="http://schemas.microsoft.com/office/drawing/2014/main" id="{9153DE0B-0508-0901-C0A0-DCB6AFE723EF}"/>
+                <a16:creationId xmlns:a16="http://schemas.microsoft.com/office/drawing/2014/main" id="{7CC96B13-2403-C5DE-A972-C144DAF579EE}"/>
               </a:ext>
             </a:extLst>
           </p:cNvPr>
@@ -8001,7 +8001,7 @@
         <p:spPr>
           <a:xfrm>
             <a:off x="762000" y="914399"/>
-            <a:ext cx="3048000" cy="279400"/>
+            <a:ext cx="3048000" cy="304800"/>
           </a:xfrm>
           <a:prstGeom prst="rect">
             <a:avLst/>
@@ -8015,7 +8015,7 @@
           <a:lstStyle/>
           <a:p>
             <a:r>
-              <a:rPr lang="en-US" sz="1500" b="1">
+              <a:rPr lang="en-US" sz="1600" b="1">
                 <a:solidFill>
                   <a:srgbClr val="3FC6AC"/>
                 </a:solidFill>
@@ -8031,7 +8031,7 @@
           <p:cNvPr id="7" name="TextBox 6">
             <a:extLst>
               <a:ext uri="{FF2B5EF4-FFF2-40B4-BE49-F238E27FC236}">
-                <a16:creationId xmlns:a16="http://schemas.microsoft.com/office/drawing/2014/main" id="{B4D2556B-21E5-6B12-8B19-A48ABB47D33B}"/>
+                <a16:creationId xmlns:a16="http://schemas.microsoft.com/office/drawing/2014/main" id="{BEF00AA0-3E6E-7EA8-FFDE-747FF4A14603}"/>
               </a:ext>
             </a:extLst>
           </p:cNvPr>
@@ -8071,7 +8071,7 @@
           <p:cNvPr id="8" name="TextBox 7">
             <a:extLst>
               <a:ext uri="{FF2B5EF4-FFF2-40B4-BE49-F238E27FC236}">
-                <a16:creationId xmlns:a16="http://schemas.microsoft.com/office/drawing/2014/main" id="{F6C9E50A-845A-187C-6D7C-47F1781372B9}"/>
+                <a16:creationId xmlns:a16="http://schemas.microsoft.com/office/drawing/2014/main" id="{DEE9CAB4-B204-5DAD-313C-0F4D67AB7C4A}"/>
               </a:ext>
             </a:extLst>
           </p:cNvPr>
@@ -8111,7 +8111,7 @@
           <p:cNvPr id="9" name="Straight Connector 8">
             <a:extLst>
               <a:ext uri="{FF2B5EF4-FFF2-40B4-BE49-F238E27FC236}">
-                <a16:creationId xmlns:a16="http://schemas.microsoft.com/office/drawing/2014/main" id="{8403E089-A711-3DC1-1F92-4ED6BBDD3DCB}"/>
+                <a16:creationId xmlns:a16="http://schemas.microsoft.com/office/drawing/2014/main" id="{5446D7CC-E292-0CE6-A0E4-789BFD22D27F}"/>
               </a:ext>
             </a:extLst>
           </p:cNvPr>
@@ -8152,7 +8152,7 @@
           <p:cNvPr id="10" name="Straight Connector 9">
             <a:extLst>
               <a:ext uri="{FF2B5EF4-FFF2-40B4-BE49-F238E27FC236}">
-                <a16:creationId xmlns:a16="http://schemas.microsoft.com/office/drawing/2014/main" id="{5E0943CC-1E99-6AC8-FB0D-F761199AF4A8}"/>
+                <a16:creationId xmlns:a16="http://schemas.microsoft.com/office/drawing/2014/main" id="{C90C14F5-48BE-0C56-8AAC-03EC83748997}"/>
               </a:ext>
             </a:extLst>
           </p:cNvPr>
@@ -8193,7 +8193,7 @@
           <p:cNvPr id="11" name="TextBox 10">
             <a:extLst>
               <a:ext uri="{FF2B5EF4-FFF2-40B4-BE49-F238E27FC236}">
-                <a16:creationId xmlns:a16="http://schemas.microsoft.com/office/drawing/2014/main" id="{E1B9B25A-260C-8751-6F49-673B62CD99D7}"/>
+                <a16:creationId xmlns:a16="http://schemas.microsoft.com/office/drawing/2014/main" id="{C3C144CF-55C1-6919-BDA1-DC77EC52782D}"/>
               </a:ext>
             </a:extLst>
           </p:cNvPr>
@@ -8233,7 +8233,7 @@
           <p:cNvPr id="12" name="Straight Connector 11">
             <a:extLst>
               <a:ext uri="{FF2B5EF4-FFF2-40B4-BE49-F238E27FC236}">
-                <a16:creationId xmlns:a16="http://schemas.microsoft.com/office/drawing/2014/main" id="{1173B72D-B5ED-306C-2505-9835302B763C}"/>
+                <a16:creationId xmlns:a16="http://schemas.microsoft.com/office/drawing/2014/main" id="{1227659C-EAEA-1863-4C76-613EF980826D}"/>
               </a:ext>
             </a:extLst>
           </p:cNvPr>
@@ -8274,7 +8274,7 @@
           <p:cNvPr id="13" name="TextBox 12">
             <a:extLst>
               <a:ext uri="{FF2B5EF4-FFF2-40B4-BE49-F238E27FC236}">
-                <a16:creationId xmlns:a16="http://schemas.microsoft.com/office/drawing/2014/main" id="{C7FD64E6-A1EF-CA4C-2FE4-D86258099480}"/>
+                <a16:creationId xmlns:a16="http://schemas.microsoft.com/office/drawing/2014/main" id="{6959C9DB-47E5-26F8-F216-546E22C7BA72}"/>
               </a:ext>
             </a:extLst>
           </p:cNvPr>
@@ -8314,7 +8314,7 @@
           <p:cNvPr id="14" name="Straight Connector 13">
             <a:extLst>
               <a:ext uri="{FF2B5EF4-FFF2-40B4-BE49-F238E27FC236}">
-                <a16:creationId xmlns:a16="http://schemas.microsoft.com/office/drawing/2014/main" id="{6C57279D-9685-9F02-6C1E-F78DF0F1E070}"/>
+                <a16:creationId xmlns:a16="http://schemas.microsoft.com/office/drawing/2014/main" id="{4F821CA9-7882-EF9C-0DEE-96132DEDC9FB}"/>
               </a:ext>
             </a:extLst>
           </p:cNvPr>
@@ -8355,7 +8355,7 @@
           <p:cNvPr id="15" name="TextBox 14">
             <a:extLst>
               <a:ext uri="{FF2B5EF4-FFF2-40B4-BE49-F238E27FC236}">
-                <a16:creationId xmlns:a16="http://schemas.microsoft.com/office/drawing/2014/main" id="{EB581EEA-33D2-8BBF-1ED6-5E769A57A80E}"/>
+                <a16:creationId xmlns:a16="http://schemas.microsoft.com/office/drawing/2014/main" id="{5D094BBD-7072-0DEA-D3BE-3135B45D2D7F}"/>
               </a:ext>
             </a:extLst>
           </p:cNvPr>
@@ -8395,7 +8395,7 @@
           <p:cNvPr id="16" name="Rectangle: Rounded Corners 15">
             <a:extLst>
               <a:ext uri="{FF2B5EF4-FFF2-40B4-BE49-F238E27FC236}">
-                <a16:creationId xmlns:a16="http://schemas.microsoft.com/office/drawing/2014/main" id="{D7C545EE-BF76-F82D-52CC-58B501F4D6F7}"/>
+                <a16:creationId xmlns:a16="http://schemas.microsoft.com/office/drawing/2014/main" id="{D860BC64-253D-4B19-14D4-1C9935FC426D}"/>
               </a:ext>
             </a:extLst>
           </p:cNvPr>
@@ -8463,7 +8463,7 @@
           <p:cNvPr id="17" name="TextBox 16">
             <a:extLst>
               <a:ext uri="{FF2B5EF4-FFF2-40B4-BE49-F238E27FC236}">
-                <a16:creationId xmlns:a16="http://schemas.microsoft.com/office/drawing/2014/main" id="{59382D77-1941-A6D3-CEC6-D55E94704673}"/>
+                <a16:creationId xmlns:a16="http://schemas.microsoft.com/office/drawing/2014/main" id="{7B556E3D-0D78-5D44-EDA8-7B612BAFEFB8}"/>
               </a:ext>
             </a:extLst>
           </p:cNvPr>
@@ -8502,7 +8502,7 @@
     </p:spTree>
     <p:extLst>
       <p:ext uri="{BB962C8B-B14F-4D97-AF65-F5344CB8AC3E}">
-        <p14:creationId xmlns:p14="http://schemas.microsoft.com/office/powerpoint/2010/main" val="892118178"/>
+        <p14:creationId xmlns:p14="http://schemas.microsoft.com/office/powerpoint/2010/main" val="4286466720"/>
       </p:ext>
     </p:extLst>
   </p:cSld>
@@ -8542,7 +8542,7 @@
           <p:cNvPr id="2" name="TextBox 1">
             <a:extLst>
               <a:ext uri="{FF2B5EF4-FFF2-40B4-BE49-F238E27FC236}">
-                <a16:creationId xmlns:a16="http://schemas.microsoft.com/office/drawing/2014/main" id="{D8F702F2-848A-1BF4-921F-73EED8FC6F6F}"/>
+                <a16:creationId xmlns:a16="http://schemas.microsoft.com/office/drawing/2014/main" id="{3581747E-C277-4809-3DA0-52186AFBC906}"/>
               </a:ext>
             </a:extLst>
           </p:cNvPr>
@@ -8551,8 +8551,8 @@
         </p:nvSpPr>
         <p:spPr>
           <a:xfrm>
-            <a:off x="609600" y="254000"/>
-            <a:ext cx="3429000" cy="228600"/>
+            <a:off x="609600" y="228599"/>
+            <a:ext cx="3810000" cy="279400"/>
           </a:xfrm>
           <a:prstGeom prst="rect">
             <a:avLst/>
@@ -8566,7 +8566,7 @@
           <a:lstStyle/>
           <a:p>
             <a:r>
-              <a:rPr lang="en-US" sz="1100" b="1">
+              <a:rPr lang="en-US" sz="1600" b="1">
                 <a:solidFill>
                   <a:srgbClr val="83939D"/>
                 </a:solidFill>
@@ -8582,7 +8582,7 @@
           <p:cNvPr id="3" name="Straight Connector 2">
             <a:extLst>
               <a:ext uri="{FF2B5EF4-FFF2-40B4-BE49-F238E27FC236}">
-                <a16:creationId xmlns:a16="http://schemas.microsoft.com/office/drawing/2014/main" id="{D3BD3EF3-197E-1F87-7D2F-744885848F85}"/>
+                <a16:creationId xmlns:a16="http://schemas.microsoft.com/office/drawing/2014/main" id="{2602DC5D-CA2E-A4F9-7E07-8C6D32D43BD6}"/>
               </a:ext>
             </a:extLst>
           </p:cNvPr>
@@ -8623,7 +8623,7 @@
           <p:cNvPr id="4" name="TextBox 3">
             <a:extLst>
               <a:ext uri="{FF2B5EF4-FFF2-40B4-BE49-F238E27FC236}">
-                <a16:creationId xmlns:a16="http://schemas.microsoft.com/office/drawing/2014/main" id="{303DDB8D-C739-7279-C428-1A8A7B497209}"/>
+                <a16:creationId xmlns:a16="http://schemas.microsoft.com/office/drawing/2014/main" id="{0F0E91DA-9322-A962-858B-D74008691C58}"/>
               </a:ext>
             </a:extLst>
           </p:cNvPr>
@@ -8632,8 +8632,8 @@
         </p:nvSpPr>
         <p:spPr>
           <a:xfrm>
-            <a:off x="11201400" y="6451600"/>
-            <a:ext cx="381000" cy="203200"/>
+            <a:off x="11150600" y="6388099"/>
+            <a:ext cx="431800" cy="279400"/>
           </a:xfrm>
           <a:prstGeom prst="rect">
             <a:avLst/>
@@ -8648,7 +8648,7 @@
           <a:p>
             <a:pPr algn="r"/>
             <a:r>
-              <a:rPr lang="en-US" sz="1000">
+              <a:rPr lang="en-US" sz="1600">
                 <a:solidFill>
                   <a:srgbClr val="83939D"/>
                 </a:solidFill>
@@ -8664,7 +8664,7 @@
           <p:cNvPr id="5" name="TextBox 4">
             <a:extLst>
               <a:ext uri="{FF2B5EF4-FFF2-40B4-BE49-F238E27FC236}">
-                <a16:creationId xmlns:a16="http://schemas.microsoft.com/office/drawing/2014/main" id="{557DFAAA-18A1-2EAA-73E4-BEFBEEB2D9A8}"/>
+                <a16:creationId xmlns:a16="http://schemas.microsoft.com/office/drawing/2014/main" id="{A6902A66-2DE8-7554-3911-65D2A163CF2E}"/>
               </a:ext>
             </a:extLst>
           </p:cNvPr>
@@ -8673,8 +8673,8 @@
         </p:nvSpPr>
         <p:spPr>
           <a:xfrm>
-            <a:off x="609600" y="6438900"/>
-            <a:ext cx="3556000" cy="203200"/>
+            <a:off x="609600" y="6388099"/>
+            <a:ext cx="4064000" cy="279400"/>
           </a:xfrm>
           <a:prstGeom prst="rect">
             <a:avLst/>
@@ -8688,7 +8688,7 @@
           <a:lstStyle/>
           <a:p>
             <a:r>
-              <a:rPr lang="en-US" sz="900">
+              <a:rPr lang="en-US" sz="1600">
                 <a:solidFill>
                   <a:srgbClr val="83939D"/>
                 </a:solidFill>
@@ -8704,7 +8704,7 @@
           <p:cNvPr id="6" name="TextBox 5">
             <a:extLst>
               <a:ext uri="{FF2B5EF4-FFF2-40B4-BE49-F238E27FC236}">
-                <a16:creationId xmlns:a16="http://schemas.microsoft.com/office/drawing/2014/main" id="{6D26EC30-E0DF-7787-5B1C-BB7EF7B5C6BB}"/>
+                <a16:creationId xmlns:a16="http://schemas.microsoft.com/office/drawing/2014/main" id="{BDBAC04F-93D8-9A88-4E99-8C2F2E17A3DE}"/>
               </a:ext>
             </a:extLst>
           </p:cNvPr>
@@ -8744,7 +8744,7 @@
           <p:cNvPr id="7" name="Straight Connector 6">
             <a:extLst>
               <a:ext uri="{FF2B5EF4-FFF2-40B4-BE49-F238E27FC236}">
-                <a16:creationId xmlns:a16="http://schemas.microsoft.com/office/drawing/2014/main" id="{85D2DC96-F201-CC0C-298F-CE6BF187DD23}"/>
+                <a16:creationId xmlns:a16="http://schemas.microsoft.com/office/drawing/2014/main" id="{5CC6DE40-9FF8-6BC8-49E6-B5C1E72933A2}"/>
               </a:ext>
             </a:extLst>
           </p:cNvPr>
@@ -8785,7 +8785,7 @@
           <p:cNvPr id="8" name="TextBox 7">
             <a:extLst>
               <a:ext uri="{FF2B5EF4-FFF2-40B4-BE49-F238E27FC236}">
-                <a16:creationId xmlns:a16="http://schemas.microsoft.com/office/drawing/2014/main" id="{2CAAE50B-424E-06B7-4CDC-B20F3FE5F8FC}"/>
+                <a16:creationId xmlns:a16="http://schemas.microsoft.com/office/drawing/2014/main" id="{F1CCC872-4207-7620-B301-65CCFB013E90}"/>
               </a:ext>
             </a:extLst>
           </p:cNvPr>
@@ -8825,7 +8825,7 @@
           <p:cNvPr id="9" name="Straight Connector 8">
             <a:extLst>
               <a:ext uri="{FF2B5EF4-FFF2-40B4-BE49-F238E27FC236}">
-                <a16:creationId xmlns:a16="http://schemas.microsoft.com/office/drawing/2014/main" id="{5342C707-5DD1-4486-6A65-2540DA53CE2B}"/>
+                <a16:creationId xmlns:a16="http://schemas.microsoft.com/office/drawing/2014/main" id="{14CB8640-42E1-52D7-91F2-CC741A5EA3A3}"/>
               </a:ext>
             </a:extLst>
           </p:cNvPr>
@@ -8866,7 +8866,7 @@
           <p:cNvPr id="10" name="TextBox 9">
             <a:extLst>
               <a:ext uri="{FF2B5EF4-FFF2-40B4-BE49-F238E27FC236}">
-                <a16:creationId xmlns:a16="http://schemas.microsoft.com/office/drawing/2014/main" id="{D352AF62-527D-C1C6-08B6-FEF72860D0E5}"/>
+                <a16:creationId xmlns:a16="http://schemas.microsoft.com/office/drawing/2014/main" id="{CB61A93D-6980-197A-8FF0-DC38A11F65AA}"/>
               </a:ext>
             </a:extLst>
           </p:cNvPr>
@@ -8906,7 +8906,7 @@
           <p:cNvPr id="11" name="Straight Connector 10">
             <a:extLst>
               <a:ext uri="{FF2B5EF4-FFF2-40B4-BE49-F238E27FC236}">
-                <a16:creationId xmlns:a16="http://schemas.microsoft.com/office/drawing/2014/main" id="{882BE4A7-DE69-BE81-15C7-9015464F763B}"/>
+                <a16:creationId xmlns:a16="http://schemas.microsoft.com/office/drawing/2014/main" id="{2C00AB70-C7BA-A5FB-08E3-3EE7ADB95495}"/>
               </a:ext>
             </a:extLst>
           </p:cNvPr>
@@ -8947,7 +8947,7 @@
           <p:cNvPr id="12" name="TextBox 11">
             <a:extLst>
               <a:ext uri="{FF2B5EF4-FFF2-40B4-BE49-F238E27FC236}">
-                <a16:creationId xmlns:a16="http://schemas.microsoft.com/office/drawing/2014/main" id="{1FF57BDC-18EE-05A4-82A9-CD70C12C7CBF}"/>
+                <a16:creationId xmlns:a16="http://schemas.microsoft.com/office/drawing/2014/main" id="{D67A19E8-F919-C948-FBF5-B8E35BF73965}"/>
               </a:ext>
             </a:extLst>
           </p:cNvPr>
@@ -8987,7 +8987,7 @@
           <p:cNvPr id="13" name="Rectangle: Rounded Corners 12">
             <a:extLst>
               <a:ext uri="{FF2B5EF4-FFF2-40B4-BE49-F238E27FC236}">
-                <a16:creationId xmlns:a16="http://schemas.microsoft.com/office/drawing/2014/main" id="{416A1614-D8AB-E659-03FF-7A3B6BA2DEF3}"/>
+                <a16:creationId xmlns:a16="http://schemas.microsoft.com/office/drawing/2014/main" id="{DE9598A4-02A9-B72A-7300-4B57F8EA8FD8}"/>
               </a:ext>
             </a:extLst>
           </p:cNvPr>
@@ -9038,10 +9038,10 @@
       </p:sp>
       <p:pic>
         <p:nvPicPr>
-          <p:cNvPr id="15" name="Picture 14" descr="GridGuard overview showing the seven-locality schematic and frozen controller summary">
-            <a:extLst>
-              <a:ext uri="{FF2B5EF4-FFF2-40B4-BE49-F238E27FC236}">
-                <a16:creationId xmlns:a16="http://schemas.microsoft.com/office/drawing/2014/main" id="{05265F23-4295-647A-8A9E-CE6129320FC6}"/>
+          <p:cNvPr id="15" name="Picture 14" descr="GridGuard overview showing seven administrative locality boundaries and the frozen controller summary">
+            <a:extLst>
+              <a:ext uri="{FF2B5EF4-FFF2-40B4-BE49-F238E27FC236}">
+                <a16:creationId xmlns:a16="http://schemas.microsoft.com/office/drawing/2014/main" id="{7DEF9CC5-B1ED-A827-2B75-16BDD56D247F}"/>
               </a:ext>
             </a:extLst>
           </p:cNvPr>
@@ -9077,7 +9077,7 @@
           <p:cNvPr id="16" name="TextBox 15">
             <a:extLst>
               <a:ext uri="{FF2B5EF4-FFF2-40B4-BE49-F238E27FC236}">
-                <a16:creationId xmlns:a16="http://schemas.microsoft.com/office/drawing/2014/main" id="{AA1A3379-77DC-DF1D-9788-4917370D8610}"/>
+                <a16:creationId xmlns:a16="http://schemas.microsoft.com/office/drawing/2014/main" id="{177A7543-804D-967B-4CE1-175A5EFBA599}"/>
               </a:ext>
             </a:extLst>
           </p:cNvPr>
@@ -9115,7 +9115,7 @@
     </p:spTree>
     <p:extLst>
       <p:ext uri="{BB962C8B-B14F-4D97-AF65-F5344CB8AC3E}">
-        <p14:creationId xmlns:p14="http://schemas.microsoft.com/office/powerpoint/2010/main" val="1270980374"/>
+        <p14:creationId xmlns:p14="http://schemas.microsoft.com/office/powerpoint/2010/main" val="2620795634"/>
       </p:ext>
     </p:extLst>
   </p:cSld>
@@ -9155,7 +9155,7 @@
           <p:cNvPr id="2" name="TextBox 1">
             <a:extLst>
               <a:ext uri="{FF2B5EF4-FFF2-40B4-BE49-F238E27FC236}">
-                <a16:creationId xmlns:a16="http://schemas.microsoft.com/office/drawing/2014/main" id="{D95099D2-0754-F694-D82E-B12BC5D211B2}"/>
+                <a16:creationId xmlns:a16="http://schemas.microsoft.com/office/drawing/2014/main" id="{2B97EDB4-8A57-F6CD-7664-17E9168A4783}"/>
               </a:ext>
             </a:extLst>
           </p:cNvPr>
@@ -9164,8 +9164,8 @@
         </p:nvSpPr>
         <p:spPr>
           <a:xfrm>
-            <a:off x="609600" y="254000"/>
-            <a:ext cx="3429000" cy="228600"/>
+            <a:off x="609600" y="228599"/>
+            <a:ext cx="3810000" cy="279400"/>
           </a:xfrm>
           <a:prstGeom prst="rect">
             <a:avLst/>
@@ -9179,7 +9179,7 @@
           <a:lstStyle/>
           <a:p>
             <a:r>
-              <a:rPr lang="en-US" sz="1100" b="1">
+              <a:rPr lang="en-US" sz="1600" b="1">
                 <a:solidFill>
                   <a:srgbClr val="60727D"/>
                 </a:solidFill>
@@ -9195,7 +9195,7 @@
           <p:cNvPr id="3" name="Straight Connector 2">
             <a:extLst>
               <a:ext uri="{FF2B5EF4-FFF2-40B4-BE49-F238E27FC236}">
-                <a16:creationId xmlns:a16="http://schemas.microsoft.com/office/drawing/2014/main" id="{1E52874B-006F-869E-0264-C2442FA4438D}"/>
+                <a16:creationId xmlns:a16="http://schemas.microsoft.com/office/drawing/2014/main" id="{C96C6082-83EC-F6EA-87CE-22E6DDE089C4}"/>
               </a:ext>
             </a:extLst>
           </p:cNvPr>
@@ -9236,7 +9236,7 @@
           <p:cNvPr id="4" name="TextBox 3">
             <a:extLst>
               <a:ext uri="{FF2B5EF4-FFF2-40B4-BE49-F238E27FC236}">
-                <a16:creationId xmlns:a16="http://schemas.microsoft.com/office/drawing/2014/main" id="{56959729-C088-21FC-F7CC-25D29FEFAA1A}"/>
+                <a16:creationId xmlns:a16="http://schemas.microsoft.com/office/drawing/2014/main" id="{E7528B1E-5FF2-E37A-4388-203887DB03A4}"/>
               </a:ext>
             </a:extLst>
           </p:cNvPr>
@@ -9245,8 +9245,8 @@
         </p:nvSpPr>
         <p:spPr>
           <a:xfrm>
-            <a:off x="11201400" y="6451600"/>
-            <a:ext cx="381000" cy="203200"/>
+            <a:off x="11150600" y="6388099"/>
+            <a:ext cx="431800" cy="279400"/>
           </a:xfrm>
           <a:prstGeom prst="rect">
             <a:avLst/>
@@ -9261,7 +9261,7 @@
           <a:p>
             <a:pPr algn="r"/>
             <a:r>
-              <a:rPr lang="en-US" sz="1000">
+              <a:rPr lang="en-US" sz="1600">
                 <a:solidFill>
                   <a:srgbClr val="60727D"/>
                 </a:solidFill>
@@ -9277,7 +9277,7 @@
           <p:cNvPr id="5" name="TextBox 4">
             <a:extLst>
               <a:ext uri="{FF2B5EF4-FFF2-40B4-BE49-F238E27FC236}">
-                <a16:creationId xmlns:a16="http://schemas.microsoft.com/office/drawing/2014/main" id="{9FA1D27C-06B2-0C3B-0F47-C92DB0D02313}"/>
+                <a16:creationId xmlns:a16="http://schemas.microsoft.com/office/drawing/2014/main" id="{26E35F0C-16CB-F7C1-E085-8FC92D6B2FF3}"/>
               </a:ext>
             </a:extLst>
           </p:cNvPr>
@@ -9286,8 +9286,8 @@
         </p:nvSpPr>
         <p:spPr>
           <a:xfrm>
-            <a:off x="609600" y="6438900"/>
-            <a:ext cx="3556000" cy="203200"/>
+            <a:off x="609600" y="6388099"/>
+            <a:ext cx="4064000" cy="279400"/>
           </a:xfrm>
           <a:prstGeom prst="rect">
             <a:avLst/>
@@ -9301,7 +9301,7 @@
           <a:lstStyle/>
           <a:p>
             <a:r>
-              <a:rPr lang="en-US" sz="900">
+              <a:rPr lang="en-US" sz="1600">
                 <a:solidFill>
                   <a:srgbClr val="60727D"/>
                 </a:solidFill>
@@ -9317,7 +9317,7 @@
           <p:cNvPr id="6" name="TextBox 5">
             <a:extLst>
               <a:ext uri="{FF2B5EF4-FFF2-40B4-BE49-F238E27FC236}">
-                <a16:creationId xmlns:a16="http://schemas.microsoft.com/office/drawing/2014/main" id="{53E4D272-35E0-C22D-01F3-F5476BDEC78C}"/>
+                <a16:creationId xmlns:a16="http://schemas.microsoft.com/office/drawing/2014/main" id="{3413AE98-3BC0-8F72-C881-8A3B7B96759C}"/>
               </a:ext>
             </a:extLst>
           </p:cNvPr>
@@ -9357,7 +9357,7 @@
           <p:cNvPr id="7" name="Straight Connector 6">
             <a:extLst>
               <a:ext uri="{FF2B5EF4-FFF2-40B4-BE49-F238E27FC236}">
-                <a16:creationId xmlns:a16="http://schemas.microsoft.com/office/drawing/2014/main" id="{B7F30537-6895-FFBB-6AC0-83E59360152F}"/>
+                <a16:creationId xmlns:a16="http://schemas.microsoft.com/office/drawing/2014/main" id="{3E150445-101D-D826-2912-DF5162B5DC51}"/>
               </a:ext>
             </a:extLst>
           </p:cNvPr>
@@ -9399,7 +9399,7 @@
           <p:cNvPr id="8" name="Straight Connector 7">
             <a:extLst>
               <a:ext uri="{FF2B5EF4-FFF2-40B4-BE49-F238E27FC236}">
-                <a16:creationId xmlns:a16="http://schemas.microsoft.com/office/drawing/2014/main" id="{E9EAFF4D-F2F8-2D67-9FC5-B260155BAC3A}"/>
+                <a16:creationId xmlns:a16="http://schemas.microsoft.com/office/drawing/2014/main" id="{977FDC3E-556F-73AF-C709-0D9131519A62}"/>
               </a:ext>
             </a:extLst>
           </p:cNvPr>
@@ -9441,7 +9441,7 @@
           <p:cNvPr id="9" name="Straight Connector 8">
             <a:extLst>
               <a:ext uri="{FF2B5EF4-FFF2-40B4-BE49-F238E27FC236}">
-                <a16:creationId xmlns:a16="http://schemas.microsoft.com/office/drawing/2014/main" id="{D4C3FD2D-0939-2F1D-86D9-2C497C51C6C4}"/>
+                <a16:creationId xmlns:a16="http://schemas.microsoft.com/office/drawing/2014/main" id="{5B3903F0-CFA4-3F83-35B1-530343CF0F34}"/>
               </a:ext>
             </a:extLst>
           </p:cNvPr>
@@ -9483,7 +9483,7 @@
           <p:cNvPr id="10" name="Straight Connector 9">
             <a:extLst>
               <a:ext uri="{FF2B5EF4-FFF2-40B4-BE49-F238E27FC236}">
-                <a16:creationId xmlns:a16="http://schemas.microsoft.com/office/drawing/2014/main" id="{9A79D210-1802-4580-B072-88B0DD03FE2E}"/>
+                <a16:creationId xmlns:a16="http://schemas.microsoft.com/office/drawing/2014/main" id="{99E4BDFE-1817-536E-709D-2397CFF9BB87}"/>
               </a:ext>
             </a:extLst>
           </p:cNvPr>
@@ -9525,7 +9525,7 @@
           <p:cNvPr id="11" name="Rectangle: Rounded Corners 10">
             <a:extLst>
               <a:ext uri="{FF2B5EF4-FFF2-40B4-BE49-F238E27FC236}">
-                <a16:creationId xmlns:a16="http://schemas.microsoft.com/office/drawing/2014/main" id="{149701A5-BB91-E680-5179-1E31172A85A8}"/>
+                <a16:creationId xmlns:a16="http://schemas.microsoft.com/office/drawing/2014/main" id="{9B60C3A3-A0F8-D380-6383-27B5F949D0F2}"/>
               </a:ext>
             </a:extLst>
           </p:cNvPr>
@@ -9593,7 +9593,7 @@
           <p:cNvPr id="12" name="TextBox 11">
             <a:extLst>
               <a:ext uri="{FF2B5EF4-FFF2-40B4-BE49-F238E27FC236}">
-                <a16:creationId xmlns:a16="http://schemas.microsoft.com/office/drawing/2014/main" id="{AF149629-9924-100B-7344-790103168E70}"/>
+                <a16:creationId xmlns:a16="http://schemas.microsoft.com/office/drawing/2014/main" id="{E41AA78A-C641-4106-022F-930CDB222709}"/>
               </a:ext>
             </a:extLst>
           </p:cNvPr>
@@ -9635,7 +9635,7 @@
           <p:cNvPr id="13" name="Rectangle: Rounded Corners 12">
             <a:extLst>
               <a:ext uri="{FF2B5EF4-FFF2-40B4-BE49-F238E27FC236}">
-                <a16:creationId xmlns:a16="http://schemas.microsoft.com/office/drawing/2014/main" id="{A48E6ABC-5ED5-CF4D-E103-322835F32435}"/>
+                <a16:creationId xmlns:a16="http://schemas.microsoft.com/office/drawing/2014/main" id="{963DC37C-DD4E-0E02-F382-BE73DC45B243}"/>
               </a:ext>
             </a:extLst>
           </p:cNvPr>
@@ -9703,7 +9703,7 @@
           <p:cNvPr id="14" name="TextBox 13">
             <a:extLst>
               <a:ext uri="{FF2B5EF4-FFF2-40B4-BE49-F238E27FC236}">
-                <a16:creationId xmlns:a16="http://schemas.microsoft.com/office/drawing/2014/main" id="{11B25BF7-012A-79AB-36ED-11639B84F46E}"/>
+                <a16:creationId xmlns:a16="http://schemas.microsoft.com/office/drawing/2014/main" id="{D5922122-9AB4-C880-9C9D-EBB0C52A89DB}"/>
               </a:ext>
             </a:extLst>
           </p:cNvPr>
@@ -9745,7 +9745,7 @@
           <p:cNvPr id="15" name="Rectangle: Rounded Corners 14">
             <a:extLst>
               <a:ext uri="{FF2B5EF4-FFF2-40B4-BE49-F238E27FC236}">
-                <a16:creationId xmlns:a16="http://schemas.microsoft.com/office/drawing/2014/main" id="{DA25C83D-D466-301A-8212-8E8CF7031CC1}"/>
+                <a16:creationId xmlns:a16="http://schemas.microsoft.com/office/drawing/2014/main" id="{0E08BB0A-805E-BDB2-09E2-2D88A7DB7B84}"/>
               </a:ext>
             </a:extLst>
           </p:cNvPr>
@@ -9813,7 +9813,7 @@
           <p:cNvPr id="16" name="TextBox 15">
             <a:extLst>
               <a:ext uri="{FF2B5EF4-FFF2-40B4-BE49-F238E27FC236}">
-                <a16:creationId xmlns:a16="http://schemas.microsoft.com/office/drawing/2014/main" id="{EF88BC23-C941-5825-2779-0C1EFFED001C}"/>
+                <a16:creationId xmlns:a16="http://schemas.microsoft.com/office/drawing/2014/main" id="{E82A2E27-00A7-51E6-57CC-2E0C079A3F00}"/>
               </a:ext>
             </a:extLst>
           </p:cNvPr>
@@ -9855,7 +9855,7 @@
           <p:cNvPr id="17" name="Rectangle: Rounded Corners 16">
             <a:extLst>
               <a:ext uri="{FF2B5EF4-FFF2-40B4-BE49-F238E27FC236}">
-                <a16:creationId xmlns:a16="http://schemas.microsoft.com/office/drawing/2014/main" id="{20AB13CC-3E6F-2CF5-3BEF-4AF854A4F23B}"/>
+                <a16:creationId xmlns:a16="http://schemas.microsoft.com/office/drawing/2014/main" id="{DB607CF5-7C33-E98F-9A37-C5EAFB5965A0}"/>
               </a:ext>
             </a:extLst>
           </p:cNvPr>
@@ -9923,7 +9923,7 @@
           <p:cNvPr id="18" name="TextBox 17">
             <a:extLst>
               <a:ext uri="{FF2B5EF4-FFF2-40B4-BE49-F238E27FC236}">
-                <a16:creationId xmlns:a16="http://schemas.microsoft.com/office/drawing/2014/main" id="{F3C855AD-7197-03F6-080D-B1BE5D1FA4E8}"/>
+                <a16:creationId xmlns:a16="http://schemas.microsoft.com/office/drawing/2014/main" id="{25CB2ECD-5EE7-FF9F-712A-438DD74D1965}"/>
               </a:ext>
             </a:extLst>
           </p:cNvPr>
@@ -9965,7 +9965,7 @@
           <p:cNvPr id="19" name="Rectangle: Rounded Corners 18">
             <a:extLst>
               <a:ext uri="{FF2B5EF4-FFF2-40B4-BE49-F238E27FC236}">
-                <a16:creationId xmlns:a16="http://schemas.microsoft.com/office/drawing/2014/main" id="{74E2C667-B4FA-5121-B20C-6DD9B163B2E5}"/>
+                <a16:creationId xmlns:a16="http://schemas.microsoft.com/office/drawing/2014/main" id="{15ACCF93-34ED-3768-F7B0-36C3BCB29F0C}"/>
               </a:ext>
             </a:extLst>
           </p:cNvPr>
@@ -10033,7 +10033,7 @@
           <p:cNvPr id="20" name="TextBox 19">
             <a:extLst>
               <a:ext uri="{FF2B5EF4-FFF2-40B4-BE49-F238E27FC236}">
-                <a16:creationId xmlns:a16="http://schemas.microsoft.com/office/drawing/2014/main" id="{E9ACF94E-E806-09CD-3080-E778793A15F1}"/>
+                <a16:creationId xmlns:a16="http://schemas.microsoft.com/office/drawing/2014/main" id="{B65F1248-F89D-C83C-B6B3-04794D626AF6}"/>
               </a:ext>
             </a:extLst>
           </p:cNvPr>
@@ -10075,7 +10075,7 @@
           <p:cNvPr id="21" name="TextBox 20">
             <a:extLst>
               <a:ext uri="{FF2B5EF4-FFF2-40B4-BE49-F238E27FC236}">
-                <a16:creationId xmlns:a16="http://schemas.microsoft.com/office/drawing/2014/main" id="{48F4FB53-B513-2499-7F0D-89348F280D5D}"/>
+                <a16:creationId xmlns:a16="http://schemas.microsoft.com/office/drawing/2014/main" id="{440FB328-FA19-78AA-16E4-20C0BAF88847}"/>
               </a:ext>
             </a:extLst>
           </p:cNvPr>
@@ -10115,7 +10115,7 @@
           <p:cNvPr id="22" name="Straight Connector 21">
             <a:extLst>
               <a:ext uri="{FF2B5EF4-FFF2-40B4-BE49-F238E27FC236}">
-                <a16:creationId xmlns:a16="http://schemas.microsoft.com/office/drawing/2014/main" id="{08B877AE-730F-2F1B-AE51-44125AF3763A}"/>
+                <a16:creationId xmlns:a16="http://schemas.microsoft.com/office/drawing/2014/main" id="{C4151DD3-7C4B-0A54-2A86-D3623925CF25}"/>
               </a:ext>
             </a:extLst>
           </p:cNvPr>
@@ -10156,7 +10156,7 @@
           <p:cNvPr id="23" name="TextBox 22">
             <a:extLst>
               <a:ext uri="{FF2B5EF4-FFF2-40B4-BE49-F238E27FC236}">
-                <a16:creationId xmlns:a16="http://schemas.microsoft.com/office/drawing/2014/main" id="{A8706574-5F1B-CB10-31F2-BB4799FBF91B}"/>
+                <a16:creationId xmlns:a16="http://schemas.microsoft.com/office/drawing/2014/main" id="{988C7A4F-8236-B332-1D87-F343FFC711BC}"/>
               </a:ext>
             </a:extLst>
           </p:cNvPr>
@@ -10196,7 +10196,7 @@
           <p:cNvPr id="24" name="TextBox 23">
             <a:extLst>
               <a:ext uri="{FF2B5EF4-FFF2-40B4-BE49-F238E27FC236}">
-                <a16:creationId xmlns:a16="http://schemas.microsoft.com/office/drawing/2014/main" id="{D5393F50-A604-E8D2-FC69-D5027218E632}"/>
+                <a16:creationId xmlns:a16="http://schemas.microsoft.com/office/drawing/2014/main" id="{F37CD3FB-246C-3654-4E13-7015A53A1007}"/>
               </a:ext>
             </a:extLst>
           </p:cNvPr>
@@ -10236,7 +10236,7 @@
           <p:cNvPr id="25" name="TextBox 24">
             <a:extLst>
               <a:ext uri="{FF2B5EF4-FFF2-40B4-BE49-F238E27FC236}">
-                <a16:creationId xmlns:a16="http://schemas.microsoft.com/office/drawing/2014/main" id="{663C469E-EDE3-C6A9-BA3E-78E1D331F6D9}"/>
+                <a16:creationId xmlns:a16="http://schemas.microsoft.com/office/drawing/2014/main" id="{BED3D890-3282-F820-D82E-7D7A275A8BBA}"/>
               </a:ext>
             </a:extLst>
           </p:cNvPr>
@@ -10274,7 +10274,7 @@
     </p:spTree>
     <p:extLst>
       <p:ext uri="{BB962C8B-B14F-4D97-AF65-F5344CB8AC3E}">
-        <p14:creationId xmlns:p14="http://schemas.microsoft.com/office/powerpoint/2010/main" val="749115976"/>
+        <p14:creationId xmlns:p14="http://schemas.microsoft.com/office/powerpoint/2010/main" val="2788614609"/>
       </p:ext>
     </p:extLst>
   </p:cSld>
@@ -10314,7 +10314,7 @@
           <p:cNvPr id="2" name="TextBox 1">
             <a:extLst>
               <a:ext uri="{FF2B5EF4-FFF2-40B4-BE49-F238E27FC236}">
-                <a16:creationId xmlns:a16="http://schemas.microsoft.com/office/drawing/2014/main" id="{CA23BC58-7A53-4CEF-4FAD-3FBEFAF443DC}"/>
+                <a16:creationId xmlns:a16="http://schemas.microsoft.com/office/drawing/2014/main" id="{8BDAF6FF-498A-E17C-7B04-A3E9D763AB43}"/>
               </a:ext>
             </a:extLst>
           </p:cNvPr>
@@ -10323,8 +10323,8 @@
         </p:nvSpPr>
         <p:spPr>
           <a:xfrm>
-            <a:off x="609600" y="254000"/>
-            <a:ext cx="3429000" cy="228600"/>
+            <a:off x="609600" y="228599"/>
+            <a:ext cx="3810000" cy="279400"/>
           </a:xfrm>
           <a:prstGeom prst="rect">
             <a:avLst/>
@@ -10338,7 +10338,7 @@
           <a:lstStyle/>
           <a:p>
             <a:r>
-              <a:rPr lang="en-US" sz="1100" b="1">
+              <a:rPr lang="en-US" sz="1600" b="1">
                 <a:solidFill>
                   <a:srgbClr val="83939D"/>
                 </a:solidFill>
@@ -10354,7 +10354,7 @@
           <p:cNvPr id="3" name="Straight Connector 2">
             <a:extLst>
               <a:ext uri="{FF2B5EF4-FFF2-40B4-BE49-F238E27FC236}">
-                <a16:creationId xmlns:a16="http://schemas.microsoft.com/office/drawing/2014/main" id="{CE2810F2-0445-AB62-A3CB-A24925027651}"/>
+                <a16:creationId xmlns:a16="http://schemas.microsoft.com/office/drawing/2014/main" id="{4D3BF224-ACC9-EF49-0D7E-9911E1558CB9}"/>
               </a:ext>
             </a:extLst>
           </p:cNvPr>
@@ -10395,7 +10395,7 @@
           <p:cNvPr id="4" name="TextBox 3">
             <a:extLst>
               <a:ext uri="{FF2B5EF4-FFF2-40B4-BE49-F238E27FC236}">
-                <a16:creationId xmlns:a16="http://schemas.microsoft.com/office/drawing/2014/main" id="{BA740734-9900-A1AC-3B25-3EB3854D52E1}"/>
+                <a16:creationId xmlns:a16="http://schemas.microsoft.com/office/drawing/2014/main" id="{8ABF5236-8434-4902-AD7E-F8493D1C73D3}"/>
               </a:ext>
             </a:extLst>
           </p:cNvPr>
@@ -10404,8 +10404,8 @@
         </p:nvSpPr>
         <p:spPr>
           <a:xfrm>
-            <a:off x="11201400" y="6451600"/>
-            <a:ext cx="381000" cy="203200"/>
+            <a:off x="11150600" y="6388099"/>
+            <a:ext cx="431800" cy="279400"/>
           </a:xfrm>
           <a:prstGeom prst="rect">
             <a:avLst/>
@@ -10420,7 +10420,7 @@
           <a:p>
             <a:pPr algn="r"/>
             <a:r>
-              <a:rPr lang="en-US" sz="1000">
+              <a:rPr lang="en-US" sz="1600">
                 <a:solidFill>
                   <a:srgbClr val="83939D"/>
                 </a:solidFill>
@@ -10436,7 +10436,7 @@
           <p:cNvPr id="5" name="TextBox 4">
             <a:extLst>
               <a:ext uri="{FF2B5EF4-FFF2-40B4-BE49-F238E27FC236}">
-                <a16:creationId xmlns:a16="http://schemas.microsoft.com/office/drawing/2014/main" id="{ACDC8087-9BF6-2F58-77C3-25A3ABD06EA2}"/>
+                <a16:creationId xmlns:a16="http://schemas.microsoft.com/office/drawing/2014/main" id="{5942508A-411B-8C9B-BDD5-AD55820DFFA7}"/>
               </a:ext>
             </a:extLst>
           </p:cNvPr>
@@ -10445,8 +10445,8 @@
         </p:nvSpPr>
         <p:spPr>
           <a:xfrm>
-            <a:off x="609600" y="6438900"/>
-            <a:ext cx="3556000" cy="203200"/>
+            <a:off x="609600" y="6388099"/>
+            <a:ext cx="4064000" cy="279400"/>
           </a:xfrm>
           <a:prstGeom prst="rect">
             <a:avLst/>
@@ -10460,7 +10460,7 @@
           <a:lstStyle/>
           <a:p>
             <a:r>
-              <a:rPr lang="en-US" sz="900">
+              <a:rPr lang="en-US" sz="1600">
                 <a:solidFill>
                   <a:srgbClr val="83939D"/>
                 </a:solidFill>
@@ -10476,7 +10476,7 @@
           <p:cNvPr id="6" name="TextBox 5">
             <a:extLst>
               <a:ext uri="{FF2B5EF4-FFF2-40B4-BE49-F238E27FC236}">
-                <a16:creationId xmlns:a16="http://schemas.microsoft.com/office/drawing/2014/main" id="{2CCB1812-F1F4-545E-5130-56F93217EA46}"/>
+                <a16:creationId xmlns:a16="http://schemas.microsoft.com/office/drawing/2014/main" id="{C936B773-9716-48DB-2B33-8196C1FFDA36}"/>
               </a:ext>
             </a:extLst>
           </p:cNvPr>
@@ -10516,7 +10516,7 @@
           <p:cNvPr id="7" name="TextBox 6">
             <a:extLst>
               <a:ext uri="{FF2B5EF4-FFF2-40B4-BE49-F238E27FC236}">
-                <a16:creationId xmlns:a16="http://schemas.microsoft.com/office/drawing/2014/main" id="{492B6332-F741-86B6-0FD9-5E2D98AC7544}"/>
+                <a16:creationId xmlns:a16="http://schemas.microsoft.com/office/drawing/2014/main" id="{050FC856-9A1F-D7B4-49A2-39CAFC363959}"/>
               </a:ext>
             </a:extLst>
           </p:cNvPr>
@@ -10557,7 +10557,7 @@
           <p:cNvPr id="8" name="TextBox 7">
             <a:extLst>
               <a:ext uri="{FF2B5EF4-FFF2-40B4-BE49-F238E27FC236}">
-                <a16:creationId xmlns:a16="http://schemas.microsoft.com/office/drawing/2014/main" id="{C84F972D-CDF4-8289-2AE3-CF974648605F}"/>
+                <a16:creationId xmlns:a16="http://schemas.microsoft.com/office/drawing/2014/main" id="{FA1A98DD-F403-B0C9-EADB-43186015760A}"/>
               </a:ext>
             </a:extLst>
           </p:cNvPr>
@@ -10599,7 +10599,7 @@
           <p:cNvPr id="9" name="TextBox 8">
             <a:extLst>
               <a:ext uri="{FF2B5EF4-FFF2-40B4-BE49-F238E27FC236}">
-                <a16:creationId xmlns:a16="http://schemas.microsoft.com/office/drawing/2014/main" id="{4BBD147C-941C-4507-12DB-3DBBB0A5948D}"/>
+                <a16:creationId xmlns:a16="http://schemas.microsoft.com/office/drawing/2014/main" id="{2A17AFE0-B561-15AC-86E3-BEE9BDC98C18}"/>
               </a:ext>
             </a:extLst>
           </p:cNvPr>
@@ -10640,7 +10640,7 @@
           <p:cNvPr id="10" name="TextBox 9">
             <a:extLst>
               <a:ext uri="{FF2B5EF4-FFF2-40B4-BE49-F238E27FC236}">
-                <a16:creationId xmlns:a16="http://schemas.microsoft.com/office/drawing/2014/main" id="{92A510E0-95BA-623E-DD85-3AB33DD668F4}"/>
+                <a16:creationId xmlns:a16="http://schemas.microsoft.com/office/drawing/2014/main" id="{FFCC2192-2412-B15A-8564-1923400A6C4C}"/>
               </a:ext>
             </a:extLst>
           </p:cNvPr>
@@ -10681,7 +10681,7 @@
           <p:cNvPr id="11" name="TextBox 10">
             <a:extLst>
               <a:ext uri="{FF2B5EF4-FFF2-40B4-BE49-F238E27FC236}">
-                <a16:creationId xmlns:a16="http://schemas.microsoft.com/office/drawing/2014/main" id="{D592243A-6AB4-CC00-4FA9-82DCDFA1903A}"/>
+                <a16:creationId xmlns:a16="http://schemas.microsoft.com/office/drawing/2014/main" id="{BDF444C9-A276-A7F5-B673-CFDF205A9A7D}"/>
               </a:ext>
             </a:extLst>
           </p:cNvPr>
@@ -10723,7 +10723,7 @@
           <p:cNvPr id="12" name="TextBox 11">
             <a:extLst>
               <a:ext uri="{FF2B5EF4-FFF2-40B4-BE49-F238E27FC236}">
-                <a16:creationId xmlns:a16="http://schemas.microsoft.com/office/drawing/2014/main" id="{1F5F1FD3-A30F-B611-099D-4D16CEC4BDB5}"/>
+                <a16:creationId xmlns:a16="http://schemas.microsoft.com/office/drawing/2014/main" id="{D99433F2-03D2-96AA-ACEC-806284CE800E}"/>
               </a:ext>
             </a:extLst>
           </p:cNvPr>
@@ -10764,7 +10764,7 @@
           <p:cNvPr id="13" name="TextBox 12">
             <a:extLst>
               <a:ext uri="{FF2B5EF4-FFF2-40B4-BE49-F238E27FC236}">
-                <a16:creationId xmlns:a16="http://schemas.microsoft.com/office/drawing/2014/main" id="{36E432D3-E3D4-E99C-88FA-441F0835755E}"/>
+                <a16:creationId xmlns:a16="http://schemas.microsoft.com/office/drawing/2014/main" id="{DFD86F75-FC0B-8486-E64A-0AE56084DF37}"/>
               </a:ext>
             </a:extLst>
           </p:cNvPr>
@@ -10805,7 +10805,7 @@
           <p:cNvPr id="14" name="TextBox 13">
             <a:extLst>
               <a:ext uri="{FF2B5EF4-FFF2-40B4-BE49-F238E27FC236}">
-                <a16:creationId xmlns:a16="http://schemas.microsoft.com/office/drawing/2014/main" id="{6ED60021-8C52-DD04-8E80-945C0B66A0E1}"/>
+                <a16:creationId xmlns:a16="http://schemas.microsoft.com/office/drawing/2014/main" id="{FB7D1258-B8B7-22DF-C09D-1426B2E1FC5A}"/>
               </a:ext>
             </a:extLst>
           </p:cNvPr>
@@ -10847,7 +10847,7 @@
           <p:cNvPr id="15" name="Straight Connector 14">
             <a:extLst>
               <a:ext uri="{FF2B5EF4-FFF2-40B4-BE49-F238E27FC236}">
-                <a16:creationId xmlns:a16="http://schemas.microsoft.com/office/drawing/2014/main" id="{217012F1-437D-F08D-2F0C-4C216E63BD5E}"/>
+                <a16:creationId xmlns:a16="http://schemas.microsoft.com/office/drawing/2014/main" id="{4760EB01-AE12-8E1C-7C26-B52FA08D00C1}"/>
               </a:ext>
             </a:extLst>
           </p:cNvPr>
@@ -10888,7 +10888,7 @@
           <p:cNvPr id="16" name="TextBox 15">
             <a:extLst>
               <a:ext uri="{FF2B5EF4-FFF2-40B4-BE49-F238E27FC236}">
-                <a16:creationId xmlns:a16="http://schemas.microsoft.com/office/drawing/2014/main" id="{F3CA1620-8EC7-C24F-84FE-1DCFE5B5D516}"/>
+                <a16:creationId xmlns:a16="http://schemas.microsoft.com/office/drawing/2014/main" id="{7F0FC851-C6C4-383E-BE65-D5CF881ACBB3}"/>
               </a:ext>
             </a:extLst>
           </p:cNvPr>
@@ -10928,7 +10928,7 @@
           <p:cNvPr id="17" name="TextBox 16">
             <a:extLst>
               <a:ext uri="{FF2B5EF4-FFF2-40B4-BE49-F238E27FC236}">
-                <a16:creationId xmlns:a16="http://schemas.microsoft.com/office/drawing/2014/main" id="{9639DBDF-B687-0496-EAAF-D96354FD7C72}"/>
+                <a16:creationId xmlns:a16="http://schemas.microsoft.com/office/drawing/2014/main" id="{D9E41112-903F-86D4-86FF-39DC7762E2A0}"/>
               </a:ext>
             </a:extLst>
           </p:cNvPr>
@@ -10969,7 +10969,7 @@
           <p:cNvPr id="18" name="TextBox 17">
             <a:extLst>
               <a:ext uri="{FF2B5EF4-FFF2-40B4-BE49-F238E27FC236}">
-                <a16:creationId xmlns:a16="http://schemas.microsoft.com/office/drawing/2014/main" id="{F40B925A-8050-F87E-572C-57E12E71D947}"/>
+                <a16:creationId xmlns:a16="http://schemas.microsoft.com/office/drawing/2014/main" id="{5927FEAE-3B78-627E-4694-1E4732B92A51}"/>
               </a:ext>
             </a:extLst>
           </p:cNvPr>
@@ -11009,7 +11009,7 @@
           <p:cNvPr id="19" name="TextBox 18">
             <a:extLst>
               <a:ext uri="{FF2B5EF4-FFF2-40B4-BE49-F238E27FC236}">
-                <a16:creationId xmlns:a16="http://schemas.microsoft.com/office/drawing/2014/main" id="{86960BDC-E914-6B08-3935-B6DA6F786F01}"/>
+                <a16:creationId xmlns:a16="http://schemas.microsoft.com/office/drawing/2014/main" id="{409B2506-C583-4E0F-8E9C-D7349A5FDC14}"/>
               </a:ext>
             </a:extLst>
           </p:cNvPr>
@@ -11050,7 +11050,7 @@
           <p:cNvPr id="20" name="TextBox 19">
             <a:extLst>
               <a:ext uri="{FF2B5EF4-FFF2-40B4-BE49-F238E27FC236}">
-                <a16:creationId xmlns:a16="http://schemas.microsoft.com/office/drawing/2014/main" id="{6161D413-8526-19E8-7611-1C81A9BEEF16}"/>
+                <a16:creationId xmlns:a16="http://schemas.microsoft.com/office/drawing/2014/main" id="{4F4E9FCE-02CE-D873-F478-82066FA0C902}"/>
               </a:ext>
             </a:extLst>
           </p:cNvPr>
@@ -11089,7 +11089,7 @@
     </p:spTree>
     <p:extLst>
       <p:ext uri="{BB962C8B-B14F-4D97-AF65-F5344CB8AC3E}">
-        <p14:creationId xmlns:p14="http://schemas.microsoft.com/office/powerpoint/2010/main" val="810924571"/>
+        <p14:creationId xmlns:p14="http://schemas.microsoft.com/office/powerpoint/2010/main" val="882380454"/>
       </p:ext>
     </p:extLst>
   </p:cSld>
@@ -11129,7 +11129,7 @@
           <p:cNvPr id="2" name="TextBox 1">
             <a:extLst>
               <a:ext uri="{FF2B5EF4-FFF2-40B4-BE49-F238E27FC236}">
-                <a16:creationId xmlns:a16="http://schemas.microsoft.com/office/drawing/2014/main" id="{AC8CD650-92AB-2C23-D875-57F688BB45E0}"/>
+                <a16:creationId xmlns:a16="http://schemas.microsoft.com/office/drawing/2014/main" id="{174BA779-651B-EAF2-A7BE-23DF7853156C}"/>
               </a:ext>
             </a:extLst>
           </p:cNvPr>
@@ -11138,8 +11138,8 @@
         </p:nvSpPr>
         <p:spPr>
           <a:xfrm>
-            <a:off x="609600" y="254000"/>
-            <a:ext cx="3429000" cy="228600"/>
+            <a:off x="609600" y="228599"/>
+            <a:ext cx="3810000" cy="279400"/>
           </a:xfrm>
           <a:prstGeom prst="rect">
             <a:avLst/>
@@ -11153,7 +11153,7 @@
           <a:lstStyle/>
           <a:p>
             <a:r>
-              <a:rPr lang="en-US" sz="1100" b="1">
+              <a:rPr lang="en-US" sz="1600" b="1">
                 <a:solidFill>
                   <a:srgbClr val="60727D"/>
                 </a:solidFill>
@@ -11169,7 +11169,7 @@
           <p:cNvPr id="3" name="Straight Connector 2">
             <a:extLst>
               <a:ext uri="{FF2B5EF4-FFF2-40B4-BE49-F238E27FC236}">
-                <a16:creationId xmlns:a16="http://schemas.microsoft.com/office/drawing/2014/main" id="{7094A19A-0C6C-68BC-C566-07BFAFEAAA65}"/>
+                <a16:creationId xmlns:a16="http://schemas.microsoft.com/office/drawing/2014/main" id="{A2D997C5-5988-24A7-E9F8-1ACCA2496C55}"/>
               </a:ext>
             </a:extLst>
           </p:cNvPr>
@@ -11210,7 +11210,7 @@
           <p:cNvPr id="4" name="TextBox 3">
             <a:extLst>
               <a:ext uri="{FF2B5EF4-FFF2-40B4-BE49-F238E27FC236}">
-                <a16:creationId xmlns:a16="http://schemas.microsoft.com/office/drawing/2014/main" id="{E47D27E8-7E31-1CBB-869A-4B26E6BB2544}"/>
+                <a16:creationId xmlns:a16="http://schemas.microsoft.com/office/drawing/2014/main" id="{58B60EC9-9493-0D32-9EAA-1FEE04E1CDEB}"/>
               </a:ext>
             </a:extLst>
           </p:cNvPr>
@@ -11219,8 +11219,8 @@
         </p:nvSpPr>
         <p:spPr>
           <a:xfrm>
-            <a:off x="11201400" y="6451600"/>
-            <a:ext cx="381000" cy="203200"/>
+            <a:off x="11150600" y="6388099"/>
+            <a:ext cx="431800" cy="279400"/>
           </a:xfrm>
           <a:prstGeom prst="rect">
             <a:avLst/>
@@ -11235,7 +11235,7 @@
           <a:p>
             <a:pPr algn="r"/>
             <a:r>
-              <a:rPr lang="en-US" sz="1000">
+              <a:rPr lang="en-US" sz="1600">
                 <a:solidFill>
                   <a:srgbClr val="60727D"/>
                 </a:solidFill>
@@ -11251,7 +11251,7 @@
           <p:cNvPr id="5" name="TextBox 4">
             <a:extLst>
               <a:ext uri="{FF2B5EF4-FFF2-40B4-BE49-F238E27FC236}">
-                <a16:creationId xmlns:a16="http://schemas.microsoft.com/office/drawing/2014/main" id="{D42C8F1F-EAC6-15BE-BB02-39F4C057B4C8}"/>
+                <a16:creationId xmlns:a16="http://schemas.microsoft.com/office/drawing/2014/main" id="{C49537C2-1E60-51B3-D0D9-A4673795502A}"/>
               </a:ext>
             </a:extLst>
           </p:cNvPr>
@@ -11260,8 +11260,8 @@
         </p:nvSpPr>
         <p:spPr>
           <a:xfrm>
-            <a:off x="609600" y="6438900"/>
-            <a:ext cx="3556000" cy="203200"/>
+            <a:off x="609600" y="6388099"/>
+            <a:ext cx="4064000" cy="279400"/>
           </a:xfrm>
           <a:prstGeom prst="rect">
             <a:avLst/>
@@ -11275,7 +11275,7 @@
           <a:lstStyle/>
           <a:p>
             <a:r>
-              <a:rPr lang="en-US" sz="900">
+              <a:rPr lang="en-US" sz="1600">
                 <a:solidFill>
                   <a:srgbClr val="60727D"/>
                 </a:solidFill>
@@ -11291,7 +11291,7 @@
           <p:cNvPr id="6" name="TextBox 5">
             <a:extLst>
               <a:ext uri="{FF2B5EF4-FFF2-40B4-BE49-F238E27FC236}">
-                <a16:creationId xmlns:a16="http://schemas.microsoft.com/office/drawing/2014/main" id="{FC887106-9FBB-E823-4407-E5AF5D51A938}"/>
+                <a16:creationId xmlns:a16="http://schemas.microsoft.com/office/drawing/2014/main" id="{DDA9DC15-FE54-E615-F7E2-CA6B8C816CB9}"/>
               </a:ext>
             </a:extLst>
           </p:cNvPr>
@@ -11331,7 +11331,7 @@
           <p:cNvPr id="7" name="Straight Connector 6">
             <a:extLst>
               <a:ext uri="{FF2B5EF4-FFF2-40B4-BE49-F238E27FC236}">
-                <a16:creationId xmlns:a16="http://schemas.microsoft.com/office/drawing/2014/main" id="{79DC0F5C-1296-580B-E9A5-55E682E94864}"/>
+                <a16:creationId xmlns:a16="http://schemas.microsoft.com/office/drawing/2014/main" id="{1CA18D4F-CFDE-7458-8675-50B48A6B7AE6}"/>
               </a:ext>
             </a:extLst>
           </p:cNvPr>
@@ -11373,7 +11373,7 @@
           <p:cNvPr id="8" name="Straight Connector 7">
             <a:extLst>
               <a:ext uri="{FF2B5EF4-FFF2-40B4-BE49-F238E27FC236}">
-                <a16:creationId xmlns:a16="http://schemas.microsoft.com/office/drawing/2014/main" id="{9B71A5C2-9D95-1FD8-1732-2DBF4F0BE742}"/>
+                <a16:creationId xmlns:a16="http://schemas.microsoft.com/office/drawing/2014/main" id="{FF342671-58AC-FCD2-1271-1B9DFA33881F}"/>
               </a:ext>
             </a:extLst>
           </p:cNvPr>
@@ -11415,7 +11415,7 @@
           <p:cNvPr id="9" name="Rectangle: Rounded Corners 8">
             <a:extLst>
               <a:ext uri="{FF2B5EF4-FFF2-40B4-BE49-F238E27FC236}">
-                <a16:creationId xmlns:a16="http://schemas.microsoft.com/office/drawing/2014/main" id="{3B325630-776E-3CD2-F7B8-FDA830059F5D}"/>
+                <a16:creationId xmlns:a16="http://schemas.microsoft.com/office/drawing/2014/main" id="{F0335FCA-D198-94AC-B3CD-AF9E3017AA18}"/>
               </a:ext>
             </a:extLst>
           </p:cNvPr>
@@ -11483,7 +11483,7 @@
           <p:cNvPr id="10" name="TextBox 9">
             <a:extLst>
               <a:ext uri="{FF2B5EF4-FFF2-40B4-BE49-F238E27FC236}">
-                <a16:creationId xmlns:a16="http://schemas.microsoft.com/office/drawing/2014/main" id="{94804977-F6FC-EB33-8A21-C21B428727EA}"/>
+                <a16:creationId xmlns:a16="http://schemas.microsoft.com/office/drawing/2014/main" id="{A85ABFCC-6F37-FBBA-9EA4-A62AD25AD12A}"/>
               </a:ext>
             </a:extLst>
           </p:cNvPr>
@@ -11524,7 +11524,7 @@
           <p:cNvPr id="11" name="TextBox 10">
             <a:extLst>
               <a:ext uri="{FF2B5EF4-FFF2-40B4-BE49-F238E27FC236}">
-                <a16:creationId xmlns:a16="http://schemas.microsoft.com/office/drawing/2014/main" id="{1865B744-45C1-48E9-15E8-33A20D27D261}"/>
+                <a16:creationId xmlns:a16="http://schemas.microsoft.com/office/drawing/2014/main" id="{3733590F-4EBD-1E05-C28B-7D00793BE2F0}"/>
               </a:ext>
             </a:extLst>
           </p:cNvPr>
@@ -11567,7 +11567,7 @@
           <p:cNvPr id="12" name="Rectangle: Rounded Corners 11">
             <a:extLst>
               <a:ext uri="{FF2B5EF4-FFF2-40B4-BE49-F238E27FC236}">
-                <a16:creationId xmlns:a16="http://schemas.microsoft.com/office/drawing/2014/main" id="{78026B0A-686A-A481-BDD1-1A842207B1F3}"/>
+                <a16:creationId xmlns:a16="http://schemas.microsoft.com/office/drawing/2014/main" id="{A139C811-368E-8FD4-27B3-0C79AE7484BC}"/>
               </a:ext>
             </a:extLst>
           </p:cNvPr>
@@ -11635,7 +11635,7 @@
           <p:cNvPr id="13" name="TextBox 12">
             <a:extLst>
               <a:ext uri="{FF2B5EF4-FFF2-40B4-BE49-F238E27FC236}">
-                <a16:creationId xmlns:a16="http://schemas.microsoft.com/office/drawing/2014/main" id="{442194C1-EE00-F535-1A5F-176587D4088D}"/>
+                <a16:creationId xmlns:a16="http://schemas.microsoft.com/office/drawing/2014/main" id="{FAF6AA11-F130-1AB7-C118-15818887DB5B}"/>
               </a:ext>
             </a:extLst>
           </p:cNvPr>
@@ -11676,7 +11676,7 @@
           <p:cNvPr id="14" name="TextBox 13">
             <a:extLst>
               <a:ext uri="{FF2B5EF4-FFF2-40B4-BE49-F238E27FC236}">
-                <a16:creationId xmlns:a16="http://schemas.microsoft.com/office/drawing/2014/main" id="{691C9967-D2A5-C700-CD45-21BD053630F8}"/>
+                <a16:creationId xmlns:a16="http://schemas.microsoft.com/office/drawing/2014/main" id="{02623D7E-707C-D1D2-1B4E-9AD23C6EF7A1}"/>
               </a:ext>
             </a:extLst>
           </p:cNvPr>
@@ -11685,8 +11685,8 @@
         </p:nvSpPr>
         <p:spPr>
           <a:xfrm>
-            <a:off x="5105400" y="3174999"/>
-            <a:ext cx="1473200" cy="304800"/>
+            <a:off x="5054600" y="3174999"/>
+            <a:ext cx="1574800" cy="304800"/>
           </a:xfrm>
           <a:prstGeom prst="rect">
             <a:avLst/>
@@ -11701,7 +11701,7 @@
           <a:p>
             <a:pPr algn="ctr"/>
             <a:r>
-              <a:rPr lang="en-US" sz="1500" b="1">
+              <a:rPr lang="en-US" sz="1600" b="1">
                 <a:solidFill>
                   <a:srgbClr val="071923"/>
                 </a:solidFill>
@@ -11717,7 +11717,7 @@
           <p:cNvPr id="15" name="Rectangle: Rounded Corners 14">
             <a:extLst>
               <a:ext uri="{FF2B5EF4-FFF2-40B4-BE49-F238E27FC236}">
-                <a16:creationId xmlns:a16="http://schemas.microsoft.com/office/drawing/2014/main" id="{F35388B6-6BDF-1FF7-476F-FD128789E204}"/>
+                <a16:creationId xmlns:a16="http://schemas.microsoft.com/office/drawing/2014/main" id="{E7A21BDF-D574-4535-A08B-8A96E080C3B1}"/>
               </a:ext>
             </a:extLst>
           </p:cNvPr>
@@ -11785,7 +11785,7 @@
           <p:cNvPr id="16" name="TextBox 15">
             <a:extLst>
               <a:ext uri="{FF2B5EF4-FFF2-40B4-BE49-F238E27FC236}">
-                <a16:creationId xmlns:a16="http://schemas.microsoft.com/office/drawing/2014/main" id="{DA515817-38A0-2636-D04B-1A6C15050C39}"/>
+                <a16:creationId xmlns:a16="http://schemas.microsoft.com/office/drawing/2014/main" id="{8C67E87D-385F-3B5C-388C-6378624EE4D4}"/>
               </a:ext>
             </a:extLst>
           </p:cNvPr>
@@ -11826,7 +11826,7 @@
           <p:cNvPr id="17" name="TextBox 16">
             <a:extLst>
               <a:ext uri="{FF2B5EF4-FFF2-40B4-BE49-F238E27FC236}">
-                <a16:creationId xmlns:a16="http://schemas.microsoft.com/office/drawing/2014/main" id="{340F1CB4-0876-FC2B-825B-4DC1023A767C}"/>
+                <a16:creationId xmlns:a16="http://schemas.microsoft.com/office/drawing/2014/main" id="{49514C09-063B-B4B1-2908-FDDD1522BBB3}"/>
               </a:ext>
             </a:extLst>
           </p:cNvPr>
@@ -11869,7 +11869,7 @@
           <p:cNvPr id="18" name="TextBox 17">
             <a:extLst>
               <a:ext uri="{FF2B5EF4-FFF2-40B4-BE49-F238E27FC236}">
-                <a16:creationId xmlns:a16="http://schemas.microsoft.com/office/drawing/2014/main" id="{225882DB-E59B-0910-5082-8C10BB0381ED}"/>
+                <a16:creationId xmlns:a16="http://schemas.microsoft.com/office/drawing/2014/main" id="{616DFEA5-B92F-3CA6-DA42-6FBED2B0B965}"/>
               </a:ext>
             </a:extLst>
           </p:cNvPr>
@@ -11909,7 +11909,7 @@
           <p:cNvPr id="19" name="Straight Connector 18">
             <a:extLst>
               <a:ext uri="{FF2B5EF4-FFF2-40B4-BE49-F238E27FC236}">
-                <a16:creationId xmlns:a16="http://schemas.microsoft.com/office/drawing/2014/main" id="{21EE63F7-1995-8C0B-A8A6-E726C32E99C8}"/>
+                <a16:creationId xmlns:a16="http://schemas.microsoft.com/office/drawing/2014/main" id="{1AFEE0B8-A775-101F-55DC-4E19246BC5E6}"/>
               </a:ext>
             </a:extLst>
           </p:cNvPr>
@@ -11950,7 +11950,7 @@
           <p:cNvPr id="20" name="TextBox 19">
             <a:extLst>
               <a:ext uri="{FF2B5EF4-FFF2-40B4-BE49-F238E27FC236}">
-                <a16:creationId xmlns:a16="http://schemas.microsoft.com/office/drawing/2014/main" id="{3D7A78EC-3B8C-50D6-06F1-3A5C87A5F928}"/>
+                <a16:creationId xmlns:a16="http://schemas.microsoft.com/office/drawing/2014/main" id="{E9A34DA4-DD80-5599-E54F-F312C442DD3D}"/>
               </a:ext>
             </a:extLst>
           </p:cNvPr>
@@ -11990,7 +11990,7 @@
           <p:cNvPr id="21" name="Straight Connector 20">
             <a:extLst>
               <a:ext uri="{FF2B5EF4-FFF2-40B4-BE49-F238E27FC236}">
-                <a16:creationId xmlns:a16="http://schemas.microsoft.com/office/drawing/2014/main" id="{B735C0EF-A0F1-83E7-5D38-4CC84BFF20CC}"/>
+                <a16:creationId xmlns:a16="http://schemas.microsoft.com/office/drawing/2014/main" id="{06130BEF-B2AD-BA00-C3D7-DD50127FAA8D}"/>
               </a:ext>
             </a:extLst>
           </p:cNvPr>
@@ -12031,7 +12031,7 @@
           <p:cNvPr id="22" name="TextBox 21">
             <a:extLst>
               <a:ext uri="{FF2B5EF4-FFF2-40B4-BE49-F238E27FC236}">
-                <a16:creationId xmlns:a16="http://schemas.microsoft.com/office/drawing/2014/main" id="{69F7DEC0-AA0C-87EA-B28A-5BBC49FA1AAB}"/>
+                <a16:creationId xmlns:a16="http://schemas.microsoft.com/office/drawing/2014/main" id="{D8A49489-2965-549D-ECE3-8F3E3680F7AA}"/>
               </a:ext>
             </a:extLst>
           </p:cNvPr>
@@ -12071,7 +12071,7 @@
           <p:cNvPr id="23" name="Straight Connector 22">
             <a:extLst>
               <a:ext uri="{FF2B5EF4-FFF2-40B4-BE49-F238E27FC236}">
-                <a16:creationId xmlns:a16="http://schemas.microsoft.com/office/drawing/2014/main" id="{C6424520-DF83-DADD-CA25-95BABF48AFAD}"/>
+                <a16:creationId xmlns:a16="http://schemas.microsoft.com/office/drawing/2014/main" id="{5DBF6E94-05DD-31D9-0953-1714D71DA797}"/>
               </a:ext>
             </a:extLst>
           </p:cNvPr>
@@ -12112,7 +12112,7 @@
           <p:cNvPr id="24" name="TextBox 23">
             <a:extLst>
               <a:ext uri="{FF2B5EF4-FFF2-40B4-BE49-F238E27FC236}">
-                <a16:creationId xmlns:a16="http://schemas.microsoft.com/office/drawing/2014/main" id="{607AA6F8-48FC-F3C2-2226-BE9CB201856F}"/>
+                <a16:creationId xmlns:a16="http://schemas.microsoft.com/office/drawing/2014/main" id="{6AC3B780-34FC-FB60-C1F2-7278C67ECA4D}"/>
               </a:ext>
             </a:extLst>
           </p:cNvPr>
@@ -12150,7 +12150,7 @@
     </p:spTree>
     <p:extLst>
       <p:ext uri="{BB962C8B-B14F-4D97-AF65-F5344CB8AC3E}">
-        <p14:creationId xmlns:p14="http://schemas.microsoft.com/office/powerpoint/2010/main" val="3640199672"/>
+        <p14:creationId xmlns:p14="http://schemas.microsoft.com/office/powerpoint/2010/main" val="3426412469"/>
       </p:ext>
     </p:extLst>
   </p:cSld>
@@ -12190,7 +12190,7 @@
           <p:cNvPr id="2" name="TextBox 1">
             <a:extLst>
               <a:ext uri="{FF2B5EF4-FFF2-40B4-BE49-F238E27FC236}">
-                <a16:creationId xmlns:a16="http://schemas.microsoft.com/office/drawing/2014/main" id="{624ED787-3A99-3268-3F58-3442CA978576}"/>
+                <a16:creationId xmlns:a16="http://schemas.microsoft.com/office/drawing/2014/main" id="{A253F77D-2538-B1D8-E7F7-4F553D1D72C5}"/>
               </a:ext>
             </a:extLst>
           </p:cNvPr>
@@ -12199,8 +12199,8 @@
         </p:nvSpPr>
         <p:spPr>
           <a:xfrm>
-            <a:off x="609600" y="254000"/>
-            <a:ext cx="3429000" cy="228600"/>
+            <a:off x="609600" y="228599"/>
+            <a:ext cx="3810000" cy="279400"/>
           </a:xfrm>
           <a:prstGeom prst="rect">
             <a:avLst/>
@@ -12214,7 +12214,7 @@
           <a:lstStyle/>
           <a:p>
             <a:r>
-              <a:rPr lang="en-US" sz="1100" b="1">
+              <a:rPr lang="en-US" sz="1600" b="1">
                 <a:solidFill>
                   <a:srgbClr val="83939D"/>
                 </a:solidFill>
@@ -12230,7 +12230,7 @@
           <p:cNvPr id="3" name="Straight Connector 2">
             <a:extLst>
               <a:ext uri="{FF2B5EF4-FFF2-40B4-BE49-F238E27FC236}">
-                <a16:creationId xmlns:a16="http://schemas.microsoft.com/office/drawing/2014/main" id="{E82674F6-26A0-38BA-F047-CD8018B08095}"/>
+                <a16:creationId xmlns:a16="http://schemas.microsoft.com/office/drawing/2014/main" id="{FFFA0E6B-343E-5F47-79A5-FBE53B6CEFD7}"/>
               </a:ext>
             </a:extLst>
           </p:cNvPr>
@@ -12271,7 +12271,7 @@
           <p:cNvPr id="4" name="TextBox 3">
             <a:extLst>
               <a:ext uri="{FF2B5EF4-FFF2-40B4-BE49-F238E27FC236}">
-                <a16:creationId xmlns:a16="http://schemas.microsoft.com/office/drawing/2014/main" id="{B018146B-D748-51A8-E74A-7DF123EE796C}"/>
+                <a16:creationId xmlns:a16="http://schemas.microsoft.com/office/drawing/2014/main" id="{23F8E0AE-6343-6D45-BFB9-772FC35AE032}"/>
               </a:ext>
             </a:extLst>
           </p:cNvPr>
@@ -12280,8 +12280,8 @@
         </p:nvSpPr>
         <p:spPr>
           <a:xfrm>
-            <a:off x="11201400" y="6451600"/>
-            <a:ext cx="381000" cy="203200"/>
+            <a:off x="11150600" y="6388099"/>
+            <a:ext cx="431800" cy="279400"/>
           </a:xfrm>
           <a:prstGeom prst="rect">
             <a:avLst/>
@@ -12296,7 +12296,7 @@
           <a:p>
             <a:pPr algn="r"/>
             <a:r>
-              <a:rPr lang="en-US" sz="1000">
+              <a:rPr lang="en-US" sz="1600">
                 <a:solidFill>
                   <a:srgbClr val="83939D"/>
                 </a:solidFill>
@@ -12312,7 +12312,7 @@
           <p:cNvPr id="5" name="TextBox 4">
             <a:extLst>
               <a:ext uri="{FF2B5EF4-FFF2-40B4-BE49-F238E27FC236}">
-                <a16:creationId xmlns:a16="http://schemas.microsoft.com/office/drawing/2014/main" id="{AECB6ABF-5633-741F-5888-333213E075DD}"/>
+                <a16:creationId xmlns:a16="http://schemas.microsoft.com/office/drawing/2014/main" id="{E269D684-6133-C35D-B9FE-335F4B5E2D35}"/>
               </a:ext>
             </a:extLst>
           </p:cNvPr>
@@ -12321,8 +12321,8 @@
         </p:nvSpPr>
         <p:spPr>
           <a:xfrm>
-            <a:off x="609600" y="6438900"/>
-            <a:ext cx="3556000" cy="203200"/>
+            <a:off x="609600" y="6388099"/>
+            <a:ext cx="4064000" cy="279400"/>
           </a:xfrm>
           <a:prstGeom prst="rect">
             <a:avLst/>
@@ -12336,7 +12336,7 @@
           <a:lstStyle/>
           <a:p>
             <a:r>
-              <a:rPr lang="en-US" sz="900">
+              <a:rPr lang="en-US" sz="1600">
                 <a:solidFill>
                   <a:srgbClr val="83939D"/>
                 </a:solidFill>
@@ -12352,7 +12352,7 @@
           <p:cNvPr id="6" name="TextBox 5">
             <a:extLst>
               <a:ext uri="{FF2B5EF4-FFF2-40B4-BE49-F238E27FC236}">
-                <a16:creationId xmlns:a16="http://schemas.microsoft.com/office/drawing/2014/main" id="{8266C0CF-ADE4-55A6-E4AE-1C31801F6A9E}"/>
+                <a16:creationId xmlns:a16="http://schemas.microsoft.com/office/drawing/2014/main" id="{C7AB00C8-5C0B-83A0-67DC-02B6ABF1FF6B}"/>
               </a:ext>
             </a:extLst>
           </p:cNvPr>
@@ -12392,7 +12392,7 @@
           <p:cNvPr id="7" name="Rectangle: Rounded Corners 6">
             <a:extLst>
               <a:ext uri="{FF2B5EF4-FFF2-40B4-BE49-F238E27FC236}">
-                <a16:creationId xmlns:a16="http://schemas.microsoft.com/office/drawing/2014/main" id="{C167AB8B-C1DA-7709-CEC8-AD52A2A2D2C4}"/>
+                <a16:creationId xmlns:a16="http://schemas.microsoft.com/office/drawing/2014/main" id="{61EA8167-F5B6-C1B1-FE74-CB0653F0759D}"/>
               </a:ext>
             </a:extLst>
           </p:cNvPr>
@@ -12443,10 +12443,10 @@
       </p:sp>
       <p:pic>
         <p:nvPicPr>
-          <p:cNvPr id="9" name="Picture 8" descr="Live Scenario page showing a shared GPU run, interactive schematic, and locality detail">
-            <a:extLst>
-              <a:ext uri="{FF2B5EF4-FFF2-40B4-BE49-F238E27FC236}">
-                <a16:creationId xmlns:a16="http://schemas.microsoft.com/office/drawing/2014/main" id="{D59BC1EC-E643-8214-FE8A-017B6D745286}"/>
+          <p:cNvPr id="9" name="Picture 8" descr="Live Scenario page showing a shared GPU run, interactive administrative map, and locality detail">
+            <a:extLst>
+              <a:ext uri="{FF2B5EF4-FFF2-40B4-BE49-F238E27FC236}">
+                <a16:creationId xmlns:a16="http://schemas.microsoft.com/office/drawing/2014/main" id="{7D9AC1A2-D966-4363-8BC8-A0A13F8F3A97}"/>
               </a:ext>
             </a:extLst>
           </p:cNvPr>
@@ -12482,7 +12482,7 @@
           <p:cNvPr id="10" name="TextBox 9">
             <a:extLst>
               <a:ext uri="{FF2B5EF4-FFF2-40B4-BE49-F238E27FC236}">
-                <a16:creationId xmlns:a16="http://schemas.microsoft.com/office/drawing/2014/main" id="{E838EEF5-F673-D28C-7CF1-62B2479BEF33}"/>
+                <a16:creationId xmlns:a16="http://schemas.microsoft.com/office/drawing/2014/main" id="{69FC05E0-584D-4344-612B-C35C4BBA30D6}"/>
               </a:ext>
             </a:extLst>
           </p:cNvPr>
@@ -12491,8 +12491,8 @@
         </p:nvSpPr>
         <p:spPr>
           <a:xfrm>
-            <a:off x="1079500" y="6121400"/>
-            <a:ext cx="10033000" cy="254000"/>
+            <a:off x="990600" y="6095999"/>
+            <a:ext cx="10210800" cy="304800"/>
           </a:xfrm>
           <a:prstGeom prst="rect">
             <a:avLst/>
@@ -12507,7 +12507,7 @@
           <a:p>
             <a:pPr algn="ctr"/>
             <a:r>
-              <a:rPr lang="en-US" sz="1400" b="1">
+              <a:rPr lang="en-US" sz="1600" b="1">
                 <a:solidFill>
                   <a:srgbClr val="3FC6AC"/>
                 </a:solidFill>
@@ -12521,7 +12521,7 @@
     </p:spTree>
     <p:extLst>
       <p:ext uri="{BB962C8B-B14F-4D97-AF65-F5344CB8AC3E}">
-        <p14:creationId xmlns:p14="http://schemas.microsoft.com/office/powerpoint/2010/main" val="2184828174"/>
+        <p14:creationId xmlns:p14="http://schemas.microsoft.com/office/powerpoint/2010/main" val="4024831373"/>
       </p:ext>
     </p:extLst>
   </p:cSld>
@@ -12561,7 +12561,7 @@
           <p:cNvPr id="2" name="TextBox 1">
             <a:extLst>
               <a:ext uri="{FF2B5EF4-FFF2-40B4-BE49-F238E27FC236}">
-                <a16:creationId xmlns:a16="http://schemas.microsoft.com/office/drawing/2014/main" id="{A794522B-9424-7D1C-2ADA-E20629A1282E}"/>
+                <a16:creationId xmlns:a16="http://schemas.microsoft.com/office/drawing/2014/main" id="{B0853572-7720-494E-761B-F757BD6B629E}"/>
               </a:ext>
             </a:extLst>
           </p:cNvPr>
@@ -12570,8 +12570,8 @@
         </p:nvSpPr>
         <p:spPr>
           <a:xfrm>
-            <a:off x="609600" y="254000"/>
-            <a:ext cx="3429000" cy="228600"/>
+            <a:off x="609600" y="228599"/>
+            <a:ext cx="3810000" cy="279400"/>
           </a:xfrm>
           <a:prstGeom prst="rect">
             <a:avLst/>
@@ -12585,7 +12585,7 @@
           <a:lstStyle/>
           <a:p>
             <a:r>
-              <a:rPr lang="en-US" sz="1100" b="1">
+              <a:rPr lang="en-US" sz="1600" b="1">
                 <a:solidFill>
                   <a:srgbClr val="60727D"/>
                 </a:solidFill>
@@ -12601,7 +12601,7 @@
           <p:cNvPr id="3" name="Straight Connector 2">
             <a:extLst>
               <a:ext uri="{FF2B5EF4-FFF2-40B4-BE49-F238E27FC236}">
-                <a16:creationId xmlns:a16="http://schemas.microsoft.com/office/drawing/2014/main" id="{7E49541A-FAA3-6212-47F1-4ED3E4DAF0D9}"/>
+                <a16:creationId xmlns:a16="http://schemas.microsoft.com/office/drawing/2014/main" id="{702E0A25-6117-2E1D-BE9E-12D5681F1D93}"/>
               </a:ext>
             </a:extLst>
           </p:cNvPr>
@@ -12642,7 +12642,7 @@
           <p:cNvPr id="4" name="TextBox 3">
             <a:extLst>
               <a:ext uri="{FF2B5EF4-FFF2-40B4-BE49-F238E27FC236}">
-                <a16:creationId xmlns:a16="http://schemas.microsoft.com/office/drawing/2014/main" id="{69016C06-84B4-55AB-29CE-A5318EB5141B}"/>
+                <a16:creationId xmlns:a16="http://schemas.microsoft.com/office/drawing/2014/main" id="{1F2060CA-80B7-2018-E1D0-482291DAC335}"/>
               </a:ext>
             </a:extLst>
           </p:cNvPr>
@@ -12651,8 +12651,8 @@
         </p:nvSpPr>
         <p:spPr>
           <a:xfrm>
-            <a:off x="11201400" y="6451600"/>
-            <a:ext cx="381000" cy="203200"/>
+            <a:off x="11150600" y="6388099"/>
+            <a:ext cx="431800" cy="279400"/>
           </a:xfrm>
           <a:prstGeom prst="rect">
             <a:avLst/>
@@ -12667,7 +12667,7 @@
           <a:p>
             <a:pPr algn="r"/>
             <a:r>
-              <a:rPr lang="en-US" sz="1000">
+              <a:rPr lang="en-US" sz="1600">
                 <a:solidFill>
                   <a:srgbClr val="60727D"/>
                 </a:solidFill>
@@ -12683,7 +12683,7 @@
           <p:cNvPr id="5" name="TextBox 4">
             <a:extLst>
               <a:ext uri="{FF2B5EF4-FFF2-40B4-BE49-F238E27FC236}">
-                <a16:creationId xmlns:a16="http://schemas.microsoft.com/office/drawing/2014/main" id="{CFD59649-79AD-8AD0-F91A-4C6B7951B9C2}"/>
+                <a16:creationId xmlns:a16="http://schemas.microsoft.com/office/drawing/2014/main" id="{6A9D9790-E74E-97C3-2FA9-DBAF52A51460}"/>
               </a:ext>
             </a:extLst>
           </p:cNvPr>
@@ -12692,8 +12692,8 @@
         </p:nvSpPr>
         <p:spPr>
           <a:xfrm>
-            <a:off x="609600" y="6438900"/>
-            <a:ext cx="3556000" cy="203200"/>
+            <a:off x="609600" y="6388099"/>
+            <a:ext cx="4064000" cy="279400"/>
           </a:xfrm>
           <a:prstGeom prst="rect">
             <a:avLst/>
@@ -12707,7 +12707,7 @@
           <a:lstStyle/>
           <a:p>
             <a:r>
-              <a:rPr lang="en-US" sz="900">
+              <a:rPr lang="en-US" sz="1600">
                 <a:solidFill>
                   <a:srgbClr val="60727D"/>
                 </a:solidFill>
@@ -12723,7 +12723,7 @@
           <p:cNvPr id="6" name="TextBox 5">
             <a:extLst>
               <a:ext uri="{FF2B5EF4-FFF2-40B4-BE49-F238E27FC236}">
-                <a16:creationId xmlns:a16="http://schemas.microsoft.com/office/drawing/2014/main" id="{F38CD248-98A9-B548-E7A7-C5011CBF3639}"/>
+                <a16:creationId xmlns:a16="http://schemas.microsoft.com/office/drawing/2014/main" id="{7D883C82-5041-08B8-65EE-B8660F007E1B}"/>
               </a:ext>
             </a:extLst>
           </p:cNvPr>
@@ -12763,7 +12763,7 @@
           <p:cNvPr id="7" name="TextBox 6">
             <a:extLst>
               <a:ext uri="{FF2B5EF4-FFF2-40B4-BE49-F238E27FC236}">
-                <a16:creationId xmlns:a16="http://schemas.microsoft.com/office/drawing/2014/main" id="{E1FF0D35-03DC-FEA1-1BB9-3D246A754A31}"/>
+                <a16:creationId xmlns:a16="http://schemas.microsoft.com/office/drawing/2014/main" id="{0D9A47D3-E49C-36AA-A949-E9E24F61F225}"/>
               </a:ext>
             </a:extLst>
           </p:cNvPr>
@@ -12803,7 +12803,7 @@
           <p:cNvPr id="8" name="TextBox 7">
             <a:extLst>
               <a:ext uri="{FF2B5EF4-FFF2-40B4-BE49-F238E27FC236}">
-                <a16:creationId xmlns:a16="http://schemas.microsoft.com/office/drawing/2014/main" id="{8DD7E8F4-1666-8E1B-A412-B9C6FF773588}"/>
+                <a16:creationId xmlns:a16="http://schemas.microsoft.com/office/drawing/2014/main" id="{61A5764A-A386-856C-CF9C-D30939EFCC96}"/>
               </a:ext>
             </a:extLst>
           </p:cNvPr>
@@ -12843,7 +12843,7 @@
           <p:cNvPr id="9" name="TextBox 8">
             <a:extLst>
               <a:ext uri="{FF2B5EF4-FFF2-40B4-BE49-F238E27FC236}">
-                <a16:creationId xmlns:a16="http://schemas.microsoft.com/office/drawing/2014/main" id="{7A8B68E0-F76A-7DCE-CB76-D9BE85CBDE38}"/>
+                <a16:creationId xmlns:a16="http://schemas.microsoft.com/office/drawing/2014/main" id="{7E0B9E32-B2D8-B022-FA9C-6AFAD7457B69}"/>
               </a:ext>
             </a:extLst>
           </p:cNvPr>
@@ -12883,7 +12883,7 @@
           <p:cNvPr id="10" name="TextBox 9">
             <a:extLst>
               <a:ext uri="{FF2B5EF4-FFF2-40B4-BE49-F238E27FC236}">
-                <a16:creationId xmlns:a16="http://schemas.microsoft.com/office/drawing/2014/main" id="{7337BC55-5661-4A66-E3D6-D8FC074E7589}"/>
+                <a16:creationId xmlns:a16="http://schemas.microsoft.com/office/drawing/2014/main" id="{4A561A36-4AC6-B00A-D55B-1F489B3B2C4D}"/>
               </a:ext>
             </a:extLst>
           </p:cNvPr>
@@ -12923,7 +12923,7 @@
           <p:cNvPr id="11" name="TextBox 10">
             <a:extLst>
               <a:ext uri="{FF2B5EF4-FFF2-40B4-BE49-F238E27FC236}">
-                <a16:creationId xmlns:a16="http://schemas.microsoft.com/office/drawing/2014/main" id="{4F5A2455-BCF5-EE62-283C-5DCDDFFBF782}"/>
+                <a16:creationId xmlns:a16="http://schemas.microsoft.com/office/drawing/2014/main" id="{4B014784-D55A-2A1D-95FA-B1A75E697F90}"/>
               </a:ext>
             </a:extLst>
           </p:cNvPr>
@@ -12963,7 +12963,7 @@
           <p:cNvPr id="12" name="Rectangle 11">
             <a:extLst>
               <a:ext uri="{FF2B5EF4-FFF2-40B4-BE49-F238E27FC236}">
-                <a16:creationId xmlns:a16="http://schemas.microsoft.com/office/drawing/2014/main" id="{2DFAC8C9-BE19-FC5B-FFC7-9F069F975380}"/>
+                <a16:creationId xmlns:a16="http://schemas.microsoft.com/office/drawing/2014/main" id="{5B39858E-101B-C302-AE8C-9ADB88C309CC}"/>
               </a:ext>
             </a:extLst>
           </p:cNvPr>
@@ -13031,7 +13031,7 @@
           <p:cNvPr id="13" name="Rectangle 12">
             <a:extLst>
               <a:ext uri="{FF2B5EF4-FFF2-40B4-BE49-F238E27FC236}">
-                <a16:creationId xmlns:a16="http://schemas.microsoft.com/office/drawing/2014/main" id="{524F690B-1235-2D2D-EE9B-B237115E5651}"/>
+                <a16:creationId xmlns:a16="http://schemas.microsoft.com/office/drawing/2014/main" id="{2C982DAA-EEE9-782E-9A75-241575F69113}"/>
               </a:ext>
             </a:extLst>
           </p:cNvPr>
@@ -13099,7 +13099,7 @@
           <p:cNvPr id="14" name="Rectangle 13">
             <a:extLst>
               <a:ext uri="{FF2B5EF4-FFF2-40B4-BE49-F238E27FC236}">
-                <a16:creationId xmlns:a16="http://schemas.microsoft.com/office/drawing/2014/main" id="{51E2A99D-691B-DADA-31AF-D08FA15AA170}"/>
+                <a16:creationId xmlns:a16="http://schemas.microsoft.com/office/drawing/2014/main" id="{ECFD3F14-F7D2-DE69-8D69-327C81518B3C}"/>
               </a:ext>
             </a:extLst>
           </p:cNvPr>
@@ -13167,7 +13167,7 @@
           <p:cNvPr id="15" name="Rectangle 14">
             <a:extLst>
               <a:ext uri="{FF2B5EF4-FFF2-40B4-BE49-F238E27FC236}">
-                <a16:creationId xmlns:a16="http://schemas.microsoft.com/office/drawing/2014/main" id="{40950774-3F36-91A6-6803-3952797E9157}"/>
+                <a16:creationId xmlns:a16="http://schemas.microsoft.com/office/drawing/2014/main" id="{4EDA0876-5F49-8363-495D-B54A5C63AE5D}"/>
               </a:ext>
             </a:extLst>
           </p:cNvPr>
@@ -13235,7 +13235,7 @@
           <p:cNvPr id="16" name="TextBox 15">
             <a:extLst>
               <a:ext uri="{FF2B5EF4-FFF2-40B4-BE49-F238E27FC236}">
-                <a16:creationId xmlns:a16="http://schemas.microsoft.com/office/drawing/2014/main" id="{18727393-4540-42E1-C3E5-3BCE15622D4A}"/>
+                <a16:creationId xmlns:a16="http://schemas.microsoft.com/office/drawing/2014/main" id="{5AC7EDF7-DC45-EF9E-4961-006D02ED9BDC}"/>
               </a:ext>
             </a:extLst>
           </p:cNvPr>
@@ -13244,8 +13244,8 @@
         </p:nvSpPr>
         <p:spPr>
           <a:xfrm>
-            <a:off x="10033000" y="3594100"/>
-            <a:ext cx="1333500" cy="254000"/>
+            <a:off x="9906000" y="3581399"/>
+            <a:ext cx="1524000" cy="279400"/>
           </a:xfrm>
           <a:prstGeom prst="rect">
             <a:avLst/>
@@ -13259,7 +13259,7 @@
           <a:lstStyle/>
           <a:p>
             <a:r>
-              <a:rPr lang="en-US" sz="1400">
+              <a:rPr lang="en-US" sz="1600">
                 <a:solidFill>
                   <a:srgbClr val="60727D"/>
                 </a:solidFill>
@@ -13275,7 +13275,7 @@
           <p:cNvPr id="17" name="TextBox 16">
             <a:extLst>
               <a:ext uri="{FF2B5EF4-FFF2-40B4-BE49-F238E27FC236}">
-                <a16:creationId xmlns:a16="http://schemas.microsoft.com/office/drawing/2014/main" id="{8DEDB071-B705-BC6F-D490-47611C02AB67}"/>
+                <a16:creationId xmlns:a16="http://schemas.microsoft.com/office/drawing/2014/main" id="{F4949B4F-98C7-780C-EEE1-FDD4F7F821C0}"/>
               </a:ext>
             </a:extLst>
           </p:cNvPr>
@@ -13284,8 +13284,8 @@
         </p:nvSpPr>
         <p:spPr>
           <a:xfrm>
-            <a:off x="10033000" y="3860800"/>
-            <a:ext cx="1333500" cy="254000"/>
+            <a:off x="9906000" y="3848099"/>
+            <a:ext cx="1524000" cy="279400"/>
           </a:xfrm>
           <a:prstGeom prst="rect">
             <a:avLst/>
@@ -13299,7 +13299,7 @@
           <a:lstStyle/>
           <a:p>
             <a:r>
-              <a:rPr lang="en-US" sz="1400" b="1">
+              <a:rPr lang="en-US" sz="1600" b="1">
                 <a:solidFill>
                   <a:srgbClr val="13232E"/>
                 </a:solidFill>
@@ -13315,7 +13315,7 @@
           <p:cNvPr id="18" name="Straight Connector 17">
             <a:extLst>
               <a:ext uri="{FF2B5EF4-FFF2-40B4-BE49-F238E27FC236}">
-                <a16:creationId xmlns:a16="http://schemas.microsoft.com/office/drawing/2014/main" id="{1F0FC56A-BB76-B8B0-D343-8F7373D03CFD}"/>
+                <a16:creationId xmlns:a16="http://schemas.microsoft.com/office/drawing/2014/main" id="{BCA12E81-93DB-0525-8B95-2E5920BE3584}"/>
               </a:ext>
             </a:extLst>
           </p:cNvPr>
@@ -13356,7 +13356,7 @@
           <p:cNvPr id="19" name="TextBox 18">
             <a:extLst>
               <a:ext uri="{FF2B5EF4-FFF2-40B4-BE49-F238E27FC236}">
-                <a16:creationId xmlns:a16="http://schemas.microsoft.com/office/drawing/2014/main" id="{EDD6F856-CB84-474B-33E7-CF067325833C}"/>
+                <a16:creationId xmlns:a16="http://schemas.microsoft.com/office/drawing/2014/main" id="{51536E1F-29F4-772E-8C83-F229B0241A90}"/>
               </a:ext>
             </a:extLst>
           </p:cNvPr>
@@ -13396,7 +13396,7 @@
           <p:cNvPr id="20" name="TextBox 19">
             <a:extLst>
               <a:ext uri="{FF2B5EF4-FFF2-40B4-BE49-F238E27FC236}">
-                <a16:creationId xmlns:a16="http://schemas.microsoft.com/office/drawing/2014/main" id="{9D72E6D1-64C4-605D-6FE4-6FF1AD89B0C6}"/>
+                <a16:creationId xmlns:a16="http://schemas.microsoft.com/office/drawing/2014/main" id="{8EF6E5DE-106B-644E-7C42-079D96212A8C}"/>
               </a:ext>
             </a:extLst>
           </p:cNvPr>
@@ -13436,7 +13436,7 @@
     </p:spTree>
     <p:extLst>
       <p:ext uri="{BB962C8B-B14F-4D97-AF65-F5344CB8AC3E}">
-        <p14:creationId xmlns:p14="http://schemas.microsoft.com/office/powerpoint/2010/main" val="2966546866"/>
+        <p14:creationId xmlns:p14="http://schemas.microsoft.com/office/powerpoint/2010/main" val="3455812846"/>
       </p:ext>
     </p:extLst>
   </p:cSld>
@@ -13476,7 +13476,7 @@
           <p:cNvPr id="2" name="TextBox 1">
             <a:extLst>
               <a:ext uri="{FF2B5EF4-FFF2-40B4-BE49-F238E27FC236}">
-                <a16:creationId xmlns:a16="http://schemas.microsoft.com/office/drawing/2014/main" id="{0931FC44-ABE8-2FF2-B71A-74EF90AF277B}"/>
+                <a16:creationId xmlns:a16="http://schemas.microsoft.com/office/drawing/2014/main" id="{AC53514C-FB02-0970-35F9-ED2CEAFF9FA9}"/>
               </a:ext>
             </a:extLst>
           </p:cNvPr>
@@ -13485,8 +13485,8 @@
         </p:nvSpPr>
         <p:spPr>
           <a:xfrm>
-            <a:off x="609600" y="254000"/>
-            <a:ext cx="3429000" cy="228600"/>
+            <a:off x="609600" y="228599"/>
+            <a:ext cx="3810000" cy="279400"/>
           </a:xfrm>
           <a:prstGeom prst="rect">
             <a:avLst/>
@@ -13500,7 +13500,7 @@
           <a:lstStyle/>
           <a:p>
             <a:r>
-              <a:rPr lang="en-US" sz="1100" b="1">
+              <a:rPr lang="en-US" sz="1600" b="1">
                 <a:solidFill>
                   <a:srgbClr val="83939D"/>
                 </a:solidFill>
@@ -13516,7 +13516,7 @@
           <p:cNvPr id="3" name="Straight Connector 2">
             <a:extLst>
               <a:ext uri="{FF2B5EF4-FFF2-40B4-BE49-F238E27FC236}">
-                <a16:creationId xmlns:a16="http://schemas.microsoft.com/office/drawing/2014/main" id="{08594883-CFFB-52F1-42A1-58EDFC3B8308}"/>
+                <a16:creationId xmlns:a16="http://schemas.microsoft.com/office/drawing/2014/main" id="{6950B542-62C7-ACED-8840-6086D8041B65}"/>
               </a:ext>
             </a:extLst>
           </p:cNvPr>
@@ -13557,7 +13557,7 @@
           <p:cNvPr id="4" name="TextBox 3">
             <a:extLst>
               <a:ext uri="{FF2B5EF4-FFF2-40B4-BE49-F238E27FC236}">
-                <a16:creationId xmlns:a16="http://schemas.microsoft.com/office/drawing/2014/main" id="{8555EA3B-9E88-BD2C-0661-8EA45F45C29A}"/>
+                <a16:creationId xmlns:a16="http://schemas.microsoft.com/office/drawing/2014/main" id="{12F8A889-A2E5-3D4A-5122-43E91D0C2842}"/>
               </a:ext>
             </a:extLst>
           </p:cNvPr>
@@ -13566,8 +13566,8 @@
         </p:nvSpPr>
         <p:spPr>
           <a:xfrm>
-            <a:off x="11201400" y="6451600"/>
-            <a:ext cx="381000" cy="203200"/>
+            <a:off x="11150600" y="6388099"/>
+            <a:ext cx="431800" cy="279400"/>
           </a:xfrm>
           <a:prstGeom prst="rect">
             <a:avLst/>
@@ -13582,7 +13582,7 @@
           <a:p>
             <a:pPr algn="r"/>
             <a:r>
-              <a:rPr lang="en-US" sz="1000">
+              <a:rPr lang="en-US" sz="1600">
                 <a:solidFill>
                   <a:srgbClr val="83939D"/>
                 </a:solidFill>
@@ -13598,7 +13598,7 @@
           <p:cNvPr id="5" name="TextBox 4">
             <a:extLst>
               <a:ext uri="{FF2B5EF4-FFF2-40B4-BE49-F238E27FC236}">
-                <a16:creationId xmlns:a16="http://schemas.microsoft.com/office/drawing/2014/main" id="{FBC82554-DCFF-CDC7-CF96-96494ED8308D}"/>
+                <a16:creationId xmlns:a16="http://schemas.microsoft.com/office/drawing/2014/main" id="{632F9187-5F52-27EB-442E-857667CB6062}"/>
               </a:ext>
             </a:extLst>
           </p:cNvPr>
@@ -13607,8 +13607,8 @@
         </p:nvSpPr>
         <p:spPr>
           <a:xfrm>
-            <a:off x="609600" y="6438900"/>
-            <a:ext cx="3556000" cy="203200"/>
+            <a:off x="609600" y="6388099"/>
+            <a:ext cx="4064000" cy="279400"/>
           </a:xfrm>
           <a:prstGeom prst="rect">
             <a:avLst/>
@@ -13622,7 +13622,7 @@
           <a:lstStyle/>
           <a:p>
             <a:r>
-              <a:rPr lang="en-US" sz="900">
+              <a:rPr lang="en-US" sz="1600">
                 <a:solidFill>
                   <a:srgbClr val="83939D"/>
                 </a:solidFill>
@@ -13638,7 +13638,7 @@
           <p:cNvPr id="6" name="TextBox 5">
             <a:extLst>
               <a:ext uri="{FF2B5EF4-FFF2-40B4-BE49-F238E27FC236}">
-                <a16:creationId xmlns:a16="http://schemas.microsoft.com/office/drawing/2014/main" id="{A65E26E0-2B2F-07CF-7F7E-6D2A6E3C96DC}"/>
+                <a16:creationId xmlns:a16="http://schemas.microsoft.com/office/drawing/2014/main" id="{475504C4-86E3-AAA9-AF6D-F682658300B3}"/>
               </a:ext>
             </a:extLst>
           </p:cNvPr>
@@ -13678,7 +13678,7 @@
           <p:cNvPr id="7" name="TextBox 6">
             <a:extLst>
               <a:ext uri="{FF2B5EF4-FFF2-40B4-BE49-F238E27FC236}">
-                <a16:creationId xmlns:a16="http://schemas.microsoft.com/office/drawing/2014/main" id="{EFEAB5AF-1135-8C7C-891D-4D0AAB9FF704}"/>
+                <a16:creationId xmlns:a16="http://schemas.microsoft.com/office/drawing/2014/main" id="{0C5CE754-42C9-DBC9-995F-D213EAB864D8}"/>
               </a:ext>
             </a:extLst>
           </p:cNvPr>
@@ -13718,7 +13718,7 @@
           <p:cNvPr id="8" name="Rectangle 7">
             <a:extLst>
               <a:ext uri="{FF2B5EF4-FFF2-40B4-BE49-F238E27FC236}">
-                <a16:creationId xmlns:a16="http://schemas.microsoft.com/office/drawing/2014/main" id="{692BE702-E448-BFAA-DFB3-B9C269F0C956}"/>
+                <a16:creationId xmlns:a16="http://schemas.microsoft.com/office/drawing/2014/main" id="{3BE54C82-A027-9496-81CF-53A8359CD928}"/>
               </a:ext>
             </a:extLst>
           </p:cNvPr>
@@ -13786,7 +13786,7 @@
           <p:cNvPr id="9" name="Rectangle 8">
             <a:extLst>
               <a:ext uri="{FF2B5EF4-FFF2-40B4-BE49-F238E27FC236}">
-                <a16:creationId xmlns:a16="http://schemas.microsoft.com/office/drawing/2014/main" id="{7B4CB6F3-3308-AB5A-657B-9F8D609C5DD7}"/>
+                <a16:creationId xmlns:a16="http://schemas.microsoft.com/office/drawing/2014/main" id="{1389CF46-9CBC-0DCA-8697-6062AD18E218}"/>
               </a:ext>
             </a:extLst>
           </p:cNvPr>
@@ -13854,7 +13854,7 @@
           <p:cNvPr id="10" name="Rectangle 9">
             <a:extLst>
               <a:ext uri="{FF2B5EF4-FFF2-40B4-BE49-F238E27FC236}">
-                <a16:creationId xmlns:a16="http://schemas.microsoft.com/office/drawing/2014/main" id="{9EA9790D-7723-239C-C000-A2875FC32936}"/>
+                <a16:creationId xmlns:a16="http://schemas.microsoft.com/office/drawing/2014/main" id="{6D9C429C-AB62-AA88-E1FB-99191D1A0117}"/>
               </a:ext>
             </a:extLst>
           </p:cNvPr>
@@ -13922,7 +13922,7 @@
           <p:cNvPr id="11" name="Rectangle 10">
             <a:extLst>
               <a:ext uri="{FF2B5EF4-FFF2-40B4-BE49-F238E27FC236}">
-                <a16:creationId xmlns:a16="http://schemas.microsoft.com/office/drawing/2014/main" id="{75AEC0D8-5E5F-6EDA-360E-40EA1353FAE8}"/>
+                <a16:creationId xmlns:a16="http://schemas.microsoft.com/office/drawing/2014/main" id="{C480E67E-FBEC-89FE-7C35-EAE8D6C4D903}"/>
               </a:ext>
             </a:extLst>
           </p:cNvPr>
@@ -13990,7 +13990,7 @@
           <p:cNvPr id="12" name="TextBox 11">
             <a:extLst>
               <a:ext uri="{FF2B5EF4-FFF2-40B4-BE49-F238E27FC236}">
-                <a16:creationId xmlns:a16="http://schemas.microsoft.com/office/drawing/2014/main" id="{E3BBB5E2-9B3C-AC68-4038-E58B1B66AB57}"/>
+                <a16:creationId xmlns:a16="http://schemas.microsoft.com/office/drawing/2014/main" id="{3CEF35EC-0703-78DE-48B5-EA5F89B136E4}"/>
               </a:ext>
             </a:extLst>
           </p:cNvPr>
@@ -13999,8 +13999,8 @@
         </p:nvSpPr>
         <p:spPr>
           <a:xfrm>
-            <a:off x="10033000" y="1917700"/>
-            <a:ext cx="1333500" cy="254000"/>
+            <a:off x="9906000" y="1904999"/>
+            <a:ext cx="1524000" cy="279400"/>
           </a:xfrm>
           <a:prstGeom prst="rect">
             <a:avLst/>
@@ -14014,7 +14014,7 @@
           <a:lstStyle/>
           <a:p>
             <a:r>
-              <a:rPr lang="en-US" sz="1400">
+              <a:rPr lang="en-US" sz="1600">
                 <a:solidFill>
                   <a:srgbClr val="83939D"/>
                 </a:solidFill>
@@ -14030,7 +14030,7 @@
           <p:cNvPr id="13" name="TextBox 12">
             <a:extLst>
               <a:ext uri="{FF2B5EF4-FFF2-40B4-BE49-F238E27FC236}">
-                <a16:creationId xmlns:a16="http://schemas.microsoft.com/office/drawing/2014/main" id="{F243B871-CC8F-DF72-C24E-7C89B15CEAE0}"/>
+                <a16:creationId xmlns:a16="http://schemas.microsoft.com/office/drawing/2014/main" id="{3F7DE906-7948-3570-2CCE-484E4BB92252}"/>
               </a:ext>
             </a:extLst>
           </p:cNvPr>
@@ -14039,8 +14039,8 @@
         </p:nvSpPr>
         <p:spPr>
           <a:xfrm>
-            <a:off x="10033000" y="2184400"/>
-            <a:ext cx="1333500" cy="254000"/>
+            <a:off x="9906000" y="2171699"/>
+            <a:ext cx="1524000" cy="279400"/>
           </a:xfrm>
           <a:prstGeom prst="rect">
             <a:avLst/>
@@ -14054,7 +14054,7 @@
           <a:lstStyle/>
           <a:p>
             <a:r>
-              <a:rPr lang="en-US" sz="1400" b="1">
+              <a:rPr lang="en-US" sz="1600" b="1">
                 <a:solidFill>
                   <a:srgbClr val="F3F0E8"/>
                 </a:solidFill>
@@ -14070,7 +14070,7 @@
           <p:cNvPr id="14" name="TextBox 13">
             <a:extLst>
               <a:ext uri="{FF2B5EF4-FFF2-40B4-BE49-F238E27FC236}">
-                <a16:creationId xmlns:a16="http://schemas.microsoft.com/office/drawing/2014/main" id="{FF256A1B-F8BF-8FA8-3601-240C9A73B813}"/>
+                <a16:creationId xmlns:a16="http://schemas.microsoft.com/office/drawing/2014/main" id="{6A47D4AD-7C49-6D72-38F1-71EF616CDE87}"/>
               </a:ext>
             </a:extLst>
           </p:cNvPr>
@@ -14110,7 +14110,7 @@
           <p:cNvPr id="15" name="Rectangle 14">
             <a:extLst>
               <a:ext uri="{FF2B5EF4-FFF2-40B4-BE49-F238E27FC236}">
-                <a16:creationId xmlns:a16="http://schemas.microsoft.com/office/drawing/2014/main" id="{87AA13BA-1D4F-C808-DBD3-BB598DE08CDE}"/>
+                <a16:creationId xmlns:a16="http://schemas.microsoft.com/office/drawing/2014/main" id="{C67F0B82-4D4B-2968-77EA-F908EDA7A9FF}"/>
               </a:ext>
             </a:extLst>
           </p:cNvPr>
@@ -14178,7 +14178,7 @@
           <p:cNvPr id="16" name="Rectangle 15">
             <a:extLst>
               <a:ext uri="{FF2B5EF4-FFF2-40B4-BE49-F238E27FC236}">
-                <a16:creationId xmlns:a16="http://schemas.microsoft.com/office/drawing/2014/main" id="{E1E547D7-E260-4561-9FEC-352F40BEA209}"/>
+                <a16:creationId xmlns:a16="http://schemas.microsoft.com/office/drawing/2014/main" id="{17D856B9-D0BF-2030-4337-A5383B175E3A}"/>
               </a:ext>
             </a:extLst>
           </p:cNvPr>
@@ -14246,7 +14246,7 @@
           <p:cNvPr id="17" name="Rectangle 16">
             <a:extLst>
               <a:ext uri="{FF2B5EF4-FFF2-40B4-BE49-F238E27FC236}">
-                <a16:creationId xmlns:a16="http://schemas.microsoft.com/office/drawing/2014/main" id="{C62A82AC-3C6F-1162-58F6-4220596CB02A}"/>
+                <a16:creationId xmlns:a16="http://schemas.microsoft.com/office/drawing/2014/main" id="{57C2E57B-85F2-CFF0-8247-C67D694CDEF8}"/>
               </a:ext>
             </a:extLst>
           </p:cNvPr>
@@ -14314,7 +14314,7 @@
           <p:cNvPr id="18" name="Rectangle 17">
             <a:extLst>
               <a:ext uri="{FF2B5EF4-FFF2-40B4-BE49-F238E27FC236}">
-                <a16:creationId xmlns:a16="http://schemas.microsoft.com/office/drawing/2014/main" id="{303C3F7D-9766-CDAD-5EE5-621B050F7C83}"/>
+                <a16:creationId xmlns:a16="http://schemas.microsoft.com/office/drawing/2014/main" id="{C40F1554-6FD6-B7E1-35CE-42D2B0BE711E}"/>
               </a:ext>
             </a:extLst>
           </p:cNvPr>
@@ -14382,7 +14382,7 @@
           <p:cNvPr id="19" name="TextBox 18">
             <a:extLst>
               <a:ext uri="{FF2B5EF4-FFF2-40B4-BE49-F238E27FC236}">
-                <a16:creationId xmlns:a16="http://schemas.microsoft.com/office/drawing/2014/main" id="{C3A069A8-C8CC-171D-9689-F4F387006F09}"/>
+                <a16:creationId xmlns:a16="http://schemas.microsoft.com/office/drawing/2014/main" id="{14927D62-F43D-8A7A-0A4E-C2EEDBC369DD}"/>
               </a:ext>
             </a:extLst>
           </p:cNvPr>
@@ -14391,8 +14391,8 @@
         </p:nvSpPr>
         <p:spPr>
           <a:xfrm>
-            <a:off x="10033000" y="3048000"/>
-            <a:ext cx="1333500" cy="254000"/>
+            <a:off x="9906000" y="3035299"/>
+            <a:ext cx="1524000" cy="279400"/>
           </a:xfrm>
           <a:prstGeom prst="rect">
             <a:avLst/>
@@ -14406,7 +14406,7 @@
           <a:lstStyle/>
           <a:p>
             <a:r>
-              <a:rPr lang="en-US" sz="1400">
+              <a:rPr lang="en-US" sz="1600">
                 <a:solidFill>
                   <a:srgbClr val="83939D"/>
                 </a:solidFill>
@@ -14422,7 +14422,7 @@
           <p:cNvPr id="20" name="TextBox 19">
             <a:extLst>
               <a:ext uri="{FF2B5EF4-FFF2-40B4-BE49-F238E27FC236}">
-                <a16:creationId xmlns:a16="http://schemas.microsoft.com/office/drawing/2014/main" id="{46665BBE-2F14-077C-6FEE-A5B6B704122A}"/>
+                <a16:creationId xmlns:a16="http://schemas.microsoft.com/office/drawing/2014/main" id="{F60EF05A-D363-A2B7-E3D3-4F976BBAB455}"/>
               </a:ext>
             </a:extLst>
           </p:cNvPr>
@@ -14431,8 +14431,8 @@
         </p:nvSpPr>
         <p:spPr>
           <a:xfrm>
-            <a:off x="10033000" y="3314700"/>
-            <a:ext cx="1333500" cy="254000"/>
+            <a:off x="9906000" y="3301999"/>
+            <a:ext cx="1524000" cy="279400"/>
           </a:xfrm>
           <a:prstGeom prst="rect">
             <a:avLst/>
@@ -14446,7 +14446,7 @@
           <a:lstStyle/>
           <a:p>
             <a:r>
-              <a:rPr lang="en-US" sz="1400" b="1">
+              <a:rPr lang="en-US" sz="1600" b="1">
                 <a:solidFill>
                   <a:srgbClr val="F3F0E8"/>
                 </a:solidFill>
@@ -14462,7 +14462,7 @@
           <p:cNvPr id="21" name="TextBox 20">
             <a:extLst>
               <a:ext uri="{FF2B5EF4-FFF2-40B4-BE49-F238E27FC236}">
-                <a16:creationId xmlns:a16="http://schemas.microsoft.com/office/drawing/2014/main" id="{26FD1026-F149-3D17-8859-D16F27A56942}"/>
+                <a16:creationId xmlns:a16="http://schemas.microsoft.com/office/drawing/2014/main" id="{EA9A8AB0-60E8-C3D8-2E45-E6CD734E215A}"/>
               </a:ext>
             </a:extLst>
           </p:cNvPr>
@@ -14502,7 +14502,7 @@
           <p:cNvPr id="22" name="Rectangle 21">
             <a:extLst>
               <a:ext uri="{FF2B5EF4-FFF2-40B4-BE49-F238E27FC236}">
-                <a16:creationId xmlns:a16="http://schemas.microsoft.com/office/drawing/2014/main" id="{97320191-3683-01E9-7C9D-E2DA1A7C3370}"/>
+                <a16:creationId xmlns:a16="http://schemas.microsoft.com/office/drawing/2014/main" id="{375DE172-A2A1-BB0D-43CB-050ACAF73287}"/>
               </a:ext>
             </a:extLst>
           </p:cNvPr>
@@ -14570,7 +14570,7 @@
           <p:cNvPr id="23" name="Rectangle 22">
             <a:extLst>
               <a:ext uri="{FF2B5EF4-FFF2-40B4-BE49-F238E27FC236}">
-                <a16:creationId xmlns:a16="http://schemas.microsoft.com/office/drawing/2014/main" id="{DCE5B90B-E1A0-8A4C-F1D0-364AC76BAD7E}"/>
+                <a16:creationId xmlns:a16="http://schemas.microsoft.com/office/drawing/2014/main" id="{446E3B54-056C-BF19-B238-00B794A260BB}"/>
               </a:ext>
             </a:extLst>
           </p:cNvPr>
@@ -14638,7 +14638,7 @@
           <p:cNvPr id="24" name="Rectangle 23">
             <a:extLst>
               <a:ext uri="{FF2B5EF4-FFF2-40B4-BE49-F238E27FC236}">
-                <a16:creationId xmlns:a16="http://schemas.microsoft.com/office/drawing/2014/main" id="{D529E306-DE85-3087-189A-D01154A0DECD}"/>
+                <a16:creationId xmlns:a16="http://schemas.microsoft.com/office/drawing/2014/main" id="{13E96AC2-EE18-C592-5D15-0EC9CC212A43}"/>
               </a:ext>
             </a:extLst>
           </p:cNvPr>
@@ -14706,7 +14706,7 @@
           <p:cNvPr id="25" name="Rectangle 24">
             <a:extLst>
               <a:ext uri="{FF2B5EF4-FFF2-40B4-BE49-F238E27FC236}">
-                <a16:creationId xmlns:a16="http://schemas.microsoft.com/office/drawing/2014/main" id="{4EFEAC2D-DCD1-C71E-37F3-CB837ADD3C09}"/>
+                <a16:creationId xmlns:a16="http://schemas.microsoft.com/office/drawing/2014/main" id="{E580767A-D276-C988-223F-A23C9D343920}"/>
               </a:ext>
             </a:extLst>
           </p:cNvPr>
@@ -14774,7 +14774,7 @@
           <p:cNvPr id="26" name="TextBox 25">
             <a:extLst>
               <a:ext uri="{FF2B5EF4-FFF2-40B4-BE49-F238E27FC236}">
-                <a16:creationId xmlns:a16="http://schemas.microsoft.com/office/drawing/2014/main" id="{3121F3EA-7B58-B247-C188-4184A2F8153D}"/>
+                <a16:creationId xmlns:a16="http://schemas.microsoft.com/office/drawing/2014/main" id="{2522251F-7725-CA74-701A-84447C77820D}"/>
               </a:ext>
             </a:extLst>
           </p:cNvPr>
@@ -14783,8 +14783,8 @@
         </p:nvSpPr>
         <p:spPr>
           <a:xfrm>
-            <a:off x="10033000" y="4178300"/>
-            <a:ext cx="1333500" cy="254000"/>
+            <a:off x="9906000" y="4165599"/>
+            <a:ext cx="1524000" cy="279400"/>
           </a:xfrm>
           <a:prstGeom prst="rect">
             <a:avLst/>
@@ -14798,7 +14798,7 @@
           <a:lstStyle/>
           <a:p>
             <a:r>
-              <a:rPr lang="en-US" sz="1400">
+              <a:rPr lang="en-US" sz="1600">
                 <a:solidFill>
                   <a:srgbClr val="83939D"/>
                 </a:solidFill>
@@ -14814,7 +14814,7 @@
           <p:cNvPr id="27" name="TextBox 26">
             <a:extLst>
               <a:ext uri="{FF2B5EF4-FFF2-40B4-BE49-F238E27FC236}">
-                <a16:creationId xmlns:a16="http://schemas.microsoft.com/office/drawing/2014/main" id="{E6750B6E-BE3A-5528-0B40-ED9B606742D1}"/>
+                <a16:creationId xmlns:a16="http://schemas.microsoft.com/office/drawing/2014/main" id="{7DA64C30-8557-8F50-FBA4-8723C0811EDC}"/>
               </a:ext>
             </a:extLst>
           </p:cNvPr>
@@ -14823,8 +14823,8 @@
         </p:nvSpPr>
         <p:spPr>
           <a:xfrm>
-            <a:off x="10033000" y="4445000"/>
-            <a:ext cx="1333500" cy="254000"/>
+            <a:off x="9906000" y="4432299"/>
+            <a:ext cx="1524000" cy="279400"/>
           </a:xfrm>
           <a:prstGeom prst="rect">
             <a:avLst/>
@@ -14838,7 +14838,7 @@
           <a:lstStyle/>
           <a:p>
             <a:r>
-              <a:rPr lang="en-US" sz="1400" b="1">
+              <a:rPr lang="en-US" sz="1600" b="1">
                 <a:solidFill>
                   <a:srgbClr val="F3F0E8"/>
                 </a:solidFill>
@@ -14854,7 +14854,7 @@
           <p:cNvPr id="28" name="TextBox 27">
             <a:extLst>
               <a:ext uri="{FF2B5EF4-FFF2-40B4-BE49-F238E27FC236}">
-                <a16:creationId xmlns:a16="http://schemas.microsoft.com/office/drawing/2014/main" id="{2FD192D6-6482-BC18-FC66-68153074C92C}"/>
+                <a16:creationId xmlns:a16="http://schemas.microsoft.com/office/drawing/2014/main" id="{DBC3AD8A-F542-A5DC-232C-DC9E591BA494}"/>
               </a:ext>
             </a:extLst>
           </p:cNvPr>
@@ -14894,7 +14894,7 @@
           <p:cNvPr id="29" name="TextBox 28">
             <a:extLst>
               <a:ext uri="{FF2B5EF4-FFF2-40B4-BE49-F238E27FC236}">
-                <a16:creationId xmlns:a16="http://schemas.microsoft.com/office/drawing/2014/main" id="{1AAE4602-B61D-87F6-F5BE-2214E0DF646A}"/>
+                <a16:creationId xmlns:a16="http://schemas.microsoft.com/office/drawing/2014/main" id="{77D2CA97-DFCD-617F-F745-526D61AD7889}"/>
               </a:ext>
             </a:extLst>
           </p:cNvPr>
@@ -14934,7 +14934,7 @@
           <p:cNvPr id="30" name="TextBox 29">
             <a:extLst>
               <a:ext uri="{FF2B5EF4-FFF2-40B4-BE49-F238E27FC236}">
-                <a16:creationId xmlns:a16="http://schemas.microsoft.com/office/drawing/2014/main" id="{70C1CD1F-3404-2B45-8CC1-DD8FF02070EF}"/>
+                <a16:creationId xmlns:a16="http://schemas.microsoft.com/office/drawing/2014/main" id="{5A6E3183-4435-4F00-1C0D-A8CD621973CC}"/>
               </a:ext>
             </a:extLst>
           </p:cNvPr>
@@ -14972,7 +14972,7 @@
     </p:spTree>
     <p:extLst>
       <p:ext uri="{BB962C8B-B14F-4D97-AF65-F5344CB8AC3E}">
-        <p14:creationId xmlns:p14="http://schemas.microsoft.com/office/powerpoint/2010/main" val="3879634143"/>
+        <p14:creationId xmlns:p14="http://schemas.microsoft.com/office/powerpoint/2010/main" val="281743511"/>
       </p:ext>
     </p:extLst>
   </p:cSld>
@@ -15012,7 +15012,7 @@
           <p:cNvPr id="2" name="TextBox 1">
             <a:extLst>
               <a:ext uri="{FF2B5EF4-FFF2-40B4-BE49-F238E27FC236}">
-                <a16:creationId xmlns:a16="http://schemas.microsoft.com/office/drawing/2014/main" id="{E7CCE1E9-4C0B-22BA-999F-1802DAD6EC6C}"/>
+                <a16:creationId xmlns:a16="http://schemas.microsoft.com/office/drawing/2014/main" id="{61667713-0B6F-404F-C73D-1BB40F15DA3B}"/>
               </a:ext>
             </a:extLst>
           </p:cNvPr>
@@ -15021,8 +15021,8 @@
         </p:nvSpPr>
         <p:spPr>
           <a:xfrm>
-            <a:off x="609600" y="254000"/>
-            <a:ext cx="3429000" cy="228600"/>
+            <a:off x="609600" y="228599"/>
+            <a:ext cx="3810000" cy="279400"/>
           </a:xfrm>
           <a:prstGeom prst="rect">
             <a:avLst/>
@@ -15036,7 +15036,7 @@
           <a:lstStyle/>
           <a:p>
             <a:r>
-              <a:rPr lang="en-US" sz="1100" b="1">
+              <a:rPr lang="en-US" sz="1600" b="1">
                 <a:solidFill>
                   <a:srgbClr val="60727D"/>
                 </a:solidFill>
@@ -15052,7 +15052,7 @@
           <p:cNvPr id="3" name="Straight Connector 2">
             <a:extLst>
               <a:ext uri="{FF2B5EF4-FFF2-40B4-BE49-F238E27FC236}">
-                <a16:creationId xmlns:a16="http://schemas.microsoft.com/office/drawing/2014/main" id="{2079392D-EE1C-0BF3-000B-14269E205C02}"/>
+                <a16:creationId xmlns:a16="http://schemas.microsoft.com/office/drawing/2014/main" id="{EFBB37E5-14C1-5F8A-4F61-FB16C2D52833}"/>
               </a:ext>
             </a:extLst>
           </p:cNvPr>
@@ -15093,7 +15093,7 @@
           <p:cNvPr id="4" name="TextBox 3">
             <a:extLst>
               <a:ext uri="{FF2B5EF4-FFF2-40B4-BE49-F238E27FC236}">
-                <a16:creationId xmlns:a16="http://schemas.microsoft.com/office/drawing/2014/main" id="{81CD2083-584D-6833-37A5-F5751070DD04}"/>
+                <a16:creationId xmlns:a16="http://schemas.microsoft.com/office/drawing/2014/main" id="{EDDC93F2-9614-0E2F-F26E-20374ECF548D}"/>
               </a:ext>
             </a:extLst>
           </p:cNvPr>
@@ -15102,8 +15102,8 @@
         </p:nvSpPr>
         <p:spPr>
           <a:xfrm>
-            <a:off x="11201400" y="6451600"/>
-            <a:ext cx="381000" cy="203200"/>
+            <a:off x="11150600" y="6388099"/>
+            <a:ext cx="431800" cy="279400"/>
           </a:xfrm>
           <a:prstGeom prst="rect">
             <a:avLst/>
@@ -15118,7 +15118,7 @@
           <a:p>
             <a:pPr algn="r"/>
             <a:r>
-              <a:rPr lang="en-US" sz="1000">
+              <a:rPr lang="en-US" sz="1600">
                 <a:solidFill>
                   <a:srgbClr val="60727D"/>
                 </a:solidFill>
@@ -15134,7 +15134,7 @@
           <p:cNvPr id="5" name="TextBox 4">
             <a:extLst>
               <a:ext uri="{FF2B5EF4-FFF2-40B4-BE49-F238E27FC236}">
-                <a16:creationId xmlns:a16="http://schemas.microsoft.com/office/drawing/2014/main" id="{455F3292-0179-019A-AD5D-4B2E4F16B6D8}"/>
+                <a16:creationId xmlns:a16="http://schemas.microsoft.com/office/drawing/2014/main" id="{04226E2A-B3AC-6E0E-42E0-E50894C3EB2C}"/>
               </a:ext>
             </a:extLst>
           </p:cNvPr>
@@ -15143,8 +15143,8 @@
         </p:nvSpPr>
         <p:spPr>
           <a:xfrm>
-            <a:off x="609600" y="6438900"/>
-            <a:ext cx="3556000" cy="203200"/>
+            <a:off x="609600" y="6388099"/>
+            <a:ext cx="4064000" cy="279400"/>
           </a:xfrm>
           <a:prstGeom prst="rect">
             <a:avLst/>
@@ -15158,7 +15158,7 @@
           <a:lstStyle/>
           <a:p>
             <a:r>
-              <a:rPr lang="en-US" sz="900">
+              <a:rPr lang="en-US" sz="1600">
                 <a:solidFill>
                   <a:srgbClr val="60727D"/>
                 </a:solidFill>
@@ -15174,7 +15174,7 @@
           <p:cNvPr id="6" name="TextBox 5">
             <a:extLst>
               <a:ext uri="{FF2B5EF4-FFF2-40B4-BE49-F238E27FC236}">
-                <a16:creationId xmlns:a16="http://schemas.microsoft.com/office/drawing/2014/main" id="{9D040476-B2C8-647A-1C15-31668F7265C5}"/>
+                <a16:creationId xmlns:a16="http://schemas.microsoft.com/office/drawing/2014/main" id="{3C8B514A-FA2E-EC03-F88C-2093E2D226EF}"/>
               </a:ext>
             </a:extLst>
           </p:cNvPr>
@@ -15214,7 +15214,7 @@
           <p:cNvPr id="7" name="TextBox 6">
             <a:extLst>
               <a:ext uri="{FF2B5EF4-FFF2-40B4-BE49-F238E27FC236}">
-                <a16:creationId xmlns:a16="http://schemas.microsoft.com/office/drawing/2014/main" id="{4BEF28F6-D3DA-7335-59DF-C0CEF1F4FD03}"/>
+                <a16:creationId xmlns:a16="http://schemas.microsoft.com/office/drawing/2014/main" id="{686B9589-869F-E80C-D0FD-F700C61236E6}"/>
               </a:ext>
             </a:extLst>
           </p:cNvPr>
@@ -15254,7 +15254,7 @@
           <p:cNvPr id="8" name="TextBox 7">
             <a:extLst>
               <a:ext uri="{FF2B5EF4-FFF2-40B4-BE49-F238E27FC236}">
-                <a16:creationId xmlns:a16="http://schemas.microsoft.com/office/drawing/2014/main" id="{49FC0DC0-F79D-83AE-D2E4-B7A6B309223E}"/>
+                <a16:creationId xmlns:a16="http://schemas.microsoft.com/office/drawing/2014/main" id="{6279FB3C-AE52-F11B-A937-12938F606315}"/>
               </a:ext>
             </a:extLst>
           </p:cNvPr>
@@ -15294,7 +15294,7 @@
           <p:cNvPr id="9" name="TextBox 8">
             <a:extLst>
               <a:ext uri="{FF2B5EF4-FFF2-40B4-BE49-F238E27FC236}">
-                <a16:creationId xmlns:a16="http://schemas.microsoft.com/office/drawing/2014/main" id="{EDB55632-6EB7-6588-0C4B-5E9B3627F16E}"/>
+                <a16:creationId xmlns:a16="http://schemas.microsoft.com/office/drawing/2014/main" id="{F605B919-B17B-616E-5567-A31ADF52F85A}"/>
               </a:ext>
             </a:extLst>
           </p:cNvPr>
@@ -15334,7 +15334,7 @@
           <p:cNvPr id="10" name="Rectangle 9">
             <a:extLst>
               <a:ext uri="{FF2B5EF4-FFF2-40B4-BE49-F238E27FC236}">
-                <a16:creationId xmlns:a16="http://schemas.microsoft.com/office/drawing/2014/main" id="{9CCA18CD-1776-AF14-F98A-96CDDD79AEC3}"/>
+                <a16:creationId xmlns:a16="http://schemas.microsoft.com/office/drawing/2014/main" id="{013DFE7C-9CFC-D556-7098-474CEE381B1B}"/>
               </a:ext>
             </a:extLst>
           </p:cNvPr>
@@ -15402,7 +15402,7 @@
           <p:cNvPr id="11" name="TextBox 10">
             <a:extLst>
               <a:ext uri="{FF2B5EF4-FFF2-40B4-BE49-F238E27FC236}">
-                <a16:creationId xmlns:a16="http://schemas.microsoft.com/office/drawing/2014/main" id="{AB3B8791-DFAE-B49A-F7D8-C63E8F0FE68A}"/>
+                <a16:creationId xmlns:a16="http://schemas.microsoft.com/office/drawing/2014/main" id="{1344DBEA-A75B-59CA-691E-1A2A776A364F}"/>
               </a:ext>
             </a:extLst>
           </p:cNvPr>
@@ -15442,7 +15442,7 @@
           <p:cNvPr id="12" name="TextBox 11">
             <a:extLst>
               <a:ext uri="{FF2B5EF4-FFF2-40B4-BE49-F238E27FC236}">
-                <a16:creationId xmlns:a16="http://schemas.microsoft.com/office/drawing/2014/main" id="{0F9F2AA2-7C3A-0596-8A55-9C3B289DA4F8}"/>
+                <a16:creationId xmlns:a16="http://schemas.microsoft.com/office/drawing/2014/main" id="{C2416C25-17C0-5E57-5666-2FA6FAA26775}"/>
               </a:ext>
             </a:extLst>
           </p:cNvPr>
@@ -15482,7 +15482,7 @@
           <p:cNvPr id="13" name="TextBox 12">
             <a:extLst>
               <a:ext uri="{FF2B5EF4-FFF2-40B4-BE49-F238E27FC236}">
-                <a16:creationId xmlns:a16="http://schemas.microsoft.com/office/drawing/2014/main" id="{71C0BC11-3979-40F2-8431-4557C4100FB1}"/>
+                <a16:creationId xmlns:a16="http://schemas.microsoft.com/office/drawing/2014/main" id="{8ED40CC8-588B-3BA7-B56E-C83EDAECA5E5}"/>
               </a:ext>
             </a:extLst>
           </p:cNvPr>
@@ -15522,7 +15522,7 @@
           <p:cNvPr id="14" name="TextBox 13">
             <a:extLst>
               <a:ext uri="{FF2B5EF4-FFF2-40B4-BE49-F238E27FC236}">
-                <a16:creationId xmlns:a16="http://schemas.microsoft.com/office/drawing/2014/main" id="{F4AC4EB7-AE15-6948-E57D-FE5EA2EC8479}"/>
+                <a16:creationId xmlns:a16="http://schemas.microsoft.com/office/drawing/2014/main" id="{3DAF4A74-6D58-E9E6-289C-82BDE8E36077}"/>
               </a:ext>
             </a:extLst>
           </p:cNvPr>
@@ -15562,7 +15562,7 @@
           <p:cNvPr id="15" name="TextBox 14">
             <a:extLst>
               <a:ext uri="{FF2B5EF4-FFF2-40B4-BE49-F238E27FC236}">
-                <a16:creationId xmlns:a16="http://schemas.microsoft.com/office/drawing/2014/main" id="{7BEF28D6-1864-8565-9AB5-C9FFCD580572}"/>
+                <a16:creationId xmlns:a16="http://schemas.microsoft.com/office/drawing/2014/main" id="{9AC4F3E4-31D3-60E1-5F26-DAD27DE90267}"/>
               </a:ext>
             </a:extLst>
           </p:cNvPr>
@@ -15602,7 +15602,7 @@
           <p:cNvPr id="16" name="TextBox 15">
             <a:extLst>
               <a:ext uri="{FF2B5EF4-FFF2-40B4-BE49-F238E27FC236}">
-                <a16:creationId xmlns:a16="http://schemas.microsoft.com/office/drawing/2014/main" id="{15EB0F5A-D351-72B8-524C-DC3B80A86C96}"/>
+                <a16:creationId xmlns:a16="http://schemas.microsoft.com/office/drawing/2014/main" id="{B3CF8649-49F2-2B8A-F43A-72DB8F091DA7}"/>
               </a:ext>
             </a:extLst>
           </p:cNvPr>
@@ -15642,7 +15642,7 @@
           <p:cNvPr id="17" name="Rectangle 16">
             <a:extLst>
               <a:ext uri="{FF2B5EF4-FFF2-40B4-BE49-F238E27FC236}">
-                <a16:creationId xmlns:a16="http://schemas.microsoft.com/office/drawing/2014/main" id="{833E69CF-5215-CDDE-9AE5-E97ACB5EB0BC}"/>
+                <a16:creationId xmlns:a16="http://schemas.microsoft.com/office/drawing/2014/main" id="{F52DB557-2AA1-5EED-33B2-F9028167C5B1}"/>
               </a:ext>
             </a:extLst>
           </p:cNvPr>
@@ -15710,7 +15710,7 @@
           <p:cNvPr id="18" name="TextBox 17">
             <a:extLst>
               <a:ext uri="{FF2B5EF4-FFF2-40B4-BE49-F238E27FC236}">
-                <a16:creationId xmlns:a16="http://schemas.microsoft.com/office/drawing/2014/main" id="{3FD76543-C74C-1A3B-59CD-3F00834DB0CD}"/>
+                <a16:creationId xmlns:a16="http://schemas.microsoft.com/office/drawing/2014/main" id="{039C9083-9735-60F1-D89B-688BE4C38A6D}"/>
               </a:ext>
             </a:extLst>
           </p:cNvPr>
@@ -15750,7 +15750,7 @@
           <p:cNvPr id="19" name="TextBox 18">
             <a:extLst>
               <a:ext uri="{FF2B5EF4-FFF2-40B4-BE49-F238E27FC236}">
-                <a16:creationId xmlns:a16="http://schemas.microsoft.com/office/drawing/2014/main" id="{BCC4A0C7-B7AE-4FC7-BD03-5A4B757C6111}"/>
+                <a16:creationId xmlns:a16="http://schemas.microsoft.com/office/drawing/2014/main" id="{C2E70A0F-3589-F721-A231-6D4273D1A102}"/>
               </a:ext>
             </a:extLst>
           </p:cNvPr>
@@ -15790,7 +15790,7 @@
           <p:cNvPr id="20" name="TextBox 19">
             <a:extLst>
               <a:ext uri="{FF2B5EF4-FFF2-40B4-BE49-F238E27FC236}">
-                <a16:creationId xmlns:a16="http://schemas.microsoft.com/office/drawing/2014/main" id="{0172491B-7A14-B6CE-4E03-6A46237B5E85}"/>
+                <a16:creationId xmlns:a16="http://schemas.microsoft.com/office/drawing/2014/main" id="{E377096A-5CB8-542C-5AA8-20B32FCA68B7}"/>
               </a:ext>
             </a:extLst>
           </p:cNvPr>
@@ -15830,7 +15830,7 @@
           <p:cNvPr id="21" name="TextBox 20">
             <a:extLst>
               <a:ext uri="{FF2B5EF4-FFF2-40B4-BE49-F238E27FC236}">
-                <a16:creationId xmlns:a16="http://schemas.microsoft.com/office/drawing/2014/main" id="{281E64CD-D797-E999-115F-60D82B83935E}"/>
+                <a16:creationId xmlns:a16="http://schemas.microsoft.com/office/drawing/2014/main" id="{D7EF94CE-B439-60D9-A0D2-B068B83D5782}"/>
               </a:ext>
             </a:extLst>
           </p:cNvPr>
@@ -15870,7 +15870,7 @@
           <p:cNvPr id="22" name="TextBox 21">
             <a:extLst>
               <a:ext uri="{FF2B5EF4-FFF2-40B4-BE49-F238E27FC236}">
-                <a16:creationId xmlns:a16="http://schemas.microsoft.com/office/drawing/2014/main" id="{89EB281D-C520-E292-A990-C056C31E00A4}"/>
+                <a16:creationId xmlns:a16="http://schemas.microsoft.com/office/drawing/2014/main" id="{93BC23B7-E43D-1071-D01A-925A465F7DCE}"/>
               </a:ext>
             </a:extLst>
           </p:cNvPr>
@@ -15910,7 +15910,7 @@
           <p:cNvPr id="23" name="TextBox 22">
             <a:extLst>
               <a:ext uri="{FF2B5EF4-FFF2-40B4-BE49-F238E27FC236}">
-                <a16:creationId xmlns:a16="http://schemas.microsoft.com/office/drawing/2014/main" id="{B9D03BB4-45ED-64DB-B98B-8A609F41A0F5}"/>
+                <a16:creationId xmlns:a16="http://schemas.microsoft.com/office/drawing/2014/main" id="{E91E2223-22DF-4459-E648-8F38C897CB4B}"/>
               </a:ext>
             </a:extLst>
           </p:cNvPr>
@@ -15950,7 +15950,7 @@
           <p:cNvPr id="24" name="Rectangle 23">
             <a:extLst>
               <a:ext uri="{FF2B5EF4-FFF2-40B4-BE49-F238E27FC236}">
-                <a16:creationId xmlns:a16="http://schemas.microsoft.com/office/drawing/2014/main" id="{A015D74A-2381-66F6-6243-9DE714D33EFA}"/>
+                <a16:creationId xmlns:a16="http://schemas.microsoft.com/office/drawing/2014/main" id="{11F7D770-1738-4E9D-3E6E-248AC9DECD77}"/>
               </a:ext>
             </a:extLst>
           </p:cNvPr>
@@ -16018,7 +16018,7 @@
           <p:cNvPr id="25" name="TextBox 24">
             <a:extLst>
               <a:ext uri="{FF2B5EF4-FFF2-40B4-BE49-F238E27FC236}">
-                <a16:creationId xmlns:a16="http://schemas.microsoft.com/office/drawing/2014/main" id="{E14C9B13-E58C-CF3E-55A3-6686234EB2A8}"/>
+                <a16:creationId xmlns:a16="http://schemas.microsoft.com/office/drawing/2014/main" id="{00A0263D-B636-604E-7489-731EA7F57CB7}"/>
               </a:ext>
             </a:extLst>
           </p:cNvPr>
@@ -16058,7 +16058,7 @@
           <p:cNvPr id="26" name="TextBox 25">
             <a:extLst>
               <a:ext uri="{FF2B5EF4-FFF2-40B4-BE49-F238E27FC236}">
-                <a16:creationId xmlns:a16="http://schemas.microsoft.com/office/drawing/2014/main" id="{A3C865D8-DC82-6B3B-F4F5-69E6F5844A76}"/>
+                <a16:creationId xmlns:a16="http://schemas.microsoft.com/office/drawing/2014/main" id="{D4BF488B-C504-082F-646B-D9B041192D16}"/>
               </a:ext>
             </a:extLst>
           </p:cNvPr>
@@ -16098,7 +16098,7 @@
           <p:cNvPr id="27" name="TextBox 26">
             <a:extLst>
               <a:ext uri="{FF2B5EF4-FFF2-40B4-BE49-F238E27FC236}">
-                <a16:creationId xmlns:a16="http://schemas.microsoft.com/office/drawing/2014/main" id="{59861040-1445-91B4-D64E-D07750210CE9}"/>
+                <a16:creationId xmlns:a16="http://schemas.microsoft.com/office/drawing/2014/main" id="{83BD7CF2-FC30-E116-EDE8-A17EE3017E26}"/>
               </a:ext>
             </a:extLst>
           </p:cNvPr>
@@ -16138,7 +16138,7 @@
           <p:cNvPr id="28" name="TextBox 27">
             <a:extLst>
               <a:ext uri="{FF2B5EF4-FFF2-40B4-BE49-F238E27FC236}">
-                <a16:creationId xmlns:a16="http://schemas.microsoft.com/office/drawing/2014/main" id="{0AE4F97D-D933-6B6A-B2AF-36779C063D8E}"/>
+                <a16:creationId xmlns:a16="http://schemas.microsoft.com/office/drawing/2014/main" id="{C4220E00-3297-51E2-7F32-A1EE8196236F}"/>
               </a:ext>
             </a:extLst>
           </p:cNvPr>
@@ -16178,7 +16178,7 @@
           <p:cNvPr id="29" name="TextBox 28">
             <a:extLst>
               <a:ext uri="{FF2B5EF4-FFF2-40B4-BE49-F238E27FC236}">
-                <a16:creationId xmlns:a16="http://schemas.microsoft.com/office/drawing/2014/main" id="{B20A2D0C-9400-34D8-2633-39D385228E9C}"/>
+                <a16:creationId xmlns:a16="http://schemas.microsoft.com/office/drawing/2014/main" id="{2E0C72FC-AF16-21B5-2EE6-E0FEDDE21753}"/>
               </a:ext>
             </a:extLst>
           </p:cNvPr>
@@ -16218,7 +16218,7 @@
           <p:cNvPr id="30" name="TextBox 29">
             <a:extLst>
               <a:ext uri="{FF2B5EF4-FFF2-40B4-BE49-F238E27FC236}">
-                <a16:creationId xmlns:a16="http://schemas.microsoft.com/office/drawing/2014/main" id="{76D92187-74CC-8078-3EB2-62A81B66058C}"/>
+                <a16:creationId xmlns:a16="http://schemas.microsoft.com/office/drawing/2014/main" id="{0FAF950A-79EB-266E-5FF6-C94AF893D195}"/>
               </a:ext>
             </a:extLst>
           </p:cNvPr>
@@ -16258,7 +16258,7 @@
           <p:cNvPr id="31" name="Rectangle 30">
             <a:extLst>
               <a:ext uri="{FF2B5EF4-FFF2-40B4-BE49-F238E27FC236}">
-                <a16:creationId xmlns:a16="http://schemas.microsoft.com/office/drawing/2014/main" id="{2940B6DA-789C-B093-2114-D6E4D6237D63}"/>
+                <a16:creationId xmlns:a16="http://schemas.microsoft.com/office/drawing/2014/main" id="{D43A2CEA-A59B-371F-7799-7A5DCDBAD26A}"/>
               </a:ext>
             </a:extLst>
           </p:cNvPr>
@@ -16326,7 +16326,7 @@
           <p:cNvPr id="32" name="TextBox 31">
             <a:extLst>
               <a:ext uri="{FF2B5EF4-FFF2-40B4-BE49-F238E27FC236}">
-                <a16:creationId xmlns:a16="http://schemas.microsoft.com/office/drawing/2014/main" id="{543EE2F8-5A53-DBDD-3A09-7728396D2221}"/>
+                <a16:creationId xmlns:a16="http://schemas.microsoft.com/office/drawing/2014/main" id="{966DB1F0-E63D-8BE6-9671-CB30892EA50C}"/>
               </a:ext>
             </a:extLst>
           </p:cNvPr>
@@ -16366,7 +16366,7 @@
           <p:cNvPr id="33" name="TextBox 32">
             <a:extLst>
               <a:ext uri="{FF2B5EF4-FFF2-40B4-BE49-F238E27FC236}">
-                <a16:creationId xmlns:a16="http://schemas.microsoft.com/office/drawing/2014/main" id="{C14C2B57-71DB-CE34-3569-9ADB62F1CEE7}"/>
+                <a16:creationId xmlns:a16="http://schemas.microsoft.com/office/drawing/2014/main" id="{30ECDFB9-C02A-C354-EC07-E8C88638AC4F}"/>
               </a:ext>
             </a:extLst>
           </p:cNvPr>
@@ -16406,7 +16406,7 @@
           <p:cNvPr id="34" name="TextBox 33">
             <a:extLst>
               <a:ext uri="{FF2B5EF4-FFF2-40B4-BE49-F238E27FC236}">
-                <a16:creationId xmlns:a16="http://schemas.microsoft.com/office/drawing/2014/main" id="{F7274E5F-6C9B-4877-34DD-399F6AE27631}"/>
+                <a16:creationId xmlns:a16="http://schemas.microsoft.com/office/drawing/2014/main" id="{37CF1F5F-737D-B70F-1612-6836CC897902}"/>
               </a:ext>
             </a:extLst>
           </p:cNvPr>
@@ -16446,7 +16446,7 @@
           <p:cNvPr id="35" name="TextBox 34">
             <a:extLst>
               <a:ext uri="{FF2B5EF4-FFF2-40B4-BE49-F238E27FC236}">
-                <a16:creationId xmlns:a16="http://schemas.microsoft.com/office/drawing/2014/main" id="{0F41F430-BCCD-6EF3-1D19-E7ED22485E62}"/>
+                <a16:creationId xmlns:a16="http://schemas.microsoft.com/office/drawing/2014/main" id="{9B38F767-1101-9475-DEF6-2524CC478339}"/>
               </a:ext>
             </a:extLst>
           </p:cNvPr>
@@ -16455,8 +16455,8 @@
         </p:nvSpPr>
         <p:spPr>
           <a:xfrm>
-            <a:off x="812800" y="6070599"/>
-            <a:ext cx="10414000" cy="279400"/>
+            <a:off x="812800" y="6045199"/>
+            <a:ext cx="10414000" cy="304800"/>
           </a:xfrm>
           <a:prstGeom prst="rect">
             <a:avLst/>
@@ -16470,7 +16470,7 @@
           <a:lstStyle/>
           <a:p>
             <a:r>
-              <a:rPr lang="en-US" sz="1500">
+              <a:rPr lang="en-US" sz="1600">
                 <a:solidFill>
                   <a:srgbClr val="60727D"/>
                 </a:solidFill>
@@ -16484,7 +16484,7 @@
     </p:spTree>
     <p:extLst>
       <p:ext uri="{BB962C8B-B14F-4D97-AF65-F5344CB8AC3E}">
-        <p14:creationId xmlns:p14="http://schemas.microsoft.com/office/powerpoint/2010/main" val="3977669788"/>
+        <p14:creationId xmlns:p14="http://schemas.microsoft.com/office/powerpoint/2010/main" val="2577933210"/>
       </p:ext>
     </p:extLst>
   </p:cSld>

</xml_diff>

<commit_message>
feat: refresh presentation surfaces and visual evidence
</commit_message>
<xml_diff>
--- a/output/presentation/gridguard-khartoum-defense.pptx
+++ b/output/presentation/gridguard-khartoum-defense.pptx
@@ -202,9 +202,9 @@
             </a:lvl1pPr>
           </a:lstStyle>
           <a:p>
-            <a:fld id="{33B8A4F9-EFA0-4290-B501-829966B9C6A3}" type="datetimeFigureOut">
+            <a:fld id="{E89048A6-5D6A-448B-81F8-77304A8870A2}" type="datetimeFigureOut">
               <a:rPr lang="en-US" smtClean="0"/>
-              <a:t>8/26/2026</a:t>
+              <a:t>8/27/2026</a:t>
             </a:fld>
             <a:endParaRPr lang="en-US"/>
           </a:p>
@@ -360,7 +360,7 @@
             </a:lvl1pPr>
           </a:lstStyle>
           <a:p>
-            <a:fld id="{F628B4D0-9E59-43BF-A427-B10DB8326E40}" type="slidenum">
+            <a:fld id="{A90F9F25-4631-43F5-97A3-922655910913}" type="slidenum">
               <a:rPr lang="en-US" smtClean="0"/>
               <a:t>‹#›</a:t>
             </a:fld>
@@ -371,7 +371,7 @@
     </p:spTree>
     <p:extLst>
       <p:ext uri="{BB962C8B-B14F-4D97-AF65-F5344CB8AC3E}">
-        <p14:creationId xmlns:p14="http://schemas.microsoft.com/office/powerpoint/2010/main" val="1364782649"/>
+        <p14:creationId xmlns:p14="http://schemas.microsoft.com/office/powerpoint/2010/main" val="2744257114"/>
       </p:ext>
     </p:extLst>
   </p:cSld>
@@ -564,7 +564,7 @@
           <a:bodyPr/>
           <a:lstStyle/>
           <a:p>
-            <a:fld id="{F628B4D0-9E59-43BF-A427-B10DB8326E40}" type="slidenum">
+            <a:fld id="{A90F9F25-4631-43F5-97A3-922655910913}" type="slidenum">
               <a:rPr lang="en-US" smtClean="0"/>
               <a:t>1</a:t>
             </a:fld>
@@ -575,7 +575,7 @@
     </p:spTree>
     <p:extLst>
       <p:ext uri="{BB962C8B-B14F-4D97-AF65-F5344CB8AC3E}">
-        <p14:creationId xmlns:p14="http://schemas.microsoft.com/office/powerpoint/2010/main" val="1071919906"/>
+        <p14:creationId xmlns:p14="http://schemas.microsoft.com/office/powerpoint/2010/main" val="1349486114"/>
       </p:ext>
     </p:extLst>
   </p:cSld>
@@ -678,7 +678,7 @@
           <a:bodyPr/>
           <a:lstStyle/>
           <a:p>
-            <a:fld id="{F628B4D0-9E59-43BF-A427-B10DB8326E40}" type="slidenum">
+            <a:fld id="{A90F9F25-4631-43F5-97A3-922655910913}" type="slidenum">
               <a:rPr lang="en-US" smtClean="0"/>
               <a:t>10</a:t>
             </a:fld>
@@ -689,7 +689,7 @@
     </p:spTree>
     <p:extLst>
       <p:ext uri="{BB962C8B-B14F-4D97-AF65-F5344CB8AC3E}">
-        <p14:creationId xmlns:p14="http://schemas.microsoft.com/office/powerpoint/2010/main" val="3344777818"/>
+        <p14:creationId xmlns:p14="http://schemas.microsoft.com/office/powerpoint/2010/main" val="2299243170"/>
       </p:ext>
     </p:extLst>
   </p:cSld>
@@ -745,7 +745,7 @@
           <a:p>
             <a:r>
               <a:rPr lang="en-US"/>
-              <a:t>The accepted artifact preserves provenance, but acceptance used its seeds. Confirmatory claims use the separate untouched seed layer.</a:t>
+              <a:t>The accepted artifact preserves provenance, but acceptance used its seeds. Reviewer-facing comparisons use the separate documented-seed-disjoint holdout, subject to its stated custody limitation.</a:t>
             </a:r>
           </a:p>
           <a:p>
@@ -760,7 +760,7 @@
           <a:p>
             <a:r>
               <a:rPr lang="en-US"/>
-              <a:t>- data/evidence/paired-benchmark.json, SHA-256 6052e9e47d92e82a0f1db0d3643a2e9be6edc5f3e9fc615b0b185964b54c1677</a:t>
+              <a:t>- data/evidence/paired-benchmark.json, SHA-256 7f2009c4f7efbbedf098069ced9218addec51d55a18b969e6c54433027020af5</a:t>
             </a:r>
           </a:p>
           <a:p>
@@ -792,7 +792,7 @@
           <a:bodyPr/>
           <a:lstStyle/>
           <a:p>
-            <a:fld id="{F628B4D0-9E59-43BF-A427-B10DB8326E40}" type="slidenum">
+            <a:fld id="{A90F9F25-4631-43F5-97A3-922655910913}" type="slidenum">
               <a:rPr lang="en-US" smtClean="0"/>
               <a:t>11</a:t>
             </a:fld>
@@ -803,7 +803,7 @@
     </p:spTree>
     <p:extLst>
       <p:ext uri="{BB962C8B-B14F-4D97-AF65-F5344CB8AC3E}">
-        <p14:creationId xmlns:p14="http://schemas.microsoft.com/office/powerpoint/2010/main" val="3467231413"/>
+        <p14:creationId xmlns:p14="http://schemas.microsoft.com/office/powerpoint/2010/main" val="1766210412"/>
       </p:ext>
     </p:extLst>
   </p:cSld>
@@ -859,7 +859,7 @@
           <a:p>
             <a:r>
               <a:rPr lang="en-US"/>
-              <a:t>The experiment models shortage allocation, not a power-flow network, and the data are synthetic.</a:t>
+              <a:t>The experiment models shortage allocation, not a power-flow network, and the data are synthetic. Fixed Rotation is supply-blind, limited to Off and Full Service, and cannot select Critical Only. No behavior-cloning-only ablation was run, so this comparison cannot isolate the incremental effect of PPO fine-tuning.</a:t>
             </a:r>
           </a:p>
           <a:p>
@@ -906,7 +906,7 @@
           <a:bodyPr/>
           <a:lstStyle/>
           <a:p>
-            <a:fld id="{F628B4D0-9E59-43BF-A427-B10DB8326E40}" type="slidenum">
+            <a:fld id="{A90F9F25-4631-43F5-97A3-922655910913}" type="slidenum">
               <a:rPr lang="en-US" smtClean="0"/>
               <a:t>12</a:t>
             </a:fld>
@@ -917,7 +917,7 @@
     </p:spTree>
     <p:extLst>
       <p:ext uri="{BB962C8B-B14F-4D97-AF65-F5344CB8AC3E}">
-        <p14:creationId xmlns:p14="http://schemas.microsoft.com/office/powerpoint/2010/main" val="1704945219"/>
+        <p14:creationId xmlns:p14="http://schemas.microsoft.com/office/powerpoint/2010/main" val="1219574278"/>
       </p:ext>
     </p:extLst>
   </p:cSld>
@@ -973,7 +973,7 @@
           <a:p>
             <a:r>
               <a:rPr lang="en-US"/>
-              <a:t>PPO outperformed Fixed Rotation under this locked synthetic protocol. Operational-data and network validation must precede field use.</a:t>
+              <a:t>PPO outperformed Fixed Rotation under this locked synthetic protocol. Fixed Rotation is supply-blind, limited to Off and Full Service, and cannot select Critical Only; this is not evidence of general controller superiority. No behavior-cloning-only ablation was run, so the comparison cannot isolate the incremental effect of PPO fine-tuning. Operational-data and network validation must precede field use.</a:t>
             </a:r>
           </a:p>
           <a:p>
@@ -1020,7 +1020,7 @@
           <a:bodyPr/>
           <a:lstStyle/>
           <a:p>
-            <a:fld id="{F628B4D0-9E59-43BF-A427-B10DB8326E40}" type="slidenum">
+            <a:fld id="{A90F9F25-4631-43F5-97A3-922655910913}" type="slidenum">
               <a:rPr lang="en-US" smtClean="0"/>
               <a:t>13</a:t>
             </a:fld>
@@ -1031,7 +1031,7 @@
     </p:spTree>
     <p:extLst>
       <p:ext uri="{BB962C8B-B14F-4D97-AF65-F5344CB8AC3E}">
-        <p14:creationId xmlns:p14="http://schemas.microsoft.com/office/powerpoint/2010/main" val="1020384089"/>
+        <p14:creationId xmlns:p14="http://schemas.microsoft.com/office/powerpoint/2010/main" val="619387505"/>
       </p:ext>
     </p:extLst>
   </p:cSld>
@@ -1134,7 +1134,7 @@
           <a:bodyPr/>
           <a:lstStyle/>
           <a:p>
-            <a:fld id="{F628B4D0-9E59-43BF-A427-B10DB8326E40}" type="slidenum">
+            <a:fld id="{A90F9F25-4631-43F5-97A3-922655910913}" type="slidenum">
               <a:rPr lang="en-US" smtClean="0"/>
               <a:t>2</a:t>
             </a:fld>
@@ -1145,7 +1145,7 @@
     </p:spTree>
     <p:extLst>
       <p:ext uri="{BB962C8B-B14F-4D97-AF65-F5344CB8AC3E}">
-        <p14:creationId xmlns:p14="http://schemas.microsoft.com/office/powerpoint/2010/main" val="3064405783"/>
+        <p14:creationId xmlns:p14="http://schemas.microsoft.com/office/powerpoint/2010/main" val="156483792"/>
       </p:ext>
     </p:extLst>
   </p:cSld>
@@ -1248,7 +1248,7 @@
           <a:bodyPr/>
           <a:lstStyle/>
           <a:p>
-            <a:fld id="{F628B4D0-9E59-43BF-A427-B10DB8326E40}" type="slidenum">
+            <a:fld id="{A90F9F25-4631-43F5-97A3-922655910913}" type="slidenum">
               <a:rPr lang="en-US" smtClean="0"/>
               <a:t>3</a:t>
             </a:fld>
@@ -1259,7 +1259,7 @@
     </p:spTree>
     <p:extLst>
       <p:ext uri="{BB962C8B-B14F-4D97-AF65-F5344CB8AC3E}">
-        <p14:creationId xmlns:p14="http://schemas.microsoft.com/office/powerpoint/2010/main" val="3491645500"/>
+        <p14:creationId xmlns:p14="http://schemas.microsoft.com/office/powerpoint/2010/main" val="3206552377"/>
       </p:ext>
     </p:extLst>
   </p:cSld>
@@ -1315,7 +1315,7 @@
           <a:p>
             <a:r>
               <a:rPr lang="en-US"/>
-              <a:t>The 960 conditions are severity variants of 320 independent base draws. Both controllers receive the same immutable scenario.</a:t>
+              <a:t>The 960 conditions are severity variants of 320 independent base draws. Both controllers receive the same guarded scenario; detected demand/supply mutation fails closed.</a:t>
             </a:r>
           </a:p>
           <a:p>
@@ -1336,7 +1336,7 @@
           <a:p>
             <a:r>
               <a:rPr lang="en-US"/>
-              <a:t>- data/evidence/robustness-supplement.json, SHA-256 c89e04b1bdca371e1728f6b4cb19f4e899261ab805c2e400c15e835eaf75a30b</a:t>
+              <a:t>- data/evidence/robustness-supplement.json, SHA-256 fabb5a2f13ab31cd51f641f4e6a6db3cce8a28a6e2c4fa144612f634bad0beb1</a:t>
             </a:r>
           </a:p>
           <a:p>
@@ -1362,7 +1362,7 @@
           <a:bodyPr/>
           <a:lstStyle/>
           <a:p>
-            <a:fld id="{F628B4D0-9E59-43BF-A427-B10DB8326E40}" type="slidenum">
+            <a:fld id="{A90F9F25-4631-43F5-97A3-922655910913}" type="slidenum">
               <a:rPr lang="en-US" smtClean="0"/>
               <a:t>4</a:t>
             </a:fld>
@@ -1373,7 +1373,7 @@
     </p:spTree>
     <p:extLst>
       <p:ext uri="{BB962C8B-B14F-4D97-AF65-F5344CB8AC3E}">
-        <p14:creationId xmlns:p14="http://schemas.microsoft.com/office/powerpoint/2010/main" val="1540796508"/>
+        <p14:creationId xmlns:p14="http://schemas.microsoft.com/office/powerpoint/2010/main" val="2750972729"/>
       </p:ext>
     </p:extLst>
   </p:cSld>
@@ -1429,7 +1429,7 @@
           <a:p>
             <a:r>
               <a:rPr lang="en-US"/>
-              <a:t>The historical teacher-guided initialization precedes PPO training; the deployed controller remains PPO.</a:t>
+              <a:t>The displayed runtime, convergence, and checkpoint facts describe selected seed 43; the candidate experiment comprised 3 runs totaling 1,800 iterations, 460,800 episodes, and 11,059,200 transitions. Historical reward gates document model selection and are not independent current headline evidence. The teacher-guided initialization precedes PPO training; the deployed controller remains PPO. No behavior-cloning-only ablation was run, so this comparison cannot isolate the incremental effect of PPO fine-tuning.</a:t>
             </a:r>
           </a:p>
           <a:p>
@@ -1444,7 +1444,7 @@
           <a:p>
             <a:r>
               <a:rPr lang="en-US"/>
-              <a:t>- data/model/training-provenance.yaml, SHA-256 2cfa158a4b26596fd1f155c57fa79a88dc1c41ce8df946792c559184a815128a</a:t>
+              <a:t>- data/model/training-provenance.yaml, SHA-256 d2568bce26e9221afa8c266113a704f6fbf2370d3bc949f5aa6c72a7411ba1a8</a:t>
             </a:r>
           </a:p>
           <a:p>
@@ -1476,7 +1476,7 @@
           <a:bodyPr/>
           <a:lstStyle/>
           <a:p>
-            <a:fld id="{F628B4D0-9E59-43BF-A427-B10DB8326E40}" type="slidenum">
+            <a:fld id="{A90F9F25-4631-43F5-97A3-922655910913}" type="slidenum">
               <a:rPr lang="en-US" smtClean="0"/>
               <a:t>5</a:t>
             </a:fld>
@@ -1487,7 +1487,7 @@
     </p:spTree>
     <p:extLst>
       <p:ext uri="{BB962C8B-B14F-4D97-AF65-F5344CB8AC3E}">
-        <p14:creationId xmlns:p14="http://schemas.microsoft.com/office/powerpoint/2010/main" val="2717644879"/>
+        <p14:creationId xmlns:p14="http://schemas.microsoft.com/office/powerpoint/2010/main" val="3710232905"/>
       </p:ext>
     </p:extLst>
   </p:cSld>
@@ -1543,7 +1543,7 @@
           <a:p>
             <a:r>
               <a:rPr lang="en-US"/>
-              <a:t>Simulation, PPO inference, metrics, and bootstrap stay GPU-first. One final host transfer supports portable artifact assembly.</a:t>
+              <a:t>Simulation, PPO inference, metrics, and bootstrap stay GPU-first. Scalar invariant flags may synchronize; one final full-array host transfer supports portable artifact assembly.</a:t>
             </a:r>
           </a:p>
           <a:p>
@@ -1590,7 +1590,7 @@
           <a:bodyPr/>
           <a:lstStyle/>
           <a:p>
-            <a:fld id="{F628B4D0-9E59-43BF-A427-B10DB8326E40}" type="slidenum">
+            <a:fld id="{A90F9F25-4631-43F5-97A3-922655910913}" type="slidenum">
               <a:rPr lang="en-US" smtClean="0"/>
               <a:t>6</a:t>
             </a:fld>
@@ -1601,7 +1601,7 @@
     </p:spTree>
     <p:extLst>
       <p:ext uri="{BB962C8B-B14F-4D97-AF65-F5344CB8AC3E}">
-        <p14:creationId xmlns:p14="http://schemas.microsoft.com/office/powerpoint/2010/main" val="2038188418"/>
+        <p14:creationId xmlns:p14="http://schemas.microsoft.com/office/powerpoint/2010/main" val="269251964"/>
       </p:ext>
     </p:extLst>
   </p:cSld>
@@ -1704,7 +1704,7 @@
           <a:bodyPr/>
           <a:lstStyle/>
           <a:p>
-            <a:fld id="{F628B4D0-9E59-43BF-A427-B10DB8326E40}" type="slidenum">
+            <a:fld id="{A90F9F25-4631-43F5-97A3-922655910913}" type="slidenum">
               <a:rPr lang="en-US" smtClean="0"/>
               <a:t>7</a:t>
             </a:fld>
@@ -1715,7 +1715,7 @@
     </p:spTree>
     <p:extLst>
       <p:ext uri="{BB962C8B-B14F-4D97-AF65-F5344CB8AC3E}">
-        <p14:creationId xmlns:p14="http://schemas.microsoft.com/office/powerpoint/2010/main" val="3673495365"/>
+        <p14:creationId xmlns:p14="http://schemas.microsoft.com/office/powerpoint/2010/main" val="876031067"/>
       </p:ext>
     </p:extLst>
   </p:cSld>
@@ -1771,7 +1771,7 @@
           <a:p>
             <a:r>
               <a:rPr lang="en-US"/>
-              <a:t>These are the only three headline outcomes. They use 10 untouched seeds and were reported as observed; result direction was not a release condition.</a:t>
+              <a:t>These are the only three headline outcomes. The seeds are disjoint only from documented activity: the holdout was not preregistered or independently custodied and cannot rule out undocumented activity. Results were reported as observed; direction was not a release condition. No behavior-cloning-only ablation was run, so this comparison cannot isolate the incremental effect of PPO fine-tuning.</a:t>
             </a:r>
           </a:p>
           <a:p>
@@ -1786,7 +1786,7 @@
           <a:p>
             <a:r>
               <a:rPr lang="en-US"/>
-              <a:t>- data/evidence/robustness-supplement.json, SHA-256 c89e04b1bdca371e1728f6b4cb19f4e899261ab805c2e400c15e835eaf75a30b</a:t>
+              <a:t>- data/evidence/robustness-supplement.json, SHA-256 fabb5a2f13ab31cd51f641f4e6a6db3cce8a28a6e2c4fa144612f634bad0beb1</a:t>
             </a:r>
           </a:p>
           <a:p>
@@ -1818,7 +1818,7 @@
           <a:bodyPr/>
           <a:lstStyle/>
           <a:p>
-            <a:fld id="{F628B4D0-9E59-43BF-A427-B10DB8326E40}" type="slidenum">
+            <a:fld id="{A90F9F25-4631-43F5-97A3-922655910913}" type="slidenum">
               <a:rPr lang="en-US" smtClean="0"/>
               <a:t>8</a:t>
             </a:fld>
@@ -1829,7 +1829,7 @@
     </p:spTree>
     <p:extLst>
       <p:ext uri="{BB962C8B-B14F-4D97-AF65-F5344CB8AC3E}">
-        <p14:creationId xmlns:p14="http://schemas.microsoft.com/office/powerpoint/2010/main" val="1681969622"/>
+        <p14:creationId xmlns:p14="http://schemas.microsoft.com/office/powerpoint/2010/main" val="3564319738"/>
       </p:ext>
     </p:extLst>
   </p:cSld>
@@ -1885,7 +1885,7 @@
           <a:p>
             <a:r>
               <a:rPr lang="en-US"/>
-              <a:t>All 24 variants retain favorable paired direction for each primary outcome. Difference-in-differences is mixed and no result-direction gate filtered the artifact.</a:t>
+              <a:t>The cards report observed direction counts, not a gate. Sensitivity intervals are descriptive, pointwise 95%, and unadjusted for multiple comparisons; they do not support family-wide significance claims. Difference-in-differences reports effect-size shifts versus base.</a:t>
             </a:r>
           </a:p>
           <a:p>
@@ -1932,7 +1932,7 @@
           <a:bodyPr/>
           <a:lstStyle/>
           <a:p>
-            <a:fld id="{F628B4D0-9E59-43BF-A427-B10DB8326E40}" type="slidenum">
+            <a:fld id="{A90F9F25-4631-43F5-97A3-922655910913}" type="slidenum">
               <a:rPr lang="en-US" smtClean="0"/>
               <a:t>9</a:t>
             </a:fld>
@@ -1943,7 +1943,7 @@
     </p:spTree>
     <p:extLst>
       <p:ext uri="{BB962C8B-B14F-4D97-AF65-F5344CB8AC3E}">
-        <p14:creationId xmlns:p14="http://schemas.microsoft.com/office/powerpoint/2010/main" val="4181033574"/>
+        <p14:creationId xmlns:p14="http://schemas.microsoft.com/office/powerpoint/2010/main" val="934478509"/>
       </p:ext>
     </p:extLst>
   </p:cSld>
@@ -1975,7 +1975,7 @@
           <p:cNvPr id="2" name="Title 1">
             <a:extLst>
               <a:ext uri="{FF2B5EF4-FFF2-40B4-BE49-F238E27FC236}">
-                <a16:creationId xmlns:a16="http://schemas.microsoft.com/office/drawing/2014/main" id="{2E43EFF6-2A29-60DB-9898-D886647AEDB9}"/>
+                <a16:creationId xmlns:a16="http://schemas.microsoft.com/office/drawing/2014/main" id="{D00A2336-F06A-5CD8-3E93-118963C27309}"/>
               </a:ext>
             </a:extLst>
           </p:cNvPr>
@@ -2012,7 +2012,7 @@
           <p:cNvPr id="3" name="Subtitle 2">
             <a:extLst>
               <a:ext uri="{FF2B5EF4-FFF2-40B4-BE49-F238E27FC236}">
-                <a16:creationId xmlns:a16="http://schemas.microsoft.com/office/drawing/2014/main" id="{4AA5CF46-DC40-1259-B080-DE96D83EACE8}"/>
+                <a16:creationId xmlns:a16="http://schemas.microsoft.com/office/drawing/2014/main" id="{22CA1B57-01DD-4F8B-C176-E1A1E1845B7F}"/>
               </a:ext>
             </a:extLst>
           </p:cNvPr>
@@ -2082,7 +2082,7 @@
           <p:cNvPr id="4" name="Date Placeholder 3">
             <a:extLst>
               <a:ext uri="{FF2B5EF4-FFF2-40B4-BE49-F238E27FC236}">
-                <a16:creationId xmlns:a16="http://schemas.microsoft.com/office/drawing/2014/main" id="{1704AEBA-3459-EFBC-E46B-6394F628C272}"/>
+                <a16:creationId xmlns:a16="http://schemas.microsoft.com/office/drawing/2014/main" id="{37153007-D74C-09A5-A7E3-E35FA42F63CB}"/>
               </a:ext>
             </a:extLst>
           </p:cNvPr>
@@ -2098,9 +2098,9 @@
           <a:bodyPr/>
           <a:lstStyle/>
           <a:p>
-            <a:fld id="{A6BAA431-359D-4C1A-9B3A-7EAB5F6A80FB}" type="datetimeFigureOut">
+            <a:fld id="{7C1452FA-4B05-4D50-9D4B-B5BDEE9852A8}" type="datetimeFigureOut">
               <a:rPr lang="en-US" smtClean="0"/>
-              <a:t>8/26/2026</a:t>
+              <a:t>8/27/2026</a:t>
             </a:fld>
             <a:endParaRPr lang="en-US"/>
           </a:p>
@@ -2111,7 +2111,7 @@
           <p:cNvPr id="5" name="Footer Placeholder 4">
             <a:extLst>
               <a:ext uri="{FF2B5EF4-FFF2-40B4-BE49-F238E27FC236}">
-                <a16:creationId xmlns:a16="http://schemas.microsoft.com/office/drawing/2014/main" id="{2D5F5412-E6AA-153C-5171-3E9CDFD24A36}"/>
+                <a16:creationId xmlns:a16="http://schemas.microsoft.com/office/drawing/2014/main" id="{A1B9B967-87AF-4FD0-8240-CBF4FBA86A70}"/>
               </a:ext>
             </a:extLst>
           </p:cNvPr>
@@ -2136,7 +2136,7 @@
           <p:cNvPr id="6" name="Slide Number Placeholder 5">
             <a:extLst>
               <a:ext uri="{FF2B5EF4-FFF2-40B4-BE49-F238E27FC236}">
-                <a16:creationId xmlns:a16="http://schemas.microsoft.com/office/drawing/2014/main" id="{127AEAB8-957B-8B63-2166-115294D2B871}"/>
+                <a16:creationId xmlns:a16="http://schemas.microsoft.com/office/drawing/2014/main" id="{7A5C1E4A-FBFA-2CF4-05C9-94E123ABBDD2}"/>
               </a:ext>
             </a:extLst>
           </p:cNvPr>
@@ -2152,7 +2152,7 @@
           <a:bodyPr/>
           <a:lstStyle/>
           <a:p>
-            <a:fld id="{EF41EA56-A879-4DA1-9200-527E75E644FC}" type="slidenum">
+            <a:fld id="{2865BCB8-0C88-4FC1-96D7-FA9A8E2C4D3A}" type="slidenum">
               <a:rPr lang="en-US" smtClean="0"/>
               <a:t>‹#›</a:t>
             </a:fld>
@@ -2163,7 +2163,7 @@
     </p:spTree>
     <p:extLst>
       <p:ext uri="{BB962C8B-B14F-4D97-AF65-F5344CB8AC3E}">
-        <p14:creationId xmlns:p14="http://schemas.microsoft.com/office/powerpoint/2010/main" val="2037863051"/>
+        <p14:creationId xmlns:p14="http://schemas.microsoft.com/office/powerpoint/2010/main" val="1939138383"/>
       </p:ext>
     </p:extLst>
   </p:cSld>
@@ -2195,7 +2195,7 @@
           <p:cNvPr id="2" name="Title 1">
             <a:extLst>
               <a:ext uri="{FF2B5EF4-FFF2-40B4-BE49-F238E27FC236}">
-                <a16:creationId xmlns:a16="http://schemas.microsoft.com/office/drawing/2014/main" id="{E576D414-EBF2-C61F-BCB6-6215C7AE30EB}"/>
+                <a16:creationId xmlns:a16="http://schemas.microsoft.com/office/drawing/2014/main" id="{7799A609-C7E3-2A29-8189-6EF215D9B630}"/>
               </a:ext>
             </a:extLst>
           </p:cNvPr>
@@ -2223,7 +2223,7 @@
           <p:cNvPr id="3" name="Vertical Text Placeholder 2">
             <a:extLst>
               <a:ext uri="{FF2B5EF4-FFF2-40B4-BE49-F238E27FC236}">
-                <a16:creationId xmlns:a16="http://schemas.microsoft.com/office/drawing/2014/main" id="{AAC0ED2E-F0BE-57A6-8FAC-D63503CA3D2D}"/>
+                <a16:creationId xmlns:a16="http://schemas.microsoft.com/office/drawing/2014/main" id="{0DA4AE5D-52CE-CFE0-1471-8BCF03DE16B0}"/>
               </a:ext>
             </a:extLst>
           </p:cNvPr>
@@ -2280,7 +2280,7 @@
           <p:cNvPr id="4" name="Date Placeholder 3">
             <a:extLst>
               <a:ext uri="{FF2B5EF4-FFF2-40B4-BE49-F238E27FC236}">
-                <a16:creationId xmlns:a16="http://schemas.microsoft.com/office/drawing/2014/main" id="{80D97957-2CB8-2FE0-0810-2A84830AA5AF}"/>
+                <a16:creationId xmlns:a16="http://schemas.microsoft.com/office/drawing/2014/main" id="{549E1D15-1BF2-CC3A-99B0-8A33679A63A2}"/>
               </a:ext>
             </a:extLst>
           </p:cNvPr>
@@ -2296,9 +2296,9 @@
           <a:bodyPr/>
           <a:lstStyle/>
           <a:p>
-            <a:fld id="{A6BAA431-359D-4C1A-9B3A-7EAB5F6A80FB}" type="datetimeFigureOut">
+            <a:fld id="{7C1452FA-4B05-4D50-9D4B-B5BDEE9852A8}" type="datetimeFigureOut">
               <a:rPr lang="en-US" smtClean="0"/>
-              <a:t>8/26/2026</a:t>
+              <a:t>8/27/2026</a:t>
             </a:fld>
             <a:endParaRPr lang="en-US"/>
           </a:p>
@@ -2309,7 +2309,7 @@
           <p:cNvPr id="5" name="Footer Placeholder 4">
             <a:extLst>
               <a:ext uri="{FF2B5EF4-FFF2-40B4-BE49-F238E27FC236}">
-                <a16:creationId xmlns:a16="http://schemas.microsoft.com/office/drawing/2014/main" id="{ADB8BB79-1FAE-F732-AF78-62BDEF315F9F}"/>
+                <a16:creationId xmlns:a16="http://schemas.microsoft.com/office/drawing/2014/main" id="{3615F41D-6F95-EB20-1CF6-C5B57292B496}"/>
               </a:ext>
             </a:extLst>
           </p:cNvPr>
@@ -2334,7 +2334,7 @@
           <p:cNvPr id="6" name="Slide Number Placeholder 5">
             <a:extLst>
               <a:ext uri="{FF2B5EF4-FFF2-40B4-BE49-F238E27FC236}">
-                <a16:creationId xmlns:a16="http://schemas.microsoft.com/office/drawing/2014/main" id="{C838D6B8-A01A-C108-3715-EEDA6644B889}"/>
+                <a16:creationId xmlns:a16="http://schemas.microsoft.com/office/drawing/2014/main" id="{3BBFAC7A-1452-19A6-34DA-E939D38C0C9C}"/>
               </a:ext>
             </a:extLst>
           </p:cNvPr>
@@ -2350,7 +2350,7 @@
           <a:bodyPr/>
           <a:lstStyle/>
           <a:p>
-            <a:fld id="{EF41EA56-A879-4DA1-9200-527E75E644FC}" type="slidenum">
+            <a:fld id="{2865BCB8-0C88-4FC1-96D7-FA9A8E2C4D3A}" type="slidenum">
               <a:rPr lang="en-US" smtClean="0"/>
               <a:t>‹#›</a:t>
             </a:fld>
@@ -2361,7 +2361,7 @@
     </p:spTree>
     <p:extLst>
       <p:ext uri="{BB962C8B-B14F-4D97-AF65-F5344CB8AC3E}">
-        <p14:creationId xmlns:p14="http://schemas.microsoft.com/office/powerpoint/2010/main" val="129338692"/>
+        <p14:creationId xmlns:p14="http://schemas.microsoft.com/office/powerpoint/2010/main" val="3590837308"/>
       </p:ext>
     </p:extLst>
   </p:cSld>
@@ -2393,7 +2393,7 @@
           <p:cNvPr id="2" name="Vertical Title 1">
             <a:extLst>
               <a:ext uri="{FF2B5EF4-FFF2-40B4-BE49-F238E27FC236}">
-                <a16:creationId xmlns:a16="http://schemas.microsoft.com/office/drawing/2014/main" id="{46167231-66ED-2BE3-12CD-09251E7C94D2}"/>
+                <a16:creationId xmlns:a16="http://schemas.microsoft.com/office/drawing/2014/main" id="{F755B02A-4868-4C2F-5E9E-FCBE329F4F60}"/>
               </a:ext>
             </a:extLst>
           </p:cNvPr>
@@ -2426,7 +2426,7 @@
           <p:cNvPr id="3" name="Vertical Text Placeholder 2">
             <a:extLst>
               <a:ext uri="{FF2B5EF4-FFF2-40B4-BE49-F238E27FC236}">
-                <a16:creationId xmlns:a16="http://schemas.microsoft.com/office/drawing/2014/main" id="{8C5B0BE7-B376-A053-28A5-2E8E6BE64DB5}"/>
+                <a16:creationId xmlns:a16="http://schemas.microsoft.com/office/drawing/2014/main" id="{533990C8-7BC6-7CE8-DC38-A166E62FE118}"/>
               </a:ext>
             </a:extLst>
           </p:cNvPr>
@@ -2488,7 +2488,7 @@
           <p:cNvPr id="4" name="Date Placeholder 3">
             <a:extLst>
               <a:ext uri="{FF2B5EF4-FFF2-40B4-BE49-F238E27FC236}">
-                <a16:creationId xmlns:a16="http://schemas.microsoft.com/office/drawing/2014/main" id="{AF559254-BA3A-F198-A488-1DFC6540B6CD}"/>
+                <a16:creationId xmlns:a16="http://schemas.microsoft.com/office/drawing/2014/main" id="{6808A680-DA30-AE65-7F62-DBA40A38DBA1}"/>
               </a:ext>
             </a:extLst>
           </p:cNvPr>
@@ -2504,9 +2504,9 @@
           <a:bodyPr/>
           <a:lstStyle/>
           <a:p>
-            <a:fld id="{A6BAA431-359D-4C1A-9B3A-7EAB5F6A80FB}" type="datetimeFigureOut">
+            <a:fld id="{7C1452FA-4B05-4D50-9D4B-B5BDEE9852A8}" type="datetimeFigureOut">
               <a:rPr lang="en-US" smtClean="0"/>
-              <a:t>8/26/2026</a:t>
+              <a:t>8/27/2026</a:t>
             </a:fld>
             <a:endParaRPr lang="en-US"/>
           </a:p>
@@ -2517,7 +2517,7 @@
           <p:cNvPr id="5" name="Footer Placeholder 4">
             <a:extLst>
               <a:ext uri="{FF2B5EF4-FFF2-40B4-BE49-F238E27FC236}">
-                <a16:creationId xmlns:a16="http://schemas.microsoft.com/office/drawing/2014/main" id="{FA630413-C7A2-1C1D-83DE-1D55F9480EE8}"/>
+                <a16:creationId xmlns:a16="http://schemas.microsoft.com/office/drawing/2014/main" id="{25645391-BB2E-B87E-B960-C6C18862CF5F}"/>
               </a:ext>
             </a:extLst>
           </p:cNvPr>
@@ -2542,7 +2542,7 @@
           <p:cNvPr id="6" name="Slide Number Placeholder 5">
             <a:extLst>
               <a:ext uri="{FF2B5EF4-FFF2-40B4-BE49-F238E27FC236}">
-                <a16:creationId xmlns:a16="http://schemas.microsoft.com/office/drawing/2014/main" id="{617235D8-D0D6-7F5D-C02E-1E0F55D74A07}"/>
+                <a16:creationId xmlns:a16="http://schemas.microsoft.com/office/drawing/2014/main" id="{CB6835CE-6F63-18A8-7289-0DA13C618A82}"/>
               </a:ext>
             </a:extLst>
           </p:cNvPr>
@@ -2558,7 +2558,7 @@
           <a:bodyPr/>
           <a:lstStyle/>
           <a:p>
-            <a:fld id="{EF41EA56-A879-4DA1-9200-527E75E644FC}" type="slidenum">
+            <a:fld id="{2865BCB8-0C88-4FC1-96D7-FA9A8E2C4D3A}" type="slidenum">
               <a:rPr lang="en-US" smtClean="0"/>
               <a:t>‹#›</a:t>
             </a:fld>
@@ -2569,7 +2569,7 @@
     </p:spTree>
     <p:extLst>
       <p:ext uri="{BB962C8B-B14F-4D97-AF65-F5344CB8AC3E}">
-        <p14:creationId xmlns:p14="http://schemas.microsoft.com/office/powerpoint/2010/main" val="583873137"/>
+        <p14:creationId xmlns:p14="http://schemas.microsoft.com/office/powerpoint/2010/main" val="155436510"/>
       </p:ext>
     </p:extLst>
   </p:cSld>
@@ -2601,7 +2601,7 @@
           <p:cNvPr id="2" name="Title 1">
             <a:extLst>
               <a:ext uri="{FF2B5EF4-FFF2-40B4-BE49-F238E27FC236}">
-                <a16:creationId xmlns:a16="http://schemas.microsoft.com/office/drawing/2014/main" id="{744668EC-8DD6-8A0D-76F7-FD69558D2A29}"/>
+                <a16:creationId xmlns:a16="http://schemas.microsoft.com/office/drawing/2014/main" id="{203E3FFC-7CE8-E975-E95E-E0EDDD379983}"/>
               </a:ext>
             </a:extLst>
           </p:cNvPr>
@@ -2629,7 +2629,7 @@
           <p:cNvPr id="3" name="Content Placeholder 2">
             <a:extLst>
               <a:ext uri="{FF2B5EF4-FFF2-40B4-BE49-F238E27FC236}">
-                <a16:creationId xmlns:a16="http://schemas.microsoft.com/office/drawing/2014/main" id="{63224AED-898A-1470-191A-9873D282ED07}"/>
+                <a16:creationId xmlns:a16="http://schemas.microsoft.com/office/drawing/2014/main" id="{0B32A947-6107-641A-EC46-FC8E34EC5633}"/>
               </a:ext>
             </a:extLst>
           </p:cNvPr>
@@ -2686,7 +2686,7 @@
           <p:cNvPr id="4" name="Date Placeholder 3">
             <a:extLst>
               <a:ext uri="{FF2B5EF4-FFF2-40B4-BE49-F238E27FC236}">
-                <a16:creationId xmlns:a16="http://schemas.microsoft.com/office/drawing/2014/main" id="{BCC95FA3-7DB3-DEF0-18C1-C263A4636FDF}"/>
+                <a16:creationId xmlns:a16="http://schemas.microsoft.com/office/drawing/2014/main" id="{0683BFD0-7ED0-1852-A675-B785444BB232}"/>
               </a:ext>
             </a:extLst>
           </p:cNvPr>
@@ -2702,9 +2702,9 @@
           <a:bodyPr/>
           <a:lstStyle/>
           <a:p>
-            <a:fld id="{A6BAA431-359D-4C1A-9B3A-7EAB5F6A80FB}" type="datetimeFigureOut">
+            <a:fld id="{7C1452FA-4B05-4D50-9D4B-B5BDEE9852A8}" type="datetimeFigureOut">
               <a:rPr lang="en-US" smtClean="0"/>
-              <a:t>8/26/2026</a:t>
+              <a:t>8/27/2026</a:t>
             </a:fld>
             <a:endParaRPr lang="en-US"/>
           </a:p>
@@ -2715,7 +2715,7 @@
           <p:cNvPr id="5" name="Footer Placeholder 4">
             <a:extLst>
               <a:ext uri="{FF2B5EF4-FFF2-40B4-BE49-F238E27FC236}">
-                <a16:creationId xmlns:a16="http://schemas.microsoft.com/office/drawing/2014/main" id="{EDFD943A-862B-6AC4-AF38-C95335D4A2A9}"/>
+                <a16:creationId xmlns:a16="http://schemas.microsoft.com/office/drawing/2014/main" id="{15FB7A3D-B505-0E62-FBA1-AF8564D22CE6}"/>
               </a:ext>
             </a:extLst>
           </p:cNvPr>
@@ -2740,7 +2740,7 @@
           <p:cNvPr id="6" name="Slide Number Placeholder 5">
             <a:extLst>
               <a:ext uri="{FF2B5EF4-FFF2-40B4-BE49-F238E27FC236}">
-                <a16:creationId xmlns:a16="http://schemas.microsoft.com/office/drawing/2014/main" id="{75A14BD2-A361-25CE-D639-02FDDD29B2E7}"/>
+                <a16:creationId xmlns:a16="http://schemas.microsoft.com/office/drawing/2014/main" id="{52073997-067F-2E3E-4CAA-55CCFF421A56}"/>
               </a:ext>
             </a:extLst>
           </p:cNvPr>
@@ -2756,7 +2756,7 @@
           <a:bodyPr/>
           <a:lstStyle/>
           <a:p>
-            <a:fld id="{EF41EA56-A879-4DA1-9200-527E75E644FC}" type="slidenum">
+            <a:fld id="{2865BCB8-0C88-4FC1-96D7-FA9A8E2C4D3A}" type="slidenum">
               <a:rPr lang="en-US" smtClean="0"/>
               <a:t>‹#›</a:t>
             </a:fld>
@@ -2767,7 +2767,7 @@
     </p:spTree>
     <p:extLst>
       <p:ext uri="{BB962C8B-B14F-4D97-AF65-F5344CB8AC3E}">
-        <p14:creationId xmlns:p14="http://schemas.microsoft.com/office/powerpoint/2010/main" val="3697617580"/>
+        <p14:creationId xmlns:p14="http://schemas.microsoft.com/office/powerpoint/2010/main" val="2934827788"/>
       </p:ext>
     </p:extLst>
   </p:cSld>
@@ -2799,7 +2799,7 @@
           <p:cNvPr id="2" name="Title 1">
             <a:extLst>
               <a:ext uri="{FF2B5EF4-FFF2-40B4-BE49-F238E27FC236}">
-                <a16:creationId xmlns:a16="http://schemas.microsoft.com/office/drawing/2014/main" id="{6E52AE8B-8A3C-60B3-0B94-689EC9513253}"/>
+                <a16:creationId xmlns:a16="http://schemas.microsoft.com/office/drawing/2014/main" id="{C49EA50F-0C52-7937-322C-D962D7C85F65}"/>
               </a:ext>
             </a:extLst>
           </p:cNvPr>
@@ -2836,7 +2836,7 @@
           <p:cNvPr id="3" name="Text Placeholder 2">
             <a:extLst>
               <a:ext uri="{FF2B5EF4-FFF2-40B4-BE49-F238E27FC236}">
-                <a16:creationId xmlns:a16="http://schemas.microsoft.com/office/drawing/2014/main" id="{BB5EE90A-845F-FCD4-D16E-FB28CBA191D3}"/>
+                <a16:creationId xmlns:a16="http://schemas.microsoft.com/office/drawing/2014/main" id="{4B6190EA-4FF9-2502-A69A-DC3D8F3770BB}"/>
               </a:ext>
             </a:extLst>
           </p:cNvPr>
@@ -2961,7 +2961,7 @@
           <p:cNvPr id="4" name="Date Placeholder 3">
             <a:extLst>
               <a:ext uri="{FF2B5EF4-FFF2-40B4-BE49-F238E27FC236}">
-                <a16:creationId xmlns:a16="http://schemas.microsoft.com/office/drawing/2014/main" id="{7DAD9102-22D6-6937-09C2-AF7E14162BD6}"/>
+                <a16:creationId xmlns:a16="http://schemas.microsoft.com/office/drawing/2014/main" id="{F7BDBFE3-9104-EF2E-C633-B8B3D4EDFE25}"/>
               </a:ext>
             </a:extLst>
           </p:cNvPr>
@@ -2977,9 +2977,9 @@
           <a:bodyPr/>
           <a:lstStyle/>
           <a:p>
-            <a:fld id="{A6BAA431-359D-4C1A-9B3A-7EAB5F6A80FB}" type="datetimeFigureOut">
+            <a:fld id="{7C1452FA-4B05-4D50-9D4B-B5BDEE9852A8}" type="datetimeFigureOut">
               <a:rPr lang="en-US" smtClean="0"/>
-              <a:t>8/26/2026</a:t>
+              <a:t>8/27/2026</a:t>
             </a:fld>
             <a:endParaRPr lang="en-US"/>
           </a:p>
@@ -2990,7 +2990,7 @@
           <p:cNvPr id="5" name="Footer Placeholder 4">
             <a:extLst>
               <a:ext uri="{FF2B5EF4-FFF2-40B4-BE49-F238E27FC236}">
-                <a16:creationId xmlns:a16="http://schemas.microsoft.com/office/drawing/2014/main" id="{F96EEB8F-8869-D58C-6D66-D66A26F67618}"/>
+                <a16:creationId xmlns:a16="http://schemas.microsoft.com/office/drawing/2014/main" id="{B5604DD5-2F73-35AD-2880-86C1E8061F7E}"/>
               </a:ext>
             </a:extLst>
           </p:cNvPr>
@@ -3015,7 +3015,7 @@
           <p:cNvPr id="6" name="Slide Number Placeholder 5">
             <a:extLst>
               <a:ext uri="{FF2B5EF4-FFF2-40B4-BE49-F238E27FC236}">
-                <a16:creationId xmlns:a16="http://schemas.microsoft.com/office/drawing/2014/main" id="{F8CCF2F1-22AC-96E7-A3A8-F8748326CBD3}"/>
+                <a16:creationId xmlns:a16="http://schemas.microsoft.com/office/drawing/2014/main" id="{BE5D45D9-E461-6FC3-0CD7-36BF9C06A22A}"/>
               </a:ext>
             </a:extLst>
           </p:cNvPr>
@@ -3031,7 +3031,7 @@
           <a:bodyPr/>
           <a:lstStyle/>
           <a:p>
-            <a:fld id="{EF41EA56-A879-4DA1-9200-527E75E644FC}" type="slidenum">
+            <a:fld id="{2865BCB8-0C88-4FC1-96D7-FA9A8E2C4D3A}" type="slidenum">
               <a:rPr lang="en-US" smtClean="0"/>
               <a:t>‹#›</a:t>
             </a:fld>
@@ -3042,7 +3042,7 @@
     </p:spTree>
     <p:extLst>
       <p:ext uri="{BB962C8B-B14F-4D97-AF65-F5344CB8AC3E}">
-        <p14:creationId xmlns:p14="http://schemas.microsoft.com/office/powerpoint/2010/main" val="2877170943"/>
+        <p14:creationId xmlns:p14="http://schemas.microsoft.com/office/powerpoint/2010/main" val="2396495636"/>
       </p:ext>
     </p:extLst>
   </p:cSld>
@@ -3074,7 +3074,7 @@
           <p:cNvPr id="2" name="Title 1">
             <a:extLst>
               <a:ext uri="{FF2B5EF4-FFF2-40B4-BE49-F238E27FC236}">
-                <a16:creationId xmlns:a16="http://schemas.microsoft.com/office/drawing/2014/main" id="{8B655D19-649B-B8EA-E45E-95030578DCA8}"/>
+                <a16:creationId xmlns:a16="http://schemas.microsoft.com/office/drawing/2014/main" id="{D369E5B1-5DB4-9703-FAA4-39C48939F187}"/>
               </a:ext>
             </a:extLst>
           </p:cNvPr>
@@ -3102,7 +3102,7 @@
           <p:cNvPr id="3" name="Content Placeholder 2">
             <a:extLst>
               <a:ext uri="{FF2B5EF4-FFF2-40B4-BE49-F238E27FC236}">
-                <a16:creationId xmlns:a16="http://schemas.microsoft.com/office/drawing/2014/main" id="{6381BCF4-D403-5AFD-72E9-52E9AC80A0E1}"/>
+                <a16:creationId xmlns:a16="http://schemas.microsoft.com/office/drawing/2014/main" id="{3E5BD140-72DA-2863-757A-04EF888D0A43}"/>
               </a:ext>
             </a:extLst>
           </p:cNvPr>
@@ -3164,7 +3164,7 @@
           <p:cNvPr id="4" name="Content Placeholder 3">
             <a:extLst>
               <a:ext uri="{FF2B5EF4-FFF2-40B4-BE49-F238E27FC236}">
-                <a16:creationId xmlns:a16="http://schemas.microsoft.com/office/drawing/2014/main" id="{339A02DA-0E7B-9567-69C9-54C94DD50FFF}"/>
+                <a16:creationId xmlns:a16="http://schemas.microsoft.com/office/drawing/2014/main" id="{62C9371D-6D93-DA41-F037-FA5E6A9B935A}"/>
               </a:ext>
             </a:extLst>
           </p:cNvPr>
@@ -3226,7 +3226,7 @@
           <p:cNvPr id="5" name="Date Placeholder 4">
             <a:extLst>
               <a:ext uri="{FF2B5EF4-FFF2-40B4-BE49-F238E27FC236}">
-                <a16:creationId xmlns:a16="http://schemas.microsoft.com/office/drawing/2014/main" id="{9AEC41E9-62EA-B280-94E8-14F3FBDC41AF}"/>
+                <a16:creationId xmlns:a16="http://schemas.microsoft.com/office/drawing/2014/main" id="{D127769A-22BA-A1B2-A4D7-E387B6A46E3A}"/>
               </a:ext>
             </a:extLst>
           </p:cNvPr>
@@ -3242,9 +3242,9 @@
           <a:bodyPr/>
           <a:lstStyle/>
           <a:p>
-            <a:fld id="{A6BAA431-359D-4C1A-9B3A-7EAB5F6A80FB}" type="datetimeFigureOut">
+            <a:fld id="{7C1452FA-4B05-4D50-9D4B-B5BDEE9852A8}" type="datetimeFigureOut">
               <a:rPr lang="en-US" smtClean="0"/>
-              <a:t>8/26/2026</a:t>
+              <a:t>8/27/2026</a:t>
             </a:fld>
             <a:endParaRPr lang="en-US"/>
           </a:p>
@@ -3255,7 +3255,7 @@
           <p:cNvPr id="6" name="Footer Placeholder 5">
             <a:extLst>
               <a:ext uri="{FF2B5EF4-FFF2-40B4-BE49-F238E27FC236}">
-                <a16:creationId xmlns:a16="http://schemas.microsoft.com/office/drawing/2014/main" id="{5D8334C3-0D23-6B75-DB5F-D009CAA4004B}"/>
+                <a16:creationId xmlns:a16="http://schemas.microsoft.com/office/drawing/2014/main" id="{EF191833-25A3-BDC5-3139-1798DD5CA144}"/>
               </a:ext>
             </a:extLst>
           </p:cNvPr>
@@ -3280,7 +3280,7 @@
           <p:cNvPr id="7" name="Slide Number Placeholder 6">
             <a:extLst>
               <a:ext uri="{FF2B5EF4-FFF2-40B4-BE49-F238E27FC236}">
-                <a16:creationId xmlns:a16="http://schemas.microsoft.com/office/drawing/2014/main" id="{5E220E9B-9EA9-FFA7-0EBA-C56EA9E2211F}"/>
+                <a16:creationId xmlns:a16="http://schemas.microsoft.com/office/drawing/2014/main" id="{2D7DA7E9-8CF0-CC5B-F548-A049E31A14B0}"/>
               </a:ext>
             </a:extLst>
           </p:cNvPr>
@@ -3296,7 +3296,7 @@
           <a:bodyPr/>
           <a:lstStyle/>
           <a:p>
-            <a:fld id="{EF41EA56-A879-4DA1-9200-527E75E644FC}" type="slidenum">
+            <a:fld id="{2865BCB8-0C88-4FC1-96D7-FA9A8E2C4D3A}" type="slidenum">
               <a:rPr lang="en-US" smtClean="0"/>
               <a:t>‹#›</a:t>
             </a:fld>
@@ -3307,7 +3307,7 @@
     </p:spTree>
     <p:extLst>
       <p:ext uri="{BB962C8B-B14F-4D97-AF65-F5344CB8AC3E}">
-        <p14:creationId xmlns:p14="http://schemas.microsoft.com/office/powerpoint/2010/main" val="2705909814"/>
+        <p14:creationId xmlns:p14="http://schemas.microsoft.com/office/powerpoint/2010/main" val="4247593966"/>
       </p:ext>
     </p:extLst>
   </p:cSld>
@@ -3339,7 +3339,7 @@
           <p:cNvPr id="2" name="Title 1">
             <a:extLst>
               <a:ext uri="{FF2B5EF4-FFF2-40B4-BE49-F238E27FC236}">
-                <a16:creationId xmlns:a16="http://schemas.microsoft.com/office/drawing/2014/main" id="{A3F4F516-81DE-9E3A-DBEC-41BCA1AE8235}"/>
+                <a16:creationId xmlns:a16="http://schemas.microsoft.com/office/drawing/2014/main" id="{AE4F3B64-D064-D09B-7F71-7AC78D5573CC}"/>
               </a:ext>
             </a:extLst>
           </p:cNvPr>
@@ -3372,7 +3372,7 @@
           <p:cNvPr id="3" name="Text Placeholder 2">
             <a:extLst>
               <a:ext uri="{FF2B5EF4-FFF2-40B4-BE49-F238E27FC236}">
-                <a16:creationId xmlns:a16="http://schemas.microsoft.com/office/drawing/2014/main" id="{6D40D53C-585E-AF58-5226-AC9A5AA025AF}"/>
+                <a16:creationId xmlns:a16="http://schemas.microsoft.com/office/drawing/2014/main" id="{73ADDA3E-FBC5-220E-A3F7-D0D4B394C9FB}"/>
               </a:ext>
             </a:extLst>
           </p:cNvPr>
@@ -3443,7 +3443,7 @@
           <p:cNvPr id="4" name="Content Placeholder 3">
             <a:extLst>
               <a:ext uri="{FF2B5EF4-FFF2-40B4-BE49-F238E27FC236}">
-                <a16:creationId xmlns:a16="http://schemas.microsoft.com/office/drawing/2014/main" id="{210F136C-C0F5-B64C-B912-706C70D7110A}"/>
+                <a16:creationId xmlns:a16="http://schemas.microsoft.com/office/drawing/2014/main" id="{95D44360-406E-2CDC-CDDE-FC5CD7DBA031}"/>
               </a:ext>
             </a:extLst>
           </p:cNvPr>
@@ -3505,7 +3505,7 @@
           <p:cNvPr id="5" name="Text Placeholder 4">
             <a:extLst>
               <a:ext uri="{FF2B5EF4-FFF2-40B4-BE49-F238E27FC236}">
-                <a16:creationId xmlns:a16="http://schemas.microsoft.com/office/drawing/2014/main" id="{D5EE8ADF-606B-45D4-AD66-E511C115BD63}"/>
+                <a16:creationId xmlns:a16="http://schemas.microsoft.com/office/drawing/2014/main" id="{A464D964-AF18-9DAF-49A3-CAC6AC804858}"/>
               </a:ext>
             </a:extLst>
           </p:cNvPr>
@@ -3576,7 +3576,7 @@
           <p:cNvPr id="6" name="Content Placeholder 5">
             <a:extLst>
               <a:ext uri="{FF2B5EF4-FFF2-40B4-BE49-F238E27FC236}">
-                <a16:creationId xmlns:a16="http://schemas.microsoft.com/office/drawing/2014/main" id="{22D76F10-E473-6433-0A78-A9821745E454}"/>
+                <a16:creationId xmlns:a16="http://schemas.microsoft.com/office/drawing/2014/main" id="{2D894DA9-707B-2AC3-7F03-96918994F086}"/>
               </a:ext>
             </a:extLst>
           </p:cNvPr>
@@ -3638,7 +3638,7 @@
           <p:cNvPr id="7" name="Date Placeholder 6">
             <a:extLst>
               <a:ext uri="{FF2B5EF4-FFF2-40B4-BE49-F238E27FC236}">
-                <a16:creationId xmlns:a16="http://schemas.microsoft.com/office/drawing/2014/main" id="{895DB758-65E8-D860-A094-6A899F82D4A9}"/>
+                <a16:creationId xmlns:a16="http://schemas.microsoft.com/office/drawing/2014/main" id="{B94FCF2D-98CB-8DEA-0BA8-0D667EBBCA0F}"/>
               </a:ext>
             </a:extLst>
           </p:cNvPr>
@@ -3654,9 +3654,9 @@
           <a:bodyPr/>
           <a:lstStyle/>
           <a:p>
-            <a:fld id="{A6BAA431-359D-4C1A-9B3A-7EAB5F6A80FB}" type="datetimeFigureOut">
+            <a:fld id="{7C1452FA-4B05-4D50-9D4B-B5BDEE9852A8}" type="datetimeFigureOut">
               <a:rPr lang="en-US" smtClean="0"/>
-              <a:t>8/26/2026</a:t>
+              <a:t>8/27/2026</a:t>
             </a:fld>
             <a:endParaRPr lang="en-US"/>
           </a:p>
@@ -3667,7 +3667,7 @@
           <p:cNvPr id="8" name="Footer Placeholder 7">
             <a:extLst>
               <a:ext uri="{FF2B5EF4-FFF2-40B4-BE49-F238E27FC236}">
-                <a16:creationId xmlns:a16="http://schemas.microsoft.com/office/drawing/2014/main" id="{CD12B0CE-E0FE-C042-5F29-4FE78CDCD683}"/>
+                <a16:creationId xmlns:a16="http://schemas.microsoft.com/office/drawing/2014/main" id="{88E1CEF2-5621-F965-E20F-43111BF55E96}"/>
               </a:ext>
             </a:extLst>
           </p:cNvPr>
@@ -3692,7 +3692,7 @@
           <p:cNvPr id="9" name="Slide Number Placeholder 8">
             <a:extLst>
               <a:ext uri="{FF2B5EF4-FFF2-40B4-BE49-F238E27FC236}">
-                <a16:creationId xmlns:a16="http://schemas.microsoft.com/office/drawing/2014/main" id="{88083181-3F1C-868A-32A8-B308A5563E57}"/>
+                <a16:creationId xmlns:a16="http://schemas.microsoft.com/office/drawing/2014/main" id="{AD35DD33-7507-36C5-CE21-8E033D34D138}"/>
               </a:ext>
             </a:extLst>
           </p:cNvPr>
@@ -3708,7 +3708,7 @@
           <a:bodyPr/>
           <a:lstStyle/>
           <a:p>
-            <a:fld id="{EF41EA56-A879-4DA1-9200-527E75E644FC}" type="slidenum">
+            <a:fld id="{2865BCB8-0C88-4FC1-96D7-FA9A8E2C4D3A}" type="slidenum">
               <a:rPr lang="en-US" smtClean="0"/>
               <a:t>‹#›</a:t>
             </a:fld>
@@ -3719,7 +3719,7 @@
     </p:spTree>
     <p:extLst>
       <p:ext uri="{BB962C8B-B14F-4D97-AF65-F5344CB8AC3E}">
-        <p14:creationId xmlns:p14="http://schemas.microsoft.com/office/powerpoint/2010/main" val="3441585368"/>
+        <p14:creationId xmlns:p14="http://schemas.microsoft.com/office/powerpoint/2010/main" val="3283110740"/>
       </p:ext>
     </p:extLst>
   </p:cSld>
@@ -3751,7 +3751,7 @@
           <p:cNvPr id="2" name="Title 1">
             <a:extLst>
               <a:ext uri="{FF2B5EF4-FFF2-40B4-BE49-F238E27FC236}">
-                <a16:creationId xmlns:a16="http://schemas.microsoft.com/office/drawing/2014/main" id="{ADC0A27A-49FD-2499-0ED5-3C97BD68DD94}"/>
+                <a16:creationId xmlns:a16="http://schemas.microsoft.com/office/drawing/2014/main" id="{F3BE2B24-FA52-BF6E-CAEA-59D76EC4A485}"/>
               </a:ext>
             </a:extLst>
           </p:cNvPr>
@@ -3779,7 +3779,7 @@
           <p:cNvPr id="3" name="Date Placeholder 2">
             <a:extLst>
               <a:ext uri="{FF2B5EF4-FFF2-40B4-BE49-F238E27FC236}">
-                <a16:creationId xmlns:a16="http://schemas.microsoft.com/office/drawing/2014/main" id="{87BBFB05-9A8F-9D30-1C06-59EF7ECDEC53}"/>
+                <a16:creationId xmlns:a16="http://schemas.microsoft.com/office/drawing/2014/main" id="{F7521CF5-1D7C-EFD0-83D6-39E8D8F27FC2}"/>
               </a:ext>
             </a:extLst>
           </p:cNvPr>
@@ -3795,9 +3795,9 @@
           <a:bodyPr/>
           <a:lstStyle/>
           <a:p>
-            <a:fld id="{A6BAA431-359D-4C1A-9B3A-7EAB5F6A80FB}" type="datetimeFigureOut">
+            <a:fld id="{7C1452FA-4B05-4D50-9D4B-B5BDEE9852A8}" type="datetimeFigureOut">
               <a:rPr lang="en-US" smtClean="0"/>
-              <a:t>8/26/2026</a:t>
+              <a:t>8/27/2026</a:t>
             </a:fld>
             <a:endParaRPr lang="en-US"/>
           </a:p>
@@ -3808,7 +3808,7 @@
           <p:cNvPr id="4" name="Footer Placeholder 3">
             <a:extLst>
               <a:ext uri="{FF2B5EF4-FFF2-40B4-BE49-F238E27FC236}">
-                <a16:creationId xmlns:a16="http://schemas.microsoft.com/office/drawing/2014/main" id="{4445959C-8CED-A574-03DE-844066EBE58B}"/>
+                <a16:creationId xmlns:a16="http://schemas.microsoft.com/office/drawing/2014/main" id="{C8535A8E-B281-FC0F-DDB1-32108C9781F7}"/>
               </a:ext>
             </a:extLst>
           </p:cNvPr>
@@ -3833,7 +3833,7 @@
           <p:cNvPr id="5" name="Slide Number Placeholder 4">
             <a:extLst>
               <a:ext uri="{FF2B5EF4-FFF2-40B4-BE49-F238E27FC236}">
-                <a16:creationId xmlns:a16="http://schemas.microsoft.com/office/drawing/2014/main" id="{E71D9945-0893-863E-2827-8107117C597B}"/>
+                <a16:creationId xmlns:a16="http://schemas.microsoft.com/office/drawing/2014/main" id="{F6C8FA72-7470-EF1C-2CE5-73A1262E70FF}"/>
               </a:ext>
             </a:extLst>
           </p:cNvPr>
@@ -3849,7 +3849,7 @@
           <a:bodyPr/>
           <a:lstStyle/>
           <a:p>
-            <a:fld id="{EF41EA56-A879-4DA1-9200-527E75E644FC}" type="slidenum">
+            <a:fld id="{2865BCB8-0C88-4FC1-96D7-FA9A8E2C4D3A}" type="slidenum">
               <a:rPr lang="en-US" smtClean="0"/>
               <a:t>‹#›</a:t>
             </a:fld>
@@ -3860,7 +3860,7 @@
     </p:spTree>
     <p:extLst>
       <p:ext uri="{BB962C8B-B14F-4D97-AF65-F5344CB8AC3E}">
-        <p14:creationId xmlns:p14="http://schemas.microsoft.com/office/powerpoint/2010/main" val="3205356220"/>
+        <p14:creationId xmlns:p14="http://schemas.microsoft.com/office/powerpoint/2010/main" val="1048654581"/>
       </p:ext>
     </p:extLst>
   </p:cSld>
@@ -3892,7 +3892,7 @@
           <p:cNvPr id="2" name="Date Placeholder 1">
             <a:extLst>
               <a:ext uri="{FF2B5EF4-FFF2-40B4-BE49-F238E27FC236}">
-                <a16:creationId xmlns:a16="http://schemas.microsoft.com/office/drawing/2014/main" id="{09B6A020-5865-1EC0-DE4D-C485D037E858}"/>
+                <a16:creationId xmlns:a16="http://schemas.microsoft.com/office/drawing/2014/main" id="{4B1241E1-93D4-D88B-EE2C-DE29CABE4C73}"/>
               </a:ext>
             </a:extLst>
           </p:cNvPr>
@@ -3908,9 +3908,9 @@
           <a:bodyPr/>
           <a:lstStyle/>
           <a:p>
-            <a:fld id="{A6BAA431-359D-4C1A-9B3A-7EAB5F6A80FB}" type="datetimeFigureOut">
+            <a:fld id="{7C1452FA-4B05-4D50-9D4B-B5BDEE9852A8}" type="datetimeFigureOut">
               <a:rPr lang="en-US" smtClean="0"/>
-              <a:t>8/26/2026</a:t>
+              <a:t>8/27/2026</a:t>
             </a:fld>
             <a:endParaRPr lang="en-US"/>
           </a:p>
@@ -3921,7 +3921,7 @@
           <p:cNvPr id="3" name="Footer Placeholder 2">
             <a:extLst>
               <a:ext uri="{FF2B5EF4-FFF2-40B4-BE49-F238E27FC236}">
-                <a16:creationId xmlns:a16="http://schemas.microsoft.com/office/drawing/2014/main" id="{964C3FCD-8173-CD32-92AA-58FDE6C068B0}"/>
+                <a16:creationId xmlns:a16="http://schemas.microsoft.com/office/drawing/2014/main" id="{6DBEE740-F404-4FAC-C105-5D85EBFD8C3E}"/>
               </a:ext>
             </a:extLst>
           </p:cNvPr>
@@ -3946,7 +3946,7 @@
           <p:cNvPr id="4" name="Slide Number Placeholder 3">
             <a:extLst>
               <a:ext uri="{FF2B5EF4-FFF2-40B4-BE49-F238E27FC236}">
-                <a16:creationId xmlns:a16="http://schemas.microsoft.com/office/drawing/2014/main" id="{7903E558-5E38-9C74-73E1-054A7D23E94A}"/>
+                <a16:creationId xmlns:a16="http://schemas.microsoft.com/office/drawing/2014/main" id="{ABB2D972-D245-5657-0DFD-95FC7F70A3CA}"/>
               </a:ext>
             </a:extLst>
           </p:cNvPr>
@@ -3962,7 +3962,7 @@
           <a:bodyPr/>
           <a:lstStyle/>
           <a:p>
-            <a:fld id="{EF41EA56-A879-4DA1-9200-527E75E644FC}" type="slidenum">
+            <a:fld id="{2865BCB8-0C88-4FC1-96D7-FA9A8E2C4D3A}" type="slidenum">
               <a:rPr lang="en-US" smtClean="0"/>
               <a:t>‹#›</a:t>
             </a:fld>
@@ -3973,7 +3973,7 @@
     </p:spTree>
     <p:extLst>
       <p:ext uri="{BB962C8B-B14F-4D97-AF65-F5344CB8AC3E}">
-        <p14:creationId xmlns:p14="http://schemas.microsoft.com/office/powerpoint/2010/main" val="4133891688"/>
+        <p14:creationId xmlns:p14="http://schemas.microsoft.com/office/powerpoint/2010/main" val="4207070119"/>
       </p:ext>
     </p:extLst>
   </p:cSld>
@@ -4005,7 +4005,7 @@
           <p:cNvPr id="2" name="Title 1">
             <a:extLst>
               <a:ext uri="{FF2B5EF4-FFF2-40B4-BE49-F238E27FC236}">
-                <a16:creationId xmlns:a16="http://schemas.microsoft.com/office/drawing/2014/main" id="{A469AA17-7137-B2F6-87C6-7630E35EB7C2}"/>
+                <a16:creationId xmlns:a16="http://schemas.microsoft.com/office/drawing/2014/main" id="{85591910-682C-FC5C-AD4E-95DE631E76EB}"/>
               </a:ext>
             </a:extLst>
           </p:cNvPr>
@@ -4042,7 +4042,7 @@
           <p:cNvPr id="3" name="Content Placeholder 2">
             <a:extLst>
               <a:ext uri="{FF2B5EF4-FFF2-40B4-BE49-F238E27FC236}">
-                <a16:creationId xmlns:a16="http://schemas.microsoft.com/office/drawing/2014/main" id="{3586C6E2-CEE8-4343-192D-E6C0A089C8E0}"/>
+                <a16:creationId xmlns:a16="http://schemas.microsoft.com/office/drawing/2014/main" id="{E0BA635A-3C16-2952-828D-86DF5EC07D57}"/>
               </a:ext>
             </a:extLst>
           </p:cNvPr>
@@ -4132,7 +4132,7 @@
           <p:cNvPr id="4" name="Text Placeholder 3">
             <a:extLst>
               <a:ext uri="{FF2B5EF4-FFF2-40B4-BE49-F238E27FC236}">
-                <a16:creationId xmlns:a16="http://schemas.microsoft.com/office/drawing/2014/main" id="{B037C518-5690-576C-AEDF-FD223CE1125C}"/>
+                <a16:creationId xmlns:a16="http://schemas.microsoft.com/office/drawing/2014/main" id="{7438A900-8FB1-C13A-8879-5A2B35D48F62}"/>
               </a:ext>
             </a:extLst>
           </p:cNvPr>
@@ -4203,7 +4203,7 @@
           <p:cNvPr id="5" name="Date Placeholder 4">
             <a:extLst>
               <a:ext uri="{FF2B5EF4-FFF2-40B4-BE49-F238E27FC236}">
-                <a16:creationId xmlns:a16="http://schemas.microsoft.com/office/drawing/2014/main" id="{38E8C9C7-ADD1-BD9B-A2CB-1D44828BD124}"/>
+                <a16:creationId xmlns:a16="http://schemas.microsoft.com/office/drawing/2014/main" id="{BD8331CF-094D-B665-AA44-881BBA2FE3FD}"/>
               </a:ext>
             </a:extLst>
           </p:cNvPr>
@@ -4219,9 +4219,9 @@
           <a:bodyPr/>
           <a:lstStyle/>
           <a:p>
-            <a:fld id="{A6BAA431-359D-4C1A-9B3A-7EAB5F6A80FB}" type="datetimeFigureOut">
+            <a:fld id="{7C1452FA-4B05-4D50-9D4B-B5BDEE9852A8}" type="datetimeFigureOut">
               <a:rPr lang="en-US" smtClean="0"/>
-              <a:t>8/26/2026</a:t>
+              <a:t>8/27/2026</a:t>
             </a:fld>
             <a:endParaRPr lang="en-US"/>
           </a:p>
@@ -4232,7 +4232,7 @@
           <p:cNvPr id="6" name="Footer Placeholder 5">
             <a:extLst>
               <a:ext uri="{FF2B5EF4-FFF2-40B4-BE49-F238E27FC236}">
-                <a16:creationId xmlns:a16="http://schemas.microsoft.com/office/drawing/2014/main" id="{9534B4CD-29DA-218C-22DA-AC93C490FA66}"/>
+                <a16:creationId xmlns:a16="http://schemas.microsoft.com/office/drawing/2014/main" id="{ED5E4212-80C8-C5BA-D705-93E1365AE88C}"/>
               </a:ext>
             </a:extLst>
           </p:cNvPr>
@@ -4257,7 +4257,7 @@
           <p:cNvPr id="7" name="Slide Number Placeholder 6">
             <a:extLst>
               <a:ext uri="{FF2B5EF4-FFF2-40B4-BE49-F238E27FC236}">
-                <a16:creationId xmlns:a16="http://schemas.microsoft.com/office/drawing/2014/main" id="{D7439749-B534-7966-4A66-612A65CF6F73}"/>
+                <a16:creationId xmlns:a16="http://schemas.microsoft.com/office/drawing/2014/main" id="{1F219717-465A-6CCF-6D12-7FFF02C67625}"/>
               </a:ext>
             </a:extLst>
           </p:cNvPr>
@@ -4273,7 +4273,7 @@
           <a:bodyPr/>
           <a:lstStyle/>
           <a:p>
-            <a:fld id="{EF41EA56-A879-4DA1-9200-527E75E644FC}" type="slidenum">
+            <a:fld id="{2865BCB8-0C88-4FC1-96D7-FA9A8E2C4D3A}" type="slidenum">
               <a:rPr lang="en-US" smtClean="0"/>
               <a:t>‹#›</a:t>
             </a:fld>
@@ -4284,7 +4284,7 @@
     </p:spTree>
     <p:extLst>
       <p:ext uri="{BB962C8B-B14F-4D97-AF65-F5344CB8AC3E}">
-        <p14:creationId xmlns:p14="http://schemas.microsoft.com/office/powerpoint/2010/main" val="3646900404"/>
+        <p14:creationId xmlns:p14="http://schemas.microsoft.com/office/powerpoint/2010/main" val="28576324"/>
       </p:ext>
     </p:extLst>
   </p:cSld>
@@ -4316,7 +4316,7 @@
           <p:cNvPr id="2" name="Title 1">
             <a:extLst>
               <a:ext uri="{FF2B5EF4-FFF2-40B4-BE49-F238E27FC236}">
-                <a16:creationId xmlns:a16="http://schemas.microsoft.com/office/drawing/2014/main" id="{23C923E3-DF57-41FF-822B-9BBB5C1BDC7E}"/>
+                <a16:creationId xmlns:a16="http://schemas.microsoft.com/office/drawing/2014/main" id="{CAD4BBAC-8697-0A25-0C0C-3E5756B7889A}"/>
               </a:ext>
             </a:extLst>
           </p:cNvPr>
@@ -4353,7 +4353,7 @@
           <p:cNvPr id="3" name="Picture Placeholder 2">
             <a:extLst>
               <a:ext uri="{FF2B5EF4-FFF2-40B4-BE49-F238E27FC236}">
-                <a16:creationId xmlns:a16="http://schemas.microsoft.com/office/drawing/2014/main" id="{7EF5323C-7B3E-8CE2-8198-AF2085118342}"/>
+                <a16:creationId xmlns:a16="http://schemas.microsoft.com/office/drawing/2014/main" id="{F6B486D5-EE62-3903-CB99-E702E97524E5}"/>
               </a:ext>
             </a:extLst>
           </p:cNvPr>
@@ -4420,7 +4420,7 @@
           <p:cNvPr id="4" name="Text Placeholder 3">
             <a:extLst>
               <a:ext uri="{FF2B5EF4-FFF2-40B4-BE49-F238E27FC236}">
-                <a16:creationId xmlns:a16="http://schemas.microsoft.com/office/drawing/2014/main" id="{1EA0F6F7-682F-2894-FECF-765A57ECDCFB}"/>
+                <a16:creationId xmlns:a16="http://schemas.microsoft.com/office/drawing/2014/main" id="{4772A0F5-200B-95DA-4340-94B9667D409E}"/>
               </a:ext>
             </a:extLst>
           </p:cNvPr>
@@ -4491,7 +4491,7 @@
           <p:cNvPr id="5" name="Date Placeholder 4">
             <a:extLst>
               <a:ext uri="{FF2B5EF4-FFF2-40B4-BE49-F238E27FC236}">
-                <a16:creationId xmlns:a16="http://schemas.microsoft.com/office/drawing/2014/main" id="{0F093097-05DA-DC79-598B-FEA5A1658803}"/>
+                <a16:creationId xmlns:a16="http://schemas.microsoft.com/office/drawing/2014/main" id="{61B42D8D-8CF8-408B-3EF1-35B6E3848387}"/>
               </a:ext>
             </a:extLst>
           </p:cNvPr>
@@ -4507,9 +4507,9 @@
           <a:bodyPr/>
           <a:lstStyle/>
           <a:p>
-            <a:fld id="{A6BAA431-359D-4C1A-9B3A-7EAB5F6A80FB}" type="datetimeFigureOut">
+            <a:fld id="{7C1452FA-4B05-4D50-9D4B-B5BDEE9852A8}" type="datetimeFigureOut">
               <a:rPr lang="en-US" smtClean="0"/>
-              <a:t>8/26/2026</a:t>
+              <a:t>8/27/2026</a:t>
             </a:fld>
             <a:endParaRPr lang="en-US"/>
           </a:p>
@@ -4520,7 +4520,7 @@
           <p:cNvPr id="6" name="Footer Placeholder 5">
             <a:extLst>
               <a:ext uri="{FF2B5EF4-FFF2-40B4-BE49-F238E27FC236}">
-                <a16:creationId xmlns:a16="http://schemas.microsoft.com/office/drawing/2014/main" id="{863921FF-589E-B8E9-E219-E605F56A8ABD}"/>
+                <a16:creationId xmlns:a16="http://schemas.microsoft.com/office/drawing/2014/main" id="{C3699054-880A-4B07-A03F-61DD2A52F801}"/>
               </a:ext>
             </a:extLst>
           </p:cNvPr>
@@ -4545,7 +4545,7 @@
           <p:cNvPr id="7" name="Slide Number Placeholder 6">
             <a:extLst>
               <a:ext uri="{FF2B5EF4-FFF2-40B4-BE49-F238E27FC236}">
-                <a16:creationId xmlns:a16="http://schemas.microsoft.com/office/drawing/2014/main" id="{CA87B654-A48B-83A6-A70B-CD417A8D1E25}"/>
+                <a16:creationId xmlns:a16="http://schemas.microsoft.com/office/drawing/2014/main" id="{63D7718C-E7C0-9AEB-4F10-A36F6E404B11}"/>
               </a:ext>
             </a:extLst>
           </p:cNvPr>
@@ -4561,7 +4561,7 @@
           <a:bodyPr/>
           <a:lstStyle/>
           <a:p>
-            <a:fld id="{EF41EA56-A879-4DA1-9200-527E75E644FC}" type="slidenum">
+            <a:fld id="{2865BCB8-0C88-4FC1-96D7-FA9A8E2C4D3A}" type="slidenum">
               <a:rPr lang="en-US" smtClean="0"/>
               <a:t>‹#›</a:t>
             </a:fld>
@@ -4572,7 +4572,7 @@
     </p:spTree>
     <p:extLst>
       <p:ext uri="{BB962C8B-B14F-4D97-AF65-F5344CB8AC3E}">
-        <p14:creationId xmlns:p14="http://schemas.microsoft.com/office/powerpoint/2010/main" val="463861391"/>
+        <p14:creationId xmlns:p14="http://schemas.microsoft.com/office/powerpoint/2010/main" val="209690494"/>
       </p:ext>
     </p:extLst>
   </p:cSld>
@@ -4609,7 +4609,7 @@
           <p:cNvPr id="2" name="Title Placeholder 1">
             <a:extLst>
               <a:ext uri="{FF2B5EF4-FFF2-40B4-BE49-F238E27FC236}">
-                <a16:creationId xmlns:a16="http://schemas.microsoft.com/office/drawing/2014/main" id="{5DEC0136-CD9C-772A-E5C7-534AFB8D895A}"/>
+                <a16:creationId xmlns:a16="http://schemas.microsoft.com/office/drawing/2014/main" id="{9157D37A-E94C-C303-6499-A8E3020566AA}"/>
               </a:ext>
             </a:extLst>
           </p:cNvPr>
@@ -4647,7 +4647,7 @@
           <p:cNvPr id="3" name="Text Placeholder 2">
             <a:extLst>
               <a:ext uri="{FF2B5EF4-FFF2-40B4-BE49-F238E27FC236}">
-                <a16:creationId xmlns:a16="http://schemas.microsoft.com/office/drawing/2014/main" id="{2799F3F4-0BEB-D363-4A56-B00FBEF47E9E}"/>
+                <a16:creationId xmlns:a16="http://schemas.microsoft.com/office/drawing/2014/main" id="{F1F6477D-F2E5-931C-9352-B7FFEA30C76D}"/>
               </a:ext>
             </a:extLst>
           </p:cNvPr>
@@ -4714,7 +4714,7 @@
           <p:cNvPr id="4" name="Date Placeholder 3">
             <a:extLst>
               <a:ext uri="{FF2B5EF4-FFF2-40B4-BE49-F238E27FC236}">
-                <a16:creationId xmlns:a16="http://schemas.microsoft.com/office/drawing/2014/main" id="{CFAF9DDB-8BDE-04DA-BA22-B558CB41429C}"/>
+                <a16:creationId xmlns:a16="http://schemas.microsoft.com/office/drawing/2014/main" id="{AA1A541B-ACBB-0506-95B4-5157F552C58C}"/>
               </a:ext>
             </a:extLst>
           </p:cNvPr>
@@ -4748,9 +4748,9 @@
             </a:lvl1pPr>
           </a:lstStyle>
           <a:p>
-            <a:fld id="{A6BAA431-359D-4C1A-9B3A-7EAB5F6A80FB}" type="datetimeFigureOut">
+            <a:fld id="{7C1452FA-4B05-4D50-9D4B-B5BDEE9852A8}" type="datetimeFigureOut">
               <a:rPr lang="en-US" smtClean="0"/>
-              <a:t>8/26/2026</a:t>
+              <a:t>8/27/2026</a:t>
             </a:fld>
             <a:endParaRPr lang="en-US"/>
           </a:p>
@@ -4761,7 +4761,7 @@
           <p:cNvPr id="5" name="Footer Placeholder 4">
             <a:extLst>
               <a:ext uri="{FF2B5EF4-FFF2-40B4-BE49-F238E27FC236}">
-                <a16:creationId xmlns:a16="http://schemas.microsoft.com/office/drawing/2014/main" id="{DFE930E5-A2D7-7E86-2D58-F9C2AC9EB353}"/>
+                <a16:creationId xmlns:a16="http://schemas.microsoft.com/office/drawing/2014/main" id="{CE007E54-5BC8-7D96-96D4-C4BD1C1B3425}"/>
               </a:ext>
             </a:extLst>
           </p:cNvPr>
@@ -4804,7 +4804,7 @@
           <p:cNvPr id="6" name="Slide Number Placeholder 5">
             <a:extLst>
               <a:ext uri="{FF2B5EF4-FFF2-40B4-BE49-F238E27FC236}">
-                <a16:creationId xmlns:a16="http://schemas.microsoft.com/office/drawing/2014/main" id="{7CC8E734-0720-8C09-1670-2E605239F2F3}"/>
+                <a16:creationId xmlns:a16="http://schemas.microsoft.com/office/drawing/2014/main" id="{9AE76C2E-BFE3-40DE-3CE3-DE1563D983BA}"/>
               </a:ext>
             </a:extLst>
           </p:cNvPr>
@@ -4838,7 +4838,7 @@
             </a:lvl1pPr>
           </a:lstStyle>
           <a:p>
-            <a:fld id="{EF41EA56-A879-4DA1-9200-527E75E644FC}" type="slidenum">
+            <a:fld id="{2865BCB8-0C88-4FC1-96D7-FA9A8E2C4D3A}" type="slidenum">
               <a:rPr lang="en-US" smtClean="0"/>
               <a:t>‹#›</a:t>
             </a:fld>
@@ -4849,7 +4849,7 @@
     </p:spTree>
     <p:extLst>
       <p:ext uri="{BB962C8B-B14F-4D97-AF65-F5344CB8AC3E}">
-        <p14:creationId xmlns:p14="http://schemas.microsoft.com/office/powerpoint/2010/main" val="1262005565"/>
+        <p14:creationId xmlns:p14="http://schemas.microsoft.com/office/powerpoint/2010/main" val="2005794855"/>
       </p:ext>
     </p:extLst>
   </p:cSld>
@@ -5180,7 +5180,7 @@
           <p:cNvPr id="2" name="TextBox 1">
             <a:extLst>
               <a:ext uri="{FF2B5EF4-FFF2-40B4-BE49-F238E27FC236}">
-                <a16:creationId xmlns:a16="http://schemas.microsoft.com/office/drawing/2014/main" id="{3562923B-D577-5D5A-7E6E-9E79E02EBFCA}"/>
+                <a16:creationId xmlns:a16="http://schemas.microsoft.com/office/drawing/2014/main" id="{46CB3C61-A763-CF07-D4E6-25BD2CB32CCA}"/>
               </a:ext>
             </a:extLst>
           </p:cNvPr>
@@ -5220,7 +5220,7 @@
           <p:cNvPr id="3" name="TextBox 2">
             <a:extLst>
               <a:ext uri="{FF2B5EF4-FFF2-40B4-BE49-F238E27FC236}">
-                <a16:creationId xmlns:a16="http://schemas.microsoft.com/office/drawing/2014/main" id="{95EF81A6-1394-680A-7545-0B144BB2A7E5}"/>
+                <a16:creationId xmlns:a16="http://schemas.microsoft.com/office/drawing/2014/main" id="{C6FE3814-715C-7742-6975-1918D853140A}"/>
               </a:ext>
             </a:extLst>
           </p:cNvPr>
@@ -5260,7 +5260,7 @@
           <p:cNvPr id="4" name="TextBox 3">
             <a:extLst>
               <a:ext uri="{FF2B5EF4-FFF2-40B4-BE49-F238E27FC236}">
-                <a16:creationId xmlns:a16="http://schemas.microsoft.com/office/drawing/2014/main" id="{09F827A7-2AD7-ED68-E1DA-9E82570BE372}"/>
+                <a16:creationId xmlns:a16="http://schemas.microsoft.com/office/drawing/2014/main" id="{7B4DDC1D-D0A5-1C96-3152-991F98AC5045}"/>
               </a:ext>
             </a:extLst>
           </p:cNvPr>
@@ -5300,7 +5300,7 @@
           <p:cNvPr id="5" name="Straight Connector 4">
             <a:extLst>
               <a:ext uri="{FF2B5EF4-FFF2-40B4-BE49-F238E27FC236}">
-                <a16:creationId xmlns:a16="http://schemas.microsoft.com/office/drawing/2014/main" id="{D61E0013-4A02-FE72-BC28-31B46E052B08}"/>
+                <a16:creationId xmlns:a16="http://schemas.microsoft.com/office/drawing/2014/main" id="{B20216F9-BE94-C0DF-E376-E9629F3C90F9}"/>
               </a:ext>
             </a:extLst>
           </p:cNvPr>
@@ -5341,7 +5341,7 @@
           <p:cNvPr id="6" name="TextBox 5">
             <a:extLst>
               <a:ext uri="{FF2B5EF4-FFF2-40B4-BE49-F238E27FC236}">
-                <a16:creationId xmlns:a16="http://schemas.microsoft.com/office/drawing/2014/main" id="{0A5B95BC-D321-4E01-F2F7-FE05F35C78B8}"/>
+                <a16:creationId xmlns:a16="http://schemas.microsoft.com/office/drawing/2014/main" id="{F9E451D2-F53B-8FA4-7B4F-6A30C4A7D07F}"/>
               </a:ext>
             </a:extLst>
           </p:cNvPr>
@@ -5387,7 +5387,7 @@
           <p:cNvPr id="7" name="TextBox 6">
             <a:extLst>
               <a:ext uri="{FF2B5EF4-FFF2-40B4-BE49-F238E27FC236}">
-                <a16:creationId xmlns:a16="http://schemas.microsoft.com/office/drawing/2014/main" id="{5979E183-3EB2-AEB0-02F3-BF7FBC51F02D}"/>
+                <a16:creationId xmlns:a16="http://schemas.microsoft.com/office/drawing/2014/main" id="{F4A0AB05-DD22-3D95-30E6-5AED0103A221}"/>
               </a:ext>
             </a:extLst>
           </p:cNvPr>
@@ -5427,7 +5427,7 @@
           <p:cNvPr id="8" name="TextBox 7">
             <a:extLst>
               <a:ext uri="{FF2B5EF4-FFF2-40B4-BE49-F238E27FC236}">
-                <a16:creationId xmlns:a16="http://schemas.microsoft.com/office/drawing/2014/main" id="{B81CBB8B-61B5-E6BF-C146-966121461904}"/>
+                <a16:creationId xmlns:a16="http://schemas.microsoft.com/office/drawing/2014/main" id="{F529106E-C908-92C2-C8E4-59F72AEE5E0B}"/>
               </a:ext>
             </a:extLst>
           </p:cNvPr>
@@ -5467,7 +5467,7 @@
           <p:cNvPr id="9" name="TextBox 8">
             <a:extLst>
               <a:ext uri="{FF2B5EF4-FFF2-40B4-BE49-F238E27FC236}">
-                <a16:creationId xmlns:a16="http://schemas.microsoft.com/office/drawing/2014/main" id="{50FB29F6-99EC-3772-7032-19287D9DC791}"/>
+                <a16:creationId xmlns:a16="http://schemas.microsoft.com/office/drawing/2014/main" id="{CFF473A5-25D0-9560-F152-DED05E9F855A}"/>
               </a:ext>
             </a:extLst>
           </p:cNvPr>
@@ -5505,7 +5505,7 @@
     </p:spTree>
     <p:extLst>
       <p:ext uri="{BB962C8B-B14F-4D97-AF65-F5344CB8AC3E}">
-        <p14:creationId xmlns:p14="http://schemas.microsoft.com/office/powerpoint/2010/main" val="4274303230"/>
+        <p14:creationId xmlns:p14="http://schemas.microsoft.com/office/powerpoint/2010/main" val="1706612588"/>
       </p:ext>
     </p:extLst>
   </p:cSld>
@@ -5545,7 +5545,7 @@
           <p:cNvPr id="2" name="TextBox 1">
             <a:extLst>
               <a:ext uri="{FF2B5EF4-FFF2-40B4-BE49-F238E27FC236}">
-                <a16:creationId xmlns:a16="http://schemas.microsoft.com/office/drawing/2014/main" id="{D9FE5F8F-504E-0DF4-DD8F-F41A11FF1521}"/>
+                <a16:creationId xmlns:a16="http://schemas.microsoft.com/office/drawing/2014/main" id="{D65E3B50-CA5F-4242-040D-64325ABFB687}"/>
               </a:ext>
             </a:extLst>
           </p:cNvPr>
@@ -5585,7 +5585,7 @@
           <p:cNvPr id="3" name="Straight Connector 2">
             <a:extLst>
               <a:ext uri="{FF2B5EF4-FFF2-40B4-BE49-F238E27FC236}">
-                <a16:creationId xmlns:a16="http://schemas.microsoft.com/office/drawing/2014/main" id="{A0F27F6D-1415-CDEF-EB98-7903362834B2}"/>
+                <a16:creationId xmlns:a16="http://schemas.microsoft.com/office/drawing/2014/main" id="{E04C12A8-416A-F2EC-EC45-0019F55012E5}"/>
               </a:ext>
             </a:extLst>
           </p:cNvPr>
@@ -5626,7 +5626,7 @@
           <p:cNvPr id="4" name="TextBox 3">
             <a:extLst>
               <a:ext uri="{FF2B5EF4-FFF2-40B4-BE49-F238E27FC236}">
-                <a16:creationId xmlns:a16="http://schemas.microsoft.com/office/drawing/2014/main" id="{648B6B61-7DE0-8D8F-F58F-B5A76579C188}"/>
+                <a16:creationId xmlns:a16="http://schemas.microsoft.com/office/drawing/2014/main" id="{A0379B67-6E5B-4EEB-FC2A-5351A8845E23}"/>
               </a:ext>
             </a:extLst>
           </p:cNvPr>
@@ -5667,7 +5667,7 @@
           <p:cNvPr id="5" name="TextBox 4">
             <a:extLst>
               <a:ext uri="{FF2B5EF4-FFF2-40B4-BE49-F238E27FC236}">
-                <a16:creationId xmlns:a16="http://schemas.microsoft.com/office/drawing/2014/main" id="{60E7715C-32B9-1FA9-58FF-E8AC46A3BFF6}"/>
+                <a16:creationId xmlns:a16="http://schemas.microsoft.com/office/drawing/2014/main" id="{C461A9B5-33F9-B246-1BB1-1C5C13AC10CF}"/>
               </a:ext>
             </a:extLst>
           </p:cNvPr>
@@ -5707,7 +5707,7 @@
           <p:cNvPr id="6" name="TextBox 5">
             <a:extLst>
               <a:ext uri="{FF2B5EF4-FFF2-40B4-BE49-F238E27FC236}">
-                <a16:creationId xmlns:a16="http://schemas.microsoft.com/office/drawing/2014/main" id="{4A88AA77-616C-B348-8996-34494E30BB20}"/>
+                <a16:creationId xmlns:a16="http://schemas.microsoft.com/office/drawing/2014/main" id="{906A23E6-2024-E8E7-22E1-15CF99BD2FD0}"/>
               </a:ext>
             </a:extLst>
           </p:cNvPr>
@@ -5747,7 +5747,7 @@
           <p:cNvPr id="7" name="TextBox 6">
             <a:extLst>
               <a:ext uri="{FF2B5EF4-FFF2-40B4-BE49-F238E27FC236}">
-                <a16:creationId xmlns:a16="http://schemas.microsoft.com/office/drawing/2014/main" id="{76846DC1-DB5E-A686-D081-DCA143135CAF}"/>
+                <a16:creationId xmlns:a16="http://schemas.microsoft.com/office/drawing/2014/main" id="{5AACD480-6980-9AF9-F9E5-53B3A2F5BC82}"/>
               </a:ext>
             </a:extLst>
           </p:cNvPr>
@@ -5787,7 +5787,7 @@
           <p:cNvPr id="8" name="TextBox 7">
             <a:extLst>
               <a:ext uri="{FF2B5EF4-FFF2-40B4-BE49-F238E27FC236}">
-                <a16:creationId xmlns:a16="http://schemas.microsoft.com/office/drawing/2014/main" id="{B35F01ED-2E01-4073-9629-42911EDE7528}"/>
+                <a16:creationId xmlns:a16="http://schemas.microsoft.com/office/drawing/2014/main" id="{7AE13EE3-D3D8-940B-5EA1-13D00089BE91}"/>
               </a:ext>
             </a:extLst>
           </p:cNvPr>
@@ -5827,7 +5827,7 @@
           <p:cNvPr id="9" name="TextBox 8">
             <a:extLst>
               <a:ext uri="{FF2B5EF4-FFF2-40B4-BE49-F238E27FC236}">
-                <a16:creationId xmlns:a16="http://schemas.microsoft.com/office/drawing/2014/main" id="{EDB0C787-B5B8-C3A3-3CED-E96D49467ABF}"/>
+                <a16:creationId xmlns:a16="http://schemas.microsoft.com/office/drawing/2014/main" id="{E437D3B4-3E10-415F-776B-D010EBC54AF8}"/>
               </a:ext>
             </a:extLst>
           </p:cNvPr>
@@ -5867,7 +5867,7 @@
           <p:cNvPr id="10" name="Rectangle 9">
             <a:extLst>
               <a:ext uri="{FF2B5EF4-FFF2-40B4-BE49-F238E27FC236}">
-                <a16:creationId xmlns:a16="http://schemas.microsoft.com/office/drawing/2014/main" id="{C9CEA29C-FBB2-7A8F-F615-95772E64E3BD}"/>
+                <a16:creationId xmlns:a16="http://schemas.microsoft.com/office/drawing/2014/main" id="{3B74B0EA-EC4A-CEC6-1514-D38005E1646A}"/>
               </a:ext>
             </a:extLst>
           </p:cNvPr>
@@ -5935,7 +5935,7 @@
           <p:cNvPr id="11" name="TextBox 10">
             <a:extLst>
               <a:ext uri="{FF2B5EF4-FFF2-40B4-BE49-F238E27FC236}">
-                <a16:creationId xmlns:a16="http://schemas.microsoft.com/office/drawing/2014/main" id="{C4D5F01E-C9CE-9215-11DF-04C58B8B406A}"/>
+                <a16:creationId xmlns:a16="http://schemas.microsoft.com/office/drawing/2014/main" id="{9ED19679-836E-FF3C-508E-CC51D3AF59FB}"/>
               </a:ext>
             </a:extLst>
           </p:cNvPr>
@@ -5975,7 +5975,7 @@
           <p:cNvPr id="12" name="TextBox 11">
             <a:extLst>
               <a:ext uri="{FF2B5EF4-FFF2-40B4-BE49-F238E27FC236}">
-                <a16:creationId xmlns:a16="http://schemas.microsoft.com/office/drawing/2014/main" id="{0827C317-DDF9-FBA9-6DD3-90D653757D3C}"/>
+                <a16:creationId xmlns:a16="http://schemas.microsoft.com/office/drawing/2014/main" id="{3D64A780-AC0A-367C-5151-66C491706ECB}"/>
               </a:ext>
             </a:extLst>
           </p:cNvPr>
@@ -6015,7 +6015,7 @@
           <p:cNvPr id="13" name="TextBox 12">
             <a:extLst>
               <a:ext uri="{FF2B5EF4-FFF2-40B4-BE49-F238E27FC236}">
-                <a16:creationId xmlns:a16="http://schemas.microsoft.com/office/drawing/2014/main" id="{67859033-341C-D96B-7B78-CF037C0CF73B}"/>
+                <a16:creationId xmlns:a16="http://schemas.microsoft.com/office/drawing/2014/main" id="{EC69307D-0AB3-89E6-DA76-F755CD9FE31B}"/>
               </a:ext>
             </a:extLst>
           </p:cNvPr>
@@ -6055,7 +6055,7 @@
           <p:cNvPr id="14" name="TextBox 13">
             <a:extLst>
               <a:ext uri="{FF2B5EF4-FFF2-40B4-BE49-F238E27FC236}">
-                <a16:creationId xmlns:a16="http://schemas.microsoft.com/office/drawing/2014/main" id="{D2598A18-8958-7B13-DA30-B0AFB8E89C24}"/>
+                <a16:creationId xmlns:a16="http://schemas.microsoft.com/office/drawing/2014/main" id="{5806A9D7-897B-1859-D346-899ABBFE177E}"/>
               </a:ext>
             </a:extLst>
           </p:cNvPr>
@@ -6095,7 +6095,7 @@
           <p:cNvPr id="15" name="TextBox 14">
             <a:extLst>
               <a:ext uri="{FF2B5EF4-FFF2-40B4-BE49-F238E27FC236}">
-                <a16:creationId xmlns:a16="http://schemas.microsoft.com/office/drawing/2014/main" id="{86FCF4C0-E224-D2C3-9612-E4E596F361E3}"/>
+                <a16:creationId xmlns:a16="http://schemas.microsoft.com/office/drawing/2014/main" id="{72C389FE-4BAD-1DB0-0443-6EFCA2AD5091}"/>
               </a:ext>
             </a:extLst>
           </p:cNvPr>
@@ -6135,7 +6135,7 @@
           <p:cNvPr id="16" name="TextBox 15">
             <a:extLst>
               <a:ext uri="{FF2B5EF4-FFF2-40B4-BE49-F238E27FC236}">
-                <a16:creationId xmlns:a16="http://schemas.microsoft.com/office/drawing/2014/main" id="{6B46D2A1-79AF-BF9F-7654-163027475DF4}"/>
+                <a16:creationId xmlns:a16="http://schemas.microsoft.com/office/drawing/2014/main" id="{45965479-EB31-05C9-B2DD-28B68C4D93F6}"/>
               </a:ext>
             </a:extLst>
           </p:cNvPr>
@@ -6175,7 +6175,7 @@
           <p:cNvPr id="17" name="Rectangle 16">
             <a:extLst>
               <a:ext uri="{FF2B5EF4-FFF2-40B4-BE49-F238E27FC236}">
-                <a16:creationId xmlns:a16="http://schemas.microsoft.com/office/drawing/2014/main" id="{E8F2F3C2-FB58-359C-BF98-049BC50B479D}"/>
+                <a16:creationId xmlns:a16="http://schemas.microsoft.com/office/drawing/2014/main" id="{580B6776-683C-EC99-D152-8AD92F774468}"/>
               </a:ext>
             </a:extLst>
           </p:cNvPr>
@@ -6243,7 +6243,7 @@
           <p:cNvPr id="18" name="TextBox 17">
             <a:extLst>
               <a:ext uri="{FF2B5EF4-FFF2-40B4-BE49-F238E27FC236}">
-                <a16:creationId xmlns:a16="http://schemas.microsoft.com/office/drawing/2014/main" id="{7B20756E-CB5C-D941-2B84-7202282DD38E}"/>
+                <a16:creationId xmlns:a16="http://schemas.microsoft.com/office/drawing/2014/main" id="{3DB5655C-438D-03DA-9BFD-7A5128797758}"/>
               </a:ext>
             </a:extLst>
           </p:cNvPr>
@@ -6283,7 +6283,7 @@
           <p:cNvPr id="19" name="TextBox 18">
             <a:extLst>
               <a:ext uri="{FF2B5EF4-FFF2-40B4-BE49-F238E27FC236}">
-                <a16:creationId xmlns:a16="http://schemas.microsoft.com/office/drawing/2014/main" id="{9537058C-6A2A-ECF1-D4F2-177D120D92AF}"/>
+                <a16:creationId xmlns:a16="http://schemas.microsoft.com/office/drawing/2014/main" id="{1622B067-C20E-14BD-FCC0-50F83419C83F}"/>
               </a:ext>
             </a:extLst>
           </p:cNvPr>
@@ -6323,7 +6323,7 @@
           <p:cNvPr id="20" name="TextBox 19">
             <a:extLst>
               <a:ext uri="{FF2B5EF4-FFF2-40B4-BE49-F238E27FC236}">
-                <a16:creationId xmlns:a16="http://schemas.microsoft.com/office/drawing/2014/main" id="{E5CB57E4-3D56-F91B-5DC3-322964C0B061}"/>
+                <a16:creationId xmlns:a16="http://schemas.microsoft.com/office/drawing/2014/main" id="{F34D1051-8EEC-DA5D-0DDD-E8699D3DFD24}"/>
               </a:ext>
             </a:extLst>
           </p:cNvPr>
@@ -6363,7 +6363,7 @@
           <p:cNvPr id="21" name="TextBox 20">
             <a:extLst>
               <a:ext uri="{FF2B5EF4-FFF2-40B4-BE49-F238E27FC236}">
-                <a16:creationId xmlns:a16="http://schemas.microsoft.com/office/drawing/2014/main" id="{F7B983A3-4FBA-D613-A96A-67FE2A154595}"/>
+                <a16:creationId xmlns:a16="http://schemas.microsoft.com/office/drawing/2014/main" id="{B4818ABE-CB16-9609-D128-1A52C593856B}"/>
               </a:ext>
             </a:extLst>
           </p:cNvPr>
@@ -6403,7 +6403,7 @@
           <p:cNvPr id="22" name="TextBox 21">
             <a:extLst>
               <a:ext uri="{FF2B5EF4-FFF2-40B4-BE49-F238E27FC236}">
-                <a16:creationId xmlns:a16="http://schemas.microsoft.com/office/drawing/2014/main" id="{8E88895C-3BE4-E7B9-5B17-80CF6D88C8D6}"/>
+                <a16:creationId xmlns:a16="http://schemas.microsoft.com/office/drawing/2014/main" id="{00254107-8537-9631-E641-4FB062B0A99A}"/>
               </a:ext>
             </a:extLst>
           </p:cNvPr>
@@ -6443,7 +6443,7 @@
           <p:cNvPr id="23" name="TextBox 22">
             <a:extLst>
               <a:ext uri="{FF2B5EF4-FFF2-40B4-BE49-F238E27FC236}">
-                <a16:creationId xmlns:a16="http://schemas.microsoft.com/office/drawing/2014/main" id="{4BD55551-EB2F-1DE4-56B7-2F0C85FA8C97}"/>
+                <a16:creationId xmlns:a16="http://schemas.microsoft.com/office/drawing/2014/main" id="{8B5026E0-E3DE-E8FF-9A11-927C9C2B0F39}"/>
               </a:ext>
             </a:extLst>
           </p:cNvPr>
@@ -6483,7 +6483,7 @@
           <p:cNvPr id="24" name="Rectangle: Rounded Corners 23">
             <a:extLst>
               <a:ext uri="{FF2B5EF4-FFF2-40B4-BE49-F238E27FC236}">
-                <a16:creationId xmlns:a16="http://schemas.microsoft.com/office/drawing/2014/main" id="{5A3F35B2-D69B-4CB1-0C88-5AEC2ACF6615}"/>
+                <a16:creationId xmlns:a16="http://schemas.microsoft.com/office/drawing/2014/main" id="{49236400-1D78-0503-387B-75668A497918}"/>
               </a:ext>
             </a:extLst>
           </p:cNvPr>
@@ -6537,7 +6537,7 @@
           <p:cNvPr id="25" name="TextBox 24">
             <a:extLst>
               <a:ext uri="{FF2B5EF4-FFF2-40B4-BE49-F238E27FC236}">
-                <a16:creationId xmlns:a16="http://schemas.microsoft.com/office/drawing/2014/main" id="{4A6CF7A6-DB80-4794-7473-E12CE71405F3}"/>
+                <a16:creationId xmlns:a16="http://schemas.microsoft.com/office/drawing/2014/main" id="{B2E61CDD-3987-C382-33F4-36C49B7424A8}"/>
               </a:ext>
             </a:extLst>
           </p:cNvPr>
@@ -6578,7 +6578,7 @@
           <p:cNvPr id="26" name="TextBox 25">
             <a:extLst>
               <a:ext uri="{FF2B5EF4-FFF2-40B4-BE49-F238E27FC236}">
-                <a16:creationId xmlns:a16="http://schemas.microsoft.com/office/drawing/2014/main" id="{A95D4762-5731-366A-0A00-E05683123526}"/>
+                <a16:creationId xmlns:a16="http://schemas.microsoft.com/office/drawing/2014/main" id="{E862E84A-E80D-79A5-4DA1-4B6EBECB239F}"/>
               </a:ext>
             </a:extLst>
           </p:cNvPr>
@@ -6617,7 +6617,7 @@
     </p:spTree>
     <p:extLst>
       <p:ext uri="{BB962C8B-B14F-4D97-AF65-F5344CB8AC3E}">
-        <p14:creationId xmlns:p14="http://schemas.microsoft.com/office/powerpoint/2010/main" val="1325295983"/>
+        <p14:creationId xmlns:p14="http://schemas.microsoft.com/office/powerpoint/2010/main" val="194649266"/>
       </p:ext>
     </p:extLst>
   </p:cSld>
@@ -6657,7 +6657,7 @@
           <p:cNvPr id="2" name="TextBox 1">
             <a:extLst>
               <a:ext uri="{FF2B5EF4-FFF2-40B4-BE49-F238E27FC236}">
-                <a16:creationId xmlns:a16="http://schemas.microsoft.com/office/drawing/2014/main" id="{6155BEDB-7996-B0F5-F64F-8865D82DEFCA}"/>
+                <a16:creationId xmlns:a16="http://schemas.microsoft.com/office/drawing/2014/main" id="{F76C1CB9-A9E9-5F33-DAE4-A89EB7CDCEDA}"/>
               </a:ext>
             </a:extLst>
           </p:cNvPr>
@@ -6697,7 +6697,7 @@
           <p:cNvPr id="3" name="Straight Connector 2">
             <a:extLst>
               <a:ext uri="{FF2B5EF4-FFF2-40B4-BE49-F238E27FC236}">
-                <a16:creationId xmlns:a16="http://schemas.microsoft.com/office/drawing/2014/main" id="{0E9AA5CA-7EDD-4338-022B-F61D2425175D}"/>
+                <a16:creationId xmlns:a16="http://schemas.microsoft.com/office/drawing/2014/main" id="{EACF27E4-82A8-130F-1D99-BDEB3F13F107}"/>
               </a:ext>
             </a:extLst>
           </p:cNvPr>
@@ -6738,7 +6738,7 @@
           <p:cNvPr id="4" name="TextBox 3">
             <a:extLst>
               <a:ext uri="{FF2B5EF4-FFF2-40B4-BE49-F238E27FC236}">
-                <a16:creationId xmlns:a16="http://schemas.microsoft.com/office/drawing/2014/main" id="{17034578-A073-4A06-4D8B-03472E921575}"/>
+                <a16:creationId xmlns:a16="http://schemas.microsoft.com/office/drawing/2014/main" id="{809BC5DE-E82C-8B4B-C611-9A88C9047691}"/>
               </a:ext>
             </a:extLst>
           </p:cNvPr>
@@ -6779,7 +6779,7 @@
           <p:cNvPr id="5" name="TextBox 4">
             <a:extLst>
               <a:ext uri="{FF2B5EF4-FFF2-40B4-BE49-F238E27FC236}">
-                <a16:creationId xmlns:a16="http://schemas.microsoft.com/office/drawing/2014/main" id="{BBC68BC9-FD57-B55B-0E33-4A75111BEC2C}"/>
+                <a16:creationId xmlns:a16="http://schemas.microsoft.com/office/drawing/2014/main" id="{FBA7D9DA-8541-8993-7890-B15AC97C0452}"/>
               </a:ext>
             </a:extLst>
           </p:cNvPr>
@@ -6819,7 +6819,7 @@
           <p:cNvPr id="6" name="TextBox 5">
             <a:extLst>
               <a:ext uri="{FF2B5EF4-FFF2-40B4-BE49-F238E27FC236}">
-                <a16:creationId xmlns:a16="http://schemas.microsoft.com/office/drawing/2014/main" id="{7CEE45E1-764C-D0CD-C1ED-E9F0D30E1AA4}"/>
+                <a16:creationId xmlns:a16="http://schemas.microsoft.com/office/drawing/2014/main" id="{84FCE880-5759-9A47-E3EE-DDCED6F8E72F}"/>
               </a:ext>
             </a:extLst>
           </p:cNvPr>
@@ -6859,7 +6859,7 @@
           <p:cNvPr id="7" name="TextBox 6">
             <a:extLst>
               <a:ext uri="{FF2B5EF4-FFF2-40B4-BE49-F238E27FC236}">
-                <a16:creationId xmlns:a16="http://schemas.microsoft.com/office/drawing/2014/main" id="{DAD1E565-3FFF-B220-E643-717695F5E888}"/>
+                <a16:creationId xmlns:a16="http://schemas.microsoft.com/office/drawing/2014/main" id="{4B824F69-16CE-3048-74A0-3645F90C9E7D}"/>
               </a:ext>
             </a:extLst>
           </p:cNvPr>
@@ -6899,7 +6899,7 @@
           <p:cNvPr id="8" name="Straight Connector 7">
             <a:extLst>
               <a:ext uri="{FF2B5EF4-FFF2-40B4-BE49-F238E27FC236}">
-                <a16:creationId xmlns:a16="http://schemas.microsoft.com/office/drawing/2014/main" id="{98FF2C9A-022D-F6DD-BABE-FFB5FA159396}"/>
+                <a16:creationId xmlns:a16="http://schemas.microsoft.com/office/drawing/2014/main" id="{84C35914-CD40-68E0-5739-B41CFE0947FE}"/>
               </a:ext>
             </a:extLst>
           </p:cNvPr>
@@ -6940,7 +6940,7 @@
           <p:cNvPr id="9" name="TextBox 8">
             <a:extLst>
               <a:ext uri="{FF2B5EF4-FFF2-40B4-BE49-F238E27FC236}">
-                <a16:creationId xmlns:a16="http://schemas.microsoft.com/office/drawing/2014/main" id="{020082A6-E5BB-D1B0-9B4E-1CD05BCC9085}"/>
+                <a16:creationId xmlns:a16="http://schemas.microsoft.com/office/drawing/2014/main" id="{1D7ACA7B-3B37-7ACF-5C5B-CB1DD534B5F0}"/>
               </a:ext>
             </a:extLst>
           </p:cNvPr>
@@ -6980,7 +6980,7 @@
           <p:cNvPr id="10" name="Straight Connector 9">
             <a:extLst>
               <a:ext uri="{FF2B5EF4-FFF2-40B4-BE49-F238E27FC236}">
-                <a16:creationId xmlns:a16="http://schemas.microsoft.com/office/drawing/2014/main" id="{9A42701D-662E-DC98-2558-2341C40FE5D0}"/>
+                <a16:creationId xmlns:a16="http://schemas.microsoft.com/office/drawing/2014/main" id="{B05DA21C-F35B-A9D3-59A4-9F3419F33B1C}"/>
               </a:ext>
             </a:extLst>
           </p:cNvPr>
@@ -7021,7 +7021,7 @@
           <p:cNvPr id="11" name="TextBox 10">
             <a:extLst>
               <a:ext uri="{FF2B5EF4-FFF2-40B4-BE49-F238E27FC236}">
-                <a16:creationId xmlns:a16="http://schemas.microsoft.com/office/drawing/2014/main" id="{80AE123C-9407-499B-F90A-167FD83E9A01}"/>
+                <a16:creationId xmlns:a16="http://schemas.microsoft.com/office/drawing/2014/main" id="{F3CDF3E4-E78A-3526-9B47-AA5ECE896934}"/>
               </a:ext>
             </a:extLst>
           </p:cNvPr>
@@ -7061,7 +7061,7 @@
           <p:cNvPr id="12" name="Straight Connector 11">
             <a:extLst>
               <a:ext uri="{FF2B5EF4-FFF2-40B4-BE49-F238E27FC236}">
-                <a16:creationId xmlns:a16="http://schemas.microsoft.com/office/drawing/2014/main" id="{3495715B-D1CB-4EA8-052A-8FD456F310F2}"/>
+                <a16:creationId xmlns:a16="http://schemas.microsoft.com/office/drawing/2014/main" id="{18118873-EA80-2FCF-713D-FAD60983FACC}"/>
               </a:ext>
             </a:extLst>
           </p:cNvPr>
@@ -7102,7 +7102,7 @@
           <p:cNvPr id="13" name="TextBox 12">
             <a:extLst>
               <a:ext uri="{FF2B5EF4-FFF2-40B4-BE49-F238E27FC236}">
-                <a16:creationId xmlns:a16="http://schemas.microsoft.com/office/drawing/2014/main" id="{826FCD29-FFED-02B3-CA80-3FFFFBB17979}"/>
+                <a16:creationId xmlns:a16="http://schemas.microsoft.com/office/drawing/2014/main" id="{7E3E1529-8C28-967A-A63C-59BAB718AE40}"/>
               </a:ext>
             </a:extLst>
           </p:cNvPr>
@@ -7142,7 +7142,7 @@
           <p:cNvPr id="14" name="Straight Connector 13">
             <a:extLst>
               <a:ext uri="{FF2B5EF4-FFF2-40B4-BE49-F238E27FC236}">
-                <a16:creationId xmlns:a16="http://schemas.microsoft.com/office/drawing/2014/main" id="{F6A6B9C4-2495-D906-A40E-634F4E31C6E1}"/>
+                <a16:creationId xmlns:a16="http://schemas.microsoft.com/office/drawing/2014/main" id="{4C42B642-5D5A-7498-E614-876BFFDA22A9}"/>
               </a:ext>
             </a:extLst>
           </p:cNvPr>
@@ -7183,7 +7183,7 @@
           <p:cNvPr id="15" name="TextBox 14">
             <a:extLst>
               <a:ext uri="{FF2B5EF4-FFF2-40B4-BE49-F238E27FC236}">
-                <a16:creationId xmlns:a16="http://schemas.microsoft.com/office/drawing/2014/main" id="{7DF21A86-1333-D4D4-0F43-509E35D7163E}"/>
+                <a16:creationId xmlns:a16="http://schemas.microsoft.com/office/drawing/2014/main" id="{78F4E538-F990-2C88-B185-6B770162DB3D}"/>
               </a:ext>
             </a:extLst>
           </p:cNvPr>
@@ -7213,7 +7213,7 @@
                 </a:solidFill>
                 <a:latin typeface="Aptos" panose="020B0004020202020204" pitchFamily="34" charset="0"/>
               </a:rPr>
-              <a:t>Not untouched: promotion and acceptance used this layer</a:t>
+              <a:t>Promotion and acceptance used this layer</a:t>
             </a:r>
           </a:p>
         </p:txBody>
@@ -7223,7 +7223,7 @@
           <p:cNvPr id="16" name="Straight Connector 15">
             <a:extLst>
               <a:ext uri="{FF2B5EF4-FFF2-40B4-BE49-F238E27FC236}">
-                <a16:creationId xmlns:a16="http://schemas.microsoft.com/office/drawing/2014/main" id="{7A36A594-9F10-8DDE-9670-C8F2A3DD491C}"/>
+                <a16:creationId xmlns:a16="http://schemas.microsoft.com/office/drawing/2014/main" id="{33FB5465-F52A-25E8-0FB6-BE9798E8ED64}"/>
               </a:ext>
             </a:extLst>
           </p:cNvPr>
@@ -7264,7 +7264,7 @@
           <p:cNvPr id="17" name="TextBox 16">
             <a:extLst>
               <a:ext uri="{FF2B5EF4-FFF2-40B4-BE49-F238E27FC236}">
-                <a16:creationId xmlns:a16="http://schemas.microsoft.com/office/drawing/2014/main" id="{09ADFD38-2AF0-D89E-6C42-AB18C684BB4F}"/>
+                <a16:creationId xmlns:a16="http://schemas.microsoft.com/office/drawing/2014/main" id="{58FAF87D-496D-AC0C-5A3A-95523C1A5F50}"/>
               </a:ext>
             </a:extLst>
           </p:cNvPr>
@@ -7304,7 +7304,7 @@
           <p:cNvPr id="18" name="TextBox 17">
             <a:extLst>
               <a:ext uri="{FF2B5EF4-FFF2-40B4-BE49-F238E27FC236}">
-                <a16:creationId xmlns:a16="http://schemas.microsoft.com/office/drawing/2014/main" id="{9820C4B4-53A6-9A80-1F2F-E5157313BDC6}"/>
+                <a16:creationId xmlns:a16="http://schemas.microsoft.com/office/drawing/2014/main" id="{C12A7AE0-9AC0-DD04-8C9F-1BBC4FFE4698}"/>
               </a:ext>
             </a:extLst>
           </p:cNvPr>
@@ -7344,7 +7344,7 @@
           <p:cNvPr id="19" name="TextBox 18">
             <a:extLst>
               <a:ext uri="{FF2B5EF4-FFF2-40B4-BE49-F238E27FC236}">
-                <a16:creationId xmlns:a16="http://schemas.microsoft.com/office/drawing/2014/main" id="{5F9CDEE3-C8D9-7925-0A6E-B3316A5247A0}"/>
+                <a16:creationId xmlns:a16="http://schemas.microsoft.com/office/drawing/2014/main" id="{BC05CD52-7EAC-04C4-7686-EA3B351DF16C}"/>
               </a:ext>
             </a:extLst>
           </p:cNvPr>
@@ -7384,7 +7384,7 @@
           <p:cNvPr id="20" name="TextBox 19">
             <a:extLst>
               <a:ext uri="{FF2B5EF4-FFF2-40B4-BE49-F238E27FC236}">
-                <a16:creationId xmlns:a16="http://schemas.microsoft.com/office/drawing/2014/main" id="{F06912F4-381E-DD37-D0BD-D61B36460A92}"/>
+                <a16:creationId xmlns:a16="http://schemas.microsoft.com/office/drawing/2014/main" id="{69C6E351-3C65-D2C4-5BCC-84E8630D9D20}"/>
               </a:ext>
             </a:extLst>
           </p:cNvPr>
@@ -7424,7 +7424,7 @@
           <p:cNvPr id="21" name="TextBox 20">
             <a:extLst>
               <a:ext uri="{FF2B5EF4-FFF2-40B4-BE49-F238E27FC236}">
-                <a16:creationId xmlns:a16="http://schemas.microsoft.com/office/drawing/2014/main" id="{175D330B-9809-6BA0-DA4C-1F32ADCC417A}"/>
+                <a16:creationId xmlns:a16="http://schemas.microsoft.com/office/drawing/2014/main" id="{90DA06C1-D3CD-3147-B8B6-CF6730072F59}"/>
               </a:ext>
             </a:extLst>
           </p:cNvPr>
@@ -7464,7 +7464,7 @@
           <p:cNvPr id="22" name="TextBox 21">
             <a:extLst>
               <a:ext uri="{FF2B5EF4-FFF2-40B4-BE49-F238E27FC236}">
-                <a16:creationId xmlns:a16="http://schemas.microsoft.com/office/drawing/2014/main" id="{999848FB-C5F0-0BF9-10A1-ED280418716A}"/>
+                <a16:creationId xmlns:a16="http://schemas.microsoft.com/office/drawing/2014/main" id="{DD1DD129-E3F4-70F3-BE72-30F34D183F95}"/>
               </a:ext>
             </a:extLst>
           </p:cNvPr>
@@ -7504,7 +7504,7 @@
           <p:cNvPr id="23" name="TextBox 22">
             <a:extLst>
               <a:ext uri="{FF2B5EF4-FFF2-40B4-BE49-F238E27FC236}">
-                <a16:creationId xmlns:a16="http://schemas.microsoft.com/office/drawing/2014/main" id="{DA67E5E0-6119-9C3E-8FCC-512967E101CC}"/>
+                <a16:creationId xmlns:a16="http://schemas.microsoft.com/office/drawing/2014/main" id="{26C4B9F0-0975-F921-197B-3B63AE5F7CFF}"/>
               </a:ext>
             </a:extLst>
           </p:cNvPr>
@@ -7544,7 +7544,7 @@
           <p:cNvPr id="24" name="Rectangle: Rounded Corners 23">
             <a:extLst>
               <a:ext uri="{FF2B5EF4-FFF2-40B4-BE49-F238E27FC236}">
-                <a16:creationId xmlns:a16="http://schemas.microsoft.com/office/drawing/2014/main" id="{BA08F04B-C8F3-74CA-CD49-9125BA59B5E2}"/>
+                <a16:creationId xmlns:a16="http://schemas.microsoft.com/office/drawing/2014/main" id="{E334B283-39B8-A86A-935A-BE24E48BB99C}"/>
               </a:ext>
             </a:extLst>
           </p:cNvPr>
@@ -7598,17 +7598,17 @@
           <p:cNvPr id="25" name="TextBox 24">
             <a:extLst>
               <a:ext uri="{FF2B5EF4-FFF2-40B4-BE49-F238E27FC236}">
-                <a16:creationId xmlns:a16="http://schemas.microsoft.com/office/drawing/2014/main" id="{2A9DA8D1-B846-5A6B-3F70-17515D05FED9}"/>
-              </a:ext>
-            </a:extLst>
-          </p:cNvPr>
-          <p:cNvSpPr txBox="1"/>
-          <p:nvPr/>
-        </p:nvSpPr>
-        <p:spPr>
-          <a:xfrm>
-            <a:off x="7010400" y="5422899"/>
-            <a:ext cx="3835400" cy="508000"/>
+                <a16:creationId xmlns:a16="http://schemas.microsoft.com/office/drawing/2014/main" id="{3ACFBCCC-006B-C329-58A3-AC591C67DFAC}"/>
+              </a:ext>
+            </a:extLst>
+          </p:cNvPr>
+          <p:cNvSpPr txBox="1"/>
+          <p:nvPr/>
+        </p:nvSpPr>
+        <p:spPr>
+          <a:xfrm>
+            <a:off x="7010400" y="5346699"/>
+            <a:ext cx="3835400" cy="622300"/>
           </a:xfrm>
           <a:prstGeom prst="rect">
             <a:avLst/>
@@ -7629,7 +7629,19 @@
                 </a:solidFill>
                 <a:latin typeface="Aptos" panose="020B0004020202020204" pitchFamily="34" charset="0"/>
               </a:rPr>
-              <a:t>Untouched seeds 81001-81010 remain separate</a:t>
+              <a:t>Documented-seed-disjoint holdout</a:t>
+            </a:r>
+          </a:p>
+          <a:p>
+            <a:pPr algn="ctr"/>
+            <a:r>
+              <a:rPr lang="en-US" sz="1600" b="1">
+                <a:solidFill>
+                  <a:srgbClr val="3FC6AC"/>
+                </a:solidFill>
+                <a:latin typeface="Aptos" panose="020B0004020202020204" pitchFamily="34" charset="0"/>
+              </a:rPr>
+              <a:t>81001-81010 remains separate</a:t>
             </a:r>
           </a:p>
         </p:txBody>
@@ -7637,7 +7649,7 @@
     </p:spTree>
     <p:extLst>
       <p:ext uri="{BB962C8B-B14F-4D97-AF65-F5344CB8AC3E}">
-        <p14:creationId xmlns:p14="http://schemas.microsoft.com/office/powerpoint/2010/main" val="2669204614"/>
+        <p14:creationId xmlns:p14="http://schemas.microsoft.com/office/powerpoint/2010/main" val="2389296558"/>
       </p:ext>
     </p:extLst>
   </p:cSld>
@@ -7677,7 +7689,7 @@
           <p:cNvPr id="2" name="TextBox 1">
             <a:extLst>
               <a:ext uri="{FF2B5EF4-FFF2-40B4-BE49-F238E27FC236}">
-                <a16:creationId xmlns:a16="http://schemas.microsoft.com/office/drawing/2014/main" id="{29C76C5A-E9B7-980F-9D2E-7BE74DAE684A}"/>
+                <a16:creationId xmlns:a16="http://schemas.microsoft.com/office/drawing/2014/main" id="{A62C3A73-15B5-397C-E904-9AF211DCF53F}"/>
               </a:ext>
             </a:extLst>
           </p:cNvPr>
@@ -7717,7 +7729,7 @@
           <p:cNvPr id="3" name="Straight Connector 2">
             <a:extLst>
               <a:ext uri="{FF2B5EF4-FFF2-40B4-BE49-F238E27FC236}">
-                <a16:creationId xmlns:a16="http://schemas.microsoft.com/office/drawing/2014/main" id="{D28CB0DE-FB2C-24E8-DBE0-BA19B37A63E5}"/>
+                <a16:creationId xmlns:a16="http://schemas.microsoft.com/office/drawing/2014/main" id="{E2DA63CE-D5F1-4DD1-B836-6F55980C1DE3}"/>
               </a:ext>
             </a:extLst>
           </p:cNvPr>
@@ -7758,7 +7770,7 @@
           <p:cNvPr id="4" name="TextBox 3">
             <a:extLst>
               <a:ext uri="{FF2B5EF4-FFF2-40B4-BE49-F238E27FC236}">
-                <a16:creationId xmlns:a16="http://schemas.microsoft.com/office/drawing/2014/main" id="{6EC884B7-10D1-110B-762D-EC9E09A3D81E}"/>
+                <a16:creationId xmlns:a16="http://schemas.microsoft.com/office/drawing/2014/main" id="{1F04156C-F5E3-5C8A-651A-B011F1FA48FB}"/>
               </a:ext>
             </a:extLst>
           </p:cNvPr>
@@ -7799,7 +7811,7 @@
           <p:cNvPr id="5" name="TextBox 4">
             <a:extLst>
               <a:ext uri="{FF2B5EF4-FFF2-40B4-BE49-F238E27FC236}">
-                <a16:creationId xmlns:a16="http://schemas.microsoft.com/office/drawing/2014/main" id="{D1F3A61D-7585-BEA0-945C-F4A9BB245AF9}"/>
+                <a16:creationId xmlns:a16="http://schemas.microsoft.com/office/drawing/2014/main" id="{A9744680-5ECB-B5DE-397D-4148250917AD}"/>
               </a:ext>
             </a:extLst>
           </p:cNvPr>
@@ -7839,7 +7851,7 @@
           <p:cNvPr id="6" name="TextBox 5">
             <a:extLst>
               <a:ext uri="{FF2B5EF4-FFF2-40B4-BE49-F238E27FC236}">
-                <a16:creationId xmlns:a16="http://schemas.microsoft.com/office/drawing/2014/main" id="{D71BF4A6-943A-207C-767E-AE6D4D5EA4FA}"/>
+                <a16:creationId xmlns:a16="http://schemas.microsoft.com/office/drawing/2014/main" id="{88CFBDE2-FADA-38AA-67F8-9FB527C1A1F8}"/>
               </a:ext>
             </a:extLst>
           </p:cNvPr>
@@ -7879,7 +7891,7 @@
           <p:cNvPr id="7" name="TextBox 6">
             <a:extLst>
               <a:ext uri="{FF2B5EF4-FFF2-40B4-BE49-F238E27FC236}">
-                <a16:creationId xmlns:a16="http://schemas.microsoft.com/office/drawing/2014/main" id="{E71DF4BB-B600-00D5-BAAB-59F719735863}"/>
+                <a16:creationId xmlns:a16="http://schemas.microsoft.com/office/drawing/2014/main" id="{3348B76B-70B8-F3F6-76D0-07244A466CDE}"/>
               </a:ext>
             </a:extLst>
           </p:cNvPr>
@@ -7919,7 +7931,7 @@
           <p:cNvPr id="8" name="Straight Connector 7">
             <a:extLst>
               <a:ext uri="{FF2B5EF4-FFF2-40B4-BE49-F238E27FC236}">
-                <a16:creationId xmlns:a16="http://schemas.microsoft.com/office/drawing/2014/main" id="{533E1037-FA98-E81F-227C-D4E94967C1FE}"/>
+                <a16:creationId xmlns:a16="http://schemas.microsoft.com/office/drawing/2014/main" id="{79C46A39-2580-6F13-AF38-6FA1FAB78B6F}"/>
               </a:ext>
             </a:extLst>
           </p:cNvPr>
@@ -7960,7 +7972,7 @@
           <p:cNvPr id="9" name="TextBox 8">
             <a:extLst>
               <a:ext uri="{FF2B5EF4-FFF2-40B4-BE49-F238E27FC236}">
-                <a16:creationId xmlns:a16="http://schemas.microsoft.com/office/drawing/2014/main" id="{3E703CC0-7C4A-50BA-1682-B8F9986B0C3B}"/>
+                <a16:creationId xmlns:a16="http://schemas.microsoft.com/office/drawing/2014/main" id="{44924322-EAB0-03A2-A2C4-72B416E23C57}"/>
               </a:ext>
             </a:extLst>
           </p:cNvPr>
@@ -8000,7 +8012,7 @@
           <p:cNvPr id="10" name="Straight Connector 9">
             <a:extLst>
               <a:ext uri="{FF2B5EF4-FFF2-40B4-BE49-F238E27FC236}">
-                <a16:creationId xmlns:a16="http://schemas.microsoft.com/office/drawing/2014/main" id="{9CDCFF84-4129-206F-ADE2-BDA605668630}"/>
+                <a16:creationId xmlns:a16="http://schemas.microsoft.com/office/drawing/2014/main" id="{45CE9F5A-C542-8C89-6855-D48A803D2D5F}"/>
               </a:ext>
             </a:extLst>
           </p:cNvPr>
@@ -8041,7 +8053,7 @@
           <p:cNvPr id="11" name="TextBox 10">
             <a:extLst>
               <a:ext uri="{FF2B5EF4-FFF2-40B4-BE49-F238E27FC236}">
-                <a16:creationId xmlns:a16="http://schemas.microsoft.com/office/drawing/2014/main" id="{E709BE7D-B780-2A06-631E-279228F863C7}"/>
+                <a16:creationId xmlns:a16="http://schemas.microsoft.com/office/drawing/2014/main" id="{EE9A8755-19DD-F67D-26DF-65483907A161}"/>
               </a:ext>
             </a:extLst>
           </p:cNvPr>
@@ -8081,7 +8093,7 @@
           <p:cNvPr id="12" name="Straight Connector 11">
             <a:extLst>
               <a:ext uri="{FF2B5EF4-FFF2-40B4-BE49-F238E27FC236}">
-                <a16:creationId xmlns:a16="http://schemas.microsoft.com/office/drawing/2014/main" id="{5C152DEC-2371-61F7-488E-2204CFC61D91}"/>
+                <a16:creationId xmlns:a16="http://schemas.microsoft.com/office/drawing/2014/main" id="{5FBF8FD0-74D9-52EB-C545-68F8C65BBFDB}"/>
               </a:ext>
             </a:extLst>
           </p:cNvPr>
@@ -8122,7 +8134,7 @@
           <p:cNvPr id="13" name="TextBox 12">
             <a:extLst>
               <a:ext uri="{FF2B5EF4-FFF2-40B4-BE49-F238E27FC236}">
-                <a16:creationId xmlns:a16="http://schemas.microsoft.com/office/drawing/2014/main" id="{E0DE06DD-C505-C143-C194-FA7100BE3A40}"/>
+                <a16:creationId xmlns:a16="http://schemas.microsoft.com/office/drawing/2014/main" id="{8396FB6C-FECA-1D7F-8486-D0C438FB87B5}"/>
               </a:ext>
             </a:extLst>
           </p:cNvPr>
@@ -8162,7 +8174,7 @@
           <p:cNvPr id="14" name="Straight Connector 13">
             <a:extLst>
               <a:ext uri="{FF2B5EF4-FFF2-40B4-BE49-F238E27FC236}">
-                <a16:creationId xmlns:a16="http://schemas.microsoft.com/office/drawing/2014/main" id="{E68D5973-4D6D-876A-BE04-291B1A0D0441}"/>
+                <a16:creationId xmlns:a16="http://schemas.microsoft.com/office/drawing/2014/main" id="{6FA800BE-32A3-D9E5-08A1-5858E51AE0DA}"/>
               </a:ext>
             </a:extLst>
           </p:cNvPr>
@@ -8203,7 +8215,7 @@
           <p:cNvPr id="15" name="TextBox 14">
             <a:extLst>
               <a:ext uri="{FF2B5EF4-FFF2-40B4-BE49-F238E27FC236}">
-                <a16:creationId xmlns:a16="http://schemas.microsoft.com/office/drawing/2014/main" id="{BEA6A0F1-8A86-009F-12EB-B89B0FBF475D}"/>
+                <a16:creationId xmlns:a16="http://schemas.microsoft.com/office/drawing/2014/main" id="{192DBA83-FEF9-166C-2467-32BDA9C18128}"/>
               </a:ext>
             </a:extLst>
           </p:cNvPr>
@@ -8243,7 +8255,7 @@
           <p:cNvPr id="16" name="TextBox 15">
             <a:extLst>
               <a:ext uri="{FF2B5EF4-FFF2-40B4-BE49-F238E27FC236}">
-                <a16:creationId xmlns:a16="http://schemas.microsoft.com/office/drawing/2014/main" id="{D76F459A-1AD3-A12E-CAB7-AF073258418B}"/>
+                <a16:creationId xmlns:a16="http://schemas.microsoft.com/office/drawing/2014/main" id="{DC817537-DCD7-EE28-8A49-9C1CD62F8775}"/>
               </a:ext>
             </a:extLst>
           </p:cNvPr>
@@ -8283,7 +8295,7 @@
           <p:cNvPr id="17" name="Straight Connector 16">
             <a:extLst>
               <a:ext uri="{FF2B5EF4-FFF2-40B4-BE49-F238E27FC236}">
-                <a16:creationId xmlns:a16="http://schemas.microsoft.com/office/drawing/2014/main" id="{767B115B-BD25-0275-134F-AED11E2BE2B5}"/>
+                <a16:creationId xmlns:a16="http://schemas.microsoft.com/office/drawing/2014/main" id="{A578D69C-640F-7D4F-33C1-C01C12736051}"/>
               </a:ext>
             </a:extLst>
           </p:cNvPr>
@@ -8324,7 +8336,7 @@
           <p:cNvPr id="18" name="TextBox 17">
             <a:extLst>
               <a:ext uri="{FF2B5EF4-FFF2-40B4-BE49-F238E27FC236}">
-                <a16:creationId xmlns:a16="http://schemas.microsoft.com/office/drawing/2014/main" id="{FCFA9A0E-8417-D70B-F4C7-5B5ED5B28461}"/>
+                <a16:creationId xmlns:a16="http://schemas.microsoft.com/office/drawing/2014/main" id="{BC531FF7-8BD3-7629-E394-E72C0BB42D33}"/>
               </a:ext>
             </a:extLst>
           </p:cNvPr>
@@ -8364,7 +8376,7 @@
           <p:cNvPr id="19" name="Straight Connector 18">
             <a:extLst>
               <a:ext uri="{FF2B5EF4-FFF2-40B4-BE49-F238E27FC236}">
-                <a16:creationId xmlns:a16="http://schemas.microsoft.com/office/drawing/2014/main" id="{665B3DA0-F917-F537-8D86-76A6F881BF2F}"/>
+                <a16:creationId xmlns:a16="http://schemas.microsoft.com/office/drawing/2014/main" id="{6BD1FDA4-8FB8-BBFD-C8E2-B022C5B861E1}"/>
               </a:ext>
             </a:extLst>
           </p:cNvPr>
@@ -8405,7 +8417,7 @@
           <p:cNvPr id="20" name="TextBox 19">
             <a:extLst>
               <a:ext uri="{FF2B5EF4-FFF2-40B4-BE49-F238E27FC236}">
-                <a16:creationId xmlns:a16="http://schemas.microsoft.com/office/drawing/2014/main" id="{EB7D83F3-EE99-58A0-AA7C-F6F866C61137}"/>
+                <a16:creationId xmlns:a16="http://schemas.microsoft.com/office/drawing/2014/main" id="{A4B0E372-914F-9EFC-8E9C-AEA263E8216C}"/>
               </a:ext>
             </a:extLst>
           </p:cNvPr>
@@ -8435,7 +8447,7 @@
                 </a:solidFill>
                 <a:latin typeface="Aptos" panose="020B0004020202020204" pitchFamily="34" charset="0"/>
               </a:rPr>
-              <a:t>Voltage, frequency, protection, or network stability</a:t>
+              <a:t>Electrical-network or forecast validation</a:t>
             </a:r>
           </a:p>
         </p:txBody>
@@ -8445,7 +8457,7 @@
           <p:cNvPr id="21" name="Straight Connector 20">
             <a:extLst>
               <a:ext uri="{FF2B5EF4-FFF2-40B4-BE49-F238E27FC236}">
-                <a16:creationId xmlns:a16="http://schemas.microsoft.com/office/drawing/2014/main" id="{7025F4ED-FDBB-9A99-C458-42993DF973C2}"/>
+                <a16:creationId xmlns:a16="http://schemas.microsoft.com/office/drawing/2014/main" id="{C9A3598D-70C2-A1AC-98E1-28496B40CCF2}"/>
               </a:ext>
             </a:extLst>
           </p:cNvPr>
@@ -8486,7 +8498,7 @@
           <p:cNvPr id="22" name="TextBox 21">
             <a:extLst>
               <a:ext uri="{FF2B5EF4-FFF2-40B4-BE49-F238E27FC236}">
-                <a16:creationId xmlns:a16="http://schemas.microsoft.com/office/drawing/2014/main" id="{EDE77B4B-0ABC-797F-C843-F2CB79BB4CCE}"/>
+                <a16:creationId xmlns:a16="http://schemas.microsoft.com/office/drawing/2014/main" id="{FCC1CE9C-C665-AFF5-EF0A-E0617C8C1441}"/>
               </a:ext>
             </a:extLst>
           </p:cNvPr>
@@ -8516,7 +8528,7 @@
                 </a:solidFill>
                 <a:latin typeface="Aptos" panose="020B0004020202020204" pitchFamily="34" charset="0"/>
               </a:rPr>
-              <a:t>Real-data forecast calibration</a:t>
+              <a:t>Incremental PPO effect beyond initialization</a:t>
             </a:r>
           </a:p>
         </p:txBody>
@@ -8526,7 +8538,7 @@
           <p:cNvPr id="23" name="Straight Connector 22">
             <a:extLst>
               <a:ext uri="{FF2B5EF4-FFF2-40B4-BE49-F238E27FC236}">
-                <a16:creationId xmlns:a16="http://schemas.microsoft.com/office/drawing/2014/main" id="{BDD34E86-83DD-13B5-7A6B-D8B03A827FE8}"/>
+                <a16:creationId xmlns:a16="http://schemas.microsoft.com/office/drawing/2014/main" id="{98A8A804-6BAD-FFA8-40F9-AE1C2EADB2A0}"/>
               </a:ext>
             </a:extLst>
           </p:cNvPr>
@@ -8567,7 +8579,7 @@
           <p:cNvPr id="24" name="TextBox 23">
             <a:extLst>
               <a:ext uri="{FF2B5EF4-FFF2-40B4-BE49-F238E27FC236}">
-                <a16:creationId xmlns:a16="http://schemas.microsoft.com/office/drawing/2014/main" id="{CF871E34-2BA9-3EA6-01FA-15D95C1A7869}"/>
+                <a16:creationId xmlns:a16="http://schemas.microsoft.com/office/drawing/2014/main" id="{99538775-1318-811A-F5B0-533C2DD67BE9}"/>
               </a:ext>
             </a:extLst>
           </p:cNvPr>
@@ -8597,7 +8609,7 @@
                 </a:solidFill>
                 <a:latin typeface="Aptos" panose="020B0004020202020204" pitchFamily="34" charset="0"/>
               </a:rPr>
-              <a:t>Automatic operational dispatch</a:t>
+              <a:t>General superiority over stronger baselines</a:t>
             </a:r>
           </a:p>
         </p:txBody>
@@ -8607,7 +8619,7 @@
           <p:cNvPr id="25" name="Rectangle: Rounded Corners 24">
             <a:extLst>
               <a:ext uri="{FF2B5EF4-FFF2-40B4-BE49-F238E27FC236}">
-                <a16:creationId xmlns:a16="http://schemas.microsoft.com/office/drawing/2014/main" id="{3F9E3D67-4FCE-2BB6-64B2-04ABBCFB48B0}"/>
+                <a16:creationId xmlns:a16="http://schemas.microsoft.com/office/drawing/2014/main" id="{982D240C-9B01-D8FD-4AA6-52FDF2F12038}"/>
               </a:ext>
             </a:extLst>
           </p:cNvPr>
@@ -8661,7 +8673,7 @@
           <p:cNvPr id="26" name="TextBox 25">
             <a:extLst>
               <a:ext uri="{FF2B5EF4-FFF2-40B4-BE49-F238E27FC236}">
-                <a16:creationId xmlns:a16="http://schemas.microsoft.com/office/drawing/2014/main" id="{710829FF-CB8A-869D-ADEC-38C00B5A517D}"/>
+                <a16:creationId xmlns:a16="http://schemas.microsoft.com/office/drawing/2014/main" id="{F3C50601-D945-8A5A-633F-6C8DD025D692}"/>
               </a:ext>
             </a:extLst>
           </p:cNvPr>
@@ -8692,7 +8704,7 @@
                 </a:solidFill>
                 <a:latin typeface="Aptos" panose="020B0004020202020204" pitchFamily="34" charset="0"/>
               </a:rPr>
-              <a:t>Synthetic demand and administrative geography are abstractions, not geographic measurements or electrical topology.</a:t>
+              <a:t>Fixed Rotation is supply-blind: limited to Off and Full Service; it cannot select Critical Only. Synthetic evidence only.</a:t>
             </a:r>
           </a:p>
         </p:txBody>
@@ -8700,7 +8712,7 @@
     </p:spTree>
     <p:extLst>
       <p:ext uri="{BB962C8B-B14F-4D97-AF65-F5344CB8AC3E}">
-        <p14:creationId xmlns:p14="http://schemas.microsoft.com/office/powerpoint/2010/main" val="1360582856"/>
+        <p14:creationId xmlns:p14="http://schemas.microsoft.com/office/powerpoint/2010/main" val="2963014385"/>
       </p:ext>
     </p:extLst>
   </p:cSld>
@@ -8740,7 +8752,7 @@
           <p:cNvPr id="2" name="TextBox 1">
             <a:extLst>
               <a:ext uri="{FF2B5EF4-FFF2-40B4-BE49-F238E27FC236}">
-                <a16:creationId xmlns:a16="http://schemas.microsoft.com/office/drawing/2014/main" id="{C1A8C785-D0D5-BCBD-D1E2-B4CAC0D58A59}"/>
+                <a16:creationId xmlns:a16="http://schemas.microsoft.com/office/drawing/2014/main" id="{C33CE7DC-0D3B-E8F5-D1FA-BC956E2B37A2}"/>
               </a:ext>
             </a:extLst>
           </p:cNvPr>
@@ -8780,7 +8792,7 @@
           <p:cNvPr id="3" name="Straight Connector 2">
             <a:extLst>
               <a:ext uri="{FF2B5EF4-FFF2-40B4-BE49-F238E27FC236}">
-                <a16:creationId xmlns:a16="http://schemas.microsoft.com/office/drawing/2014/main" id="{EAFC80E6-FB17-8C9A-CF66-BEF59BD917FA}"/>
+                <a16:creationId xmlns:a16="http://schemas.microsoft.com/office/drawing/2014/main" id="{23D6C21E-A7F3-BA23-9C3C-06A406DBC670}"/>
               </a:ext>
             </a:extLst>
           </p:cNvPr>
@@ -8821,7 +8833,7 @@
           <p:cNvPr id="4" name="TextBox 3">
             <a:extLst>
               <a:ext uri="{FF2B5EF4-FFF2-40B4-BE49-F238E27FC236}">
-                <a16:creationId xmlns:a16="http://schemas.microsoft.com/office/drawing/2014/main" id="{D5FD31EB-F847-DE13-308E-84195E683075}"/>
+                <a16:creationId xmlns:a16="http://schemas.microsoft.com/office/drawing/2014/main" id="{D42B902C-5DCF-6D8E-C14A-3C82E1AA15CC}"/>
               </a:ext>
             </a:extLst>
           </p:cNvPr>
@@ -8862,7 +8874,7 @@
           <p:cNvPr id="5" name="TextBox 4">
             <a:extLst>
               <a:ext uri="{FF2B5EF4-FFF2-40B4-BE49-F238E27FC236}">
-                <a16:creationId xmlns:a16="http://schemas.microsoft.com/office/drawing/2014/main" id="{9A4AC617-B5E8-6C58-6424-55F3290CC31C}"/>
+                <a16:creationId xmlns:a16="http://schemas.microsoft.com/office/drawing/2014/main" id="{D0A48713-592A-1122-D23B-FBAAAF052FC8}"/>
               </a:ext>
             </a:extLst>
           </p:cNvPr>
@@ -8902,7 +8914,7 @@
           <p:cNvPr id="6" name="TextBox 5">
             <a:extLst>
               <a:ext uri="{FF2B5EF4-FFF2-40B4-BE49-F238E27FC236}">
-                <a16:creationId xmlns:a16="http://schemas.microsoft.com/office/drawing/2014/main" id="{F791BBA1-49A9-9030-A193-A346B4C02A8E}"/>
+                <a16:creationId xmlns:a16="http://schemas.microsoft.com/office/drawing/2014/main" id="{7994539B-883B-0645-37C8-87087D586C96}"/>
               </a:ext>
             </a:extLst>
           </p:cNvPr>
@@ -8942,7 +8954,7 @@
           <p:cNvPr id="7" name="TextBox 6">
             <a:extLst>
               <a:ext uri="{FF2B5EF4-FFF2-40B4-BE49-F238E27FC236}">
-                <a16:creationId xmlns:a16="http://schemas.microsoft.com/office/drawing/2014/main" id="{AF040889-1320-A1BB-A965-01C8E75C57F7}"/>
+                <a16:creationId xmlns:a16="http://schemas.microsoft.com/office/drawing/2014/main" id="{67F70209-BED1-F62D-22ED-618654419536}"/>
               </a:ext>
             </a:extLst>
           </p:cNvPr>
@@ -8982,7 +8994,7 @@
           <p:cNvPr id="8" name="TextBox 7">
             <a:extLst>
               <a:ext uri="{FF2B5EF4-FFF2-40B4-BE49-F238E27FC236}">
-                <a16:creationId xmlns:a16="http://schemas.microsoft.com/office/drawing/2014/main" id="{168AD185-909E-BF82-91D2-7255F9B14573}"/>
+                <a16:creationId xmlns:a16="http://schemas.microsoft.com/office/drawing/2014/main" id="{B58187A2-E435-26D5-BDBF-C985C0D8342D}"/>
               </a:ext>
             </a:extLst>
           </p:cNvPr>
@@ -9022,7 +9034,7 @@
           <p:cNvPr id="9" name="Straight Connector 8">
             <a:extLst>
               <a:ext uri="{FF2B5EF4-FFF2-40B4-BE49-F238E27FC236}">
-                <a16:creationId xmlns:a16="http://schemas.microsoft.com/office/drawing/2014/main" id="{D03D45F6-FB84-D953-ED3D-D85817E64859}"/>
+                <a16:creationId xmlns:a16="http://schemas.microsoft.com/office/drawing/2014/main" id="{3BD2ED7E-12E5-8A01-AE0E-F8C857663054}"/>
               </a:ext>
             </a:extLst>
           </p:cNvPr>
@@ -9063,7 +9075,7 @@
           <p:cNvPr id="10" name="Straight Connector 9">
             <a:extLst>
               <a:ext uri="{FF2B5EF4-FFF2-40B4-BE49-F238E27FC236}">
-                <a16:creationId xmlns:a16="http://schemas.microsoft.com/office/drawing/2014/main" id="{6D8E7E67-8155-0B9D-8E3A-06CCA8581D4E}"/>
+                <a16:creationId xmlns:a16="http://schemas.microsoft.com/office/drawing/2014/main" id="{0BBF8E1E-8A22-BCEC-86FE-D5B2594E055B}"/>
               </a:ext>
             </a:extLst>
           </p:cNvPr>
@@ -9104,7 +9116,7 @@
           <p:cNvPr id="11" name="TextBox 10">
             <a:extLst>
               <a:ext uri="{FF2B5EF4-FFF2-40B4-BE49-F238E27FC236}">
-                <a16:creationId xmlns:a16="http://schemas.microsoft.com/office/drawing/2014/main" id="{42A9988B-F57E-F5FB-6AD4-06134A3E23E9}"/>
+                <a16:creationId xmlns:a16="http://schemas.microsoft.com/office/drawing/2014/main" id="{AC2B059D-D36E-89B3-7A7F-4918BA53F35D}"/>
               </a:ext>
             </a:extLst>
           </p:cNvPr>
@@ -9134,7 +9146,7 @@
                 </a:solidFill>
                 <a:latin typeface="Aptos" panose="020B0004020202020204" pitchFamily="34" charset="0"/>
               </a:rPr>
-              <a:t>Three untouched primary outcomes - reported without a favorable-result gate</a:t>
+              <a:t>Three documented-seed-disjoint outcomes - no favorable-result gate</a:t>
             </a:r>
           </a:p>
         </p:txBody>
@@ -9144,7 +9156,7 @@
           <p:cNvPr id="12" name="Straight Connector 11">
             <a:extLst>
               <a:ext uri="{FF2B5EF4-FFF2-40B4-BE49-F238E27FC236}">
-                <a16:creationId xmlns:a16="http://schemas.microsoft.com/office/drawing/2014/main" id="{63188D85-E35E-CE65-34D8-73548D4182CE}"/>
+                <a16:creationId xmlns:a16="http://schemas.microsoft.com/office/drawing/2014/main" id="{B72EDB58-CB38-8489-3128-679AE731B549}"/>
               </a:ext>
             </a:extLst>
           </p:cNvPr>
@@ -9185,7 +9197,7 @@
           <p:cNvPr id="13" name="TextBox 12">
             <a:extLst>
               <a:ext uri="{FF2B5EF4-FFF2-40B4-BE49-F238E27FC236}">
-                <a16:creationId xmlns:a16="http://schemas.microsoft.com/office/drawing/2014/main" id="{80F6072C-B599-D293-2C8B-F1E6CBC60297}"/>
+                <a16:creationId xmlns:a16="http://schemas.microsoft.com/office/drawing/2014/main" id="{16CD85E3-02F8-0934-B7D8-A022ACDCD6A7}"/>
               </a:ext>
             </a:extLst>
           </p:cNvPr>
@@ -9215,7 +9227,7 @@
                 </a:solidFill>
                 <a:latin typeface="Aptos" panose="020B0004020202020204" pitchFamily="34" charset="0"/>
               </a:rPr>
-              <a:t>Matched scenarios, explicit seed roles, and hash-bound evidence</a:t>
+              <a:t>Against supply-blind Fixed Rotation limited to Off and Full Service; no Critical Only</a:t>
             </a:r>
           </a:p>
         </p:txBody>
@@ -9225,7 +9237,7 @@
           <p:cNvPr id="14" name="Straight Connector 13">
             <a:extLst>
               <a:ext uri="{FF2B5EF4-FFF2-40B4-BE49-F238E27FC236}">
-                <a16:creationId xmlns:a16="http://schemas.microsoft.com/office/drawing/2014/main" id="{2F2D8118-D122-3C1E-A645-4D4E2B4E1ABC}"/>
+                <a16:creationId xmlns:a16="http://schemas.microsoft.com/office/drawing/2014/main" id="{8630A174-EFBA-B329-20C7-0FF54B32C407}"/>
               </a:ext>
             </a:extLst>
           </p:cNvPr>
@@ -9266,7 +9278,7 @@
           <p:cNvPr id="15" name="TextBox 14">
             <a:extLst>
               <a:ext uri="{FF2B5EF4-FFF2-40B4-BE49-F238E27FC236}">
-                <a16:creationId xmlns:a16="http://schemas.microsoft.com/office/drawing/2014/main" id="{9C7A3B6F-C1F0-CC4B-511B-80376B73D2D1}"/>
+                <a16:creationId xmlns:a16="http://schemas.microsoft.com/office/drawing/2014/main" id="{EB48DAAC-35B4-4841-CAA5-06F39CE730A9}"/>
               </a:ext>
             </a:extLst>
           </p:cNvPr>
@@ -9306,7 +9318,7 @@
           <p:cNvPr id="16" name="Rectangle: Rounded Corners 15">
             <a:extLst>
               <a:ext uri="{FF2B5EF4-FFF2-40B4-BE49-F238E27FC236}">
-                <a16:creationId xmlns:a16="http://schemas.microsoft.com/office/drawing/2014/main" id="{CC673CF9-AA06-9EB6-76F1-122C495C4D96}"/>
+                <a16:creationId xmlns:a16="http://schemas.microsoft.com/office/drawing/2014/main" id="{EFC64ECA-9BE9-3B2A-7CEB-729FE939AC2A}"/>
               </a:ext>
             </a:extLst>
           </p:cNvPr>
@@ -9374,7 +9386,7 @@
           <p:cNvPr id="17" name="TextBox 16">
             <a:extLst>
               <a:ext uri="{FF2B5EF4-FFF2-40B4-BE49-F238E27FC236}">
-                <a16:creationId xmlns:a16="http://schemas.microsoft.com/office/drawing/2014/main" id="{B4C41A6D-AF07-6184-5FEE-ACFAAE34A62E}"/>
+                <a16:creationId xmlns:a16="http://schemas.microsoft.com/office/drawing/2014/main" id="{025FA5A0-1533-B16B-FF74-6E75060DC184}"/>
               </a:ext>
             </a:extLst>
           </p:cNvPr>
@@ -9413,7 +9425,7 @@
     </p:spTree>
     <p:extLst>
       <p:ext uri="{BB962C8B-B14F-4D97-AF65-F5344CB8AC3E}">
-        <p14:creationId xmlns:p14="http://schemas.microsoft.com/office/powerpoint/2010/main" val="2230587274"/>
+        <p14:creationId xmlns:p14="http://schemas.microsoft.com/office/powerpoint/2010/main" val="2761154220"/>
       </p:ext>
     </p:extLst>
   </p:cSld>
@@ -9453,7 +9465,7 @@
           <p:cNvPr id="2" name="TextBox 1">
             <a:extLst>
               <a:ext uri="{FF2B5EF4-FFF2-40B4-BE49-F238E27FC236}">
-                <a16:creationId xmlns:a16="http://schemas.microsoft.com/office/drawing/2014/main" id="{1506993F-71CA-7E99-C903-A55AF14FF905}"/>
+                <a16:creationId xmlns:a16="http://schemas.microsoft.com/office/drawing/2014/main" id="{8BBD5741-0879-0317-DDD6-A91DCDDED07B}"/>
               </a:ext>
             </a:extLst>
           </p:cNvPr>
@@ -9493,7 +9505,7 @@
           <p:cNvPr id="3" name="Straight Connector 2">
             <a:extLst>
               <a:ext uri="{FF2B5EF4-FFF2-40B4-BE49-F238E27FC236}">
-                <a16:creationId xmlns:a16="http://schemas.microsoft.com/office/drawing/2014/main" id="{E2605044-E674-BAE7-2CF6-4B49D19E5204}"/>
+                <a16:creationId xmlns:a16="http://schemas.microsoft.com/office/drawing/2014/main" id="{E9269E04-114C-6E82-734C-AC92C9DDA6CE}"/>
               </a:ext>
             </a:extLst>
           </p:cNvPr>
@@ -9534,7 +9546,7 @@
           <p:cNvPr id="4" name="TextBox 3">
             <a:extLst>
               <a:ext uri="{FF2B5EF4-FFF2-40B4-BE49-F238E27FC236}">
-                <a16:creationId xmlns:a16="http://schemas.microsoft.com/office/drawing/2014/main" id="{BCF34079-7B01-5344-70D9-21D45668C3B9}"/>
+                <a16:creationId xmlns:a16="http://schemas.microsoft.com/office/drawing/2014/main" id="{D4CFCD2C-7835-3E3D-FE30-64437C13A7C6}"/>
               </a:ext>
             </a:extLst>
           </p:cNvPr>
@@ -9575,7 +9587,7 @@
           <p:cNvPr id="5" name="TextBox 4">
             <a:extLst>
               <a:ext uri="{FF2B5EF4-FFF2-40B4-BE49-F238E27FC236}">
-                <a16:creationId xmlns:a16="http://schemas.microsoft.com/office/drawing/2014/main" id="{FD5507C5-FA02-3878-223A-316C19EC0846}"/>
+                <a16:creationId xmlns:a16="http://schemas.microsoft.com/office/drawing/2014/main" id="{821F48AA-7CE8-B91A-B61B-A03167F9B3CC}"/>
               </a:ext>
             </a:extLst>
           </p:cNvPr>
@@ -9615,7 +9627,7 @@
           <p:cNvPr id="6" name="TextBox 5">
             <a:extLst>
               <a:ext uri="{FF2B5EF4-FFF2-40B4-BE49-F238E27FC236}">
-                <a16:creationId xmlns:a16="http://schemas.microsoft.com/office/drawing/2014/main" id="{EEBA317A-4406-62EC-6C60-A92411BA03C5}"/>
+                <a16:creationId xmlns:a16="http://schemas.microsoft.com/office/drawing/2014/main" id="{7C457114-F049-F056-44B2-05678DFFE5DF}"/>
               </a:ext>
             </a:extLst>
           </p:cNvPr>
@@ -9655,7 +9667,7 @@
           <p:cNvPr id="7" name="Straight Connector 6">
             <a:extLst>
               <a:ext uri="{FF2B5EF4-FFF2-40B4-BE49-F238E27FC236}">
-                <a16:creationId xmlns:a16="http://schemas.microsoft.com/office/drawing/2014/main" id="{7BB52E0D-6C22-6A66-B14C-BB96D2469E9A}"/>
+                <a16:creationId xmlns:a16="http://schemas.microsoft.com/office/drawing/2014/main" id="{48619450-86EB-87C8-E793-907853D313F9}"/>
               </a:ext>
             </a:extLst>
           </p:cNvPr>
@@ -9696,7 +9708,7 @@
           <p:cNvPr id="8" name="TextBox 7">
             <a:extLst>
               <a:ext uri="{FF2B5EF4-FFF2-40B4-BE49-F238E27FC236}">
-                <a16:creationId xmlns:a16="http://schemas.microsoft.com/office/drawing/2014/main" id="{ED0EE1B9-E3CB-7438-5595-8F2E2C3C4C5C}"/>
+                <a16:creationId xmlns:a16="http://schemas.microsoft.com/office/drawing/2014/main" id="{18D199EF-EA8E-8FA4-EFBA-D6D601FB2179}"/>
               </a:ext>
             </a:extLst>
           </p:cNvPr>
@@ -9736,7 +9748,7 @@
           <p:cNvPr id="9" name="Straight Connector 8">
             <a:extLst>
               <a:ext uri="{FF2B5EF4-FFF2-40B4-BE49-F238E27FC236}">
-                <a16:creationId xmlns:a16="http://schemas.microsoft.com/office/drawing/2014/main" id="{DEAB17CC-66DD-CF0D-1E07-A6258F4924A4}"/>
+                <a16:creationId xmlns:a16="http://schemas.microsoft.com/office/drawing/2014/main" id="{12CC7513-2E19-9ADE-9007-E0E0D55AA9AE}"/>
               </a:ext>
             </a:extLst>
           </p:cNvPr>
@@ -9777,7 +9789,7 @@
           <p:cNvPr id="10" name="TextBox 9">
             <a:extLst>
               <a:ext uri="{FF2B5EF4-FFF2-40B4-BE49-F238E27FC236}">
-                <a16:creationId xmlns:a16="http://schemas.microsoft.com/office/drawing/2014/main" id="{32E26B9C-9395-A663-6E82-397BE06FFE56}"/>
+                <a16:creationId xmlns:a16="http://schemas.microsoft.com/office/drawing/2014/main" id="{4FD2C7CA-30EA-7B62-FF64-B79365967114}"/>
               </a:ext>
             </a:extLst>
           </p:cNvPr>
@@ -9817,7 +9829,7 @@
           <p:cNvPr id="11" name="Straight Connector 10">
             <a:extLst>
               <a:ext uri="{FF2B5EF4-FFF2-40B4-BE49-F238E27FC236}">
-                <a16:creationId xmlns:a16="http://schemas.microsoft.com/office/drawing/2014/main" id="{086C4D82-7D9B-5FFC-8861-364F942E69A1}"/>
+                <a16:creationId xmlns:a16="http://schemas.microsoft.com/office/drawing/2014/main" id="{96B20904-B8C8-E38F-C945-49E327BA1F4A}"/>
               </a:ext>
             </a:extLst>
           </p:cNvPr>
@@ -9858,7 +9870,7 @@
           <p:cNvPr id="12" name="TextBox 11">
             <a:extLst>
               <a:ext uri="{FF2B5EF4-FFF2-40B4-BE49-F238E27FC236}">
-                <a16:creationId xmlns:a16="http://schemas.microsoft.com/office/drawing/2014/main" id="{AB395B68-71C4-E9D5-8655-1FC0E636FB2C}"/>
+                <a16:creationId xmlns:a16="http://schemas.microsoft.com/office/drawing/2014/main" id="{E32FD062-7FEC-6935-6BF6-6D207BBE3FDD}"/>
               </a:ext>
             </a:extLst>
           </p:cNvPr>
@@ -9898,7 +9910,7 @@
           <p:cNvPr id="13" name="Rectangle: Rounded Corners 12">
             <a:extLst>
               <a:ext uri="{FF2B5EF4-FFF2-40B4-BE49-F238E27FC236}">
-                <a16:creationId xmlns:a16="http://schemas.microsoft.com/office/drawing/2014/main" id="{63C30E1E-62F9-AA9C-2EDF-3302DF56EBA4}"/>
+                <a16:creationId xmlns:a16="http://schemas.microsoft.com/office/drawing/2014/main" id="{23687734-9E18-3135-9C9E-A15B702AF5C1}"/>
               </a:ext>
             </a:extLst>
           </p:cNvPr>
@@ -9952,7 +9964,7 @@
           <p:cNvPr id="15" name="Picture 14" descr="Overview showing seven administrative locality boundaries and frozen outcomes">
             <a:extLst>
               <a:ext uri="{FF2B5EF4-FFF2-40B4-BE49-F238E27FC236}">
-                <a16:creationId xmlns:a16="http://schemas.microsoft.com/office/drawing/2014/main" id="{784DF85B-E74B-CF58-53ED-65093A6B519A}"/>
+                <a16:creationId xmlns:a16="http://schemas.microsoft.com/office/drawing/2014/main" id="{AF5D3578-F201-F610-657F-443C9A55E5C1}"/>
               </a:ext>
             </a:extLst>
           </p:cNvPr>
@@ -9988,7 +10000,7 @@
           <p:cNvPr id="16" name="TextBox 15">
             <a:extLst>
               <a:ext uri="{FF2B5EF4-FFF2-40B4-BE49-F238E27FC236}">
-                <a16:creationId xmlns:a16="http://schemas.microsoft.com/office/drawing/2014/main" id="{618CF5F5-5269-50B1-7EDC-FED472E5C2BA}"/>
+                <a16:creationId xmlns:a16="http://schemas.microsoft.com/office/drawing/2014/main" id="{DD9694C1-379E-A770-D9E9-651767172173}"/>
               </a:ext>
             </a:extLst>
           </p:cNvPr>
@@ -10026,7 +10038,7 @@
     </p:spTree>
     <p:extLst>
       <p:ext uri="{BB962C8B-B14F-4D97-AF65-F5344CB8AC3E}">
-        <p14:creationId xmlns:p14="http://schemas.microsoft.com/office/powerpoint/2010/main" val="1264931409"/>
+        <p14:creationId xmlns:p14="http://schemas.microsoft.com/office/powerpoint/2010/main" val="442897055"/>
       </p:ext>
     </p:extLst>
   </p:cSld>
@@ -10066,7 +10078,7 @@
           <p:cNvPr id="2" name="TextBox 1">
             <a:extLst>
               <a:ext uri="{FF2B5EF4-FFF2-40B4-BE49-F238E27FC236}">
-                <a16:creationId xmlns:a16="http://schemas.microsoft.com/office/drawing/2014/main" id="{CBBFC4FE-5F6D-B32B-D0F1-9FFD2AF25E55}"/>
+                <a16:creationId xmlns:a16="http://schemas.microsoft.com/office/drawing/2014/main" id="{FD4CF0F3-0408-F5AA-416B-5E76F9D81A82}"/>
               </a:ext>
             </a:extLst>
           </p:cNvPr>
@@ -10106,7 +10118,7 @@
           <p:cNvPr id="3" name="Straight Connector 2">
             <a:extLst>
               <a:ext uri="{FF2B5EF4-FFF2-40B4-BE49-F238E27FC236}">
-                <a16:creationId xmlns:a16="http://schemas.microsoft.com/office/drawing/2014/main" id="{09FA356C-E36F-7C65-6D1F-24F97013694F}"/>
+                <a16:creationId xmlns:a16="http://schemas.microsoft.com/office/drawing/2014/main" id="{10882362-6390-5090-A29F-E4B01B77E519}"/>
               </a:ext>
             </a:extLst>
           </p:cNvPr>
@@ -10147,7 +10159,7 @@
           <p:cNvPr id="4" name="TextBox 3">
             <a:extLst>
               <a:ext uri="{FF2B5EF4-FFF2-40B4-BE49-F238E27FC236}">
-                <a16:creationId xmlns:a16="http://schemas.microsoft.com/office/drawing/2014/main" id="{CB93CFBF-74A5-F6C0-5381-2BFB7B90EE6F}"/>
+                <a16:creationId xmlns:a16="http://schemas.microsoft.com/office/drawing/2014/main" id="{EE8CAE7F-CB1D-FBC6-3641-600F68DD5B4D}"/>
               </a:ext>
             </a:extLst>
           </p:cNvPr>
@@ -10188,7 +10200,7 @@
           <p:cNvPr id="5" name="TextBox 4">
             <a:extLst>
               <a:ext uri="{FF2B5EF4-FFF2-40B4-BE49-F238E27FC236}">
-                <a16:creationId xmlns:a16="http://schemas.microsoft.com/office/drawing/2014/main" id="{CAB24B19-DF68-9210-1EA0-C17070DC5A36}"/>
+                <a16:creationId xmlns:a16="http://schemas.microsoft.com/office/drawing/2014/main" id="{03B0742E-3FE2-7F4A-72E6-F342F2930327}"/>
               </a:ext>
             </a:extLst>
           </p:cNvPr>
@@ -10228,7 +10240,7 @@
           <p:cNvPr id="6" name="TextBox 5">
             <a:extLst>
               <a:ext uri="{FF2B5EF4-FFF2-40B4-BE49-F238E27FC236}">
-                <a16:creationId xmlns:a16="http://schemas.microsoft.com/office/drawing/2014/main" id="{63D40B47-DD91-4DC2-08A3-014C7E0FA285}"/>
+                <a16:creationId xmlns:a16="http://schemas.microsoft.com/office/drawing/2014/main" id="{A4BCB82C-6A17-3B2B-9F15-508A73A912DC}"/>
               </a:ext>
             </a:extLst>
           </p:cNvPr>
@@ -10268,7 +10280,7 @@
           <p:cNvPr id="7" name="Straight Connector 6">
             <a:extLst>
               <a:ext uri="{FF2B5EF4-FFF2-40B4-BE49-F238E27FC236}">
-                <a16:creationId xmlns:a16="http://schemas.microsoft.com/office/drawing/2014/main" id="{45B2AFAE-40CE-712A-112A-2F7B90A65285}"/>
+                <a16:creationId xmlns:a16="http://schemas.microsoft.com/office/drawing/2014/main" id="{AF083351-0B4E-0032-C457-184DA0ADB757}"/>
               </a:ext>
             </a:extLst>
           </p:cNvPr>
@@ -10310,7 +10322,7 @@
           <p:cNvPr id="8" name="Straight Connector 7">
             <a:extLst>
               <a:ext uri="{FF2B5EF4-FFF2-40B4-BE49-F238E27FC236}">
-                <a16:creationId xmlns:a16="http://schemas.microsoft.com/office/drawing/2014/main" id="{BF609829-D52C-504D-C27F-026C2D342D89}"/>
+                <a16:creationId xmlns:a16="http://schemas.microsoft.com/office/drawing/2014/main" id="{5495474F-648A-79FE-0F15-37D7C8968C73}"/>
               </a:ext>
             </a:extLst>
           </p:cNvPr>
@@ -10352,7 +10364,7 @@
           <p:cNvPr id="9" name="Straight Connector 8">
             <a:extLst>
               <a:ext uri="{FF2B5EF4-FFF2-40B4-BE49-F238E27FC236}">
-                <a16:creationId xmlns:a16="http://schemas.microsoft.com/office/drawing/2014/main" id="{F0702623-410C-C4A8-D267-6E8262C08CB3}"/>
+                <a16:creationId xmlns:a16="http://schemas.microsoft.com/office/drawing/2014/main" id="{4EFCBBA2-7517-1AF0-7663-6941CB30006D}"/>
               </a:ext>
             </a:extLst>
           </p:cNvPr>
@@ -10394,7 +10406,7 @@
           <p:cNvPr id="10" name="Straight Connector 9">
             <a:extLst>
               <a:ext uri="{FF2B5EF4-FFF2-40B4-BE49-F238E27FC236}">
-                <a16:creationId xmlns:a16="http://schemas.microsoft.com/office/drawing/2014/main" id="{87916E89-80E0-CF3B-9A19-8A31D5B9BCF3}"/>
+                <a16:creationId xmlns:a16="http://schemas.microsoft.com/office/drawing/2014/main" id="{9C6B4CE2-29FF-B24B-5171-680E01F0898A}"/>
               </a:ext>
             </a:extLst>
           </p:cNvPr>
@@ -10436,7 +10448,7 @@
           <p:cNvPr id="11" name="Rectangle: Rounded Corners 10">
             <a:extLst>
               <a:ext uri="{FF2B5EF4-FFF2-40B4-BE49-F238E27FC236}">
-                <a16:creationId xmlns:a16="http://schemas.microsoft.com/office/drawing/2014/main" id="{AAC208A1-D7EA-67F1-E015-CD1B375C2DFF}"/>
+                <a16:creationId xmlns:a16="http://schemas.microsoft.com/office/drawing/2014/main" id="{AC5CEDED-DA95-59C1-7ABD-486ECBEF1956}"/>
               </a:ext>
             </a:extLst>
           </p:cNvPr>
@@ -10504,7 +10516,7 @@
           <p:cNvPr id="12" name="TextBox 11">
             <a:extLst>
               <a:ext uri="{FF2B5EF4-FFF2-40B4-BE49-F238E27FC236}">
-                <a16:creationId xmlns:a16="http://schemas.microsoft.com/office/drawing/2014/main" id="{561CBB95-393C-BEE0-6ECA-09E9E88878E3}"/>
+                <a16:creationId xmlns:a16="http://schemas.microsoft.com/office/drawing/2014/main" id="{6465ED5C-11C6-A334-526D-D7B4D417519B}"/>
               </a:ext>
             </a:extLst>
           </p:cNvPr>
@@ -10557,7 +10569,7 @@
           <p:cNvPr id="13" name="Rectangle: Rounded Corners 12">
             <a:extLst>
               <a:ext uri="{FF2B5EF4-FFF2-40B4-BE49-F238E27FC236}">
-                <a16:creationId xmlns:a16="http://schemas.microsoft.com/office/drawing/2014/main" id="{0611576D-C145-9645-E53D-79E7B2DD7928}"/>
+                <a16:creationId xmlns:a16="http://schemas.microsoft.com/office/drawing/2014/main" id="{F70E7D94-36EE-0E9E-116F-4FD1CD022333}"/>
               </a:ext>
             </a:extLst>
           </p:cNvPr>
@@ -10625,7 +10637,7 @@
           <p:cNvPr id="14" name="TextBox 13">
             <a:extLst>
               <a:ext uri="{FF2B5EF4-FFF2-40B4-BE49-F238E27FC236}">
-                <a16:creationId xmlns:a16="http://schemas.microsoft.com/office/drawing/2014/main" id="{6AA30D01-49E0-E0C3-7078-782C1AE07230}"/>
+                <a16:creationId xmlns:a16="http://schemas.microsoft.com/office/drawing/2014/main" id="{922B0B24-13A4-5AFE-95EA-4685A8EE083F}"/>
               </a:ext>
             </a:extLst>
           </p:cNvPr>
@@ -10678,7 +10690,7 @@
           <p:cNvPr id="15" name="Rectangle: Rounded Corners 14">
             <a:extLst>
               <a:ext uri="{FF2B5EF4-FFF2-40B4-BE49-F238E27FC236}">
-                <a16:creationId xmlns:a16="http://schemas.microsoft.com/office/drawing/2014/main" id="{D99467F6-E271-6500-78EC-849AEF5F5A49}"/>
+                <a16:creationId xmlns:a16="http://schemas.microsoft.com/office/drawing/2014/main" id="{C5CADE38-36B5-8683-1A28-0B4CE63BBFDF}"/>
               </a:ext>
             </a:extLst>
           </p:cNvPr>
@@ -10746,7 +10758,7 @@
           <p:cNvPr id="16" name="TextBox 15">
             <a:extLst>
               <a:ext uri="{FF2B5EF4-FFF2-40B4-BE49-F238E27FC236}">
-                <a16:creationId xmlns:a16="http://schemas.microsoft.com/office/drawing/2014/main" id="{13C838EA-478A-DBCF-8FFB-6CA375203536}"/>
+                <a16:creationId xmlns:a16="http://schemas.microsoft.com/office/drawing/2014/main" id="{8A26D17F-4053-9552-2728-BE626CD95E9B}"/>
               </a:ext>
             </a:extLst>
           </p:cNvPr>
@@ -10799,7 +10811,7 @@
           <p:cNvPr id="17" name="Rectangle: Rounded Corners 16">
             <a:extLst>
               <a:ext uri="{FF2B5EF4-FFF2-40B4-BE49-F238E27FC236}">
-                <a16:creationId xmlns:a16="http://schemas.microsoft.com/office/drawing/2014/main" id="{148D6551-137C-A73F-A279-663ACBC84E10}"/>
+                <a16:creationId xmlns:a16="http://schemas.microsoft.com/office/drawing/2014/main" id="{7103170F-7471-3F32-4E53-31DE40DBCF34}"/>
               </a:ext>
             </a:extLst>
           </p:cNvPr>
@@ -10867,7 +10879,7 @@
           <p:cNvPr id="18" name="TextBox 17">
             <a:extLst>
               <a:ext uri="{FF2B5EF4-FFF2-40B4-BE49-F238E27FC236}">
-                <a16:creationId xmlns:a16="http://schemas.microsoft.com/office/drawing/2014/main" id="{C95CA618-AD91-E8CC-578A-4CD9F7E0FF7C}"/>
+                <a16:creationId xmlns:a16="http://schemas.microsoft.com/office/drawing/2014/main" id="{A1B904DE-BCCE-B60C-C02D-3F31C41EBA97}"/>
               </a:ext>
             </a:extLst>
           </p:cNvPr>
@@ -10920,7 +10932,7 @@
           <p:cNvPr id="19" name="Rectangle: Rounded Corners 18">
             <a:extLst>
               <a:ext uri="{FF2B5EF4-FFF2-40B4-BE49-F238E27FC236}">
-                <a16:creationId xmlns:a16="http://schemas.microsoft.com/office/drawing/2014/main" id="{C339A014-AFD4-3ABF-3F5D-EE86D6545156}"/>
+                <a16:creationId xmlns:a16="http://schemas.microsoft.com/office/drawing/2014/main" id="{24403B61-0FE6-083B-387D-6883E58E7767}"/>
               </a:ext>
             </a:extLst>
           </p:cNvPr>
@@ -10988,7 +11000,7 @@
           <p:cNvPr id="20" name="TextBox 19">
             <a:extLst>
               <a:ext uri="{FF2B5EF4-FFF2-40B4-BE49-F238E27FC236}">
-                <a16:creationId xmlns:a16="http://schemas.microsoft.com/office/drawing/2014/main" id="{21A81EA7-E8BA-AFD7-9987-811D6FD64EB8}"/>
+                <a16:creationId xmlns:a16="http://schemas.microsoft.com/office/drawing/2014/main" id="{F55F4A99-2552-C82B-5C42-F1C8A495EBB5}"/>
               </a:ext>
             </a:extLst>
           </p:cNvPr>
@@ -11041,7 +11053,7 @@
           <p:cNvPr id="21" name="TextBox 20">
             <a:extLst>
               <a:ext uri="{FF2B5EF4-FFF2-40B4-BE49-F238E27FC236}">
-                <a16:creationId xmlns:a16="http://schemas.microsoft.com/office/drawing/2014/main" id="{363D80A8-70D7-E78E-8EB1-0D7C41635475}"/>
+                <a16:creationId xmlns:a16="http://schemas.microsoft.com/office/drawing/2014/main" id="{5F5E9FE7-F5AC-E9D6-8079-A0C895A6A9F3}"/>
               </a:ext>
             </a:extLst>
           </p:cNvPr>
@@ -11081,7 +11093,7 @@
           <p:cNvPr id="22" name="Straight Connector 21">
             <a:extLst>
               <a:ext uri="{FF2B5EF4-FFF2-40B4-BE49-F238E27FC236}">
-                <a16:creationId xmlns:a16="http://schemas.microsoft.com/office/drawing/2014/main" id="{D6A99D17-93ED-710B-33C8-AC679F84713D}"/>
+                <a16:creationId xmlns:a16="http://schemas.microsoft.com/office/drawing/2014/main" id="{1831B05F-EBF6-7862-0F0F-ADB955985385}"/>
               </a:ext>
             </a:extLst>
           </p:cNvPr>
@@ -11122,7 +11134,7 @@
           <p:cNvPr id="23" name="TextBox 22">
             <a:extLst>
               <a:ext uri="{FF2B5EF4-FFF2-40B4-BE49-F238E27FC236}">
-                <a16:creationId xmlns:a16="http://schemas.microsoft.com/office/drawing/2014/main" id="{FAB2AEEC-1C5E-6558-B77E-E31359CCA6C8}"/>
+                <a16:creationId xmlns:a16="http://schemas.microsoft.com/office/drawing/2014/main" id="{D8CE97A7-88C4-E8BD-37FE-39146C346687}"/>
               </a:ext>
             </a:extLst>
           </p:cNvPr>
@@ -11162,7 +11174,7 @@
           <p:cNvPr id="24" name="TextBox 23">
             <a:extLst>
               <a:ext uri="{FF2B5EF4-FFF2-40B4-BE49-F238E27FC236}">
-                <a16:creationId xmlns:a16="http://schemas.microsoft.com/office/drawing/2014/main" id="{46273824-187B-E62A-C905-ADA790801BE3}"/>
+                <a16:creationId xmlns:a16="http://schemas.microsoft.com/office/drawing/2014/main" id="{FDDF58C2-BB79-55A9-A3A4-FA6CD210E0B3}"/>
               </a:ext>
             </a:extLst>
           </p:cNvPr>
@@ -11202,7 +11214,7 @@
           <p:cNvPr id="25" name="TextBox 24">
             <a:extLst>
               <a:ext uri="{FF2B5EF4-FFF2-40B4-BE49-F238E27FC236}">
-                <a16:creationId xmlns:a16="http://schemas.microsoft.com/office/drawing/2014/main" id="{34E05AC5-2789-6E52-10F4-715479E9AE3B}"/>
+                <a16:creationId xmlns:a16="http://schemas.microsoft.com/office/drawing/2014/main" id="{35ED4BC8-1E9A-F29E-6C9E-1C594820DDDB}"/>
               </a:ext>
             </a:extLst>
           </p:cNvPr>
@@ -11240,7 +11252,7 @@
     </p:spTree>
     <p:extLst>
       <p:ext uri="{BB962C8B-B14F-4D97-AF65-F5344CB8AC3E}">
-        <p14:creationId xmlns:p14="http://schemas.microsoft.com/office/powerpoint/2010/main" val="805243974"/>
+        <p14:creationId xmlns:p14="http://schemas.microsoft.com/office/powerpoint/2010/main" val="1498952719"/>
       </p:ext>
     </p:extLst>
   </p:cSld>
@@ -11280,7 +11292,7 @@
           <p:cNvPr id="2" name="TextBox 1">
             <a:extLst>
               <a:ext uri="{FF2B5EF4-FFF2-40B4-BE49-F238E27FC236}">
-                <a16:creationId xmlns:a16="http://schemas.microsoft.com/office/drawing/2014/main" id="{767A68DE-FE26-6DD2-450B-AB3DA4BAE6E0}"/>
+                <a16:creationId xmlns:a16="http://schemas.microsoft.com/office/drawing/2014/main" id="{59B46F43-024F-0AAC-1212-659E9E688B5C}"/>
               </a:ext>
             </a:extLst>
           </p:cNvPr>
@@ -11320,7 +11332,7 @@
           <p:cNvPr id="3" name="Straight Connector 2">
             <a:extLst>
               <a:ext uri="{FF2B5EF4-FFF2-40B4-BE49-F238E27FC236}">
-                <a16:creationId xmlns:a16="http://schemas.microsoft.com/office/drawing/2014/main" id="{4F454A26-B1B3-153E-94B9-AF6BB885D90D}"/>
+                <a16:creationId xmlns:a16="http://schemas.microsoft.com/office/drawing/2014/main" id="{1F9DB25B-1BAA-E530-80C7-486B12F5F1AE}"/>
               </a:ext>
             </a:extLst>
           </p:cNvPr>
@@ -11361,7 +11373,7 @@
           <p:cNvPr id="4" name="TextBox 3">
             <a:extLst>
               <a:ext uri="{FF2B5EF4-FFF2-40B4-BE49-F238E27FC236}">
-                <a16:creationId xmlns:a16="http://schemas.microsoft.com/office/drawing/2014/main" id="{C166A9EB-C99B-D91B-4B91-0393EF2AFFBB}"/>
+                <a16:creationId xmlns:a16="http://schemas.microsoft.com/office/drawing/2014/main" id="{68634E80-4301-B8B6-5595-515A115D8296}"/>
               </a:ext>
             </a:extLst>
           </p:cNvPr>
@@ -11402,7 +11414,7 @@
           <p:cNvPr id="5" name="TextBox 4">
             <a:extLst>
               <a:ext uri="{FF2B5EF4-FFF2-40B4-BE49-F238E27FC236}">
-                <a16:creationId xmlns:a16="http://schemas.microsoft.com/office/drawing/2014/main" id="{119D7BEB-B668-27E0-BCFA-A85DE7CEE8B0}"/>
+                <a16:creationId xmlns:a16="http://schemas.microsoft.com/office/drawing/2014/main" id="{01048670-D933-3228-AD8B-AA0B869CAEAF}"/>
               </a:ext>
             </a:extLst>
           </p:cNvPr>
@@ -11442,7 +11454,7 @@
           <p:cNvPr id="6" name="TextBox 5">
             <a:extLst>
               <a:ext uri="{FF2B5EF4-FFF2-40B4-BE49-F238E27FC236}">
-                <a16:creationId xmlns:a16="http://schemas.microsoft.com/office/drawing/2014/main" id="{C7F6CE42-67FF-98A1-AC36-B3E6AE522EB2}"/>
+                <a16:creationId xmlns:a16="http://schemas.microsoft.com/office/drawing/2014/main" id="{EA4AABC3-22F6-DA33-C5BF-DC450ED35967}"/>
               </a:ext>
             </a:extLst>
           </p:cNvPr>
@@ -11482,7 +11494,7 @@
           <p:cNvPr id="7" name="Rectangle: Rounded Corners 6">
             <a:extLst>
               <a:ext uri="{FF2B5EF4-FFF2-40B4-BE49-F238E27FC236}">
-                <a16:creationId xmlns:a16="http://schemas.microsoft.com/office/drawing/2014/main" id="{E15081A7-C284-7213-49CF-41F353692B73}"/>
+                <a16:creationId xmlns:a16="http://schemas.microsoft.com/office/drawing/2014/main" id="{E1F92BC8-A575-A4EB-ACC4-EC739053A59E}"/>
               </a:ext>
             </a:extLst>
           </p:cNvPr>
@@ -11550,7 +11562,7 @@
           <p:cNvPr id="8" name="TextBox 7">
             <a:extLst>
               <a:ext uri="{FF2B5EF4-FFF2-40B4-BE49-F238E27FC236}">
-                <a16:creationId xmlns:a16="http://schemas.microsoft.com/office/drawing/2014/main" id="{D282A05F-E673-CBDA-FD44-6513F48072B1}"/>
+                <a16:creationId xmlns:a16="http://schemas.microsoft.com/office/drawing/2014/main" id="{5284E885-5280-10CC-3F04-2B131EF9F65A}"/>
               </a:ext>
             </a:extLst>
           </p:cNvPr>
@@ -11591,7 +11603,7 @@
           <p:cNvPr id="9" name="TextBox 8">
             <a:extLst>
               <a:ext uri="{FF2B5EF4-FFF2-40B4-BE49-F238E27FC236}">
-                <a16:creationId xmlns:a16="http://schemas.microsoft.com/office/drawing/2014/main" id="{950288BC-D9E8-93F4-9575-57FD5787D831}"/>
+                <a16:creationId xmlns:a16="http://schemas.microsoft.com/office/drawing/2014/main" id="{73551DAA-BC69-5CE3-EC2C-CD6F22F6F6B0}"/>
               </a:ext>
             </a:extLst>
           </p:cNvPr>
@@ -11622,7 +11634,7 @@
                 </a:solidFill>
                 <a:latin typeface="Aptos" panose="020B0004020202020204" pitchFamily="34" charset="0"/>
               </a:rPr>
-              <a:t>10 untouched seeds x 32 episodes</a:t>
+              <a:t>10 seeds x 32 episodes</a:t>
             </a:r>
           </a:p>
         </p:txBody>
@@ -11632,7 +11644,48 @@
           <p:cNvPr id="10" name="TextBox 9">
             <a:extLst>
               <a:ext uri="{FF2B5EF4-FFF2-40B4-BE49-F238E27FC236}">
-                <a16:creationId xmlns:a16="http://schemas.microsoft.com/office/drawing/2014/main" id="{545ACF30-7CB2-C6D1-4F5F-8D0F7E9938DF}"/>
+                <a16:creationId xmlns:a16="http://schemas.microsoft.com/office/drawing/2014/main" id="{7F82F420-4081-AFDA-B26B-F4030F6DD755}"/>
+              </a:ext>
+            </a:extLst>
+          </p:cNvPr>
+          <p:cNvSpPr txBox="1"/>
+          <p:nvPr/>
+        </p:nvSpPr>
+        <p:spPr>
+          <a:xfrm>
+            <a:off x="787400" y="3632199"/>
+            <a:ext cx="10617200" cy="279400"/>
+          </a:xfrm>
+          <a:prstGeom prst="rect">
+            <a:avLst/>
+          </a:prstGeom>
+          <a:noFill/>
+        </p:spPr>
+        <p:txBody>
+          <a:bodyPr vert="horz" wrap="square" lIns="0" tIns="0" rIns="0" bIns="0" rtlCol="0">
+            <a:noAutofit/>
+          </a:bodyPr>
+          <a:lstStyle/>
+          <a:p>
+            <a:pPr algn="ctr"/>
+            <a:r>
+              <a:rPr lang="en-US" sz="1600" b="1">
+                <a:solidFill>
+                  <a:srgbClr val="83939D"/>
+                </a:solidFill>
+                <a:latin typeface="Aptos" panose="020B0004020202020204" pitchFamily="34" charset="0"/>
+              </a:rPr>
+              <a:t>Documented-seed-disjoint holdout</a:t>
+            </a:r>
+          </a:p>
+        </p:txBody>
+      </p:sp>
+      <p:sp>
+        <p:nvSpPr>
+          <p:cNvPr id="11" name="TextBox 10">
+            <a:extLst>
+              <a:ext uri="{FF2B5EF4-FFF2-40B4-BE49-F238E27FC236}">
+                <a16:creationId xmlns:a16="http://schemas.microsoft.com/office/drawing/2014/main" id="{FD1BBCE7-78E5-1D68-4C8C-A86B484F4612}"/>
               </a:ext>
             </a:extLst>
           </p:cNvPr>
@@ -11670,10 +11723,10 @@
       </p:sp>
       <p:sp>
         <p:nvSpPr>
-          <p:cNvPr id="11" name="Rectangle: Rounded Corners 10">
-            <a:extLst>
-              <a:ext uri="{FF2B5EF4-FFF2-40B4-BE49-F238E27FC236}">
-                <a16:creationId xmlns:a16="http://schemas.microsoft.com/office/drawing/2014/main" id="{D078645D-D074-4212-A84C-D75AF7B865E8}"/>
+          <p:cNvPr id="12" name="Rectangle: Rounded Corners 11">
+            <a:extLst>
+              <a:ext uri="{FF2B5EF4-FFF2-40B4-BE49-F238E27FC236}">
+                <a16:creationId xmlns:a16="http://schemas.microsoft.com/office/drawing/2014/main" id="{9445A692-B7AB-6753-78BE-E189D887280C}"/>
               </a:ext>
             </a:extLst>
           </p:cNvPr>
@@ -11738,10 +11791,10 @@
       </p:sp>
       <p:sp>
         <p:nvSpPr>
-          <p:cNvPr id="12" name="TextBox 11">
-            <a:extLst>
-              <a:ext uri="{FF2B5EF4-FFF2-40B4-BE49-F238E27FC236}">
-                <a16:creationId xmlns:a16="http://schemas.microsoft.com/office/drawing/2014/main" id="{B72ACD19-18D5-1D5D-7E28-BA65F8ECF03C}"/>
+          <p:cNvPr id="13" name="TextBox 12">
+            <a:extLst>
+              <a:ext uri="{FF2B5EF4-FFF2-40B4-BE49-F238E27FC236}">
+                <a16:creationId xmlns:a16="http://schemas.microsoft.com/office/drawing/2014/main" id="{88083DF2-30AB-82B9-58E0-11FF0D22F557}"/>
               </a:ext>
             </a:extLst>
           </p:cNvPr>
@@ -11779,10 +11832,10 @@
       </p:sp>
       <p:sp>
         <p:nvSpPr>
-          <p:cNvPr id="13" name="TextBox 12">
-            <a:extLst>
-              <a:ext uri="{FF2B5EF4-FFF2-40B4-BE49-F238E27FC236}">
-                <a16:creationId xmlns:a16="http://schemas.microsoft.com/office/drawing/2014/main" id="{0CEDA577-6D72-6615-2AC5-D058C772D987}"/>
+          <p:cNvPr id="14" name="TextBox 13">
+            <a:extLst>
+              <a:ext uri="{FF2B5EF4-FFF2-40B4-BE49-F238E27FC236}">
+                <a16:creationId xmlns:a16="http://schemas.microsoft.com/office/drawing/2014/main" id="{3A979D04-7705-9893-3ABA-88DB8896300C}"/>
               </a:ext>
             </a:extLst>
           </p:cNvPr>
@@ -11813,17 +11866,17 @@
                 </a:solidFill>
                 <a:latin typeface="Aptos" panose="020B0004020202020204" pitchFamily="34" charset="0"/>
               </a:rPr>
-              <a:t>mild, moderate, severe shortage</a:t>
-            </a:r>
-          </a:p>
-        </p:txBody>
-      </p:sp>
-      <p:sp>
-        <p:nvSpPr>
-          <p:cNvPr id="14" name="TextBox 13">
-            <a:extLst>
-              <a:ext uri="{FF2B5EF4-FFF2-40B4-BE49-F238E27FC236}">
-                <a16:creationId xmlns:a16="http://schemas.microsoft.com/office/drawing/2014/main" id="{78D99360-90BF-D2E9-450C-6730B5AA58BA}"/>
+              <a:t>Mild, Moderate, Severe shortage</a:t>
+            </a:r>
+          </a:p>
+        </p:txBody>
+      </p:sp>
+      <p:sp>
+        <p:nvSpPr>
+          <p:cNvPr id="15" name="TextBox 14">
+            <a:extLst>
+              <a:ext uri="{FF2B5EF4-FFF2-40B4-BE49-F238E27FC236}">
+                <a16:creationId xmlns:a16="http://schemas.microsoft.com/office/drawing/2014/main" id="{83C6D29F-8E55-19C6-04D0-7935FB2BB2CD}"/>
               </a:ext>
             </a:extLst>
           </p:cNvPr>
@@ -11861,10 +11914,10 @@
       </p:sp>
       <p:sp>
         <p:nvSpPr>
-          <p:cNvPr id="15" name="Rectangle: Rounded Corners 14">
-            <a:extLst>
-              <a:ext uri="{FF2B5EF4-FFF2-40B4-BE49-F238E27FC236}">
-                <a16:creationId xmlns:a16="http://schemas.microsoft.com/office/drawing/2014/main" id="{115BBC45-4B86-B6E2-77A0-4C7F1B253342}"/>
+          <p:cNvPr id="16" name="Rectangle: Rounded Corners 15">
+            <a:extLst>
+              <a:ext uri="{FF2B5EF4-FFF2-40B4-BE49-F238E27FC236}">
+                <a16:creationId xmlns:a16="http://schemas.microsoft.com/office/drawing/2014/main" id="{8A739083-38E1-F2A7-A248-CC72AF8A91B0}"/>
               </a:ext>
             </a:extLst>
           </p:cNvPr>
@@ -11929,10 +11982,10 @@
       </p:sp>
       <p:sp>
         <p:nvSpPr>
-          <p:cNvPr id="16" name="TextBox 15">
-            <a:extLst>
-              <a:ext uri="{FF2B5EF4-FFF2-40B4-BE49-F238E27FC236}">
-                <a16:creationId xmlns:a16="http://schemas.microsoft.com/office/drawing/2014/main" id="{29286F6A-46C0-9FC9-4B6E-B56FA87EB824}"/>
+          <p:cNvPr id="17" name="TextBox 16">
+            <a:extLst>
+              <a:ext uri="{FF2B5EF4-FFF2-40B4-BE49-F238E27FC236}">
+                <a16:creationId xmlns:a16="http://schemas.microsoft.com/office/drawing/2014/main" id="{672495D8-D513-E9D7-D372-DE87CB0354ED}"/>
               </a:ext>
             </a:extLst>
           </p:cNvPr>
@@ -11970,10 +12023,10 @@
       </p:sp>
       <p:sp>
         <p:nvSpPr>
-          <p:cNvPr id="17" name="TextBox 16">
-            <a:extLst>
-              <a:ext uri="{FF2B5EF4-FFF2-40B4-BE49-F238E27FC236}">
-                <a16:creationId xmlns:a16="http://schemas.microsoft.com/office/drawing/2014/main" id="{9A493526-F4D8-B0EA-230E-6B9AFEC62FEF}"/>
+          <p:cNvPr id="18" name="TextBox 17">
+            <a:extLst>
+              <a:ext uri="{FF2B5EF4-FFF2-40B4-BE49-F238E27FC236}">
+                <a16:creationId xmlns:a16="http://schemas.microsoft.com/office/drawing/2014/main" id="{49360196-DC01-8BBD-6EF4-E5C21F61CFFF}"/>
               </a:ext>
             </a:extLst>
           </p:cNvPr>
@@ -12011,10 +12064,10 @@
       </p:sp>
       <p:cxnSp>
         <p:nvCxnSpPr>
-          <p:cNvPr id="18" name="Straight Connector 17">
-            <a:extLst>
-              <a:ext uri="{FF2B5EF4-FFF2-40B4-BE49-F238E27FC236}">
-                <a16:creationId xmlns:a16="http://schemas.microsoft.com/office/drawing/2014/main" id="{FF1AF3FF-5D39-55ED-7643-163C4CC53CDF}"/>
+          <p:cNvPr id="19" name="Straight Connector 18">
+            <a:extLst>
+              <a:ext uri="{FF2B5EF4-FFF2-40B4-BE49-F238E27FC236}">
+                <a16:creationId xmlns:a16="http://schemas.microsoft.com/office/drawing/2014/main" id="{A0621D2B-7989-DBA2-EA93-7E8AEF2A0B6C}"/>
               </a:ext>
             </a:extLst>
           </p:cNvPr>
@@ -12052,10 +12105,10 @@
       </p:cxnSp>
       <p:sp>
         <p:nvSpPr>
-          <p:cNvPr id="19" name="TextBox 18">
-            <a:extLst>
-              <a:ext uri="{FF2B5EF4-FFF2-40B4-BE49-F238E27FC236}">
-                <a16:creationId xmlns:a16="http://schemas.microsoft.com/office/drawing/2014/main" id="{FFD6334D-7ADF-727E-E6C6-19653130544A}"/>
+          <p:cNvPr id="20" name="TextBox 19">
+            <a:extLst>
+              <a:ext uri="{FF2B5EF4-FFF2-40B4-BE49-F238E27FC236}">
+                <a16:creationId xmlns:a16="http://schemas.microsoft.com/office/drawing/2014/main" id="{2277A425-C4D3-68F6-A703-AB80FE3850F2}"/>
               </a:ext>
             </a:extLst>
           </p:cNvPr>
@@ -12092,10 +12145,10 @@
       </p:sp>
       <p:sp>
         <p:nvSpPr>
-          <p:cNvPr id="20" name="TextBox 19">
-            <a:extLst>
-              <a:ext uri="{FF2B5EF4-FFF2-40B4-BE49-F238E27FC236}">
-                <a16:creationId xmlns:a16="http://schemas.microsoft.com/office/drawing/2014/main" id="{B6F5370E-D36C-A8F3-56C7-88E69866EE54}"/>
+          <p:cNvPr id="21" name="TextBox 20">
+            <a:extLst>
+              <a:ext uri="{FF2B5EF4-FFF2-40B4-BE49-F238E27FC236}">
+                <a16:creationId xmlns:a16="http://schemas.microsoft.com/office/drawing/2014/main" id="{AB044164-8CFB-CD0C-0505-D0FEF4B08D98}"/>
               </a:ext>
             </a:extLst>
           </p:cNvPr>
@@ -12143,10 +12196,10 @@
       </p:sp>
       <p:sp>
         <p:nvSpPr>
-          <p:cNvPr id="21" name="TextBox 20">
-            <a:extLst>
-              <a:ext uri="{FF2B5EF4-FFF2-40B4-BE49-F238E27FC236}">
-                <a16:creationId xmlns:a16="http://schemas.microsoft.com/office/drawing/2014/main" id="{CACBBD4F-A5B7-7BA6-F91D-F4970DCE9E8B}"/>
+          <p:cNvPr id="22" name="TextBox 21">
+            <a:extLst>
+              <a:ext uri="{FF2B5EF4-FFF2-40B4-BE49-F238E27FC236}">
+                <a16:creationId xmlns:a16="http://schemas.microsoft.com/office/drawing/2014/main" id="{F19D95C2-C796-EB87-FA53-399ED8C4DBF9}"/>
               </a:ext>
             </a:extLst>
           </p:cNvPr>
@@ -12183,10 +12236,10 @@
       </p:sp>
       <p:sp>
         <p:nvSpPr>
-          <p:cNvPr id="22" name="TextBox 21">
-            <a:extLst>
-              <a:ext uri="{FF2B5EF4-FFF2-40B4-BE49-F238E27FC236}">
-                <a16:creationId xmlns:a16="http://schemas.microsoft.com/office/drawing/2014/main" id="{16B682F7-1340-DCF0-0063-747F32ECBAE0}"/>
+          <p:cNvPr id="23" name="TextBox 22">
+            <a:extLst>
+              <a:ext uri="{FF2B5EF4-FFF2-40B4-BE49-F238E27FC236}">
+                <a16:creationId xmlns:a16="http://schemas.microsoft.com/office/drawing/2014/main" id="{F1F771E7-C4A0-D4F5-820D-D3400182C4B4}"/>
               </a:ext>
             </a:extLst>
           </p:cNvPr>
@@ -12234,10 +12287,10 @@
       </p:sp>
       <p:sp>
         <p:nvSpPr>
-          <p:cNvPr id="23" name="TextBox 22">
-            <a:extLst>
-              <a:ext uri="{FF2B5EF4-FFF2-40B4-BE49-F238E27FC236}">
-                <a16:creationId xmlns:a16="http://schemas.microsoft.com/office/drawing/2014/main" id="{8AE66367-0D0B-6A16-D78E-E83EAF500F08}"/>
+          <p:cNvPr id="24" name="TextBox 23">
+            <a:extLst>
+              <a:ext uri="{FF2B5EF4-FFF2-40B4-BE49-F238E27FC236}">
+                <a16:creationId xmlns:a16="http://schemas.microsoft.com/office/drawing/2014/main" id="{40C84807-1A6F-48AB-C0B2-16D832D12422}"/>
               </a:ext>
             </a:extLst>
           </p:cNvPr>
@@ -12276,7 +12329,7 @@
     </p:spTree>
     <p:extLst>
       <p:ext uri="{BB962C8B-B14F-4D97-AF65-F5344CB8AC3E}">
-        <p14:creationId xmlns:p14="http://schemas.microsoft.com/office/powerpoint/2010/main" val="1815619948"/>
+        <p14:creationId xmlns:p14="http://schemas.microsoft.com/office/powerpoint/2010/main" val="1967072378"/>
       </p:ext>
     </p:extLst>
   </p:cSld>
@@ -12316,7 +12369,7 @@
           <p:cNvPr id="2" name="TextBox 1">
             <a:extLst>
               <a:ext uri="{FF2B5EF4-FFF2-40B4-BE49-F238E27FC236}">
-                <a16:creationId xmlns:a16="http://schemas.microsoft.com/office/drawing/2014/main" id="{FDC4FE8F-5FD0-2828-AC04-2512685E0826}"/>
+                <a16:creationId xmlns:a16="http://schemas.microsoft.com/office/drawing/2014/main" id="{57904472-C98E-B7E6-369F-A12CE83ECDA0}"/>
               </a:ext>
             </a:extLst>
           </p:cNvPr>
@@ -12356,7 +12409,7 @@
           <p:cNvPr id="3" name="Straight Connector 2">
             <a:extLst>
               <a:ext uri="{FF2B5EF4-FFF2-40B4-BE49-F238E27FC236}">
-                <a16:creationId xmlns:a16="http://schemas.microsoft.com/office/drawing/2014/main" id="{6D98E551-0ABE-A2CD-717C-B7ACCB37E6FF}"/>
+                <a16:creationId xmlns:a16="http://schemas.microsoft.com/office/drawing/2014/main" id="{6B919D22-DF8A-9EDF-40E7-26C5A3657CAE}"/>
               </a:ext>
             </a:extLst>
           </p:cNvPr>
@@ -12397,7 +12450,7 @@
           <p:cNvPr id="4" name="TextBox 3">
             <a:extLst>
               <a:ext uri="{FF2B5EF4-FFF2-40B4-BE49-F238E27FC236}">
-                <a16:creationId xmlns:a16="http://schemas.microsoft.com/office/drawing/2014/main" id="{4E4EF67A-77CB-1FEA-878E-665331A50266}"/>
+                <a16:creationId xmlns:a16="http://schemas.microsoft.com/office/drawing/2014/main" id="{78A8F97F-AB0C-5AAA-D347-45185B86A164}"/>
               </a:ext>
             </a:extLst>
           </p:cNvPr>
@@ -12438,7 +12491,7 @@
           <p:cNvPr id="5" name="TextBox 4">
             <a:extLst>
               <a:ext uri="{FF2B5EF4-FFF2-40B4-BE49-F238E27FC236}">
-                <a16:creationId xmlns:a16="http://schemas.microsoft.com/office/drawing/2014/main" id="{E5BF4BE2-9D2B-3963-8076-5F601D6969D4}"/>
+                <a16:creationId xmlns:a16="http://schemas.microsoft.com/office/drawing/2014/main" id="{6B438FA7-4ECD-F3AF-F771-358698AF86D1}"/>
               </a:ext>
             </a:extLst>
           </p:cNvPr>
@@ -12478,7 +12531,7 @@
           <p:cNvPr id="6" name="TextBox 5">
             <a:extLst>
               <a:ext uri="{FF2B5EF4-FFF2-40B4-BE49-F238E27FC236}">
-                <a16:creationId xmlns:a16="http://schemas.microsoft.com/office/drawing/2014/main" id="{4EBAE97B-251C-4DC0-C970-AD50B2EA1CB5}"/>
+                <a16:creationId xmlns:a16="http://schemas.microsoft.com/office/drawing/2014/main" id="{B69204E0-56AA-08AB-20D3-CB6C583ABACA}"/>
               </a:ext>
             </a:extLst>
           </p:cNvPr>
@@ -12518,7 +12571,7 @@
           <p:cNvPr id="7" name="Rectangle: Rounded Corners 6">
             <a:extLst>
               <a:ext uri="{FF2B5EF4-FFF2-40B4-BE49-F238E27FC236}">
-                <a16:creationId xmlns:a16="http://schemas.microsoft.com/office/drawing/2014/main" id="{0FC9C1D1-299A-52AE-1453-242333570F80}"/>
+                <a16:creationId xmlns:a16="http://schemas.microsoft.com/office/drawing/2014/main" id="{C3A15460-2D17-E4A9-E712-827511363C3D}"/>
               </a:ext>
             </a:extLst>
           </p:cNvPr>
@@ -12572,7 +12625,7 @@
           <p:cNvPr id="8" name="TextBox 7">
             <a:extLst>
               <a:ext uri="{FF2B5EF4-FFF2-40B4-BE49-F238E27FC236}">
-                <a16:creationId xmlns:a16="http://schemas.microsoft.com/office/drawing/2014/main" id="{D802F2B6-F02A-13C5-FFFB-E811BA2B209C}"/>
+                <a16:creationId xmlns:a16="http://schemas.microsoft.com/office/drawing/2014/main" id="{BC562184-C492-233A-80B9-5344C8FC0DFE}"/>
               </a:ext>
             </a:extLst>
           </p:cNvPr>
@@ -12612,7 +12665,7 @@
           <p:cNvPr id="9" name="TextBox 8">
             <a:extLst>
               <a:ext uri="{FF2B5EF4-FFF2-40B4-BE49-F238E27FC236}">
-                <a16:creationId xmlns:a16="http://schemas.microsoft.com/office/drawing/2014/main" id="{3DA39377-84B0-7946-7FEE-DB0E399841C9}"/>
+                <a16:creationId xmlns:a16="http://schemas.microsoft.com/office/drawing/2014/main" id="{E6D61DE2-74F0-3AFD-635C-E0C15E5872D6}"/>
               </a:ext>
             </a:extLst>
           </p:cNvPr>
@@ -12652,7 +12705,7 @@
           <p:cNvPr id="10" name="TextBox 9">
             <a:extLst>
               <a:ext uri="{FF2B5EF4-FFF2-40B4-BE49-F238E27FC236}">
-                <a16:creationId xmlns:a16="http://schemas.microsoft.com/office/drawing/2014/main" id="{F3C784DA-8FA6-D45D-E75D-CC7D63F5178A}"/>
+                <a16:creationId xmlns:a16="http://schemas.microsoft.com/office/drawing/2014/main" id="{614F1728-2DBD-5F68-8F2A-46E442461092}"/>
               </a:ext>
             </a:extLst>
           </p:cNvPr>
@@ -12692,7 +12745,7 @@
           <p:cNvPr id="11" name="TextBox 10">
             <a:extLst>
               <a:ext uri="{FF2B5EF4-FFF2-40B4-BE49-F238E27FC236}">
-                <a16:creationId xmlns:a16="http://schemas.microsoft.com/office/drawing/2014/main" id="{7A9E9D20-BF41-A36F-8162-77CF95AD62CD}"/>
+                <a16:creationId xmlns:a16="http://schemas.microsoft.com/office/drawing/2014/main" id="{7A9D84F5-18CE-6E66-3A53-8218017AD262}"/>
               </a:ext>
             </a:extLst>
           </p:cNvPr>
@@ -12732,7 +12785,7 @@
           <p:cNvPr id="12" name="TextBox 11">
             <a:extLst>
               <a:ext uri="{FF2B5EF4-FFF2-40B4-BE49-F238E27FC236}">
-                <a16:creationId xmlns:a16="http://schemas.microsoft.com/office/drawing/2014/main" id="{1103ABAC-B330-20F1-D3DA-402AAFE033AF}"/>
+                <a16:creationId xmlns:a16="http://schemas.microsoft.com/office/drawing/2014/main" id="{0A26BE46-6495-4615-A80B-10ADFE2E69EC}"/>
               </a:ext>
             </a:extLst>
           </p:cNvPr>
@@ -12772,7 +12825,7 @@
           <p:cNvPr id="13" name="TextBox 12">
             <a:extLst>
               <a:ext uri="{FF2B5EF4-FFF2-40B4-BE49-F238E27FC236}">
-                <a16:creationId xmlns:a16="http://schemas.microsoft.com/office/drawing/2014/main" id="{9C3415B5-C70E-978C-D701-F0634C07CE28}"/>
+                <a16:creationId xmlns:a16="http://schemas.microsoft.com/office/drawing/2014/main" id="{2AF1F138-CD3B-E001-7FF5-F462112665E7}"/>
               </a:ext>
             </a:extLst>
           </p:cNvPr>
@@ -12812,7 +12865,7 @@
           <p:cNvPr id="14" name="TextBox 13">
             <a:extLst>
               <a:ext uri="{FF2B5EF4-FFF2-40B4-BE49-F238E27FC236}">
-                <a16:creationId xmlns:a16="http://schemas.microsoft.com/office/drawing/2014/main" id="{AF5492D1-E824-83A7-59B0-CD10556BDC7E}"/>
+                <a16:creationId xmlns:a16="http://schemas.microsoft.com/office/drawing/2014/main" id="{EE3B1AB7-E85F-049E-D327-FBDB267C6907}"/>
               </a:ext>
             </a:extLst>
           </p:cNvPr>
@@ -12852,7 +12905,7 @@
           <p:cNvPr id="15" name="Straight Connector 14">
             <a:extLst>
               <a:ext uri="{FF2B5EF4-FFF2-40B4-BE49-F238E27FC236}">
-                <a16:creationId xmlns:a16="http://schemas.microsoft.com/office/drawing/2014/main" id="{9884839C-6D9C-B8B1-4547-CF0DB6C42AE6}"/>
+                <a16:creationId xmlns:a16="http://schemas.microsoft.com/office/drawing/2014/main" id="{FD87BEE6-F523-6021-ADD7-80F667DFBF75}"/>
               </a:ext>
             </a:extLst>
           </p:cNvPr>
@@ -12893,7 +12946,7 @@
           <p:cNvPr id="16" name="TextBox 15">
             <a:extLst>
               <a:ext uri="{FF2B5EF4-FFF2-40B4-BE49-F238E27FC236}">
-                <a16:creationId xmlns:a16="http://schemas.microsoft.com/office/drawing/2014/main" id="{A1EFC705-9680-E944-9483-E6A38C7DC9CA}"/>
+                <a16:creationId xmlns:a16="http://schemas.microsoft.com/office/drawing/2014/main" id="{EEFFC9A3-43B0-78C5-E863-772221D2E7E8}"/>
               </a:ext>
             </a:extLst>
           </p:cNvPr>
@@ -12903,7 +12956,7 @@
         <p:spPr>
           <a:xfrm>
             <a:off x="1168400" y="3784599"/>
-            <a:ext cx="4978400" cy="469900"/>
+            <a:ext cx="4978400" cy="393700"/>
           </a:xfrm>
           <a:prstGeom prst="rect">
             <a:avLst/>
@@ -12933,7 +12986,7 @@
           <p:cNvPr id="17" name="Straight Connector 16">
             <a:extLst>
               <a:ext uri="{FF2B5EF4-FFF2-40B4-BE49-F238E27FC236}">
-                <a16:creationId xmlns:a16="http://schemas.microsoft.com/office/drawing/2014/main" id="{5A74A6AE-EE1F-C8B7-B424-D86AFB9F4812}"/>
+                <a16:creationId xmlns:a16="http://schemas.microsoft.com/office/drawing/2014/main" id="{96BDB0F9-D74C-FFAD-ED08-7CFC7BD08878}"/>
               </a:ext>
             </a:extLst>
           </p:cNvPr>
@@ -12942,7 +12995,7 @@
         </p:nvCxnSpPr>
         <p:spPr>
           <a:xfrm>
-            <a:off x="812800" y="4445000"/>
+            <a:off x="812800" y="4368800"/>
             <a:ext cx="203200" cy="0"/>
           </a:xfrm>
           <a:prstGeom prst="line">
@@ -12974,17 +13027,17 @@
           <p:cNvPr id="18" name="TextBox 17">
             <a:extLst>
               <a:ext uri="{FF2B5EF4-FFF2-40B4-BE49-F238E27FC236}">
-                <a16:creationId xmlns:a16="http://schemas.microsoft.com/office/drawing/2014/main" id="{9CCA293D-D32E-BBEF-B939-B97C0DEB1899}"/>
-              </a:ext>
-            </a:extLst>
-          </p:cNvPr>
-          <p:cNvSpPr txBox="1"/>
-          <p:nvPr/>
-        </p:nvSpPr>
-        <p:spPr>
-          <a:xfrm>
-            <a:off x="1168400" y="4292599"/>
-            <a:ext cx="4978400" cy="469900"/>
+                <a16:creationId xmlns:a16="http://schemas.microsoft.com/office/drawing/2014/main" id="{4E6F68BE-5C98-9C24-11F6-9515DEED7281}"/>
+              </a:ext>
+            </a:extLst>
+          </p:cNvPr>
+          <p:cNvSpPr txBox="1"/>
+          <p:nvPr/>
+        </p:nvSpPr>
+        <p:spPr>
+          <a:xfrm>
+            <a:off x="1168400" y="4216399"/>
+            <a:ext cx="4978400" cy="393700"/>
           </a:xfrm>
           <a:prstGeom prst="rect">
             <a:avLst/>
@@ -13014,7 +13067,7 @@
           <p:cNvPr id="19" name="Straight Connector 18">
             <a:extLst>
               <a:ext uri="{FF2B5EF4-FFF2-40B4-BE49-F238E27FC236}">
-                <a16:creationId xmlns:a16="http://schemas.microsoft.com/office/drawing/2014/main" id="{AA9D253F-106A-3DEB-ADA1-78F71FC37A25}"/>
+                <a16:creationId xmlns:a16="http://schemas.microsoft.com/office/drawing/2014/main" id="{15080366-CA6E-7553-1C3C-9B45B922697F}"/>
               </a:ext>
             </a:extLst>
           </p:cNvPr>
@@ -13023,7 +13076,7 @@
         </p:nvCxnSpPr>
         <p:spPr>
           <a:xfrm>
-            <a:off x="812800" y="4953000"/>
+            <a:off x="812800" y="4800600"/>
             <a:ext cx="203200" cy="0"/>
           </a:xfrm>
           <a:prstGeom prst="line">
@@ -13055,17 +13108,17 @@
           <p:cNvPr id="20" name="TextBox 19">
             <a:extLst>
               <a:ext uri="{FF2B5EF4-FFF2-40B4-BE49-F238E27FC236}">
-                <a16:creationId xmlns:a16="http://schemas.microsoft.com/office/drawing/2014/main" id="{3E2B45FF-D1FD-760F-7C38-288526606DEB}"/>
-              </a:ext>
-            </a:extLst>
-          </p:cNvPr>
-          <p:cNvSpPr txBox="1"/>
-          <p:nvPr/>
-        </p:nvSpPr>
-        <p:spPr>
-          <a:xfrm>
-            <a:off x="1168400" y="4800599"/>
-            <a:ext cx="4978400" cy="469900"/>
+                <a16:creationId xmlns:a16="http://schemas.microsoft.com/office/drawing/2014/main" id="{7FEAF728-C7E3-5989-4C5F-FFD430486FE8}"/>
+              </a:ext>
+            </a:extLst>
+          </p:cNvPr>
+          <p:cNvSpPr txBox="1"/>
+          <p:nvPr/>
+        </p:nvSpPr>
+        <p:spPr>
+          <a:xfrm>
+            <a:off x="1168400" y="4648199"/>
+            <a:ext cx="4978400" cy="393700"/>
           </a:xfrm>
           <a:prstGeom prst="rect">
             <a:avLst/>
@@ -13085,7 +13138,7 @@
                 </a:solidFill>
                 <a:latin typeface="Aptos" panose="020B0004020202020204" pitchFamily="34" charset="0"/>
               </a:rPr>
-              <a:t>600 PPO iterations  |  153600 episodes</a:t>
+              <a:t>Selected seed 43</a:t>
             </a:r>
           </a:p>
         </p:txBody>
@@ -13095,7 +13148,7 @@
           <p:cNvPr id="21" name="Straight Connector 20">
             <a:extLst>
               <a:ext uri="{FF2B5EF4-FFF2-40B4-BE49-F238E27FC236}">
-                <a16:creationId xmlns:a16="http://schemas.microsoft.com/office/drawing/2014/main" id="{D8316F4B-A7C4-F678-0102-89ED524E0A17}"/>
+                <a16:creationId xmlns:a16="http://schemas.microsoft.com/office/drawing/2014/main" id="{2CD9C4C2-B0EB-9184-712E-2CDC3E94E248}"/>
               </a:ext>
             </a:extLst>
           </p:cNvPr>
@@ -13104,7 +13157,7 @@
         </p:nvCxnSpPr>
         <p:spPr>
           <a:xfrm>
-            <a:off x="812800" y="5461000"/>
+            <a:off x="812800" y="5232400"/>
             <a:ext cx="203200" cy="0"/>
           </a:xfrm>
           <a:prstGeom prst="line">
@@ -13136,17 +13189,17 @@
           <p:cNvPr id="22" name="TextBox 21">
             <a:extLst>
               <a:ext uri="{FF2B5EF4-FFF2-40B4-BE49-F238E27FC236}">
-                <a16:creationId xmlns:a16="http://schemas.microsoft.com/office/drawing/2014/main" id="{CDD4B520-8688-B17A-B304-72A57C9A0E4F}"/>
-              </a:ext>
-            </a:extLst>
-          </p:cNvPr>
-          <p:cNvSpPr txBox="1"/>
-          <p:nvPr/>
-        </p:nvSpPr>
-        <p:spPr>
-          <a:xfrm>
-            <a:off x="1168400" y="5308599"/>
-            <a:ext cx="4978400" cy="469900"/>
+                <a16:creationId xmlns:a16="http://schemas.microsoft.com/office/drawing/2014/main" id="{0F107D80-23B7-714B-2F7B-69E20885F279}"/>
+              </a:ext>
+            </a:extLst>
+          </p:cNvPr>
+          <p:cNvSpPr txBox="1"/>
+          <p:nvPr/>
+        </p:nvSpPr>
+        <p:spPr>
+          <a:xfrm>
+            <a:off x="1168400" y="5079999"/>
+            <a:ext cx="4978400" cy="393700"/>
           </a:xfrm>
           <a:prstGeom prst="rect">
             <a:avLst/>
@@ -13166,17 +13219,98 @@
                 </a:solidFill>
                 <a:latin typeface="Aptos" panose="020B0004020202020204" pitchFamily="34" charset="0"/>
               </a:rPr>
-              <a:t>3686400 transitions  |  learning rate 0.0001</a:t>
-            </a:r>
-          </a:p>
-        </p:txBody>
-      </p:sp>
-      <p:sp>
-        <p:nvSpPr>
-          <p:cNvPr id="23" name="TextBox 22">
-            <a:extLst>
-              <a:ext uri="{FF2B5EF4-FFF2-40B4-BE49-F238E27FC236}">
-                <a16:creationId xmlns:a16="http://schemas.microsoft.com/office/drawing/2014/main" id="{856AAC59-1F82-E575-EFD7-F2036F684CCB}"/>
+              <a:t>600 PPO iterations  |  153,600 episodes</a:t>
+            </a:r>
+          </a:p>
+        </p:txBody>
+      </p:sp>
+      <p:cxnSp>
+        <p:nvCxnSpPr>
+          <p:cNvPr id="23" name="Straight Connector 22">
+            <a:extLst>
+              <a:ext uri="{FF2B5EF4-FFF2-40B4-BE49-F238E27FC236}">
+                <a16:creationId xmlns:a16="http://schemas.microsoft.com/office/drawing/2014/main" id="{EB0F30B2-FAEF-B81F-4F52-55C5B4F8CF58}"/>
+              </a:ext>
+            </a:extLst>
+          </p:cNvPr>
+          <p:cNvCxnSpPr/>
+          <p:nvPr/>
+        </p:nvCxnSpPr>
+        <p:spPr>
+          <a:xfrm>
+            <a:off x="812800" y="5664200"/>
+            <a:ext cx="203200" cy="0"/>
+          </a:xfrm>
+          <a:prstGeom prst="line">
+            <a:avLst/>
+          </a:prstGeom>
+          <a:ln w="38100">
+            <a:solidFill>
+              <a:srgbClr val="3FC6AC"/>
+            </a:solidFill>
+          </a:ln>
+        </p:spPr>
+        <p:style>
+          <a:lnRef idx="2">
+            <a:schemeClr val="accent1"/>
+          </a:lnRef>
+          <a:fillRef idx="0">
+            <a:schemeClr val="accent1"/>
+          </a:fillRef>
+          <a:effectRef idx="1">
+            <a:schemeClr val="accent1"/>
+          </a:effectRef>
+          <a:fontRef idx="minor">
+            <a:schemeClr val="tx1"/>
+          </a:fontRef>
+        </p:style>
+      </p:cxnSp>
+      <p:sp>
+        <p:nvSpPr>
+          <p:cNvPr id="24" name="TextBox 23">
+            <a:extLst>
+              <a:ext uri="{FF2B5EF4-FFF2-40B4-BE49-F238E27FC236}">
+                <a16:creationId xmlns:a16="http://schemas.microsoft.com/office/drawing/2014/main" id="{F59631F6-6158-0FF4-1C71-FC699FA56D89}"/>
+              </a:ext>
+            </a:extLst>
+          </p:cNvPr>
+          <p:cNvSpPr txBox="1"/>
+          <p:nvPr/>
+        </p:nvSpPr>
+        <p:spPr>
+          <a:xfrm>
+            <a:off x="1168400" y="5511799"/>
+            <a:ext cx="4978400" cy="393700"/>
+          </a:xfrm>
+          <a:prstGeom prst="rect">
+            <a:avLst/>
+          </a:prstGeom>
+          <a:noFill/>
+        </p:spPr>
+        <p:txBody>
+          <a:bodyPr vert="horz" wrap="square" lIns="0" tIns="0" rIns="0" bIns="0" rtlCol="0">
+            <a:noAutofit/>
+          </a:bodyPr>
+          <a:lstStyle/>
+          <a:p>
+            <a:r>
+              <a:rPr lang="en-US" sz="1600">
+                <a:solidFill>
+                  <a:srgbClr val="13232E"/>
+                </a:solidFill>
+                <a:latin typeface="Aptos" panose="020B0004020202020204" pitchFamily="34" charset="0"/>
+              </a:rPr>
+              <a:t>3,686,400 transitions  |  learning rate 0.0001</a:t>
+            </a:r>
+          </a:p>
+        </p:txBody>
+      </p:sp>
+      <p:sp>
+        <p:nvSpPr>
+          <p:cNvPr id="25" name="TextBox 24">
+            <a:extLst>
+              <a:ext uri="{FF2B5EF4-FFF2-40B4-BE49-F238E27FC236}">
+                <a16:creationId xmlns:a16="http://schemas.microsoft.com/office/drawing/2014/main" id="{1EF42986-EEE7-5FFE-F91C-E5F3C2345D65}"/>
               </a:ext>
             </a:extLst>
           </p:cNvPr>
@@ -13213,10 +13347,10 @@
       </p:sp>
       <p:sp>
         <p:nvSpPr>
-          <p:cNvPr id="24" name="TextBox 23">
-            <a:extLst>
-              <a:ext uri="{FF2B5EF4-FFF2-40B4-BE49-F238E27FC236}">
-                <a16:creationId xmlns:a16="http://schemas.microsoft.com/office/drawing/2014/main" id="{B1A0AAD3-C533-0A1D-8926-1F76505012EB}"/>
+          <p:cNvPr id="26" name="TextBox 25">
+            <a:extLst>
+              <a:ext uri="{FF2B5EF4-FFF2-40B4-BE49-F238E27FC236}">
+                <a16:creationId xmlns:a16="http://schemas.microsoft.com/office/drawing/2014/main" id="{AA0CF4A5-2C57-487C-D4CE-CC77ACF137F0}"/>
               </a:ext>
             </a:extLst>
           </p:cNvPr>
@@ -13253,10 +13387,10 @@
       </p:sp>
       <p:sp>
         <p:nvSpPr>
-          <p:cNvPr id="25" name="TextBox 24">
-            <a:extLst>
-              <a:ext uri="{FF2B5EF4-FFF2-40B4-BE49-F238E27FC236}">
-                <a16:creationId xmlns:a16="http://schemas.microsoft.com/office/drawing/2014/main" id="{F09A5C37-3AE7-4D22-F79C-E2D486222270}"/>
+          <p:cNvPr id="27" name="TextBox 26">
+            <a:extLst>
+              <a:ext uri="{FF2B5EF4-FFF2-40B4-BE49-F238E27FC236}">
+                <a16:creationId xmlns:a16="http://schemas.microsoft.com/office/drawing/2014/main" id="{2EEC55D0-884B-5A25-12EC-D2A0F583DC71}"/>
               </a:ext>
             </a:extLst>
           </p:cNvPr>
@@ -13293,10 +13427,10 @@
       </p:sp>
       <p:sp>
         <p:nvSpPr>
-          <p:cNvPr id="26" name="TextBox 25">
-            <a:extLst>
-              <a:ext uri="{FF2B5EF4-FFF2-40B4-BE49-F238E27FC236}">
-                <a16:creationId xmlns:a16="http://schemas.microsoft.com/office/drawing/2014/main" id="{0AFF8194-5983-3F57-17D7-56ADAA4F028D}"/>
+          <p:cNvPr id="28" name="TextBox 27">
+            <a:extLst>
+              <a:ext uri="{FF2B5EF4-FFF2-40B4-BE49-F238E27FC236}">
+                <a16:creationId xmlns:a16="http://schemas.microsoft.com/office/drawing/2014/main" id="{799EB0A6-A7DF-A40F-8290-2A0DAFF7A684}"/>
               </a:ext>
             </a:extLst>
           </p:cNvPr>
@@ -13333,10 +13467,10 @@
       </p:sp>
       <p:sp>
         <p:nvSpPr>
-          <p:cNvPr id="27" name="TextBox 26">
-            <a:extLst>
-              <a:ext uri="{FF2B5EF4-FFF2-40B4-BE49-F238E27FC236}">
-                <a16:creationId xmlns:a16="http://schemas.microsoft.com/office/drawing/2014/main" id="{BABDAED5-C07A-6BCA-79FD-3082D57CCC4B}"/>
+          <p:cNvPr id="29" name="TextBox 28">
+            <a:extLst>
+              <a:ext uri="{FF2B5EF4-FFF2-40B4-BE49-F238E27FC236}">
+                <a16:creationId xmlns:a16="http://schemas.microsoft.com/office/drawing/2014/main" id="{F1912F28-D80F-13C3-DA6F-A16396AA6B2B}"/>
               </a:ext>
             </a:extLst>
           </p:cNvPr>
@@ -13373,20 +13507,20 @@
       </p:sp>
       <p:sp>
         <p:nvSpPr>
-          <p:cNvPr id="28" name="TextBox 27">
-            <a:extLst>
-              <a:ext uri="{FF2B5EF4-FFF2-40B4-BE49-F238E27FC236}">
-                <a16:creationId xmlns:a16="http://schemas.microsoft.com/office/drawing/2014/main" id="{C50C0F3F-2784-3C60-A792-B3D32809D0A3}"/>
-              </a:ext>
-            </a:extLst>
-          </p:cNvPr>
-          <p:cNvSpPr txBox="1"/>
-          <p:nvPr/>
-        </p:nvSpPr>
-        <p:spPr>
-          <a:xfrm>
-            <a:off x="6807200" y="5130799"/>
-            <a:ext cx="4445000" cy="863600"/>
+          <p:cNvPr id="30" name="TextBox 29">
+            <a:extLst>
+              <a:ext uri="{FF2B5EF4-FFF2-40B4-BE49-F238E27FC236}">
+                <a16:creationId xmlns:a16="http://schemas.microsoft.com/office/drawing/2014/main" id="{C7A648DC-8459-2DC2-B5A9-BD45F84F064E}"/>
+              </a:ext>
+            </a:extLst>
+          </p:cNvPr>
+          <p:cNvSpPr txBox="1"/>
+          <p:nvPr/>
+        </p:nvSpPr>
+        <p:spPr>
+          <a:xfrm>
+            <a:off x="6807200" y="5016499"/>
+            <a:ext cx="4445000" cy="304800"/>
           </a:xfrm>
           <a:prstGeom prst="rect">
             <a:avLst/>
@@ -13402,11 +13536,91 @@
             <a:r>
               <a:rPr lang="en-US" sz="1700" b="1">
                 <a:solidFill>
+                  <a:srgbClr val="E0B957"/>
+                </a:solidFill>
+                <a:latin typeface="Aptos" panose="020B0004020202020204" pitchFamily="34" charset="0"/>
+              </a:rPr>
+              <a:t>Three-seed candidate experiment</a:t>
+            </a:r>
+          </a:p>
+        </p:txBody>
+      </p:sp>
+      <p:sp>
+        <p:nvSpPr>
+          <p:cNvPr id="31" name="TextBox 30">
+            <a:extLst>
+              <a:ext uri="{FF2B5EF4-FFF2-40B4-BE49-F238E27FC236}">
+                <a16:creationId xmlns:a16="http://schemas.microsoft.com/office/drawing/2014/main" id="{960E426E-2055-6986-B297-EAD87224B20C}"/>
+              </a:ext>
+            </a:extLst>
+          </p:cNvPr>
+          <p:cNvSpPr txBox="1"/>
+          <p:nvPr/>
+        </p:nvSpPr>
+        <p:spPr>
+          <a:xfrm>
+            <a:off x="6807200" y="5372099"/>
+            <a:ext cx="4445000" cy="279400"/>
+          </a:xfrm>
+          <a:prstGeom prst="rect">
+            <a:avLst/>
+          </a:prstGeom>
+          <a:noFill/>
+        </p:spPr>
+        <p:txBody>
+          <a:bodyPr vert="horz" wrap="square" lIns="0" tIns="0" rIns="0" bIns="0" rtlCol="0">
+            <a:noAutofit/>
+          </a:bodyPr>
+          <a:lstStyle/>
+          <a:p>
+            <a:r>
+              <a:rPr lang="en-US" sz="1600" b="1">
+                <a:solidFill>
                   <a:srgbClr val="13232E"/>
                 </a:solidFill>
                 <a:latin typeface="Aptos" panose="020B0004020202020204" pitchFamily="34" charset="0"/>
               </a:rPr>
-              <a:t>Model selection used validation seeds; untouched evaluation seeds were not used for training or selection.</a:t>
+              <a:t>1,800 iterations  |  460,800 episodes</a:t>
+            </a:r>
+          </a:p>
+        </p:txBody>
+      </p:sp>
+      <p:sp>
+        <p:nvSpPr>
+          <p:cNvPr id="32" name="TextBox 31">
+            <a:extLst>
+              <a:ext uri="{FF2B5EF4-FFF2-40B4-BE49-F238E27FC236}">
+                <a16:creationId xmlns:a16="http://schemas.microsoft.com/office/drawing/2014/main" id="{58A0F063-C533-72FC-5094-2A15C9598F80}"/>
+              </a:ext>
+            </a:extLst>
+          </p:cNvPr>
+          <p:cNvSpPr txBox="1"/>
+          <p:nvPr/>
+        </p:nvSpPr>
+        <p:spPr>
+          <a:xfrm>
+            <a:off x="6807200" y="5702299"/>
+            <a:ext cx="4445000" cy="279400"/>
+          </a:xfrm>
+          <a:prstGeom prst="rect">
+            <a:avLst/>
+          </a:prstGeom>
+          <a:noFill/>
+        </p:spPr>
+        <p:txBody>
+          <a:bodyPr vert="horz" wrap="square" lIns="0" tIns="0" rIns="0" bIns="0" rtlCol="0">
+            <a:noAutofit/>
+          </a:bodyPr>
+          <a:lstStyle/>
+          <a:p>
+            <a:r>
+              <a:rPr lang="en-US" sz="1600" b="1">
+                <a:solidFill>
+                  <a:srgbClr val="60727D"/>
+                </a:solidFill>
+                <a:latin typeface="Aptos" panose="020B0004020202020204" pitchFamily="34" charset="0"/>
+              </a:rPr>
+              <a:t>11,059,200 transitions total</a:t>
             </a:r>
           </a:p>
         </p:txBody>
@@ -13414,7 +13628,7 @@
     </p:spTree>
     <p:extLst>
       <p:ext uri="{BB962C8B-B14F-4D97-AF65-F5344CB8AC3E}">
-        <p14:creationId xmlns:p14="http://schemas.microsoft.com/office/powerpoint/2010/main" val="3746162130"/>
+        <p14:creationId xmlns:p14="http://schemas.microsoft.com/office/powerpoint/2010/main" val="597389037"/>
       </p:ext>
     </p:extLst>
   </p:cSld>
@@ -13454,7 +13668,7 @@
           <p:cNvPr id="2" name="TextBox 1">
             <a:extLst>
               <a:ext uri="{FF2B5EF4-FFF2-40B4-BE49-F238E27FC236}">
-                <a16:creationId xmlns:a16="http://schemas.microsoft.com/office/drawing/2014/main" id="{F86695EC-7B0C-6D24-7F6E-41E78A96315D}"/>
+                <a16:creationId xmlns:a16="http://schemas.microsoft.com/office/drawing/2014/main" id="{FFBBE9B4-2465-E1C8-0728-92685A457B00}"/>
               </a:ext>
             </a:extLst>
           </p:cNvPr>
@@ -13494,7 +13708,7 @@
           <p:cNvPr id="3" name="Straight Connector 2">
             <a:extLst>
               <a:ext uri="{FF2B5EF4-FFF2-40B4-BE49-F238E27FC236}">
-                <a16:creationId xmlns:a16="http://schemas.microsoft.com/office/drawing/2014/main" id="{589805B5-625F-A8AC-AE57-382B28A68D4A}"/>
+                <a16:creationId xmlns:a16="http://schemas.microsoft.com/office/drawing/2014/main" id="{2D7C9CA5-EE5E-6B77-5CA7-5CC6BA11B26F}"/>
               </a:ext>
             </a:extLst>
           </p:cNvPr>
@@ -13535,7 +13749,7 @@
           <p:cNvPr id="4" name="TextBox 3">
             <a:extLst>
               <a:ext uri="{FF2B5EF4-FFF2-40B4-BE49-F238E27FC236}">
-                <a16:creationId xmlns:a16="http://schemas.microsoft.com/office/drawing/2014/main" id="{18ACA4AD-5446-31E2-106C-EF0F8456DB78}"/>
+                <a16:creationId xmlns:a16="http://schemas.microsoft.com/office/drawing/2014/main" id="{4D95D222-838C-91E1-7E41-3F98C2A69106}"/>
               </a:ext>
             </a:extLst>
           </p:cNvPr>
@@ -13576,7 +13790,7 @@
           <p:cNvPr id="5" name="TextBox 4">
             <a:extLst>
               <a:ext uri="{FF2B5EF4-FFF2-40B4-BE49-F238E27FC236}">
-                <a16:creationId xmlns:a16="http://schemas.microsoft.com/office/drawing/2014/main" id="{8F294EB6-C858-0D44-CCE5-1C6A12F23258}"/>
+                <a16:creationId xmlns:a16="http://schemas.microsoft.com/office/drawing/2014/main" id="{8164E32C-7E14-0D4A-D19A-FF8FE0E2C3E6}"/>
               </a:ext>
             </a:extLst>
           </p:cNvPr>
@@ -13616,7 +13830,7 @@
           <p:cNvPr id="6" name="TextBox 5">
             <a:extLst>
               <a:ext uri="{FF2B5EF4-FFF2-40B4-BE49-F238E27FC236}">
-                <a16:creationId xmlns:a16="http://schemas.microsoft.com/office/drawing/2014/main" id="{141FB93D-30AF-3F58-537E-2F4A6FE7284C}"/>
+                <a16:creationId xmlns:a16="http://schemas.microsoft.com/office/drawing/2014/main" id="{0C5BBF17-3268-9E06-6010-FC4238DB80F1}"/>
               </a:ext>
             </a:extLst>
           </p:cNvPr>
@@ -13656,7 +13870,7 @@
           <p:cNvPr id="7" name="Straight Connector 6">
             <a:extLst>
               <a:ext uri="{FF2B5EF4-FFF2-40B4-BE49-F238E27FC236}">
-                <a16:creationId xmlns:a16="http://schemas.microsoft.com/office/drawing/2014/main" id="{9D03E2C2-C45C-F332-43BF-ABE3C50761A2}"/>
+                <a16:creationId xmlns:a16="http://schemas.microsoft.com/office/drawing/2014/main" id="{7C09F615-3B44-646C-E766-A58D5758D17F}"/>
               </a:ext>
             </a:extLst>
           </p:cNvPr>
@@ -13698,7 +13912,7 @@
           <p:cNvPr id="8" name="Straight Connector 7">
             <a:extLst>
               <a:ext uri="{FF2B5EF4-FFF2-40B4-BE49-F238E27FC236}">
-                <a16:creationId xmlns:a16="http://schemas.microsoft.com/office/drawing/2014/main" id="{698528DA-8E25-1F3D-8415-E2012B5C168D}"/>
+                <a16:creationId xmlns:a16="http://schemas.microsoft.com/office/drawing/2014/main" id="{298F579F-3396-30DA-1F7D-BB78F97B29C6}"/>
               </a:ext>
             </a:extLst>
           </p:cNvPr>
@@ -13740,7 +13954,7 @@
           <p:cNvPr id="9" name="Rectangle: Rounded Corners 8">
             <a:extLst>
               <a:ext uri="{FF2B5EF4-FFF2-40B4-BE49-F238E27FC236}">
-                <a16:creationId xmlns:a16="http://schemas.microsoft.com/office/drawing/2014/main" id="{382E433D-AE80-281E-094C-130F5DFA1348}"/>
+                <a16:creationId xmlns:a16="http://schemas.microsoft.com/office/drawing/2014/main" id="{83AC890C-E878-1B42-64C3-EE8478B549A3}"/>
               </a:ext>
             </a:extLst>
           </p:cNvPr>
@@ -13808,7 +14022,7 @@
           <p:cNvPr id="10" name="TextBox 9">
             <a:extLst>
               <a:ext uri="{FF2B5EF4-FFF2-40B4-BE49-F238E27FC236}">
-                <a16:creationId xmlns:a16="http://schemas.microsoft.com/office/drawing/2014/main" id="{E1840D90-0E2E-740B-2E30-90B0047F040D}"/>
+                <a16:creationId xmlns:a16="http://schemas.microsoft.com/office/drawing/2014/main" id="{790FD82E-E4C4-160B-DFFC-450D9D5B517A}"/>
               </a:ext>
             </a:extLst>
           </p:cNvPr>
@@ -13849,7 +14063,7 @@
           <p:cNvPr id="11" name="TextBox 10">
             <a:extLst>
               <a:ext uri="{FF2B5EF4-FFF2-40B4-BE49-F238E27FC236}">
-                <a16:creationId xmlns:a16="http://schemas.microsoft.com/office/drawing/2014/main" id="{F7CDB6C9-FE33-A3D4-7634-60887C08B082}"/>
+                <a16:creationId xmlns:a16="http://schemas.microsoft.com/office/drawing/2014/main" id="{F6522E61-EACC-067E-5F56-D94FAE7BA4D7}"/>
               </a:ext>
             </a:extLst>
           </p:cNvPr>
@@ -13920,7 +14134,7 @@
           <p:cNvPr id="12" name="Rectangle: Rounded Corners 11">
             <a:extLst>
               <a:ext uri="{FF2B5EF4-FFF2-40B4-BE49-F238E27FC236}">
-                <a16:creationId xmlns:a16="http://schemas.microsoft.com/office/drawing/2014/main" id="{F3A311FE-F43B-5B73-9DD0-5DA49FAFAC6A}"/>
+                <a16:creationId xmlns:a16="http://schemas.microsoft.com/office/drawing/2014/main" id="{848CA157-0493-D6A3-3614-456FC1D06039}"/>
               </a:ext>
             </a:extLst>
           </p:cNvPr>
@@ -13988,7 +14202,7 @@
           <p:cNvPr id="13" name="TextBox 12">
             <a:extLst>
               <a:ext uri="{FF2B5EF4-FFF2-40B4-BE49-F238E27FC236}">
-                <a16:creationId xmlns:a16="http://schemas.microsoft.com/office/drawing/2014/main" id="{95424430-FBF9-6917-1B96-B8B1A2EC9FF0}"/>
+                <a16:creationId xmlns:a16="http://schemas.microsoft.com/office/drawing/2014/main" id="{D68CDF42-A356-3C3C-2828-73FD5D6AF142}"/>
               </a:ext>
             </a:extLst>
           </p:cNvPr>
@@ -14029,7 +14243,7 @@
           <p:cNvPr id="14" name="TextBox 13">
             <a:extLst>
               <a:ext uri="{FF2B5EF4-FFF2-40B4-BE49-F238E27FC236}">
-                <a16:creationId xmlns:a16="http://schemas.microsoft.com/office/drawing/2014/main" id="{C23653AF-536A-164F-047A-543BD734A45F}"/>
+                <a16:creationId xmlns:a16="http://schemas.microsoft.com/office/drawing/2014/main" id="{4AE02975-78B5-40C1-425A-FD828C893F8A}"/>
               </a:ext>
             </a:extLst>
           </p:cNvPr>
@@ -14082,7 +14296,7 @@
           <p:cNvPr id="15" name="Rectangle: Rounded Corners 14">
             <a:extLst>
               <a:ext uri="{FF2B5EF4-FFF2-40B4-BE49-F238E27FC236}">
-                <a16:creationId xmlns:a16="http://schemas.microsoft.com/office/drawing/2014/main" id="{027C63EC-2B50-309C-C719-4A8BFF2B6C98}"/>
+                <a16:creationId xmlns:a16="http://schemas.microsoft.com/office/drawing/2014/main" id="{BC9FED9B-F937-D7DF-8C54-D3288D3713AA}"/>
               </a:ext>
             </a:extLst>
           </p:cNvPr>
@@ -14150,7 +14364,7 @@
           <p:cNvPr id="16" name="TextBox 15">
             <a:extLst>
               <a:ext uri="{FF2B5EF4-FFF2-40B4-BE49-F238E27FC236}">
-                <a16:creationId xmlns:a16="http://schemas.microsoft.com/office/drawing/2014/main" id="{4715394F-DD90-96DC-ECDA-B835B92C5ADA}"/>
+                <a16:creationId xmlns:a16="http://schemas.microsoft.com/office/drawing/2014/main" id="{852926FD-4CEC-E286-A166-79C1662B5D51}"/>
               </a:ext>
             </a:extLst>
           </p:cNvPr>
@@ -14191,7 +14405,7 @@
           <p:cNvPr id="17" name="TextBox 16">
             <a:extLst>
               <a:ext uri="{FF2B5EF4-FFF2-40B4-BE49-F238E27FC236}">
-                <a16:creationId xmlns:a16="http://schemas.microsoft.com/office/drawing/2014/main" id="{7829B82A-9331-8782-2771-3ADFC07B5D0E}"/>
+                <a16:creationId xmlns:a16="http://schemas.microsoft.com/office/drawing/2014/main" id="{D218C291-CE54-FBDA-4497-E2A03B22D555}"/>
               </a:ext>
             </a:extLst>
           </p:cNvPr>
@@ -14256,7 +14470,7 @@
           <p:cNvPr id="18" name="Straight Connector 17">
             <a:extLst>
               <a:ext uri="{FF2B5EF4-FFF2-40B4-BE49-F238E27FC236}">
-                <a16:creationId xmlns:a16="http://schemas.microsoft.com/office/drawing/2014/main" id="{1F6C08AE-77C5-5CC7-218F-EE5445DD7885}"/>
+                <a16:creationId xmlns:a16="http://schemas.microsoft.com/office/drawing/2014/main" id="{079BBF49-62C9-DA9F-FFEF-D6CDA8044020}"/>
               </a:ext>
             </a:extLst>
           </p:cNvPr>
@@ -14297,7 +14511,7 @@
           <p:cNvPr id="19" name="TextBox 18">
             <a:extLst>
               <a:ext uri="{FF2B5EF4-FFF2-40B4-BE49-F238E27FC236}">
-                <a16:creationId xmlns:a16="http://schemas.microsoft.com/office/drawing/2014/main" id="{A8152EF1-FA04-D8BF-A22A-1BF3C7668BD5}"/>
+                <a16:creationId xmlns:a16="http://schemas.microsoft.com/office/drawing/2014/main" id="{D540E6FA-7BB8-13A7-2761-F99DC6E8B0E3}"/>
               </a:ext>
             </a:extLst>
           </p:cNvPr>
@@ -14337,7 +14551,7 @@
           <p:cNvPr id="20" name="Straight Connector 19">
             <a:extLst>
               <a:ext uri="{FF2B5EF4-FFF2-40B4-BE49-F238E27FC236}">
-                <a16:creationId xmlns:a16="http://schemas.microsoft.com/office/drawing/2014/main" id="{6E3C6ACD-06E0-861F-6164-2917B7FC9F56}"/>
+                <a16:creationId xmlns:a16="http://schemas.microsoft.com/office/drawing/2014/main" id="{426FCB84-9B8D-57CF-3A5D-079F75E25E11}"/>
               </a:ext>
             </a:extLst>
           </p:cNvPr>
@@ -14378,7 +14592,7 @@
           <p:cNvPr id="21" name="TextBox 20">
             <a:extLst>
               <a:ext uri="{FF2B5EF4-FFF2-40B4-BE49-F238E27FC236}">
-                <a16:creationId xmlns:a16="http://schemas.microsoft.com/office/drawing/2014/main" id="{D3D78172-7DA9-44F6-270B-BC0F614056F8}"/>
+                <a16:creationId xmlns:a16="http://schemas.microsoft.com/office/drawing/2014/main" id="{1FE3EDFC-F7DF-A602-1EFA-F43BA459F326}"/>
               </a:ext>
             </a:extLst>
           </p:cNvPr>
@@ -14418,7 +14632,7 @@
           <p:cNvPr id="22" name="Straight Connector 21">
             <a:extLst>
               <a:ext uri="{FF2B5EF4-FFF2-40B4-BE49-F238E27FC236}">
-                <a16:creationId xmlns:a16="http://schemas.microsoft.com/office/drawing/2014/main" id="{2773921B-863C-5B6C-360E-67A29673448F}"/>
+                <a16:creationId xmlns:a16="http://schemas.microsoft.com/office/drawing/2014/main" id="{28FEE2AB-46FD-6FA5-8D67-B64FC395C2F3}"/>
               </a:ext>
             </a:extLst>
           </p:cNvPr>
@@ -14459,7 +14673,7 @@
           <p:cNvPr id="23" name="TextBox 22">
             <a:extLst>
               <a:ext uri="{FF2B5EF4-FFF2-40B4-BE49-F238E27FC236}">
-                <a16:creationId xmlns:a16="http://schemas.microsoft.com/office/drawing/2014/main" id="{1B49123B-FF6D-A50F-9EDE-ADF8E3318F87}"/>
+                <a16:creationId xmlns:a16="http://schemas.microsoft.com/office/drawing/2014/main" id="{BCF841D7-926E-2330-7B9D-2988A0B05A2E}"/>
               </a:ext>
             </a:extLst>
           </p:cNvPr>
@@ -14489,7 +14703,7 @@
                 </a:solidFill>
                 <a:latin typeface="Aptos" panose="020B0004020202020204" pitchFamily="34" charset="0"/>
               </a:rPr>
-              <a:t>One final host transfer assembles evidence; it is not a controller fallback</a:t>
+              <a:t>Scalar validity flags may synchronize; one final bulk transfer assembles evidence</a:t>
             </a:r>
           </a:p>
         </p:txBody>
@@ -14497,7 +14711,7 @@
     </p:spTree>
     <p:extLst>
       <p:ext uri="{BB962C8B-B14F-4D97-AF65-F5344CB8AC3E}">
-        <p14:creationId xmlns:p14="http://schemas.microsoft.com/office/powerpoint/2010/main" val="3899118283"/>
+        <p14:creationId xmlns:p14="http://schemas.microsoft.com/office/powerpoint/2010/main" val="2508960389"/>
       </p:ext>
     </p:extLst>
   </p:cSld>
@@ -14537,7 +14751,7 @@
           <p:cNvPr id="2" name="TextBox 1">
             <a:extLst>
               <a:ext uri="{FF2B5EF4-FFF2-40B4-BE49-F238E27FC236}">
-                <a16:creationId xmlns:a16="http://schemas.microsoft.com/office/drawing/2014/main" id="{BD277CA1-CDF6-49B3-1B19-01B4638065F6}"/>
+                <a16:creationId xmlns:a16="http://schemas.microsoft.com/office/drawing/2014/main" id="{9AA57882-1F64-84F3-D1BD-933D2CDDF307}"/>
               </a:ext>
             </a:extLst>
           </p:cNvPr>
@@ -14577,7 +14791,7 @@
           <p:cNvPr id="3" name="Straight Connector 2">
             <a:extLst>
               <a:ext uri="{FF2B5EF4-FFF2-40B4-BE49-F238E27FC236}">
-                <a16:creationId xmlns:a16="http://schemas.microsoft.com/office/drawing/2014/main" id="{08CD11F4-A00D-1786-93BF-5E1D011165C6}"/>
+                <a16:creationId xmlns:a16="http://schemas.microsoft.com/office/drawing/2014/main" id="{08468497-218F-2D9E-D1BC-8EB1D8C5F885}"/>
               </a:ext>
             </a:extLst>
           </p:cNvPr>
@@ -14618,7 +14832,7 @@
           <p:cNvPr id="4" name="TextBox 3">
             <a:extLst>
               <a:ext uri="{FF2B5EF4-FFF2-40B4-BE49-F238E27FC236}">
-                <a16:creationId xmlns:a16="http://schemas.microsoft.com/office/drawing/2014/main" id="{50D60F89-8649-CCCC-B457-1ACF5DA639FE}"/>
+                <a16:creationId xmlns:a16="http://schemas.microsoft.com/office/drawing/2014/main" id="{6E798957-2059-7167-591E-90D0AC0CD5A8}"/>
               </a:ext>
             </a:extLst>
           </p:cNvPr>
@@ -14659,7 +14873,7 @@
           <p:cNvPr id="5" name="TextBox 4">
             <a:extLst>
               <a:ext uri="{FF2B5EF4-FFF2-40B4-BE49-F238E27FC236}">
-                <a16:creationId xmlns:a16="http://schemas.microsoft.com/office/drawing/2014/main" id="{DC26F0F2-0E27-9667-FAEA-0F06F6A3F673}"/>
+                <a16:creationId xmlns:a16="http://schemas.microsoft.com/office/drawing/2014/main" id="{798FD7C3-A528-8FF8-A5BC-7A6003414A9F}"/>
               </a:ext>
             </a:extLst>
           </p:cNvPr>
@@ -14699,7 +14913,7 @@
           <p:cNvPr id="6" name="TextBox 5">
             <a:extLst>
               <a:ext uri="{FF2B5EF4-FFF2-40B4-BE49-F238E27FC236}">
-                <a16:creationId xmlns:a16="http://schemas.microsoft.com/office/drawing/2014/main" id="{4D5D561C-17A5-5B3C-9395-7F1544B46A93}"/>
+                <a16:creationId xmlns:a16="http://schemas.microsoft.com/office/drawing/2014/main" id="{5F55D902-B2A5-5B1B-0F8B-39CB6B60B88F}"/>
               </a:ext>
             </a:extLst>
           </p:cNvPr>
@@ -14739,7 +14953,7 @@
           <p:cNvPr id="7" name="Rectangle: Rounded Corners 6">
             <a:extLst>
               <a:ext uri="{FF2B5EF4-FFF2-40B4-BE49-F238E27FC236}">
-                <a16:creationId xmlns:a16="http://schemas.microsoft.com/office/drawing/2014/main" id="{3C12CE96-A0EB-A04D-4E4A-36BA4E902C21}"/>
+                <a16:creationId xmlns:a16="http://schemas.microsoft.com/office/drawing/2014/main" id="{7067AE82-E506-1C68-89FF-F3AACD195B02}"/>
               </a:ext>
             </a:extLst>
           </p:cNvPr>
@@ -14793,7 +15007,7 @@
           <p:cNvPr id="9" name="Picture 8" descr="Live Scenario page showing one shared GPU scenario and locality detail">
             <a:extLst>
               <a:ext uri="{FF2B5EF4-FFF2-40B4-BE49-F238E27FC236}">
-                <a16:creationId xmlns:a16="http://schemas.microsoft.com/office/drawing/2014/main" id="{ED3B97E2-D94F-81A8-A963-9C3830AD2290}"/>
+                <a16:creationId xmlns:a16="http://schemas.microsoft.com/office/drawing/2014/main" id="{E246104B-1B66-9963-CBAF-8C5297087486}"/>
               </a:ext>
             </a:extLst>
           </p:cNvPr>
@@ -14829,7 +15043,7 @@
           <p:cNvPr id="10" name="TextBox 9">
             <a:extLst>
               <a:ext uri="{FF2B5EF4-FFF2-40B4-BE49-F238E27FC236}">
-                <a16:creationId xmlns:a16="http://schemas.microsoft.com/office/drawing/2014/main" id="{08D07558-7AEF-9999-A22E-9CC136A91770}"/>
+                <a16:creationId xmlns:a16="http://schemas.microsoft.com/office/drawing/2014/main" id="{C79B204A-ED20-F96A-EE2D-B38DB3BE8D5F}"/>
               </a:ext>
             </a:extLst>
           </p:cNvPr>
@@ -14868,7 +15082,7 @@
     </p:spTree>
     <p:extLst>
       <p:ext uri="{BB962C8B-B14F-4D97-AF65-F5344CB8AC3E}">
-        <p14:creationId xmlns:p14="http://schemas.microsoft.com/office/powerpoint/2010/main" val="4016314205"/>
+        <p14:creationId xmlns:p14="http://schemas.microsoft.com/office/powerpoint/2010/main" val="3267870797"/>
       </p:ext>
     </p:extLst>
   </p:cSld>
@@ -14908,7 +15122,7 @@
           <p:cNvPr id="2" name="TextBox 1">
             <a:extLst>
               <a:ext uri="{FF2B5EF4-FFF2-40B4-BE49-F238E27FC236}">
-                <a16:creationId xmlns:a16="http://schemas.microsoft.com/office/drawing/2014/main" id="{C5DDED42-CD0C-E331-D92C-1A1D0117CF93}"/>
+                <a16:creationId xmlns:a16="http://schemas.microsoft.com/office/drawing/2014/main" id="{FC2B901D-D014-90E6-5F99-CBA06C5CBA20}"/>
               </a:ext>
             </a:extLst>
           </p:cNvPr>
@@ -14948,7 +15162,7 @@
           <p:cNvPr id="3" name="Straight Connector 2">
             <a:extLst>
               <a:ext uri="{FF2B5EF4-FFF2-40B4-BE49-F238E27FC236}">
-                <a16:creationId xmlns:a16="http://schemas.microsoft.com/office/drawing/2014/main" id="{1518934E-1EC8-215A-FAF7-D1F40CD4D76F}"/>
+                <a16:creationId xmlns:a16="http://schemas.microsoft.com/office/drawing/2014/main" id="{210E60F0-F8B8-299E-161F-D09A38ECDA34}"/>
               </a:ext>
             </a:extLst>
           </p:cNvPr>
@@ -14989,7 +15203,7 @@
           <p:cNvPr id="4" name="TextBox 3">
             <a:extLst>
               <a:ext uri="{FF2B5EF4-FFF2-40B4-BE49-F238E27FC236}">
-                <a16:creationId xmlns:a16="http://schemas.microsoft.com/office/drawing/2014/main" id="{37EDB43D-5E99-5C25-AC86-64CE5A43AF42}"/>
+                <a16:creationId xmlns:a16="http://schemas.microsoft.com/office/drawing/2014/main" id="{8DDA1F04-DC62-DDD5-0CB7-DCC62FD3075E}"/>
               </a:ext>
             </a:extLst>
           </p:cNvPr>
@@ -15030,7 +15244,7 @@
           <p:cNvPr id="5" name="TextBox 4">
             <a:extLst>
               <a:ext uri="{FF2B5EF4-FFF2-40B4-BE49-F238E27FC236}">
-                <a16:creationId xmlns:a16="http://schemas.microsoft.com/office/drawing/2014/main" id="{4B3C7B67-64B7-8CFB-B3C8-8649B909C8EB}"/>
+                <a16:creationId xmlns:a16="http://schemas.microsoft.com/office/drawing/2014/main" id="{3521CA99-9758-6399-68A5-D98E492125FD}"/>
               </a:ext>
             </a:extLst>
           </p:cNvPr>
@@ -15070,7 +15284,7 @@
           <p:cNvPr id="6" name="TextBox 5">
             <a:extLst>
               <a:ext uri="{FF2B5EF4-FFF2-40B4-BE49-F238E27FC236}">
-                <a16:creationId xmlns:a16="http://schemas.microsoft.com/office/drawing/2014/main" id="{BC7CF2BA-834A-6D3F-C999-D4D07F487E4D}"/>
+                <a16:creationId xmlns:a16="http://schemas.microsoft.com/office/drawing/2014/main" id="{FA811394-1780-00E5-6D17-77CBD1CD21D9}"/>
               </a:ext>
             </a:extLst>
           </p:cNvPr>
@@ -15100,7 +15314,7 @@
                 </a:solidFill>
                 <a:latin typeface="Aptos" panose="020B0004020202020204" pitchFamily="34" charset="0"/>
               </a:rPr>
-              <a:t>Untouched confirmatory evidence reports three primary outcomes</a:t>
+              <a:t>Documented-seed-disjoint holdout reports three primary outcomes</a:t>
             </a:r>
           </a:p>
         </p:txBody>
@@ -15110,7 +15324,7 @@
           <p:cNvPr id="7" name="TextBox 6">
             <a:extLst>
               <a:ext uri="{FF2B5EF4-FFF2-40B4-BE49-F238E27FC236}">
-                <a16:creationId xmlns:a16="http://schemas.microsoft.com/office/drawing/2014/main" id="{357EEDD6-F742-838F-2843-56763A15E93D}"/>
+                <a16:creationId xmlns:a16="http://schemas.microsoft.com/office/drawing/2014/main" id="{F2EA7674-6404-9989-6460-4C01809FBF8A}"/>
               </a:ext>
             </a:extLst>
           </p:cNvPr>
@@ -15150,7 +15364,7 @@
           <p:cNvPr id="8" name="TextBox 7">
             <a:extLst>
               <a:ext uri="{FF2B5EF4-FFF2-40B4-BE49-F238E27FC236}">
-                <a16:creationId xmlns:a16="http://schemas.microsoft.com/office/drawing/2014/main" id="{3F76095A-E62E-D9BD-9BAE-5882855099BB}"/>
+                <a16:creationId xmlns:a16="http://schemas.microsoft.com/office/drawing/2014/main" id="{0A0B15D5-AECC-8A93-9AB4-632318C925B6}"/>
               </a:ext>
             </a:extLst>
           </p:cNvPr>
@@ -15190,7 +15404,7 @@
           <p:cNvPr id="9" name="TextBox 8">
             <a:extLst>
               <a:ext uri="{FF2B5EF4-FFF2-40B4-BE49-F238E27FC236}">
-                <a16:creationId xmlns:a16="http://schemas.microsoft.com/office/drawing/2014/main" id="{BFF4791E-90D3-C3C8-04A1-D76493F211C5}"/>
+                <a16:creationId xmlns:a16="http://schemas.microsoft.com/office/drawing/2014/main" id="{47175782-D733-8394-4D84-0934D98FEDE0}"/>
               </a:ext>
             </a:extLst>
           </p:cNvPr>
@@ -15230,7 +15444,7 @@
           <p:cNvPr id="10" name="TextBox 9">
             <a:extLst>
               <a:ext uri="{FF2B5EF4-FFF2-40B4-BE49-F238E27FC236}">
-                <a16:creationId xmlns:a16="http://schemas.microsoft.com/office/drawing/2014/main" id="{2DC38105-88E4-4AC1-48D1-2725DD3D57B4}"/>
+                <a16:creationId xmlns:a16="http://schemas.microsoft.com/office/drawing/2014/main" id="{499E06D8-CE24-E349-7083-61CAC4B6B850}"/>
               </a:ext>
             </a:extLst>
           </p:cNvPr>
@@ -15270,7 +15484,7 @@
           <p:cNvPr id="11" name="TextBox 10">
             <a:extLst>
               <a:ext uri="{FF2B5EF4-FFF2-40B4-BE49-F238E27FC236}">
-                <a16:creationId xmlns:a16="http://schemas.microsoft.com/office/drawing/2014/main" id="{FF9C1B27-EAE6-E929-5866-1FAA5F4C3E23}"/>
+                <a16:creationId xmlns:a16="http://schemas.microsoft.com/office/drawing/2014/main" id="{CE8DABAD-03ED-C9D4-DC84-1B4AEC3ABB30}"/>
               </a:ext>
             </a:extLst>
           </p:cNvPr>
@@ -15310,7 +15524,7 @@
           <p:cNvPr id="12" name="Rectangle 11">
             <a:extLst>
               <a:ext uri="{FF2B5EF4-FFF2-40B4-BE49-F238E27FC236}">
-                <a16:creationId xmlns:a16="http://schemas.microsoft.com/office/drawing/2014/main" id="{50744C4B-57EC-AB27-7143-026DBF41C2BC}"/>
+                <a16:creationId xmlns:a16="http://schemas.microsoft.com/office/drawing/2014/main" id="{02E955F8-9185-DE7A-2DF5-F60BF0AFC59A}"/>
               </a:ext>
             </a:extLst>
           </p:cNvPr>
@@ -15378,7 +15592,7 @@
           <p:cNvPr id="13" name="TextBox 12">
             <a:extLst>
               <a:ext uri="{FF2B5EF4-FFF2-40B4-BE49-F238E27FC236}">
-                <a16:creationId xmlns:a16="http://schemas.microsoft.com/office/drawing/2014/main" id="{DAB9A6BC-0437-A33E-151C-65E15091CB71}"/>
+                <a16:creationId xmlns:a16="http://schemas.microsoft.com/office/drawing/2014/main" id="{FFB7C730-B296-905A-892D-E65CB8CCD311}"/>
               </a:ext>
             </a:extLst>
           </p:cNvPr>
@@ -15418,7 +15632,7 @@
           <p:cNvPr id="14" name="TextBox 13">
             <a:extLst>
               <a:ext uri="{FF2B5EF4-FFF2-40B4-BE49-F238E27FC236}">
-                <a16:creationId xmlns:a16="http://schemas.microsoft.com/office/drawing/2014/main" id="{E79CB5A5-66A4-1623-DD61-A1CD5EE580C6}"/>
+                <a16:creationId xmlns:a16="http://schemas.microsoft.com/office/drawing/2014/main" id="{FE12983C-89A0-DDDF-654F-026479DE8F6F}"/>
               </a:ext>
             </a:extLst>
           </p:cNvPr>
@@ -15458,7 +15672,7 @@
           <p:cNvPr id="15" name="TextBox 14">
             <a:extLst>
               <a:ext uri="{FF2B5EF4-FFF2-40B4-BE49-F238E27FC236}">
-                <a16:creationId xmlns:a16="http://schemas.microsoft.com/office/drawing/2014/main" id="{83DADC72-63EC-8D65-22A5-EA46076C73FD}"/>
+                <a16:creationId xmlns:a16="http://schemas.microsoft.com/office/drawing/2014/main" id="{7F80828F-644C-77E5-5FA0-8F2E24293348}"/>
               </a:ext>
             </a:extLst>
           </p:cNvPr>
@@ -15498,7 +15712,7 @@
           <p:cNvPr id="16" name="TextBox 15">
             <a:extLst>
               <a:ext uri="{FF2B5EF4-FFF2-40B4-BE49-F238E27FC236}">
-                <a16:creationId xmlns:a16="http://schemas.microsoft.com/office/drawing/2014/main" id="{C13407F4-6DBA-95DE-FF40-F8E1EFA874AB}"/>
+                <a16:creationId xmlns:a16="http://schemas.microsoft.com/office/drawing/2014/main" id="{35A5D6A8-7E5B-BC0D-E56A-7296DA94DCE0}"/>
               </a:ext>
             </a:extLst>
           </p:cNvPr>
@@ -15538,7 +15752,7 @@
           <p:cNvPr id="17" name="TextBox 16">
             <a:extLst>
               <a:ext uri="{FF2B5EF4-FFF2-40B4-BE49-F238E27FC236}">
-                <a16:creationId xmlns:a16="http://schemas.microsoft.com/office/drawing/2014/main" id="{96708C87-2682-2E6F-9C2B-9558DC9B7986}"/>
+                <a16:creationId xmlns:a16="http://schemas.microsoft.com/office/drawing/2014/main" id="{4BBF2DAB-B220-05E7-F4AA-25D9A61F3CFA}"/>
               </a:ext>
             </a:extLst>
           </p:cNvPr>
@@ -15578,7 +15792,7 @@
           <p:cNvPr id="18" name="TextBox 17">
             <a:extLst>
               <a:ext uri="{FF2B5EF4-FFF2-40B4-BE49-F238E27FC236}">
-                <a16:creationId xmlns:a16="http://schemas.microsoft.com/office/drawing/2014/main" id="{13D6C50E-7BA3-7C2A-8BE7-97B32290FD86}"/>
+                <a16:creationId xmlns:a16="http://schemas.microsoft.com/office/drawing/2014/main" id="{27B9F094-DBCA-382C-DEFB-3F6FC72A391A}"/>
               </a:ext>
             </a:extLst>
           </p:cNvPr>
@@ -15618,7 +15832,7 @@
           <p:cNvPr id="19" name="TextBox 18">
             <a:extLst>
               <a:ext uri="{FF2B5EF4-FFF2-40B4-BE49-F238E27FC236}">
-                <a16:creationId xmlns:a16="http://schemas.microsoft.com/office/drawing/2014/main" id="{0ADF118E-FAE1-2CBC-AE62-9FC925EEDEF9}"/>
+                <a16:creationId xmlns:a16="http://schemas.microsoft.com/office/drawing/2014/main" id="{A94960C2-BE1B-FC9E-D27B-125195DED1A6}"/>
               </a:ext>
             </a:extLst>
           </p:cNvPr>
@@ -15658,7 +15872,7 @@
           <p:cNvPr id="20" name="TextBox 19">
             <a:extLst>
               <a:ext uri="{FF2B5EF4-FFF2-40B4-BE49-F238E27FC236}">
-                <a16:creationId xmlns:a16="http://schemas.microsoft.com/office/drawing/2014/main" id="{34AFEDF0-DABD-BD70-F3DF-3F36533AF67C}"/>
+                <a16:creationId xmlns:a16="http://schemas.microsoft.com/office/drawing/2014/main" id="{43A9201A-0436-9EEE-CF25-17D9D0DFC091}"/>
               </a:ext>
             </a:extLst>
           </p:cNvPr>
@@ -15698,7 +15912,7 @@
           <p:cNvPr id="21" name="TextBox 20">
             <a:extLst>
               <a:ext uri="{FF2B5EF4-FFF2-40B4-BE49-F238E27FC236}">
-                <a16:creationId xmlns:a16="http://schemas.microsoft.com/office/drawing/2014/main" id="{B1CBCC48-9609-C8A2-8103-AC03C4475CEF}"/>
+                <a16:creationId xmlns:a16="http://schemas.microsoft.com/office/drawing/2014/main" id="{4BC53BD7-D813-8D9F-768F-3A2E79A7342E}"/>
               </a:ext>
             </a:extLst>
           </p:cNvPr>
@@ -15738,7 +15952,7 @@
           <p:cNvPr id="22" name="TextBox 21">
             <a:extLst>
               <a:ext uri="{FF2B5EF4-FFF2-40B4-BE49-F238E27FC236}">
-                <a16:creationId xmlns:a16="http://schemas.microsoft.com/office/drawing/2014/main" id="{DFA566FD-12B5-71A3-2032-D5A0CC31EDBD}"/>
+                <a16:creationId xmlns:a16="http://schemas.microsoft.com/office/drawing/2014/main" id="{FC7D6CAF-FBCE-F461-FF61-D4CD29ACA386}"/>
               </a:ext>
             </a:extLst>
           </p:cNvPr>
@@ -15778,7 +15992,7 @@
           <p:cNvPr id="23" name="Rectangle 22">
             <a:extLst>
               <a:ext uri="{FF2B5EF4-FFF2-40B4-BE49-F238E27FC236}">
-                <a16:creationId xmlns:a16="http://schemas.microsoft.com/office/drawing/2014/main" id="{4D63A210-6451-2A57-410A-F9F188119869}"/>
+                <a16:creationId xmlns:a16="http://schemas.microsoft.com/office/drawing/2014/main" id="{576BBA8E-7222-3121-FAF5-CC8D5EB8E5BA}"/>
               </a:ext>
             </a:extLst>
           </p:cNvPr>
@@ -15846,7 +16060,7 @@
           <p:cNvPr id="24" name="TextBox 23">
             <a:extLst>
               <a:ext uri="{FF2B5EF4-FFF2-40B4-BE49-F238E27FC236}">
-                <a16:creationId xmlns:a16="http://schemas.microsoft.com/office/drawing/2014/main" id="{666E5C8D-58B8-8C10-ED87-1D64F4731415}"/>
+                <a16:creationId xmlns:a16="http://schemas.microsoft.com/office/drawing/2014/main" id="{F95A5CF1-4E9D-D616-1A2A-ED0D1FD7AF3E}"/>
               </a:ext>
             </a:extLst>
           </p:cNvPr>
@@ -15886,7 +16100,7 @@
           <p:cNvPr id="25" name="TextBox 24">
             <a:extLst>
               <a:ext uri="{FF2B5EF4-FFF2-40B4-BE49-F238E27FC236}">
-                <a16:creationId xmlns:a16="http://schemas.microsoft.com/office/drawing/2014/main" id="{EA889C8D-1F44-FB0E-0D27-7201D8B9D0D8}"/>
+                <a16:creationId xmlns:a16="http://schemas.microsoft.com/office/drawing/2014/main" id="{0B1BE9CA-15E9-E0AE-EE23-4A3555945B51}"/>
               </a:ext>
             </a:extLst>
           </p:cNvPr>
@@ -15926,7 +16140,7 @@
           <p:cNvPr id="26" name="TextBox 25">
             <a:extLst>
               <a:ext uri="{FF2B5EF4-FFF2-40B4-BE49-F238E27FC236}">
-                <a16:creationId xmlns:a16="http://schemas.microsoft.com/office/drawing/2014/main" id="{FA9B5DB9-D6B2-8EF3-6B15-E4242B7FA583}"/>
+                <a16:creationId xmlns:a16="http://schemas.microsoft.com/office/drawing/2014/main" id="{D60F7C23-F21D-F3DE-5B51-C1D865EF5B4C}"/>
               </a:ext>
             </a:extLst>
           </p:cNvPr>
@@ -15966,7 +16180,7 @@
           <p:cNvPr id="27" name="TextBox 26">
             <a:extLst>
               <a:ext uri="{FF2B5EF4-FFF2-40B4-BE49-F238E27FC236}">
-                <a16:creationId xmlns:a16="http://schemas.microsoft.com/office/drawing/2014/main" id="{506A9C11-C6E5-9B45-E045-D62F392B55D1}"/>
+                <a16:creationId xmlns:a16="http://schemas.microsoft.com/office/drawing/2014/main" id="{50173D8D-885D-2BEE-934F-DE736242DE46}"/>
               </a:ext>
             </a:extLst>
           </p:cNvPr>
@@ -16006,7 +16220,7 @@
           <p:cNvPr id="28" name="TextBox 27">
             <a:extLst>
               <a:ext uri="{FF2B5EF4-FFF2-40B4-BE49-F238E27FC236}">
-                <a16:creationId xmlns:a16="http://schemas.microsoft.com/office/drawing/2014/main" id="{941EAFF7-D358-E5CE-034B-278ABC012876}"/>
+                <a16:creationId xmlns:a16="http://schemas.microsoft.com/office/drawing/2014/main" id="{210588AC-16A2-23DF-4EBE-9BA4BDEB9EA8}"/>
               </a:ext>
             </a:extLst>
           </p:cNvPr>
@@ -16046,7 +16260,7 @@
           <p:cNvPr id="29" name="Straight Connector 28">
             <a:extLst>
               <a:ext uri="{FF2B5EF4-FFF2-40B4-BE49-F238E27FC236}">
-                <a16:creationId xmlns:a16="http://schemas.microsoft.com/office/drawing/2014/main" id="{47384D49-E00B-A300-8168-4896AD35A307}"/>
+                <a16:creationId xmlns:a16="http://schemas.microsoft.com/office/drawing/2014/main" id="{6E1FE1FF-8CB5-482E-5718-6A5E5A053F64}"/>
               </a:ext>
             </a:extLst>
           </p:cNvPr>
@@ -16087,7 +16301,7 @@
           <p:cNvPr id="30" name="TextBox 29">
             <a:extLst>
               <a:ext uri="{FF2B5EF4-FFF2-40B4-BE49-F238E27FC236}">
-                <a16:creationId xmlns:a16="http://schemas.microsoft.com/office/drawing/2014/main" id="{B20D21C7-9D3B-6CC2-9715-C4793B7E2360}"/>
+                <a16:creationId xmlns:a16="http://schemas.microsoft.com/office/drawing/2014/main" id="{38371D86-73EF-121B-833B-1D7A0056F841}"/>
               </a:ext>
             </a:extLst>
           </p:cNvPr>
@@ -16127,7 +16341,7 @@
           <p:cNvPr id="31" name="TextBox 30">
             <a:extLst>
               <a:ext uri="{FF2B5EF4-FFF2-40B4-BE49-F238E27FC236}">
-                <a16:creationId xmlns:a16="http://schemas.microsoft.com/office/drawing/2014/main" id="{A3AED694-448A-C02D-2876-61E3344C3458}"/>
+                <a16:creationId xmlns:a16="http://schemas.microsoft.com/office/drawing/2014/main" id="{F5E423F0-C5AF-8298-00C1-E62DE42E8383}"/>
               </a:ext>
             </a:extLst>
           </p:cNvPr>
@@ -16167,7 +16381,7 @@
           <p:cNvPr id="32" name="Rectangle: Rounded Corners 31">
             <a:extLst>
               <a:ext uri="{FF2B5EF4-FFF2-40B4-BE49-F238E27FC236}">
-                <a16:creationId xmlns:a16="http://schemas.microsoft.com/office/drawing/2014/main" id="{26527452-292D-2750-00B5-728F6BE6A874}"/>
+                <a16:creationId xmlns:a16="http://schemas.microsoft.com/office/drawing/2014/main" id="{6A46B9BD-2E7D-0EE6-70FF-C6F7EDE9C0DB}"/>
               </a:ext>
             </a:extLst>
           </p:cNvPr>
@@ -16176,18 +16390,18 @@
         </p:nvSpPr>
         <p:spPr>
           <a:xfrm>
-            <a:off x="812800" y="5626100"/>
-            <a:ext cx="10515600" cy="482600"/>
+            <a:off x="812800" y="5359400"/>
+            <a:ext cx="10515600" cy="927100"/>
           </a:xfrm>
           <a:prstGeom prst="roundRect">
             <a:avLst/>
           </a:prstGeom>
           <a:solidFill>
-            <a:srgbClr val="E4F4F0"/>
+            <a:srgbClr val="F6E8E3"/>
           </a:solidFill>
           <a:ln w="15240">
             <a:solidFill>
-              <a:srgbClr val="3FC6AC"/>
+              <a:srgbClr val="A15E40"/>
             </a:solidFill>
           </a:ln>
         </p:spPr>
@@ -16221,7 +16435,48 @@
           <p:cNvPr id="33" name="TextBox 32">
             <a:extLst>
               <a:ext uri="{FF2B5EF4-FFF2-40B4-BE49-F238E27FC236}">
-                <a16:creationId xmlns:a16="http://schemas.microsoft.com/office/drawing/2014/main" id="{D15AA916-F124-6DA9-848C-C8038A1C9355}"/>
+                <a16:creationId xmlns:a16="http://schemas.microsoft.com/office/drawing/2014/main" id="{7E79F71F-856C-F161-0032-F2997EC3FAB6}"/>
+              </a:ext>
+            </a:extLst>
+          </p:cNvPr>
+          <p:cNvSpPr txBox="1"/>
+          <p:nvPr/>
+        </p:nvSpPr>
+        <p:spPr>
+          <a:xfrm>
+            <a:off x="1016000" y="5460999"/>
+            <a:ext cx="10109200" cy="279400"/>
+          </a:xfrm>
+          <a:prstGeom prst="rect">
+            <a:avLst/>
+          </a:prstGeom>
+          <a:noFill/>
+        </p:spPr>
+        <p:txBody>
+          <a:bodyPr vert="horz" wrap="square" lIns="0" tIns="0" rIns="0" bIns="0" rtlCol="0">
+            <a:noAutofit/>
+          </a:bodyPr>
+          <a:lstStyle/>
+          <a:p>
+            <a:pPr algn="ctr"/>
+            <a:r>
+              <a:rPr lang="en-US" sz="1700" b="1">
+                <a:solidFill>
+                  <a:srgbClr val="13232E"/>
+                </a:solidFill>
+                <a:latin typeface="Aptos" panose="020B0004020202020204" pitchFamily="34" charset="0"/>
+              </a:rPr>
+              <a:t>Not preregistered or independently custodied  |  no direction gate</a:t>
+            </a:r>
+          </a:p>
+        </p:txBody>
+      </p:sp>
+      <p:sp>
+        <p:nvSpPr>
+          <p:cNvPr id="34" name="TextBox 33">
+            <a:extLst>
+              <a:ext uri="{FF2B5EF4-FFF2-40B4-BE49-F238E27FC236}">
+                <a16:creationId xmlns:a16="http://schemas.microsoft.com/office/drawing/2014/main" id="{B63EFF90-5745-4D7C-3E3F-CCEDD305F0C9}"/>
               </a:ext>
             </a:extLst>
           </p:cNvPr>
@@ -16231,7 +16486,7 @@
         <p:spPr>
           <a:xfrm>
             <a:off x="1016000" y="5740399"/>
-            <a:ext cx="10109200" cy="279400"/>
+            <a:ext cx="10109200" cy="508000"/>
           </a:xfrm>
           <a:prstGeom prst="rect">
             <a:avLst/>
@@ -16246,13 +16501,13 @@
           <a:p>
             <a:pPr algn="ctr"/>
             <a:r>
-              <a:rPr lang="en-US" sz="1700" b="1">
+              <a:rPr lang="en-US" sz="1600" b="1">
                 <a:solidFill>
                   <a:srgbClr val="13232E"/>
                 </a:solidFill>
                 <a:latin typeface="Aptos" panose="020B0004020202020204" pitchFamily="34" charset="0"/>
               </a:rPr>
-              <a:t>Observed as-is  |  no favorable/adverse release gate</a:t>
+              <a:t>No behavior-cloning-only ablation was run, so this comparison cannot isolate the incremental effect of PPO fine-tuning.</a:t>
             </a:r>
           </a:p>
         </p:txBody>
@@ -16260,7 +16515,7 @@
     </p:spTree>
     <p:extLst>
       <p:ext uri="{BB962C8B-B14F-4D97-AF65-F5344CB8AC3E}">
-        <p14:creationId xmlns:p14="http://schemas.microsoft.com/office/powerpoint/2010/main" val="1897699327"/>
+        <p14:creationId xmlns:p14="http://schemas.microsoft.com/office/powerpoint/2010/main" val="2234281235"/>
       </p:ext>
     </p:extLst>
   </p:cSld>
@@ -16300,7 +16555,7 @@
           <p:cNvPr id="2" name="TextBox 1">
             <a:extLst>
               <a:ext uri="{FF2B5EF4-FFF2-40B4-BE49-F238E27FC236}">
-                <a16:creationId xmlns:a16="http://schemas.microsoft.com/office/drawing/2014/main" id="{248F3181-5EBB-D33C-9B75-A26E7BB07763}"/>
+                <a16:creationId xmlns:a16="http://schemas.microsoft.com/office/drawing/2014/main" id="{C718CCA1-5CC0-CD7E-3497-4909716F16BF}"/>
               </a:ext>
             </a:extLst>
           </p:cNvPr>
@@ -16340,7 +16595,7 @@
           <p:cNvPr id="3" name="Straight Connector 2">
             <a:extLst>
               <a:ext uri="{FF2B5EF4-FFF2-40B4-BE49-F238E27FC236}">
-                <a16:creationId xmlns:a16="http://schemas.microsoft.com/office/drawing/2014/main" id="{1D496658-BF9D-86BC-8CE8-198D866C07E0}"/>
+                <a16:creationId xmlns:a16="http://schemas.microsoft.com/office/drawing/2014/main" id="{589DDC79-208E-AD30-6884-512FA5F148DE}"/>
               </a:ext>
             </a:extLst>
           </p:cNvPr>
@@ -16381,7 +16636,7 @@
           <p:cNvPr id="4" name="TextBox 3">
             <a:extLst>
               <a:ext uri="{FF2B5EF4-FFF2-40B4-BE49-F238E27FC236}">
-                <a16:creationId xmlns:a16="http://schemas.microsoft.com/office/drawing/2014/main" id="{19314FFF-A8BC-E0C3-05FD-9040226A3BCC}"/>
+                <a16:creationId xmlns:a16="http://schemas.microsoft.com/office/drawing/2014/main" id="{4171CC76-4859-0B71-DFBB-579037EF4946}"/>
               </a:ext>
             </a:extLst>
           </p:cNvPr>
@@ -16422,7 +16677,7 @@
           <p:cNvPr id="5" name="TextBox 4">
             <a:extLst>
               <a:ext uri="{FF2B5EF4-FFF2-40B4-BE49-F238E27FC236}">
-                <a16:creationId xmlns:a16="http://schemas.microsoft.com/office/drawing/2014/main" id="{D45ADFB3-3565-1C3D-3DD5-E22D8C1800A7}"/>
+                <a16:creationId xmlns:a16="http://schemas.microsoft.com/office/drawing/2014/main" id="{733E6B4B-8E15-4B20-2400-4A2239BFFB5F}"/>
               </a:ext>
             </a:extLst>
           </p:cNvPr>
@@ -16462,7 +16717,7 @@
           <p:cNvPr id="6" name="TextBox 5">
             <a:extLst>
               <a:ext uri="{FF2B5EF4-FFF2-40B4-BE49-F238E27FC236}">
-                <a16:creationId xmlns:a16="http://schemas.microsoft.com/office/drawing/2014/main" id="{63212B51-2195-08F4-5372-98958B81AAD7}"/>
+                <a16:creationId xmlns:a16="http://schemas.microsoft.com/office/drawing/2014/main" id="{E8C7351C-5D01-FA83-D47A-BD0130672C7C}"/>
               </a:ext>
             </a:extLst>
           </p:cNvPr>
@@ -16492,7 +16747,7 @@
                 </a:solidFill>
                 <a:latin typeface="Aptos" panose="020B0004020202020204" pitchFamily="34" charset="0"/>
               </a:rPr>
-              <a:t>24 demand-allocation variants preserve PPO's direction</a:t>
+              <a:t>24 demand-allocation variants test local sensitivity</a:t>
             </a:r>
           </a:p>
         </p:txBody>
@@ -16502,7 +16757,7 @@
           <p:cNvPr id="7" name="TextBox 6">
             <a:extLst>
               <a:ext uri="{FF2B5EF4-FFF2-40B4-BE49-F238E27FC236}">
-                <a16:creationId xmlns:a16="http://schemas.microsoft.com/office/drawing/2014/main" id="{39AFFF3D-2166-5364-2E1D-3E6F62E4550B}"/>
+                <a16:creationId xmlns:a16="http://schemas.microsoft.com/office/drawing/2014/main" id="{C7603354-F17A-E0BA-4960-61E8E1DE5514}"/>
               </a:ext>
             </a:extLst>
           </p:cNvPr>
@@ -16542,7 +16797,7 @@
           <p:cNvPr id="8" name="TextBox 7">
             <a:extLst>
               <a:ext uri="{FF2B5EF4-FFF2-40B4-BE49-F238E27FC236}">
-                <a16:creationId xmlns:a16="http://schemas.microsoft.com/office/drawing/2014/main" id="{44C5D066-AADE-5136-6818-E3A96CCFAB39}"/>
+                <a16:creationId xmlns:a16="http://schemas.microsoft.com/office/drawing/2014/main" id="{4D31CB8F-EAF8-4C7B-4365-D9972DECF345}"/>
               </a:ext>
             </a:extLst>
           </p:cNvPr>
@@ -16582,7 +16837,7 @@
           <p:cNvPr id="9" name="Rectangle: Rounded Corners 8">
             <a:extLst>
               <a:ext uri="{FF2B5EF4-FFF2-40B4-BE49-F238E27FC236}">
-                <a16:creationId xmlns:a16="http://schemas.microsoft.com/office/drawing/2014/main" id="{F38B5CAB-E698-5632-F51A-CF22C8D1CDF8}"/>
+                <a16:creationId xmlns:a16="http://schemas.microsoft.com/office/drawing/2014/main" id="{97D31CEB-1735-DC23-CA81-009E60BC8498}"/>
               </a:ext>
             </a:extLst>
           </p:cNvPr>
@@ -16650,7 +16905,7 @@
           <p:cNvPr id="10" name="TextBox 9">
             <a:extLst>
               <a:ext uri="{FF2B5EF4-FFF2-40B4-BE49-F238E27FC236}">
-                <a16:creationId xmlns:a16="http://schemas.microsoft.com/office/drawing/2014/main" id="{69D0E7FB-2BCB-243E-CFF9-323623358920}"/>
+                <a16:creationId xmlns:a16="http://schemas.microsoft.com/office/drawing/2014/main" id="{B28D6425-C25F-7765-F265-666902D9A034}"/>
               </a:ext>
             </a:extLst>
           </p:cNvPr>
@@ -16691,7 +16946,7 @@
           <p:cNvPr id="11" name="TextBox 10">
             <a:extLst>
               <a:ext uri="{FF2B5EF4-FFF2-40B4-BE49-F238E27FC236}">
-                <a16:creationId xmlns:a16="http://schemas.microsoft.com/office/drawing/2014/main" id="{81E4FBD4-C10B-42FA-0E0F-88F55D05B521}"/>
+                <a16:creationId xmlns:a16="http://schemas.microsoft.com/office/drawing/2014/main" id="{346282FD-2962-711E-E332-37567BBFFADC}"/>
               </a:ext>
             </a:extLst>
           </p:cNvPr>
@@ -16732,7 +16987,7 @@
           <p:cNvPr id="12" name="Rectangle: Rounded Corners 11">
             <a:extLst>
               <a:ext uri="{FF2B5EF4-FFF2-40B4-BE49-F238E27FC236}">
-                <a16:creationId xmlns:a16="http://schemas.microsoft.com/office/drawing/2014/main" id="{8385B61B-6496-EF53-1111-734A56B0221C}"/>
+                <a16:creationId xmlns:a16="http://schemas.microsoft.com/office/drawing/2014/main" id="{E1A20804-042D-9879-535E-B5A4171AC618}"/>
               </a:ext>
             </a:extLst>
           </p:cNvPr>
@@ -16800,7 +17055,7 @@
           <p:cNvPr id="13" name="TextBox 12">
             <a:extLst>
               <a:ext uri="{FF2B5EF4-FFF2-40B4-BE49-F238E27FC236}">
-                <a16:creationId xmlns:a16="http://schemas.microsoft.com/office/drawing/2014/main" id="{D6CAC142-01F1-9349-CD69-3AE7B3EA1F6C}"/>
+                <a16:creationId xmlns:a16="http://schemas.microsoft.com/office/drawing/2014/main" id="{B094BA6E-2CCD-8C3C-3E3C-81D4CE377872}"/>
               </a:ext>
             </a:extLst>
           </p:cNvPr>
@@ -16841,7 +17096,7 @@
           <p:cNvPr id="14" name="TextBox 13">
             <a:extLst>
               <a:ext uri="{FF2B5EF4-FFF2-40B4-BE49-F238E27FC236}">
-                <a16:creationId xmlns:a16="http://schemas.microsoft.com/office/drawing/2014/main" id="{2A4B4391-741A-60DC-C5FC-B2E3A41C9894}"/>
+                <a16:creationId xmlns:a16="http://schemas.microsoft.com/office/drawing/2014/main" id="{4C3B30D4-BFF7-E926-AFD3-86FCC6C01603}"/>
               </a:ext>
             </a:extLst>
           </p:cNvPr>
@@ -16882,7 +17137,7 @@
           <p:cNvPr id="15" name="Rectangle: Rounded Corners 14">
             <a:extLst>
               <a:ext uri="{FF2B5EF4-FFF2-40B4-BE49-F238E27FC236}">
-                <a16:creationId xmlns:a16="http://schemas.microsoft.com/office/drawing/2014/main" id="{C0716882-5EA1-6CAF-A151-6C5E29A9DE6D}"/>
+                <a16:creationId xmlns:a16="http://schemas.microsoft.com/office/drawing/2014/main" id="{44D98366-6722-93D4-751C-15513C82BD1B}"/>
               </a:ext>
             </a:extLst>
           </p:cNvPr>
@@ -16950,7 +17205,7 @@
           <p:cNvPr id="16" name="TextBox 15">
             <a:extLst>
               <a:ext uri="{FF2B5EF4-FFF2-40B4-BE49-F238E27FC236}">
-                <a16:creationId xmlns:a16="http://schemas.microsoft.com/office/drawing/2014/main" id="{7C45899C-F9B3-F9DB-03B6-8DAC0853C22D}"/>
+                <a16:creationId xmlns:a16="http://schemas.microsoft.com/office/drawing/2014/main" id="{8ACFB60F-1F04-1BC6-57CC-F583B8F20C1D}"/>
               </a:ext>
             </a:extLst>
           </p:cNvPr>
@@ -16991,7 +17246,7 @@
           <p:cNvPr id="17" name="TextBox 16">
             <a:extLst>
               <a:ext uri="{FF2B5EF4-FFF2-40B4-BE49-F238E27FC236}">
-                <a16:creationId xmlns:a16="http://schemas.microsoft.com/office/drawing/2014/main" id="{92A596C4-C1AA-7F05-4275-C14349F97915}"/>
+                <a16:creationId xmlns:a16="http://schemas.microsoft.com/office/drawing/2014/main" id="{BB9E81A9-6FD3-05A3-91CB-E7532E4474CB}"/>
               </a:ext>
             </a:extLst>
           </p:cNvPr>
@@ -17032,7 +17287,7 @@
           <p:cNvPr id="18" name="TextBox 17">
             <a:extLst>
               <a:ext uri="{FF2B5EF4-FFF2-40B4-BE49-F238E27FC236}">
-                <a16:creationId xmlns:a16="http://schemas.microsoft.com/office/drawing/2014/main" id="{32630367-D8D7-8BAE-019D-269C81621603}"/>
+                <a16:creationId xmlns:a16="http://schemas.microsoft.com/office/drawing/2014/main" id="{E786E3B4-92DB-8B98-3C4C-7E769A760F93}"/>
               </a:ext>
             </a:extLst>
           </p:cNvPr>
@@ -17072,7 +17327,7 @@
           <p:cNvPr id="19" name="TextBox 18">
             <a:extLst>
               <a:ext uri="{FF2B5EF4-FFF2-40B4-BE49-F238E27FC236}">
-                <a16:creationId xmlns:a16="http://schemas.microsoft.com/office/drawing/2014/main" id="{625C5114-BB7F-064D-56D5-1594E09EAE11}"/>
+                <a16:creationId xmlns:a16="http://schemas.microsoft.com/office/drawing/2014/main" id="{D5F2FAEC-984D-A05F-2CD6-3AE1E7BD1228}"/>
               </a:ext>
             </a:extLst>
           </p:cNvPr>
@@ -17102,7 +17357,7 @@
                 </a:solidFill>
                 <a:latin typeface="Aptos" panose="020B0004020202020204" pitchFamily="34" charset="0"/>
               </a:rPr>
-              <a:t>Outage: 19 adverse  |  3 favorable  |  2 ambiguous</a:t>
+              <a:t>Outage: 19 adverse  |  4 favorable  |  1 ambiguous</a:t>
             </a:r>
             <a:endParaRPr lang="en-US" sz="1700" b="1">
               <a:solidFill>
@@ -17118,7 +17373,7 @@
           <p:cNvPr id="20" name="TextBox 19">
             <a:extLst>
               <a:ext uri="{FF2B5EF4-FFF2-40B4-BE49-F238E27FC236}">
-                <a16:creationId xmlns:a16="http://schemas.microsoft.com/office/drawing/2014/main" id="{C633EDC8-8434-4F4D-8850-EA8CDB847605}"/>
+                <a16:creationId xmlns:a16="http://schemas.microsoft.com/office/drawing/2014/main" id="{8071B4A7-F834-9030-5DCA-BCDC8573279C}"/>
               </a:ext>
             </a:extLst>
           </p:cNvPr>
@@ -17148,7 +17403,7 @@
                 </a:solidFill>
                 <a:latin typeface="Aptos" panose="020B0004020202020204" pitchFamily="34" charset="0"/>
               </a:rPr>
-              <a:t>Direction persists, but effect size is not invariant. Classifications are evidence, not a release gate.</a:t>
+              <a:t>Descriptive pointwise 95% intervals; unadjusted for multiple comparisons; no family-wide claim.</a:t>
             </a:r>
           </a:p>
         </p:txBody>
@@ -17156,7 +17411,7 @@
     </p:spTree>
     <p:extLst>
       <p:ext uri="{BB962C8B-B14F-4D97-AF65-F5344CB8AC3E}">
-        <p14:creationId xmlns:p14="http://schemas.microsoft.com/office/powerpoint/2010/main" val="2668230187"/>
+        <p14:creationId xmlns:p14="http://schemas.microsoft.com/office/powerpoint/2010/main" val="2907194677"/>
       </p:ext>
     </p:extLst>
   </p:cSld>

</xml_diff>

<commit_message>
fix(academic): bound claims and refresh inspected graduation artifacts
</commit_message>
<xml_diff>
--- a/output/presentation/gridguard-khartoum-defense.pptx
+++ b/output/presentation/gridguard-khartoum-defense.pptx
@@ -202,9 +202,9 @@
             </a:lvl1pPr>
           </a:lstStyle>
           <a:p>
-            <a:fld id="{E89048A6-5D6A-448B-81F8-77304A8870A2}" type="datetimeFigureOut">
+            <a:fld id="{827195CA-8015-4D13-8E50-00B425D229C8}" type="datetimeFigureOut">
               <a:rPr lang="en-US" smtClean="0"/>
-              <a:t>8/27/2026</a:t>
+              <a:t>10/21/2026</a:t>
             </a:fld>
             <a:endParaRPr lang="en-US"/>
           </a:p>
@@ -360,7 +360,7 @@
             </a:lvl1pPr>
           </a:lstStyle>
           <a:p>
-            <a:fld id="{A90F9F25-4631-43F5-97A3-922655910913}" type="slidenum">
+            <a:fld id="{3170AC7A-110A-46E3-B788-B77DD47A3800}" type="slidenum">
               <a:rPr lang="en-US" smtClean="0"/>
               <a:t>‹#›</a:t>
             </a:fld>
@@ -371,7 +371,7 @@
     </p:spTree>
     <p:extLst>
       <p:ext uri="{BB962C8B-B14F-4D97-AF65-F5344CB8AC3E}">
-        <p14:creationId xmlns:p14="http://schemas.microsoft.com/office/powerpoint/2010/main" val="2744257114"/>
+        <p14:creationId xmlns:p14="http://schemas.microsoft.com/office/powerpoint/2010/main" val="399647185"/>
       </p:ext>
     </p:extLst>
   </p:cSld>
@@ -564,7 +564,7 @@
           <a:bodyPr/>
           <a:lstStyle/>
           <a:p>
-            <a:fld id="{A90F9F25-4631-43F5-97A3-922655910913}" type="slidenum">
+            <a:fld id="{3170AC7A-110A-46E3-B788-B77DD47A3800}" type="slidenum">
               <a:rPr lang="en-US" smtClean="0"/>
               <a:t>1</a:t>
             </a:fld>
@@ -575,7 +575,7 @@
     </p:spTree>
     <p:extLst>
       <p:ext uri="{BB962C8B-B14F-4D97-AF65-F5344CB8AC3E}">
-        <p14:creationId xmlns:p14="http://schemas.microsoft.com/office/powerpoint/2010/main" val="1349486114"/>
+        <p14:creationId xmlns:p14="http://schemas.microsoft.com/office/powerpoint/2010/main" val="779396866"/>
       </p:ext>
     </p:extLst>
   </p:cSld>
@@ -678,7 +678,7 @@
           <a:bodyPr/>
           <a:lstStyle/>
           <a:p>
-            <a:fld id="{A90F9F25-4631-43F5-97A3-922655910913}" type="slidenum">
+            <a:fld id="{3170AC7A-110A-46E3-B788-B77DD47A3800}" type="slidenum">
               <a:rPr lang="en-US" smtClean="0"/>
               <a:t>10</a:t>
             </a:fld>
@@ -689,7 +689,7 @@
     </p:spTree>
     <p:extLst>
       <p:ext uri="{BB962C8B-B14F-4D97-AF65-F5344CB8AC3E}">
-        <p14:creationId xmlns:p14="http://schemas.microsoft.com/office/powerpoint/2010/main" val="2299243170"/>
+        <p14:creationId xmlns:p14="http://schemas.microsoft.com/office/powerpoint/2010/main" val="4080884353"/>
       </p:ext>
     </p:extLst>
   </p:cSld>
@@ -792,7 +792,7 @@
           <a:bodyPr/>
           <a:lstStyle/>
           <a:p>
-            <a:fld id="{A90F9F25-4631-43F5-97A3-922655910913}" type="slidenum">
+            <a:fld id="{3170AC7A-110A-46E3-B788-B77DD47A3800}" type="slidenum">
               <a:rPr lang="en-US" smtClean="0"/>
               <a:t>11</a:t>
             </a:fld>
@@ -803,7 +803,7 @@
     </p:spTree>
     <p:extLst>
       <p:ext uri="{BB962C8B-B14F-4D97-AF65-F5344CB8AC3E}">
-        <p14:creationId xmlns:p14="http://schemas.microsoft.com/office/powerpoint/2010/main" val="1766210412"/>
+        <p14:creationId xmlns:p14="http://schemas.microsoft.com/office/powerpoint/2010/main" val="1482525949"/>
       </p:ext>
     </p:extLst>
   </p:cSld>
@@ -906,7 +906,7 @@
           <a:bodyPr/>
           <a:lstStyle/>
           <a:p>
-            <a:fld id="{A90F9F25-4631-43F5-97A3-922655910913}" type="slidenum">
+            <a:fld id="{3170AC7A-110A-46E3-B788-B77DD47A3800}" type="slidenum">
               <a:rPr lang="en-US" smtClean="0"/>
               <a:t>12</a:t>
             </a:fld>
@@ -917,7 +917,7 @@
     </p:spTree>
     <p:extLst>
       <p:ext uri="{BB962C8B-B14F-4D97-AF65-F5344CB8AC3E}">
-        <p14:creationId xmlns:p14="http://schemas.microsoft.com/office/powerpoint/2010/main" val="1219574278"/>
+        <p14:creationId xmlns:p14="http://schemas.microsoft.com/office/powerpoint/2010/main" val="4232516742"/>
       </p:ext>
     </p:extLst>
   </p:cSld>
@@ -1020,7 +1020,7 @@
           <a:bodyPr/>
           <a:lstStyle/>
           <a:p>
-            <a:fld id="{A90F9F25-4631-43F5-97A3-922655910913}" type="slidenum">
+            <a:fld id="{3170AC7A-110A-46E3-B788-B77DD47A3800}" type="slidenum">
               <a:rPr lang="en-US" smtClean="0"/>
               <a:t>13</a:t>
             </a:fld>
@@ -1031,7 +1031,7 @@
     </p:spTree>
     <p:extLst>
       <p:ext uri="{BB962C8B-B14F-4D97-AF65-F5344CB8AC3E}">
-        <p14:creationId xmlns:p14="http://schemas.microsoft.com/office/powerpoint/2010/main" val="619387505"/>
+        <p14:creationId xmlns:p14="http://schemas.microsoft.com/office/powerpoint/2010/main" val="3986281887"/>
       </p:ext>
     </p:extLst>
   </p:cSld>
@@ -1134,7 +1134,7 @@
           <a:bodyPr/>
           <a:lstStyle/>
           <a:p>
-            <a:fld id="{A90F9F25-4631-43F5-97A3-922655910913}" type="slidenum">
+            <a:fld id="{3170AC7A-110A-46E3-B788-B77DD47A3800}" type="slidenum">
               <a:rPr lang="en-US" smtClean="0"/>
               <a:t>2</a:t>
             </a:fld>
@@ -1145,7 +1145,7 @@
     </p:spTree>
     <p:extLst>
       <p:ext uri="{BB962C8B-B14F-4D97-AF65-F5344CB8AC3E}">
-        <p14:creationId xmlns:p14="http://schemas.microsoft.com/office/powerpoint/2010/main" val="156483792"/>
+        <p14:creationId xmlns:p14="http://schemas.microsoft.com/office/powerpoint/2010/main" val="3459823563"/>
       </p:ext>
     </p:extLst>
   </p:cSld>
@@ -1248,7 +1248,7 @@
           <a:bodyPr/>
           <a:lstStyle/>
           <a:p>
-            <a:fld id="{A90F9F25-4631-43F5-97A3-922655910913}" type="slidenum">
+            <a:fld id="{3170AC7A-110A-46E3-B788-B77DD47A3800}" type="slidenum">
               <a:rPr lang="en-US" smtClean="0"/>
               <a:t>3</a:t>
             </a:fld>
@@ -1259,7 +1259,7 @@
     </p:spTree>
     <p:extLst>
       <p:ext uri="{BB962C8B-B14F-4D97-AF65-F5344CB8AC3E}">
-        <p14:creationId xmlns:p14="http://schemas.microsoft.com/office/powerpoint/2010/main" val="3206552377"/>
+        <p14:creationId xmlns:p14="http://schemas.microsoft.com/office/powerpoint/2010/main" val="3033788126"/>
       </p:ext>
     </p:extLst>
   </p:cSld>
@@ -1336,7 +1336,7 @@
           <a:p>
             <a:r>
               <a:rPr lang="en-US"/>
-              <a:t>- data/evidence/robustness-supplement.json, SHA-256 fabb5a2f13ab31cd51f641f4e6a6db3cce8a28a6e2c4fa144612f634bad0beb1</a:t>
+              <a:t>- data/evidence/robustness-supplement.json, SHA-256 6b56d149331ee191302cd9e6f22365988db0ae301f9441190b61214acf832e48</a:t>
             </a:r>
           </a:p>
           <a:p>
@@ -1362,7 +1362,7 @@
           <a:bodyPr/>
           <a:lstStyle/>
           <a:p>
-            <a:fld id="{A90F9F25-4631-43F5-97A3-922655910913}" type="slidenum">
+            <a:fld id="{3170AC7A-110A-46E3-B788-B77DD47A3800}" type="slidenum">
               <a:rPr lang="en-US" smtClean="0"/>
               <a:t>4</a:t>
             </a:fld>
@@ -1373,7 +1373,7 @@
     </p:spTree>
     <p:extLst>
       <p:ext uri="{BB962C8B-B14F-4D97-AF65-F5344CB8AC3E}">
-        <p14:creationId xmlns:p14="http://schemas.microsoft.com/office/powerpoint/2010/main" val="2750972729"/>
+        <p14:creationId xmlns:p14="http://schemas.microsoft.com/office/powerpoint/2010/main" val="2906003875"/>
       </p:ext>
     </p:extLst>
   </p:cSld>
@@ -1476,7 +1476,7 @@
           <a:bodyPr/>
           <a:lstStyle/>
           <a:p>
-            <a:fld id="{A90F9F25-4631-43F5-97A3-922655910913}" type="slidenum">
+            <a:fld id="{3170AC7A-110A-46E3-B788-B77DD47A3800}" type="slidenum">
               <a:rPr lang="en-US" smtClean="0"/>
               <a:t>5</a:t>
             </a:fld>
@@ -1487,7 +1487,7 @@
     </p:spTree>
     <p:extLst>
       <p:ext uri="{BB962C8B-B14F-4D97-AF65-F5344CB8AC3E}">
-        <p14:creationId xmlns:p14="http://schemas.microsoft.com/office/powerpoint/2010/main" val="3710232905"/>
+        <p14:creationId xmlns:p14="http://schemas.microsoft.com/office/powerpoint/2010/main" val="2905402951"/>
       </p:ext>
     </p:extLst>
   </p:cSld>
@@ -1590,7 +1590,7 @@
           <a:bodyPr/>
           <a:lstStyle/>
           <a:p>
-            <a:fld id="{A90F9F25-4631-43F5-97A3-922655910913}" type="slidenum">
+            <a:fld id="{3170AC7A-110A-46E3-B788-B77DD47A3800}" type="slidenum">
               <a:rPr lang="en-US" smtClean="0"/>
               <a:t>6</a:t>
             </a:fld>
@@ -1601,7 +1601,7 @@
     </p:spTree>
     <p:extLst>
       <p:ext uri="{BB962C8B-B14F-4D97-AF65-F5344CB8AC3E}">
-        <p14:creationId xmlns:p14="http://schemas.microsoft.com/office/powerpoint/2010/main" val="269251964"/>
+        <p14:creationId xmlns:p14="http://schemas.microsoft.com/office/powerpoint/2010/main" val="2415746711"/>
       </p:ext>
     </p:extLst>
   </p:cSld>
@@ -1704,7 +1704,7 @@
           <a:bodyPr/>
           <a:lstStyle/>
           <a:p>
-            <a:fld id="{A90F9F25-4631-43F5-97A3-922655910913}" type="slidenum">
+            <a:fld id="{3170AC7A-110A-46E3-B788-B77DD47A3800}" type="slidenum">
               <a:rPr lang="en-US" smtClean="0"/>
               <a:t>7</a:t>
             </a:fld>
@@ -1715,7 +1715,7 @@
     </p:spTree>
     <p:extLst>
       <p:ext uri="{BB962C8B-B14F-4D97-AF65-F5344CB8AC3E}">
-        <p14:creationId xmlns:p14="http://schemas.microsoft.com/office/powerpoint/2010/main" val="876031067"/>
+        <p14:creationId xmlns:p14="http://schemas.microsoft.com/office/powerpoint/2010/main" val="970062912"/>
       </p:ext>
     </p:extLst>
   </p:cSld>
@@ -1786,7 +1786,7 @@
           <a:p>
             <a:r>
               <a:rPr lang="en-US"/>
-              <a:t>- data/evidence/robustness-supplement.json, SHA-256 fabb5a2f13ab31cd51f641f4e6a6db3cce8a28a6e2c4fa144612f634bad0beb1</a:t>
+              <a:t>- data/evidence/robustness-supplement.json, SHA-256 6b56d149331ee191302cd9e6f22365988db0ae301f9441190b61214acf832e48</a:t>
             </a:r>
           </a:p>
           <a:p>
@@ -1818,7 +1818,7 @@
           <a:bodyPr/>
           <a:lstStyle/>
           <a:p>
-            <a:fld id="{A90F9F25-4631-43F5-97A3-922655910913}" type="slidenum">
+            <a:fld id="{3170AC7A-110A-46E3-B788-B77DD47A3800}" type="slidenum">
               <a:rPr lang="en-US" smtClean="0"/>
               <a:t>8</a:t>
             </a:fld>
@@ -1829,7 +1829,7 @@
     </p:spTree>
     <p:extLst>
       <p:ext uri="{BB962C8B-B14F-4D97-AF65-F5344CB8AC3E}">
-        <p14:creationId xmlns:p14="http://schemas.microsoft.com/office/powerpoint/2010/main" val="3564319738"/>
+        <p14:creationId xmlns:p14="http://schemas.microsoft.com/office/powerpoint/2010/main" val="2508447708"/>
       </p:ext>
     </p:extLst>
   </p:cSld>
@@ -1932,7 +1932,7 @@
           <a:bodyPr/>
           <a:lstStyle/>
           <a:p>
-            <a:fld id="{A90F9F25-4631-43F5-97A3-922655910913}" type="slidenum">
+            <a:fld id="{3170AC7A-110A-46E3-B788-B77DD47A3800}" type="slidenum">
               <a:rPr lang="en-US" smtClean="0"/>
               <a:t>9</a:t>
             </a:fld>
@@ -1943,7 +1943,7 @@
     </p:spTree>
     <p:extLst>
       <p:ext uri="{BB962C8B-B14F-4D97-AF65-F5344CB8AC3E}">
-        <p14:creationId xmlns:p14="http://schemas.microsoft.com/office/powerpoint/2010/main" val="934478509"/>
+        <p14:creationId xmlns:p14="http://schemas.microsoft.com/office/powerpoint/2010/main" val="1835046735"/>
       </p:ext>
     </p:extLst>
   </p:cSld>
@@ -1975,7 +1975,7 @@
           <p:cNvPr id="2" name="Title 1">
             <a:extLst>
               <a:ext uri="{FF2B5EF4-FFF2-40B4-BE49-F238E27FC236}">
-                <a16:creationId xmlns:a16="http://schemas.microsoft.com/office/drawing/2014/main" id="{D00A2336-F06A-5CD8-3E93-118963C27309}"/>
+                <a16:creationId xmlns:a16="http://schemas.microsoft.com/office/drawing/2014/main" id="{8490D82E-FC79-C931-2D6B-39765823A2C5}"/>
               </a:ext>
             </a:extLst>
           </p:cNvPr>
@@ -2012,7 +2012,7 @@
           <p:cNvPr id="3" name="Subtitle 2">
             <a:extLst>
               <a:ext uri="{FF2B5EF4-FFF2-40B4-BE49-F238E27FC236}">
-                <a16:creationId xmlns:a16="http://schemas.microsoft.com/office/drawing/2014/main" id="{22CA1B57-01DD-4F8B-C176-E1A1E1845B7F}"/>
+                <a16:creationId xmlns:a16="http://schemas.microsoft.com/office/drawing/2014/main" id="{C2D161F8-FD6F-ED9F-FFD4-FC44ABCBA39E}"/>
               </a:ext>
             </a:extLst>
           </p:cNvPr>
@@ -2082,7 +2082,7 @@
           <p:cNvPr id="4" name="Date Placeholder 3">
             <a:extLst>
               <a:ext uri="{FF2B5EF4-FFF2-40B4-BE49-F238E27FC236}">
-                <a16:creationId xmlns:a16="http://schemas.microsoft.com/office/drawing/2014/main" id="{37153007-D74C-09A5-A7E3-E35FA42F63CB}"/>
+                <a16:creationId xmlns:a16="http://schemas.microsoft.com/office/drawing/2014/main" id="{85E848B6-F0AA-1C8D-20BA-D45ADA7D05D4}"/>
               </a:ext>
             </a:extLst>
           </p:cNvPr>
@@ -2098,9 +2098,9 @@
           <a:bodyPr/>
           <a:lstStyle/>
           <a:p>
-            <a:fld id="{7C1452FA-4B05-4D50-9D4B-B5BDEE9852A8}" type="datetimeFigureOut">
+            <a:fld id="{5A1F434A-A4E2-44EE-8FE5-26BA97D6F415}" type="datetimeFigureOut">
               <a:rPr lang="en-US" smtClean="0"/>
-              <a:t>8/27/2026</a:t>
+              <a:t>10/21/2026</a:t>
             </a:fld>
             <a:endParaRPr lang="en-US"/>
           </a:p>
@@ -2111,7 +2111,7 @@
           <p:cNvPr id="5" name="Footer Placeholder 4">
             <a:extLst>
               <a:ext uri="{FF2B5EF4-FFF2-40B4-BE49-F238E27FC236}">
-                <a16:creationId xmlns:a16="http://schemas.microsoft.com/office/drawing/2014/main" id="{A1B9B967-87AF-4FD0-8240-CBF4FBA86A70}"/>
+                <a16:creationId xmlns:a16="http://schemas.microsoft.com/office/drawing/2014/main" id="{82F7405E-590C-758E-67B0-C27C97B8AE60}"/>
               </a:ext>
             </a:extLst>
           </p:cNvPr>
@@ -2136,7 +2136,7 @@
           <p:cNvPr id="6" name="Slide Number Placeholder 5">
             <a:extLst>
               <a:ext uri="{FF2B5EF4-FFF2-40B4-BE49-F238E27FC236}">
-                <a16:creationId xmlns:a16="http://schemas.microsoft.com/office/drawing/2014/main" id="{7A5C1E4A-FBFA-2CF4-05C9-94E123ABBDD2}"/>
+                <a16:creationId xmlns:a16="http://schemas.microsoft.com/office/drawing/2014/main" id="{719EB0FD-EB7A-E075-5583-AFF5D3CBCC99}"/>
               </a:ext>
             </a:extLst>
           </p:cNvPr>
@@ -2152,7 +2152,7 @@
           <a:bodyPr/>
           <a:lstStyle/>
           <a:p>
-            <a:fld id="{2865BCB8-0C88-4FC1-96D7-FA9A8E2C4D3A}" type="slidenum">
+            <a:fld id="{2DF905A9-3EDB-48A4-9CAE-3DEC204A8FAE}" type="slidenum">
               <a:rPr lang="en-US" smtClean="0"/>
               <a:t>‹#›</a:t>
             </a:fld>
@@ -2163,7 +2163,7 @@
     </p:spTree>
     <p:extLst>
       <p:ext uri="{BB962C8B-B14F-4D97-AF65-F5344CB8AC3E}">
-        <p14:creationId xmlns:p14="http://schemas.microsoft.com/office/powerpoint/2010/main" val="1939138383"/>
+        <p14:creationId xmlns:p14="http://schemas.microsoft.com/office/powerpoint/2010/main" val="511499972"/>
       </p:ext>
     </p:extLst>
   </p:cSld>
@@ -2195,7 +2195,7 @@
           <p:cNvPr id="2" name="Title 1">
             <a:extLst>
               <a:ext uri="{FF2B5EF4-FFF2-40B4-BE49-F238E27FC236}">
-                <a16:creationId xmlns:a16="http://schemas.microsoft.com/office/drawing/2014/main" id="{7799A609-C7E3-2A29-8189-6EF215D9B630}"/>
+                <a16:creationId xmlns:a16="http://schemas.microsoft.com/office/drawing/2014/main" id="{6B0973DA-C2DB-3704-994B-5A8109C09A7A}"/>
               </a:ext>
             </a:extLst>
           </p:cNvPr>
@@ -2223,7 +2223,7 @@
           <p:cNvPr id="3" name="Vertical Text Placeholder 2">
             <a:extLst>
               <a:ext uri="{FF2B5EF4-FFF2-40B4-BE49-F238E27FC236}">
-                <a16:creationId xmlns:a16="http://schemas.microsoft.com/office/drawing/2014/main" id="{0DA4AE5D-52CE-CFE0-1471-8BCF03DE16B0}"/>
+                <a16:creationId xmlns:a16="http://schemas.microsoft.com/office/drawing/2014/main" id="{A6B893D6-869B-2EDC-87C8-6CC36AA6261D}"/>
               </a:ext>
             </a:extLst>
           </p:cNvPr>
@@ -2280,7 +2280,7 @@
           <p:cNvPr id="4" name="Date Placeholder 3">
             <a:extLst>
               <a:ext uri="{FF2B5EF4-FFF2-40B4-BE49-F238E27FC236}">
-                <a16:creationId xmlns:a16="http://schemas.microsoft.com/office/drawing/2014/main" id="{549E1D15-1BF2-CC3A-99B0-8A33679A63A2}"/>
+                <a16:creationId xmlns:a16="http://schemas.microsoft.com/office/drawing/2014/main" id="{693AF646-50A8-71D2-D8D0-EC4FCF1E1B87}"/>
               </a:ext>
             </a:extLst>
           </p:cNvPr>
@@ -2296,9 +2296,9 @@
           <a:bodyPr/>
           <a:lstStyle/>
           <a:p>
-            <a:fld id="{7C1452FA-4B05-4D50-9D4B-B5BDEE9852A8}" type="datetimeFigureOut">
+            <a:fld id="{5A1F434A-A4E2-44EE-8FE5-26BA97D6F415}" type="datetimeFigureOut">
               <a:rPr lang="en-US" smtClean="0"/>
-              <a:t>8/27/2026</a:t>
+              <a:t>10/21/2026</a:t>
             </a:fld>
             <a:endParaRPr lang="en-US"/>
           </a:p>
@@ -2309,7 +2309,7 @@
           <p:cNvPr id="5" name="Footer Placeholder 4">
             <a:extLst>
               <a:ext uri="{FF2B5EF4-FFF2-40B4-BE49-F238E27FC236}">
-                <a16:creationId xmlns:a16="http://schemas.microsoft.com/office/drawing/2014/main" id="{3615F41D-6F95-EB20-1CF6-C5B57292B496}"/>
+                <a16:creationId xmlns:a16="http://schemas.microsoft.com/office/drawing/2014/main" id="{8BB04EA3-784F-4DFB-DEF1-BE36E225CC7D}"/>
               </a:ext>
             </a:extLst>
           </p:cNvPr>
@@ -2334,7 +2334,7 @@
           <p:cNvPr id="6" name="Slide Number Placeholder 5">
             <a:extLst>
               <a:ext uri="{FF2B5EF4-FFF2-40B4-BE49-F238E27FC236}">
-                <a16:creationId xmlns:a16="http://schemas.microsoft.com/office/drawing/2014/main" id="{3BBFAC7A-1452-19A6-34DA-E939D38C0C9C}"/>
+                <a16:creationId xmlns:a16="http://schemas.microsoft.com/office/drawing/2014/main" id="{419CE560-640F-787D-E61B-DB59F9CAB628}"/>
               </a:ext>
             </a:extLst>
           </p:cNvPr>
@@ -2350,7 +2350,7 @@
           <a:bodyPr/>
           <a:lstStyle/>
           <a:p>
-            <a:fld id="{2865BCB8-0C88-4FC1-96D7-FA9A8E2C4D3A}" type="slidenum">
+            <a:fld id="{2DF905A9-3EDB-48A4-9CAE-3DEC204A8FAE}" type="slidenum">
               <a:rPr lang="en-US" smtClean="0"/>
               <a:t>‹#›</a:t>
             </a:fld>
@@ -2361,7 +2361,7 @@
     </p:spTree>
     <p:extLst>
       <p:ext uri="{BB962C8B-B14F-4D97-AF65-F5344CB8AC3E}">
-        <p14:creationId xmlns:p14="http://schemas.microsoft.com/office/powerpoint/2010/main" val="3590837308"/>
+        <p14:creationId xmlns:p14="http://schemas.microsoft.com/office/powerpoint/2010/main" val="3870501202"/>
       </p:ext>
     </p:extLst>
   </p:cSld>
@@ -2393,7 +2393,7 @@
           <p:cNvPr id="2" name="Vertical Title 1">
             <a:extLst>
               <a:ext uri="{FF2B5EF4-FFF2-40B4-BE49-F238E27FC236}">
-                <a16:creationId xmlns:a16="http://schemas.microsoft.com/office/drawing/2014/main" id="{F755B02A-4868-4C2F-5E9E-FCBE329F4F60}"/>
+                <a16:creationId xmlns:a16="http://schemas.microsoft.com/office/drawing/2014/main" id="{81235BDA-B114-935F-B772-5EF146FC61E3}"/>
               </a:ext>
             </a:extLst>
           </p:cNvPr>
@@ -2426,7 +2426,7 @@
           <p:cNvPr id="3" name="Vertical Text Placeholder 2">
             <a:extLst>
               <a:ext uri="{FF2B5EF4-FFF2-40B4-BE49-F238E27FC236}">
-                <a16:creationId xmlns:a16="http://schemas.microsoft.com/office/drawing/2014/main" id="{533990C8-7BC6-7CE8-DC38-A166E62FE118}"/>
+                <a16:creationId xmlns:a16="http://schemas.microsoft.com/office/drawing/2014/main" id="{DB832606-39FB-761D-8CFB-82C8BE47B4AC}"/>
               </a:ext>
             </a:extLst>
           </p:cNvPr>
@@ -2488,7 +2488,7 @@
           <p:cNvPr id="4" name="Date Placeholder 3">
             <a:extLst>
               <a:ext uri="{FF2B5EF4-FFF2-40B4-BE49-F238E27FC236}">
-                <a16:creationId xmlns:a16="http://schemas.microsoft.com/office/drawing/2014/main" id="{6808A680-DA30-AE65-7F62-DBA40A38DBA1}"/>
+                <a16:creationId xmlns:a16="http://schemas.microsoft.com/office/drawing/2014/main" id="{73EEF129-52E9-CC1F-9352-538ED78132B2}"/>
               </a:ext>
             </a:extLst>
           </p:cNvPr>
@@ -2504,9 +2504,9 @@
           <a:bodyPr/>
           <a:lstStyle/>
           <a:p>
-            <a:fld id="{7C1452FA-4B05-4D50-9D4B-B5BDEE9852A8}" type="datetimeFigureOut">
+            <a:fld id="{5A1F434A-A4E2-44EE-8FE5-26BA97D6F415}" type="datetimeFigureOut">
               <a:rPr lang="en-US" smtClean="0"/>
-              <a:t>8/27/2026</a:t>
+              <a:t>10/21/2026</a:t>
             </a:fld>
             <a:endParaRPr lang="en-US"/>
           </a:p>
@@ -2517,7 +2517,7 @@
           <p:cNvPr id="5" name="Footer Placeholder 4">
             <a:extLst>
               <a:ext uri="{FF2B5EF4-FFF2-40B4-BE49-F238E27FC236}">
-                <a16:creationId xmlns:a16="http://schemas.microsoft.com/office/drawing/2014/main" id="{25645391-BB2E-B87E-B960-C6C18862CF5F}"/>
+                <a16:creationId xmlns:a16="http://schemas.microsoft.com/office/drawing/2014/main" id="{7BC35254-D75D-85D4-9F7B-9629D1E828FE}"/>
               </a:ext>
             </a:extLst>
           </p:cNvPr>
@@ -2542,7 +2542,7 @@
           <p:cNvPr id="6" name="Slide Number Placeholder 5">
             <a:extLst>
               <a:ext uri="{FF2B5EF4-FFF2-40B4-BE49-F238E27FC236}">
-                <a16:creationId xmlns:a16="http://schemas.microsoft.com/office/drawing/2014/main" id="{CB6835CE-6F63-18A8-7289-0DA13C618A82}"/>
+                <a16:creationId xmlns:a16="http://schemas.microsoft.com/office/drawing/2014/main" id="{D2771A7D-FB78-5D7C-8D77-38578AC75729}"/>
               </a:ext>
             </a:extLst>
           </p:cNvPr>
@@ -2558,7 +2558,7 @@
           <a:bodyPr/>
           <a:lstStyle/>
           <a:p>
-            <a:fld id="{2865BCB8-0C88-4FC1-96D7-FA9A8E2C4D3A}" type="slidenum">
+            <a:fld id="{2DF905A9-3EDB-48A4-9CAE-3DEC204A8FAE}" type="slidenum">
               <a:rPr lang="en-US" smtClean="0"/>
               <a:t>‹#›</a:t>
             </a:fld>
@@ -2569,7 +2569,7 @@
     </p:spTree>
     <p:extLst>
       <p:ext uri="{BB962C8B-B14F-4D97-AF65-F5344CB8AC3E}">
-        <p14:creationId xmlns:p14="http://schemas.microsoft.com/office/powerpoint/2010/main" val="155436510"/>
+        <p14:creationId xmlns:p14="http://schemas.microsoft.com/office/powerpoint/2010/main" val="2717740875"/>
       </p:ext>
     </p:extLst>
   </p:cSld>
@@ -2601,7 +2601,7 @@
           <p:cNvPr id="2" name="Title 1">
             <a:extLst>
               <a:ext uri="{FF2B5EF4-FFF2-40B4-BE49-F238E27FC236}">
-                <a16:creationId xmlns:a16="http://schemas.microsoft.com/office/drawing/2014/main" id="{203E3FFC-7CE8-E975-E95E-E0EDDD379983}"/>
+                <a16:creationId xmlns:a16="http://schemas.microsoft.com/office/drawing/2014/main" id="{4B2EF4D2-46F9-A8AC-967D-35DBEBF8D76B}"/>
               </a:ext>
             </a:extLst>
           </p:cNvPr>
@@ -2629,7 +2629,7 @@
           <p:cNvPr id="3" name="Content Placeholder 2">
             <a:extLst>
               <a:ext uri="{FF2B5EF4-FFF2-40B4-BE49-F238E27FC236}">
-                <a16:creationId xmlns:a16="http://schemas.microsoft.com/office/drawing/2014/main" id="{0B32A947-6107-641A-EC46-FC8E34EC5633}"/>
+                <a16:creationId xmlns:a16="http://schemas.microsoft.com/office/drawing/2014/main" id="{3898E505-50EB-4977-0F9D-CD25A6BAE63E}"/>
               </a:ext>
             </a:extLst>
           </p:cNvPr>
@@ -2686,7 +2686,7 @@
           <p:cNvPr id="4" name="Date Placeholder 3">
             <a:extLst>
               <a:ext uri="{FF2B5EF4-FFF2-40B4-BE49-F238E27FC236}">
-                <a16:creationId xmlns:a16="http://schemas.microsoft.com/office/drawing/2014/main" id="{0683BFD0-7ED0-1852-A675-B785444BB232}"/>
+                <a16:creationId xmlns:a16="http://schemas.microsoft.com/office/drawing/2014/main" id="{4E705764-C6E6-E690-1466-8099954967AC}"/>
               </a:ext>
             </a:extLst>
           </p:cNvPr>
@@ -2702,9 +2702,9 @@
           <a:bodyPr/>
           <a:lstStyle/>
           <a:p>
-            <a:fld id="{7C1452FA-4B05-4D50-9D4B-B5BDEE9852A8}" type="datetimeFigureOut">
+            <a:fld id="{5A1F434A-A4E2-44EE-8FE5-26BA97D6F415}" type="datetimeFigureOut">
               <a:rPr lang="en-US" smtClean="0"/>
-              <a:t>8/27/2026</a:t>
+              <a:t>10/21/2026</a:t>
             </a:fld>
             <a:endParaRPr lang="en-US"/>
           </a:p>
@@ -2715,7 +2715,7 @@
           <p:cNvPr id="5" name="Footer Placeholder 4">
             <a:extLst>
               <a:ext uri="{FF2B5EF4-FFF2-40B4-BE49-F238E27FC236}">
-                <a16:creationId xmlns:a16="http://schemas.microsoft.com/office/drawing/2014/main" id="{15FB7A3D-B505-0E62-FBA1-AF8564D22CE6}"/>
+                <a16:creationId xmlns:a16="http://schemas.microsoft.com/office/drawing/2014/main" id="{AEA391D7-3FEE-36EE-ED8C-22141D2B9809}"/>
               </a:ext>
             </a:extLst>
           </p:cNvPr>
@@ -2740,7 +2740,7 @@
           <p:cNvPr id="6" name="Slide Number Placeholder 5">
             <a:extLst>
               <a:ext uri="{FF2B5EF4-FFF2-40B4-BE49-F238E27FC236}">
-                <a16:creationId xmlns:a16="http://schemas.microsoft.com/office/drawing/2014/main" id="{52073997-067F-2E3E-4CAA-55CCFF421A56}"/>
+                <a16:creationId xmlns:a16="http://schemas.microsoft.com/office/drawing/2014/main" id="{95E5FE7C-A2A2-AE64-DBE6-C81125AB834C}"/>
               </a:ext>
             </a:extLst>
           </p:cNvPr>
@@ -2756,7 +2756,7 @@
           <a:bodyPr/>
           <a:lstStyle/>
           <a:p>
-            <a:fld id="{2865BCB8-0C88-4FC1-96D7-FA9A8E2C4D3A}" type="slidenum">
+            <a:fld id="{2DF905A9-3EDB-48A4-9CAE-3DEC204A8FAE}" type="slidenum">
               <a:rPr lang="en-US" smtClean="0"/>
               <a:t>‹#›</a:t>
             </a:fld>
@@ -2767,7 +2767,7 @@
     </p:spTree>
     <p:extLst>
       <p:ext uri="{BB962C8B-B14F-4D97-AF65-F5344CB8AC3E}">
-        <p14:creationId xmlns:p14="http://schemas.microsoft.com/office/powerpoint/2010/main" val="2934827788"/>
+        <p14:creationId xmlns:p14="http://schemas.microsoft.com/office/powerpoint/2010/main" val="1124720087"/>
       </p:ext>
     </p:extLst>
   </p:cSld>
@@ -2799,7 +2799,7 @@
           <p:cNvPr id="2" name="Title 1">
             <a:extLst>
               <a:ext uri="{FF2B5EF4-FFF2-40B4-BE49-F238E27FC236}">
-                <a16:creationId xmlns:a16="http://schemas.microsoft.com/office/drawing/2014/main" id="{C49EA50F-0C52-7937-322C-D962D7C85F65}"/>
+                <a16:creationId xmlns:a16="http://schemas.microsoft.com/office/drawing/2014/main" id="{BFBEDF1D-BB64-02F0-F49D-B4AB36FF0C29}"/>
               </a:ext>
             </a:extLst>
           </p:cNvPr>
@@ -2836,7 +2836,7 @@
           <p:cNvPr id="3" name="Text Placeholder 2">
             <a:extLst>
               <a:ext uri="{FF2B5EF4-FFF2-40B4-BE49-F238E27FC236}">
-                <a16:creationId xmlns:a16="http://schemas.microsoft.com/office/drawing/2014/main" id="{4B6190EA-4FF9-2502-A69A-DC3D8F3770BB}"/>
+                <a16:creationId xmlns:a16="http://schemas.microsoft.com/office/drawing/2014/main" id="{6171A3D9-6682-3B97-16BB-C39E0872F4FD}"/>
               </a:ext>
             </a:extLst>
           </p:cNvPr>
@@ -2961,7 +2961,7 @@
           <p:cNvPr id="4" name="Date Placeholder 3">
             <a:extLst>
               <a:ext uri="{FF2B5EF4-FFF2-40B4-BE49-F238E27FC236}">
-                <a16:creationId xmlns:a16="http://schemas.microsoft.com/office/drawing/2014/main" id="{F7BDBFE3-9104-EF2E-C633-B8B3D4EDFE25}"/>
+                <a16:creationId xmlns:a16="http://schemas.microsoft.com/office/drawing/2014/main" id="{7877B5BB-99D6-FEBB-3ABB-D21627BA53FB}"/>
               </a:ext>
             </a:extLst>
           </p:cNvPr>
@@ -2977,9 +2977,9 @@
           <a:bodyPr/>
           <a:lstStyle/>
           <a:p>
-            <a:fld id="{7C1452FA-4B05-4D50-9D4B-B5BDEE9852A8}" type="datetimeFigureOut">
+            <a:fld id="{5A1F434A-A4E2-44EE-8FE5-26BA97D6F415}" type="datetimeFigureOut">
               <a:rPr lang="en-US" smtClean="0"/>
-              <a:t>8/27/2026</a:t>
+              <a:t>10/21/2026</a:t>
             </a:fld>
             <a:endParaRPr lang="en-US"/>
           </a:p>
@@ -2990,7 +2990,7 @@
           <p:cNvPr id="5" name="Footer Placeholder 4">
             <a:extLst>
               <a:ext uri="{FF2B5EF4-FFF2-40B4-BE49-F238E27FC236}">
-                <a16:creationId xmlns:a16="http://schemas.microsoft.com/office/drawing/2014/main" id="{B5604DD5-2F73-35AD-2880-86C1E8061F7E}"/>
+                <a16:creationId xmlns:a16="http://schemas.microsoft.com/office/drawing/2014/main" id="{8BFE87BF-C597-2C91-93DA-63A357429042}"/>
               </a:ext>
             </a:extLst>
           </p:cNvPr>
@@ -3015,7 +3015,7 @@
           <p:cNvPr id="6" name="Slide Number Placeholder 5">
             <a:extLst>
               <a:ext uri="{FF2B5EF4-FFF2-40B4-BE49-F238E27FC236}">
-                <a16:creationId xmlns:a16="http://schemas.microsoft.com/office/drawing/2014/main" id="{BE5D45D9-E461-6FC3-0CD7-36BF9C06A22A}"/>
+                <a16:creationId xmlns:a16="http://schemas.microsoft.com/office/drawing/2014/main" id="{2226FBD9-025C-EC7C-938F-16712AD92B76}"/>
               </a:ext>
             </a:extLst>
           </p:cNvPr>
@@ -3031,7 +3031,7 @@
           <a:bodyPr/>
           <a:lstStyle/>
           <a:p>
-            <a:fld id="{2865BCB8-0C88-4FC1-96D7-FA9A8E2C4D3A}" type="slidenum">
+            <a:fld id="{2DF905A9-3EDB-48A4-9CAE-3DEC204A8FAE}" type="slidenum">
               <a:rPr lang="en-US" smtClean="0"/>
               <a:t>‹#›</a:t>
             </a:fld>
@@ -3042,7 +3042,7 @@
     </p:spTree>
     <p:extLst>
       <p:ext uri="{BB962C8B-B14F-4D97-AF65-F5344CB8AC3E}">
-        <p14:creationId xmlns:p14="http://schemas.microsoft.com/office/powerpoint/2010/main" val="2396495636"/>
+        <p14:creationId xmlns:p14="http://schemas.microsoft.com/office/powerpoint/2010/main" val="776549930"/>
       </p:ext>
     </p:extLst>
   </p:cSld>
@@ -3074,7 +3074,7 @@
           <p:cNvPr id="2" name="Title 1">
             <a:extLst>
               <a:ext uri="{FF2B5EF4-FFF2-40B4-BE49-F238E27FC236}">
-                <a16:creationId xmlns:a16="http://schemas.microsoft.com/office/drawing/2014/main" id="{D369E5B1-5DB4-9703-FAA4-39C48939F187}"/>
+                <a16:creationId xmlns:a16="http://schemas.microsoft.com/office/drawing/2014/main" id="{E9D82907-03BB-7D03-350D-4E5BB5ABBAFE}"/>
               </a:ext>
             </a:extLst>
           </p:cNvPr>
@@ -3102,7 +3102,7 @@
           <p:cNvPr id="3" name="Content Placeholder 2">
             <a:extLst>
               <a:ext uri="{FF2B5EF4-FFF2-40B4-BE49-F238E27FC236}">
-                <a16:creationId xmlns:a16="http://schemas.microsoft.com/office/drawing/2014/main" id="{3E5BD140-72DA-2863-757A-04EF888D0A43}"/>
+                <a16:creationId xmlns:a16="http://schemas.microsoft.com/office/drawing/2014/main" id="{13F6AEC4-2603-6ED7-9D99-6507A14B2E7F}"/>
               </a:ext>
             </a:extLst>
           </p:cNvPr>
@@ -3164,7 +3164,7 @@
           <p:cNvPr id="4" name="Content Placeholder 3">
             <a:extLst>
               <a:ext uri="{FF2B5EF4-FFF2-40B4-BE49-F238E27FC236}">
-                <a16:creationId xmlns:a16="http://schemas.microsoft.com/office/drawing/2014/main" id="{62C9371D-6D93-DA41-F037-FA5E6A9B935A}"/>
+                <a16:creationId xmlns:a16="http://schemas.microsoft.com/office/drawing/2014/main" id="{C2F6A3A1-E712-FDFC-0D80-5114D32AD347}"/>
               </a:ext>
             </a:extLst>
           </p:cNvPr>
@@ -3226,7 +3226,7 @@
           <p:cNvPr id="5" name="Date Placeholder 4">
             <a:extLst>
               <a:ext uri="{FF2B5EF4-FFF2-40B4-BE49-F238E27FC236}">
-                <a16:creationId xmlns:a16="http://schemas.microsoft.com/office/drawing/2014/main" id="{D127769A-22BA-A1B2-A4D7-E387B6A46E3A}"/>
+                <a16:creationId xmlns:a16="http://schemas.microsoft.com/office/drawing/2014/main" id="{235FE664-FC47-2D4F-BA65-F78849CF72DA}"/>
               </a:ext>
             </a:extLst>
           </p:cNvPr>
@@ -3242,9 +3242,9 @@
           <a:bodyPr/>
           <a:lstStyle/>
           <a:p>
-            <a:fld id="{7C1452FA-4B05-4D50-9D4B-B5BDEE9852A8}" type="datetimeFigureOut">
+            <a:fld id="{5A1F434A-A4E2-44EE-8FE5-26BA97D6F415}" type="datetimeFigureOut">
               <a:rPr lang="en-US" smtClean="0"/>
-              <a:t>8/27/2026</a:t>
+              <a:t>10/21/2026</a:t>
             </a:fld>
             <a:endParaRPr lang="en-US"/>
           </a:p>
@@ -3255,7 +3255,7 @@
           <p:cNvPr id="6" name="Footer Placeholder 5">
             <a:extLst>
               <a:ext uri="{FF2B5EF4-FFF2-40B4-BE49-F238E27FC236}">
-                <a16:creationId xmlns:a16="http://schemas.microsoft.com/office/drawing/2014/main" id="{EF191833-25A3-BDC5-3139-1798DD5CA144}"/>
+                <a16:creationId xmlns:a16="http://schemas.microsoft.com/office/drawing/2014/main" id="{AB66D22C-DEDC-9973-1A8B-AB9F4D474B36}"/>
               </a:ext>
             </a:extLst>
           </p:cNvPr>
@@ -3280,7 +3280,7 @@
           <p:cNvPr id="7" name="Slide Number Placeholder 6">
             <a:extLst>
               <a:ext uri="{FF2B5EF4-FFF2-40B4-BE49-F238E27FC236}">
-                <a16:creationId xmlns:a16="http://schemas.microsoft.com/office/drawing/2014/main" id="{2D7DA7E9-8CF0-CC5B-F548-A049E31A14B0}"/>
+                <a16:creationId xmlns:a16="http://schemas.microsoft.com/office/drawing/2014/main" id="{1104DD3A-611B-4F64-A9C9-D18C37875D46}"/>
               </a:ext>
             </a:extLst>
           </p:cNvPr>
@@ -3296,7 +3296,7 @@
           <a:bodyPr/>
           <a:lstStyle/>
           <a:p>
-            <a:fld id="{2865BCB8-0C88-4FC1-96D7-FA9A8E2C4D3A}" type="slidenum">
+            <a:fld id="{2DF905A9-3EDB-48A4-9CAE-3DEC204A8FAE}" type="slidenum">
               <a:rPr lang="en-US" smtClean="0"/>
               <a:t>‹#›</a:t>
             </a:fld>
@@ -3307,7 +3307,7 @@
     </p:spTree>
     <p:extLst>
       <p:ext uri="{BB962C8B-B14F-4D97-AF65-F5344CB8AC3E}">
-        <p14:creationId xmlns:p14="http://schemas.microsoft.com/office/powerpoint/2010/main" val="4247593966"/>
+        <p14:creationId xmlns:p14="http://schemas.microsoft.com/office/powerpoint/2010/main" val="2120832531"/>
       </p:ext>
     </p:extLst>
   </p:cSld>
@@ -3339,7 +3339,7 @@
           <p:cNvPr id="2" name="Title 1">
             <a:extLst>
               <a:ext uri="{FF2B5EF4-FFF2-40B4-BE49-F238E27FC236}">
-                <a16:creationId xmlns:a16="http://schemas.microsoft.com/office/drawing/2014/main" id="{AE4F3B64-D064-D09B-7F71-7AC78D5573CC}"/>
+                <a16:creationId xmlns:a16="http://schemas.microsoft.com/office/drawing/2014/main" id="{24CC6B9F-CA9A-5C06-1115-57C90A11A5C8}"/>
               </a:ext>
             </a:extLst>
           </p:cNvPr>
@@ -3372,7 +3372,7 @@
           <p:cNvPr id="3" name="Text Placeholder 2">
             <a:extLst>
               <a:ext uri="{FF2B5EF4-FFF2-40B4-BE49-F238E27FC236}">
-                <a16:creationId xmlns:a16="http://schemas.microsoft.com/office/drawing/2014/main" id="{73ADDA3E-FBC5-220E-A3F7-D0D4B394C9FB}"/>
+                <a16:creationId xmlns:a16="http://schemas.microsoft.com/office/drawing/2014/main" id="{D13D49E4-3C40-6745-414B-2080C31A6AAA}"/>
               </a:ext>
             </a:extLst>
           </p:cNvPr>
@@ -3443,7 +3443,7 @@
           <p:cNvPr id="4" name="Content Placeholder 3">
             <a:extLst>
               <a:ext uri="{FF2B5EF4-FFF2-40B4-BE49-F238E27FC236}">
-                <a16:creationId xmlns:a16="http://schemas.microsoft.com/office/drawing/2014/main" id="{95D44360-406E-2CDC-CDDE-FC5CD7DBA031}"/>
+                <a16:creationId xmlns:a16="http://schemas.microsoft.com/office/drawing/2014/main" id="{D9EB6460-A539-43F0-4BDE-37F3E8BA251A}"/>
               </a:ext>
             </a:extLst>
           </p:cNvPr>
@@ -3505,7 +3505,7 @@
           <p:cNvPr id="5" name="Text Placeholder 4">
             <a:extLst>
               <a:ext uri="{FF2B5EF4-FFF2-40B4-BE49-F238E27FC236}">
-                <a16:creationId xmlns:a16="http://schemas.microsoft.com/office/drawing/2014/main" id="{A464D964-AF18-9DAF-49A3-CAC6AC804858}"/>
+                <a16:creationId xmlns:a16="http://schemas.microsoft.com/office/drawing/2014/main" id="{4892F51B-CC50-D86F-DFE2-6E8CD7902352}"/>
               </a:ext>
             </a:extLst>
           </p:cNvPr>
@@ -3576,7 +3576,7 @@
           <p:cNvPr id="6" name="Content Placeholder 5">
             <a:extLst>
               <a:ext uri="{FF2B5EF4-FFF2-40B4-BE49-F238E27FC236}">
-                <a16:creationId xmlns:a16="http://schemas.microsoft.com/office/drawing/2014/main" id="{2D894DA9-707B-2AC3-7F03-96918994F086}"/>
+                <a16:creationId xmlns:a16="http://schemas.microsoft.com/office/drawing/2014/main" id="{9D7E7189-9F14-74CB-1D0D-88051AAA5605}"/>
               </a:ext>
             </a:extLst>
           </p:cNvPr>
@@ -3638,7 +3638,7 @@
           <p:cNvPr id="7" name="Date Placeholder 6">
             <a:extLst>
               <a:ext uri="{FF2B5EF4-FFF2-40B4-BE49-F238E27FC236}">
-                <a16:creationId xmlns:a16="http://schemas.microsoft.com/office/drawing/2014/main" id="{B94FCF2D-98CB-8DEA-0BA8-0D667EBBCA0F}"/>
+                <a16:creationId xmlns:a16="http://schemas.microsoft.com/office/drawing/2014/main" id="{87FBC77B-6750-5393-3AEF-9211E3E8161D}"/>
               </a:ext>
             </a:extLst>
           </p:cNvPr>
@@ -3654,9 +3654,9 @@
           <a:bodyPr/>
           <a:lstStyle/>
           <a:p>
-            <a:fld id="{7C1452FA-4B05-4D50-9D4B-B5BDEE9852A8}" type="datetimeFigureOut">
+            <a:fld id="{5A1F434A-A4E2-44EE-8FE5-26BA97D6F415}" type="datetimeFigureOut">
               <a:rPr lang="en-US" smtClean="0"/>
-              <a:t>8/27/2026</a:t>
+              <a:t>10/21/2026</a:t>
             </a:fld>
             <a:endParaRPr lang="en-US"/>
           </a:p>
@@ -3667,7 +3667,7 @@
           <p:cNvPr id="8" name="Footer Placeholder 7">
             <a:extLst>
               <a:ext uri="{FF2B5EF4-FFF2-40B4-BE49-F238E27FC236}">
-                <a16:creationId xmlns:a16="http://schemas.microsoft.com/office/drawing/2014/main" id="{88E1CEF2-5621-F965-E20F-43111BF55E96}"/>
+                <a16:creationId xmlns:a16="http://schemas.microsoft.com/office/drawing/2014/main" id="{AA2FC9A9-6D9E-75D6-ABD0-4F42F8BEB404}"/>
               </a:ext>
             </a:extLst>
           </p:cNvPr>
@@ -3692,7 +3692,7 @@
           <p:cNvPr id="9" name="Slide Number Placeholder 8">
             <a:extLst>
               <a:ext uri="{FF2B5EF4-FFF2-40B4-BE49-F238E27FC236}">
-                <a16:creationId xmlns:a16="http://schemas.microsoft.com/office/drawing/2014/main" id="{AD35DD33-7507-36C5-CE21-8E033D34D138}"/>
+                <a16:creationId xmlns:a16="http://schemas.microsoft.com/office/drawing/2014/main" id="{909B81C5-42C5-2264-1EB4-7455E0F6DF02}"/>
               </a:ext>
             </a:extLst>
           </p:cNvPr>
@@ -3708,7 +3708,7 @@
           <a:bodyPr/>
           <a:lstStyle/>
           <a:p>
-            <a:fld id="{2865BCB8-0C88-4FC1-96D7-FA9A8E2C4D3A}" type="slidenum">
+            <a:fld id="{2DF905A9-3EDB-48A4-9CAE-3DEC204A8FAE}" type="slidenum">
               <a:rPr lang="en-US" smtClean="0"/>
               <a:t>‹#›</a:t>
             </a:fld>
@@ -3719,7 +3719,7 @@
     </p:spTree>
     <p:extLst>
       <p:ext uri="{BB962C8B-B14F-4D97-AF65-F5344CB8AC3E}">
-        <p14:creationId xmlns:p14="http://schemas.microsoft.com/office/powerpoint/2010/main" val="3283110740"/>
+        <p14:creationId xmlns:p14="http://schemas.microsoft.com/office/powerpoint/2010/main" val="3716277374"/>
       </p:ext>
     </p:extLst>
   </p:cSld>
@@ -3751,7 +3751,7 @@
           <p:cNvPr id="2" name="Title 1">
             <a:extLst>
               <a:ext uri="{FF2B5EF4-FFF2-40B4-BE49-F238E27FC236}">
-                <a16:creationId xmlns:a16="http://schemas.microsoft.com/office/drawing/2014/main" id="{F3BE2B24-FA52-BF6E-CAEA-59D76EC4A485}"/>
+                <a16:creationId xmlns:a16="http://schemas.microsoft.com/office/drawing/2014/main" id="{1AEFF241-9DBE-5F0B-83CE-C496A8B68908}"/>
               </a:ext>
             </a:extLst>
           </p:cNvPr>
@@ -3779,7 +3779,7 @@
           <p:cNvPr id="3" name="Date Placeholder 2">
             <a:extLst>
               <a:ext uri="{FF2B5EF4-FFF2-40B4-BE49-F238E27FC236}">
-                <a16:creationId xmlns:a16="http://schemas.microsoft.com/office/drawing/2014/main" id="{F7521CF5-1D7C-EFD0-83D6-39E8D8F27FC2}"/>
+                <a16:creationId xmlns:a16="http://schemas.microsoft.com/office/drawing/2014/main" id="{ADDCA294-AE37-A140-9440-5921D302DDFC}"/>
               </a:ext>
             </a:extLst>
           </p:cNvPr>
@@ -3795,9 +3795,9 @@
           <a:bodyPr/>
           <a:lstStyle/>
           <a:p>
-            <a:fld id="{7C1452FA-4B05-4D50-9D4B-B5BDEE9852A8}" type="datetimeFigureOut">
+            <a:fld id="{5A1F434A-A4E2-44EE-8FE5-26BA97D6F415}" type="datetimeFigureOut">
               <a:rPr lang="en-US" smtClean="0"/>
-              <a:t>8/27/2026</a:t>
+              <a:t>10/21/2026</a:t>
             </a:fld>
             <a:endParaRPr lang="en-US"/>
           </a:p>
@@ -3808,7 +3808,7 @@
           <p:cNvPr id="4" name="Footer Placeholder 3">
             <a:extLst>
               <a:ext uri="{FF2B5EF4-FFF2-40B4-BE49-F238E27FC236}">
-                <a16:creationId xmlns:a16="http://schemas.microsoft.com/office/drawing/2014/main" id="{C8535A8E-B281-FC0F-DDB1-32108C9781F7}"/>
+                <a16:creationId xmlns:a16="http://schemas.microsoft.com/office/drawing/2014/main" id="{3DFF89D0-8964-9935-CA8C-F60230D29710}"/>
               </a:ext>
             </a:extLst>
           </p:cNvPr>
@@ -3833,7 +3833,7 @@
           <p:cNvPr id="5" name="Slide Number Placeholder 4">
             <a:extLst>
               <a:ext uri="{FF2B5EF4-FFF2-40B4-BE49-F238E27FC236}">
-                <a16:creationId xmlns:a16="http://schemas.microsoft.com/office/drawing/2014/main" id="{F6C8FA72-7470-EF1C-2CE5-73A1262E70FF}"/>
+                <a16:creationId xmlns:a16="http://schemas.microsoft.com/office/drawing/2014/main" id="{FD2300C4-0977-3950-4CF1-24810E24046B}"/>
               </a:ext>
             </a:extLst>
           </p:cNvPr>
@@ -3849,7 +3849,7 @@
           <a:bodyPr/>
           <a:lstStyle/>
           <a:p>
-            <a:fld id="{2865BCB8-0C88-4FC1-96D7-FA9A8E2C4D3A}" type="slidenum">
+            <a:fld id="{2DF905A9-3EDB-48A4-9CAE-3DEC204A8FAE}" type="slidenum">
               <a:rPr lang="en-US" smtClean="0"/>
               <a:t>‹#›</a:t>
             </a:fld>
@@ -3860,7 +3860,7 @@
     </p:spTree>
     <p:extLst>
       <p:ext uri="{BB962C8B-B14F-4D97-AF65-F5344CB8AC3E}">
-        <p14:creationId xmlns:p14="http://schemas.microsoft.com/office/powerpoint/2010/main" val="1048654581"/>
+        <p14:creationId xmlns:p14="http://schemas.microsoft.com/office/powerpoint/2010/main" val="1867071018"/>
       </p:ext>
     </p:extLst>
   </p:cSld>
@@ -3892,7 +3892,7 @@
           <p:cNvPr id="2" name="Date Placeholder 1">
             <a:extLst>
               <a:ext uri="{FF2B5EF4-FFF2-40B4-BE49-F238E27FC236}">
-                <a16:creationId xmlns:a16="http://schemas.microsoft.com/office/drawing/2014/main" id="{4B1241E1-93D4-D88B-EE2C-DE29CABE4C73}"/>
+                <a16:creationId xmlns:a16="http://schemas.microsoft.com/office/drawing/2014/main" id="{182C00A0-E244-AA0D-68E7-D50B3DF9756C}"/>
               </a:ext>
             </a:extLst>
           </p:cNvPr>
@@ -3908,9 +3908,9 @@
           <a:bodyPr/>
           <a:lstStyle/>
           <a:p>
-            <a:fld id="{7C1452FA-4B05-4D50-9D4B-B5BDEE9852A8}" type="datetimeFigureOut">
+            <a:fld id="{5A1F434A-A4E2-44EE-8FE5-26BA97D6F415}" type="datetimeFigureOut">
               <a:rPr lang="en-US" smtClean="0"/>
-              <a:t>8/27/2026</a:t>
+              <a:t>10/21/2026</a:t>
             </a:fld>
             <a:endParaRPr lang="en-US"/>
           </a:p>
@@ -3921,7 +3921,7 @@
           <p:cNvPr id="3" name="Footer Placeholder 2">
             <a:extLst>
               <a:ext uri="{FF2B5EF4-FFF2-40B4-BE49-F238E27FC236}">
-                <a16:creationId xmlns:a16="http://schemas.microsoft.com/office/drawing/2014/main" id="{6DBEE740-F404-4FAC-C105-5D85EBFD8C3E}"/>
+                <a16:creationId xmlns:a16="http://schemas.microsoft.com/office/drawing/2014/main" id="{67DC061E-4AF5-1FCE-6829-94D28A27E376}"/>
               </a:ext>
             </a:extLst>
           </p:cNvPr>
@@ -3946,7 +3946,7 @@
           <p:cNvPr id="4" name="Slide Number Placeholder 3">
             <a:extLst>
               <a:ext uri="{FF2B5EF4-FFF2-40B4-BE49-F238E27FC236}">
-                <a16:creationId xmlns:a16="http://schemas.microsoft.com/office/drawing/2014/main" id="{ABB2D972-D245-5657-0DFD-95FC7F70A3CA}"/>
+                <a16:creationId xmlns:a16="http://schemas.microsoft.com/office/drawing/2014/main" id="{DF64A5D7-D22F-8B69-45E7-72D8C21343B1}"/>
               </a:ext>
             </a:extLst>
           </p:cNvPr>
@@ -3962,7 +3962,7 @@
           <a:bodyPr/>
           <a:lstStyle/>
           <a:p>
-            <a:fld id="{2865BCB8-0C88-4FC1-96D7-FA9A8E2C4D3A}" type="slidenum">
+            <a:fld id="{2DF905A9-3EDB-48A4-9CAE-3DEC204A8FAE}" type="slidenum">
               <a:rPr lang="en-US" smtClean="0"/>
               <a:t>‹#›</a:t>
             </a:fld>
@@ -3973,7 +3973,7 @@
     </p:spTree>
     <p:extLst>
       <p:ext uri="{BB962C8B-B14F-4D97-AF65-F5344CB8AC3E}">
-        <p14:creationId xmlns:p14="http://schemas.microsoft.com/office/powerpoint/2010/main" val="4207070119"/>
+        <p14:creationId xmlns:p14="http://schemas.microsoft.com/office/powerpoint/2010/main" val="491064235"/>
       </p:ext>
     </p:extLst>
   </p:cSld>
@@ -4005,7 +4005,7 @@
           <p:cNvPr id="2" name="Title 1">
             <a:extLst>
               <a:ext uri="{FF2B5EF4-FFF2-40B4-BE49-F238E27FC236}">
-                <a16:creationId xmlns:a16="http://schemas.microsoft.com/office/drawing/2014/main" id="{85591910-682C-FC5C-AD4E-95DE631E76EB}"/>
+                <a16:creationId xmlns:a16="http://schemas.microsoft.com/office/drawing/2014/main" id="{C09BA5C1-0DB6-59B5-23CC-0BB967C503BE}"/>
               </a:ext>
             </a:extLst>
           </p:cNvPr>
@@ -4042,7 +4042,7 @@
           <p:cNvPr id="3" name="Content Placeholder 2">
             <a:extLst>
               <a:ext uri="{FF2B5EF4-FFF2-40B4-BE49-F238E27FC236}">
-                <a16:creationId xmlns:a16="http://schemas.microsoft.com/office/drawing/2014/main" id="{E0BA635A-3C16-2952-828D-86DF5EC07D57}"/>
+                <a16:creationId xmlns:a16="http://schemas.microsoft.com/office/drawing/2014/main" id="{302D3604-8330-7E86-9B41-AF7AF044E3B2}"/>
               </a:ext>
             </a:extLst>
           </p:cNvPr>
@@ -4132,7 +4132,7 @@
           <p:cNvPr id="4" name="Text Placeholder 3">
             <a:extLst>
               <a:ext uri="{FF2B5EF4-FFF2-40B4-BE49-F238E27FC236}">
-                <a16:creationId xmlns:a16="http://schemas.microsoft.com/office/drawing/2014/main" id="{7438A900-8FB1-C13A-8879-5A2B35D48F62}"/>
+                <a16:creationId xmlns:a16="http://schemas.microsoft.com/office/drawing/2014/main" id="{9173EC27-7339-7E65-D66C-E36FAB801308}"/>
               </a:ext>
             </a:extLst>
           </p:cNvPr>
@@ -4203,7 +4203,7 @@
           <p:cNvPr id="5" name="Date Placeholder 4">
             <a:extLst>
               <a:ext uri="{FF2B5EF4-FFF2-40B4-BE49-F238E27FC236}">
-                <a16:creationId xmlns:a16="http://schemas.microsoft.com/office/drawing/2014/main" id="{BD8331CF-094D-B665-AA44-881BBA2FE3FD}"/>
+                <a16:creationId xmlns:a16="http://schemas.microsoft.com/office/drawing/2014/main" id="{70F2B560-F652-5E5D-EEF6-8DBEC3A27BEB}"/>
               </a:ext>
             </a:extLst>
           </p:cNvPr>
@@ -4219,9 +4219,9 @@
           <a:bodyPr/>
           <a:lstStyle/>
           <a:p>
-            <a:fld id="{7C1452FA-4B05-4D50-9D4B-B5BDEE9852A8}" type="datetimeFigureOut">
+            <a:fld id="{5A1F434A-A4E2-44EE-8FE5-26BA97D6F415}" type="datetimeFigureOut">
               <a:rPr lang="en-US" smtClean="0"/>
-              <a:t>8/27/2026</a:t>
+              <a:t>10/21/2026</a:t>
             </a:fld>
             <a:endParaRPr lang="en-US"/>
           </a:p>
@@ -4232,7 +4232,7 @@
           <p:cNvPr id="6" name="Footer Placeholder 5">
             <a:extLst>
               <a:ext uri="{FF2B5EF4-FFF2-40B4-BE49-F238E27FC236}">
-                <a16:creationId xmlns:a16="http://schemas.microsoft.com/office/drawing/2014/main" id="{ED5E4212-80C8-C5BA-D705-93E1365AE88C}"/>
+                <a16:creationId xmlns:a16="http://schemas.microsoft.com/office/drawing/2014/main" id="{AE2A6B08-F077-7EB4-A957-F5E8236367C7}"/>
               </a:ext>
             </a:extLst>
           </p:cNvPr>
@@ -4257,7 +4257,7 @@
           <p:cNvPr id="7" name="Slide Number Placeholder 6">
             <a:extLst>
               <a:ext uri="{FF2B5EF4-FFF2-40B4-BE49-F238E27FC236}">
-                <a16:creationId xmlns:a16="http://schemas.microsoft.com/office/drawing/2014/main" id="{1F219717-465A-6CCF-6D12-7FFF02C67625}"/>
+                <a16:creationId xmlns:a16="http://schemas.microsoft.com/office/drawing/2014/main" id="{21505407-CB6A-9D18-00AE-51FB4515F3D0}"/>
               </a:ext>
             </a:extLst>
           </p:cNvPr>
@@ -4273,7 +4273,7 @@
           <a:bodyPr/>
           <a:lstStyle/>
           <a:p>
-            <a:fld id="{2865BCB8-0C88-4FC1-96D7-FA9A8E2C4D3A}" type="slidenum">
+            <a:fld id="{2DF905A9-3EDB-48A4-9CAE-3DEC204A8FAE}" type="slidenum">
               <a:rPr lang="en-US" smtClean="0"/>
               <a:t>‹#›</a:t>
             </a:fld>
@@ -4284,7 +4284,7 @@
     </p:spTree>
     <p:extLst>
       <p:ext uri="{BB962C8B-B14F-4D97-AF65-F5344CB8AC3E}">
-        <p14:creationId xmlns:p14="http://schemas.microsoft.com/office/powerpoint/2010/main" val="28576324"/>
+        <p14:creationId xmlns:p14="http://schemas.microsoft.com/office/powerpoint/2010/main" val="4154868072"/>
       </p:ext>
     </p:extLst>
   </p:cSld>
@@ -4316,7 +4316,7 @@
           <p:cNvPr id="2" name="Title 1">
             <a:extLst>
               <a:ext uri="{FF2B5EF4-FFF2-40B4-BE49-F238E27FC236}">
-                <a16:creationId xmlns:a16="http://schemas.microsoft.com/office/drawing/2014/main" id="{CAD4BBAC-8697-0A25-0C0C-3E5756B7889A}"/>
+                <a16:creationId xmlns:a16="http://schemas.microsoft.com/office/drawing/2014/main" id="{1158370B-197A-8158-A574-24C6A4D04659}"/>
               </a:ext>
             </a:extLst>
           </p:cNvPr>
@@ -4353,12 +4353,12 @@
           <p:cNvPr id="3" name="Picture Placeholder 2">
             <a:extLst>
               <a:ext uri="{FF2B5EF4-FFF2-40B4-BE49-F238E27FC236}">
-                <a16:creationId xmlns:a16="http://schemas.microsoft.com/office/drawing/2014/main" id="{F6B486D5-EE62-3903-CB99-E702E97524E5}"/>
+                <a16:creationId xmlns:a16="http://schemas.microsoft.com/office/drawing/2014/main" id="{4F79AD52-D4B0-D57A-1AB8-3D83A3BE991E}"/>
               </a:ext>
             </a:extLst>
           </p:cNvPr>
           <p:cNvSpPr>
-            <a:spLocks noGrp="1"/>
+            <a:spLocks noGrp="1" noChangeAspect="1"/>
           </p:cNvSpPr>
           <p:nvPr>
             <p:ph type="pic" idx="1"/>
@@ -4420,7 +4420,7 @@
           <p:cNvPr id="4" name="Text Placeholder 3">
             <a:extLst>
               <a:ext uri="{FF2B5EF4-FFF2-40B4-BE49-F238E27FC236}">
-                <a16:creationId xmlns:a16="http://schemas.microsoft.com/office/drawing/2014/main" id="{4772A0F5-200B-95DA-4340-94B9667D409E}"/>
+                <a16:creationId xmlns:a16="http://schemas.microsoft.com/office/drawing/2014/main" id="{E7F0EB70-18C6-E72E-7743-106F7389F4B6}"/>
               </a:ext>
             </a:extLst>
           </p:cNvPr>
@@ -4491,7 +4491,7 @@
           <p:cNvPr id="5" name="Date Placeholder 4">
             <a:extLst>
               <a:ext uri="{FF2B5EF4-FFF2-40B4-BE49-F238E27FC236}">
-                <a16:creationId xmlns:a16="http://schemas.microsoft.com/office/drawing/2014/main" id="{61B42D8D-8CF8-408B-3EF1-35B6E3848387}"/>
+                <a16:creationId xmlns:a16="http://schemas.microsoft.com/office/drawing/2014/main" id="{FCC42B02-8170-8862-911B-ED6FA6354BA2}"/>
               </a:ext>
             </a:extLst>
           </p:cNvPr>
@@ -4507,9 +4507,9 @@
           <a:bodyPr/>
           <a:lstStyle/>
           <a:p>
-            <a:fld id="{7C1452FA-4B05-4D50-9D4B-B5BDEE9852A8}" type="datetimeFigureOut">
+            <a:fld id="{5A1F434A-A4E2-44EE-8FE5-26BA97D6F415}" type="datetimeFigureOut">
               <a:rPr lang="en-US" smtClean="0"/>
-              <a:t>8/27/2026</a:t>
+              <a:t>10/21/2026</a:t>
             </a:fld>
             <a:endParaRPr lang="en-US"/>
           </a:p>
@@ -4520,7 +4520,7 @@
           <p:cNvPr id="6" name="Footer Placeholder 5">
             <a:extLst>
               <a:ext uri="{FF2B5EF4-FFF2-40B4-BE49-F238E27FC236}">
-                <a16:creationId xmlns:a16="http://schemas.microsoft.com/office/drawing/2014/main" id="{C3699054-880A-4B07-A03F-61DD2A52F801}"/>
+                <a16:creationId xmlns:a16="http://schemas.microsoft.com/office/drawing/2014/main" id="{9E1E4910-A294-7E29-6090-9E5FED9F930C}"/>
               </a:ext>
             </a:extLst>
           </p:cNvPr>
@@ -4545,7 +4545,7 @@
           <p:cNvPr id="7" name="Slide Number Placeholder 6">
             <a:extLst>
               <a:ext uri="{FF2B5EF4-FFF2-40B4-BE49-F238E27FC236}">
-                <a16:creationId xmlns:a16="http://schemas.microsoft.com/office/drawing/2014/main" id="{63D7718C-E7C0-9AEB-4F10-A36F6E404B11}"/>
+                <a16:creationId xmlns:a16="http://schemas.microsoft.com/office/drawing/2014/main" id="{873D985F-736A-9867-0BC8-406D411C3353}"/>
               </a:ext>
             </a:extLst>
           </p:cNvPr>
@@ -4561,7 +4561,7 @@
           <a:bodyPr/>
           <a:lstStyle/>
           <a:p>
-            <a:fld id="{2865BCB8-0C88-4FC1-96D7-FA9A8E2C4D3A}" type="slidenum">
+            <a:fld id="{2DF905A9-3EDB-48A4-9CAE-3DEC204A8FAE}" type="slidenum">
               <a:rPr lang="en-US" smtClean="0"/>
               <a:t>‹#›</a:t>
             </a:fld>
@@ -4572,7 +4572,7 @@
     </p:spTree>
     <p:extLst>
       <p:ext uri="{BB962C8B-B14F-4D97-AF65-F5344CB8AC3E}">
-        <p14:creationId xmlns:p14="http://schemas.microsoft.com/office/powerpoint/2010/main" val="209690494"/>
+        <p14:creationId xmlns:p14="http://schemas.microsoft.com/office/powerpoint/2010/main" val="2553021271"/>
       </p:ext>
     </p:extLst>
   </p:cSld>
@@ -4609,7 +4609,7 @@
           <p:cNvPr id="2" name="Title Placeholder 1">
             <a:extLst>
               <a:ext uri="{FF2B5EF4-FFF2-40B4-BE49-F238E27FC236}">
-                <a16:creationId xmlns:a16="http://schemas.microsoft.com/office/drawing/2014/main" id="{9157D37A-E94C-C303-6499-A8E3020566AA}"/>
+                <a16:creationId xmlns:a16="http://schemas.microsoft.com/office/drawing/2014/main" id="{B175E950-8613-CA33-4AF3-DCAFECB78F88}"/>
               </a:ext>
             </a:extLst>
           </p:cNvPr>
@@ -4647,7 +4647,7 @@
           <p:cNvPr id="3" name="Text Placeholder 2">
             <a:extLst>
               <a:ext uri="{FF2B5EF4-FFF2-40B4-BE49-F238E27FC236}">
-                <a16:creationId xmlns:a16="http://schemas.microsoft.com/office/drawing/2014/main" id="{F1F6477D-F2E5-931C-9352-B7FFEA30C76D}"/>
+                <a16:creationId xmlns:a16="http://schemas.microsoft.com/office/drawing/2014/main" id="{A625ECFC-89E1-4216-26BB-6F4F23632F2A}"/>
               </a:ext>
             </a:extLst>
           </p:cNvPr>
@@ -4714,7 +4714,7 @@
           <p:cNvPr id="4" name="Date Placeholder 3">
             <a:extLst>
               <a:ext uri="{FF2B5EF4-FFF2-40B4-BE49-F238E27FC236}">
-                <a16:creationId xmlns:a16="http://schemas.microsoft.com/office/drawing/2014/main" id="{AA1A541B-ACBB-0506-95B4-5157F552C58C}"/>
+                <a16:creationId xmlns:a16="http://schemas.microsoft.com/office/drawing/2014/main" id="{BA7FFE75-AB57-64CF-01EA-D1780AC131F4}"/>
               </a:ext>
             </a:extLst>
           </p:cNvPr>
@@ -4748,9 +4748,9 @@
             </a:lvl1pPr>
           </a:lstStyle>
           <a:p>
-            <a:fld id="{7C1452FA-4B05-4D50-9D4B-B5BDEE9852A8}" type="datetimeFigureOut">
+            <a:fld id="{5A1F434A-A4E2-44EE-8FE5-26BA97D6F415}" type="datetimeFigureOut">
               <a:rPr lang="en-US" smtClean="0"/>
-              <a:t>8/27/2026</a:t>
+              <a:t>10/21/2026</a:t>
             </a:fld>
             <a:endParaRPr lang="en-US"/>
           </a:p>
@@ -4761,7 +4761,7 @@
           <p:cNvPr id="5" name="Footer Placeholder 4">
             <a:extLst>
               <a:ext uri="{FF2B5EF4-FFF2-40B4-BE49-F238E27FC236}">
-                <a16:creationId xmlns:a16="http://schemas.microsoft.com/office/drawing/2014/main" id="{CE007E54-5BC8-7D96-96D4-C4BD1C1B3425}"/>
+                <a16:creationId xmlns:a16="http://schemas.microsoft.com/office/drawing/2014/main" id="{249A70B8-B846-A0E1-BD02-888C558AAE98}"/>
               </a:ext>
             </a:extLst>
           </p:cNvPr>
@@ -4804,7 +4804,7 @@
           <p:cNvPr id="6" name="Slide Number Placeholder 5">
             <a:extLst>
               <a:ext uri="{FF2B5EF4-FFF2-40B4-BE49-F238E27FC236}">
-                <a16:creationId xmlns:a16="http://schemas.microsoft.com/office/drawing/2014/main" id="{9AE76C2E-BFE3-40DE-3CE3-DE1563D983BA}"/>
+                <a16:creationId xmlns:a16="http://schemas.microsoft.com/office/drawing/2014/main" id="{F8255E2D-229E-D077-14EB-ACCD8072D175}"/>
               </a:ext>
             </a:extLst>
           </p:cNvPr>
@@ -4838,7 +4838,7 @@
             </a:lvl1pPr>
           </a:lstStyle>
           <a:p>
-            <a:fld id="{2865BCB8-0C88-4FC1-96D7-FA9A8E2C4D3A}" type="slidenum">
+            <a:fld id="{2DF905A9-3EDB-48A4-9CAE-3DEC204A8FAE}" type="slidenum">
               <a:rPr lang="en-US" smtClean="0"/>
               <a:t>‹#›</a:t>
             </a:fld>
@@ -4849,7 +4849,7 @@
     </p:spTree>
     <p:extLst>
       <p:ext uri="{BB962C8B-B14F-4D97-AF65-F5344CB8AC3E}">
-        <p14:creationId xmlns:p14="http://schemas.microsoft.com/office/powerpoint/2010/main" val="2005794855"/>
+        <p14:creationId xmlns:p14="http://schemas.microsoft.com/office/powerpoint/2010/main" val="2865381856"/>
       </p:ext>
     </p:extLst>
   </p:cSld>
@@ -5180,7 +5180,7 @@
           <p:cNvPr id="2" name="TextBox 1">
             <a:extLst>
               <a:ext uri="{FF2B5EF4-FFF2-40B4-BE49-F238E27FC236}">
-                <a16:creationId xmlns:a16="http://schemas.microsoft.com/office/drawing/2014/main" id="{46CB3C61-A763-CF07-D4E6-25BD2CB32CCA}"/>
+                <a16:creationId xmlns:a16="http://schemas.microsoft.com/office/drawing/2014/main" id="{C93BDCDE-4D2F-303D-587A-D5C353D3A1EE}"/>
               </a:ext>
             </a:extLst>
           </p:cNvPr>
@@ -5220,7 +5220,7 @@
           <p:cNvPr id="3" name="TextBox 2">
             <a:extLst>
               <a:ext uri="{FF2B5EF4-FFF2-40B4-BE49-F238E27FC236}">
-                <a16:creationId xmlns:a16="http://schemas.microsoft.com/office/drawing/2014/main" id="{C6FE3814-715C-7742-6975-1918D853140A}"/>
+                <a16:creationId xmlns:a16="http://schemas.microsoft.com/office/drawing/2014/main" id="{2BB82501-25F9-5390-091C-AC531E1B434D}"/>
               </a:ext>
             </a:extLst>
           </p:cNvPr>
@@ -5260,7 +5260,7 @@
           <p:cNvPr id="4" name="TextBox 3">
             <a:extLst>
               <a:ext uri="{FF2B5EF4-FFF2-40B4-BE49-F238E27FC236}">
-                <a16:creationId xmlns:a16="http://schemas.microsoft.com/office/drawing/2014/main" id="{7B4DDC1D-D0A5-1C96-3152-991F98AC5045}"/>
+                <a16:creationId xmlns:a16="http://schemas.microsoft.com/office/drawing/2014/main" id="{EE715E85-D96C-49B7-6F9C-3DD94FDB8CD4}"/>
               </a:ext>
             </a:extLst>
           </p:cNvPr>
@@ -5300,7 +5300,7 @@
           <p:cNvPr id="5" name="Straight Connector 4">
             <a:extLst>
               <a:ext uri="{FF2B5EF4-FFF2-40B4-BE49-F238E27FC236}">
-                <a16:creationId xmlns:a16="http://schemas.microsoft.com/office/drawing/2014/main" id="{B20216F9-BE94-C0DF-E376-E9629F3C90F9}"/>
+                <a16:creationId xmlns:a16="http://schemas.microsoft.com/office/drawing/2014/main" id="{F9E951F1-D557-CB31-5C08-4A1E62D3DD68}"/>
               </a:ext>
             </a:extLst>
           </p:cNvPr>
@@ -5341,7 +5341,7 @@
           <p:cNvPr id="6" name="TextBox 5">
             <a:extLst>
               <a:ext uri="{FF2B5EF4-FFF2-40B4-BE49-F238E27FC236}">
-                <a16:creationId xmlns:a16="http://schemas.microsoft.com/office/drawing/2014/main" id="{F9E451D2-F53B-8FA4-7B4F-6A30C4A7D07F}"/>
+                <a16:creationId xmlns:a16="http://schemas.microsoft.com/office/drawing/2014/main" id="{7F45DA4F-2F8F-E509-2152-6D800CDC5D9E}"/>
               </a:ext>
             </a:extLst>
           </p:cNvPr>
@@ -5387,7 +5387,7 @@
           <p:cNvPr id="7" name="TextBox 6">
             <a:extLst>
               <a:ext uri="{FF2B5EF4-FFF2-40B4-BE49-F238E27FC236}">
-                <a16:creationId xmlns:a16="http://schemas.microsoft.com/office/drawing/2014/main" id="{F4A0AB05-DD22-3D95-30E6-5AED0103A221}"/>
+                <a16:creationId xmlns:a16="http://schemas.microsoft.com/office/drawing/2014/main" id="{DE64D276-4366-9081-B3E0-5FFDA7455A2B}"/>
               </a:ext>
             </a:extLst>
           </p:cNvPr>
@@ -5427,7 +5427,7 @@
           <p:cNvPr id="8" name="TextBox 7">
             <a:extLst>
               <a:ext uri="{FF2B5EF4-FFF2-40B4-BE49-F238E27FC236}">
-                <a16:creationId xmlns:a16="http://schemas.microsoft.com/office/drawing/2014/main" id="{F529106E-C908-92C2-C8E4-59F72AEE5E0B}"/>
+                <a16:creationId xmlns:a16="http://schemas.microsoft.com/office/drawing/2014/main" id="{2F5C1934-3E1F-9DA8-FF3F-1162C7FDF476}"/>
               </a:ext>
             </a:extLst>
           </p:cNvPr>
@@ -5467,7 +5467,7 @@
           <p:cNvPr id="9" name="TextBox 8">
             <a:extLst>
               <a:ext uri="{FF2B5EF4-FFF2-40B4-BE49-F238E27FC236}">
-                <a16:creationId xmlns:a16="http://schemas.microsoft.com/office/drawing/2014/main" id="{CFF473A5-25D0-9560-F152-DED05E9F855A}"/>
+                <a16:creationId xmlns:a16="http://schemas.microsoft.com/office/drawing/2014/main" id="{0621D97E-B09F-1CE5-C9A8-2AE1719B7A1E}"/>
               </a:ext>
             </a:extLst>
           </p:cNvPr>
@@ -5505,7 +5505,7 @@
     </p:spTree>
     <p:extLst>
       <p:ext uri="{BB962C8B-B14F-4D97-AF65-F5344CB8AC3E}">
-        <p14:creationId xmlns:p14="http://schemas.microsoft.com/office/powerpoint/2010/main" val="1706612588"/>
+        <p14:creationId xmlns:p14="http://schemas.microsoft.com/office/powerpoint/2010/main" val="2019807551"/>
       </p:ext>
     </p:extLst>
   </p:cSld>
@@ -5545,7 +5545,7 @@
           <p:cNvPr id="2" name="TextBox 1">
             <a:extLst>
               <a:ext uri="{FF2B5EF4-FFF2-40B4-BE49-F238E27FC236}">
-                <a16:creationId xmlns:a16="http://schemas.microsoft.com/office/drawing/2014/main" id="{D65E3B50-CA5F-4242-040D-64325ABFB687}"/>
+                <a16:creationId xmlns:a16="http://schemas.microsoft.com/office/drawing/2014/main" id="{40676505-E06F-9BFC-CA7B-E00771B18B3A}"/>
               </a:ext>
             </a:extLst>
           </p:cNvPr>
@@ -5585,7 +5585,7 @@
           <p:cNvPr id="3" name="Straight Connector 2">
             <a:extLst>
               <a:ext uri="{FF2B5EF4-FFF2-40B4-BE49-F238E27FC236}">
-                <a16:creationId xmlns:a16="http://schemas.microsoft.com/office/drawing/2014/main" id="{E04C12A8-416A-F2EC-EC45-0019F55012E5}"/>
+                <a16:creationId xmlns:a16="http://schemas.microsoft.com/office/drawing/2014/main" id="{CD52E43D-FEE7-FE31-E5E7-86309AA51FFA}"/>
               </a:ext>
             </a:extLst>
           </p:cNvPr>
@@ -5626,7 +5626,7 @@
           <p:cNvPr id="4" name="TextBox 3">
             <a:extLst>
               <a:ext uri="{FF2B5EF4-FFF2-40B4-BE49-F238E27FC236}">
-                <a16:creationId xmlns:a16="http://schemas.microsoft.com/office/drawing/2014/main" id="{A0379B67-6E5B-4EEB-FC2A-5351A8845E23}"/>
+                <a16:creationId xmlns:a16="http://schemas.microsoft.com/office/drawing/2014/main" id="{AEB2E779-6E10-926C-F670-33C1A88EABEA}"/>
               </a:ext>
             </a:extLst>
           </p:cNvPr>
@@ -5667,7 +5667,7 @@
           <p:cNvPr id="5" name="TextBox 4">
             <a:extLst>
               <a:ext uri="{FF2B5EF4-FFF2-40B4-BE49-F238E27FC236}">
-                <a16:creationId xmlns:a16="http://schemas.microsoft.com/office/drawing/2014/main" id="{C461A9B5-33F9-B246-1BB1-1C5C13AC10CF}"/>
+                <a16:creationId xmlns:a16="http://schemas.microsoft.com/office/drawing/2014/main" id="{F3E3F877-1F2B-E187-0A2A-F081BEE97B63}"/>
               </a:ext>
             </a:extLst>
           </p:cNvPr>
@@ -5707,7 +5707,7 @@
           <p:cNvPr id="6" name="TextBox 5">
             <a:extLst>
               <a:ext uri="{FF2B5EF4-FFF2-40B4-BE49-F238E27FC236}">
-                <a16:creationId xmlns:a16="http://schemas.microsoft.com/office/drawing/2014/main" id="{906A23E6-2024-E8E7-22E1-15CF99BD2FD0}"/>
+                <a16:creationId xmlns:a16="http://schemas.microsoft.com/office/drawing/2014/main" id="{8137BAA7-D5CB-8D1D-0014-E209B9C5A69C}"/>
               </a:ext>
             </a:extLst>
           </p:cNvPr>
@@ -5747,7 +5747,7 @@
           <p:cNvPr id="7" name="TextBox 6">
             <a:extLst>
               <a:ext uri="{FF2B5EF4-FFF2-40B4-BE49-F238E27FC236}">
-                <a16:creationId xmlns:a16="http://schemas.microsoft.com/office/drawing/2014/main" id="{5AACD480-6980-9AF9-F9E5-53B3A2F5BC82}"/>
+                <a16:creationId xmlns:a16="http://schemas.microsoft.com/office/drawing/2014/main" id="{43947E3E-8BA5-EA0F-1FB6-A5DA61BD629C}"/>
               </a:ext>
             </a:extLst>
           </p:cNvPr>
@@ -5777,7 +5777,7 @@
                 </a:solidFill>
                 <a:latin typeface="Aptos" panose="020B0004020202020204" pitchFamily="34" charset="0"/>
               </a:rPr>
-              <a:t>Pooled error metric</a:t>
+              <a:t>Pooled error metric (MW)</a:t>
             </a:r>
           </a:p>
         </p:txBody>
@@ -5787,7 +5787,7 @@
           <p:cNvPr id="8" name="TextBox 7">
             <a:extLst>
               <a:ext uri="{FF2B5EF4-FFF2-40B4-BE49-F238E27FC236}">
-                <a16:creationId xmlns:a16="http://schemas.microsoft.com/office/drawing/2014/main" id="{7AE13EE3-D3D8-940B-5EA1-13D00089BE91}"/>
+                <a16:creationId xmlns:a16="http://schemas.microsoft.com/office/drawing/2014/main" id="{456AAD11-7B38-6E56-80C2-66698A002F60}"/>
               </a:ext>
             </a:extLst>
           </p:cNvPr>
@@ -5813,7 +5813,7 @@
             <a:r>
               <a:rPr lang="en-US" sz="1600" b="1">
                 <a:solidFill>
-                  <a:srgbClr val="3FC6AC"/>
+                  <a:srgbClr val="007565"/>
                 </a:solidFill>
                 <a:latin typeface="Aptos" panose="020B0004020202020204" pitchFamily="34" charset="0"/>
               </a:rPr>
@@ -5827,7 +5827,7 @@
           <p:cNvPr id="9" name="TextBox 8">
             <a:extLst>
               <a:ext uri="{FF2B5EF4-FFF2-40B4-BE49-F238E27FC236}">
-                <a16:creationId xmlns:a16="http://schemas.microsoft.com/office/drawing/2014/main" id="{E437D3B4-3E10-415F-776B-D010EBC54AF8}"/>
+                <a16:creationId xmlns:a16="http://schemas.microsoft.com/office/drawing/2014/main" id="{EA2247D6-51AC-74FA-653D-B94448E146A6}"/>
               </a:ext>
             </a:extLst>
           </p:cNvPr>
@@ -5867,7 +5867,7 @@
           <p:cNvPr id="10" name="Rectangle 9">
             <a:extLst>
               <a:ext uri="{FF2B5EF4-FFF2-40B4-BE49-F238E27FC236}">
-                <a16:creationId xmlns:a16="http://schemas.microsoft.com/office/drawing/2014/main" id="{3B74B0EA-EC4A-CEC6-1514-D38005E1646A}"/>
+                <a16:creationId xmlns:a16="http://schemas.microsoft.com/office/drawing/2014/main" id="{516D791A-2394-745E-BA80-87C633314320}"/>
               </a:ext>
             </a:extLst>
           </p:cNvPr>
@@ -5935,7 +5935,7 @@
           <p:cNvPr id="11" name="TextBox 10">
             <a:extLst>
               <a:ext uri="{FF2B5EF4-FFF2-40B4-BE49-F238E27FC236}">
-                <a16:creationId xmlns:a16="http://schemas.microsoft.com/office/drawing/2014/main" id="{9ED19679-836E-FF3C-508E-CC51D3AF59FB}"/>
+                <a16:creationId xmlns:a16="http://schemas.microsoft.com/office/drawing/2014/main" id="{80C4D048-3CB1-5827-0C82-E81E544D3668}"/>
               </a:ext>
             </a:extLst>
           </p:cNvPr>
@@ -5975,7 +5975,7 @@
           <p:cNvPr id="12" name="TextBox 11">
             <a:extLst>
               <a:ext uri="{FF2B5EF4-FFF2-40B4-BE49-F238E27FC236}">
-                <a16:creationId xmlns:a16="http://schemas.microsoft.com/office/drawing/2014/main" id="{3D64A780-AC0A-367C-5151-66C491706ECB}"/>
+                <a16:creationId xmlns:a16="http://schemas.microsoft.com/office/drawing/2014/main" id="{E6ABA853-3268-2DAF-4299-D929BF650FBD}"/>
               </a:ext>
             </a:extLst>
           </p:cNvPr>
@@ -6001,7 +6001,7 @@
             <a:r>
               <a:rPr lang="en-US" sz="1900" b="1">
                 <a:solidFill>
-                  <a:srgbClr val="3FC6AC"/>
+                  <a:srgbClr val="007565"/>
                 </a:solidFill>
                 <a:latin typeface="Aptos" panose="020B0004020202020204" pitchFamily="34" charset="0"/>
               </a:rPr>
@@ -6015,7 +6015,7 @@
           <p:cNvPr id="13" name="TextBox 12">
             <a:extLst>
               <a:ext uri="{FF2B5EF4-FFF2-40B4-BE49-F238E27FC236}">
-                <a16:creationId xmlns:a16="http://schemas.microsoft.com/office/drawing/2014/main" id="{EC69307D-0AB3-89E6-DA76-F755CD9FE31B}"/>
+                <a16:creationId xmlns:a16="http://schemas.microsoft.com/office/drawing/2014/main" id="{5D758E2B-1EB7-D460-5408-284275A59DFB}"/>
               </a:ext>
             </a:extLst>
           </p:cNvPr>
@@ -6055,7 +6055,7 @@
           <p:cNvPr id="14" name="TextBox 13">
             <a:extLst>
               <a:ext uri="{FF2B5EF4-FFF2-40B4-BE49-F238E27FC236}">
-                <a16:creationId xmlns:a16="http://schemas.microsoft.com/office/drawing/2014/main" id="{5806A9D7-897B-1859-D346-899ABBFE177E}"/>
+                <a16:creationId xmlns:a16="http://schemas.microsoft.com/office/drawing/2014/main" id="{FD023DF0-AAED-3A3D-2D92-4E11CB5F4E19}"/>
               </a:ext>
             </a:extLst>
           </p:cNvPr>
@@ -6095,7 +6095,7 @@
           <p:cNvPr id="15" name="TextBox 14">
             <a:extLst>
               <a:ext uri="{FF2B5EF4-FFF2-40B4-BE49-F238E27FC236}">
-                <a16:creationId xmlns:a16="http://schemas.microsoft.com/office/drawing/2014/main" id="{72C389FE-4BAD-1DB0-0443-6EFCA2AD5091}"/>
+                <a16:creationId xmlns:a16="http://schemas.microsoft.com/office/drawing/2014/main" id="{6E825EDB-DD97-00AE-0D08-B73B13861676}"/>
               </a:ext>
             </a:extLst>
           </p:cNvPr>
@@ -6121,7 +6121,7 @@
             <a:r>
               <a:rPr lang="en-US" sz="1900" b="1">
                 <a:solidFill>
-                  <a:srgbClr val="3FC6AC"/>
+                  <a:srgbClr val="007565"/>
                 </a:solidFill>
                 <a:latin typeface="Aptos" panose="020B0004020202020204" pitchFamily="34" charset="0"/>
               </a:rPr>
@@ -6135,7 +6135,7 @@
           <p:cNvPr id="16" name="TextBox 15">
             <a:extLst>
               <a:ext uri="{FF2B5EF4-FFF2-40B4-BE49-F238E27FC236}">
-                <a16:creationId xmlns:a16="http://schemas.microsoft.com/office/drawing/2014/main" id="{45965479-EB31-05C9-B2DD-28B68C4D93F6}"/>
+                <a16:creationId xmlns:a16="http://schemas.microsoft.com/office/drawing/2014/main" id="{0CC7803E-E220-CD35-B9CF-FB6F33A41A17}"/>
               </a:ext>
             </a:extLst>
           </p:cNvPr>
@@ -6175,7 +6175,7 @@
           <p:cNvPr id="17" name="Rectangle 16">
             <a:extLst>
               <a:ext uri="{FF2B5EF4-FFF2-40B4-BE49-F238E27FC236}">
-                <a16:creationId xmlns:a16="http://schemas.microsoft.com/office/drawing/2014/main" id="{580B6776-683C-EC99-D152-8AD92F774468}"/>
+                <a16:creationId xmlns:a16="http://schemas.microsoft.com/office/drawing/2014/main" id="{AEF3347B-6B32-CE45-3D7F-5FBECB14EBAD}"/>
               </a:ext>
             </a:extLst>
           </p:cNvPr>
@@ -6243,7 +6243,7 @@
           <p:cNvPr id="18" name="TextBox 17">
             <a:extLst>
               <a:ext uri="{FF2B5EF4-FFF2-40B4-BE49-F238E27FC236}">
-                <a16:creationId xmlns:a16="http://schemas.microsoft.com/office/drawing/2014/main" id="{3DB5655C-438D-03DA-9BFD-7A5128797758}"/>
+                <a16:creationId xmlns:a16="http://schemas.microsoft.com/office/drawing/2014/main" id="{02415FE3-F3E4-252D-CC5B-83208CF87376}"/>
               </a:ext>
             </a:extLst>
           </p:cNvPr>
@@ -6283,7 +6283,7 @@
           <p:cNvPr id="19" name="TextBox 18">
             <a:extLst>
               <a:ext uri="{FF2B5EF4-FFF2-40B4-BE49-F238E27FC236}">
-                <a16:creationId xmlns:a16="http://schemas.microsoft.com/office/drawing/2014/main" id="{1622B067-C20E-14BD-FCC0-50F83419C83F}"/>
+                <a16:creationId xmlns:a16="http://schemas.microsoft.com/office/drawing/2014/main" id="{3320BEAD-80C5-04E4-0B5D-2F651930DE72}"/>
               </a:ext>
             </a:extLst>
           </p:cNvPr>
@@ -6309,7 +6309,7 @@
             <a:r>
               <a:rPr lang="en-US" sz="1900" b="1">
                 <a:solidFill>
-                  <a:srgbClr val="3FC6AC"/>
+                  <a:srgbClr val="007565"/>
                 </a:solidFill>
                 <a:latin typeface="Aptos" panose="020B0004020202020204" pitchFamily="34" charset="0"/>
               </a:rPr>
@@ -6323,7 +6323,7 @@
           <p:cNvPr id="20" name="TextBox 19">
             <a:extLst>
               <a:ext uri="{FF2B5EF4-FFF2-40B4-BE49-F238E27FC236}">
-                <a16:creationId xmlns:a16="http://schemas.microsoft.com/office/drawing/2014/main" id="{F34D1051-8EEC-DA5D-0DDD-E8699D3DFD24}"/>
+                <a16:creationId xmlns:a16="http://schemas.microsoft.com/office/drawing/2014/main" id="{03525CE1-7747-ABE0-80FB-CFAE00B39028}"/>
               </a:ext>
             </a:extLst>
           </p:cNvPr>
@@ -6363,7 +6363,7 @@
           <p:cNvPr id="21" name="TextBox 20">
             <a:extLst>
               <a:ext uri="{FF2B5EF4-FFF2-40B4-BE49-F238E27FC236}">
-                <a16:creationId xmlns:a16="http://schemas.microsoft.com/office/drawing/2014/main" id="{B4818ABE-CB16-9609-D128-1A52C593856B}"/>
+                <a16:creationId xmlns:a16="http://schemas.microsoft.com/office/drawing/2014/main" id="{330C0211-C538-EA14-5B46-0E96BE4929F7}"/>
               </a:ext>
             </a:extLst>
           </p:cNvPr>
@@ -6403,7 +6403,7 @@
           <p:cNvPr id="22" name="TextBox 21">
             <a:extLst>
               <a:ext uri="{FF2B5EF4-FFF2-40B4-BE49-F238E27FC236}">
-                <a16:creationId xmlns:a16="http://schemas.microsoft.com/office/drawing/2014/main" id="{00254107-8537-9631-E641-4FB062B0A99A}"/>
+                <a16:creationId xmlns:a16="http://schemas.microsoft.com/office/drawing/2014/main" id="{2E4DFF17-9CAB-43DE-0EC2-54377192384E}"/>
               </a:ext>
             </a:extLst>
           </p:cNvPr>
@@ -6429,7 +6429,7 @@
             <a:r>
               <a:rPr lang="en-US" sz="1900" b="1">
                 <a:solidFill>
-                  <a:srgbClr val="3FC6AC"/>
+                  <a:srgbClr val="007565"/>
                 </a:solidFill>
                 <a:latin typeface="Aptos" panose="020B0004020202020204" pitchFamily="34" charset="0"/>
               </a:rPr>
@@ -6443,7 +6443,7 @@
           <p:cNvPr id="23" name="TextBox 22">
             <a:extLst>
               <a:ext uri="{FF2B5EF4-FFF2-40B4-BE49-F238E27FC236}">
-                <a16:creationId xmlns:a16="http://schemas.microsoft.com/office/drawing/2014/main" id="{8B5026E0-E3DE-E8FF-9A11-927C9C2B0F39}"/>
+                <a16:creationId xmlns:a16="http://schemas.microsoft.com/office/drawing/2014/main" id="{80D0A9D6-B49E-F98F-0340-91B664382A2B}"/>
               </a:ext>
             </a:extLst>
           </p:cNvPr>
@@ -6483,7 +6483,7 @@
           <p:cNvPr id="24" name="Rectangle: Rounded Corners 23">
             <a:extLst>
               <a:ext uri="{FF2B5EF4-FFF2-40B4-BE49-F238E27FC236}">
-                <a16:creationId xmlns:a16="http://schemas.microsoft.com/office/drawing/2014/main" id="{49236400-1D78-0503-387B-75668A497918}"/>
+                <a16:creationId xmlns:a16="http://schemas.microsoft.com/office/drawing/2014/main" id="{15551125-7924-DC1C-85E9-1C0882EC1294}"/>
               </a:ext>
             </a:extLst>
           </p:cNvPr>
@@ -6537,7 +6537,7 @@
           <p:cNvPr id="25" name="TextBox 24">
             <a:extLst>
               <a:ext uri="{FF2B5EF4-FFF2-40B4-BE49-F238E27FC236}">
-                <a16:creationId xmlns:a16="http://schemas.microsoft.com/office/drawing/2014/main" id="{B2E61CDD-3987-C382-33F4-36C49B7424A8}"/>
+                <a16:creationId xmlns:a16="http://schemas.microsoft.com/office/drawing/2014/main" id="{03493CB0-2784-597B-92DC-4E9D0F9E9D78}"/>
               </a:ext>
             </a:extLst>
           </p:cNvPr>
@@ -6578,7 +6578,7 @@
           <p:cNvPr id="26" name="TextBox 25">
             <a:extLst>
               <a:ext uri="{FF2B5EF4-FFF2-40B4-BE49-F238E27FC236}">
-                <a16:creationId xmlns:a16="http://schemas.microsoft.com/office/drawing/2014/main" id="{E862E84A-E80D-79A5-4DA1-4B6EBECB239F}"/>
+                <a16:creationId xmlns:a16="http://schemas.microsoft.com/office/drawing/2014/main" id="{EA7E8329-B8CF-1D69-D590-FA7A7FEF610B}"/>
               </a:ext>
             </a:extLst>
           </p:cNvPr>
@@ -6617,7 +6617,7 @@
     </p:spTree>
     <p:extLst>
       <p:ext uri="{BB962C8B-B14F-4D97-AF65-F5344CB8AC3E}">
-        <p14:creationId xmlns:p14="http://schemas.microsoft.com/office/powerpoint/2010/main" val="194649266"/>
+        <p14:creationId xmlns:p14="http://schemas.microsoft.com/office/powerpoint/2010/main" val="3035100465"/>
       </p:ext>
     </p:extLst>
   </p:cSld>
@@ -6657,7 +6657,7 @@
           <p:cNvPr id="2" name="TextBox 1">
             <a:extLst>
               <a:ext uri="{FF2B5EF4-FFF2-40B4-BE49-F238E27FC236}">
-                <a16:creationId xmlns:a16="http://schemas.microsoft.com/office/drawing/2014/main" id="{F76C1CB9-A9E9-5F33-DAE4-A89EB7CDCEDA}"/>
+                <a16:creationId xmlns:a16="http://schemas.microsoft.com/office/drawing/2014/main" id="{44134386-2372-C965-E68F-7E4957050FFC}"/>
               </a:ext>
             </a:extLst>
           </p:cNvPr>
@@ -6697,7 +6697,7 @@
           <p:cNvPr id="3" name="Straight Connector 2">
             <a:extLst>
               <a:ext uri="{FF2B5EF4-FFF2-40B4-BE49-F238E27FC236}">
-                <a16:creationId xmlns:a16="http://schemas.microsoft.com/office/drawing/2014/main" id="{EACF27E4-82A8-130F-1D99-BDEB3F13F107}"/>
+                <a16:creationId xmlns:a16="http://schemas.microsoft.com/office/drawing/2014/main" id="{899830B2-A2A5-9222-8097-FE31AE7FAADE}"/>
               </a:ext>
             </a:extLst>
           </p:cNvPr>
@@ -6738,7 +6738,7 @@
           <p:cNvPr id="4" name="TextBox 3">
             <a:extLst>
               <a:ext uri="{FF2B5EF4-FFF2-40B4-BE49-F238E27FC236}">
-                <a16:creationId xmlns:a16="http://schemas.microsoft.com/office/drawing/2014/main" id="{809BC5DE-E82C-8B4B-C611-9A88C9047691}"/>
+                <a16:creationId xmlns:a16="http://schemas.microsoft.com/office/drawing/2014/main" id="{FD1D353F-4594-FC77-1FDA-3A444F8C89F0}"/>
               </a:ext>
             </a:extLst>
           </p:cNvPr>
@@ -6779,7 +6779,7 @@
           <p:cNvPr id="5" name="TextBox 4">
             <a:extLst>
               <a:ext uri="{FF2B5EF4-FFF2-40B4-BE49-F238E27FC236}">
-                <a16:creationId xmlns:a16="http://schemas.microsoft.com/office/drawing/2014/main" id="{FBA7D9DA-8541-8993-7890-B15AC97C0452}"/>
+                <a16:creationId xmlns:a16="http://schemas.microsoft.com/office/drawing/2014/main" id="{F157511F-C59B-2386-5907-CFE63488774C}"/>
               </a:ext>
             </a:extLst>
           </p:cNvPr>
@@ -6819,7 +6819,7 @@
           <p:cNvPr id="6" name="TextBox 5">
             <a:extLst>
               <a:ext uri="{FF2B5EF4-FFF2-40B4-BE49-F238E27FC236}">
-                <a16:creationId xmlns:a16="http://schemas.microsoft.com/office/drawing/2014/main" id="{84FCE880-5759-9A47-E3EE-DDCED6F8E72F}"/>
+                <a16:creationId xmlns:a16="http://schemas.microsoft.com/office/drawing/2014/main" id="{039ED97C-BF6E-FCB4-0BFA-09B9C0CF581C}"/>
               </a:ext>
             </a:extLst>
           </p:cNvPr>
@@ -6859,7 +6859,7 @@
           <p:cNvPr id="7" name="TextBox 6">
             <a:extLst>
               <a:ext uri="{FF2B5EF4-FFF2-40B4-BE49-F238E27FC236}">
-                <a16:creationId xmlns:a16="http://schemas.microsoft.com/office/drawing/2014/main" id="{4B824F69-16CE-3048-74A0-3645F90C9E7D}"/>
+                <a16:creationId xmlns:a16="http://schemas.microsoft.com/office/drawing/2014/main" id="{C0B2CDD6-5086-7A8C-A95A-25EA5CEAD3B2}"/>
               </a:ext>
             </a:extLst>
           </p:cNvPr>
@@ -6899,7 +6899,7 @@
           <p:cNvPr id="8" name="Straight Connector 7">
             <a:extLst>
               <a:ext uri="{FF2B5EF4-FFF2-40B4-BE49-F238E27FC236}">
-                <a16:creationId xmlns:a16="http://schemas.microsoft.com/office/drawing/2014/main" id="{84C35914-CD40-68E0-5739-B41CFE0947FE}"/>
+                <a16:creationId xmlns:a16="http://schemas.microsoft.com/office/drawing/2014/main" id="{F36B86B7-65C7-0CFC-C3F7-95FFBD32E75C}"/>
               </a:ext>
             </a:extLst>
           </p:cNvPr>
@@ -6940,7 +6940,7 @@
           <p:cNvPr id="9" name="TextBox 8">
             <a:extLst>
               <a:ext uri="{FF2B5EF4-FFF2-40B4-BE49-F238E27FC236}">
-                <a16:creationId xmlns:a16="http://schemas.microsoft.com/office/drawing/2014/main" id="{1D7ACA7B-3B37-7ACF-5C5B-CB1DD534B5F0}"/>
+                <a16:creationId xmlns:a16="http://schemas.microsoft.com/office/drawing/2014/main" id="{2FEB0232-8595-5DFC-3570-04DFFA4A767A}"/>
               </a:ext>
             </a:extLst>
           </p:cNvPr>
@@ -6980,7 +6980,7 @@
           <p:cNvPr id="10" name="Straight Connector 9">
             <a:extLst>
               <a:ext uri="{FF2B5EF4-FFF2-40B4-BE49-F238E27FC236}">
-                <a16:creationId xmlns:a16="http://schemas.microsoft.com/office/drawing/2014/main" id="{B05DA21C-F35B-A9D3-59A4-9F3419F33B1C}"/>
+                <a16:creationId xmlns:a16="http://schemas.microsoft.com/office/drawing/2014/main" id="{9F974885-0B4C-C311-4886-AA8D95CF308F}"/>
               </a:ext>
             </a:extLst>
           </p:cNvPr>
@@ -7021,7 +7021,7 @@
           <p:cNvPr id="11" name="TextBox 10">
             <a:extLst>
               <a:ext uri="{FF2B5EF4-FFF2-40B4-BE49-F238E27FC236}">
-                <a16:creationId xmlns:a16="http://schemas.microsoft.com/office/drawing/2014/main" id="{F3CDF3E4-E78A-3526-9B47-AA5ECE896934}"/>
+                <a16:creationId xmlns:a16="http://schemas.microsoft.com/office/drawing/2014/main" id="{39B4A523-D9FB-9FEA-43C8-B8C58938F261}"/>
               </a:ext>
             </a:extLst>
           </p:cNvPr>
@@ -7061,7 +7061,7 @@
           <p:cNvPr id="12" name="Straight Connector 11">
             <a:extLst>
               <a:ext uri="{FF2B5EF4-FFF2-40B4-BE49-F238E27FC236}">
-                <a16:creationId xmlns:a16="http://schemas.microsoft.com/office/drawing/2014/main" id="{18118873-EA80-2FCF-713D-FAD60983FACC}"/>
+                <a16:creationId xmlns:a16="http://schemas.microsoft.com/office/drawing/2014/main" id="{66BEC8A9-7E5A-DC0B-AB9F-693A6E4DF34B}"/>
               </a:ext>
             </a:extLst>
           </p:cNvPr>
@@ -7102,7 +7102,7 @@
           <p:cNvPr id="13" name="TextBox 12">
             <a:extLst>
               <a:ext uri="{FF2B5EF4-FFF2-40B4-BE49-F238E27FC236}">
-                <a16:creationId xmlns:a16="http://schemas.microsoft.com/office/drawing/2014/main" id="{7E3E1529-8C28-967A-A63C-59BAB718AE40}"/>
+                <a16:creationId xmlns:a16="http://schemas.microsoft.com/office/drawing/2014/main" id="{95DBFF1A-ACE7-6DA5-2206-344A7BFD81C0}"/>
               </a:ext>
             </a:extLst>
           </p:cNvPr>
@@ -7142,7 +7142,7 @@
           <p:cNvPr id="14" name="Straight Connector 13">
             <a:extLst>
               <a:ext uri="{FF2B5EF4-FFF2-40B4-BE49-F238E27FC236}">
-                <a16:creationId xmlns:a16="http://schemas.microsoft.com/office/drawing/2014/main" id="{4C42B642-5D5A-7498-E614-876BFFDA22A9}"/>
+                <a16:creationId xmlns:a16="http://schemas.microsoft.com/office/drawing/2014/main" id="{9E427EB3-951C-C0E2-BB1F-2B381A6B9BB9}"/>
               </a:ext>
             </a:extLst>
           </p:cNvPr>
@@ -7183,7 +7183,7 @@
           <p:cNvPr id="15" name="TextBox 14">
             <a:extLst>
               <a:ext uri="{FF2B5EF4-FFF2-40B4-BE49-F238E27FC236}">
-                <a16:creationId xmlns:a16="http://schemas.microsoft.com/office/drawing/2014/main" id="{78F4E538-F990-2C88-B185-6B770162DB3D}"/>
+                <a16:creationId xmlns:a16="http://schemas.microsoft.com/office/drawing/2014/main" id="{17FEA002-B4B1-AB5C-5E8D-0637FF8E376B}"/>
               </a:ext>
             </a:extLst>
           </p:cNvPr>
@@ -7223,7 +7223,7 @@
           <p:cNvPr id="16" name="Straight Connector 15">
             <a:extLst>
               <a:ext uri="{FF2B5EF4-FFF2-40B4-BE49-F238E27FC236}">
-                <a16:creationId xmlns:a16="http://schemas.microsoft.com/office/drawing/2014/main" id="{33FB5465-F52A-25E8-0FB6-BE9798E8ED64}"/>
+                <a16:creationId xmlns:a16="http://schemas.microsoft.com/office/drawing/2014/main" id="{C68C609C-F8F5-0073-FBEA-9EA599981993}"/>
               </a:ext>
             </a:extLst>
           </p:cNvPr>
@@ -7264,7 +7264,7 @@
           <p:cNvPr id="17" name="TextBox 16">
             <a:extLst>
               <a:ext uri="{FF2B5EF4-FFF2-40B4-BE49-F238E27FC236}">
-                <a16:creationId xmlns:a16="http://schemas.microsoft.com/office/drawing/2014/main" id="{58FAF87D-496D-AC0C-5A3A-95523C1A5F50}"/>
+                <a16:creationId xmlns:a16="http://schemas.microsoft.com/office/drawing/2014/main" id="{3DD9E258-1168-9F6C-1D04-390E10A3E568}"/>
               </a:ext>
             </a:extLst>
           </p:cNvPr>
@@ -7304,7 +7304,7 @@
           <p:cNvPr id="18" name="TextBox 17">
             <a:extLst>
               <a:ext uri="{FF2B5EF4-FFF2-40B4-BE49-F238E27FC236}">
-                <a16:creationId xmlns:a16="http://schemas.microsoft.com/office/drawing/2014/main" id="{C12A7AE0-9AC0-DD04-8C9F-1BBC4FFE4698}"/>
+                <a16:creationId xmlns:a16="http://schemas.microsoft.com/office/drawing/2014/main" id="{88EA3A41-32E0-761F-5D33-DEEB634B5ECE}"/>
               </a:ext>
             </a:extLst>
           </p:cNvPr>
@@ -7344,7 +7344,7 @@
           <p:cNvPr id="19" name="TextBox 18">
             <a:extLst>
               <a:ext uri="{FF2B5EF4-FFF2-40B4-BE49-F238E27FC236}">
-                <a16:creationId xmlns:a16="http://schemas.microsoft.com/office/drawing/2014/main" id="{BC05CD52-7EAC-04C4-7686-EA3B351DF16C}"/>
+                <a16:creationId xmlns:a16="http://schemas.microsoft.com/office/drawing/2014/main" id="{569AE538-EBD7-1FAB-2548-ED1F7EF2C609}"/>
               </a:ext>
             </a:extLst>
           </p:cNvPr>
@@ -7384,7 +7384,7 @@
           <p:cNvPr id="20" name="TextBox 19">
             <a:extLst>
               <a:ext uri="{FF2B5EF4-FFF2-40B4-BE49-F238E27FC236}">
-                <a16:creationId xmlns:a16="http://schemas.microsoft.com/office/drawing/2014/main" id="{69C6E351-3C65-D2C4-5BCC-84E8630D9D20}"/>
+                <a16:creationId xmlns:a16="http://schemas.microsoft.com/office/drawing/2014/main" id="{E74DA0CF-8B8A-4D37-0D03-BA9F03C021FC}"/>
               </a:ext>
             </a:extLst>
           </p:cNvPr>
@@ -7424,7 +7424,7 @@
           <p:cNvPr id="21" name="TextBox 20">
             <a:extLst>
               <a:ext uri="{FF2B5EF4-FFF2-40B4-BE49-F238E27FC236}">
-                <a16:creationId xmlns:a16="http://schemas.microsoft.com/office/drawing/2014/main" id="{90DA06C1-D3CD-3147-B8B6-CF6730072F59}"/>
+                <a16:creationId xmlns:a16="http://schemas.microsoft.com/office/drawing/2014/main" id="{5E059BA7-AB6E-3AA6-4232-3BA6135B082E}"/>
               </a:ext>
             </a:extLst>
           </p:cNvPr>
@@ -7464,7 +7464,7 @@
           <p:cNvPr id="22" name="TextBox 21">
             <a:extLst>
               <a:ext uri="{FF2B5EF4-FFF2-40B4-BE49-F238E27FC236}">
-                <a16:creationId xmlns:a16="http://schemas.microsoft.com/office/drawing/2014/main" id="{DD1DD129-E3F4-70F3-BE72-30F34D183F95}"/>
+                <a16:creationId xmlns:a16="http://schemas.microsoft.com/office/drawing/2014/main" id="{5D9E1761-AB2F-53F8-4179-A45D5698B939}"/>
               </a:ext>
             </a:extLst>
           </p:cNvPr>
@@ -7504,7 +7504,7 @@
           <p:cNvPr id="23" name="TextBox 22">
             <a:extLst>
               <a:ext uri="{FF2B5EF4-FFF2-40B4-BE49-F238E27FC236}">
-                <a16:creationId xmlns:a16="http://schemas.microsoft.com/office/drawing/2014/main" id="{26C4B9F0-0975-F921-197B-3B63AE5F7CFF}"/>
+                <a16:creationId xmlns:a16="http://schemas.microsoft.com/office/drawing/2014/main" id="{C3A0AEC2-6CFD-46E9-EDF1-910969CCF32C}"/>
               </a:ext>
             </a:extLst>
           </p:cNvPr>
@@ -7544,7 +7544,7 @@
           <p:cNvPr id="24" name="Rectangle: Rounded Corners 23">
             <a:extLst>
               <a:ext uri="{FF2B5EF4-FFF2-40B4-BE49-F238E27FC236}">
-                <a16:creationId xmlns:a16="http://schemas.microsoft.com/office/drawing/2014/main" id="{E334B283-39B8-A86A-935A-BE24E48BB99C}"/>
+                <a16:creationId xmlns:a16="http://schemas.microsoft.com/office/drawing/2014/main" id="{6983E8B6-0B47-F93A-E028-F429A0D87E1B}"/>
               </a:ext>
             </a:extLst>
           </p:cNvPr>
@@ -7598,7 +7598,7 @@
           <p:cNvPr id="25" name="TextBox 24">
             <a:extLst>
               <a:ext uri="{FF2B5EF4-FFF2-40B4-BE49-F238E27FC236}">
-                <a16:creationId xmlns:a16="http://schemas.microsoft.com/office/drawing/2014/main" id="{3ACFBCCC-006B-C329-58A3-AC591C67DFAC}"/>
+                <a16:creationId xmlns:a16="http://schemas.microsoft.com/office/drawing/2014/main" id="{9AD39D35-D945-8525-5260-D99995C7E76E}"/>
               </a:ext>
             </a:extLst>
           </p:cNvPr>
@@ -7649,7 +7649,7 @@
     </p:spTree>
     <p:extLst>
       <p:ext uri="{BB962C8B-B14F-4D97-AF65-F5344CB8AC3E}">
-        <p14:creationId xmlns:p14="http://schemas.microsoft.com/office/powerpoint/2010/main" val="2389296558"/>
+        <p14:creationId xmlns:p14="http://schemas.microsoft.com/office/powerpoint/2010/main" val="4274129029"/>
       </p:ext>
     </p:extLst>
   </p:cSld>
@@ -7689,7 +7689,7 @@
           <p:cNvPr id="2" name="TextBox 1">
             <a:extLst>
               <a:ext uri="{FF2B5EF4-FFF2-40B4-BE49-F238E27FC236}">
-                <a16:creationId xmlns:a16="http://schemas.microsoft.com/office/drawing/2014/main" id="{A62C3A73-15B5-397C-E904-9AF211DCF53F}"/>
+                <a16:creationId xmlns:a16="http://schemas.microsoft.com/office/drawing/2014/main" id="{94A74814-843E-A652-EEE4-AEE3D01757B6}"/>
               </a:ext>
             </a:extLst>
           </p:cNvPr>
@@ -7729,7 +7729,7 @@
           <p:cNvPr id="3" name="Straight Connector 2">
             <a:extLst>
               <a:ext uri="{FF2B5EF4-FFF2-40B4-BE49-F238E27FC236}">
-                <a16:creationId xmlns:a16="http://schemas.microsoft.com/office/drawing/2014/main" id="{E2DA63CE-D5F1-4DD1-B836-6F55980C1DE3}"/>
+                <a16:creationId xmlns:a16="http://schemas.microsoft.com/office/drawing/2014/main" id="{736C9366-30E8-A69E-9455-885D903DE50E}"/>
               </a:ext>
             </a:extLst>
           </p:cNvPr>
@@ -7770,7 +7770,7 @@
           <p:cNvPr id="4" name="TextBox 3">
             <a:extLst>
               <a:ext uri="{FF2B5EF4-FFF2-40B4-BE49-F238E27FC236}">
-                <a16:creationId xmlns:a16="http://schemas.microsoft.com/office/drawing/2014/main" id="{1F04156C-F5E3-5C8A-651A-B011F1FA48FB}"/>
+                <a16:creationId xmlns:a16="http://schemas.microsoft.com/office/drawing/2014/main" id="{857440EA-49EB-7329-E2AD-BD5A60477917}"/>
               </a:ext>
             </a:extLst>
           </p:cNvPr>
@@ -7811,7 +7811,7 @@
           <p:cNvPr id="5" name="TextBox 4">
             <a:extLst>
               <a:ext uri="{FF2B5EF4-FFF2-40B4-BE49-F238E27FC236}">
-                <a16:creationId xmlns:a16="http://schemas.microsoft.com/office/drawing/2014/main" id="{A9744680-5ECB-B5DE-397D-4148250917AD}"/>
+                <a16:creationId xmlns:a16="http://schemas.microsoft.com/office/drawing/2014/main" id="{C32FF7BF-1955-740D-9F14-556719F4E1A5}"/>
               </a:ext>
             </a:extLst>
           </p:cNvPr>
@@ -7851,7 +7851,7 @@
           <p:cNvPr id="6" name="TextBox 5">
             <a:extLst>
               <a:ext uri="{FF2B5EF4-FFF2-40B4-BE49-F238E27FC236}">
-                <a16:creationId xmlns:a16="http://schemas.microsoft.com/office/drawing/2014/main" id="{88CFBDE2-FADA-38AA-67F8-9FB527C1A1F8}"/>
+                <a16:creationId xmlns:a16="http://schemas.microsoft.com/office/drawing/2014/main" id="{568707D9-8F4A-E1C5-9284-0A2721D0CAB8}"/>
               </a:ext>
             </a:extLst>
           </p:cNvPr>
@@ -7891,7 +7891,7 @@
           <p:cNvPr id="7" name="TextBox 6">
             <a:extLst>
               <a:ext uri="{FF2B5EF4-FFF2-40B4-BE49-F238E27FC236}">
-                <a16:creationId xmlns:a16="http://schemas.microsoft.com/office/drawing/2014/main" id="{3348B76B-70B8-F3F6-76D0-07244A466CDE}"/>
+                <a16:creationId xmlns:a16="http://schemas.microsoft.com/office/drawing/2014/main" id="{87DAFEBC-D201-CA99-F477-147E11DE7799}"/>
               </a:ext>
             </a:extLst>
           </p:cNvPr>
@@ -7917,7 +7917,7 @@
             <a:r>
               <a:rPr lang="en-US" sz="2300" b="1">
                 <a:solidFill>
-                  <a:srgbClr val="3FC6AC"/>
+                  <a:srgbClr val="007565"/>
                 </a:solidFill>
                 <a:latin typeface="Aptos" panose="020B0004020202020204" pitchFamily="34" charset="0"/>
               </a:rPr>
@@ -7931,7 +7931,7 @@
           <p:cNvPr id="8" name="Straight Connector 7">
             <a:extLst>
               <a:ext uri="{FF2B5EF4-FFF2-40B4-BE49-F238E27FC236}">
-                <a16:creationId xmlns:a16="http://schemas.microsoft.com/office/drawing/2014/main" id="{79C46A39-2580-6F13-AF38-6FA1FAB78B6F}"/>
+                <a16:creationId xmlns:a16="http://schemas.microsoft.com/office/drawing/2014/main" id="{82D7B83C-2954-1DC6-46AD-51B3E51CA74B}"/>
               </a:ext>
             </a:extLst>
           </p:cNvPr>
@@ -7972,7 +7972,7 @@
           <p:cNvPr id="9" name="TextBox 8">
             <a:extLst>
               <a:ext uri="{FF2B5EF4-FFF2-40B4-BE49-F238E27FC236}">
-                <a16:creationId xmlns:a16="http://schemas.microsoft.com/office/drawing/2014/main" id="{44924322-EAB0-03A2-A2C4-72B416E23C57}"/>
+                <a16:creationId xmlns:a16="http://schemas.microsoft.com/office/drawing/2014/main" id="{A3507154-369A-69AF-43B9-0FEF2ADFD8F1}"/>
               </a:ext>
             </a:extLst>
           </p:cNvPr>
@@ -8012,7 +8012,7 @@
           <p:cNvPr id="10" name="Straight Connector 9">
             <a:extLst>
               <a:ext uri="{FF2B5EF4-FFF2-40B4-BE49-F238E27FC236}">
-                <a16:creationId xmlns:a16="http://schemas.microsoft.com/office/drawing/2014/main" id="{45CE9F5A-C542-8C89-6855-D48A803D2D5F}"/>
+                <a16:creationId xmlns:a16="http://schemas.microsoft.com/office/drawing/2014/main" id="{7C75A60A-D316-DF4F-7DF4-CFF9A5BA2987}"/>
               </a:ext>
             </a:extLst>
           </p:cNvPr>
@@ -8053,7 +8053,7 @@
           <p:cNvPr id="11" name="TextBox 10">
             <a:extLst>
               <a:ext uri="{FF2B5EF4-FFF2-40B4-BE49-F238E27FC236}">
-                <a16:creationId xmlns:a16="http://schemas.microsoft.com/office/drawing/2014/main" id="{EE9A8755-19DD-F67D-26DF-65483907A161}"/>
+                <a16:creationId xmlns:a16="http://schemas.microsoft.com/office/drawing/2014/main" id="{8AA39579-A1C1-0C0D-4257-9B8736849039}"/>
               </a:ext>
             </a:extLst>
           </p:cNvPr>
@@ -8093,7 +8093,7 @@
           <p:cNvPr id="12" name="Straight Connector 11">
             <a:extLst>
               <a:ext uri="{FF2B5EF4-FFF2-40B4-BE49-F238E27FC236}">
-                <a16:creationId xmlns:a16="http://schemas.microsoft.com/office/drawing/2014/main" id="{5FBF8FD0-74D9-52EB-C545-68F8C65BBFDB}"/>
+                <a16:creationId xmlns:a16="http://schemas.microsoft.com/office/drawing/2014/main" id="{78787B34-4DF5-43B9-3B5B-C87C75007458}"/>
               </a:ext>
             </a:extLst>
           </p:cNvPr>
@@ -8134,7 +8134,7 @@
           <p:cNvPr id="13" name="TextBox 12">
             <a:extLst>
               <a:ext uri="{FF2B5EF4-FFF2-40B4-BE49-F238E27FC236}">
-                <a16:creationId xmlns:a16="http://schemas.microsoft.com/office/drawing/2014/main" id="{8396FB6C-FECA-1D7F-8486-D0C438FB87B5}"/>
+                <a16:creationId xmlns:a16="http://schemas.microsoft.com/office/drawing/2014/main" id="{3AA1CF76-D233-1AD7-2370-CC91A8CAFA80}"/>
               </a:ext>
             </a:extLst>
           </p:cNvPr>
@@ -8174,7 +8174,7 @@
           <p:cNvPr id="14" name="Straight Connector 13">
             <a:extLst>
               <a:ext uri="{FF2B5EF4-FFF2-40B4-BE49-F238E27FC236}">
-                <a16:creationId xmlns:a16="http://schemas.microsoft.com/office/drawing/2014/main" id="{6FA800BE-32A3-D9E5-08A1-5858E51AE0DA}"/>
+                <a16:creationId xmlns:a16="http://schemas.microsoft.com/office/drawing/2014/main" id="{607D3933-847C-A4A8-4128-A860E97AF3FD}"/>
               </a:ext>
             </a:extLst>
           </p:cNvPr>
@@ -8215,7 +8215,7 @@
           <p:cNvPr id="15" name="TextBox 14">
             <a:extLst>
               <a:ext uri="{FF2B5EF4-FFF2-40B4-BE49-F238E27FC236}">
-                <a16:creationId xmlns:a16="http://schemas.microsoft.com/office/drawing/2014/main" id="{192DBA83-FEF9-166C-2467-32BDA9C18128}"/>
+                <a16:creationId xmlns:a16="http://schemas.microsoft.com/office/drawing/2014/main" id="{3E3DBECA-CF74-B848-57E8-C6179F463232}"/>
               </a:ext>
             </a:extLst>
           </p:cNvPr>
@@ -8255,7 +8255,7 @@
           <p:cNvPr id="16" name="TextBox 15">
             <a:extLst>
               <a:ext uri="{FF2B5EF4-FFF2-40B4-BE49-F238E27FC236}">
-                <a16:creationId xmlns:a16="http://schemas.microsoft.com/office/drawing/2014/main" id="{DC817537-DCD7-EE28-8A49-9C1CD62F8775}"/>
+                <a16:creationId xmlns:a16="http://schemas.microsoft.com/office/drawing/2014/main" id="{55DB0613-3EA9-A82C-3C27-D3EA082C335C}"/>
               </a:ext>
             </a:extLst>
           </p:cNvPr>
@@ -8295,7 +8295,7 @@
           <p:cNvPr id="17" name="Straight Connector 16">
             <a:extLst>
               <a:ext uri="{FF2B5EF4-FFF2-40B4-BE49-F238E27FC236}">
-                <a16:creationId xmlns:a16="http://schemas.microsoft.com/office/drawing/2014/main" id="{A578D69C-640F-7D4F-33C1-C01C12736051}"/>
+                <a16:creationId xmlns:a16="http://schemas.microsoft.com/office/drawing/2014/main" id="{2CD82ADD-704B-AF92-FBA3-F61DB07DA4E1}"/>
               </a:ext>
             </a:extLst>
           </p:cNvPr>
@@ -8336,7 +8336,7 @@
           <p:cNvPr id="18" name="TextBox 17">
             <a:extLst>
               <a:ext uri="{FF2B5EF4-FFF2-40B4-BE49-F238E27FC236}">
-                <a16:creationId xmlns:a16="http://schemas.microsoft.com/office/drawing/2014/main" id="{BC531FF7-8BD3-7629-E394-E72C0BB42D33}"/>
+                <a16:creationId xmlns:a16="http://schemas.microsoft.com/office/drawing/2014/main" id="{DE851C8F-4820-9305-0D26-5BC6241615B9}"/>
               </a:ext>
             </a:extLst>
           </p:cNvPr>
@@ -8376,7 +8376,7 @@
           <p:cNvPr id="19" name="Straight Connector 18">
             <a:extLst>
               <a:ext uri="{FF2B5EF4-FFF2-40B4-BE49-F238E27FC236}">
-                <a16:creationId xmlns:a16="http://schemas.microsoft.com/office/drawing/2014/main" id="{6BD1FDA4-8FB8-BBFD-C8E2-B022C5B861E1}"/>
+                <a16:creationId xmlns:a16="http://schemas.microsoft.com/office/drawing/2014/main" id="{4B469E89-7013-11CD-BBFE-2225942753E1}"/>
               </a:ext>
             </a:extLst>
           </p:cNvPr>
@@ -8417,7 +8417,7 @@
           <p:cNvPr id="20" name="TextBox 19">
             <a:extLst>
               <a:ext uri="{FF2B5EF4-FFF2-40B4-BE49-F238E27FC236}">
-                <a16:creationId xmlns:a16="http://schemas.microsoft.com/office/drawing/2014/main" id="{A4B0E372-914F-9EFC-8E9C-AEA263E8216C}"/>
+                <a16:creationId xmlns:a16="http://schemas.microsoft.com/office/drawing/2014/main" id="{499F5C05-DA95-7315-322A-B65978A628F5}"/>
               </a:ext>
             </a:extLst>
           </p:cNvPr>
@@ -8457,7 +8457,7 @@
           <p:cNvPr id="21" name="Straight Connector 20">
             <a:extLst>
               <a:ext uri="{FF2B5EF4-FFF2-40B4-BE49-F238E27FC236}">
-                <a16:creationId xmlns:a16="http://schemas.microsoft.com/office/drawing/2014/main" id="{C9A3598D-70C2-A1AC-98E1-28496B40CCF2}"/>
+                <a16:creationId xmlns:a16="http://schemas.microsoft.com/office/drawing/2014/main" id="{C944E060-0EEC-3DA1-C34D-5A35B28CDA11}"/>
               </a:ext>
             </a:extLst>
           </p:cNvPr>
@@ -8498,7 +8498,7 @@
           <p:cNvPr id="22" name="TextBox 21">
             <a:extLst>
               <a:ext uri="{FF2B5EF4-FFF2-40B4-BE49-F238E27FC236}">
-                <a16:creationId xmlns:a16="http://schemas.microsoft.com/office/drawing/2014/main" id="{FCC1CE9C-C665-AFF5-EF0A-E0617C8C1441}"/>
+                <a16:creationId xmlns:a16="http://schemas.microsoft.com/office/drawing/2014/main" id="{88795FB2-F1B9-7EA3-0EB7-FA1691C21DFF}"/>
               </a:ext>
             </a:extLst>
           </p:cNvPr>
@@ -8538,7 +8538,7 @@
           <p:cNvPr id="23" name="Straight Connector 22">
             <a:extLst>
               <a:ext uri="{FF2B5EF4-FFF2-40B4-BE49-F238E27FC236}">
-                <a16:creationId xmlns:a16="http://schemas.microsoft.com/office/drawing/2014/main" id="{98A8A804-6BAD-FFA8-40F9-AE1C2EADB2A0}"/>
+                <a16:creationId xmlns:a16="http://schemas.microsoft.com/office/drawing/2014/main" id="{7639A792-5CC0-2594-8E15-62A2092D391C}"/>
               </a:ext>
             </a:extLst>
           </p:cNvPr>
@@ -8579,7 +8579,7 @@
           <p:cNvPr id="24" name="TextBox 23">
             <a:extLst>
               <a:ext uri="{FF2B5EF4-FFF2-40B4-BE49-F238E27FC236}">
-                <a16:creationId xmlns:a16="http://schemas.microsoft.com/office/drawing/2014/main" id="{99538775-1318-811A-F5B0-533C2DD67BE9}"/>
+                <a16:creationId xmlns:a16="http://schemas.microsoft.com/office/drawing/2014/main" id="{A62EE5A2-A3A2-7548-DEDE-EA5E6EE72955}"/>
               </a:ext>
             </a:extLst>
           </p:cNvPr>
@@ -8619,7 +8619,7 @@
           <p:cNvPr id="25" name="Rectangle: Rounded Corners 24">
             <a:extLst>
               <a:ext uri="{FF2B5EF4-FFF2-40B4-BE49-F238E27FC236}">
-                <a16:creationId xmlns:a16="http://schemas.microsoft.com/office/drawing/2014/main" id="{982D240C-9B01-D8FD-4AA6-52FDF2F12038}"/>
+                <a16:creationId xmlns:a16="http://schemas.microsoft.com/office/drawing/2014/main" id="{65C24FEF-DA44-C13C-BB26-2406844E188F}"/>
               </a:ext>
             </a:extLst>
           </p:cNvPr>
@@ -8673,7 +8673,7 @@
           <p:cNvPr id="26" name="TextBox 25">
             <a:extLst>
               <a:ext uri="{FF2B5EF4-FFF2-40B4-BE49-F238E27FC236}">
-                <a16:creationId xmlns:a16="http://schemas.microsoft.com/office/drawing/2014/main" id="{F3C50601-D945-8A5A-633F-6C8DD025D692}"/>
+                <a16:creationId xmlns:a16="http://schemas.microsoft.com/office/drawing/2014/main" id="{F60E65FB-DACA-AE4B-D74B-B75AC6BAE866}"/>
               </a:ext>
             </a:extLst>
           </p:cNvPr>
@@ -8712,7 +8712,7 @@
     </p:spTree>
     <p:extLst>
       <p:ext uri="{BB962C8B-B14F-4D97-AF65-F5344CB8AC3E}">
-        <p14:creationId xmlns:p14="http://schemas.microsoft.com/office/powerpoint/2010/main" val="2963014385"/>
+        <p14:creationId xmlns:p14="http://schemas.microsoft.com/office/powerpoint/2010/main" val="378204200"/>
       </p:ext>
     </p:extLst>
   </p:cSld>
@@ -8752,7 +8752,7 @@
           <p:cNvPr id="2" name="TextBox 1">
             <a:extLst>
               <a:ext uri="{FF2B5EF4-FFF2-40B4-BE49-F238E27FC236}">
-                <a16:creationId xmlns:a16="http://schemas.microsoft.com/office/drawing/2014/main" id="{C33CE7DC-0D3B-E8F5-D1FA-BC956E2B37A2}"/>
+                <a16:creationId xmlns:a16="http://schemas.microsoft.com/office/drawing/2014/main" id="{A4B7BD22-FD4A-F1FC-E556-590C357048D2}"/>
               </a:ext>
             </a:extLst>
           </p:cNvPr>
@@ -8792,7 +8792,7 @@
           <p:cNvPr id="3" name="Straight Connector 2">
             <a:extLst>
               <a:ext uri="{FF2B5EF4-FFF2-40B4-BE49-F238E27FC236}">
-                <a16:creationId xmlns:a16="http://schemas.microsoft.com/office/drawing/2014/main" id="{23D6C21E-A7F3-BA23-9C3C-06A406DBC670}"/>
+                <a16:creationId xmlns:a16="http://schemas.microsoft.com/office/drawing/2014/main" id="{D4446C2C-D2C0-67E9-F718-EC32A239B0DB}"/>
               </a:ext>
             </a:extLst>
           </p:cNvPr>
@@ -8833,7 +8833,7 @@
           <p:cNvPr id="4" name="TextBox 3">
             <a:extLst>
               <a:ext uri="{FF2B5EF4-FFF2-40B4-BE49-F238E27FC236}">
-                <a16:creationId xmlns:a16="http://schemas.microsoft.com/office/drawing/2014/main" id="{D42B902C-5DCF-6D8E-C14A-3C82E1AA15CC}"/>
+                <a16:creationId xmlns:a16="http://schemas.microsoft.com/office/drawing/2014/main" id="{4EC3FA65-BDD9-A716-4943-1A0F8CE2B434}"/>
               </a:ext>
             </a:extLst>
           </p:cNvPr>
@@ -8874,7 +8874,7 @@
           <p:cNvPr id="5" name="TextBox 4">
             <a:extLst>
               <a:ext uri="{FF2B5EF4-FFF2-40B4-BE49-F238E27FC236}">
-                <a16:creationId xmlns:a16="http://schemas.microsoft.com/office/drawing/2014/main" id="{D0A48713-592A-1122-D23B-FBAAAF052FC8}"/>
+                <a16:creationId xmlns:a16="http://schemas.microsoft.com/office/drawing/2014/main" id="{B4FCBDF3-986F-7CA3-E364-FEB33D7FEDD0}"/>
               </a:ext>
             </a:extLst>
           </p:cNvPr>
@@ -8914,7 +8914,7 @@
           <p:cNvPr id="6" name="TextBox 5">
             <a:extLst>
               <a:ext uri="{FF2B5EF4-FFF2-40B4-BE49-F238E27FC236}">
-                <a16:creationId xmlns:a16="http://schemas.microsoft.com/office/drawing/2014/main" id="{7994539B-883B-0645-37C8-87087D586C96}"/>
+                <a16:creationId xmlns:a16="http://schemas.microsoft.com/office/drawing/2014/main" id="{062568EC-1FC7-5C9C-36D4-974481F102C5}"/>
               </a:ext>
             </a:extLst>
           </p:cNvPr>
@@ -8954,7 +8954,7 @@
           <p:cNvPr id="7" name="TextBox 6">
             <a:extLst>
               <a:ext uri="{FF2B5EF4-FFF2-40B4-BE49-F238E27FC236}">
-                <a16:creationId xmlns:a16="http://schemas.microsoft.com/office/drawing/2014/main" id="{67F70209-BED1-F62D-22ED-618654419536}"/>
+                <a16:creationId xmlns:a16="http://schemas.microsoft.com/office/drawing/2014/main" id="{C87336A3-2814-B53E-1101-6047FDF837AB}"/>
               </a:ext>
             </a:extLst>
           </p:cNvPr>
@@ -8994,7 +8994,7 @@
           <p:cNvPr id="8" name="TextBox 7">
             <a:extLst>
               <a:ext uri="{FF2B5EF4-FFF2-40B4-BE49-F238E27FC236}">
-                <a16:creationId xmlns:a16="http://schemas.microsoft.com/office/drawing/2014/main" id="{B58187A2-E435-26D5-BDBF-C985C0D8342D}"/>
+                <a16:creationId xmlns:a16="http://schemas.microsoft.com/office/drawing/2014/main" id="{2F189602-7EA7-F21A-CB2E-B4A4BDD2D856}"/>
               </a:ext>
             </a:extLst>
           </p:cNvPr>
@@ -9034,7 +9034,7 @@
           <p:cNvPr id="9" name="Straight Connector 8">
             <a:extLst>
               <a:ext uri="{FF2B5EF4-FFF2-40B4-BE49-F238E27FC236}">
-                <a16:creationId xmlns:a16="http://schemas.microsoft.com/office/drawing/2014/main" id="{3BD2ED7E-12E5-8A01-AE0E-F8C857663054}"/>
+                <a16:creationId xmlns:a16="http://schemas.microsoft.com/office/drawing/2014/main" id="{D0AEC76E-7042-9460-45CF-9DBDBD7A9CEC}"/>
               </a:ext>
             </a:extLst>
           </p:cNvPr>
@@ -9075,7 +9075,7 @@
           <p:cNvPr id="10" name="Straight Connector 9">
             <a:extLst>
               <a:ext uri="{FF2B5EF4-FFF2-40B4-BE49-F238E27FC236}">
-                <a16:creationId xmlns:a16="http://schemas.microsoft.com/office/drawing/2014/main" id="{0BBF8E1E-8A22-BCEC-86FE-D5B2594E055B}"/>
+                <a16:creationId xmlns:a16="http://schemas.microsoft.com/office/drawing/2014/main" id="{FE368058-F87B-3CEB-CEE5-7E5F6C9974D4}"/>
               </a:ext>
             </a:extLst>
           </p:cNvPr>
@@ -9116,7 +9116,7 @@
           <p:cNvPr id="11" name="TextBox 10">
             <a:extLst>
               <a:ext uri="{FF2B5EF4-FFF2-40B4-BE49-F238E27FC236}">
-                <a16:creationId xmlns:a16="http://schemas.microsoft.com/office/drawing/2014/main" id="{AC2B059D-D36E-89B3-7A7F-4918BA53F35D}"/>
+                <a16:creationId xmlns:a16="http://schemas.microsoft.com/office/drawing/2014/main" id="{0F4814D6-3608-6A4A-E606-5E88912F9CE6}"/>
               </a:ext>
             </a:extLst>
           </p:cNvPr>
@@ -9156,7 +9156,7 @@
           <p:cNvPr id="12" name="Straight Connector 11">
             <a:extLst>
               <a:ext uri="{FF2B5EF4-FFF2-40B4-BE49-F238E27FC236}">
-                <a16:creationId xmlns:a16="http://schemas.microsoft.com/office/drawing/2014/main" id="{B72EDB58-CB38-8489-3128-679AE731B549}"/>
+                <a16:creationId xmlns:a16="http://schemas.microsoft.com/office/drawing/2014/main" id="{0CE1F82C-8A93-2629-ADFA-18C9C5F04341}"/>
               </a:ext>
             </a:extLst>
           </p:cNvPr>
@@ -9197,7 +9197,7 @@
           <p:cNvPr id="13" name="TextBox 12">
             <a:extLst>
               <a:ext uri="{FF2B5EF4-FFF2-40B4-BE49-F238E27FC236}">
-                <a16:creationId xmlns:a16="http://schemas.microsoft.com/office/drawing/2014/main" id="{16CD85E3-02F8-0934-B7D8-A022ACDCD6A7}"/>
+                <a16:creationId xmlns:a16="http://schemas.microsoft.com/office/drawing/2014/main" id="{7F5A5446-F443-D975-FBEF-3BF65DD3BF1E}"/>
               </a:ext>
             </a:extLst>
           </p:cNvPr>
@@ -9237,7 +9237,7 @@
           <p:cNvPr id="14" name="Straight Connector 13">
             <a:extLst>
               <a:ext uri="{FF2B5EF4-FFF2-40B4-BE49-F238E27FC236}">
-                <a16:creationId xmlns:a16="http://schemas.microsoft.com/office/drawing/2014/main" id="{8630A174-EFBA-B329-20C7-0FF54B32C407}"/>
+                <a16:creationId xmlns:a16="http://schemas.microsoft.com/office/drawing/2014/main" id="{0F844CF8-E80B-EB66-4EAB-0E78943F99A0}"/>
               </a:ext>
             </a:extLst>
           </p:cNvPr>
@@ -9278,7 +9278,7 @@
           <p:cNvPr id="15" name="TextBox 14">
             <a:extLst>
               <a:ext uri="{FF2B5EF4-FFF2-40B4-BE49-F238E27FC236}">
-                <a16:creationId xmlns:a16="http://schemas.microsoft.com/office/drawing/2014/main" id="{EB48DAAC-35B4-4841-CAA5-06F39CE730A9}"/>
+                <a16:creationId xmlns:a16="http://schemas.microsoft.com/office/drawing/2014/main" id="{7C2DDABF-22E8-1097-91EC-A7B2727140BD}"/>
               </a:ext>
             </a:extLst>
           </p:cNvPr>
@@ -9318,7 +9318,7 @@
           <p:cNvPr id="16" name="Rectangle: Rounded Corners 15">
             <a:extLst>
               <a:ext uri="{FF2B5EF4-FFF2-40B4-BE49-F238E27FC236}">
-                <a16:creationId xmlns:a16="http://schemas.microsoft.com/office/drawing/2014/main" id="{EFC64ECA-9BE9-3B2A-7CEB-729FE939AC2A}"/>
+                <a16:creationId xmlns:a16="http://schemas.microsoft.com/office/drawing/2014/main" id="{FFC98BD0-245B-A6A1-2CEB-E15CEB42B54A}"/>
               </a:ext>
             </a:extLst>
           </p:cNvPr>
@@ -9386,7 +9386,7 @@
           <p:cNvPr id="17" name="TextBox 16">
             <a:extLst>
               <a:ext uri="{FF2B5EF4-FFF2-40B4-BE49-F238E27FC236}">
-                <a16:creationId xmlns:a16="http://schemas.microsoft.com/office/drawing/2014/main" id="{025FA5A0-1533-B16B-FF74-6E75060DC184}"/>
+                <a16:creationId xmlns:a16="http://schemas.microsoft.com/office/drawing/2014/main" id="{2727F489-05EC-9546-A5F9-BBAF7750CC98}"/>
               </a:ext>
             </a:extLst>
           </p:cNvPr>
@@ -9425,7 +9425,7 @@
     </p:spTree>
     <p:extLst>
       <p:ext uri="{BB962C8B-B14F-4D97-AF65-F5344CB8AC3E}">
-        <p14:creationId xmlns:p14="http://schemas.microsoft.com/office/powerpoint/2010/main" val="2761154220"/>
+        <p14:creationId xmlns:p14="http://schemas.microsoft.com/office/powerpoint/2010/main" val="855470593"/>
       </p:ext>
     </p:extLst>
   </p:cSld>
@@ -9465,7 +9465,7 @@
           <p:cNvPr id="2" name="TextBox 1">
             <a:extLst>
               <a:ext uri="{FF2B5EF4-FFF2-40B4-BE49-F238E27FC236}">
-                <a16:creationId xmlns:a16="http://schemas.microsoft.com/office/drawing/2014/main" id="{8BBD5741-0879-0317-DDD6-A91DCDDED07B}"/>
+                <a16:creationId xmlns:a16="http://schemas.microsoft.com/office/drawing/2014/main" id="{99204416-7242-0F7C-D27E-A340D0F1D7C9}"/>
               </a:ext>
             </a:extLst>
           </p:cNvPr>
@@ -9505,7 +9505,7 @@
           <p:cNvPr id="3" name="Straight Connector 2">
             <a:extLst>
               <a:ext uri="{FF2B5EF4-FFF2-40B4-BE49-F238E27FC236}">
-                <a16:creationId xmlns:a16="http://schemas.microsoft.com/office/drawing/2014/main" id="{E9269E04-114C-6E82-734C-AC92C9DDA6CE}"/>
+                <a16:creationId xmlns:a16="http://schemas.microsoft.com/office/drawing/2014/main" id="{54742C6B-B802-2213-C649-023EEE7B2A98}"/>
               </a:ext>
             </a:extLst>
           </p:cNvPr>
@@ -9546,7 +9546,7 @@
           <p:cNvPr id="4" name="TextBox 3">
             <a:extLst>
               <a:ext uri="{FF2B5EF4-FFF2-40B4-BE49-F238E27FC236}">
-                <a16:creationId xmlns:a16="http://schemas.microsoft.com/office/drawing/2014/main" id="{D4CFCD2C-7835-3E3D-FE30-64437C13A7C6}"/>
+                <a16:creationId xmlns:a16="http://schemas.microsoft.com/office/drawing/2014/main" id="{22C884E9-5A03-D023-A39F-181334E288D5}"/>
               </a:ext>
             </a:extLst>
           </p:cNvPr>
@@ -9587,7 +9587,7 @@
           <p:cNvPr id="5" name="TextBox 4">
             <a:extLst>
               <a:ext uri="{FF2B5EF4-FFF2-40B4-BE49-F238E27FC236}">
-                <a16:creationId xmlns:a16="http://schemas.microsoft.com/office/drawing/2014/main" id="{821F48AA-7CE8-B91A-B61B-A03167F9B3CC}"/>
+                <a16:creationId xmlns:a16="http://schemas.microsoft.com/office/drawing/2014/main" id="{5193BC62-E99C-EC11-B532-97160A476862}"/>
               </a:ext>
             </a:extLst>
           </p:cNvPr>
@@ -9627,7 +9627,7 @@
           <p:cNvPr id="6" name="TextBox 5">
             <a:extLst>
               <a:ext uri="{FF2B5EF4-FFF2-40B4-BE49-F238E27FC236}">
-                <a16:creationId xmlns:a16="http://schemas.microsoft.com/office/drawing/2014/main" id="{7C457114-F049-F056-44B2-05678DFFE5DF}"/>
+                <a16:creationId xmlns:a16="http://schemas.microsoft.com/office/drawing/2014/main" id="{B959EBF6-A182-02FB-ECAB-1FBF82CFCC7C}"/>
               </a:ext>
             </a:extLst>
           </p:cNvPr>
@@ -9667,7 +9667,7 @@
           <p:cNvPr id="7" name="Straight Connector 6">
             <a:extLst>
               <a:ext uri="{FF2B5EF4-FFF2-40B4-BE49-F238E27FC236}">
-                <a16:creationId xmlns:a16="http://schemas.microsoft.com/office/drawing/2014/main" id="{48619450-86EB-87C8-E793-907853D313F9}"/>
+                <a16:creationId xmlns:a16="http://schemas.microsoft.com/office/drawing/2014/main" id="{CB1CC6AA-BDBF-06FE-8FAB-A05BC27963A4}"/>
               </a:ext>
             </a:extLst>
           </p:cNvPr>
@@ -9708,7 +9708,7 @@
           <p:cNvPr id="8" name="TextBox 7">
             <a:extLst>
               <a:ext uri="{FF2B5EF4-FFF2-40B4-BE49-F238E27FC236}">
-                <a16:creationId xmlns:a16="http://schemas.microsoft.com/office/drawing/2014/main" id="{18D199EF-EA8E-8FA4-EFBA-D6D601FB2179}"/>
+                <a16:creationId xmlns:a16="http://schemas.microsoft.com/office/drawing/2014/main" id="{65424182-6FEA-05A5-5503-BB26454D5902}"/>
               </a:ext>
             </a:extLst>
           </p:cNvPr>
@@ -9748,7 +9748,7 @@
           <p:cNvPr id="9" name="Straight Connector 8">
             <a:extLst>
               <a:ext uri="{FF2B5EF4-FFF2-40B4-BE49-F238E27FC236}">
-                <a16:creationId xmlns:a16="http://schemas.microsoft.com/office/drawing/2014/main" id="{12CC7513-2E19-9ADE-9007-E0E0D55AA9AE}"/>
+                <a16:creationId xmlns:a16="http://schemas.microsoft.com/office/drawing/2014/main" id="{79F297C0-9558-AE01-3F13-AF775B8EBEDE}"/>
               </a:ext>
             </a:extLst>
           </p:cNvPr>
@@ -9789,7 +9789,7 @@
           <p:cNvPr id="10" name="TextBox 9">
             <a:extLst>
               <a:ext uri="{FF2B5EF4-FFF2-40B4-BE49-F238E27FC236}">
-                <a16:creationId xmlns:a16="http://schemas.microsoft.com/office/drawing/2014/main" id="{4FD2C7CA-30EA-7B62-FF64-B79365967114}"/>
+                <a16:creationId xmlns:a16="http://schemas.microsoft.com/office/drawing/2014/main" id="{84EFB993-E3F9-4F99-9D7C-46BA6B5B1E0F}"/>
               </a:ext>
             </a:extLst>
           </p:cNvPr>
@@ -9829,7 +9829,7 @@
           <p:cNvPr id="11" name="Straight Connector 10">
             <a:extLst>
               <a:ext uri="{FF2B5EF4-FFF2-40B4-BE49-F238E27FC236}">
-                <a16:creationId xmlns:a16="http://schemas.microsoft.com/office/drawing/2014/main" id="{96B20904-B8C8-E38F-C945-49E327BA1F4A}"/>
+                <a16:creationId xmlns:a16="http://schemas.microsoft.com/office/drawing/2014/main" id="{6AF6D905-C1FE-8C93-E1D1-B3F906E6B556}"/>
               </a:ext>
             </a:extLst>
           </p:cNvPr>
@@ -9870,7 +9870,7 @@
           <p:cNvPr id="12" name="TextBox 11">
             <a:extLst>
               <a:ext uri="{FF2B5EF4-FFF2-40B4-BE49-F238E27FC236}">
-                <a16:creationId xmlns:a16="http://schemas.microsoft.com/office/drawing/2014/main" id="{E32FD062-7FEC-6935-6BF6-6D207BBE3FDD}"/>
+                <a16:creationId xmlns:a16="http://schemas.microsoft.com/office/drawing/2014/main" id="{A5FA8CC7-B859-82C4-3F2D-4FE2CE86D6C1}"/>
               </a:ext>
             </a:extLst>
           </p:cNvPr>
@@ -9910,7 +9910,7 @@
           <p:cNvPr id="13" name="Rectangle: Rounded Corners 12">
             <a:extLst>
               <a:ext uri="{FF2B5EF4-FFF2-40B4-BE49-F238E27FC236}">
-                <a16:creationId xmlns:a16="http://schemas.microsoft.com/office/drawing/2014/main" id="{23687734-9E18-3135-9C9E-A15B702AF5C1}"/>
+                <a16:creationId xmlns:a16="http://schemas.microsoft.com/office/drawing/2014/main" id="{DD0A7F3A-3607-E49F-881D-A13A0145C355}"/>
               </a:ext>
             </a:extLst>
           </p:cNvPr>
@@ -9964,7 +9964,7 @@
           <p:cNvPr id="15" name="Picture 14" descr="Overview showing seven administrative locality boundaries and frozen outcomes">
             <a:extLst>
               <a:ext uri="{FF2B5EF4-FFF2-40B4-BE49-F238E27FC236}">
-                <a16:creationId xmlns:a16="http://schemas.microsoft.com/office/drawing/2014/main" id="{AF5D3578-F201-F610-657F-443C9A55E5C1}"/>
+                <a16:creationId xmlns:a16="http://schemas.microsoft.com/office/drawing/2014/main" id="{B1A150B5-39EB-4D24-0F70-7BE355517FB3}"/>
               </a:ext>
             </a:extLst>
           </p:cNvPr>
@@ -10000,7 +10000,7 @@
           <p:cNvPr id="16" name="TextBox 15">
             <a:extLst>
               <a:ext uri="{FF2B5EF4-FFF2-40B4-BE49-F238E27FC236}">
-                <a16:creationId xmlns:a16="http://schemas.microsoft.com/office/drawing/2014/main" id="{DD9694C1-379E-A770-D9E9-651767172173}"/>
+                <a16:creationId xmlns:a16="http://schemas.microsoft.com/office/drawing/2014/main" id="{09600543-E4AA-B91F-683B-069FA38E90CF}"/>
               </a:ext>
             </a:extLst>
           </p:cNvPr>
@@ -10038,7 +10038,7 @@
     </p:spTree>
     <p:extLst>
       <p:ext uri="{BB962C8B-B14F-4D97-AF65-F5344CB8AC3E}">
-        <p14:creationId xmlns:p14="http://schemas.microsoft.com/office/powerpoint/2010/main" val="442897055"/>
+        <p14:creationId xmlns:p14="http://schemas.microsoft.com/office/powerpoint/2010/main" val="1063902145"/>
       </p:ext>
     </p:extLst>
   </p:cSld>
@@ -10078,7 +10078,7 @@
           <p:cNvPr id="2" name="TextBox 1">
             <a:extLst>
               <a:ext uri="{FF2B5EF4-FFF2-40B4-BE49-F238E27FC236}">
-                <a16:creationId xmlns:a16="http://schemas.microsoft.com/office/drawing/2014/main" id="{FD4CF0F3-0408-F5AA-416B-5E76F9D81A82}"/>
+                <a16:creationId xmlns:a16="http://schemas.microsoft.com/office/drawing/2014/main" id="{EB0EB5D7-D654-0BA6-72A1-298D60D1BB05}"/>
               </a:ext>
             </a:extLst>
           </p:cNvPr>
@@ -10118,7 +10118,7 @@
           <p:cNvPr id="3" name="Straight Connector 2">
             <a:extLst>
               <a:ext uri="{FF2B5EF4-FFF2-40B4-BE49-F238E27FC236}">
-                <a16:creationId xmlns:a16="http://schemas.microsoft.com/office/drawing/2014/main" id="{10882362-6390-5090-A29F-E4B01B77E519}"/>
+                <a16:creationId xmlns:a16="http://schemas.microsoft.com/office/drawing/2014/main" id="{C0A32BD4-31B8-59D3-42E5-A25DB4AF2B03}"/>
               </a:ext>
             </a:extLst>
           </p:cNvPr>
@@ -10159,7 +10159,7 @@
           <p:cNvPr id="4" name="TextBox 3">
             <a:extLst>
               <a:ext uri="{FF2B5EF4-FFF2-40B4-BE49-F238E27FC236}">
-                <a16:creationId xmlns:a16="http://schemas.microsoft.com/office/drawing/2014/main" id="{EE8CAE7F-CB1D-FBC6-3641-600F68DD5B4D}"/>
+                <a16:creationId xmlns:a16="http://schemas.microsoft.com/office/drawing/2014/main" id="{DBA27A3C-5EFF-D28C-D7D4-4D5F46CB3382}"/>
               </a:ext>
             </a:extLst>
           </p:cNvPr>
@@ -10200,7 +10200,7 @@
           <p:cNvPr id="5" name="TextBox 4">
             <a:extLst>
               <a:ext uri="{FF2B5EF4-FFF2-40B4-BE49-F238E27FC236}">
-                <a16:creationId xmlns:a16="http://schemas.microsoft.com/office/drawing/2014/main" id="{03B0742E-3FE2-7F4A-72E6-F342F2930327}"/>
+                <a16:creationId xmlns:a16="http://schemas.microsoft.com/office/drawing/2014/main" id="{F946E41C-655A-BA90-42A6-5763AFC60AA7}"/>
               </a:ext>
             </a:extLst>
           </p:cNvPr>
@@ -10240,7 +10240,7 @@
           <p:cNvPr id="6" name="TextBox 5">
             <a:extLst>
               <a:ext uri="{FF2B5EF4-FFF2-40B4-BE49-F238E27FC236}">
-                <a16:creationId xmlns:a16="http://schemas.microsoft.com/office/drawing/2014/main" id="{A4BCB82C-6A17-3B2B-9F15-508A73A912DC}"/>
+                <a16:creationId xmlns:a16="http://schemas.microsoft.com/office/drawing/2014/main" id="{F6615FB7-5520-BDDC-491E-8DE5A81C2BFD}"/>
               </a:ext>
             </a:extLst>
           </p:cNvPr>
@@ -10280,7 +10280,7 @@
           <p:cNvPr id="7" name="Straight Connector 6">
             <a:extLst>
               <a:ext uri="{FF2B5EF4-FFF2-40B4-BE49-F238E27FC236}">
-                <a16:creationId xmlns:a16="http://schemas.microsoft.com/office/drawing/2014/main" id="{AF083351-0B4E-0032-C457-184DA0ADB757}"/>
+                <a16:creationId xmlns:a16="http://schemas.microsoft.com/office/drawing/2014/main" id="{CCF09DD9-3604-2B60-98DC-8281739034A1}"/>
               </a:ext>
             </a:extLst>
           </p:cNvPr>
@@ -10322,7 +10322,7 @@
           <p:cNvPr id="8" name="Straight Connector 7">
             <a:extLst>
               <a:ext uri="{FF2B5EF4-FFF2-40B4-BE49-F238E27FC236}">
-                <a16:creationId xmlns:a16="http://schemas.microsoft.com/office/drawing/2014/main" id="{5495474F-648A-79FE-0F15-37D7C8968C73}"/>
+                <a16:creationId xmlns:a16="http://schemas.microsoft.com/office/drawing/2014/main" id="{F5E51820-9F28-E098-6645-57829F75A475}"/>
               </a:ext>
             </a:extLst>
           </p:cNvPr>
@@ -10364,7 +10364,7 @@
           <p:cNvPr id="9" name="Straight Connector 8">
             <a:extLst>
               <a:ext uri="{FF2B5EF4-FFF2-40B4-BE49-F238E27FC236}">
-                <a16:creationId xmlns:a16="http://schemas.microsoft.com/office/drawing/2014/main" id="{4EFCBBA2-7517-1AF0-7663-6941CB30006D}"/>
+                <a16:creationId xmlns:a16="http://schemas.microsoft.com/office/drawing/2014/main" id="{784F07B7-A09C-B3D6-922E-6A6BA79F8143}"/>
               </a:ext>
             </a:extLst>
           </p:cNvPr>
@@ -10406,7 +10406,7 @@
           <p:cNvPr id="10" name="Straight Connector 9">
             <a:extLst>
               <a:ext uri="{FF2B5EF4-FFF2-40B4-BE49-F238E27FC236}">
-                <a16:creationId xmlns:a16="http://schemas.microsoft.com/office/drawing/2014/main" id="{9C6B4CE2-29FF-B24B-5171-680E01F0898A}"/>
+                <a16:creationId xmlns:a16="http://schemas.microsoft.com/office/drawing/2014/main" id="{26B05703-C059-8349-17D0-520AEB3AA48E}"/>
               </a:ext>
             </a:extLst>
           </p:cNvPr>
@@ -10448,7 +10448,7 @@
           <p:cNvPr id="11" name="Rectangle: Rounded Corners 10">
             <a:extLst>
               <a:ext uri="{FF2B5EF4-FFF2-40B4-BE49-F238E27FC236}">
-                <a16:creationId xmlns:a16="http://schemas.microsoft.com/office/drawing/2014/main" id="{AC5CEDED-DA95-59C1-7ABD-486ECBEF1956}"/>
+                <a16:creationId xmlns:a16="http://schemas.microsoft.com/office/drawing/2014/main" id="{BF95DA16-CEFF-2921-D28C-8A1613A8674D}"/>
               </a:ext>
             </a:extLst>
           </p:cNvPr>
@@ -10516,7 +10516,7 @@
           <p:cNvPr id="12" name="TextBox 11">
             <a:extLst>
               <a:ext uri="{FF2B5EF4-FFF2-40B4-BE49-F238E27FC236}">
-                <a16:creationId xmlns:a16="http://schemas.microsoft.com/office/drawing/2014/main" id="{6465ED5C-11C6-A334-526D-D7B4D417519B}"/>
+                <a16:creationId xmlns:a16="http://schemas.microsoft.com/office/drawing/2014/main" id="{FDDA0CC0-6186-BA04-B7B7-BC604BB37377}"/>
               </a:ext>
             </a:extLst>
           </p:cNvPr>
@@ -10569,7 +10569,7 @@
           <p:cNvPr id="13" name="Rectangle: Rounded Corners 12">
             <a:extLst>
               <a:ext uri="{FF2B5EF4-FFF2-40B4-BE49-F238E27FC236}">
-                <a16:creationId xmlns:a16="http://schemas.microsoft.com/office/drawing/2014/main" id="{F70E7D94-36EE-0E9E-116F-4FD1CD022333}"/>
+                <a16:creationId xmlns:a16="http://schemas.microsoft.com/office/drawing/2014/main" id="{27B03840-600A-58FF-8D92-2F98DED566E9}"/>
               </a:ext>
             </a:extLst>
           </p:cNvPr>
@@ -10637,7 +10637,7 @@
           <p:cNvPr id="14" name="TextBox 13">
             <a:extLst>
               <a:ext uri="{FF2B5EF4-FFF2-40B4-BE49-F238E27FC236}">
-                <a16:creationId xmlns:a16="http://schemas.microsoft.com/office/drawing/2014/main" id="{922B0B24-13A4-5AFE-95EA-4685A8EE083F}"/>
+                <a16:creationId xmlns:a16="http://schemas.microsoft.com/office/drawing/2014/main" id="{AA8BCA4A-1E84-A419-7E6A-26F474221F48}"/>
               </a:ext>
             </a:extLst>
           </p:cNvPr>
@@ -10690,7 +10690,7 @@
           <p:cNvPr id="15" name="Rectangle: Rounded Corners 14">
             <a:extLst>
               <a:ext uri="{FF2B5EF4-FFF2-40B4-BE49-F238E27FC236}">
-                <a16:creationId xmlns:a16="http://schemas.microsoft.com/office/drawing/2014/main" id="{C5CADE38-36B5-8683-1A28-0B4CE63BBFDF}"/>
+                <a16:creationId xmlns:a16="http://schemas.microsoft.com/office/drawing/2014/main" id="{D010DAD8-256E-C686-002E-DED6BF886D20}"/>
               </a:ext>
             </a:extLst>
           </p:cNvPr>
@@ -10758,7 +10758,7 @@
           <p:cNvPr id="16" name="TextBox 15">
             <a:extLst>
               <a:ext uri="{FF2B5EF4-FFF2-40B4-BE49-F238E27FC236}">
-                <a16:creationId xmlns:a16="http://schemas.microsoft.com/office/drawing/2014/main" id="{8A26D17F-4053-9552-2728-BE626CD95E9B}"/>
+                <a16:creationId xmlns:a16="http://schemas.microsoft.com/office/drawing/2014/main" id="{A9848BD2-A99A-7503-6418-CBB916C73F79}"/>
               </a:ext>
             </a:extLst>
           </p:cNvPr>
@@ -10785,7 +10785,7 @@
             <a:r>
               <a:rPr lang="en-US" sz="1700" b="1">
                 <a:solidFill>
-                  <a:srgbClr val="F3F0E8"/>
+                  <a:srgbClr val="071923"/>
                 </a:solidFill>
                 <a:latin typeface="Aptos" panose="020B0004020202020204" pitchFamily="34" charset="0"/>
               </a:rPr>
@@ -10797,7 +10797,7 @@
             <a:r>
               <a:rPr lang="en-US" sz="1700" b="1">
                 <a:solidFill>
-                  <a:srgbClr val="F3F0E8"/>
+                  <a:srgbClr val="071923"/>
                 </a:solidFill>
                 <a:latin typeface="Aptos" panose="020B0004020202020204" pitchFamily="34" charset="0"/>
               </a:rPr>
@@ -10811,7 +10811,7 @@
           <p:cNvPr id="17" name="Rectangle: Rounded Corners 16">
             <a:extLst>
               <a:ext uri="{FF2B5EF4-FFF2-40B4-BE49-F238E27FC236}">
-                <a16:creationId xmlns:a16="http://schemas.microsoft.com/office/drawing/2014/main" id="{7103170F-7471-3F32-4E53-31DE40DBCF34}"/>
+                <a16:creationId xmlns:a16="http://schemas.microsoft.com/office/drawing/2014/main" id="{ED3B3D58-9F3E-D712-8EA6-9180801937B2}"/>
               </a:ext>
             </a:extLst>
           </p:cNvPr>
@@ -10879,7 +10879,7 @@
           <p:cNvPr id="18" name="TextBox 17">
             <a:extLst>
               <a:ext uri="{FF2B5EF4-FFF2-40B4-BE49-F238E27FC236}">
-                <a16:creationId xmlns:a16="http://schemas.microsoft.com/office/drawing/2014/main" id="{A1B904DE-BCCE-B60C-C02D-3F31C41EBA97}"/>
+                <a16:creationId xmlns:a16="http://schemas.microsoft.com/office/drawing/2014/main" id="{31DD08E6-FC90-4138-DAEE-0FFC34ADA6AE}"/>
               </a:ext>
             </a:extLst>
           </p:cNvPr>
@@ -10932,7 +10932,7 @@
           <p:cNvPr id="19" name="Rectangle: Rounded Corners 18">
             <a:extLst>
               <a:ext uri="{FF2B5EF4-FFF2-40B4-BE49-F238E27FC236}">
-                <a16:creationId xmlns:a16="http://schemas.microsoft.com/office/drawing/2014/main" id="{24403B61-0FE6-083B-387D-6883E58E7767}"/>
+                <a16:creationId xmlns:a16="http://schemas.microsoft.com/office/drawing/2014/main" id="{BDB397AF-B996-9268-C0FF-7A9206153EB8}"/>
               </a:ext>
             </a:extLst>
           </p:cNvPr>
@@ -11000,7 +11000,7 @@
           <p:cNvPr id="20" name="TextBox 19">
             <a:extLst>
               <a:ext uri="{FF2B5EF4-FFF2-40B4-BE49-F238E27FC236}">
-                <a16:creationId xmlns:a16="http://schemas.microsoft.com/office/drawing/2014/main" id="{F55F4A99-2552-C82B-5C42-F1C8A495EBB5}"/>
+                <a16:creationId xmlns:a16="http://schemas.microsoft.com/office/drawing/2014/main" id="{B3DD9AE8-7B93-8D62-E8A6-F4E07EEC5937}"/>
               </a:ext>
             </a:extLst>
           </p:cNvPr>
@@ -11027,7 +11027,7 @@
             <a:r>
               <a:rPr lang="en-US" sz="1700" b="1">
                 <a:solidFill>
-                  <a:srgbClr val="F3F0E8"/>
+                  <a:srgbClr val="071923"/>
                 </a:solidFill>
                 <a:latin typeface="Aptos" panose="020B0004020202020204" pitchFamily="34" charset="0"/>
               </a:rPr>
@@ -11039,7 +11039,7 @@
             <a:r>
               <a:rPr lang="en-US" sz="1700" b="1">
                 <a:solidFill>
-                  <a:srgbClr val="F3F0E8"/>
+                  <a:srgbClr val="071923"/>
                 </a:solidFill>
                 <a:latin typeface="Aptos" panose="020B0004020202020204" pitchFamily="34" charset="0"/>
               </a:rPr>
@@ -11053,7 +11053,7 @@
           <p:cNvPr id="21" name="TextBox 20">
             <a:extLst>
               <a:ext uri="{FF2B5EF4-FFF2-40B4-BE49-F238E27FC236}">
-                <a16:creationId xmlns:a16="http://schemas.microsoft.com/office/drawing/2014/main" id="{5F5E9FE7-F5AC-E9D6-8079-A0C895A6A9F3}"/>
+                <a16:creationId xmlns:a16="http://schemas.microsoft.com/office/drawing/2014/main" id="{D154EC11-E536-6350-AEBF-042D9ECCCC43}"/>
               </a:ext>
             </a:extLst>
           </p:cNvPr>
@@ -11093,7 +11093,7 @@
           <p:cNvPr id="22" name="Straight Connector 21">
             <a:extLst>
               <a:ext uri="{FF2B5EF4-FFF2-40B4-BE49-F238E27FC236}">
-                <a16:creationId xmlns:a16="http://schemas.microsoft.com/office/drawing/2014/main" id="{1831B05F-EBF6-7862-0F0F-ADB955985385}"/>
+                <a16:creationId xmlns:a16="http://schemas.microsoft.com/office/drawing/2014/main" id="{CF3089CA-7574-2E01-D9CF-1F5BCE6CA8AF}"/>
               </a:ext>
             </a:extLst>
           </p:cNvPr>
@@ -11134,7 +11134,7 @@
           <p:cNvPr id="23" name="TextBox 22">
             <a:extLst>
               <a:ext uri="{FF2B5EF4-FFF2-40B4-BE49-F238E27FC236}">
-                <a16:creationId xmlns:a16="http://schemas.microsoft.com/office/drawing/2014/main" id="{D8CE97A7-88C4-E8BD-37FE-39146C346687}"/>
+                <a16:creationId xmlns:a16="http://schemas.microsoft.com/office/drawing/2014/main" id="{D2BE4148-EB04-944D-32A0-C13551F6C999}"/>
               </a:ext>
             </a:extLst>
           </p:cNvPr>
@@ -11174,7 +11174,7 @@
           <p:cNvPr id="24" name="TextBox 23">
             <a:extLst>
               <a:ext uri="{FF2B5EF4-FFF2-40B4-BE49-F238E27FC236}">
-                <a16:creationId xmlns:a16="http://schemas.microsoft.com/office/drawing/2014/main" id="{FDDF58C2-BB79-55A9-A3A4-FA6CD210E0B3}"/>
+                <a16:creationId xmlns:a16="http://schemas.microsoft.com/office/drawing/2014/main" id="{D3E9E211-E367-2254-7C95-C723071594AE}"/>
               </a:ext>
             </a:extLst>
           </p:cNvPr>
@@ -11214,7 +11214,7 @@
           <p:cNvPr id="25" name="TextBox 24">
             <a:extLst>
               <a:ext uri="{FF2B5EF4-FFF2-40B4-BE49-F238E27FC236}">
-                <a16:creationId xmlns:a16="http://schemas.microsoft.com/office/drawing/2014/main" id="{35ED4BC8-1E9A-F29E-6C9E-1C594820DDDB}"/>
+                <a16:creationId xmlns:a16="http://schemas.microsoft.com/office/drawing/2014/main" id="{CB96D79B-AD56-7097-3587-32E036A1B172}"/>
               </a:ext>
             </a:extLst>
           </p:cNvPr>
@@ -11240,7 +11240,7 @@
             <a:r>
               <a:rPr lang="en-US" b="1">
                 <a:solidFill>
-                  <a:srgbClr val="3FC6AC"/>
+                  <a:srgbClr val="007565"/>
                 </a:solidFill>
                 <a:latin typeface="Aptos" panose="020B0004020202020204" pitchFamily="34" charset="0"/>
               </a:rPr>
@@ -11252,7 +11252,7 @@
     </p:spTree>
     <p:extLst>
       <p:ext uri="{BB962C8B-B14F-4D97-AF65-F5344CB8AC3E}">
-        <p14:creationId xmlns:p14="http://schemas.microsoft.com/office/powerpoint/2010/main" val="1498952719"/>
+        <p14:creationId xmlns:p14="http://schemas.microsoft.com/office/powerpoint/2010/main" val="3746362595"/>
       </p:ext>
     </p:extLst>
   </p:cSld>
@@ -11292,7 +11292,7 @@
           <p:cNvPr id="2" name="TextBox 1">
             <a:extLst>
               <a:ext uri="{FF2B5EF4-FFF2-40B4-BE49-F238E27FC236}">
-                <a16:creationId xmlns:a16="http://schemas.microsoft.com/office/drawing/2014/main" id="{59B46F43-024F-0AAC-1212-659E9E688B5C}"/>
+                <a16:creationId xmlns:a16="http://schemas.microsoft.com/office/drawing/2014/main" id="{717F8CBF-7E92-410B-B3B3-6FD94473ED47}"/>
               </a:ext>
             </a:extLst>
           </p:cNvPr>
@@ -11332,7 +11332,7 @@
           <p:cNvPr id="3" name="Straight Connector 2">
             <a:extLst>
               <a:ext uri="{FF2B5EF4-FFF2-40B4-BE49-F238E27FC236}">
-                <a16:creationId xmlns:a16="http://schemas.microsoft.com/office/drawing/2014/main" id="{1F9DB25B-1BAA-E530-80C7-486B12F5F1AE}"/>
+                <a16:creationId xmlns:a16="http://schemas.microsoft.com/office/drawing/2014/main" id="{8FA5A2E2-E334-E0D9-1DF4-C14D41D23E24}"/>
               </a:ext>
             </a:extLst>
           </p:cNvPr>
@@ -11373,7 +11373,7 @@
           <p:cNvPr id="4" name="TextBox 3">
             <a:extLst>
               <a:ext uri="{FF2B5EF4-FFF2-40B4-BE49-F238E27FC236}">
-                <a16:creationId xmlns:a16="http://schemas.microsoft.com/office/drawing/2014/main" id="{68634E80-4301-B8B6-5595-515A115D8296}"/>
+                <a16:creationId xmlns:a16="http://schemas.microsoft.com/office/drawing/2014/main" id="{0E1F19CA-B125-99CA-F20F-1782604AA59F}"/>
               </a:ext>
             </a:extLst>
           </p:cNvPr>
@@ -11414,7 +11414,7 @@
           <p:cNvPr id="5" name="TextBox 4">
             <a:extLst>
               <a:ext uri="{FF2B5EF4-FFF2-40B4-BE49-F238E27FC236}">
-                <a16:creationId xmlns:a16="http://schemas.microsoft.com/office/drawing/2014/main" id="{01048670-D933-3228-AD8B-AA0B869CAEAF}"/>
+                <a16:creationId xmlns:a16="http://schemas.microsoft.com/office/drawing/2014/main" id="{970B2EF0-792A-5A92-D4FA-547B3E533456}"/>
               </a:ext>
             </a:extLst>
           </p:cNvPr>
@@ -11454,7 +11454,7 @@
           <p:cNvPr id="6" name="TextBox 5">
             <a:extLst>
               <a:ext uri="{FF2B5EF4-FFF2-40B4-BE49-F238E27FC236}">
-                <a16:creationId xmlns:a16="http://schemas.microsoft.com/office/drawing/2014/main" id="{EA4AABC3-22F6-DA33-C5BF-DC450ED35967}"/>
+                <a16:creationId xmlns:a16="http://schemas.microsoft.com/office/drawing/2014/main" id="{98FAAA75-CCB1-E3EA-9A7E-A8C547E37081}"/>
               </a:ext>
             </a:extLst>
           </p:cNvPr>
@@ -11494,7 +11494,7 @@
           <p:cNvPr id="7" name="Rectangle: Rounded Corners 6">
             <a:extLst>
               <a:ext uri="{FF2B5EF4-FFF2-40B4-BE49-F238E27FC236}">
-                <a16:creationId xmlns:a16="http://schemas.microsoft.com/office/drawing/2014/main" id="{E1F92BC8-A575-A4EB-ACC4-EC739053A59E}"/>
+                <a16:creationId xmlns:a16="http://schemas.microsoft.com/office/drawing/2014/main" id="{15F224B3-D5E6-FEE2-A0FD-72A8BF652D25}"/>
               </a:ext>
             </a:extLst>
           </p:cNvPr>
@@ -11562,7 +11562,7 @@
           <p:cNvPr id="8" name="TextBox 7">
             <a:extLst>
               <a:ext uri="{FF2B5EF4-FFF2-40B4-BE49-F238E27FC236}">
-                <a16:creationId xmlns:a16="http://schemas.microsoft.com/office/drawing/2014/main" id="{5284E885-5280-10CC-3F04-2B131EF9F65A}"/>
+                <a16:creationId xmlns:a16="http://schemas.microsoft.com/office/drawing/2014/main" id="{9EFC3CD9-A944-A227-196C-699B0652208D}"/>
               </a:ext>
             </a:extLst>
           </p:cNvPr>
@@ -11603,7 +11603,7 @@
           <p:cNvPr id="9" name="TextBox 8">
             <a:extLst>
               <a:ext uri="{FF2B5EF4-FFF2-40B4-BE49-F238E27FC236}">
-                <a16:creationId xmlns:a16="http://schemas.microsoft.com/office/drawing/2014/main" id="{73551DAA-BC69-5CE3-EC2C-CD6F22F6F6B0}"/>
+                <a16:creationId xmlns:a16="http://schemas.microsoft.com/office/drawing/2014/main" id="{E19BC73B-AB2B-6202-19D1-716397757C83}"/>
               </a:ext>
             </a:extLst>
           </p:cNvPr>
@@ -11644,7 +11644,7 @@
           <p:cNvPr id="10" name="TextBox 9">
             <a:extLst>
               <a:ext uri="{FF2B5EF4-FFF2-40B4-BE49-F238E27FC236}">
-                <a16:creationId xmlns:a16="http://schemas.microsoft.com/office/drawing/2014/main" id="{7F82F420-4081-AFDA-B26B-F4030F6DD755}"/>
+                <a16:creationId xmlns:a16="http://schemas.microsoft.com/office/drawing/2014/main" id="{8982DD5D-EB8C-2C2A-64BD-E8ADCFDA93BD}"/>
               </a:ext>
             </a:extLst>
           </p:cNvPr>
@@ -11685,7 +11685,7 @@
           <p:cNvPr id="11" name="TextBox 10">
             <a:extLst>
               <a:ext uri="{FF2B5EF4-FFF2-40B4-BE49-F238E27FC236}">
-                <a16:creationId xmlns:a16="http://schemas.microsoft.com/office/drawing/2014/main" id="{FD1BBCE7-78E5-1D68-4C8C-A86B484F4612}"/>
+                <a16:creationId xmlns:a16="http://schemas.microsoft.com/office/drawing/2014/main" id="{37BA3345-84B2-998F-1BEC-8CB3CBFF1F90}"/>
               </a:ext>
             </a:extLst>
           </p:cNvPr>
@@ -11726,7 +11726,7 @@
           <p:cNvPr id="12" name="Rectangle: Rounded Corners 11">
             <a:extLst>
               <a:ext uri="{FF2B5EF4-FFF2-40B4-BE49-F238E27FC236}">
-                <a16:creationId xmlns:a16="http://schemas.microsoft.com/office/drawing/2014/main" id="{9445A692-B7AB-6753-78BE-E189D887280C}"/>
+                <a16:creationId xmlns:a16="http://schemas.microsoft.com/office/drawing/2014/main" id="{7588B1BD-9924-3886-686F-C7B1B1F113A8}"/>
               </a:ext>
             </a:extLst>
           </p:cNvPr>
@@ -11794,7 +11794,7 @@
           <p:cNvPr id="13" name="TextBox 12">
             <a:extLst>
               <a:ext uri="{FF2B5EF4-FFF2-40B4-BE49-F238E27FC236}">
-                <a16:creationId xmlns:a16="http://schemas.microsoft.com/office/drawing/2014/main" id="{88083DF2-30AB-82B9-58E0-11FF0D22F557}"/>
+                <a16:creationId xmlns:a16="http://schemas.microsoft.com/office/drawing/2014/main" id="{5D1914E2-A4D9-1A97-D4AC-1642557C299E}"/>
               </a:ext>
             </a:extLst>
           </p:cNvPr>
@@ -11835,7 +11835,7 @@
           <p:cNvPr id="14" name="TextBox 13">
             <a:extLst>
               <a:ext uri="{FF2B5EF4-FFF2-40B4-BE49-F238E27FC236}">
-                <a16:creationId xmlns:a16="http://schemas.microsoft.com/office/drawing/2014/main" id="{3A979D04-7705-9893-3ABA-88DB8896300C}"/>
+                <a16:creationId xmlns:a16="http://schemas.microsoft.com/office/drawing/2014/main" id="{3EECCA37-7F59-3AA3-AC5D-776F96EFE6C5}"/>
               </a:ext>
             </a:extLst>
           </p:cNvPr>
@@ -11862,7 +11862,7 @@
             <a:r>
               <a:rPr lang="en-US" sz="1600" b="1">
                 <a:solidFill>
-                  <a:srgbClr val="F3F0E8"/>
+                  <a:srgbClr val="071923"/>
                 </a:solidFill>
                 <a:latin typeface="Aptos" panose="020B0004020202020204" pitchFamily="34" charset="0"/>
               </a:rPr>
@@ -11876,7 +11876,7 @@
           <p:cNvPr id="15" name="TextBox 14">
             <a:extLst>
               <a:ext uri="{FF2B5EF4-FFF2-40B4-BE49-F238E27FC236}">
-                <a16:creationId xmlns:a16="http://schemas.microsoft.com/office/drawing/2014/main" id="{83C6D29F-8E55-19C6-04D0-7935FB2BB2CD}"/>
+                <a16:creationId xmlns:a16="http://schemas.microsoft.com/office/drawing/2014/main" id="{8B447AE4-E602-BB17-125C-C89D53D910A5}"/>
               </a:ext>
             </a:extLst>
           </p:cNvPr>
@@ -11917,7 +11917,7 @@
           <p:cNvPr id="16" name="Rectangle: Rounded Corners 15">
             <a:extLst>
               <a:ext uri="{FF2B5EF4-FFF2-40B4-BE49-F238E27FC236}">
-                <a16:creationId xmlns:a16="http://schemas.microsoft.com/office/drawing/2014/main" id="{8A739083-38E1-F2A7-A248-CC72AF8A91B0}"/>
+                <a16:creationId xmlns:a16="http://schemas.microsoft.com/office/drawing/2014/main" id="{B50C7EBE-9EE5-6618-B8B3-DC68FA4A8CC2}"/>
               </a:ext>
             </a:extLst>
           </p:cNvPr>
@@ -11985,7 +11985,7 @@
           <p:cNvPr id="17" name="TextBox 16">
             <a:extLst>
               <a:ext uri="{FF2B5EF4-FFF2-40B4-BE49-F238E27FC236}">
-                <a16:creationId xmlns:a16="http://schemas.microsoft.com/office/drawing/2014/main" id="{672495D8-D513-E9D7-D372-DE87CB0354ED}"/>
+                <a16:creationId xmlns:a16="http://schemas.microsoft.com/office/drawing/2014/main" id="{88E68315-F6F6-1B5B-0E67-A897D88DDE5E}"/>
               </a:ext>
             </a:extLst>
           </p:cNvPr>
@@ -12026,7 +12026,7 @@
           <p:cNvPr id="18" name="TextBox 17">
             <a:extLst>
               <a:ext uri="{FF2B5EF4-FFF2-40B4-BE49-F238E27FC236}">
-                <a16:creationId xmlns:a16="http://schemas.microsoft.com/office/drawing/2014/main" id="{49360196-DC01-8BBD-6EF4-E5C21F61CFFF}"/>
+                <a16:creationId xmlns:a16="http://schemas.microsoft.com/office/drawing/2014/main" id="{F5C3936F-503C-BD29-B8FC-BEC0C2DD7554}"/>
               </a:ext>
             </a:extLst>
           </p:cNvPr>
@@ -12067,7 +12067,7 @@
           <p:cNvPr id="19" name="Straight Connector 18">
             <a:extLst>
               <a:ext uri="{FF2B5EF4-FFF2-40B4-BE49-F238E27FC236}">
-                <a16:creationId xmlns:a16="http://schemas.microsoft.com/office/drawing/2014/main" id="{A0621D2B-7989-DBA2-EA93-7E8AEF2A0B6C}"/>
+                <a16:creationId xmlns:a16="http://schemas.microsoft.com/office/drawing/2014/main" id="{6FCB830C-D0EB-7BB4-C182-549F5D6138AA}"/>
               </a:ext>
             </a:extLst>
           </p:cNvPr>
@@ -12108,7 +12108,7 @@
           <p:cNvPr id="20" name="TextBox 19">
             <a:extLst>
               <a:ext uri="{FF2B5EF4-FFF2-40B4-BE49-F238E27FC236}">
-                <a16:creationId xmlns:a16="http://schemas.microsoft.com/office/drawing/2014/main" id="{2277A425-C4D3-68F6-A703-AB80FE3850F2}"/>
+                <a16:creationId xmlns:a16="http://schemas.microsoft.com/office/drawing/2014/main" id="{1BCA90A0-FD13-FBD8-31F2-4BAAC70E727A}"/>
               </a:ext>
             </a:extLst>
           </p:cNvPr>
@@ -12148,7 +12148,7 @@
           <p:cNvPr id="21" name="TextBox 20">
             <a:extLst>
               <a:ext uri="{FF2B5EF4-FFF2-40B4-BE49-F238E27FC236}">
-                <a16:creationId xmlns:a16="http://schemas.microsoft.com/office/drawing/2014/main" id="{AB044164-8CFB-CD0C-0505-D0FEF4B08D98}"/>
+                <a16:creationId xmlns:a16="http://schemas.microsoft.com/office/drawing/2014/main" id="{AB4421BE-2EA1-F2FE-48BE-470801C557F3}"/>
               </a:ext>
             </a:extLst>
           </p:cNvPr>
@@ -12199,7 +12199,7 @@
           <p:cNvPr id="22" name="TextBox 21">
             <a:extLst>
               <a:ext uri="{FF2B5EF4-FFF2-40B4-BE49-F238E27FC236}">
-                <a16:creationId xmlns:a16="http://schemas.microsoft.com/office/drawing/2014/main" id="{F19D95C2-C796-EB87-FA53-399ED8C4DBF9}"/>
+                <a16:creationId xmlns:a16="http://schemas.microsoft.com/office/drawing/2014/main" id="{33323739-A5DD-DD8E-5EE3-5D08706AFDFF}"/>
               </a:ext>
             </a:extLst>
           </p:cNvPr>
@@ -12239,7 +12239,7 @@
           <p:cNvPr id="23" name="TextBox 22">
             <a:extLst>
               <a:ext uri="{FF2B5EF4-FFF2-40B4-BE49-F238E27FC236}">
-                <a16:creationId xmlns:a16="http://schemas.microsoft.com/office/drawing/2014/main" id="{F1F771E7-C4A0-D4F5-820D-D3400182C4B4}"/>
+                <a16:creationId xmlns:a16="http://schemas.microsoft.com/office/drawing/2014/main" id="{F413B688-1D3F-3BB9-5CD1-FD1846223C41}"/>
               </a:ext>
             </a:extLst>
           </p:cNvPr>
@@ -12290,7 +12290,7 @@
           <p:cNvPr id="24" name="TextBox 23">
             <a:extLst>
               <a:ext uri="{FF2B5EF4-FFF2-40B4-BE49-F238E27FC236}">
-                <a16:creationId xmlns:a16="http://schemas.microsoft.com/office/drawing/2014/main" id="{40C84807-1A6F-48AB-C0B2-16D832D12422}"/>
+                <a16:creationId xmlns:a16="http://schemas.microsoft.com/office/drawing/2014/main" id="{42563CD1-693A-CECD-73C2-0AD9A4AFC123}"/>
               </a:ext>
             </a:extLst>
           </p:cNvPr>
@@ -12329,7 +12329,7 @@
     </p:spTree>
     <p:extLst>
       <p:ext uri="{BB962C8B-B14F-4D97-AF65-F5344CB8AC3E}">
-        <p14:creationId xmlns:p14="http://schemas.microsoft.com/office/powerpoint/2010/main" val="1967072378"/>
+        <p14:creationId xmlns:p14="http://schemas.microsoft.com/office/powerpoint/2010/main" val="2330392729"/>
       </p:ext>
     </p:extLst>
   </p:cSld>
@@ -12369,7 +12369,7 @@
           <p:cNvPr id="2" name="TextBox 1">
             <a:extLst>
               <a:ext uri="{FF2B5EF4-FFF2-40B4-BE49-F238E27FC236}">
-                <a16:creationId xmlns:a16="http://schemas.microsoft.com/office/drawing/2014/main" id="{57904472-C98E-B7E6-369F-A12CE83ECDA0}"/>
+                <a16:creationId xmlns:a16="http://schemas.microsoft.com/office/drawing/2014/main" id="{410E2BB3-C40F-6668-223D-88EC3A619730}"/>
               </a:ext>
             </a:extLst>
           </p:cNvPr>
@@ -12409,7 +12409,7 @@
           <p:cNvPr id="3" name="Straight Connector 2">
             <a:extLst>
               <a:ext uri="{FF2B5EF4-FFF2-40B4-BE49-F238E27FC236}">
-                <a16:creationId xmlns:a16="http://schemas.microsoft.com/office/drawing/2014/main" id="{6B919D22-DF8A-9EDF-40E7-26C5A3657CAE}"/>
+                <a16:creationId xmlns:a16="http://schemas.microsoft.com/office/drawing/2014/main" id="{3CA361E5-A3B9-3048-FB52-3ECBDB2E4198}"/>
               </a:ext>
             </a:extLst>
           </p:cNvPr>
@@ -12450,7 +12450,7 @@
           <p:cNvPr id="4" name="TextBox 3">
             <a:extLst>
               <a:ext uri="{FF2B5EF4-FFF2-40B4-BE49-F238E27FC236}">
-                <a16:creationId xmlns:a16="http://schemas.microsoft.com/office/drawing/2014/main" id="{78A8F97F-AB0C-5AAA-D347-45185B86A164}"/>
+                <a16:creationId xmlns:a16="http://schemas.microsoft.com/office/drawing/2014/main" id="{6963B065-E27E-151A-2EB8-71FED9BB8B58}"/>
               </a:ext>
             </a:extLst>
           </p:cNvPr>
@@ -12491,7 +12491,7 @@
           <p:cNvPr id="5" name="TextBox 4">
             <a:extLst>
               <a:ext uri="{FF2B5EF4-FFF2-40B4-BE49-F238E27FC236}">
-                <a16:creationId xmlns:a16="http://schemas.microsoft.com/office/drawing/2014/main" id="{6B438FA7-4ECD-F3AF-F771-358698AF86D1}"/>
+                <a16:creationId xmlns:a16="http://schemas.microsoft.com/office/drawing/2014/main" id="{E53C3339-5A08-1ACD-3E70-76A4396D83E6}"/>
               </a:ext>
             </a:extLst>
           </p:cNvPr>
@@ -12531,7 +12531,7 @@
           <p:cNvPr id="6" name="TextBox 5">
             <a:extLst>
               <a:ext uri="{FF2B5EF4-FFF2-40B4-BE49-F238E27FC236}">
-                <a16:creationId xmlns:a16="http://schemas.microsoft.com/office/drawing/2014/main" id="{B69204E0-56AA-08AB-20D3-CB6C583ABACA}"/>
+                <a16:creationId xmlns:a16="http://schemas.microsoft.com/office/drawing/2014/main" id="{6384AB62-3080-952B-CC89-3ACD7BDFC039}"/>
               </a:ext>
             </a:extLst>
           </p:cNvPr>
@@ -12571,7 +12571,7 @@
           <p:cNvPr id="7" name="Rectangle: Rounded Corners 6">
             <a:extLst>
               <a:ext uri="{FF2B5EF4-FFF2-40B4-BE49-F238E27FC236}">
-                <a16:creationId xmlns:a16="http://schemas.microsoft.com/office/drawing/2014/main" id="{C3A15460-2D17-E4A9-E712-827511363C3D}"/>
+                <a16:creationId xmlns:a16="http://schemas.microsoft.com/office/drawing/2014/main" id="{17BB0207-E572-CEE7-EF5F-035DDD4BB0C3}"/>
               </a:ext>
             </a:extLst>
           </p:cNvPr>
@@ -12625,7 +12625,7 @@
           <p:cNvPr id="8" name="TextBox 7">
             <a:extLst>
               <a:ext uri="{FF2B5EF4-FFF2-40B4-BE49-F238E27FC236}">
-                <a16:creationId xmlns:a16="http://schemas.microsoft.com/office/drawing/2014/main" id="{BC562184-C492-233A-80B9-5344C8FC0DFE}"/>
+                <a16:creationId xmlns:a16="http://schemas.microsoft.com/office/drawing/2014/main" id="{2F3647ED-ACE6-61B4-67AF-25423F811859}"/>
               </a:ext>
             </a:extLst>
           </p:cNvPr>
@@ -12665,7 +12665,7 @@
           <p:cNvPr id="9" name="TextBox 8">
             <a:extLst>
               <a:ext uri="{FF2B5EF4-FFF2-40B4-BE49-F238E27FC236}">
-                <a16:creationId xmlns:a16="http://schemas.microsoft.com/office/drawing/2014/main" id="{E6D61DE2-74F0-3AFD-635C-E0C15E5872D6}"/>
+                <a16:creationId xmlns:a16="http://schemas.microsoft.com/office/drawing/2014/main" id="{C19F6136-C7C3-BAAB-8538-289EFA298875}"/>
               </a:ext>
             </a:extLst>
           </p:cNvPr>
@@ -12705,7 +12705,7 @@
           <p:cNvPr id="10" name="TextBox 9">
             <a:extLst>
               <a:ext uri="{FF2B5EF4-FFF2-40B4-BE49-F238E27FC236}">
-                <a16:creationId xmlns:a16="http://schemas.microsoft.com/office/drawing/2014/main" id="{614F1728-2DBD-5F68-8F2A-46E442461092}"/>
+                <a16:creationId xmlns:a16="http://schemas.microsoft.com/office/drawing/2014/main" id="{7B02D158-04E0-AF19-81ED-12E6CF07B8F1}"/>
               </a:ext>
             </a:extLst>
           </p:cNvPr>
@@ -12745,7 +12745,7 @@
           <p:cNvPr id="11" name="TextBox 10">
             <a:extLst>
               <a:ext uri="{FF2B5EF4-FFF2-40B4-BE49-F238E27FC236}">
-                <a16:creationId xmlns:a16="http://schemas.microsoft.com/office/drawing/2014/main" id="{7A9D84F5-18CE-6E66-3A53-8218017AD262}"/>
+                <a16:creationId xmlns:a16="http://schemas.microsoft.com/office/drawing/2014/main" id="{DCD846A1-D597-522E-435A-9C68DD2D8AAB}"/>
               </a:ext>
             </a:extLst>
           </p:cNvPr>
@@ -12785,7 +12785,7 @@
           <p:cNvPr id="12" name="TextBox 11">
             <a:extLst>
               <a:ext uri="{FF2B5EF4-FFF2-40B4-BE49-F238E27FC236}">
-                <a16:creationId xmlns:a16="http://schemas.microsoft.com/office/drawing/2014/main" id="{0A26BE46-6495-4615-A80B-10ADFE2E69EC}"/>
+                <a16:creationId xmlns:a16="http://schemas.microsoft.com/office/drawing/2014/main" id="{A0257BE7-66CF-F06F-E961-E0D99F57A930}"/>
               </a:ext>
             </a:extLst>
           </p:cNvPr>
@@ -12825,7 +12825,7 @@
           <p:cNvPr id="13" name="TextBox 12">
             <a:extLst>
               <a:ext uri="{FF2B5EF4-FFF2-40B4-BE49-F238E27FC236}">
-                <a16:creationId xmlns:a16="http://schemas.microsoft.com/office/drawing/2014/main" id="{2AF1F138-CD3B-E001-7FF5-F462112665E7}"/>
+                <a16:creationId xmlns:a16="http://schemas.microsoft.com/office/drawing/2014/main" id="{369F7E83-A839-BD41-BD87-6FB5BF26A313}"/>
               </a:ext>
             </a:extLst>
           </p:cNvPr>
@@ -12865,7 +12865,7 @@
           <p:cNvPr id="14" name="TextBox 13">
             <a:extLst>
               <a:ext uri="{FF2B5EF4-FFF2-40B4-BE49-F238E27FC236}">
-                <a16:creationId xmlns:a16="http://schemas.microsoft.com/office/drawing/2014/main" id="{EE3B1AB7-E85F-049E-D327-FBDB267C6907}"/>
+                <a16:creationId xmlns:a16="http://schemas.microsoft.com/office/drawing/2014/main" id="{09EB2B06-B1AA-B777-BBE6-636B31C9B200}"/>
               </a:ext>
             </a:extLst>
           </p:cNvPr>
@@ -12891,7 +12891,7 @@
             <a:r>
               <a:rPr lang="en-US" sz="2100" b="1">
                 <a:solidFill>
-                  <a:srgbClr val="3FC6AC"/>
+                  <a:srgbClr val="007565"/>
                 </a:solidFill>
                 <a:latin typeface="Aptos" panose="020B0004020202020204" pitchFamily="34" charset="0"/>
               </a:rPr>
@@ -12905,7 +12905,7 @@
           <p:cNvPr id="15" name="Straight Connector 14">
             <a:extLst>
               <a:ext uri="{FF2B5EF4-FFF2-40B4-BE49-F238E27FC236}">
-                <a16:creationId xmlns:a16="http://schemas.microsoft.com/office/drawing/2014/main" id="{FD87BEE6-F523-6021-ADD7-80F667DFBF75}"/>
+                <a16:creationId xmlns:a16="http://schemas.microsoft.com/office/drawing/2014/main" id="{C26AC877-B5FB-4509-F6A8-39975FD3A315}"/>
               </a:ext>
             </a:extLst>
           </p:cNvPr>
@@ -12946,7 +12946,7 @@
           <p:cNvPr id="16" name="TextBox 15">
             <a:extLst>
               <a:ext uri="{FF2B5EF4-FFF2-40B4-BE49-F238E27FC236}">
-                <a16:creationId xmlns:a16="http://schemas.microsoft.com/office/drawing/2014/main" id="{EEFFC9A3-43B0-78C5-E863-772221D2E7E8}"/>
+                <a16:creationId xmlns:a16="http://schemas.microsoft.com/office/drawing/2014/main" id="{6D3559AA-DFB7-B474-1297-DB7244ED3F30}"/>
               </a:ext>
             </a:extLst>
           </p:cNvPr>
@@ -12986,7 +12986,7 @@
           <p:cNvPr id="17" name="Straight Connector 16">
             <a:extLst>
               <a:ext uri="{FF2B5EF4-FFF2-40B4-BE49-F238E27FC236}">
-                <a16:creationId xmlns:a16="http://schemas.microsoft.com/office/drawing/2014/main" id="{96BDB0F9-D74C-FFAD-ED08-7CFC7BD08878}"/>
+                <a16:creationId xmlns:a16="http://schemas.microsoft.com/office/drawing/2014/main" id="{23ACEDAD-7606-F0E9-5A52-F26B03C92DE8}"/>
               </a:ext>
             </a:extLst>
           </p:cNvPr>
@@ -13027,7 +13027,7 @@
           <p:cNvPr id="18" name="TextBox 17">
             <a:extLst>
               <a:ext uri="{FF2B5EF4-FFF2-40B4-BE49-F238E27FC236}">
-                <a16:creationId xmlns:a16="http://schemas.microsoft.com/office/drawing/2014/main" id="{4E6F68BE-5C98-9C24-11F6-9515DEED7281}"/>
+                <a16:creationId xmlns:a16="http://schemas.microsoft.com/office/drawing/2014/main" id="{69226BA2-E360-6BFC-AC6C-5082D7C79B8B}"/>
               </a:ext>
             </a:extLst>
           </p:cNvPr>
@@ -13067,7 +13067,7 @@
           <p:cNvPr id="19" name="Straight Connector 18">
             <a:extLst>
               <a:ext uri="{FF2B5EF4-FFF2-40B4-BE49-F238E27FC236}">
-                <a16:creationId xmlns:a16="http://schemas.microsoft.com/office/drawing/2014/main" id="{15080366-CA6E-7553-1C3C-9B45B922697F}"/>
+                <a16:creationId xmlns:a16="http://schemas.microsoft.com/office/drawing/2014/main" id="{D1F7B5DC-6FB7-9633-9CDE-38AC577B16B3}"/>
               </a:ext>
             </a:extLst>
           </p:cNvPr>
@@ -13108,7 +13108,7 @@
           <p:cNvPr id="20" name="TextBox 19">
             <a:extLst>
               <a:ext uri="{FF2B5EF4-FFF2-40B4-BE49-F238E27FC236}">
-                <a16:creationId xmlns:a16="http://schemas.microsoft.com/office/drawing/2014/main" id="{7FEAF728-C7E3-5989-4C5F-FFD430486FE8}"/>
+                <a16:creationId xmlns:a16="http://schemas.microsoft.com/office/drawing/2014/main" id="{DC82C407-DF01-4895-2EC8-5B157771CD13}"/>
               </a:ext>
             </a:extLst>
           </p:cNvPr>
@@ -13148,7 +13148,7 @@
           <p:cNvPr id="21" name="Straight Connector 20">
             <a:extLst>
               <a:ext uri="{FF2B5EF4-FFF2-40B4-BE49-F238E27FC236}">
-                <a16:creationId xmlns:a16="http://schemas.microsoft.com/office/drawing/2014/main" id="{2CD9C4C2-B0EB-9184-712E-2CDC3E94E248}"/>
+                <a16:creationId xmlns:a16="http://schemas.microsoft.com/office/drawing/2014/main" id="{689DDF17-8390-7F34-B15E-730073AC3144}"/>
               </a:ext>
             </a:extLst>
           </p:cNvPr>
@@ -13189,7 +13189,7 @@
           <p:cNvPr id="22" name="TextBox 21">
             <a:extLst>
               <a:ext uri="{FF2B5EF4-FFF2-40B4-BE49-F238E27FC236}">
-                <a16:creationId xmlns:a16="http://schemas.microsoft.com/office/drawing/2014/main" id="{0F107D80-23B7-714B-2F7B-69E20885F279}"/>
+                <a16:creationId xmlns:a16="http://schemas.microsoft.com/office/drawing/2014/main" id="{DF966BC8-4BB2-276D-151A-70D0DBE8BED1}"/>
               </a:ext>
             </a:extLst>
           </p:cNvPr>
@@ -13229,7 +13229,7 @@
           <p:cNvPr id="23" name="Straight Connector 22">
             <a:extLst>
               <a:ext uri="{FF2B5EF4-FFF2-40B4-BE49-F238E27FC236}">
-                <a16:creationId xmlns:a16="http://schemas.microsoft.com/office/drawing/2014/main" id="{EB0F30B2-FAEF-B81F-4F52-55C5B4F8CF58}"/>
+                <a16:creationId xmlns:a16="http://schemas.microsoft.com/office/drawing/2014/main" id="{3D8478D6-F416-58E0-0239-C9685687E5DE}"/>
               </a:ext>
             </a:extLst>
           </p:cNvPr>
@@ -13270,7 +13270,7 @@
           <p:cNvPr id="24" name="TextBox 23">
             <a:extLst>
               <a:ext uri="{FF2B5EF4-FFF2-40B4-BE49-F238E27FC236}">
-                <a16:creationId xmlns:a16="http://schemas.microsoft.com/office/drawing/2014/main" id="{F59631F6-6158-0FF4-1C71-FC699FA56D89}"/>
+                <a16:creationId xmlns:a16="http://schemas.microsoft.com/office/drawing/2014/main" id="{C1CB8D0A-DF07-E72F-3B81-F8E154CA726D}"/>
               </a:ext>
             </a:extLst>
           </p:cNvPr>
@@ -13310,7 +13310,7 @@
           <p:cNvPr id="25" name="TextBox 24">
             <a:extLst>
               <a:ext uri="{FF2B5EF4-FFF2-40B4-BE49-F238E27FC236}">
-                <a16:creationId xmlns:a16="http://schemas.microsoft.com/office/drawing/2014/main" id="{1EF42986-EEE7-5FFE-F91C-E5F3C2345D65}"/>
+                <a16:creationId xmlns:a16="http://schemas.microsoft.com/office/drawing/2014/main" id="{17329D04-920C-AED8-9C75-4679607FC97A}"/>
               </a:ext>
             </a:extLst>
           </p:cNvPr>
@@ -13336,7 +13336,7 @@
             <a:r>
               <a:rPr lang="en-US" sz="2000" b="1">
                 <a:solidFill>
-                  <a:srgbClr val="E0B957"/>
+                  <a:srgbClr val="835D0A"/>
                 </a:solidFill>
                 <a:latin typeface="Aptos" panose="020B0004020202020204" pitchFamily="34" charset="0"/>
               </a:rPr>
@@ -13350,7 +13350,7 @@
           <p:cNvPr id="26" name="TextBox 25">
             <a:extLst>
               <a:ext uri="{FF2B5EF4-FFF2-40B4-BE49-F238E27FC236}">
-                <a16:creationId xmlns:a16="http://schemas.microsoft.com/office/drawing/2014/main" id="{AA0CF4A5-2C57-487C-D4CE-CC77ACF137F0}"/>
+                <a16:creationId xmlns:a16="http://schemas.microsoft.com/office/drawing/2014/main" id="{93117975-8CCB-DBBF-87F9-0D15FF5500F4}"/>
               </a:ext>
             </a:extLst>
           </p:cNvPr>
@@ -13376,11 +13376,11 @@
             <a:r>
               <a:rPr lang="en-US" sz="3800" b="1">
                 <a:solidFill>
-                  <a:srgbClr val="3FC6AC"/>
-                </a:solidFill>
-                <a:latin typeface="Aptos" panose="020B0004020202020204" pitchFamily="34" charset="0"/>
-              </a:rPr>
-              <a:t>23.51</a:t>
+                  <a:srgbClr val="007565"/>
+                </a:solidFill>
+                <a:latin typeface="Aptos" panose="020B0004020202020204" pitchFamily="34" charset="0"/>
+              </a:rPr>
+              <a:t>23.510</a:t>
             </a:r>
           </a:p>
         </p:txBody>
@@ -13390,7 +13390,7 @@
           <p:cNvPr id="27" name="TextBox 26">
             <a:extLst>
               <a:ext uri="{FF2B5EF4-FFF2-40B4-BE49-F238E27FC236}">
-                <a16:creationId xmlns:a16="http://schemas.microsoft.com/office/drawing/2014/main" id="{2EEC55D0-884B-5A25-12EC-D2A0F583DC71}"/>
+                <a16:creationId xmlns:a16="http://schemas.microsoft.com/office/drawing/2014/main" id="{DBB03748-749C-1BD9-EF6A-A2F6B54DF20E}"/>
               </a:ext>
             </a:extLst>
           </p:cNvPr>
@@ -13430,7 +13430,7 @@
           <p:cNvPr id="28" name="TextBox 27">
             <a:extLst>
               <a:ext uri="{FF2B5EF4-FFF2-40B4-BE49-F238E27FC236}">
-                <a16:creationId xmlns:a16="http://schemas.microsoft.com/office/drawing/2014/main" id="{799EB0A6-A7DF-A40F-8290-2A0DAFF7A684}"/>
+                <a16:creationId xmlns:a16="http://schemas.microsoft.com/office/drawing/2014/main" id="{D13AADB6-2188-DE52-01B8-9DF3C2B81186}"/>
               </a:ext>
             </a:extLst>
           </p:cNvPr>
@@ -13460,7 +13460,7 @@
                 </a:solidFill>
                 <a:latin typeface="Aptos" panose="020B0004020202020204" pitchFamily="34" charset="0"/>
               </a:rPr>
-              <a:t>15.07</a:t>
+              <a:t>15.072</a:t>
             </a:r>
           </a:p>
         </p:txBody>
@@ -13470,7 +13470,7 @@
           <p:cNvPr id="29" name="TextBox 28">
             <a:extLst>
               <a:ext uri="{FF2B5EF4-FFF2-40B4-BE49-F238E27FC236}">
-                <a16:creationId xmlns:a16="http://schemas.microsoft.com/office/drawing/2014/main" id="{F1912F28-D80F-13C3-DA6F-A16396AA6B2B}"/>
+                <a16:creationId xmlns:a16="http://schemas.microsoft.com/office/drawing/2014/main" id="{330E43A1-A1AE-36CF-A71D-9F60A2AA46E3}"/>
               </a:ext>
             </a:extLst>
           </p:cNvPr>
@@ -13510,7 +13510,7 @@
           <p:cNvPr id="30" name="TextBox 29">
             <a:extLst>
               <a:ext uri="{FF2B5EF4-FFF2-40B4-BE49-F238E27FC236}">
-                <a16:creationId xmlns:a16="http://schemas.microsoft.com/office/drawing/2014/main" id="{C7A648DC-8459-2DC2-B5A9-BD45F84F064E}"/>
+                <a16:creationId xmlns:a16="http://schemas.microsoft.com/office/drawing/2014/main" id="{FDA2A1C6-3336-1082-B873-0633F8B507C5}"/>
               </a:ext>
             </a:extLst>
           </p:cNvPr>
@@ -13536,7 +13536,7 @@
             <a:r>
               <a:rPr lang="en-US" sz="1700" b="1">
                 <a:solidFill>
-                  <a:srgbClr val="E0B957"/>
+                  <a:srgbClr val="835D0A"/>
                 </a:solidFill>
                 <a:latin typeface="Aptos" panose="020B0004020202020204" pitchFamily="34" charset="0"/>
               </a:rPr>
@@ -13550,7 +13550,7 @@
           <p:cNvPr id="31" name="TextBox 30">
             <a:extLst>
               <a:ext uri="{FF2B5EF4-FFF2-40B4-BE49-F238E27FC236}">
-                <a16:creationId xmlns:a16="http://schemas.microsoft.com/office/drawing/2014/main" id="{960E426E-2055-6986-B297-EAD87224B20C}"/>
+                <a16:creationId xmlns:a16="http://schemas.microsoft.com/office/drawing/2014/main" id="{49FE8154-7C58-2A1C-8C22-223907C3536C}"/>
               </a:ext>
             </a:extLst>
           </p:cNvPr>
@@ -13590,7 +13590,7 @@
           <p:cNvPr id="32" name="TextBox 31">
             <a:extLst>
               <a:ext uri="{FF2B5EF4-FFF2-40B4-BE49-F238E27FC236}">
-                <a16:creationId xmlns:a16="http://schemas.microsoft.com/office/drawing/2014/main" id="{58A0F063-C533-72FC-5094-2A15C9598F80}"/>
+                <a16:creationId xmlns:a16="http://schemas.microsoft.com/office/drawing/2014/main" id="{5575EA26-C398-82E2-4385-D3B353650863}"/>
               </a:ext>
             </a:extLst>
           </p:cNvPr>
@@ -13628,7 +13628,7 @@
     </p:spTree>
     <p:extLst>
       <p:ext uri="{BB962C8B-B14F-4D97-AF65-F5344CB8AC3E}">
-        <p14:creationId xmlns:p14="http://schemas.microsoft.com/office/powerpoint/2010/main" val="597389037"/>
+        <p14:creationId xmlns:p14="http://schemas.microsoft.com/office/powerpoint/2010/main" val="3374120386"/>
       </p:ext>
     </p:extLst>
   </p:cSld>
@@ -13668,7 +13668,7 @@
           <p:cNvPr id="2" name="TextBox 1">
             <a:extLst>
               <a:ext uri="{FF2B5EF4-FFF2-40B4-BE49-F238E27FC236}">
-                <a16:creationId xmlns:a16="http://schemas.microsoft.com/office/drawing/2014/main" id="{FFBBE9B4-2465-E1C8-0728-92685A457B00}"/>
+                <a16:creationId xmlns:a16="http://schemas.microsoft.com/office/drawing/2014/main" id="{8D210207-1BB1-589D-2EDB-C3B437419A09}"/>
               </a:ext>
             </a:extLst>
           </p:cNvPr>
@@ -13708,7 +13708,7 @@
           <p:cNvPr id="3" name="Straight Connector 2">
             <a:extLst>
               <a:ext uri="{FF2B5EF4-FFF2-40B4-BE49-F238E27FC236}">
-                <a16:creationId xmlns:a16="http://schemas.microsoft.com/office/drawing/2014/main" id="{2D7C9CA5-EE5E-6B77-5CA7-5CC6BA11B26F}"/>
+                <a16:creationId xmlns:a16="http://schemas.microsoft.com/office/drawing/2014/main" id="{5B571D8F-8876-1472-7622-BA4802427768}"/>
               </a:ext>
             </a:extLst>
           </p:cNvPr>
@@ -13749,7 +13749,7 @@
           <p:cNvPr id="4" name="TextBox 3">
             <a:extLst>
               <a:ext uri="{FF2B5EF4-FFF2-40B4-BE49-F238E27FC236}">
-                <a16:creationId xmlns:a16="http://schemas.microsoft.com/office/drawing/2014/main" id="{4D95D222-838C-91E1-7E41-3F98C2A69106}"/>
+                <a16:creationId xmlns:a16="http://schemas.microsoft.com/office/drawing/2014/main" id="{58B7DCE9-340E-1802-F2AA-98884662C97F}"/>
               </a:ext>
             </a:extLst>
           </p:cNvPr>
@@ -13790,7 +13790,7 @@
           <p:cNvPr id="5" name="TextBox 4">
             <a:extLst>
               <a:ext uri="{FF2B5EF4-FFF2-40B4-BE49-F238E27FC236}">
-                <a16:creationId xmlns:a16="http://schemas.microsoft.com/office/drawing/2014/main" id="{8164E32C-7E14-0D4A-D19A-FF8FE0E2C3E6}"/>
+                <a16:creationId xmlns:a16="http://schemas.microsoft.com/office/drawing/2014/main" id="{267FEC84-D22C-D4BC-FB55-0BE5EF2D845B}"/>
               </a:ext>
             </a:extLst>
           </p:cNvPr>
@@ -13830,7 +13830,7 @@
           <p:cNvPr id="6" name="TextBox 5">
             <a:extLst>
               <a:ext uri="{FF2B5EF4-FFF2-40B4-BE49-F238E27FC236}">
-                <a16:creationId xmlns:a16="http://schemas.microsoft.com/office/drawing/2014/main" id="{0C5BBF17-3268-9E06-6010-FC4238DB80F1}"/>
+                <a16:creationId xmlns:a16="http://schemas.microsoft.com/office/drawing/2014/main" id="{BE72F938-3FD6-3074-1B86-7B33CC63D963}"/>
               </a:ext>
             </a:extLst>
           </p:cNvPr>
@@ -13870,7 +13870,7 @@
           <p:cNvPr id="7" name="Straight Connector 6">
             <a:extLst>
               <a:ext uri="{FF2B5EF4-FFF2-40B4-BE49-F238E27FC236}">
-                <a16:creationId xmlns:a16="http://schemas.microsoft.com/office/drawing/2014/main" id="{7C09F615-3B44-646C-E766-A58D5758D17F}"/>
+                <a16:creationId xmlns:a16="http://schemas.microsoft.com/office/drawing/2014/main" id="{B048DAA2-7DCE-2FF5-3380-6BE94887EA3C}"/>
               </a:ext>
             </a:extLst>
           </p:cNvPr>
@@ -13912,7 +13912,7 @@
           <p:cNvPr id="8" name="Straight Connector 7">
             <a:extLst>
               <a:ext uri="{FF2B5EF4-FFF2-40B4-BE49-F238E27FC236}">
-                <a16:creationId xmlns:a16="http://schemas.microsoft.com/office/drawing/2014/main" id="{298F579F-3396-30DA-1F7D-BB78F97B29C6}"/>
+                <a16:creationId xmlns:a16="http://schemas.microsoft.com/office/drawing/2014/main" id="{0AF8CDA9-E136-825A-B074-95BF68F13F0E}"/>
               </a:ext>
             </a:extLst>
           </p:cNvPr>
@@ -13954,7 +13954,7 @@
           <p:cNvPr id="9" name="Rectangle: Rounded Corners 8">
             <a:extLst>
               <a:ext uri="{FF2B5EF4-FFF2-40B4-BE49-F238E27FC236}">
-                <a16:creationId xmlns:a16="http://schemas.microsoft.com/office/drawing/2014/main" id="{83AC890C-E878-1B42-64C3-EE8478B549A3}"/>
+                <a16:creationId xmlns:a16="http://schemas.microsoft.com/office/drawing/2014/main" id="{B4CDCCEF-7BDC-B048-9609-78E4B6E3874C}"/>
               </a:ext>
             </a:extLst>
           </p:cNvPr>
@@ -14022,7 +14022,7 @@
           <p:cNvPr id="10" name="TextBox 9">
             <a:extLst>
               <a:ext uri="{FF2B5EF4-FFF2-40B4-BE49-F238E27FC236}">
-                <a16:creationId xmlns:a16="http://schemas.microsoft.com/office/drawing/2014/main" id="{790FD82E-E4C4-160B-DFFC-450D9D5B517A}"/>
+                <a16:creationId xmlns:a16="http://schemas.microsoft.com/office/drawing/2014/main" id="{F95C935E-969E-1846-D024-6243324A8C64}"/>
               </a:ext>
             </a:extLst>
           </p:cNvPr>
@@ -14063,7 +14063,7 @@
           <p:cNvPr id="11" name="TextBox 10">
             <a:extLst>
               <a:ext uri="{FF2B5EF4-FFF2-40B4-BE49-F238E27FC236}">
-                <a16:creationId xmlns:a16="http://schemas.microsoft.com/office/drawing/2014/main" id="{F6522E61-EACC-067E-5F56-D94FAE7BA4D7}"/>
+                <a16:creationId xmlns:a16="http://schemas.microsoft.com/office/drawing/2014/main" id="{BA3758D7-1C29-786A-A1DF-62966EC517D6}"/>
               </a:ext>
             </a:extLst>
           </p:cNvPr>
@@ -14134,7 +14134,7 @@
           <p:cNvPr id="12" name="Rectangle: Rounded Corners 11">
             <a:extLst>
               <a:ext uri="{FF2B5EF4-FFF2-40B4-BE49-F238E27FC236}">
-                <a16:creationId xmlns:a16="http://schemas.microsoft.com/office/drawing/2014/main" id="{848CA157-0493-D6A3-3614-456FC1D06039}"/>
+                <a16:creationId xmlns:a16="http://schemas.microsoft.com/office/drawing/2014/main" id="{A01B975D-4A04-4EAF-BF83-4ABA566BADC9}"/>
               </a:ext>
             </a:extLst>
           </p:cNvPr>
@@ -14202,7 +14202,7 @@
           <p:cNvPr id="13" name="TextBox 12">
             <a:extLst>
               <a:ext uri="{FF2B5EF4-FFF2-40B4-BE49-F238E27FC236}">
-                <a16:creationId xmlns:a16="http://schemas.microsoft.com/office/drawing/2014/main" id="{D68CDF42-A356-3C3C-2828-73FD5D6AF142}"/>
+                <a16:creationId xmlns:a16="http://schemas.microsoft.com/office/drawing/2014/main" id="{1A76748E-E749-C07F-891E-296FFE0BCB12}"/>
               </a:ext>
             </a:extLst>
           </p:cNvPr>
@@ -14243,7 +14243,7 @@
           <p:cNvPr id="14" name="TextBox 13">
             <a:extLst>
               <a:ext uri="{FF2B5EF4-FFF2-40B4-BE49-F238E27FC236}">
-                <a16:creationId xmlns:a16="http://schemas.microsoft.com/office/drawing/2014/main" id="{4AE02975-78B5-40C1-425A-FD828C893F8A}"/>
+                <a16:creationId xmlns:a16="http://schemas.microsoft.com/office/drawing/2014/main" id="{5AC4614E-92F6-3C3A-26EC-71835D9B9E4C}"/>
               </a:ext>
             </a:extLst>
           </p:cNvPr>
@@ -14296,7 +14296,7 @@
           <p:cNvPr id="15" name="Rectangle: Rounded Corners 14">
             <a:extLst>
               <a:ext uri="{FF2B5EF4-FFF2-40B4-BE49-F238E27FC236}">
-                <a16:creationId xmlns:a16="http://schemas.microsoft.com/office/drawing/2014/main" id="{BC9FED9B-F937-D7DF-8C54-D3288D3713AA}"/>
+                <a16:creationId xmlns:a16="http://schemas.microsoft.com/office/drawing/2014/main" id="{A038455C-BA33-4A86-6FA6-F642FC32FB3D}"/>
               </a:ext>
             </a:extLst>
           </p:cNvPr>
@@ -14364,7 +14364,7 @@
           <p:cNvPr id="16" name="TextBox 15">
             <a:extLst>
               <a:ext uri="{FF2B5EF4-FFF2-40B4-BE49-F238E27FC236}">
-                <a16:creationId xmlns:a16="http://schemas.microsoft.com/office/drawing/2014/main" id="{852926FD-4CEC-E286-A166-79C1662B5D51}"/>
+                <a16:creationId xmlns:a16="http://schemas.microsoft.com/office/drawing/2014/main" id="{A0AB76C3-8368-61D1-6BC8-8D8518CABA7F}"/>
               </a:ext>
             </a:extLst>
           </p:cNvPr>
@@ -14405,7 +14405,7 @@
           <p:cNvPr id="17" name="TextBox 16">
             <a:extLst>
               <a:ext uri="{FF2B5EF4-FFF2-40B4-BE49-F238E27FC236}">
-                <a16:creationId xmlns:a16="http://schemas.microsoft.com/office/drawing/2014/main" id="{D218C291-CE54-FBDA-4497-E2A03B22D555}"/>
+                <a16:creationId xmlns:a16="http://schemas.microsoft.com/office/drawing/2014/main" id="{9436BFC8-B89A-5F58-DB54-D25BC18AEB42}"/>
               </a:ext>
             </a:extLst>
           </p:cNvPr>
@@ -14470,7 +14470,7 @@
           <p:cNvPr id="18" name="Straight Connector 17">
             <a:extLst>
               <a:ext uri="{FF2B5EF4-FFF2-40B4-BE49-F238E27FC236}">
-                <a16:creationId xmlns:a16="http://schemas.microsoft.com/office/drawing/2014/main" id="{079BBF49-62C9-DA9F-FFEF-D6CDA8044020}"/>
+                <a16:creationId xmlns:a16="http://schemas.microsoft.com/office/drawing/2014/main" id="{D81C76B6-87C6-38D2-64BA-53BD3EC89D23}"/>
               </a:ext>
             </a:extLst>
           </p:cNvPr>
@@ -14511,7 +14511,7 @@
           <p:cNvPr id="19" name="TextBox 18">
             <a:extLst>
               <a:ext uri="{FF2B5EF4-FFF2-40B4-BE49-F238E27FC236}">
-                <a16:creationId xmlns:a16="http://schemas.microsoft.com/office/drawing/2014/main" id="{D540E6FA-7BB8-13A7-2761-F99DC6E8B0E3}"/>
+                <a16:creationId xmlns:a16="http://schemas.microsoft.com/office/drawing/2014/main" id="{9E410136-3832-59D9-D330-A399BB86E0A8}"/>
               </a:ext>
             </a:extLst>
           </p:cNvPr>
@@ -14551,7 +14551,7 @@
           <p:cNvPr id="20" name="Straight Connector 19">
             <a:extLst>
               <a:ext uri="{FF2B5EF4-FFF2-40B4-BE49-F238E27FC236}">
-                <a16:creationId xmlns:a16="http://schemas.microsoft.com/office/drawing/2014/main" id="{426FCB84-9B8D-57CF-3A5D-079F75E25E11}"/>
+                <a16:creationId xmlns:a16="http://schemas.microsoft.com/office/drawing/2014/main" id="{C9BEDFD2-534F-1E12-58C4-E2C4BA81D039}"/>
               </a:ext>
             </a:extLst>
           </p:cNvPr>
@@ -14592,7 +14592,7 @@
           <p:cNvPr id="21" name="TextBox 20">
             <a:extLst>
               <a:ext uri="{FF2B5EF4-FFF2-40B4-BE49-F238E27FC236}">
-                <a16:creationId xmlns:a16="http://schemas.microsoft.com/office/drawing/2014/main" id="{1FE3EDFC-F7DF-A602-1EFA-F43BA459F326}"/>
+                <a16:creationId xmlns:a16="http://schemas.microsoft.com/office/drawing/2014/main" id="{E0F36466-E1FD-B184-9E66-C8F31D6785C0}"/>
               </a:ext>
             </a:extLst>
           </p:cNvPr>
@@ -14632,7 +14632,7 @@
           <p:cNvPr id="22" name="Straight Connector 21">
             <a:extLst>
               <a:ext uri="{FF2B5EF4-FFF2-40B4-BE49-F238E27FC236}">
-                <a16:creationId xmlns:a16="http://schemas.microsoft.com/office/drawing/2014/main" id="{28FEE2AB-46FD-6FA5-8D67-B64FC395C2F3}"/>
+                <a16:creationId xmlns:a16="http://schemas.microsoft.com/office/drawing/2014/main" id="{317B6041-95BF-B7B6-A33E-BF8460A127ED}"/>
               </a:ext>
             </a:extLst>
           </p:cNvPr>
@@ -14673,7 +14673,7 @@
           <p:cNvPr id="23" name="TextBox 22">
             <a:extLst>
               <a:ext uri="{FF2B5EF4-FFF2-40B4-BE49-F238E27FC236}">
-                <a16:creationId xmlns:a16="http://schemas.microsoft.com/office/drawing/2014/main" id="{BCF841D7-926E-2330-7B9D-2988A0B05A2E}"/>
+                <a16:creationId xmlns:a16="http://schemas.microsoft.com/office/drawing/2014/main" id="{3958E91B-C0A6-54F4-DBBF-8E45193C5C7C}"/>
               </a:ext>
             </a:extLst>
           </p:cNvPr>
@@ -14711,7 +14711,7 @@
     </p:spTree>
     <p:extLst>
       <p:ext uri="{BB962C8B-B14F-4D97-AF65-F5344CB8AC3E}">
-        <p14:creationId xmlns:p14="http://schemas.microsoft.com/office/powerpoint/2010/main" val="2508960389"/>
+        <p14:creationId xmlns:p14="http://schemas.microsoft.com/office/powerpoint/2010/main" val="3272817024"/>
       </p:ext>
     </p:extLst>
   </p:cSld>
@@ -14751,7 +14751,7 @@
           <p:cNvPr id="2" name="TextBox 1">
             <a:extLst>
               <a:ext uri="{FF2B5EF4-FFF2-40B4-BE49-F238E27FC236}">
-                <a16:creationId xmlns:a16="http://schemas.microsoft.com/office/drawing/2014/main" id="{9AA57882-1F64-84F3-D1BD-933D2CDDF307}"/>
+                <a16:creationId xmlns:a16="http://schemas.microsoft.com/office/drawing/2014/main" id="{5558EB8B-BCCF-5FC4-A993-34022F6B06A1}"/>
               </a:ext>
             </a:extLst>
           </p:cNvPr>
@@ -14791,7 +14791,7 @@
           <p:cNvPr id="3" name="Straight Connector 2">
             <a:extLst>
               <a:ext uri="{FF2B5EF4-FFF2-40B4-BE49-F238E27FC236}">
-                <a16:creationId xmlns:a16="http://schemas.microsoft.com/office/drawing/2014/main" id="{08468497-218F-2D9E-D1BC-8EB1D8C5F885}"/>
+                <a16:creationId xmlns:a16="http://schemas.microsoft.com/office/drawing/2014/main" id="{4AD1D23D-2502-16D7-6457-1E16DB531E7D}"/>
               </a:ext>
             </a:extLst>
           </p:cNvPr>
@@ -14832,7 +14832,7 @@
           <p:cNvPr id="4" name="TextBox 3">
             <a:extLst>
               <a:ext uri="{FF2B5EF4-FFF2-40B4-BE49-F238E27FC236}">
-                <a16:creationId xmlns:a16="http://schemas.microsoft.com/office/drawing/2014/main" id="{6E798957-2059-7167-591E-90D0AC0CD5A8}"/>
+                <a16:creationId xmlns:a16="http://schemas.microsoft.com/office/drawing/2014/main" id="{8B05AE93-E841-2736-2528-1DF7C9DFFEBD}"/>
               </a:ext>
             </a:extLst>
           </p:cNvPr>
@@ -14873,7 +14873,7 @@
           <p:cNvPr id="5" name="TextBox 4">
             <a:extLst>
               <a:ext uri="{FF2B5EF4-FFF2-40B4-BE49-F238E27FC236}">
-                <a16:creationId xmlns:a16="http://schemas.microsoft.com/office/drawing/2014/main" id="{798FD7C3-A528-8FF8-A5BC-7A6003414A9F}"/>
+                <a16:creationId xmlns:a16="http://schemas.microsoft.com/office/drawing/2014/main" id="{8997F13B-56E6-F18A-6328-9AA4F6CE21AE}"/>
               </a:ext>
             </a:extLst>
           </p:cNvPr>
@@ -14913,7 +14913,7 @@
           <p:cNvPr id="6" name="TextBox 5">
             <a:extLst>
               <a:ext uri="{FF2B5EF4-FFF2-40B4-BE49-F238E27FC236}">
-                <a16:creationId xmlns:a16="http://schemas.microsoft.com/office/drawing/2014/main" id="{5F55D902-B2A5-5B1B-0F8B-39CB6B60B88F}"/>
+                <a16:creationId xmlns:a16="http://schemas.microsoft.com/office/drawing/2014/main" id="{77B3B7DB-12A0-E7EE-4657-27B0EF19D352}"/>
               </a:ext>
             </a:extLst>
           </p:cNvPr>
@@ -14953,7 +14953,7 @@
           <p:cNvPr id="7" name="Rectangle: Rounded Corners 6">
             <a:extLst>
               <a:ext uri="{FF2B5EF4-FFF2-40B4-BE49-F238E27FC236}">
-                <a16:creationId xmlns:a16="http://schemas.microsoft.com/office/drawing/2014/main" id="{7067AE82-E506-1C68-89FF-F3AACD195B02}"/>
+                <a16:creationId xmlns:a16="http://schemas.microsoft.com/office/drawing/2014/main" id="{20874A89-54BA-934F-2376-8EBA91FC354B}"/>
               </a:ext>
             </a:extLst>
           </p:cNvPr>
@@ -15007,7 +15007,7 @@
           <p:cNvPr id="9" name="Picture 8" descr="Live Scenario page showing one shared GPU scenario and locality detail">
             <a:extLst>
               <a:ext uri="{FF2B5EF4-FFF2-40B4-BE49-F238E27FC236}">
-                <a16:creationId xmlns:a16="http://schemas.microsoft.com/office/drawing/2014/main" id="{E246104B-1B66-9963-CBAF-8C5297087486}"/>
+                <a16:creationId xmlns:a16="http://schemas.microsoft.com/office/drawing/2014/main" id="{8F2C84C4-4F42-E109-AF44-AA6BE90A01E1}"/>
               </a:ext>
             </a:extLst>
           </p:cNvPr>
@@ -15030,8 +15030,8 @@
         </p:blipFill>
         <p:spPr>
           <a:xfrm>
-            <a:off x="876300" y="1689100"/>
-            <a:ext cx="10439400" cy="4292600"/>
+            <a:off x="2278494" y="1689100"/>
+            <a:ext cx="7635011" cy="4292600"/>
           </a:xfrm>
           <a:prstGeom prst="rect">
             <a:avLst/>
@@ -15043,7 +15043,7 @@
           <p:cNvPr id="10" name="TextBox 9">
             <a:extLst>
               <a:ext uri="{FF2B5EF4-FFF2-40B4-BE49-F238E27FC236}">
-                <a16:creationId xmlns:a16="http://schemas.microsoft.com/office/drawing/2014/main" id="{C79B204A-ED20-F96A-EE2D-B38DB3BE8D5F}"/>
+                <a16:creationId xmlns:a16="http://schemas.microsoft.com/office/drawing/2014/main" id="{698AE357-BB4C-1AE7-BD7E-2B08D467D1E7}"/>
               </a:ext>
             </a:extLst>
           </p:cNvPr>
@@ -15070,7 +15070,7 @@
             <a:r>
               <a:rPr lang="en-US" sz="1600" b="1">
                 <a:solidFill>
-                  <a:srgbClr val="3FC6AC"/>
+                  <a:srgbClr val="007565"/>
                 </a:solidFill>
                 <a:latin typeface="Aptos" panose="020B0004020202020204" pitchFamily="34" charset="0"/>
               </a:rPr>
@@ -15082,7 +15082,7 @@
     </p:spTree>
     <p:extLst>
       <p:ext uri="{BB962C8B-B14F-4D97-AF65-F5344CB8AC3E}">
-        <p14:creationId xmlns:p14="http://schemas.microsoft.com/office/powerpoint/2010/main" val="3267870797"/>
+        <p14:creationId xmlns:p14="http://schemas.microsoft.com/office/powerpoint/2010/main" val="1588007612"/>
       </p:ext>
     </p:extLst>
   </p:cSld>
@@ -15122,7 +15122,7 @@
           <p:cNvPr id="2" name="TextBox 1">
             <a:extLst>
               <a:ext uri="{FF2B5EF4-FFF2-40B4-BE49-F238E27FC236}">
-                <a16:creationId xmlns:a16="http://schemas.microsoft.com/office/drawing/2014/main" id="{FC2B901D-D014-90E6-5F99-CBA06C5CBA20}"/>
+                <a16:creationId xmlns:a16="http://schemas.microsoft.com/office/drawing/2014/main" id="{FC45EBBE-5F11-3690-BBC0-CC36F4D6BF0E}"/>
               </a:ext>
             </a:extLst>
           </p:cNvPr>
@@ -15162,7 +15162,7 @@
           <p:cNvPr id="3" name="Straight Connector 2">
             <a:extLst>
               <a:ext uri="{FF2B5EF4-FFF2-40B4-BE49-F238E27FC236}">
-                <a16:creationId xmlns:a16="http://schemas.microsoft.com/office/drawing/2014/main" id="{210E60F0-F8B8-299E-161F-D09A38ECDA34}"/>
+                <a16:creationId xmlns:a16="http://schemas.microsoft.com/office/drawing/2014/main" id="{D8224D32-BDC9-8D50-BBDE-BD58FE686562}"/>
               </a:ext>
             </a:extLst>
           </p:cNvPr>
@@ -15203,7 +15203,7 @@
           <p:cNvPr id="4" name="TextBox 3">
             <a:extLst>
               <a:ext uri="{FF2B5EF4-FFF2-40B4-BE49-F238E27FC236}">
-                <a16:creationId xmlns:a16="http://schemas.microsoft.com/office/drawing/2014/main" id="{8DDA1F04-DC62-DDD5-0CB7-DCC62FD3075E}"/>
+                <a16:creationId xmlns:a16="http://schemas.microsoft.com/office/drawing/2014/main" id="{52A79997-F949-BCA5-94B3-732A59E91708}"/>
               </a:ext>
             </a:extLst>
           </p:cNvPr>
@@ -15244,7 +15244,7 @@
           <p:cNvPr id="5" name="TextBox 4">
             <a:extLst>
               <a:ext uri="{FF2B5EF4-FFF2-40B4-BE49-F238E27FC236}">
-                <a16:creationId xmlns:a16="http://schemas.microsoft.com/office/drawing/2014/main" id="{3521CA99-9758-6399-68A5-D98E492125FD}"/>
+                <a16:creationId xmlns:a16="http://schemas.microsoft.com/office/drawing/2014/main" id="{5607963E-8A6D-8383-3088-A71DF6EFF29C}"/>
               </a:ext>
             </a:extLst>
           </p:cNvPr>
@@ -15284,7 +15284,7 @@
           <p:cNvPr id="6" name="TextBox 5">
             <a:extLst>
               <a:ext uri="{FF2B5EF4-FFF2-40B4-BE49-F238E27FC236}">
-                <a16:creationId xmlns:a16="http://schemas.microsoft.com/office/drawing/2014/main" id="{FA811394-1780-00E5-6D17-77CBD1CD21D9}"/>
+                <a16:creationId xmlns:a16="http://schemas.microsoft.com/office/drawing/2014/main" id="{59AEEA16-A0C9-4E8A-9CD3-8E70FAAF0F06}"/>
               </a:ext>
             </a:extLst>
           </p:cNvPr>
@@ -15324,7 +15324,7 @@
           <p:cNvPr id="7" name="TextBox 6">
             <a:extLst>
               <a:ext uri="{FF2B5EF4-FFF2-40B4-BE49-F238E27FC236}">
-                <a16:creationId xmlns:a16="http://schemas.microsoft.com/office/drawing/2014/main" id="{F2EA7674-6404-9989-6460-4C01809FBF8A}"/>
+                <a16:creationId xmlns:a16="http://schemas.microsoft.com/office/drawing/2014/main" id="{5A8B9F2E-D97C-3D72-2336-291FBA547104}"/>
               </a:ext>
             </a:extLst>
           </p:cNvPr>
@@ -15364,7 +15364,7 @@
           <p:cNvPr id="8" name="TextBox 7">
             <a:extLst>
               <a:ext uri="{FF2B5EF4-FFF2-40B4-BE49-F238E27FC236}">
-                <a16:creationId xmlns:a16="http://schemas.microsoft.com/office/drawing/2014/main" id="{0A0B15D5-AECC-8A93-9AB4-632318C925B6}"/>
+                <a16:creationId xmlns:a16="http://schemas.microsoft.com/office/drawing/2014/main" id="{29950C7A-C0F5-BB70-56BB-850047FA5D7E}"/>
               </a:ext>
             </a:extLst>
           </p:cNvPr>
@@ -15404,7 +15404,7 @@
           <p:cNvPr id="9" name="TextBox 8">
             <a:extLst>
               <a:ext uri="{FF2B5EF4-FFF2-40B4-BE49-F238E27FC236}">
-                <a16:creationId xmlns:a16="http://schemas.microsoft.com/office/drawing/2014/main" id="{47175782-D733-8394-4D84-0934D98FEDE0}"/>
+                <a16:creationId xmlns:a16="http://schemas.microsoft.com/office/drawing/2014/main" id="{B994A1EE-FC7C-695B-C5B7-1B5CFBCD5586}"/>
               </a:ext>
             </a:extLst>
           </p:cNvPr>
@@ -15444,7 +15444,7 @@
           <p:cNvPr id="10" name="TextBox 9">
             <a:extLst>
               <a:ext uri="{FF2B5EF4-FFF2-40B4-BE49-F238E27FC236}">
-                <a16:creationId xmlns:a16="http://schemas.microsoft.com/office/drawing/2014/main" id="{499E06D8-CE24-E349-7083-61CAC4B6B850}"/>
+                <a16:creationId xmlns:a16="http://schemas.microsoft.com/office/drawing/2014/main" id="{EFE74E20-ED1E-927C-6A52-A968720125A3}"/>
               </a:ext>
             </a:extLst>
           </p:cNvPr>
@@ -15484,7 +15484,7 @@
           <p:cNvPr id="11" name="TextBox 10">
             <a:extLst>
               <a:ext uri="{FF2B5EF4-FFF2-40B4-BE49-F238E27FC236}">
-                <a16:creationId xmlns:a16="http://schemas.microsoft.com/office/drawing/2014/main" id="{CE8DABAD-03ED-C9D4-DC84-1B4AEC3ABB30}"/>
+                <a16:creationId xmlns:a16="http://schemas.microsoft.com/office/drawing/2014/main" id="{2B635157-2F9C-A7FA-CE5C-AA8FCE3A40D1}"/>
               </a:ext>
             </a:extLst>
           </p:cNvPr>
@@ -15524,7 +15524,7 @@
           <p:cNvPr id="12" name="Rectangle 11">
             <a:extLst>
               <a:ext uri="{FF2B5EF4-FFF2-40B4-BE49-F238E27FC236}">
-                <a16:creationId xmlns:a16="http://schemas.microsoft.com/office/drawing/2014/main" id="{02E955F8-9185-DE7A-2DF5-F60BF0AFC59A}"/>
+                <a16:creationId xmlns:a16="http://schemas.microsoft.com/office/drawing/2014/main" id="{BC8EF1A5-48ED-57B5-A959-220BDEA5A53D}"/>
               </a:ext>
             </a:extLst>
           </p:cNvPr>
@@ -15592,7 +15592,7 @@
           <p:cNvPr id="13" name="TextBox 12">
             <a:extLst>
               <a:ext uri="{FF2B5EF4-FFF2-40B4-BE49-F238E27FC236}">
-                <a16:creationId xmlns:a16="http://schemas.microsoft.com/office/drawing/2014/main" id="{FFB7C730-B296-905A-892D-E65CB8CCD311}"/>
+                <a16:creationId xmlns:a16="http://schemas.microsoft.com/office/drawing/2014/main" id="{EDE35564-A21B-0190-C152-1012550DAD17}"/>
               </a:ext>
             </a:extLst>
           </p:cNvPr>
@@ -15632,7 +15632,7 @@
           <p:cNvPr id="14" name="TextBox 13">
             <a:extLst>
               <a:ext uri="{FF2B5EF4-FFF2-40B4-BE49-F238E27FC236}">
-                <a16:creationId xmlns:a16="http://schemas.microsoft.com/office/drawing/2014/main" id="{FE12983C-89A0-DDDF-654F-026479DE8F6F}"/>
+                <a16:creationId xmlns:a16="http://schemas.microsoft.com/office/drawing/2014/main" id="{70B78FE7-4411-93EB-36AA-927FCC6A2D14}"/>
               </a:ext>
             </a:extLst>
           </p:cNvPr>
@@ -15672,7 +15672,7 @@
           <p:cNvPr id="15" name="TextBox 14">
             <a:extLst>
               <a:ext uri="{FF2B5EF4-FFF2-40B4-BE49-F238E27FC236}">
-                <a16:creationId xmlns:a16="http://schemas.microsoft.com/office/drawing/2014/main" id="{7F80828F-644C-77E5-5FA0-8F2E24293348}"/>
+                <a16:creationId xmlns:a16="http://schemas.microsoft.com/office/drawing/2014/main" id="{2A0968A3-6E25-1B7B-78E9-FA0E328C8D6B}"/>
               </a:ext>
             </a:extLst>
           </p:cNvPr>
@@ -15698,7 +15698,7 @@
             <a:r>
               <a:rPr lang="en-US" b="1">
                 <a:solidFill>
-                  <a:srgbClr val="3FC6AC"/>
+                  <a:srgbClr val="007565"/>
                 </a:solidFill>
                 <a:latin typeface="Aptos" panose="020B0004020202020204" pitchFamily="34" charset="0"/>
               </a:rPr>
@@ -15712,7 +15712,7 @@
           <p:cNvPr id="16" name="TextBox 15">
             <a:extLst>
               <a:ext uri="{FF2B5EF4-FFF2-40B4-BE49-F238E27FC236}">
-                <a16:creationId xmlns:a16="http://schemas.microsoft.com/office/drawing/2014/main" id="{35A5D6A8-7E5B-BC0D-E56A-7296DA94DCE0}"/>
+                <a16:creationId xmlns:a16="http://schemas.microsoft.com/office/drawing/2014/main" id="{F468731F-6D68-2F18-BD08-78D929CB68AF}"/>
               </a:ext>
             </a:extLst>
           </p:cNvPr>
@@ -15738,7 +15738,7 @@
             <a:r>
               <a:rPr lang="en-US" b="1">
                 <a:solidFill>
-                  <a:srgbClr val="3FC6AC"/>
+                  <a:srgbClr val="007565"/>
                 </a:solidFill>
                 <a:latin typeface="Aptos" panose="020B0004020202020204" pitchFamily="34" charset="0"/>
               </a:rPr>
@@ -15752,7 +15752,7 @@
           <p:cNvPr id="17" name="TextBox 16">
             <a:extLst>
               <a:ext uri="{FF2B5EF4-FFF2-40B4-BE49-F238E27FC236}">
-                <a16:creationId xmlns:a16="http://schemas.microsoft.com/office/drawing/2014/main" id="{4BBF2DAB-B220-05E7-F4AA-25D9A61F3CFA}"/>
+                <a16:creationId xmlns:a16="http://schemas.microsoft.com/office/drawing/2014/main" id="{41C13E5C-8483-D98D-A2AE-CF90C9DEF6C3}"/>
               </a:ext>
             </a:extLst>
           </p:cNvPr>
@@ -15792,7 +15792,7 @@
           <p:cNvPr id="18" name="TextBox 17">
             <a:extLst>
               <a:ext uri="{FF2B5EF4-FFF2-40B4-BE49-F238E27FC236}">
-                <a16:creationId xmlns:a16="http://schemas.microsoft.com/office/drawing/2014/main" id="{27B9F094-DBCA-382C-DEFB-3F6FC72A391A}"/>
+                <a16:creationId xmlns:a16="http://schemas.microsoft.com/office/drawing/2014/main" id="{1E126041-6BE2-154F-3DE7-442723544742}"/>
               </a:ext>
             </a:extLst>
           </p:cNvPr>
@@ -15832,7 +15832,7 @@
           <p:cNvPr id="19" name="TextBox 18">
             <a:extLst>
               <a:ext uri="{FF2B5EF4-FFF2-40B4-BE49-F238E27FC236}">
-                <a16:creationId xmlns:a16="http://schemas.microsoft.com/office/drawing/2014/main" id="{A94960C2-BE1B-FC9E-D27B-125195DED1A6}"/>
+                <a16:creationId xmlns:a16="http://schemas.microsoft.com/office/drawing/2014/main" id="{AB127C8D-3F49-AEA2-1E27-4BF7A9C2F738}"/>
               </a:ext>
             </a:extLst>
           </p:cNvPr>
@@ -15872,7 +15872,7 @@
           <p:cNvPr id="20" name="TextBox 19">
             <a:extLst>
               <a:ext uri="{FF2B5EF4-FFF2-40B4-BE49-F238E27FC236}">
-                <a16:creationId xmlns:a16="http://schemas.microsoft.com/office/drawing/2014/main" id="{43A9201A-0436-9EEE-CF25-17D9D0DFC091}"/>
+                <a16:creationId xmlns:a16="http://schemas.microsoft.com/office/drawing/2014/main" id="{B1194697-314F-1BBD-89D5-25CDEE3C0949}"/>
               </a:ext>
             </a:extLst>
           </p:cNvPr>
@@ -15898,7 +15898,7 @@
             <a:r>
               <a:rPr lang="en-US" b="1">
                 <a:solidFill>
-                  <a:srgbClr val="3FC6AC"/>
+                  <a:srgbClr val="007565"/>
                 </a:solidFill>
                 <a:latin typeface="Aptos" panose="020B0004020202020204" pitchFamily="34" charset="0"/>
               </a:rPr>
@@ -15912,7 +15912,7 @@
           <p:cNvPr id="21" name="TextBox 20">
             <a:extLst>
               <a:ext uri="{FF2B5EF4-FFF2-40B4-BE49-F238E27FC236}">
-                <a16:creationId xmlns:a16="http://schemas.microsoft.com/office/drawing/2014/main" id="{4BC53BD7-D813-8D9F-768F-3A2E79A7342E}"/>
+                <a16:creationId xmlns:a16="http://schemas.microsoft.com/office/drawing/2014/main" id="{3C3C0C23-BE99-FF59-9A54-CF5604E47B5F}"/>
               </a:ext>
             </a:extLst>
           </p:cNvPr>
@@ -15938,7 +15938,7 @@
             <a:r>
               <a:rPr lang="en-US" b="1">
                 <a:solidFill>
-                  <a:srgbClr val="3FC6AC"/>
+                  <a:srgbClr val="007565"/>
                 </a:solidFill>
                 <a:latin typeface="Aptos" panose="020B0004020202020204" pitchFamily="34" charset="0"/>
               </a:rPr>
@@ -15952,7 +15952,7 @@
           <p:cNvPr id="22" name="TextBox 21">
             <a:extLst>
               <a:ext uri="{FF2B5EF4-FFF2-40B4-BE49-F238E27FC236}">
-                <a16:creationId xmlns:a16="http://schemas.microsoft.com/office/drawing/2014/main" id="{FC7D6CAF-FBCE-F461-FF61-D4CD29ACA386}"/>
+                <a16:creationId xmlns:a16="http://schemas.microsoft.com/office/drawing/2014/main" id="{75B6973D-4F50-4DD4-D7A5-E70A0E97B928}"/>
               </a:ext>
             </a:extLst>
           </p:cNvPr>
@@ -15992,7 +15992,7 @@
           <p:cNvPr id="23" name="Rectangle 22">
             <a:extLst>
               <a:ext uri="{FF2B5EF4-FFF2-40B4-BE49-F238E27FC236}">
-                <a16:creationId xmlns:a16="http://schemas.microsoft.com/office/drawing/2014/main" id="{576BBA8E-7222-3121-FAF5-CC8D5EB8E5BA}"/>
+                <a16:creationId xmlns:a16="http://schemas.microsoft.com/office/drawing/2014/main" id="{61B941D1-669C-DC02-4A56-FE9CDD04DD00}"/>
               </a:ext>
             </a:extLst>
           </p:cNvPr>
@@ -16060,7 +16060,7 @@
           <p:cNvPr id="24" name="TextBox 23">
             <a:extLst>
               <a:ext uri="{FF2B5EF4-FFF2-40B4-BE49-F238E27FC236}">
-                <a16:creationId xmlns:a16="http://schemas.microsoft.com/office/drawing/2014/main" id="{F95A5CF1-4E9D-D616-1A2A-ED0D1FD7AF3E}"/>
+                <a16:creationId xmlns:a16="http://schemas.microsoft.com/office/drawing/2014/main" id="{97A82185-D944-1DC7-C4EE-2DC16E759CB1}"/>
               </a:ext>
             </a:extLst>
           </p:cNvPr>
@@ -16100,7 +16100,7 @@
           <p:cNvPr id="25" name="TextBox 24">
             <a:extLst>
               <a:ext uri="{FF2B5EF4-FFF2-40B4-BE49-F238E27FC236}">
-                <a16:creationId xmlns:a16="http://schemas.microsoft.com/office/drawing/2014/main" id="{0B1BE9CA-15E9-E0AE-EE23-4A3555945B51}"/>
+                <a16:creationId xmlns:a16="http://schemas.microsoft.com/office/drawing/2014/main" id="{11CDEB34-6371-84C9-63F9-11B5FC531DD0}"/>
               </a:ext>
             </a:extLst>
           </p:cNvPr>
@@ -16140,7 +16140,7 @@
           <p:cNvPr id="26" name="TextBox 25">
             <a:extLst>
               <a:ext uri="{FF2B5EF4-FFF2-40B4-BE49-F238E27FC236}">
-                <a16:creationId xmlns:a16="http://schemas.microsoft.com/office/drawing/2014/main" id="{D60F7C23-F21D-F3DE-5B51-C1D865EF5B4C}"/>
+                <a16:creationId xmlns:a16="http://schemas.microsoft.com/office/drawing/2014/main" id="{D5569269-C110-5D5A-7C6D-41712AAB8C7E}"/>
               </a:ext>
             </a:extLst>
           </p:cNvPr>
@@ -16166,7 +16166,7 @@
             <a:r>
               <a:rPr lang="en-US" b="1">
                 <a:solidFill>
-                  <a:srgbClr val="3FC6AC"/>
+                  <a:srgbClr val="007565"/>
                 </a:solidFill>
                 <a:latin typeface="Aptos" panose="020B0004020202020204" pitchFamily="34" charset="0"/>
               </a:rPr>
@@ -16180,7 +16180,7 @@
           <p:cNvPr id="27" name="TextBox 26">
             <a:extLst>
               <a:ext uri="{FF2B5EF4-FFF2-40B4-BE49-F238E27FC236}">
-                <a16:creationId xmlns:a16="http://schemas.microsoft.com/office/drawing/2014/main" id="{50173D8D-885D-2BEE-934F-DE736242DE46}"/>
+                <a16:creationId xmlns:a16="http://schemas.microsoft.com/office/drawing/2014/main" id="{2C94A6D8-CB09-A6EC-147E-AA9629E954FD}"/>
               </a:ext>
             </a:extLst>
           </p:cNvPr>
@@ -16206,7 +16206,7 @@
             <a:r>
               <a:rPr lang="en-US" b="1">
                 <a:solidFill>
-                  <a:srgbClr val="3FC6AC"/>
+                  <a:srgbClr val="007565"/>
                 </a:solidFill>
                 <a:latin typeface="Aptos" panose="020B0004020202020204" pitchFamily="34" charset="0"/>
               </a:rPr>
@@ -16220,7 +16220,7 @@
           <p:cNvPr id="28" name="TextBox 27">
             <a:extLst>
               <a:ext uri="{FF2B5EF4-FFF2-40B4-BE49-F238E27FC236}">
-                <a16:creationId xmlns:a16="http://schemas.microsoft.com/office/drawing/2014/main" id="{210588AC-16A2-23DF-4EBE-9BA4BDEB9EA8}"/>
+                <a16:creationId xmlns:a16="http://schemas.microsoft.com/office/drawing/2014/main" id="{53D1FF82-E417-C985-38DA-F37F9EAACC36}"/>
               </a:ext>
             </a:extLst>
           </p:cNvPr>
@@ -16260,7 +16260,7 @@
           <p:cNvPr id="29" name="Straight Connector 28">
             <a:extLst>
               <a:ext uri="{FF2B5EF4-FFF2-40B4-BE49-F238E27FC236}">
-                <a16:creationId xmlns:a16="http://schemas.microsoft.com/office/drawing/2014/main" id="{6E1FE1FF-8CB5-482E-5718-6A5E5A053F64}"/>
+                <a16:creationId xmlns:a16="http://schemas.microsoft.com/office/drawing/2014/main" id="{D45B465A-7FB4-820B-A348-6258BA472A08}"/>
               </a:ext>
             </a:extLst>
           </p:cNvPr>
@@ -16301,7 +16301,7 @@
           <p:cNvPr id="30" name="TextBox 29">
             <a:extLst>
               <a:ext uri="{FF2B5EF4-FFF2-40B4-BE49-F238E27FC236}">
-                <a16:creationId xmlns:a16="http://schemas.microsoft.com/office/drawing/2014/main" id="{38371D86-73EF-121B-833B-1D7A0056F841}"/>
+                <a16:creationId xmlns:a16="http://schemas.microsoft.com/office/drawing/2014/main" id="{67C3264D-83FC-DE6A-B46D-3BFB0526F8DD}"/>
               </a:ext>
             </a:extLst>
           </p:cNvPr>
@@ -16341,7 +16341,7 @@
           <p:cNvPr id="31" name="TextBox 30">
             <a:extLst>
               <a:ext uri="{FF2B5EF4-FFF2-40B4-BE49-F238E27FC236}">
-                <a16:creationId xmlns:a16="http://schemas.microsoft.com/office/drawing/2014/main" id="{F5E423F0-C5AF-8298-00C1-E62DE42E8383}"/>
+                <a16:creationId xmlns:a16="http://schemas.microsoft.com/office/drawing/2014/main" id="{860E62C5-D5EA-CBA0-64FD-1970FE5B2970}"/>
               </a:ext>
             </a:extLst>
           </p:cNvPr>
@@ -16367,7 +16367,7 @@
             <a:r>
               <a:rPr lang="en-US" b="1">
                 <a:solidFill>
-                  <a:srgbClr val="3FC6AC"/>
+                  <a:srgbClr val="007565"/>
                 </a:solidFill>
                 <a:latin typeface="Aptos" panose="020B0004020202020204" pitchFamily="34" charset="0"/>
               </a:rPr>
@@ -16381,7 +16381,7 @@
           <p:cNvPr id="32" name="Rectangle: Rounded Corners 31">
             <a:extLst>
               <a:ext uri="{FF2B5EF4-FFF2-40B4-BE49-F238E27FC236}">
-                <a16:creationId xmlns:a16="http://schemas.microsoft.com/office/drawing/2014/main" id="{6A46B9BD-2E7D-0EE6-70FF-C6F7EDE9C0DB}"/>
+                <a16:creationId xmlns:a16="http://schemas.microsoft.com/office/drawing/2014/main" id="{2F3A5632-D253-D26C-81CC-C7EB9384FD42}"/>
               </a:ext>
             </a:extLst>
           </p:cNvPr>
@@ -16435,7 +16435,7 @@
           <p:cNvPr id="33" name="TextBox 32">
             <a:extLst>
               <a:ext uri="{FF2B5EF4-FFF2-40B4-BE49-F238E27FC236}">
-                <a16:creationId xmlns:a16="http://schemas.microsoft.com/office/drawing/2014/main" id="{7E79F71F-856C-F161-0032-F2997EC3FAB6}"/>
+                <a16:creationId xmlns:a16="http://schemas.microsoft.com/office/drawing/2014/main" id="{95B25183-234C-ABB3-ADE2-7058AE9DF211}"/>
               </a:ext>
             </a:extLst>
           </p:cNvPr>
@@ -16476,7 +16476,7 @@
           <p:cNvPr id="34" name="TextBox 33">
             <a:extLst>
               <a:ext uri="{FF2B5EF4-FFF2-40B4-BE49-F238E27FC236}">
-                <a16:creationId xmlns:a16="http://schemas.microsoft.com/office/drawing/2014/main" id="{B63EFF90-5745-4D7C-3E3F-CCEDD305F0C9}"/>
+                <a16:creationId xmlns:a16="http://schemas.microsoft.com/office/drawing/2014/main" id="{984333B9-C1BF-72F7-26C3-5C8407EB1864}"/>
               </a:ext>
             </a:extLst>
           </p:cNvPr>
@@ -16515,7 +16515,7 @@
     </p:spTree>
     <p:extLst>
       <p:ext uri="{BB962C8B-B14F-4D97-AF65-F5344CB8AC3E}">
-        <p14:creationId xmlns:p14="http://schemas.microsoft.com/office/powerpoint/2010/main" val="2234281235"/>
+        <p14:creationId xmlns:p14="http://schemas.microsoft.com/office/powerpoint/2010/main" val="2619035176"/>
       </p:ext>
     </p:extLst>
   </p:cSld>
@@ -16555,7 +16555,7 @@
           <p:cNvPr id="2" name="TextBox 1">
             <a:extLst>
               <a:ext uri="{FF2B5EF4-FFF2-40B4-BE49-F238E27FC236}">
-                <a16:creationId xmlns:a16="http://schemas.microsoft.com/office/drawing/2014/main" id="{C718CCA1-5CC0-CD7E-3497-4909716F16BF}"/>
+                <a16:creationId xmlns:a16="http://schemas.microsoft.com/office/drawing/2014/main" id="{02F2289F-5D96-8F67-F470-41D0892AF958}"/>
               </a:ext>
             </a:extLst>
           </p:cNvPr>
@@ -16595,7 +16595,7 @@
           <p:cNvPr id="3" name="Straight Connector 2">
             <a:extLst>
               <a:ext uri="{FF2B5EF4-FFF2-40B4-BE49-F238E27FC236}">
-                <a16:creationId xmlns:a16="http://schemas.microsoft.com/office/drawing/2014/main" id="{589DDC79-208E-AD30-6884-512FA5F148DE}"/>
+                <a16:creationId xmlns:a16="http://schemas.microsoft.com/office/drawing/2014/main" id="{41BA6DC8-3C60-C553-4C24-43A0DC9398E7}"/>
               </a:ext>
             </a:extLst>
           </p:cNvPr>
@@ -16636,7 +16636,7 @@
           <p:cNvPr id="4" name="TextBox 3">
             <a:extLst>
               <a:ext uri="{FF2B5EF4-FFF2-40B4-BE49-F238E27FC236}">
-                <a16:creationId xmlns:a16="http://schemas.microsoft.com/office/drawing/2014/main" id="{4171CC76-4859-0B71-DFBB-579037EF4946}"/>
+                <a16:creationId xmlns:a16="http://schemas.microsoft.com/office/drawing/2014/main" id="{C4DC51B1-A895-D9F6-779B-3EFDD7B07653}"/>
               </a:ext>
             </a:extLst>
           </p:cNvPr>
@@ -16677,7 +16677,7 @@
           <p:cNvPr id="5" name="TextBox 4">
             <a:extLst>
               <a:ext uri="{FF2B5EF4-FFF2-40B4-BE49-F238E27FC236}">
-                <a16:creationId xmlns:a16="http://schemas.microsoft.com/office/drawing/2014/main" id="{733E6B4B-8E15-4B20-2400-4A2239BFFB5F}"/>
+                <a16:creationId xmlns:a16="http://schemas.microsoft.com/office/drawing/2014/main" id="{3F691468-F313-2AC7-34AC-FC044932E7B5}"/>
               </a:ext>
             </a:extLst>
           </p:cNvPr>
@@ -16717,7 +16717,7 @@
           <p:cNvPr id="6" name="TextBox 5">
             <a:extLst>
               <a:ext uri="{FF2B5EF4-FFF2-40B4-BE49-F238E27FC236}">
-                <a16:creationId xmlns:a16="http://schemas.microsoft.com/office/drawing/2014/main" id="{E8C7351C-5D01-FA83-D47A-BD0130672C7C}"/>
+                <a16:creationId xmlns:a16="http://schemas.microsoft.com/office/drawing/2014/main" id="{8ED930EA-4BEA-0037-9925-505452738F7E}"/>
               </a:ext>
             </a:extLst>
           </p:cNvPr>
@@ -16757,7 +16757,7 @@
           <p:cNvPr id="7" name="TextBox 6">
             <a:extLst>
               <a:ext uri="{FF2B5EF4-FFF2-40B4-BE49-F238E27FC236}">
-                <a16:creationId xmlns:a16="http://schemas.microsoft.com/office/drawing/2014/main" id="{C7603354-F17A-E0BA-4960-61E8E1DE5514}"/>
+                <a16:creationId xmlns:a16="http://schemas.microsoft.com/office/drawing/2014/main" id="{08988387-ED45-F04F-630C-B62084C025EF}"/>
               </a:ext>
             </a:extLst>
           </p:cNvPr>
@@ -16797,7 +16797,7 @@
           <p:cNvPr id="8" name="TextBox 7">
             <a:extLst>
               <a:ext uri="{FF2B5EF4-FFF2-40B4-BE49-F238E27FC236}">
-                <a16:creationId xmlns:a16="http://schemas.microsoft.com/office/drawing/2014/main" id="{4D31CB8F-EAF8-4C7B-4365-D9972DECF345}"/>
+                <a16:creationId xmlns:a16="http://schemas.microsoft.com/office/drawing/2014/main" id="{FD8667DD-86E0-717F-A292-0647D3B1EFFE}"/>
               </a:ext>
             </a:extLst>
           </p:cNvPr>
@@ -16837,7 +16837,7 @@
           <p:cNvPr id="9" name="Rectangle: Rounded Corners 8">
             <a:extLst>
               <a:ext uri="{FF2B5EF4-FFF2-40B4-BE49-F238E27FC236}">
-                <a16:creationId xmlns:a16="http://schemas.microsoft.com/office/drawing/2014/main" id="{97D31CEB-1735-DC23-CA81-009E60BC8498}"/>
+                <a16:creationId xmlns:a16="http://schemas.microsoft.com/office/drawing/2014/main" id="{434B5E6B-858C-1E9E-CB7A-23E49900BAFD}"/>
               </a:ext>
             </a:extLst>
           </p:cNvPr>
@@ -16905,7 +16905,7 @@
           <p:cNvPr id="10" name="TextBox 9">
             <a:extLst>
               <a:ext uri="{FF2B5EF4-FFF2-40B4-BE49-F238E27FC236}">
-                <a16:creationId xmlns:a16="http://schemas.microsoft.com/office/drawing/2014/main" id="{B28D6425-C25F-7765-F265-666902D9A034}"/>
+                <a16:creationId xmlns:a16="http://schemas.microsoft.com/office/drawing/2014/main" id="{758687F6-5077-8763-1583-13D373AEE1DB}"/>
               </a:ext>
             </a:extLst>
           </p:cNvPr>
@@ -16946,7 +16946,7 @@
           <p:cNvPr id="11" name="TextBox 10">
             <a:extLst>
               <a:ext uri="{FF2B5EF4-FFF2-40B4-BE49-F238E27FC236}">
-                <a16:creationId xmlns:a16="http://schemas.microsoft.com/office/drawing/2014/main" id="{346282FD-2962-711E-E332-37567BBFFADC}"/>
+                <a16:creationId xmlns:a16="http://schemas.microsoft.com/office/drawing/2014/main" id="{F65CE052-8915-CCB9-AD0A-D4834D4E3375}"/>
               </a:ext>
             </a:extLst>
           </p:cNvPr>
@@ -16987,7 +16987,7 @@
           <p:cNvPr id="12" name="Rectangle: Rounded Corners 11">
             <a:extLst>
               <a:ext uri="{FF2B5EF4-FFF2-40B4-BE49-F238E27FC236}">
-                <a16:creationId xmlns:a16="http://schemas.microsoft.com/office/drawing/2014/main" id="{E1A20804-042D-9879-535E-B5A4171AC618}"/>
+                <a16:creationId xmlns:a16="http://schemas.microsoft.com/office/drawing/2014/main" id="{81CF20A2-FB4C-9B1E-4A09-488498961996}"/>
               </a:ext>
             </a:extLst>
           </p:cNvPr>
@@ -17055,7 +17055,7 @@
           <p:cNvPr id="13" name="TextBox 12">
             <a:extLst>
               <a:ext uri="{FF2B5EF4-FFF2-40B4-BE49-F238E27FC236}">
-                <a16:creationId xmlns:a16="http://schemas.microsoft.com/office/drawing/2014/main" id="{B094BA6E-2CCD-8C3C-3E3C-81D4CE377872}"/>
+                <a16:creationId xmlns:a16="http://schemas.microsoft.com/office/drawing/2014/main" id="{5F42AAF1-2FB0-9D81-68B0-E31FC6118900}"/>
               </a:ext>
             </a:extLst>
           </p:cNvPr>
@@ -17096,7 +17096,7 @@
           <p:cNvPr id="14" name="TextBox 13">
             <a:extLst>
               <a:ext uri="{FF2B5EF4-FFF2-40B4-BE49-F238E27FC236}">
-                <a16:creationId xmlns:a16="http://schemas.microsoft.com/office/drawing/2014/main" id="{4C3B30D4-BFF7-E926-AFD3-86FCC6C01603}"/>
+                <a16:creationId xmlns:a16="http://schemas.microsoft.com/office/drawing/2014/main" id="{F434C120-E9CE-1020-546B-0AAB40E53060}"/>
               </a:ext>
             </a:extLst>
           </p:cNvPr>
@@ -17137,7 +17137,7 @@
           <p:cNvPr id="15" name="Rectangle: Rounded Corners 14">
             <a:extLst>
               <a:ext uri="{FF2B5EF4-FFF2-40B4-BE49-F238E27FC236}">
-                <a16:creationId xmlns:a16="http://schemas.microsoft.com/office/drawing/2014/main" id="{44D98366-6722-93D4-751C-15513C82BD1B}"/>
+                <a16:creationId xmlns:a16="http://schemas.microsoft.com/office/drawing/2014/main" id="{67E81205-374C-C351-25A8-549F17E339E0}"/>
               </a:ext>
             </a:extLst>
           </p:cNvPr>
@@ -17205,7 +17205,7 @@
           <p:cNvPr id="16" name="TextBox 15">
             <a:extLst>
               <a:ext uri="{FF2B5EF4-FFF2-40B4-BE49-F238E27FC236}">
-                <a16:creationId xmlns:a16="http://schemas.microsoft.com/office/drawing/2014/main" id="{8ACFB60F-1F04-1BC6-57CC-F583B8F20C1D}"/>
+                <a16:creationId xmlns:a16="http://schemas.microsoft.com/office/drawing/2014/main" id="{D9A47689-1CAA-AFDD-310F-22F76ADAF80B}"/>
               </a:ext>
             </a:extLst>
           </p:cNvPr>
@@ -17246,7 +17246,7 @@
           <p:cNvPr id="17" name="TextBox 16">
             <a:extLst>
               <a:ext uri="{FF2B5EF4-FFF2-40B4-BE49-F238E27FC236}">
-                <a16:creationId xmlns:a16="http://schemas.microsoft.com/office/drawing/2014/main" id="{BB9E81A9-6FD3-05A3-91CB-E7532E4474CB}"/>
+                <a16:creationId xmlns:a16="http://schemas.microsoft.com/office/drawing/2014/main" id="{7EB5C9DF-7548-9EF6-14F9-B599C249E983}"/>
               </a:ext>
             </a:extLst>
           </p:cNvPr>
@@ -17287,7 +17287,7 @@
           <p:cNvPr id="18" name="TextBox 17">
             <a:extLst>
               <a:ext uri="{FF2B5EF4-FFF2-40B4-BE49-F238E27FC236}">
-                <a16:creationId xmlns:a16="http://schemas.microsoft.com/office/drawing/2014/main" id="{E786E3B4-92DB-8B98-3C4C-7E769A760F93}"/>
+                <a16:creationId xmlns:a16="http://schemas.microsoft.com/office/drawing/2014/main" id="{49726E6A-4625-AACE-2432-97C5BDA7819E}"/>
               </a:ext>
             </a:extLst>
           </p:cNvPr>
@@ -17327,7 +17327,7 @@
           <p:cNvPr id="19" name="TextBox 18">
             <a:extLst>
               <a:ext uri="{FF2B5EF4-FFF2-40B4-BE49-F238E27FC236}">
-                <a16:creationId xmlns:a16="http://schemas.microsoft.com/office/drawing/2014/main" id="{D5F2FAEC-984D-A05F-2CD6-3AE1E7BD1228}"/>
+                <a16:creationId xmlns:a16="http://schemas.microsoft.com/office/drawing/2014/main" id="{1B0D7941-7584-DB21-2BC4-09A76EF0D671}"/>
               </a:ext>
             </a:extLst>
           </p:cNvPr>
@@ -17373,7 +17373,7 @@
           <p:cNvPr id="20" name="TextBox 19">
             <a:extLst>
               <a:ext uri="{FF2B5EF4-FFF2-40B4-BE49-F238E27FC236}">
-                <a16:creationId xmlns:a16="http://schemas.microsoft.com/office/drawing/2014/main" id="{8071B4A7-F834-9030-5DCA-BCDC8573279C}"/>
+                <a16:creationId xmlns:a16="http://schemas.microsoft.com/office/drawing/2014/main" id="{CEE046EB-E763-0763-0CE4-A111AEF127E2}"/>
               </a:ext>
             </a:extLst>
           </p:cNvPr>
@@ -17411,7 +17411,7 @@
     </p:spTree>
     <p:extLst>
       <p:ext uri="{BB962C8B-B14F-4D97-AF65-F5344CB8AC3E}">
-        <p14:creationId xmlns:p14="http://schemas.microsoft.com/office/powerpoint/2010/main" val="2907194677"/>
+        <p14:creationId xmlns:p14="http://schemas.microsoft.com/office/powerpoint/2010/main" val="237364489"/>
       </p:ext>
     </p:extLst>
   </p:cSld>

</xml_diff>

<commit_message>
build: prepare redesigned desktop release artifacts
</commit_message>
<xml_diff>
--- a/output/presentation/gridguard-khartoum-defense.pptx
+++ b/output/presentation/gridguard-khartoum-defense.pptx
@@ -202,7 +202,7 @@
             </a:lvl1pPr>
           </a:lstStyle>
           <a:p>
-            <a:fld id="{827195CA-8015-4D13-8E50-00B425D229C8}" type="datetimeFigureOut">
+            <a:fld id="{2D14CE1A-D214-4129-8C51-7727893BB65F}" type="datetimeFigureOut">
               <a:rPr lang="en-US" smtClean="0"/>
               <a:t>10/21/2026</a:t>
             </a:fld>
@@ -360,7 +360,7 @@
             </a:lvl1pPr>
           </a:lstStyle>
           <a:p>
-            <a:fld id="{3170AC7A-110A-46E3-B788-B77DD47A3800}" type="slidenum">
+            <a:fld id="{E975B6EB-33BA-4191-9F69-5A340388D2ED}" type="slidenum">
               <a:rPr lang="en-US" smtClean="0"/>
               <a:t>‹#›</a:t>
             </a:fld>
@@ -371,7 +371,7 @@
     </p:spTree>
     <p:extLst>
       <p:ext uri="{BB962C8B-B14F-4D97-AF65-F5344CB8AC3E}">
-        <p14:creationId xmlns:p14="http://schemas.microsoft.com/office/powerpoint/2010/main" val="399647185"/>
+        <p14:creationId xmlns:p14="http://schemas.microsoft.com/office/powerpoint/2010/main" val="2903185898"/>
       </p:ext>
     </p:extLst>
   </p:cSld>
@@ -564,7 +564,7 @@
           <a:bodyPr/>
           <a:lstStyle/>
           <a:p>
-            <a:fld id="{3170AC7A-110A-46E3-B788-B77DD47A3800}" type="slidenum">
+            <a:fld id="{E975B6EB-33BA-4191-9F69-5A340388D2ED}" type="slidenum">
               <a:rPr lang="en-US" smtClean="0"/>
               <a:t>1</a:t>
             </a:fld>
@@ -575,7 +575,7 @@
     </p:spTree>
     <p:extLst>
       <p:ext uri="{BB962C8B-B14F-4D97-AF65-F5344CB8AC3E}">
-        <p14:creationId xmlns:p14="http://schemas.microsoft.com/office/powerpoint/2010/main" val="779396866"/>
+        <p14:creationId xmlns:p14="http://schemas.microsoft.com/office/powerpoint/2010/main" val="2733997143"/>
       </p:ext>
     </p:extLst>
   </p:cSld>
@@ -678,7 +678,7 @@
           <a:bodyPr/>
           <a:lstStyle/>
           <a:p>
-            <a:fld id="{3170AC7A-110A-46E3-B788-B77DD47A3800}" type="slidenum">
+            <a:fld id="{E975B6EB-33BA-4191-9F69-5A340388D2ED}" type="slidenum">
               <a:rPr lang="en-US" smtClean="0"/>
               <a:t>10</a:t>
             </a:fld>
@@ -689,7 +689,7 @@
     </p:spTree>
     <p:extLst>
       <p:ext uri="{BB962C8B-B14F-4D97-AF65-F5344CB8AC3E}">
-        <p14:creationId xmlns:p14="http://schemas.microsoft.com/office/powerpoint/2010/main" val="4080884353"/>
+        <p14:creationId xmlns:p14="http://schemas.microsoft.com/office/powerpoint/2010/main" val="255887207"/>
       </p:ext>
     </p:extLst>
   </p:cSld>
@@ -792,7 +792,7 @@
           <a:bodyPr/>
           <a:lstStyle/>
           <a:p>
-            <a:fld id="{3170AC7A-110A-46E3-B788-B77DD47A3800}" type="slidenum">
+            <a:fld id="{E975B6EB-33BA-4191-9F69-5A340388D2ED}" type="slidenum">
               <a:rPr lang="en-US" smtClean="0"/>
               <a:t>11</a:t>
             </a:fld>
@@ -803,7 +803,7 @@
     </p:spTree>
     <p:extLst>
       <p:ext uri="{BB962C8B-B14F-4D97-AF65-F5344CB8AC3E}">
-        <p14:creationId xmlns:p14="http://schemas.microsoft.com/office/powerpoint/2010/main" val="1482525949"/>
+        <p14:creationId xmlns:p14="http://schemas.microsoft.com/office/powerpoint/2010/main" val="911260672"/>
       </p:ext>
     </p:extLst>
   </p:cSld>
@@ -906,7 +906,7 @@
           <a:bodyPr/>
           <a:lstStyle/>
           <a:p>
-            <a:fld id="{3170AC7A-110A-46E3-B788-B77DD47A3800}" type="slidenum">
+            <a:fld id="{E975B6EB-33BA-4191-9F69-5A340388D2ED}" type="slidenum">
               <a:rPr lang="en-US" smtClean="0"/>
               <a:t>12</a:t>
             </a:fld>
@@ -917,7 +917,7 @@
     </p:spTree>
     <p:extLst>
       <p:ext uri="{BB962C8B-B14F-4D97-AF65-F5344CB8AC3E}">
-        <p14:creationId xmlns:p14="http://schemas.microsoft.com/office/powerpoint/2010/main" val="4232516742"/>
+        <p14:creationId xmlns:p14="http://schemas.microsoft.com/office/powerpoint/2010/main" val="334315678"/>
       </p:ext>
     </p:extLst>
   </p:cSld>
@@ -1020,7 +1020,7 @@
           <a:bodyPr/>
           <a:lstStyle/>
           <a:p>
-            <a:fld id="{3170AC7A-110A-46E3-B788-B77DD47A3800}" type="slidenum">
+            <a:fld id="{E975B6EB-33BA-4191-9F69-5A340388D2ED}" type="slidenum">
               <a:rPr lang="en-US" smtClean="0"/>
               <a:t>13</a:t>
             </a:fld>
@@ -1031,7 +1031,7 @@
     </p:spTree>
     <p:extLst>
       <p:ext uri="{BB962C8B-B14F-4D97-AF65-F5344CB8AC3E}">
-        <p14:creationId xmlns:p14="http://schemas.microsoft.com/office/powerpoint/2010/main" val="3986281887"/>
+        <p14:creationId xmlns:p14="http://schemas.microsoft.com/office/powerpoint/2010/main" val="2067902944"/>
       </p:ext>
     </p:extLst>
   </p:cSld>
@@ -1134,7 +1134,7 @@
           <a:bodyPr/>
           <a:lstStyle/>
           <a:p>
-            <a:fld id="{3170AC7A-110A-46E3-B788-B77DD47A3800}" type="slidenum">
+            <a:fld id="{E975B6EB-33BA-4191-9F69-5A340388D2ED}" type="slidenum">
               <a:rPr lang="en-US" smtClean="0"/>
               <a:t>2</a:t>
             </a:fld>
@@ -1145,7 +1145,7 @@
     </p:spTree>
     <p:extLst>
       <p:ext uri="{BB962C8B-B14F-4D97-AF65-F5344CB8AC3E}">
-        <p14:creationId xmlns:p14="http://schemas.microsoft.com/office/powerpoint/2010/main" val="3459823563"/>
+        <p14:creationId xmlns:p14="http://schemas.microsoft.com/office/powerpoint/2010/main" val="3242627750"/>
       </p:ext>
     </p:extLst>
   </p:cSld>
@@ -1248,7 +1248,7 @@
           <a:bodyPr/>
           <a:lstStyle/>
           <a:p>
-            <a:fld id="{3170AC7A-110A-46E3-B788-B77DD47A3800}" type="slidenum">
+            <a:fld id="{E975B6EB-33BA-4191-9F69-5A340388D2ED}" type="slidenum">
               <a:rPr lang="en-US" smtClean="0"/>
               <a:t>3</a:t>
             </a:fld>
@@ -1259,7 +1259,7 @@
     </p:spTree>
     <p:extLst>
       <p:ext uri="{BB962C8B-B14F-4D97-AF65-F5344CB8AC3E}">
-        <p14:creationId xmlns:p14="http://schemas.microsoft.com/office/powerpoint/2010/main" val="3033788126"/>
+        <p14:creationId xmlns:p14="http://schemas.microsoft.com/office/powerpoint/2010/main" val="2466300365"/>
       </p:ext>
     </p:extLst>
   </p:cSld>
@@ -1362,7 +1362,7 @@
           <a:bodyPr/>
           <a:lstStyle/>
           <a:p>
-            <a:fld id="{3170AC7A-110A-46E3-B788-B77DD47A3800}" type="slidenum">
+            <a:fld id="{E975B6EB-33BA-4191-9F69-5A340388D2ED}" type="slidenum">
               <a:rPr lang="en-US" smtClean="0"/>
               <a:t>4</a:t>
             </a:fld>
@@ -1373,7 +1373,7 @@
     </p:spTree>
     <p:extLst>
       <p:ext uri="{BB962C8B-B14F-4D97-AF65-F5344CB8AC3E}">
-        <p14:creationId xmlns:p14="http://schemas.microsoft.com/office/powerpoint/2010/main" val="2906003875"/>
+        <p14:creationId xmlns:p14="http://schemas.microsoft.com/office/powerpoint/2010/main" val="2421787297"/>
       </p:ext>
     </p:extLst>
   </p:cSld>
@@ -1476,7 +1476,7 @@
           <a:bodyPr/>
           <a:lstStyle/>
           <a:p>
-            <a:fld id="{3170AC7A-110A-46E3-B788-B77DD47A3800}" type="slidenum">
+            <a:fld id="{E975B6EB-33BA-4191-9F69-5A340388D2ED}" type="slidenum">
               <a:rPr lang="en-US" smtClean="0"/>
               <a:t>5</a:t>
             </a:fld>
@@ -1487,7 +1487,7 @@
     </p:spTree>
     <p:extLst>
       <p:ext uri="{BB962C8B-B14F-4D97-AF65-F5344CB8AC3E}">
-        <p14:creationId xmlns:p14="http://schemas.microsoft.com/office/powerpoint/2010/main" val="2905402951"/>
+        <p14:creationId xmlns:p14="http://schemas.microsoft.com/office/powerpoint/2010/main" val="1928188075"/>
       </p:ext>
     </p:extLst>
   </p:cSld>
@@ -1590,7 +1590,7 @@
           <a:bodyPr/>
           <a:lstStyle/>
           <a:p>
-            <a:fld id="{3170AC7A-110A-46E3-B788-B77DD47A3800}" type="slidenum">
+            <a:fld id="{E975B6EB-33BA-4191-9F69-5A340388D2ED}" type="slidenum">
               <a:rPr lang="en-US" smtClean="0"/>
               <a:t>6</a:t>
             </a:fld>
@@ -1601,7 +1601,7 @@
     </p:spTree>
     <p:extLst>
       <p:ext uri="{BB962C8B-B14F-4D97-AF65-F5344CB8AC3E}">
-        <p14:creationId xmlns:p14="http://schemas.microsoft.com/office/powerpoint/2010/main" val="2415746711"/>
+        <p14:creationId xmlns:p14="http://schemas.microsoft.com/office/powerpoint/2010/main" val="3016237919"/>
       </p:ext>
     </p:extLst>
   </p:cSld>
@@ -1704,7 +1704,7 @@
           <a:bodyPr/>
           <a:lstStyle/>
           <a:p>
-            <a:fld id="{3170AC7A-110A-46E3-B788-B77DD47A3800}" type="slidenum">
+            <a:fld id="{E975B6EB-33BA-4191-9F69-5A340388D2ED}" type="slidenum">
               <a:rPr lang="en-US" smtClean="0"/>
               <a:t>7</a:t>
             </a:fld>
@@ -1715,7 +1715,7 @@
     </p:spTree>
     <p:extLst>
       <p:ext uri="{BB962C8B-B14F-4D97-AF65-F5344CB8AC3E}">
-        <p14:creationId xmlns:p14="http://schemas.microsoft.com/office/powerpoint/2010/main" val="970062912"/>
+        <p14:creationId xmlns:p14="http://schemas.microsoft.com/office/powerpoint/2010/main" val="3407083905"/>
       </p:ext>
     </p:extLst>
   </p:cSld>
@@ -1818,7 +1818,7 @@
           <a:bodyPr/>
           <a:lstStyle/>
           <a:p>
-            <a:fld id="{3170AC7A-110A-46E3-B788-B77DD47A3800}" type="slidenum">
+            <a:fld id="{E975B6EB-33BA-4191-9F69-5A340388D2ED}" type="slidenum">
               <a:rPr lang="en-US" smtClean="0"/>
               <a:t>8</a:t>
             </a:fld>
@@ -1829,7 +1829,7 @@
     </p:spTree>
     <p:extLst>
       <p:ext uri="{BB962C8B-B14F-4D97-AF65-F5344CB8AC3E}">
-        <p14:creationId xmlns:p14="http://schemas.microsoft.com/office/powerpoint/2010/main" val="2508447708"/>
+        <p14:creationId xmlns:p14="http://schemas.microsoft.com/office/powerpoint/2010/main" val="2519927068"/>
       </p:ext>
     </p:extLst>
   </p:cSld>
@@ -1932,7 +1932,7 @@
           <a:bodyPr/>
           <a:lstStyle/>
           <a:p>
-            <a:fld id="{3170AC7A-110A-46E3-B788-B77DD47A3800}" type="slidenum">
+            <a:fld id="{E975B6EB-33BA-4191-9F69-5A340388D2ED}" type="slidenum">
               <a:rPr lang="en-US" smtClean="0"/>
               <a:t>9</a:t>
             </a:fld>
@@ -1943,7 +1943,7 @@
     </p:spTree>
     <p:extLst>
       <p:ext uri="{BB962C8B-B14F-4D97-AF65-F5344CB8AC3E}">
-        <p14:creationId xmlns:p14="http://schemas.microsoft.com/office/powerpoint/2010/main" val="1835046735"/>
+        <p14:creationId xmlns:p14="http://schemas.microsoft.com/office/powerpoint/2010/main" val="2397974666"/>
       </p:ext>
     </p:extLst>
   </p:cSld>
@@ -1975,7 +1975,7 @@
           <p:cNvPr id="2" name="Title 1">
             <a:extLst>
               <a:ext uri="{FF2B5EF4-FFF2-40B4-BE49-F238E27FC236}">
-                <a16:creationId xmlns:a16="http://schemas.microsoft.com/office/drawing/2014/main" id="{8490D82E-FC79-C931-2D6B-39765823A2C5}"/>
+                <a16:creationId xmlns:a16="http://schemas.microsoft.com/office/drawing/2014/main" id="{17A9A763-3042-A951-388D-B807D4942DAF}"/>
               </a:ext>
             </a:extLst>
           </p:cNvPr>
@@ -2012,7 +2012,7 @@
           <p:cNvPr id="3" name="Subtitle 2">
             <a:extLst>
               <a:ext uri="{FF2B5EF4-FFF2-40B4-BE49-F238E27FC236}">
-                <a16:creationId xmlns:a16="http://schemas.microsoft.com/office/drawing/2014/main" id="{C2D161F8-FD6F-ED9F-FFD4-FC44ABCBA39E}"/>
+                <a16:creationId xmlns:a16="http://schemas.microsoft.com/office/drawing/2014/main" id="{CCFABA7F-5CB8-6E4D-BEF5-4D13B39799FF}"/>
               </a:ext>
             </a:extLst>
           </p:cNvPr>
@@ -2082,7 +2082,7 @@
           <p:cNvPr id="4" name="Date Placeholder 3">
             <a:extLst>
               <a:ext uri="{FF2B5EF4-FFF2-40B4-BE49-F238E27FC236}">
-                <a16:creationId xmlns:a16="http://schemas.microsoft.com/office/drawing/2014/main" id="{85E848B6-F0AA-1C8D-20BA-D45ADA7D05D4}"/>
+                <a16:creationId xmlns:a16="http://schemas.microsoft.com/office/drawing/2014/main" id="{2142FB2C-1076-AAA5-C48E-51D504F60B5C}"/>
               </a:ext>
             </a:extLst>
           </p:cNvPr>
@@ -2098,7 +2098,7 @@
           <a:bodyPr/>
           <a:lstStyle/>
           <a:p>
-            <a:fld id="{5A1F434A-A4E2-44EE-8FE5-26BA97D6F415}" type="datetimeFigureOut">
+            <a:fld id="{2B98ED36-E35D-43DE-B7CA-31505E9177C9}" type="datetimeFigureOut">
               <a:rPr lang="en-US" smtClean="0"/>
               <a:t>10/21/2026</a:t>
             </a:fld>
@@ -2111,7 +2111,7 @@
           <p:cNvPr id="5" name="Footer Placeholder 4">
             <a:extLst>
               <a:ext uri="{FF2B5EF4-FFF2-40B4-BE49-F238E27FC236}">
-                <a16:creationId xmlns:a16="http://schemas.microsoft.com/office/drawing/2014/main" id="{82F7405E-590C-758E-67B0-C27C97B8AE60}"/>
+                <a16:creationId xmlns:a16="http://schemas.microsoft.com/office/drawing/2014/main" id="{81D71DFE-5C4F-B2FA-63D3-2D111C3E75B5}"/>
               </a:ext>
             </a:extLst>
           </p:cNvPr>
@@ -2136,7 +2136,7 @@
           <p:cNvPr id="6" name="Slide Number Placeholder 5">
             <a:extLst>
               <a:ext uri="{FF2B5EF4-FFF2-40B4-BE49-F238E27FC236}">
-                <a16:creationId xmlns:a16="http://schemas.microsoft.com/office/drawing/2014/main" id="{719EB0FD-EB7A-E075-5583-AFF5D3CBCC99}"/>
+                <a16:creationId xmlns:a16="http://schemas.microsoft.com/office/drawing/2014/main" id="{64F0C50A-1076-1E37-9FFC-480A7BD81532}"/>
               </a:ext>
             </a:extLst>
           </p:cNvPr>
@@ -2152,7 +2152,7 @@
           <a:bodyPr/>
           <a:lstStyle/>
           <a:p>
-            <a:fld id="{2DF905A9-3EDB-48A4-9CAE-3DEC204A8FAE}" type="slidenum">
+            <a:fld id="{7BB24B89-0397-48D1-9609-4F53AB945D78}" type="slidenum">
               <a:rPr lang="en-US" smtClean="0"/>
               <a:t>‹#›</a:t>
             </a:fld>
@@ -2163,7 +2163,7 @@
     </p:spTree>
     <p:extLst>
       <p:ext uri="{BB962C8B-B14F-4D97-AF65-F5344CB8AC3E}">
-        <p14:creationId xmlns:p14="http://schemas.microsoft.com/office/powerpoint/2010/main" val="511499972"/>
+        <p14:creationId xmlns:p14="http://schemas.microsoft.com/office/powerpoint/2010/main" val="3088891629"/>
       </p:ext>
     </p:extLst>
   </p:cSld>
@@ -2195,7 +2195,7 @@
           <p:cNvPr id="2" name="Title 1">
             <a:extLst>
               <a:ext uri="{FF2B5EF4-FFF2-40B4-BE49-F238E27FC236}">
-                <a16:creationId xmlns:a16="http://schemas.microsoft.com/office/drawing/2014/main" id="{6B0973DA-C2DB-3704-994B-5A8109C09A7A}"/>
+                <a16:creationId xmlns:a16="http://schemas.microsoft.com/office/drawing/2014/main" id="{EBEE9F20-52C6-DAC2-8142-42BB1AD98F01}"/>
               </a:ext>
             </a:extLst>
           </p:cNvPr>
@@ -2223,7 +2223,7 @@
           <p:cNvPr id="3" name="Vertical Text Placeholder 2">
             <a:extLst>
               <a:ext uri="{FF2B5EF4-FFF2-40B4-BE49-F238E27FC236}">
-                <a16:creationId xmlns:a16="http://schemas.microsoft.com/office/drawing/2014/main" id="{A6B893D6-869B-2EDC-87C8-6CC36AA6261D}"/>
+                <a16:creationId xmlns:a16="http://schemas.microsoft.com/office/drawing/2014/main" id="{BA4DA634-F7A0-B30F-6B35-827A2A8A80EC}"/>
               </a:ext>
             </a:extLst>
           </p:cNvPr>
@@ -2280,7 +2280,7 @@
           <p:cNvPr id="4" name="Date Placeholder 3">
             <a:extLst>
               <a:ext uri="{FF2B5EF4-FFF2-40B4-BE49-F238E27FC236}">
-                <a16:creationId xmlns:a16="http://schemas.microsoft.com/office/drawing/2014/main" id="{693AF646-50A8-71D2-D8D0-EC4FCF1E1B87}"/>
+                <a16:creationId xmlns:a16="http://schemas.microsoft.com/office/drawing/2014/main" id="{F4360D67-6857-AADD-ED02-24CC29F3C03A}"/>
               </a:ext>
             </a:extLst>
           </p:cNvPr>
@@ -2296,7 +2296,7 @@
           <a:bodyPr/>
           <a:lstStyle/>
           <a:p>
-            <a:fld id="{5A1F434A-A4E2-44EE-8FE5-26BA97D6F415}" type="datetimeFigureOut">
+            <a:fld id="{2B98ED36-E35D-43DE-B7CA-31505E9177C9}" type="datetimeFigureOut">
               <a:rPr lang="en-US" smtClean="0"/>
               <a:t>10/21/2026</a:t>
             </a:fld>
@@ -2309,7 +2309,7 @@
           <p:cNvPr id="5" name="Footer Placeholder 4">
             <a:extLst>
               <a:ext uri="{FF2B5EF4-FFF2-40B4-BE49-F238E27FC236}">
-                <a16:creationId xmlns:a16="http://schemas.microsoft.com/office/drawing/2014/main" id="{8BB04EA3-784F-4DFB-DEF1-BE36E225CC7D}"/>
+                <a16:creationId xmlns:a16="http://schemas.microsoft.com/office/drawing/2014/main" id="{F0FDEA9F-B9CE-EC1D-8F4F-33AB8325D835}"/>
               </a:ext>
             </a:extLst>
           </p:cNvPr>
@@ -2334,7 +2334,7 @@
           <p:cNvPr id="6" name="Slide Number Placeholder 5">
             <a:extLst>
               <a:ext uri="{FF2B5EF4-FFF2-40B4-BE49-F238E27FC236}">
-                <a16:creationId xmlns:a16="http://schemas.microsoft.com/office/drawing/2014/main" id="{419CE560-640F-787D-E61B-DB59F9CAB628}"/>
+                <a16:creationId xmlns:a16="http://schemas.microsoft.com/office/drawing/2014/main" id="{B978BE93-5C1B-7C2F-0BBC-2924675CE25B}"/>
               </a:ext>
             </a:extLst>
           </p:cNvPr>
@@ -2350,7 +2350,7 @@
           <a:bodyPr/>
           <a:lstStyle/>
           <a:p>
-            <a:fld id="{2DF905A9-3EDB-48A4-9CAE-3DEC204A8FAE}" type="slidenum">
+            <a:fld id="{7BB24B89-0397-48D1-9609-4F53AB945D78}" type="slidenum">
               <a:rPr lang="en-US" smtClean="0"/>
               <a:t>‹#›</a:t>
             </a:fld>
@@ -2361,7 +2361,7 @@
     </p:spTree>
     <p:extLst>
       <p:ext uri="{BB962C8B-B14F-4D97-AF65-F5344CB8AC3E}">
-        <p14:creationId xmlns:p14="http://schemas.microsoft.com/office/powerpoint/2010/main" val="3870501202"/>
+        <p14:creationId xmlns:p14="http://schemas.microsoft.com/office/powerpoint/2010/main" val="1558759417"/>
       </p:ext>
     </p:extLst>
   </p:cSld>
@@ -2393,7 +2393,7 @@
           <p:cNvPr id="2" name="Vertical Title 1">
             <a:extLst>
               <a:ext uri="{FF2B5EF4-FFF2-40B4-BE49-F238E27FC236}">
-                <a16:creationId xmlns:a16="http://schemas.microsoft.com/office/drawing/2014/main" id="{81235BDA-B114-935F-B772-5EF146FC61E3}"/>
+                <a16:creationId xmlns:a16="http://schemas.microsoft.com/office/drawing/2014/main" id="{60C758AA-EC80-B5AA-ECF0-6D7433FBC1AA}"/>
               </a:ext>
             </a:extLst>
           </p:cNvPr>
@@ -2426,7 +2426,7 @@
           <p:cNvPr id="3" name="Vertical Text Placeholder 2">
             <a:extLst>
               <a:ext uri="{FF2B5EF4-FFF2-40B4-BE49-F238E27FC236}">
-                <a16:creationId xmlns:a16="http://schemas.microsoft.com/office/drawing/2014/main" id="{DB832606-39FB-761D-8CFB-82C8BE47B4AC}"/>
+                <a16:creationId xmlns:a16="http://schemas.microsoft.com/office/drawing/2014/main" id="{0AED573D-DB3F-EA26-331F-46FC4313C7AE}"/>
               </a:ext>
             </a:extLst>
           </p:cNvPr>
@@ -2488,7 +2488,7 @@
           <p:cNvPr id="4" name="Date Placeholder 3">
             <a:extLst>
               <a:ext uri="{FF2B5EF4-FFF2-40B4-BE49-F238E27FC236}">
-                <a16:creationId xmlns:a16="http://schemas.microsoft.com/office/drawing/2014/main" id="{73EEF129-52E9-CC1F-9352-538ED78132B2}"/>
+                <a16:creationId xmlns:a16="http://schemas.microsoft.com/office/drawing/2014/main" id="{A48E2DA7-E46E-958D-2EF0-34382B0F646D}"/>
               </a:ext>
             </a:extLst>
           </p:cNvPr>
@@ -2504,7 +2504,7 @@
           <a:bodyPr/>
           <a:lstStyle/>
           <a:p>
-            <a:fld id="{5A1F434A-A4E2-44EE-8FE5-26BA97D6F415}" type="datetimeFigureOut">
+            <a:fld id="{2B98ED36-E35D-43DE-B7CA-31505E9177C9}" type="datetimeFigureOut">
               <a:rPr lang="en-US" smtClean="0"/>
               <a:t>10/21/2026</a:t>
             </a:fld>
@@ -2517,7 +2517,7 @@
           <p:cNvPr id="5" name="Footer Placeholder 4">
             <a:extLst>
               <a:ext uri="{FF2B5EF4-FFF2-40B4-BE49-F238E27FC236}">
-                <a16:creationId xmlns:a16="http://schemas.microsoft.com/office/drawing/2014/main" id="{7BC35254-D75D-85D4-9F7B-9629D1E828FE}"/>
+                <a16:creationId xmlns:a16="http://schemas.microsoft.com/office/drawing/2014/main" id="{AC12DD27-BB6C-7A4B-E02B-ABE461F9040B}"/>
               </a:ext>
             </a:extLst>
           </p:cNvPr>
@@ -2542,7 +2542,7 @@
           <p:cNvPr id="6" name="Slide Number Placeholder 5">
             <a:extLst>
               <a:ext uri="{FF2B5EF4-FFF2-40B4-BE49-F238E27FC236}">
-                <a16:creationId xmlns:a16="http://schemas.microsoft.com/office/drawing/2014/main" id="{D2771A7D-FB78-5D7C-8D77-38578AC75729}"/>
+                <a16:creationId xmlns:a16="http://schemas.microsoft.com/office/drawing/2014/main" id="{C19F7735-A2A9-B14D-2823-74CA645C956A}"/>
               </a:ext>
             </a:extLst>
           </p:cNvPr>
@@ -2558,7 +2558,7 @@
           <a:bodyPr/>
           <a:lstStyle/>
           <a:p>
-            <a:fld id="{2DF905A9-3EDB-48A4-9CAE-3DEC204A8FAE}" type="slidenum">
+            <a:fld id="{7BB24B89-0397-48D1-9609-4F53AB945D78}" type="slidenum">
               <a:rPr lang="en-US" smtClean="0"/>
               <a:t>‹#›</a:t>
             </a:fld>
@@ -2569,7 +2569,7 @@
     </p:spTree>
     <p:extLst>
       <p:ext uri="{BB962C8B-B14F-4D97-AF65-F5344CB8AC3E}">
-        <p14:creationId xmlns:p14="http://schemas.microsoft.com/office/powerpoint/2010/main" val="2717740875"/>
+        <p14:creationId xmlns:p14="http://schemas.microsoft.com/office/powerpoint/2010/main" val="3093345160"/>
       </p:ext>
     </p:extLst>
   </p:cSld>
@@ -2601,7 +2601,7 @@
           <p:cNvPr id="2" name="Title 1">
             <a:extLst>
               <a:ext uri="{FF2B5EF4-FFF2-40B4-BE49-F238E27FC236}">
-                <a16:creationId xmlns:a16="http://schemas.microsoft.com/office/drawing/2014/main" id="{4B2EF4D2-46F9-A8AC-967D-35DBEBF8D76B}"/>
+                <a16:creationId xmlns:a16="http://schemas.microsoft.com/office/drawing/2014/main" id="{5E6FAEBD-E8EA-0E2D-009A-660CD3743622}"/>
               </a:ext>
             </a:extLst>
           </p:cNvPr>
@@ -2629,7 +2629,7 @@
           <p:cNvPr id="3" name="Content Placeholder 2">
             <a:extLst>
               <a:ext uri="{FF2B5EF4-FFF2-40B4-BE49-F238E27FC236}">
-                <a16:creationId xmlns:a16="http://schemas.microsoft.com/office/drawing/2014/main" id="{3898E505-50EB-4977-0F9D-CD25A6BAE63E}"/>
+                <a16:creationId xmlns:a16="http://schemas.microsoft.com/office/drawing/2014/main" id="{D263432C-C853-5E0F-D335-EFBCE863EA0C}"/>
               </a:ext>
             </a:extLst>
           </p:cNvPr>
@@ -2686,7 +2686,7 @@
           <p:cNvPr id="4" name="Date Placeholder 3">
             <a:extLst>
               <a:ext uri="{FF2B5EF4-FFF2-40B4-BE49-F238E27FC236}">
-                <a16:creationId xmlns:a16="http://schemas.microsoft.com/office/drawing/2014/main" id="{4E705764-C6E6-E690-1466-8099954967AC}"/>
+                <a16:creationId xmlns:a16="http://schemas.microsoft.com/office/drawing/2014/main" id="{C36F11F5-9EEC-65E1-CBFA-B5F5A40EBB7A}"/>
               </a:ext>
             </a:extLst>
           </p:cNvPr>
@@ -2702,7 +2702,7 @@
           <a:bodyPr/>
           <a:lstStyle/>
           <a:p>
-            <a:fld id="{5A1F434A-A4E2-44EE-8FE5-26BA97D6F415}" type="datetimeFigureOut">
+            <a:fld id="{2B98ED36-E35D-43DE-B7CA-31505E9177C9}" type="datetimeFigureOut">
               <a:rPr lang="en-US" smtClean="0"/>
               <a:t>10/21/2026</a:t>
             </a:fld>
@@ -2715,7 +2715,7 @@
           <p:cNvPr id="5" name="Footer Placeholder 4">
             <a:extLst>
               <a:ext uri="{FF2B5EF4-FFF2-40B4-BE49-F238E27FC236}">
-                <a16:creationId xmlns:a16="http://schemas.microsoft.com/office/drawing/2014/main" id="{AEA391D7-3FEE-36EE-ED8C-22141D2B9809}"/>
+                <a16:creationId xmlns:a16="http://schemas.microsoft.com/office/drawing/2014/main" id="{21DBF052-70B1-BE35-B670-2C2E2E305418}"/>
               </a:ext>
             </a:extLst>
           </p:cNvPr>
@@ -2740,7 +2740,7 @@
           <p:cNvPr id="6" name="Slide Number Placeholder 5">
             <a:extLst>
               <a:ext uri="{FF2B5EF4-FFF2-40B4-BE49-F238E27FC236}">
-                <a16:creationId xmlns:a16="http://schemas.microsoft.com/office/drawing/2014/main" id="{95E5FE7C-A2A2-AE64-DBE6-C81125AB834C}"/>
+                <a16:creationId xmlns:a16="http://schemas.microsoft.com/office/drawing/2014/main" id="{A0510A3C-3433-C498-D1B4-070B16FC0081}"/>
               </a:ext>
             </a:extLst>
           </p:cNvPr>
@@ -2756,7 +2756,7 @@
           <a:bodyPr/>
           <a:lstStyle/>
           <a:p>
-            <a:fld id="{2DF905A9-3EDB-48A4-9CAE-3DEC204A8FAE}" type="slidenum">
+            <a:fld id="{7BB24B89-0397-48D1-9609-4F53AB945D78}" type="slidenum">
               <a:rPr lang="en-US" smtClean="0"/>
               <a:t>‹#›</a:t>
             </a:fld>
@@ -2767,7 +2767,7 @@
     </p:spTree>
     <p:extLst>
       <p:ext uri="{BB962C8B-B14F-4D97-AF65-F5344CB8AC3E}">
-        <p14:creationId xmlns:p14="http://schemas.microsoft.com/office/powerpoint/2010/main" val="1124720087"/>
+        <p14:creationId xmlns:p14="http://schemas.microsoft.com/office/powerpoint/2010/main" val="2526809956"/>
       </p:ext>
     </p:extLst>
   </p:cSld>
@@ -2799,7 +2799,7 @@
           <p:cNvPr id="2" name="Title 1">
             <a:extLst>
               <a:ext uri="{FF2B5EF4-FFF2-40B4-BE49-F238E27FC236}">
-                <a16:creationId xmlns:a16="http://schemas.microsoft.com/office/drawing/2014/main" id="{BFBEDF1D-BB64-02F0-F49D-B4AB36FF0C29}"/>
+                <a16:creationId xmlns:a16="http://schemas.microsoft.com/office/drawing/2014/main" id="{59D985E4-AA59-43B7-D9A0-A2ECD57FCE5D}"/>
               </a:ext>
             </a:extLst>
           </p:cNvPr>
@@ -2836,7 +2836,7 @@
           <p:cNvPr id="3" name="Text Placeholder 2">
             <a:extLst>
               <a:ext uri="{FF2B5EF4-FFF2-40B4-BE49-F238E27FC236}">
-                <a16:creationId xmlns:a16="http://schemas.microsoft.com/office/drawing/2014/main" id="{6171A3D9-6682-3B97-16BB-C39E0872F4FD}"/>
+                <a16:creationId xmlns:a16="http://schemas.microsoft.com/office/drawing/2014/main" id="{8EF3EB92-0E60-8C7F-C792-AB5C22FC15C5}"/>
               </a:ext>
             </a:extLst>
           </p:cNvPr>
@@ -2961,7 +2961,7 @@
           <p:cNvPr id="4" name="Date Placeholder 3">
             <a:extLst>
               <a:ext uri="{FF2B5EF4-FFF2-40B4-BE49-F238E27FC236}">
-                <a16:creationId xmlns:a16="http://schemas.microsoft.com/office/drawing/2014/main" id="{7877B5BB-99D6-FEBB-3ABB-D21627BA53FB}"/>
+                <a16:creationId xmlns:a16="http://schemas.microsoft.com/office/drawing/2014/main" id="{510EEEE6-E692-2406-B78D-DFFA0C713EC3}"/>
               </a:ext>
             </a:extLst>
           </p:cNvPr>
@@ -2977,7 +2977,7 @@
           <a:bodyPr/>
           <a:lstStyle/>
           <a:p>
-            <a:fld id="{5A1F434A-A4E2-44EE-8FE5-26BA97D6F415}" type="datetimeFigureOut">
+            <a:fld id="{2B98ED36-E35D-43DE-B7CA-31505E9177C9}" type="datetimeFigureOut">
               <a:rPr lang="en-US" smtClean="0"/>
               <a:t>10/21/2026</a:t>
             </a:fld>
@@ -2990,7 +2990,7 @@
           <p:cNvPr id="5" name="Footer Placeholder 4">
             <a:extLst>
               <a:ext uri="{FF2B5EF4-FFF2-40B4-BE49-F238E27FC236}">
-                <a16:creationId xmlns:a16="http://schemas.microsoft.com/office/drawing/2014/main" id="{8BFE87BF-C597-2C91-93DA-63A357429042}"/>
+                <a16:creationId xmlns:a16="http://schemas.microsoft.com/office/drawing/2014/main" id="{DDB7C272-F8A5-EF3A-0AB0-127A83BB6E8B}"/>
               </a:ext>
             </a:extLst>
           </p:cNvPr>
@@ -3015,7 +3015,7 @@
           <p:cNvPr id="6" name="Slide Number Placeholder 5">
             <a:extLst>
               <a:ext uri="{FF2B5EF4-FFF2-40B4-BE49-F238E27FC236}">
-                <a16:creationId xmlns:a16="http://schemas.microsoft.com/office/drawing/2014/main" id="{2226FBD9-025C-EC7C-938F-16712AD92B76}"/>
+                <a16:creationId xmlns:a16="http://schemas.microsoft.com/office/drawing/2014/main" id="{EC1FDE94-CB3C-D68B-C0D2-DF5F7806A090}"/>
               </a:ext>
             </a:extLst>
           </p:cNvPr>
@@ -3031,7 +3031,7 @@
           <a:bodyPr/>
           <a:lstStyle/>
           <a:p>
-            <a:fld id="{2DF905A9-3EDB-48A4-9CAE-3DEC204A8FAE}" type="slidenum">
+            <a:fld id="{7BB24B89-0397-48D1-9609-4F53AB945D78}" type="slidenum">
               <a:rPr lang="en-US" smtClean="0"/>
               <a:t>‹#›</a:t>
             </a:fld>
@@ -3042,7 +3042,7 @@
     </p:spTree>
     <p:extLst>
       <p:ext uri="{BB962C8B-B14F-4D97-AF65-F5344CB8AC3E}">
-        <p14:creationId xmlns:p14="http://schemas.microsoft.com/office/powerpoint/2010/main" val="776549930"/>
+        <p14:creationId xmlns:p14="http://schemas.microsoft.com/office/powerpoint/2010/main" val="164603674"/>
       </p:ext>
     </p:extLst>
   </p:cSld>
@@ -3074,7 +3074,7 @@
           <p:cNvPr id="2" name="Title 1">
             <a:extLst>
               <a:ext uri="{FF2B5EF4-FFF2-40B4-BE49-F238E27FC236}">
-                <a16:creationId xmlns:a16="http://schemas.microsoft.com/office/drawing/2014/main" id="{E9D82907-03BB-7D03-350D-4E5BB5ABBAFE}"/>
+                <a16:creationId xmlns:a16="http://schemas.microsoft.com/office/drawing/2014/main" id="{1FBE84BA-F4AC-618B-DF33-17A6DD886A58}"/>
               </a:ext>
             </a:extLst>
           </p:cNvPr>
@@ -3102,7 +3102,7 @@
           <p:cNvPr id="3" name="Content Placeholder 2">
             <a:extLst>
               <a:ext uri="{FF2B5EF4-FFF2-40B4-BE49-F238E27FC236}">
-                <a16:creationId xmlns:a16="http://schemas.microsoft.com/office/drawing/2014/main" id="{13F6AEC4-2603-6ED7-9D99-6507A14B2E7F}"/>
+                <a16:creationId xmlns:a16="http://schemas.microsoft.com/office/drawing/2014/main" id="{EDD4D06D-9DB7-4587-E42D-4B515479C423}"/>
               </a:ext>
             </a:extLst>
           </p:cNvPr>
@@ -3164,7 +3164,7 @@
           <p:cNvPr id="4" name="Content Placeholder 3">
             <a:extLst>
               <a:ext uri="{FF2B5EF4-FFF2-40B4-BE49-F238E27FC236}">
-                <a16:creationId xmlns:a16="http://schemas.microsoft.com/office/drawing/2014/main" id="{C2F6A3A1-E712-FDFC-0D80-5114D32AD347}"/>
+                <a16:creationId xmlns:a16="http://schemas.microsoft.com/office/drawing/2014/main" id="{70960613-1B31-9D0F-5CED-51355D8A9EA8}"/>
               </a:ext>
             </a:extLst>
           </p:cNvPr>
@@ -3226,7 +3226,7 @@
           <p:cNvPr id="5" name="Date Placeholder 4">
             <a:extLst>
               <a:ext uri="{FF2B5EF4-FFF2-40B4-BE49-F238E27FC236}">
-                <a16:creationId xmlns:a16="http://schemas.microsoft.com/office/drawing/2014/main" id="{235FE664-FC47-2D4F-BA65-F78849CF72DA}"/>
+                <a16:creationId xmlns:a16="http://schemas.microsoft.com/office/drawing/2014/main" id="{A5E54E72-9510-22D0-C86C-9E3A39D18B36}"/>
               </a:ext>
             </a:extLst>
           </p:cNvPr>
@@ -3242,7 +3242,7 @@
           <a:bodyPr/>
           <a:lstStyle/>
           <a:p>
-            <a:fld id="{5A1F434A-A4E2-44EE-8FE5-26BA97D6F415}" type="datetimeFigureOut">
+            <a:fld id="{2B98ED36-E35D-43DE-B7CA-31505E9177C9}" type="datetimeFigureOut">
               <a:rPr lang="en-US" smtClean="0"/>
               <a:t>10/21/2026</a:t>
             </a:fld>
@@ -3255,7 +3255,7 @@
           <p:cNvPr id="6" name="Footer Placeholder 5">
             <a:extLst>
               <a:ext uri="{FF2B5EF4-FFF2-40B4-BE49-F238E27FC236}">
-                <a16:creationId xmlns:a16="http://schemas.microsoft.com/office/drawing/2014/main" id="{AB66D22C-DEDC-9973-1A8B-AB9F4D474B36}"/>
+                <a16:creationId xmlns:a16="http://schemas.microsoft.com/office/drawing/2014/main" id="{EB4397F0-62C7-E00A-6F78-A2B4A1D32003}"/>
               </a:ext>
             </a:extLst>
           </p:cNvPr>
@@ -3280,7 +3280,7 @@
           <p:cNvPr id="7" name="Slide Number Placeholder 6">
             <a:extLst>
               <a:ext uri="{FF2B5EF4-FFF2-40B4-BE49-F238E27FC236}">
-                <a16:creationId xmlns:a16="http://schemas.microsoft.com/office/drawing/2014/main" id="{1104DD3A-611B-4F64-A9C9-D18C37875D46}"/>
+                <a16:creationId xmlns:a16="http://schemas.microsoft.com/office/drawing/2014/main" id="{58057BE4-3771-F311-ABBC-9F33C7082F0A}"/>
               </a:ext>
             </a:extLst>
           </p:cNvPr>
@@ -3296,7 +3296,7 @@
           <a:bodyPr/>
           <a:lstStyle/>
           <a:p>
-            <a:fld id="{2DF905A9-3EDB-48A4-9CAE-3DEC204A8FAE}" type="slidenum">
+            <a:fld id="{7BB24B89-0397-48D1-9609-4F53AB945D78}" type="slidenum">
               <a:rPr lang="en-US" smtClean="0"/>
               <a:t>‹#›</a:t>
             </a:fld>
@@ -3307,7 +3307,7 @@
     </p:spTree>
     <p:extLst>
       <p:ext uri="{BB962C8B-B14F-4D97-AF65-F5344CB8AC3E}">
-        <p14:creationId xmlns:p14="http://schemas.microsoft.com/office/powerpoint/2010/main" val="2120832531"/>
+        <p14:creationId xmlns:p14="http://schemas.microsoft.com/office/powerpoint/2010/main" val="2594866453"/>
       </p:ext>
     </p:extLst>
   </p:cSld>
@@ -3339,7 +3339,7 @@
           <p:cNvPr id="2" name="Title 1">
             <a:extLst>
               <a:ext uri="{FF2B5EF4-FFF2-40B4-BE49-F238E27FC236}">
-                <a16:creationId xmlns:a16="http://schemas.microsoft.com/office/drawing/2014/main" id="{24CC6B9F-CA9A-5C06-1115-57C90A11A5C8}"/>
+                <a16:creationId xmlns:a16="http://schemas.microsoft.com/office/drawing/2014/main" id="{3C4742C9-7AB7-9A7A-FEDA-6AA43BFF3EC2}"/>
               </a:ext>
             </a:extLst>
           </p:cNvPr>
@@ -3372,7 +3372,7 @@
           <p:cNvPr id="3" name="Text Placeholder 2">
             <a:extLst>
               <a:ext uri="{FF2B5EF4-FFF2-40B4-BE49-F238E27FC236}">
-                <a16:creationId xmlns:a16="http://schemas.microsoft.com/office/drawing/2014/main" id="{D13D49E4-3C40-6745-414B-2080C31A6AAA}"/>
+                <a16:creationId xmlns:a16="http://schemas.microsoft.com/office/drawing/2014/main" id="{816F569F-7513-D02B-8CFA-8BFF72221E11}"/>
               </a:ext>
             </a:extLst>
           </p:cNvPr>
@@ -3443,7 +3443,7 @@
           <p:cNvPr id="4" name="Content Placeholder 3">
             <a:extLst>
               <a:ext uri="{FF2B5EF4-FFF2-40B4-BE49-F238E27FC236}">
-                <a16:creationId xmlns:a16="http://schemas.microsoft.com/office/drawing/2014/main" id="{D9EB6460-A539-43F0-4BDE-37F3E8BA251A}"/>
+                <a16:creationId xmlns:a16="http://schemas.microsoft.com/office/drawing/2014/main" id="{1EF65843-8FF5-82C3-C910-FE79FDC6DFB5}"/>
               </a:ext>
             </a:extLst>
           </p:cNvPr>
@@ -3505,7 +3505,7 @@
           <p:cNvPr id="5" name="Text Placeholder 4">
             <a:extLst>
               <a:ext uri="{FF2B5EF4-FFF2-40B4-BE49-F238E27FC236}">
-                <a16:creationId xmlns:a16="http://schemas.microsoft.com/office/drawing/2014/main" id="{4892F51B-CC50-D86F-DFE2-6E8CD7902352}"/>
+                <a16:creationId xmlns:a16="http://schemas.microsoft.com/office/drawing/2014/main" id="{230261C5-3A92-3A28-EF94-88CCE0613E4E}"/>
               </a:ext>
             </a:extLst>
           </p:cNvPr>
@@ -3576,7 +3576,7 @@
           <p:cNvPr id="6" name="Content Placeholder 5">
             <a:extLst>
               <a:ext uri="{FF2B5EF4-FFF2-40B4-BE49-F238E27FC236}">
-                <a16:creationId xmlns:a16="http://schemas.microsoft.com/office/drawing/2014/main" id="{9D7E7189-9F14-74CB-1D0D-88051AAA5605}"/>
+                <a16:creationId xmlns:a16="http://schemas.microsoft.com/office/drawing/2014/main" id="{A62CE19B-65AD-90F2-A46F-E51B6B445247}"/>
               </a:ext>
             </a:extLst>
           </p:cNvPr>
@@ -3638,7 +3638,7 @@
           <p:cNvPr id="7" name="Date Placeholder 6">
             <a:extLst>
               <a:ext uri="{FF2B5EF4-FFF2-40B4-BE49-F238E27FC236}">
-                <a16:creationId xmlns:a16="http://schemas.microsoft.com/office/drawing/2014/main" id="{87FBC77B-6750-5393-3AEF-9211E3E8161D}"/>
+                <a16:creationId xmlns:a16="http://schemas.microsoft.com/office/drawing/2014/main" id="{82B984C1-1DEF-0D9F-6354-F8C19038D507}"/>
               </a:ext>
             </a:extLst>
           </p:cNvPr>
@@ -3654,7 +3654,7 @@
           <a:bodyPr/>
           <a:lstStyle/>
           <a:p>
-            <a:fld id="{5A1F434A-A4E2-44EE-8FE5-26BA97D6F415}" type="datetimeFigureOut">
+            <a:fld id="{2B98ED36-E35D-43DE-B7CA-31505E9177C9}" type="datetimeFigureOut">
               <a:rPr lang="en-US" smtClean="0"/>
               <a:t>10/21/2026</a:t>
             </a:fld>
@@ -3667,7 +3667,7 @@
           <p:cNvPr id="8" name="Footer Placeholder 7">
             <a:extLst>
               <a:ext uri="{FF2B5EF4-FFF2-40B4-BE49-F238E27FC236}">
-                <a16:creationId xmlns:a16="http://schemas.microsoft.com/office/drawing/2014/main" id="{AA2FC9A9-6D9E-75D6-ABD0-4F42F8BEB404}"/>
+                <a16:creationId xmlns:a16="http://schemas.microsoft.com/office/drawing/2014/main" id="{787C5C8D-9059-7BCF-D0E2-F7DA3E7DBE87}"/>
               </a:ext>
             </a:extLst>
           </p:cNvPr>
@@ -3692,7 +3692,7 @@
           <p:cNvPr id="9" name="Slide Number Placeholder 8">
             <a:extLst>
               <a:ext uri="{FF2B5EF4-FFF2-40B4-BE49-F238E27FC236}">
-                <a16:creationId xmlns:a16="http://schemas.microsoft.com/office/drawing/2014/main" id="{909B81C5-42C5-2264-1EB4-7455E0F6DF02}"/>
+                <a16:creationId xmlns:a16="http://schemas.microsoft.com/office/drawing/2014/main" id="{914EF063-2BD5-5E56-CEA1-0696081C9D99}"/>
               </a:ext>
             </a:extLst>
           </p:cNvPr>
@@ -3708,7 +3708,7 @@
           <a:bodyPr/>
           <a:lstStyle/>
           <a:p>
-            <a:fld id="{2DF905A9-3EDB-48A4-9CAE-3DEC204A8FAE}" type="slidenum">
+            <a:fld id="{7BB24B89-0397-48D1-9609-4F53AB945D78}" type="slidenum">
               <a:rPr lang="en-US" smtClean="0"/>
               <a:t>‹#›</a:t>
             </a:fld>
@@ -3719,7 +3719,7 @@
     </p:spTree>
     <p:extLst>
       <p:ext uri="{BB962C8B-B14F-4D97-AF65-F5344CB8AC3E}">
-        <p14:creationId xmlns:p14="http://schemas.microsoft.com/office/powerpoint/2010/main" val="3716277374"/>
+        <p14:creationId xmlns:p14="http://schemas.microsoft.com/office/powerpoint/2010/main" val="2360125273"/>
       </p:ext>
     </p:extLst>
   </p:cSld>
@@ -3751,7 +3751,7 @@
           <p:cNvPr id="2" name="Title 1">
             <a:extLst>
               <a:ext uri="{FF2B5EF4-FFF2-40B4-BE49-F238E27FC236}">
-                <a16:creationId xmlns:a16="http://schemas.microsoft.com/office/drawing/2014/main" id="{1AEFF241-9DBE-5F0B-83CE-C496A8B68908}"/>
+                <a16:creationId xmlns:a16="http://schemas.microsoft.com/office/drawing/2014/main" id="{FD23F7B6-94E0-7C0A-859E-29537FA6084E}"/>
               </a:ext>
             </a:extLst>
           </p:cNvPr>
@@ -3779,7 +3779,7 @@
           <p:cNvPr id="3" name="Date Placeholder 2">
             <a:extLst>
               <a:ext uri="{FF2B5EF4-FFF2-40B4-BE49-F238E27FC236}">
-                <a16:creationId xmlns:a16="http://schemas.microsoft.com/office/drawing/2014/main" id="{ADDCA294-AE37-A140-9440-5921D302DDFC}"/>
+                <a16:creationId xmlns:a16="http://schemas.microsoft.com/office/drawing/2014/main" id="{2E4B82B5-5CA4-65A7-988E-09E30484E459}"/>
               </a:ext>
             </a:extLst>
           </p:cNvPr>
@@ -3795,7 +3795,7 @@
           <a:bodyPr/>
           <a:lstStyle/>
           <a:p>
-            <a:fld id="{5A1F434A-A4E2-44EE-8FE5-26BA97D6F415}" type="datetimeFigureOut">
+            <a:fld id="{2B98ED36-E35D-43DE-B7CA-31505E9177C9}" type="datetimeFigureOut">
               <a:rPr lang="en-US" smtClean="0"/>
               <a:t>10/21/2026</a:t>
             </a:fld>
@@ -3808,7 +3808,7 @@
           <p:cNvPr id="4" name="Footer Placeholder 3">
             <a:extLst>
               <a:ext uri="{FF2B5EF4-FFF2-40B4-BE49-F238E27FC236}">
-                <a16:creationId xmlns:a16="http://schemas.microsoft.com/office/drawing/2014/main" id="{3DFF89D0-8964-9935-CA8C-F60230D29710}"/>
+                <a16:creationId xmlns:a16="http://schemas.microsoft.com/office/drawing/2014/main" id="{BEC2CBDD-C789-5B92-AB92-9A533003EEE9}"/>
               </a:ext>
             </a:extLst>
           </p:cNvPr>
@@ -3833,7 +3833,7 @@
           <p:cNvPr id="5" name="Slide Number Placeholder 4">
             <a:extLst>
               <a:ext uri="{FF2B5EF4-FFF2-40B4-BE49-F238E27FC236}">
-                <a16:creationId xmlns:a16="http://schemas.microsoft.com/office/drawing/2014/main" id="{FD2300C4-0977-3950-4CF1-24810E24046B}"/>
+                <a16:creationId xmlns:a16="http://schemas.microsoft.com/office/drawing/2014/main" id="{F252714F-D0C1-0275-205E-7D3684A6D554}"/>
               </a:ext>
             </a:extLst>
           </p:cNvPr>
@@ -3849,7 +3849,7 @@
           <a:bodyPr/>
           <a:lstStyle/>
           <a:p>
-            <a:fld id="{2DF905A9-3EDB-48A4-9CAE-3DEC204A8FAE}" type="slidenum">
+            <a:fld id="{7BB24B89-0397-48D1-9609-4F53AB945D78}" type="slidenum">
               <a:rPr lang="en-US" smtClean="0"/>
               <a:t>‹#›</a:t>
             </a:fld>
@@ -3860,7 +3860,7 @@
     </p:spTree>
     <p:extLst>
       <p:ext uri="{BB962C8B-B14F-4D97-AF65-F5344CB8AC3E}">
-        <p14:creationId xmlns:p14="http://schemas.microsoft.com/office/powerpoint/2010/main" val="1867071018"/>
+        <p14:creationId xmlns:p14="http://schemas.microsoft.com/office/powerpoint/2010/main" val="790289350"/>
       </p:ext>
     </p:extLst>
   </p:cSld>
@@ -3892,7 +3892,7 @@
           <p:cNvPr id="2" name="Date Placeholder 1">
             <a:extLst>
               <a:ext uri="{FF2B5EF4-FFF2-40B4-BE49-F238E27FC236}">
-                <a16:creationId xmlns:a16="http://schemas.microsoft.com/office/drawing/2014/main" id="{182C00A0-E244-AA0D-68E7-D50B3DF9756C}"/>
+                <a16:creationId xmlns:a16="http://schemas.microsoft.com/office/drawing/2014/main" id="{0165936E-2B84-01A0-789B-E4AA4047AA96}"/>
               </a:ext>
             </a:extLst>
           </p:cNvPr>
@@ -3908,7 +3908,7 @@
           <a:bodyPr/>
           <a:lstStyle/>
           <a:p>
-            <a:fld id="{5A1F434A-A4E2-44EE-8FE5-26BA97D6F415}" type="datetimeFigureOut">
+            <a:fld id="{2B98ED36-E35D-43DE-B7CA-31505E9177C9}" type="datetimeFigureOut">
               <a:rPr lang="en-US" smtClean="0"/>
               <a:t>10/21/2026</a:t>
             </a:fld>
@@ -3921,7 +3921,7 @@
           <p:cNvPr id="3" name="Footer Placeholder 2">
             <a:extLst>
               <a:ext uri="{FF2B5EF4-FFF2-40B4-BE49-F238E27FC236}">
-                <a16:creationId xmlns:a16="http://schemas.microsoft.com/office/drawing/2014/main" id="{67DC061E-4AF5-1FCE-6829-94D28A27E376}"/>
+                <a16:creationId xmlns:a16="http://schemas.microsoft.com/office/drawing/2014/main" id="{C029DFDB-412C-5941-E3B0-B3C0FA84A9A0}"/>
               </a:ext>
             </a:extLst>
           </p:cNvPr>
@@ -3946,7 +3946,7 @@
           <p:cNvPr id="4" name="Slide Number Placeholder 3">
             <a:extLst>
               <a:ext uri="{FF2B5EF4-FFF2-40B4-BE49-F238E27FC236}">
-                <a16:creationId xmlns:a16="http://schemas.microsoft.com/office/drawing/2014/main" id="{DF64A5D7-D22F-8B69-45E7-72D8C21343B1}"/>
+                <a16:creationId xmlns:a16="http://schemas.microsoft.com/office/drawing/2014/main" id="{78115D5F-217D-9C1C-ACF3-444B48929F6E}"/>
               </a:ext>
             </a:extLst>
           </p:cNvPr>
@@ -3962,7 +3962,7 @@
           <a:bodyPr/>
           <a:lstStyle/>
           <a:p>
-            <a:fld id="{2DF905A9-3EDB-48A4-9CAE-3DEC204A8FAE}" type="slidenum">
+            <a:fld id="{7BB24B89-0397-48D1-9609-4F53AB945D78}" type="slidenum">
               <a:rPr lang="en-US" smtClean="0"/>
               <a:t>‹#›</a:t>
             </a:fld>
@@ -3973,7 +3973,7 @@
     </p:spTree>
     <p:extLst>
       <p:ext uri="{BB962C8B-B14F-4D97-AF65-F5344CB8AC3E}">
-        <p14:creationId xmlns:p14="http://schemas.microsoft.com/office/powerpoint/2010/main" val="491064235"/>
+        <p14:creationId xmlns:p14="http://schemas.microsoft.com/office/powerpoint/2010/main" val="970160581"/>
       </p:ext>
     </p:extLst>
   </p:cSld>
@@ -4005,7 +4005,7 @@
           <p:cNvPr id="2" name="Title 1">
             <a:extLst>
               <a:ext uri="{FF2B5EF4-FFF2-40B4-BE49-F238E27FC236}">
-                <a16:creationId xmlns:a16="http://schemas.microsoft.com/office/drawing/2014/main" id="{C09BA5C1-0DB6-59B5-23CC-0BB967C503BE}"/>
+                <a16:creationId xmlns:a16="http://schemas.microsoft.com/office/drawing/2014/main" id="{1CA829B8-6255-85CA-D0ED-ADCC7B939E73}"/>
               </a:ext>
             </a:extLst>
           </p:cNvPr>
@@ -4042,7 +4042,7 @@
           <p:cNvPr id="3" name="Content Placeholder 2">
             <a:extLst>
               <a:ext uri="{FF2B5EF4-FFF2-40B4-BE49-F238E27FC236}">
-                <a16:creationId xmlns:a16="http://schemas.microsoft.com/office/drawing/2014/main" id="{302D3604-8330-7E86-9B41-AF7AF044E3B2}"/>
+                <a16:creationId xmlns:a16="http://schemas.microsoft.com/office/drawing/2014/main" id="{FC48FC83-17D9-F3D6-D612-FF593F9BB460}"/>
               </a:ext>
             </a:extLst>
           </p:cNvPr>
@@ -4132,7 +4132,7 @@
           <p:cNvPr id="4" name="Text Placeholder 3">
             <a:extLst>
               <a:ext uri="{FF2B5EF4-FFF2-40B4-BE49-F238E27FC236}">
-                <a16:creationId xmlns:a16="http://schemas.microsoft.com/office/drawing/2014/main" id="{9173EC27-7339-7E65-D66C-E36FAB801308}"/>
+                <a16:creationId xmlns:a16="http://schemas.microsoft.com/office/drawing/2014/main" id="{5A197A97-AD42-8014-E088-037237ABB84B}"/>
               </a:ext>
             </a:extLst>
           </p:cNvPr>
@@ -4203,7 +4203,7 @@
           <p:cNvPr id="5" name="Date Placeholder 4">
             <a:extLst>
               <a:ext uri="{FF2B5EF4-FFF2-40B4-BE49-F238E27FC236}">
-                <a16:creationId xmlns:a16="http://schemas.microsoft.com/office/drawing/2014/main" id="{70F2B560-F652-5E5D-EEF6-8DBEC3A27BEB}"/>
+                <a16:creationId xmlns:a16="http://schemas.microsoft.com/office/drawing/2014/main" id="{967E6889-3140-5D73-D00D-79431ADA0455}"/>
               </a:ext>
             </a:extLst>
           </p:cNvPr>
@@ -4219,7 +4219,7 @@
           <a:bodyPr/>
           <a:lstStyle/>
           <a:p>
-            <a:fld id="{5A1F434A-A4E2-44EE-8FE5-26BA97D6F415}" type="datetimeFigureOut">
+            <a:fld id="{2B98ED36-E35D-43DE-B7CA-31505E9177C9}" type="datetimeFigureOut">
               <a:rPr lang="en-US" smtClean="0"/>
               <a:t>10/21/2026</a:t>
             </a:fld>
@@ -4232,7 +4232,7 @@
           <p:cNvPr id="6" name="Footer Placeholder 5">
             <a:extLst>
               <a:ext uri="{FF2B5EF4-FFF2-40B4-BE49-F238E27FC236}">
-                <a16:creationId xmlns:a16="http://schemas.microsoft.com/office/drawing/2014/main" id="{AE2A6B08-F077-7EB4-A957-F5E8236367C7}"/>
+                <a16:creationId xmlns:a16="http://schemas.microsoft.com/office/drawing/2014/main" id="{63DCF569-C44B-395E-DD2D-0AC250D9197A}"/>
               </a:ext>
             </a:extLst>
           </p:cNvPr>
@@ -4257,7 +4257,7 @@
           <p:cNvPr id="7" name="Slide Number Placeholder 6">
             <a:extLst>
               <a:ext uri="{FF2B5EF4-FFF2-40B4-BE49-F238E27FC236}">
-                <a16:creationId xmlns:a16="http://schemas.microsoft.com/office/drawing/2014/main" id="{21505407-CB6A-9D18-00AE-51FB4515F3D0}"/>
+                <a16:creationId xmlns:a16="http://schemas.microsoft.com/office/drawing/2014/main" id="{DEEC1C6F-3AD3-AD3E-6A81-C7FC13627E17}"/>
               </a:ext>
             </a:extLst>
           </p:cNvPr>
@@ -4273,7 +4273,7 @@
           <a:bodyPr/>
           <a:lstStyle/>
           <a:p>
-            <a:fld id="{2DF905A9-3EDB-48A4-9CAE-3DEC204A8FAE}" type="slidenum">
+            <a:fld id="{7BB24B89-0397-48D1-9609-4F53AB945D78}" type="slidenum">
               <a:rPr lang="en-US" smtClean="0"/>
               <a:t>‹#›</a:t>
             </a:fld>
@@ -4284,7 +4284,7 @@
     </p:spTree>
     <p:extLst>
       <p:ext uri="{BB962C8B-B14F-4D97-AF65-F5344CB8AC3E}">
-        <p14:creationId xmlns:p14="http://schemas.microsoft.com/office/powerpoint/2010/main" val="4154868072"/>
+        <p14:creationId xmlns:p14="http://schemas.microsoft.com/office/powerpoint/2010/main" val="3530744715"/>
       </p:ext>
     </p:extLst>
   </p:cSld>
@@ -4316,7 +4316,7 @@
           <p:cNvPr id="2" name="Title 1">
             <a:extLst>
               <a:ext uri="{FF2B5EF4-FFF2-40B4-BE49-F238E27FC236}">
-                <a16:creationId xmlns:a16="http://schemas.microsoft.com/office/drawing/2014/main" id="{1158370B-197A-8158-A574-24C6A4D04659}"/>
+                <a16:creationId xmlns:a16="http://schemas.microsoft.com/office/drawing/2014/main" id="{DA4BC696-D801-93B4-112D-95A912100CE4}"/>
               </a:ext>
             </a:extLst>
           </p:cNvPr>
@@ -4353,7 +4353,7 @@
           <p:cNvPr id="3" name="Picture Placeholder 2">
             <a:extLst>
               <a:ext uri="{FF2B5EF4-FFF2-40B4-BE49-F238E27FC236}">
-                <a16:creationId xmlns:a16="http://schemas.microsoft.com/office/drawing/2014/main" id="{4F79AD52-D4B0-D57A-1AB8-3D83A3BE991E}"/>
+                <a16:creationId xmlns:a16="http://schemas.microsoft.com/office/drawing/2014/main" id="{C19C5909-E180-A08B-9C8D-61E7B19BA085}"/>
               </a:ext>
             </a:extLst>
           </p:cNvPr>
@@ -4420,7 +4420,7 @@
           <p:cNvPr id="4" name="Text Placeholder 3">
             <a:extLst>
               <a:ext uri="{FF2B5EF4-FFF2-40B4-BE49-F238E27FC236}">
-                <a16:creationId xmlns:a16="http://schemas.microsoft.com/office/drawing/2014/main" id="{E7F0EB70-18C6-E72E-7743-106F7389F4B6}"/>
+                <a16:creationId xmlns:a16="http://schemas.microsoft.com/office/drawing/2014/main" id="{FCFA0476-C7A5-CF14-E90D-5E09A4AFCAA7}"/>
               </a:ext>
             </a:extLst>
           </p:cNvPr>
@@ -4491,7 +4491,7 @@
           <p:cNvPr id="5" name="Date Placeholder 4">
             <a:extLst>
               <a:ext uri="{FF2B5EF4-FFF2-40B4-BE49-F238E27FC236}">
-                <a16:creationId xmlns:a16="http://schemas.microsoft.com/office/drawing/2014/main" id="{FCC42B02-8170-8862-911B-ED6FA6354BA2}"/>
+                <a16:creationId xmlns:a16="http://schemas.microsoft.com/office/drawing/2014/main" id="{716EC43E-4478-D1FA-C7B4-F3B58C3BA2CB}"/>
               </a:ext>
             </a:extLst>
           </p:cNvPr>
@@ -4507,7 +4507,7 @@
           <a:bodyPr/>
           <a:lstStyle/>
           <a:p>
-            <a:fld id="{5A1F434A-A4E2-44EE-8FE5-26BA97D6F415}" type="datetimeFigureOut">
+            <a:fld id="{2B98ED36-E35D-43DE-B7CA-31505E9177C9}" type="datetimeFigureOut">
               <a:rPr lang="en-US" smtClean="0"/>
               <a:t>10/21/2026</a:t>
             </a:fld>
@@ -4520,7 +4520,7 @@
           <p:cNvPr id="6" name="Footer Placeholder 5">
             <a:extLst>
               <a:ext uri="{FF2B5EF4-FFF2-40B4-BE49-F238E27FC236}">
-                <a16:creationId xmlns:a16="http://schemas.microsoft.com/office/drawing/2014/main" id="{9E1E4910-A294-7E29-6090-9E5FED9F930C}"/>
+                <a16:creationId xmlns:a16="http://schemas.microsoft.com/office/drawing/2014/main" id="{DB636A9F-0BED-20C7-1F39-0199E7C7034D}"/>
               </a:ext>
             </a:extLst>
           </p:cNvPr>
@@ -4545,7 +4545,7 @@
           <p:cNvPr id="7" name="Slide Number Placeholder 6">
             <a:extLst>
               <a:ext uri="{FF2B5EF4-FFF2-40B4-BE49-F238E27FC236}">
-                <a16:creationId xmlns:a16="http://schemas.microsoft.com/office/drawing/2014/main" id="{873D985F-736A-9867-0BC8-406D411C3353}"/>
+                <a16:creationId xmlns:a16="http://schemas.microsoft.com/office/drawing/2014/main" id="{9DD2F99B-4213-8B53-627A-6B1A51674B17}"/>
               </a:ext>
             </a:extLst>
           </p:cNvPr>
@@ -4561,7 +4561,7 @@
           <a:bodyPr/>
           <a:lstStyle/>
           <a:p>
-            <a:fld id="{2DF905A9-3EDB-48A4-9CAE-3DEC204A8FAE}" type="slidenum">
+            <a:fld id="{7BB24B89-0397-48D1-9609-4F53AB945D78}" type="slidenum">
               <a:rPr lang="en-US" smtClean="0"/>
               <a:t>‹#›</a:t>
             </a:fld>
@@ -4572,7 +4572,7 @@
     </p:spTree>
     <p:extLst>
       <p:ext uri="{BB962C8B-B14F-4D97-AF65-F5344CB8AC3E}">
-        <p14:creationId xmlns:p14="http://schemas.microsoft.com/office/powerpoint/2010/main" val="2553021271"/>
+        <p14:creationId xmlns:p14="http://schemas.microsoft.com/office/powerpoint/2010/main" val="2355518278"/>
       </p:ext>
     </p:extLst>
   </p:cSld>
@@ -4609,7 +4609,7 @@
           <p:cNvPr id="2" name="Title Placeholder 1">
             <a:extLst>
               <a:ext uri="{FF2B5EF4-FFF2-40B4-BE49-F238E27FC236}">
-                <a16:creationId xmlns:a16="http://schemas.microsoft.com/office/drawing/2014/main" id="{B175E950-8613-CA33-4AF3-DCAFECB78F88}"/>
+                <a16:creationId xmlns:a16="http://schemas.microsoft.com/office/drawing/2014/main" id="{32A2B1EB-BE66-634B-F76C-3974D3068D08}"/>
               </a:ext>
             </a:extLst>
           </p:cNvPr>
@@ -4647,7 +4647,7 @@
           <p:cNvPr id="3" name="Text Placeholder 2">
             <a:extLst>
               <a:ext uri="{FF2B5EF4-FFF2-40B4-BE49-F238E27FC236}">
-                <a16:creationId xmlns:a16="http://schemas.microsoft.com/office/drawing/2014/main" id="{A625ECFC-89E1-4216-26BB-6F4F23632F2A}"/>
+                <a16:creationId xmlns:a16="http://schemas.microsoft.com/office/drawing/2014/main" id="{F21ED3B4-D7FE-44F2-9ACC-CC54284263E5}"/>
               </a:ext>
             </a:extLst>
           </p:cNvPr>
@@ -4714,7 +4714,7 @@
           <p:cNvPr id="4" name="Date Placeholder 3">
             <a:extLst>
               <a:ext uri="{FF2B5EF4-FFF2-40B4-BE49-F238E27FC236}">
-                <a16:creationId xmlns:a16="http://schemas.microsoft.com/office/drawing/2014/main" id="{BA7FFE75-AB57-64CF-01EA-D1780AC131F4}"/>
+                <a16:creationId xmlns:a16="http://schemas.microsoft.com/office/drawing/2014/main" id="{3A3B370F-BD47-0C09-064F-16B689E6560E}"/>
               </a:ext>
             </a:extLst>
           </p:cNvPr>
@@ -4748,7 +4748,7 @@
             </a:lvl1pPr>
           </a:lstStyle>
           <a:p>
-            <a:fld id="{5A1F434A-A4E2-44EE-8FE5-26BA97D6F415}" type="datetimeFigureOut">
+            <a:fld id="{2B98ED36-E35D-43DE-B7CA-31505E9177C9}" type="datetimeFigureOut">
               <a:rPr lang="en-US" smtClean="0"/>
               <a:t>10/21/2026</a:t>
             </a:fld>
@@ -4761,7 +4761,7 @@
           <p:cNvPr id="5" name="Footer Placeholder 4">
             <a:extLst>
               <a:ext uri="{FF2B5EF4-FFF2-40B4-BE49-F238E27FC236}">
-                <a16:creationId xmlns:a16="http://schemas.microsoft.com/office/drawing/2014/main" id="{249A70B8-B846-A0E1-BD02-888C558AAE98}"/>
+                <a16:creationId xmlns:a16="http://schemas.microsoft.com/office/drawing/2014/main" id="{B0231257-FC26-C95F-47C7-C9201B357898}"/>
               </a:ext>
             </a:extLst>
           </p:cNvPr>
@@ -4804,7 +4804,7 @@
           <p:cNvPr id="6" name="Slide Number Placeholder 5">
             <a:extLst>
               <a:ext uri="{FF2B5EF4-FFF2-40B4-BE49-F238E27FC236}">
-                <a16:creationId xmlns:a16="http://schemas.microsoft.com/office/drawing/2014/main" id="{F8255E2D-229E-D077-14EB-ACCD8072D175}"/>
+                <a16:creationId xmlns:a16="http://schemas.microsoft.com/office/drawing/2014/main" id="{14F6FF8D-814E-F070-59A8-C26D03F4C96E}"/>
               </a:ext>
             </a:extLst>
           </p:cNvPr>
@@ -4838,7 +4838,7 @@
             </a:lvl1pPr>
           </a:lstStyle>
           <a:p>
-            <a:fld id="{2DF905A9-3EDB-48A4-9CAE-3DEC204A8FAE}" type="slidenum">
+            <a:fld id="{7BB24B89-0397-48D1-9609-4F53AB945D78}" type="slidenum">
               <a:rPr lang="en-US" smtClean="0"/>
               <a:t>‹#›</a:t>
             </a:fld>
@@ -4849,7 +4849,7 @@
     </p:spTree>
     <p:extLst>
       <p:ext uri="{BB962C8B-B14F-4D97-AF65-F5344CB8AC3E}">
-        <p14:creationId xmlns:p14="http://schemas.microsoft.com/office/powerpoint/2010/main" val="2865381856"/>
+        <p14:creationId xmlns:p14="http://schemas.microsoft.com/office/powerpoint/2010/main" val="3169514111"/>
       </p:ext>
     </p:extLst>
   </p:cSld>
@@ -5180,7 +5180,7 @@
           <p:cNvPr id="2" name="TextBox 1">
             <a:extLst>
               <a:ext uri="{FF2B5EF4-FFF2-40B4-BE49-F238E27FC236}">
-                <a16:creationId xmlns:a16="http://schemas.microsoft.com/office/drawing/2014/main" id="{C93BDCDE-4D2F-303D-587A-D5C353D3A1EE}"/>
+                <a16:creationId xmlns:a16="http://schemas.microsoft.com/office/drawing/2014/main" id="{D84EDB0F-405E-68AB-8464-A3123C1A8DD9}"/>
               </a:ext>
             </a:extLst>
           </p:cNvPr>
@@ -5220,7 +5220,7 @@
           <p:cNvPr id="3" name="TextBox 2">
             <a:extLst>
               <a:ext uri="{FF2B5EF4-FFF2-40B4-BE49-F238E27FC236}">
-                <a16:creationId xmlns:a16="http://schemas.microsoft.com/office/drawing/2014/main" id="{2BB82501-25F9-5390-091C-AC531E1B434D}"/>
+                <a16:creationId xmlns:a16="http://schemas.microsoft.com/office/drawing/2014/main" id="{DFB829D3-D016-3B3F-E6C1-5FB508093D82}"/>
               </a:ext>
             </a:extLst>
           </p:cNvPr>
@@ -5260,7 +5260,7 @@
           <p:cNvPr id="4" name="TextBox 3">
             <a:extLst>
               <a:ext uri="{FF2B5EF4-FFF2-40B4-BE49-F238E27FC236}">
-                <a16:creationId xmlns:a16="http://schemas.microsoft.com/office/drawing/2014/main" id="{EE715E85-D96C-49B7-6F9C-3DD94FDB8CD4}"/>
+                <a16:creationId xmlns:a16="http://schemas.microsoft.com/office/drawing/2014/main" id="{F941F446-F2F4-7617-5A71-891B46D1F001}"/>
               </a:ext>
             </a:extLst>
           </p:cNvPr>
@@ -5300,7 +5300,7 @@
           <p:cNvPr id="5" name="Straight Connector 4">
             <a:extLst>
               <a:ext uri="{FF2B5EF4-FFF2-40B4-BE49-F238E27FC236}">
-                <a16:creationId xmlns:a16="http://schemas.microsoft.com/office/drawing/2014/main" id="{F9E951F1-D557-CB31-5C08-4A1E62D3DD68}"/>
+                <a16:creationId xmlns:a16="http://schemas.microsoft.com/office/drawing/2014/main" id="{6E755243-E5F3-37F0-EE26-47E6615EEBB7}"/>
               </a:ext>
             </a:extLst>
           </p:cNvPr>
@@ -5341,7 +5341,7 @@
           <p:cNvPr id="6" name="TextBox 5">
             <a:extLst>
               <a:ext uri="{FF2B5EF4-FFF2-40B4-BE49-F238E27FC236}">
-                <a16:creationId xmlns:a16="http://schemas.microsoft.com/office/drawing/2014/main" id="{7F45DA4F-2F8F-E509-2152-6D800CDC5D9E}"/>
+                <a16:creationId xmlns:a16="http://schemas.microsoft.com/office/drawing/2014/main" id="{EBE4E4F7-79D1-773A-EB1C-1F506DEE5FE6}"/>
               </a:ext>
             </a:extLst>
           </p:cNvPr>
@@ -5387,7 +5387,7 @@
           <p:cNvPr id="7" name="TextBox 6">
             <a:extLst>
               <a:ext uri="{FF2B5EF4-FFF2-40B4-BE49-F238E27FC236}">
-                <a16:creationId xmlns:a16="http://schemas.microsoft.com/office/drawing/2014/main" id="{DE64D276-4366-9081-B3E0-5FFDA7455A2B}"/>
+                <a16:creationId xmlns:a16="http://schemas.microsoft.com/office/drawing/2014/main" id="{D6A02AE2-2387-C9CF-0EBD-A17017C0E29D}"/>
               </a:ext>
             </a:extLst>
           </p:cNvPr>
@@ -5427,7 +5427,7 @@
           <p:cNvPr id="8" name="TextBox 7">
             <a:extLst>
               <a:ext uri="{FF2B5EF4-FFF2-40B4-BE49-F238E27FC236}">
-                <a16:creationId xmlns:a16="http://schemas.microsoft.com/office/drawing/2014/main" id="{2F5C1934-3E1F-9DA8-FF3F-1162C7FDF476}"/>
+                <a16:creationId xmlns:a16="http://schemas.microsoft.com/office/drawing/2014/main" id="{F8ACDCCB-8573-50BD-0DD1-1330D8167ED4}"/>
               </a:ext>
             </a:extLst>
           </p:cNvPr>
@@ -5467,7 +5467,7 @@
           <p:cNvPr id="9" name="TextBox 8">
             <a:extLst>
               <a:ext uri="{FF2B5EF4-FFF2-40B4-BE49-F238E27FC236}">
-                <a16:creationId xmlns:a16="http://schemas.microsoft.com/office/drawing/2014/main" id="{0621D97E-B09F-1CE5-C9A8-2AE1719B7A1E}"/>
+                <a16:creationId xmlns:a16="http://schemas.microsoft.com/office/drawing/2014/main" id="{89832CA1-2D27-2CC6-47BB-C059271281F1}"/>
               </a:ext>
             </a:extLst>
           </p:cNvPr>
@@ -5505,7 +5505,7 @@
     </p:spTree>
     <p:extLst>
       <p:ext uri="{BB962C8B-B14F-4D97-AF65-F5344CB8AC3E}">
-        <p14:creationId xmlns:p14="http://schemas.microsoft.com/office/powerpoint/2010/main" val="2019807551"/>
+        <p14:creationId xmlns:p14="http://schemas.microsoft.com/office/powerpoint/2010/main" val="2592318599"/>
       </p:ext>
     </p:extLst>
   </p:cSld>
@@ -5545,7 +5545,7 @@
           <p:cNvPr id="2" name="TextBox 1">
             <a:extLst>
               <a:ext uri="{FF2B5EF4-FFF2-40B4-BE49-F238E27FC236}">
-                <a16:creationId xmlns:a16="http://schemas.microsoft.com/office/drawing/2014/main" id="{40676505-E06F-9BFC-CA7B-E00771B18B3A}"/>
+                <a16:creationId xmlns:a16="http://schemas.microsoft.com/office/drawing/2014/main" id="{F76DAB45-FA03-CDD8-B05A-B27478897D8C}"/>
               </a:ext>
             </a:extLst>
           </p:cNvPr>
@@ -5585,7 +5585,7 @@
           <p:cNvPr id="3" name="Straight Connector 2">
             <a:extLst>
               <a:ext uri="{FF2B5EF4-FFF2-40B4-BE49-F238E27FC236}">
-                <a16:creationId xmlns:a16="http://schemas.microsoft.com/office/drawing/2014/main" id="{CD52E43D-FEE7-FE31-E5E7-86309AA51FFA}"/>
+                <a16:creationId xmlns:a16="http://schemas.microsoft.com/office/drawing/2014/main" id="{B018A357-128C-5519-1046-7F1E633F26D8}"/>
               </a:ext>
             </a:extLst>
           </p:cNvPr>
@@ -5626,7 +5626,7 @@
           <p:cNvPr id="4" name="TextBox 3">
             <a:extLst>
               <a:ext uri="{FF2B5EF4-FFF2-40B4-BE49-F238E27FC236}">
-                <a16:creationId xmlns:a16="http://schemas.microsoft.com/office/drawing/2014/main" id="{AEB2E779-6E10-926C-F670-33C1A88EABEA}"/>
+                <a16:creationId xmlns:a16="http://schemas.microsoft.com/office/drawing/2014/main" id="{C613F9CD-D11E-66EE-2862-668E2AA9566E}"/>
               </a:ext>
             </a:extLst>
           </p:cNvPr>
@@ -5667,7 +5667,7 @@
           <p:cNvPr id="5" name="TextBox 4">
             <a:extLst>
               <a:ext uri="{FF2B5EF4-FFF2-40B4-BE49-F238E27FC236}">
-                <a16:creationId xmlns:a16="http://schemas.microsoft.com/office/drawing/2014/main" id="{F3E3F877-1F2B-E187-0A2A-F081BEE97B63}"/>
+                <a16:creationId xmlns:a16="http://schemas.microsoft.com/office/drawing/2014/main" id="{4FFE13D4-8512-6585-C96C-E8098DB64908}"/>
               </a:ext>
             </a:extLst>
           </p:cNvPr>
@@ -5707,7 +5707,7 @@
           <p:cNvPr id="6" name="TextBox 5">
             <a:extLst>
               <a:ext uri="{FF2B5EF4-FFF2-40B4-BE49-F238E27FC236}">
-                <a16:creationId xmlns:a16="http://schemas.microsoft.com/office/drawing/2014/main" id="{8137BAA7-D5CB-8D1D-0014-E209B9C5A69C}"/>
+                <a16:creationId xmlns:a16="http://schemas.microsoft.com/office/drawing/2014/main" id="{D312E904-8900-4C53-4F0B-484F9F7E20CD}"/>
               </a:ext>
             </a:extLst>
           </p:cNvPr>
@@ -5747,7 +5747,7 @@
           <p:cNvPr id="7" name="TextBox 6">
             <a:extLst>
               <a:ext uri="{FF2B5EF4-FFF2-40B4-BE49-F238E27FC236}">
-                <a16:creationId xmlns:a16="http://schemas.microsoft.com/office/drawing/2014/main" id="{43947E3E-8BA5-EA0F-1FB6-A5DA61BD629C}"/>
+                <a16:creationId xmlns:a16="http://schemas.microsoft.com/office/drawing/2014/main" id="{634661E6-20AC-BCED-CA85-230166323224}"/>
               </a:ext>
             </a:extLst>
           </p:cNvPr>
@@ -5787,7 +5787,7 @@
           <p:cNvPr id="8" name="TextBox 7">
             <a:extLst>
               <a:ext uri="{FF2B5EF4-FFF2-40B4-BE49-F238E27FC236}">
-                <a16:creationId xmlns:a16="http://schemas.microsoft.com/office/drawing/2014/main" id="{456AAD11-7B38-6E56-80C2-66698A002F60}"/>
+                <a16:creationId xmlns:a16="http://schemas.microsoft.com/office/drawing/2014/main" id="{00181AD4-67E1-5590-EE41-A45F3BEA32BA}"/>
               </a:ext>
             </a:extLst>
           </p:cNvPr>
@@ -5827,7 +5827,7 @@
           <p:cNvPr id="9" name="TextBox 8">
             <a:extLst>
               <a:ext uri="{FF2B5EF4-FFF2-40B4-BE49-F238E27FC236}">
-                <a16:creationId xmlns:a16="http://schemas.microsoft.com/office/drawing/2014/main" id="{EA2247D6-51AC-74FA-653D-B94448E146A6}"/>
+                <a16:creationId xmlns:a16="http://schemas.microsoft.com/office/drawing/2014/main" id="{42F5EE23-92A9-9554-9403-00DCF9DB297B}"/>
               </a:ext>
             </a:extLst>
           </p:cNvPr>
@@ -5867,7 +5867,7 @@
           <p:cNvPr id="10" name="Rectangle 9">
             <a:extLst>
               <a:ext uri="{FF2B5EF4-FFF2-40B4-BE49-F238E27FC236}">
-                <a16:creationId xmlns:a16="http://schemas.microsoft.com/office/drawing/2014/main" id="{516D791A-2394-745E-BA80-87C633314320}"/>
+                <a16:creationId xmlns:a16="http://schemas.microsoft.com/office/drawing/2014/main" id="{70BC8268-21A5-04AA-EB44-06CB2D1C55C6}"/>
               </a:ext>
             </a:extLst>
           </p:cNvPr>
@@ -5935,7 +5935,7 @@
           <p:cNvPr id="11" name="TextBox 10">
             <a:extLst>
               <a:ext uri="{FF2B5EF4-FFF2-40B4-BE49-F238E27FC236}">
-                <a16:creationId xmlns:a16="http://schemas.microsoft.com/office/drawing/2014/main" id="{80C4D048-3CB1-5827-0C82-E81E544D3668}"/>
+                <a16:creationId xmlns:a16="http://schemas.microsoft.com/office/drawing/2014/main" id="{E668ED86-9C8D-FBCE-6813-4481180F3BFA}"/>
               </a:ext>
             </a:extLst>
           </p:cNvPr>
@@ -5975,7 +5975,7 @@
           <p:cNvPr id="12" name="TextBox 11">
             <a:extLst>
               <a:ext uri="{FF2B5EF4-FFF2-40B4-BE49-F238E27FC236}">
-                <a16:creationId xmlns:a16="http://schemas.microsoft.com/office/drawing/2014/main" id="{E6ABA853-3268-2DAF-4299-D929BF650FBD}"/>
+                <a16:creationId xmlns:a16="http://schemas.microsoft.com/office/drawing/2014/main" id="{80DB7961-EA7F-D60C-9319-9B5647C605F8}"/>
               </a:ext>
             </a:extLst>
           </p:cNvPr>
@@ -6015,7 +6015,7 @@
           <p:cNvPr id="13" name="TextBox 12">
             <a:extLst>
               <a:ext uri="{FF2B5EF4-FFF2-40B4-BE49-F238E27FC236}">
-                <a16:creationId xmlns:a16="http://schemas.microsoft.com/office/drawing/2014/main" id="{5D758E2B-1EB7-D460-5408-284275A59DFB}"/>
+                <a16:creationId xmlns:a16="http://schemas.microsoft.com/office/drawing/2014/main" id="{FDA2420E-30BA-AC27-7238-9EFF1410F709}"/>
               </a:ext>
             </a:extLst>
           </p:cNvPr>
@@ -6055,7 +6055,7 @@
           <p:cNvPr id="14" name="TextBox 13">
             <a:extLst>
               <a:ext uri="{FF2B5EF4-FFF2-40B4-BE49-F238E27FC236}">
-                <a16:creationId xmlns:a16="http://schemas.microsoft.com/office/drawing/2014/main" id="{FD023DF0-AAED-3A3D-2D92-4E11CB5F4E19}"/>
+                <a16:creationId xmlns:a16="http://schemas.microsoft.com/office/drawing/2014/main" id="{9A5207CB-5100-09B5-45FE-DD1997D25D54}"/>
               </a:ext>
             </a:extLst>
           </p:cNvPr>
@@ -6095,7 +6095,7 @@
           <p:cNvPr id="15" name="TextBox 14">
             <a:extLst>
               <a:ext uri="{FF2B5EF4-FFF2-40B4-BE49-F238E27FC236}">
-                <a16:creationId xmlns:a16="http://schemas.microsoft.com/office/drawing/2014/main" id="{6E825EDB-DD97-00AE-0D08-B73B13861676}"/>
+                <a16:creationId xmlns:a16="http://schemas.microsoft.com/office/drawing/2014/main" id="{DE2CB9C6-C9CF-FE3D-B707-D9227A443F34}"/>
               </a:ext>
             </a:extLst>
           </p:cNvPr>
@@ -6135,7 +6135,7 @@
           <p:cNvPr id="16" name="TextBox 15">
             <a:extLst>
               <a:ext uri="{FF2B5EF4-FFF2-40B4-BE49-F238E27FC236}">
-                <a16:creationId xmlns:a16="http://schemas.microsoft.com/office/drawing/2014/main" id="{0CC7803E-E220-CD35-B9CF-FB6F33A41A17}"/>
+                <a16:creationId xmlns:a16="http://schemas.microsoft.com/office/drawing/2014/main" id="{39C6E35C-5899-A167-6F77-F71A26101E94}"/>
               </a:ext>
             </a:extLst>
           </p:cNvPr>
@@ -6175,7 +6175,7 @@
           <p:cNvPr id="17" name="Rectangle 16">
             <a:extLst>
               <a:ext uri="{FF2B5EF4-FFF2-40B4-BE49-F238E27FC236}">
-                <a16:creationId xmlns:a16="http://schemas.microsoft.com/office/drawing/2014/main" id="{AEF3347B-6B32-CE45-3D7F-5FBECB14EBAD}"/>
+                <a16:creationId xmlns:a16="http://schemas.microsoft.com/office/drawing/2014/main" id="{81D18D4E-723C-16FD-0174-4FD23D8F0B09}"/>
               </a:ext>
             </a:extLst>
           </p:cNvPr>
@@ -6243,7 +6243,7 @@
           <p:cNvPr id="18" name="TextBox 17">
             <a:extLst>
               <a:ext uri="{FF2B5EF4-FFF2-40B4-BE49-F238E27FC236}">
-                <a16:creationId xmlns:a16="http://schemas.microsoft.com/office/drawing/2014/main" id="{02415FE3-F3E4-252D-CC5B-83208CF87376}"/>
+                <a16:creationId xmlns:a16="http://schemas.microsoft.com/office/drawing/2014/main" id="{9C727BCB-A7F2-7948-DDB5-58F44A80EECE}"/>
               </a:ext>
             </a:extLst>
           </p:cNvPr>
@@ -6283,7 +6283,7 @@
           <p:cNvPr id="19" name="TextBox 18">
             <a:extLst>
               <a:ext uri="{FF2B5EF4-FFF2-40B4-BE49-F238E27FC236}">
-                <a16:creationId xmlns:a16="http://schemas.microsoft.com/office/drawing/2014/main" id="{3320BEAD-80C5-04E4-0B5D-2F651930DE72}"/>
+                <a16:creationId xmlns:a16="http://schemas.microsoft.com/office/drawing/2014/main" id="{128207AD-B6AC-786E-8077-8560E4348880}"/>
               </a:ext>
             </a:extLst>
           </p:cNvPr>
@@ -6323,7 +6323,7 @@
           <p:cNvPr id="20" name="TextBox 19">
             <a:extLst>
               <a:ext uri="{FF2B5EF4-FFF2-40B4-BE49-F238E27FC236}">
-                <a16:creationId xmlns:a16="http://schemas.microsoft.com/office/drawing/2014/main" id="{03525CE1-7747-ABE0-80FB-CFAE00B39028}"/>
+                <a16:creationId xmlns:a16="http://schemas.microsoft.com/office/drawing/2014/main" id="{DC93A111-8324-EE49-47A6-F64D3C1D6A59}"/>
               </a:ext>
             </a:extLst>
           </p:cNvPr>
@@ -6363,7 +6363,7 @@
           <p:cNvPr id="21" name="TextBox 20">
             <a:extLst>
               <a:ext uri="{FF2B5EF4-FFF2-40B4-BE49-F238E27FC236}">
-                <a16:creationId xmlns:a16="http://schemas.microsoft.com/office/drawing/2014/main" id="{330C0211-C538-EA14-5B46-0E96BE4929F7}"/>
+                <a16:creationId xmlns:a16="http://schemas.microsoft.com/office/drawing/2014/main" id="{A88D8BC4-AAA3-0B17-63E6-6E8CD8926E31}"/>
               </a:ext>
             </a:extLst>
           </p:cNvPr>
@@ -6403,7 +6403,7 @@
           <p:cNvPr id="22" name="TextBox 21">
             <a:extLst>
               <a:ext uri="{FF2B5EF4-FFF2-40B4-BE49-F238E27FC236}">
-                <a16:creationId xmlns:a16="http://schemas.microsoft.com/office/drawing/2014/main" id="{2E4DFF17-9CAB-43DE-0EC2-54377192384E}"/>
+                <a16:creationId xmlns:a16="http://schemas.microsoft.com/office/drawing/2014/main" id="{2E81328B-CA07-119E-9E82-1EF04B215B27}"/>
               </a:ext>
             </a:extLst>
           </p:cNvPr>
@@ -6443,7 +6443,7 @@
           <p:cNvPr id="23" name="TextBox 22">
             <a:extLst>
               <a:ext uri="{FF2B5EF4-FFF2-40B4-BE49-F238E27FC236}">
-                <a16:creationId xmlns:a16="http://schemas.microsoft.com/office/drawing/2014/main" id="{80D0A9D6-B49E-F98F-0340-91B664382A2B}"/>
+                <a16:creationId xmlns:a16="http://schemas.microsoft.com/office/drawing/2014/main" id="{093256F7-B0E1-EC15-1BDE-AB2CA74352A7}"/>
               </a:ext>
             </a:extLst>
           </p:cNvPr>
@@ -6483,7 +6483,7 @@
           <p:cNvPr id="24" name="Rectangle: Rounded Corners 23">
             <a:extLst>
               <a:ext uri="{FF2B5EF4-FFF2-40B4-BE49-F238E27FC236}">
-                <a16:creationId xmlns:a16="http://schemas.microsoft.com/office/drawing/2014/main" id="{15551125-7924-DC1C-85E9-1C0882EC1294}"/>
+                <a16:creationId xmlns:a16="http://schemas.microsoft.com/office/drawing/2014/main" id="{36AF041C-5828-D0D2-420C-FD15E6F4E516}"/>
               </a:ext>
             </a:extLst>
           </p:cNvPr>
@@ -6537,7 +6537,7 @@
           <p:cNvPr id="25" name="TextBox 24">
             <a:extLst>
               <a:ext uri="{FF2B5EF4-FFF2-40B4-BE49-F238E27FC236}">
-                <a16:creationId xmlns:a16="http://schemas.microsoft.com/office/drawing/2014/main" id="{03493CB0-2784-597B-92DC-4E9D0F9E9D78}"/>
+                <a16:creationId xmlns:a16="http://schemas.microsoft.com/office/drawing/2014/main" id="{F4951C3E-17AE-E7FA-4B8A-939EA6034407}"/>
               </a:ext>
             </a:extLst>
           </p:cNvPr>
@@ -6578,7 +6578,7 @@
           <p:cNvPr id="26" name="TextBox 25">
             <a:extLst>
               <a:ext uri="{FF2B5EF4-FFF2-40B4-BE49-F238E27FC236}">
-                <a16:creationId xmlns:a16="http://schemas.microsoft.com/office/drawing/2014/main" id="{EA7E8329-B8CF-1D69-D590-FA7A7FEF610B}"/>
+                <a16:creationId xmlns:a16="http://schemas.microsoft.com/office/drawing/2014/main" id="{E727EA1D-F8DC-DA9B-66E5-1F05AE82C479}"/>
               </a:ext>
             </a:extLst>
           </p:cNvPr>
@@ -6617,7 +6617,7 @@
     </p:spTree>
     <p:extLst>
       <p:ext uri="{BB962C8B-B14F-4D97-AF65-F5344CB8AC3E}">
-        <p14:creationId xmlns:p14="http://schemas.microsoft.com/office/powerpoint/2010/main" val="3035100465"/>
+        <p14:creationId xmlns:p14="http://schemas.microsoft.com/office/powerpoint/2010/main" val="2011779485"/>
       </p:ext>
     </p:extLst>
   </p:cSld>
@@ -6657,7 +6657,7 @@
           <p:cNvPr id="2" name="TextBox 1">
             <a:extLst>
               <a:ext uri="{FF2B5EF4-FFF2-40B4-BE49-F238E27FC236}">
-                <a16:creationId xmlns:a16="http://schemas.microsoft.com/office/drawing/2014/main" id="{44134386-2372-C965-E68F-7E4957050FFC}"/>
+                <a16:creationId xmlns:a16="http://schemas.microsoft.com/office/drawing/2014/main" id="{70CB5945-4054-F014-6E9B-39017D7A95F6}"/>
               </a:ext>
             </a:extLst>
           </p:cNvPr>
@@ -6697,7 +6697,7 @@
           <p:cNvPr id="3" name="Straight Connector 2">
             <a:extLst>
               <a:ext uri="{FF2B5EF4-FFF2-40B4-BE49-F238E27FC236}">
-                <a16:creationId xmlns:a16="http://schemas.microsoft.com/office/drawing/2014/main" id="{899830B2-A2A5-9222-8097-FE31AE7FAADE}"/>
+                <a16:creationId xmlns:a16="http://schemas.microsoft.com/office/drawing/2014/main" id="{78F2D5F1-FB39-2344-4C7C-48143F13EC3D}"/>
               </a:ext>
             </a:extLst>
           </p:cNvPr>
@@ -6738,7 +6738,7 @@
           <p:cNvPr id="4" name="TextBox 3">
             <a:extLst>
               <a:ext uri="{FF2B5EF4-FFF2-40B4-BE49-F238E27FC236}">
-                <a16:creationId xmlns:a16="http://schemas.microsoft.com/office/drawing/2014/main" id="{FD1D353F-4594-FC77-1FDA-3A444F8C89F0}"/>
+                <a16:creationId xmlns:a16="http://schemas.microsoft.com/office/drawing/2014/main" id="{712D6945-CB8F-B079-820B-2DB93F516FE2}"/>
               </a:ext>
             </a:extLst>
           </p:cNvPr>
@@ -6779,7 +6779,7 @@
           <p:cNvPr id="5" name="TextBox 4">
             <a:extLst>
               <a:ext uri="{FF2B5EF4-FFF2-40B4-BE49-F238E27FC236}">
-                <a16:creationId xmlns:a16="http://schemas.microsoft.com/office/drawing/2014/main" id="{F157511F-C59B-2386-5907-CFE63488774C}"/>
+                <a16:creationId xmlns:a16="http://schemas.microsoft.com/office/drawing/2014/main" id="{B4E50DC2-943D-6968-1965-5F4CFA167758}"/>
               </a:ext>
             </a:extLst>
           </p:cNvPr>
@@ -6819,7 +6819,7 @@
           <p:cNvPr id="6" name="TextBox 5">
             <a:extLst>
               <a:ext uri="{FF2B5EF4-FFF2-40B4-BE49-F238E27FC236}">
-                <a16:creationId xmlns:a16="http://schemas.microsoft.com/office/drawing/2014/main" id="{039ED97C-BF6E-FCB4-0BFA-09B9C0CF581C}"/>
+                <a16:creationId xmlns:a16="http://schemas.microsoft.com/office/drawing/2014/main" id="{2E311504-A7AA-3056-0FBE-D249E63DDA2C}"/>
               </a:ext>
             </a:extLst>
           </p:cNvPr>
@@ -6859,7 +6859,7 @@
           <p:cNvPr id="7" name="TextBox 6">
             <a:extLst>
               <a:ext uri="{FF2B5EF4-FFF2-40B4-BE49-F238E27FC236}">
-                <a16:creationId xmlns:a16="http://schemas.microsoft.com/office/drawing/2014/main" id="{C0B2CDD6-5086-7A8C-A95A-25EA5CEAD3B2}"/>
+                <a16:creationId xmlns:a16="http://schemas.microsoft.com/office/drawing/2014/main" id="{28568ABB-91D6-E6E3-1779-0660D4C3EFAF}"/>
               </a:ext>
             </a:extLst>
           </p:cNvPr>
@@ -6899,7 +6899,7 @@
           <p:cNvPr id="8" name="Straight Connector 7">
             <a:extLst>
               <a:ext uri="{FF2B5EF4-FFF2-40B4-BE49-F238E27FC236}">
-                <a16:creationId xmlns:a16="http://schemas.microsoft.com/office/drawing/2014/main" id="{F36B86B7-65C7-0CFC-C3F7-95FFBD32E75C}"/>
+                <a16:creationId xmlns:a16="http://schemas.microsoft.com/office/drawing/2014/main" id="{645F0A99-38C7-9164-BA20-94BEF401C514}"/>
               </a:ext>
             </a:extLst>
           </p:cNvPr>
@@ -6940,7 +6940,7 @@
           <p:cNvPr id="9" name="TextBox 8">
             <a:extLst>
               <a:ext uri="{FF2B5EF4-FFF2-40B4-BE49-F238E27FC236}">
-                <a16:creationId xmlns:a16="http://schemas.microsoft.com/office/drawing/2014/main" id="{2FEB0232-8595-5DFC-3570-04DFFA4A767A}"/>
+                <a16:creationId xmlns:a16="http://schemas.microsoft.com/office/drawing/2014/main" id="{F253A86C-0F1C-AC96-99EA-74E9E52F6CB9}"/>
               </a:ext>
             </a:extLst>
           </p:cNvPr>
@@ -6980,7 +6980,7 @@
           <p:cNvPr id="10" name="Straight Connector 9">
             <a:extLst>
               <a:ext uri="{FF2B5EF4-FFF2-40B4-BE49-F238E27FC236}">
-                <a16:creationId xmlns:a16="http://schemas.microsoft.com/office/drawing/2014/main" id="{9F974885-0B4C-C311-4886-AA8D95CF308F}"/>
+                <a16:creationId xmlns:a16="http://schemas.microsoft.com/office/drawing/2014/main" id="{FA99245B-AB5B-412A-0712-732599E25D82}"/>
               </a:ext>
             </a:extLst>
           </p:cNvPr>
@@ -7021,7 +7021,7 @@
           <p:cNvPr id="11" name="TextBox 10">
             <a:extLst>
               <a:ext uri="{FF2B5EF4-FFF2-40B4-BE49-F238E27FC236}">
-                <a16:creationId xmlns:a16="http://schemas.microsoft.com/office/drawing/2014/main" id="{39B4A523-D9FB-9FEA-43C8-B8C58938F261}"/>
+                <a16:creationId xmlns:a16="http://schemas.microsoft.com/office/drawing/2014/main" id="{75FA0B14-FBFA-C01B-EFF5-97C214317E74}"/>
               </a:ext>
             </a:extLst>
           </p:cNvPr>
@@ -7061,7 +7061,7 @@
           <p:cNvPr id="12" name="Straight Connector 11">
             <a:extLst>
               <a:ext uri="{FF2B5EF4-FFF2-40B4-BE49-F238E27FC236}">
-                <a16:creationId xmlns:a16="http://schemas.microsoft.com/office/drawing/2014/main" id="{66BEC8A9-7E5A-DC0B-AB9F-693A6E4DF34B}"/>
+                <a16:creationId xmlns:a16="http://schemas.microsoft.com/office/drawing/2014/main" id="{74C486C8-4EB8-6359-045C-B26B1B03AB01}"/>
               </a:ext>
             </a:extLst>
           </p:cNvPr>
@@ -7102,7 +7102,7 @@
           <p:cNvPr id="13" name="TextBox 12">
             <a:extLst>
               <a:ext uri="{FF2B5EF4-FFF2-40B4-BE49-F238E27FC236}">
-                <a16:creationId xmlns:a16="http://schemas.microsoft.com/office/drawing/2014/main" id="{95DBFF1A-ACE7-6DA5-2206-344A7BFD81C0}"/>
+                <a16:creationId xmlns:a16="http://schemas.microsoft.com/office/drawing/2014/main" id="{9D682755-D0B9-F8FA-DEC3-995B56582311}"/>
               </a:ext>
             </a:extLst>
           </p:cNvPr>
@@ -7142,7 +7142,7 @@
           <p:cNvPr id="14" name="Straight Connector 13">
             <a:extLst>
               <a:ext uri="{FF2B5EF4-FFF2-40B4-BE49-F238E27FC236}">
-                <a16:creationId xmlns:a16="http://schemas.microsoft.com/office/drawing/2014/main" id="{9E427EB3-951C-C0E2-BB1F-2B381A6B9BB9}"/>
+                <a16:creationId xmlns:a16="http://schemas.microsoft.com/office/drawing/2014/main" id="{94F9280F-ED2E-E78E-9114-7FD18988965B}"/>
               </a:ext>
             </a:extLst>
           </p:cNvPr>
@@ -7183,7 +7183,7 @@
           <p:cNvPr id="15" name="TextBox 14">
             <a:extLst>
               <a:ext uri="{FF2B5EF4-FFF2-40B4-BE49-F238E27FC236}">
-                <a16:creationId xmlns:a16="http://schemas.microsoft.com/office/drawing/2014/main" id="{17FEA002-B4B1-AB5C-5E8D-0637FF8E376B}"/>
+                <a16:creationId xmlns:a16="http://schemas.microsoft.com/office/drawing/2014/main" id="{4F4B0A68-B276-4D17-D72B-4A133D834DF4}"/>
               </a:ext>
             </a:extLst>
           </p:cNvPr>
@@ -7223,7 +7223,7 @@
           <p:cNvPr id="16" name="Straight Connector 15">
             <a:extLst>
               <a:ext uri="{FF2B5EF4-FFF2-40B4-BE49-F238E27FC236}">
-                <a16:creationId xmlns:a16="http://schemas.microsoft.com/office/drawing/2014/main" id="{C68C609C-F8F5-0073-FBEA-9EA599981993}"/>
+                <a16:creationId xmlns:a16="http://schemas.microsoft.com/office/drawing/2014/main" id="{D49DBE0D-E28D-0EEA-4AB3-2BFAC2F4F746}"/>
               </a:ext>
             </a:extLst>
           </p:cNvPr>
@@ -7264,7 +7264,7 @@
           <p:cNvPr id="17" name="TextBox 16">
             <a:extLst>
               <a:ext uri="{FF2B5EF4-FFF2-40B4-BE49-F238E27FC236}">
-                <a16:creationId xmlns:a16="http://schemas.microsoft.com/office/drawing/2014/main" id="{3DD9E258-1168-9F6C-1D04-390E10A3E568}"/>
+                <a16:creationId xmlns:a16="http://schemas.microsoft.com/office/drawing/2014/main" id="{BF46CB76-66AF-A6CE-F044-F5B4171D79A5}"/>
               </a:ext>
             </a:extLst>
           </p:cNvPr>
@@ -7304,7 +7304,7 @@
           <p:cNvPr id="18" name="TextBox 17">
             <a:extLst>
               <a:ext uri="{FF2B5EF4-FFF2-40B4-BE49-F238E27FC236}">
-                <a16:creationId xmlns:a16="http://schemas.microsoft.com/office/drawing/2014/main" id="{88EA3A41-32E0-761F-5D33-DEEB634B5ECE}"/>
+                <a16:creationId xmlns:a16="http://schemas.microsoft.com/office/drawing/2014/main" id="{685E03DA-11E3-4478-114E-8482A34B1D68}"/>
               </a:ext>
             </a:extLst>
           </p:cNvPr>
@@ -7344,7 +7344,7 @@
           <p:cNvPr id="19" name="TextBox 18">
             <a:extLst>
               <a:ext uri="{FF2B5EF4-FFF2-40B4-BE49-F238E27FC236}">
-                <a16:creationId xmlns:a16="http://schemas.microsoft.com/office/drawing/2014/main" id="{569AE538-EBD7-1FAB-2548-ED1F7EF2C609}"/>
+                <a16:creationId xmlns:a16="http://schemas.microsoft.com/office/drawing/2014/main" id="{19CFB1B1-4359-C599-07B4-4D98CC69CC4A}"/>
               </a:ext>
             </a:extLst>
           </p:cNvPr>
@@ -7384,7 +7384,7 @@
           <p:cNvPr id="20" name="TextBox 19">
             <a:extLst>
               <a:ext uri="{FF2B5EF4-FFF2-40B4-BE49-F238E27FC236}">
-                <a16:creationId xmlns:a16="http://schemas.microsoft.com/office/drawing/2014/main" id="{E74DA0CF-8B8A-4D37-0D03-BA9F03C021FC}"/>
+                <a16:creationId xmlns:a16="http://schemas.microsoft.com/office/drawing/2014/main" id="{A5A5AF9B-B04D-9215-5CE1-03E39A71D73A}"/>
               </a:ext>
             </a:extLst>
           </p:cNvPr>
@@ -7424,7 +7424,7 @@
           <p:cNvPr id="21" name="TextBox 20">
             <a:extLst>
               <a:ext uri="{FF2B5EF4-FFF2-40B4-BE49-F238E27FC236}">
-                <a16:creationId xmlns:a16="http://schemas.microsoft.com/office/drawing/2014/main" id="{5E059BA7-AB6E-3AA6-4232-3BA6135B082E}"/>
+                <a16:creationId xmlns:a16="http://schemas.microsoft.com/office/drawing/2014/main" id="{5E6F6742-C60A-3499-A109-5BC62B1F0C0F}"/>
               </a:ext>
             </a:extLst>
           </p:cNvPr>
@@ -7464,7 +7464,7 @@
           <p:cNvPr id="22" name="TextBox 21">
             <a:extLst>
               <a:ext uri="{FF2B5EF4-FFF2-40B4-BE49-F238E27FC236}">
-                <a16:creationId xmlns:a16="http://schemas.microsoft.com/office/drawing/2014/main" id="{5D9E1761-AB2F-53F8-4179-A45D5698B939}"/>
+                <a16:creationId xmlns:a16="http://schemas.microsoft.com/office/drawing/2014/main" id="{6EC6E46C-FF5D-C55B-D165-AD24FF636A0E}"/>
               </a:ext>
             </a:extLst>
           </p:cNvPr>
@@ -7504,7 +7504,7 @@
           <p:cNvPr id="23" name="TextBox 22">
             <a:extLst>
               <a:ext uri="{FF2B5EF4-FFF2-40B4-BE49-F238E27FC236}">
-                <a16:creationId xmlns:a16="http://schemas.microsoft.com/office/drawing/2014/main" id="{C3A0AEC2-6CFD-46E9-EDF1-910969CCF32C}"/>
+                <a16:creationId xmlns:a16="http://schemas.microsoft.com/office/drawing/2014/main" id="{7022308B-5BCB-9F6F-7C6E-741AEEEF43DA}"/>
               </a:ext>
             </a:extLst>
           </p:cNvPr>
@@ -7544,7 +7544,7 @@
           <p:cNvPr id="24" name="Rectangle: Rounded Corners 23">
             <a:extLst>
               <a:ext uri="{FF2B5EF4-FFF2-40B4-BE49-F238E27FC236}">
-                <a16:creationId xmlns:a16="http://schemas.microsoft.com/office/drawing/2014/main" id="{6983E8B6-0B47-F93A-E028-F429A0D87E1B}"/>
+                <a16:creationId xmlns:a16="http://schemas.microsoft.com/office/drawing/2014/main" id="{8D701A51-35B5-3F29-4293-35804146C4C7}"/>
               </a:ext>
             </a:extLst>
           </p:cNvPr>
@@ -7598,7 +7598,7 @@
           <p:cNvPr id="25" name="TextBox 24">
             <a:extLst>
               <a:ext uri="{FF2B5EF4-FFF2-40B4-BE49-F238E27FC236}">
-                <a16:creationId xmlns:a16="http://schemas.microsoft.com/office/drawing/2014/main" id="{9AD39D35-D945-8525-5260-D99995C7E76E}"/>
+                <a16:creationId xmlns:a16="http://schemas.microsoft.com/office/drawing/2014/main" id="{1B5D61F9-DE3A-3425-3E5D-9F2AAFFBF42E}"/>
               </a:ext>
             </a:extLst>
           </p:cNvPr>
@@ -7649,7 +7649,7 @@
     </p:spTree>
     <p:extLst>
       <p:ext uri="{BB962C8B-B14F-4D97-AF65-F5344CB8AC3E}">
-        <p14:creationId xmlns:p14="http://schemas.microsoft.com/office/powerpoint/2010/main" val="4274129029"/>
+        <p14:creationId xmlns:p14="http://schemas.microsoft.com/office/powerpoint/2010/main" val="292119721"/>
       </p:ext>
     </p:extLst>
   </p:cSld>
@@ -7689,7 +7689,7 @@
           <p:cNvPr id="2" name="TextBox 1">
             <a:extLst>
               <a:ext uri="{FF2B5EF4-FFF2-40B4-BE49-F238E27FC236}">
-                <a16:creationId xmlns:a16="http://schemas.microsoft.com/office/drawing/2014/main" id="{94A74814-843E-A652-EEE4-AEE3D01757B6}"/>
+                <a16:creationId xmlns:a16="http://schemas.microsoft.com/office/drawing/2014/main" id="{A0E8216C-B688-5446-21BF-91C5505CD8E1}"/>
               </a:ext>
             </a:extLst>
           </p:cNvPr>
@@ -7729,7 +7729,7 @@
           <p:cNvPr id="3" name="Straight Connector 2">
             <a:extLst>
               <a:ext uri="{FF2B5EF4-FFF2-40B4-BE49-F238E27FC236}">
-                <a16:creationId xmlns:a16="http://schemas.microsoft.com/office/drawing/2014/main" id="{736C9366-30E8-A69E-9455-885D903DE50E}"/>
+                <a16:creationId xmlns:a16="http://schemas.microsoft.com/office/drawing/2014/main" id="{E6ADEF35-082A-9027-BEFA-90E956676A92}"/>
               </a:ext>
             </a:extLst>
           </p:cNvPr>
@@ -7770,7 +7770,7 @@
           <p:cNvPr id="4" name="TextBox 3">
             <a:extLst>
               <a:ext uri="{FF2B5EF4-FFF2-40B4-BE49-F238E27FC236}">
-                <a16:creationId xmlns:a16="http://schemas.microsoft.com/office/drawing/2014/main" id="{857440EA-49EB-7329-E2AD-BD5A60477917}"/>
+                <a16:creationId xmlns:a16="http://schemas.microsoft.com/office/drawing/2014/main" id="{85B5CFC9-460E-713E-0DA7-3BC60A4B8F24}"/>
               </a:ext>
             </a:extLst>
           </p:cNvPr>
@@ -7811,7 +7811,7 @@
           <p:cNvPr id="5" name="TextBox 4">
             <a:extLst>
               <a:ext uri="{FF2B5EF4-FFF2-40B4-BE49-F238E27FC236}">
-                <a16:creationId xmlns:a16="http://schemas.microsoft.com/office/drawing/2014/main" id="{C32FF7BF-1955-740D-9F14-556719F4E1A5}"/>
+                <a16:creationId xmlns:a16="http://schemas.microsoft.com/office/drawing/2014/main" id="{666AC3CB-5A0E-F626-0F9D-004516C193DF}"/>
               </a:ext>
             </a:extLst>
           </p:cNvPr>
@@ -7851,7 +7851,7 @@
           <p:cNvPr id="6" name="TextBox 5">
             <a:extLst>
               <a:ext uri="{FF2B5EF4-FFF2-40B4-BE49-F238E27FC236}">
-                <a16:creationId xmlns:a16="http://schemas.microsoft.com/office/drawing/2014/main" id="{568707D9-8F4A-E1C5-9284-0A2721D0CAB8}"/>
+                <a16:creationId xmlns:a16="http://schemas.microsoft.com/office/drawing/2014/main" id="{E3E15B27-4658-A23A-A84C-E9455C2DE55C}"/>
               </a:ext>
             </a:extLst>
           </p:cNvPr>
@@ -7891,7 +7891,7 @@
           <p:cNvPr id="7" name="TextBox 6">
             <a:extLst>
               <a:ext uri="{FF2B5EF4-FFF2-40B4-BE49-F238E27FC236}">
-                <a16:creationId xmlns:a16="http://schemas.microsoft.com/office/drawing/2014/main" id="{87DAFEBC-D201-CA99-F477-147E11DE7799}"/>
+                <a16:creationId xmlns:a16="http://schemas.microsoft.com/office/drawing/2014/main" id="{B65943C9-B36B-DE59-A0A4-14CDE6BDC6D6}"/>
               </a:ext>
             </a:extLst>
           </p:cNvPr>
@@ -7931,7 +7931,7 @@
           <p:cNvPr id="8" name="Straight Connector 7">
             <a:extLst>
               <a:ext uri="{FF2B5EF4-FFF2-40B4-BE49-F238E27FC236}">
-                <a16:creationId xmlns:a16="http://schemas.microsoft.com/office/drawing/2014/main" id="{82D7B83C-2954-1DC6-46AD-51B3E51CA74B}"/>
+                <a16:creationId xmlns:a16="http://schemas.microsoft.com/office/drawing/2014/main" id="{24DD2FF6-9ACD-A4C0-8421-C643E3E921FD}"/>
               </a:ext>
             </a:extLst>
           </p:cNvPr>
@@ -7972,7 +7972,7 @@
           <p:cNvPr id="9" name="TextBox 8">
             <a:extLst>
               <a:ext uri="{FF2B5EF4-FFF2-40B4-BE49-F238E27FC236}">
-                <a16:creationId xmlns:a16="http://schemas.microsoft.com/office/drawing/2014/main" id="{A3507154-369A-69AF-43B9-0FEF2ADFD8F1}"/>
+                <a16:creationId xmlns:a16="http://schemas.microsoft.com/office/drawing/2014/main" id="{9890C55B-CD4C-E920-1368-E9957EB349F9}"/>
               </a:ext>
             </a:extLst>
           </p:cNvPr>
@@ -8012,7 +8012,7 @@
           <p:cNvPr id="10" name="Straight Connector 9">
             <a:extLst>
               <a:ext uri="{FF2B5EF4-FFF2-40B4-BE49-F238E27FC236}">
-                <a16:creationId xmlns:a16="http://schemas.microsoft.com/office/drawing/2014/main" id="{7C75A60A-D316-DF4F-7DF4-CFF9A5BA2987}"/>
+                <a16:creationId xmlns:a16="http://schemas.microsoft.com/office/drawing/2014/main" id="{7C32B689-AA71-98D4-8D14-8AF2CAAD8D12}"/>
               </a:ext>
             </a:extLst>
           </p:cNvPr>
@@ -8053,7 +8053,7 @@
           <p:cNvPr id="11" name="TextBox 10">
             <a:extLst>
               <a:ext uri="{FF2B5EF4-FFF2-40B4-BE49-F238E27FC236}">
-                <a16:creationId xmlns:a16="http://schemas.microsoft.com/office/drawing/2014/main" id="{8AA39579-A1C1-0C0D-4257-9B8736849039}"/>
+                <a16:creationId xmlns:a16="http://schemas.microsoft.com/office/drawing/2014/main" id="{67123B66-CD56-5599-4ADA-6F26B49E9381}"/>
               </a:ext>
             </a:extLst>
           </p:cNvPr>
@@ -8093,7 +8093,7 @@
           <p:cNvPr id="12" name="Straight Connector 11">
             <a:extLst>
               <a:ext uri="{FF2B5EF4-FFF2-40B4-BE49-F238E27FC236}">
-                <a16:creationId xmlns:a16="http://schemas.microsoft.com/office/drawing/2014/main" id="{78787B34-4DF5-43B9-3B5B-C87C75007458}"/>
+                <a16:creationId xmlns:a16="http://schemas.microsoft.com/office/drawing/2014/main" id="{95650785-17F2-FB1A-09B4-92CC3DB34F71}"/>
               </a:ext>
             </a:extLst>
           </p:cNvPr>
@@ -8134,7 +8134,7 @@
           <p:cNvPr id="13" name="TextBox 12">
             <a:extLst>
               <a:ext uri="{FF2B5EF4-FFF2-40B4-BE49-F238E27FC236}">
-                <a16:creationId xmlns:a16="http://schemas.microsoft.com/office/drawing/2014/main" id="{3AA1CF76-D233-1AD7-2370-CC91A8CAFA80}"/>
+                <a16:creationId xmlns:a16="http://schemas.microsoft.com/office/drawing/2014/main" id="{7BF2F115-9A5F-AFD4-ED38-6404DF4AE286}"/>
               </a:ext>
             </a:extLst>
           </p:cNvPr>
@@ -8174,7 +8174,7 @@
           <p:cNvPr id="14" name="Straight Connector 13">
             <a:extLst>
               <a:ext uri="{FF2B5EF4-FFF2-40B4-BE49-F238E27FC236}">
-                <a16:creationId xmlns:a16="http://schemas.microsoft.com/office/drawing/2014/main" id="{607D3933-847C-A4A8-4128-A860E97AF3FD}"/>
+                <a16:creationId xmlns:a16="http://schemas.microsoft.com/office/drawing/2014/main" id="{CE1077F1-BB52-A0FE-CCAA-79C0EF9A696E}"/>
               </a:ext>
             </a:extLst>
           </p:cNvPr>
@@ -8215,7 +8215,7 @@
           <p:cNvPr id="15" name="TextBox 14">
             <a:extLst>
               <a:ext uri="{FF2B5EF4-FFF2-40B4-BE49-F238E27FC236}">
-                <a16:creationId xmlns:a16="http://schemas.microsoft.com/office/drawing/2014/main" id="{3E3DBECA-CF74-B848-57E8-C6179F463232}"/>
+                <a16:creationId xmlns:a16="http://schemas.microsoft.com/office/drawing/2014/main" id="{F432BEF6-3534-8A38-64A1-8FCC9ACF31A9}"/>
               </a:ext>
             </a:extLst>
           </p:cNvPr>
@@ -8255,7 +8255,7 @@
           <p:cNvPr id="16" name="TextBox 15">
             <a:extLst>
               <a:ext uri="{FF2B5EF4-FFF2-40B4-BE49-F238E27FC236}">
-                <a16:creationId xmlns:a16="http://schemas.microsoft.com/office/drawing/2014/main" id="{55DB0613-3EA9-A82C-3C27-D3EA082C335C}"/>
+                <a16:creationId xmlns:a16="http://schemas.microsoft.com/office/drawing/2014/main" id="{287DFEB6-9616-4F36-73D3-89502344CB5F}"/>
               </a:ext>
             </a:extLst>
           </p:cNvPr>
@@ -8295,7 +8295,7 @@
           <p:cNvPr id="17" name="Straight Connector 16">
             <a:extLst>
               <a:ext uri="{FF2B5EF4-FFF2-40B4-BE49-F238E27FC236}">
-                <a16:creationId xmlns:a16="http://schemas.microsoft.com/office/drawing/2014/main" id="{2CD82ADD-704B-AF92-FBA3-F61DB07DA4E1}"/>
+                <a16:creationId xmlns:a16="http://schemas.microsoft.com/office/drawing/2014/main" id="{3986D58F-0E07-5C16-74C1-DB5A90EF715F}"/>
               </a:ext>
             </a:extLst>
           </p:cNvPr>
@@ -8336,7 +8336,7 @@
           <p:cNvPr id="18" name="TextBox 17">
             <a:extLst>
               <a:ext uri="{FF2B5EF4-FFF2-40B4-BE49-F238E27FC236}">
-                <a16:creationId xmlns:a16="http://schemas.microsoft.com/office/drawing/2014/main" id="{DE851C8F-4820-9305-0D26-5BC6241615B9}"/>
+                <a16:creationId xmlns:a16="http://schemas.microsoft.com/office/drawing/2014/main" id="{C1F50345-A85C-C3D0-1A76-43EEE81E4EBE}"/>
               </a:ext>
             </a:extLst>
           </p:cNvPr>
@@ -8376,7 +8376,7 @@
           <p:cNvPr id="19" name="Straight Connector 18">
             <a:extLst>
               <a:ext uri="{FF2B5EF4-FFF2-40B4-BE49-F238E27FC236}">
-                <a16:creationId xmlns:a16="http://schemas.microsoft.com/office/drawing/2014/main" id="{4B469E89-7013-11CD-BBFE-2225942753E1}"/>
+                <a16:creationId xmlns:a16="http://schemas.microsoft.com/office/drawing/2014/main" id="{2C19782E-CD70-A75B-D9A7-97ADCCD297ED}"/>
               </a:ext>
             </a:extLst>
           </p:cNvPr>
@@ -8417,7 +8417,7 @@
           <p:cNvPr id="20" name="TextBox 19">
             <a:extLst>
               <a:ext uri="{FF2B5EF4-FFF2-40B4-BE49-F238E27FC236}">
-                <a16:creationId xmlns:a16="http://schemas.microsoft.com/office/drawing/2014/main" id="{499F5C05-DA95-7315-322A-B65978A628F5}"/>
+                <a16:creationId xmlns:a16="http://schemas.microsoft.com/office/drawing/2014/main" id="{BFBC74B0-4182-31DA-ACC9-84F487241848}"/>
               </a:ext>
             </a:extLst>
           </p:cNvPr>
@@ -8457,7 +8457,7 @@
           <p:cNvPr id="21" name="Straight Connector 20">
             <a:extLst>
               <a:ext uri="{FF2B5EF4-FFF2-40B4-BE49-F238E27FC236}">
-                <a16:creationId xmlns:a16="http://schemas.microsoft.com/office/drawing/2014/main" id="{C944E060-0EEC-3DA1-C34D-5A35B28CDA11}"/>
+                <a16:creationId xmlns:a16="http://schemas.microsoft.com/office/drawing/2014/main" id="{D59BD9BA-ABC1-167E-DC5E-D970C838E0C1}"/>
               </a:ext>
             </a:extLst>
           </p:cNvPr>
@@ -8498,7 +8498,7 @@
           <p:cNvPr id="22" name="TextBox 21">
             <a:extLst>
               <a:ext uri="{FF2B5EF4-FFF2-40B4-BE49-F238E27FC236}">
-                <a16:creationId xmlns:a16="http://schemas.microsoft.com/office/drawing/2014/main" id="{88795FB2-F1B9-7EA3-0EB7-FA1691C21DFF}"/>
+                <a16:creationId xmlns:a16="http://schemas.microsoft.com/office/drawing/2014/main" id="{609423F1-9726-BB0C-82DC-A2DE2592EF25}"/>
               </a:ext>
             </a:extLst>
           </p:cNvPr>
@@ -8538,7 +8538,7 @@
           <p:cNvPr id="23" name="Straight Connector 22">
             <a:extLst>
               <a:ext uri="{FF2B5EF4-FFF2-40B4-BE49-F238E27FC236}">
-                <a16:creationId xmlns:a16="http://schemas.microsoft.com/office/drawing/2014/main" id="{7639A792-5CC0-2594-8E15-62A2092D391C}"/>
+                <a16:creationId xmlns:a16="http://schemas.microsoft.com/office/drawing/2014/main" id="{98D7E29C-969B-F0A3-E2E8-AE17ECD07FBF}"/>
               </a:ext>
             </a:extLst>
           </p:cNvPr>
@@ -8579,7 +8579,7 @@
           <p:cNvPr id="24" name="TextBox 23">
             <a:extLst>
               <a:ext uri="{FF2B5EF4-FFF2-40B4-BE49-F238E27FC236}">
-                <a16:creationId xmlns:a16="http://schemas.microsoft.com/office/drawing/2014/main" id="{A62EE5A2-A3A2-7548-DEDE-EA5E6EE72955}"/>
+                <a16:creationId xmlns:a16="http://schemas.microsoft.com/office/drawing/2014/main" id="{D5D0ADA5-BE40-FD8E-DE97-C75737FF2F38}"/>
               </a:ext>
             </a:extLst>
           </p:cNvPr>
@@ -8619,7 +8619,7 @@
           <p:cNvPr id="25" name="Rectangle: Rounded Corners 24">
             <a:extLst>
               <a:ext uri="{FF2B5EF4-FFF2-40B4-BE49-F238E27FC236}">
-                <a16:creationId xmlns:a16="http://schemas.microsoft.com/office/drawing/2014/main" id="{65C24FEF-DA44-C13C-BB26-2406844E188F}"/>
+                <a16:creationId xmlns:a16="http://schemas.microsoft.com/office/drawing/2014/main" id="{9ECCBF9D-C7FC-A9EF-94B5-3A038A08DB0B}"/>
               </a:ext>
             </a:extLst>
           </p:cNvPr>
@@ -8673,7 +8673,7 @@
           <p:cNvPr id="26" name="TextBox 25">
             <a:extLst>
               <a:ext uri="{FF2B5EF4-FFF2-40B4-BE49-F238E27FC236}">
-                <a16:creationId xmlns:a16="http://schemas.microsoft.com/office/drawing/2014/main" id="{F60E65FB-DACA-AE4B-D74B-B75AC6BAE866}"/>
+                <a16:creationId xmlns:a16="http://schemas.microsoft.com/office/drawing/2014/main" id="{05C40BAC-0497-D875-0E5B-435651A34B0C}"/>
               </a:ext>
             </a:extLst>
           </p:cNvPr>
@@ -8712,7 +8712,7 @@
     </p:spTree>
     <p:extLst>
       <p:ext uri="{BB962C8B-B14F-4D97-AF65-F5344CB8AC3E}">
-        <p14:creationId xmlns:p14="http://schemas.microsoft.com/office/powerpoint/2010/main" val="378204200"/>
+        <p14:creationId xmlns:p14="http://schemas.microsoft.com/office/powerpoint/2010/main" val="777295519"/>
       </p:ext>
     </p:extLst>
   </p:cSld>
@@ -8752,7 +8752,7 @@
           <p:cNvPr id="2" name="TextBox 1">
             <a:extLst>
               <a:ext uri="{FF2B5EF4-FFF2-40B4-BE49-F238E27FC236}">
-                <a16:creationId xmlns:a16="http://schemas.microsoft.com/office/drawing/2014/main" id="{A4B7BD22-FD4A-F1FC-E556-590C357048D2}"/>
+                <a16:creationId xmlns:a16="http://schemas.microsoft.com/office/drawing/2014/main" id="{BCB52F1C-1D4D-02B1-4EC5-A1845F456BFF}"/>
               </a:ext>
             </a:extLst>
           </p:cNvPr>
@@ -8792,7 +8792,7 @@
           <p:cNvPr id="3" name="Straight Connector 2">
             <a:extLst>
               <a:ext uri="{FF2B5EF4-FFF2-40B4-BE49-F238E27FC236}">
-                <a16:creationId xmlns:a16="http://schemas.microsoft.com/office/drawing/2014/main" id="{D4446C2C-D2C0-67E9-F718-EC32A239B0DB}"/>
+                <a16:creationId xmlns:a16="http://schemas.microsoft.com/office/drawing/2014/main" id="{6D54EE02-437A-049B-FEB6-6F3B5F0C92D1}"/>
               </a:ext>
             </a:extLst>
           </p:cNvPr>
@@ -8833,7 +8833,7 @@
           <p:cNvPr id="4" name="TextBox 3">
             <a:extLst>
               <a:ext uri="{FF2B5EF4-FFF2-40B4-BE49-F238E27FC236}">
-                <a16:creationId xmlns:a16="http://schemas.microsoft.com/office/drawing/2014/main" id="{4EC3FA65-BDD9-A716-4943-1A0F8CE2B434}"/>
+                <a16:creationId xmlns:a16="http://schemas.microsoft.com/office/drawing/2014/main" id="{100688CF-3F31-38B9-C5ED-D682A2329DC1}"/>
               </a:ext>
             </a:extLst>
           </p:cNvPr>
@@ -8874,7 +8874,7 @@
           <p:cNvPr id="5" name="TextBox 4">
             <a:extLst>
               <a:ext uri="{FF2B5EF4-FFF2-40B4-BE49-F238E27FC236}">
-                <a16:creationId xmlns:a16="http://schemas.microsoft.com/office/drawing/2014/main" id="{B4FCBDF3-986F-7CA3-E364-FEB33D7FEDD0}"/>
+                <a16:creationId xmlns:a16="http://schemas.microsoft.com/office/drawing/2014/main" id="{51A5CC1C-3A89-28AE-0DAB-6A9B1E11768B}"/>
               </a:ext>
             </a:extLst>
           </p:cNvPr>
@@ -8914,7 +8914,7 @@
           <p:cNvPr id="6" name="TextBox 5">
             <a:extLst>
               <a:ext uri="{FF2B5EF4-FFF2-40B4-BE49-F238E27FC236}">
-                <a16:creationId xmlns:a16="http://schemas.microsoft.com/office/drawing/2014/main" id="{062568EC-1FC7-5C9C-36D4-974481F102C5}"/>
+                <a16:creationId xmlns:a16="http://schemas.microsoft.com/office/drawing/2014/main" id="{BA8331BE-3839-172F-43BF-1010407D47DE}"/>
               </a:ext>
             </a:extLst>
           </p:cNvPr>
@@ -8954,7 +8954,7 @@
           <p:cNvPr id="7" name="TextBox 6">
             <a:extLst>
               <a:ext uri="{FF2B5EF4-FFF2-40B4-BE49-F238E27FC236}">
-                <a16:creationId xmlns:a16="http://schemas.microsoft.com/office/drawing/2014/main" id="{C87336A3-2814-B53E-1101-6047FDF837AB}"/>
+                <a16:creationId xmlns:a16="http://schemas.microsoft.com/office/drawing/2014/main" id="{57EEABF9-ECCA-14A1-D8C0-1550D6D68FEF}"/>
               </a:ext>
             </a:extLst>
           </p:cNvPr>
@@ -8994,7 +8994,7 @@
           <p:cNvPr id="8" name="TextBox 7">
             <a:extLst>
               <a:ext uri="{FF2B5EF4-FFF2-40B4-BE49-F238E27FC236}">
-                <a16:creationId xmlns:a16="http://schemas.microsoft.com/office/drawing/2014/main" id="{2F189602-7EA7-F21A-CB2E-B4A4BDD2D856}"/>
+                <a16:creationId xmlns:a16="http://schemas.microsoft.com/office/drawing/2014/main" id="{57C6B8D6-4741-7E63-5228-C3BBCB68A585}"/>
               </a:ext>
             </a:extLst>
           </p:cNvPr>
@@ -9034,7 +9034,7 @@
           <p:cNvPr id="9" name="Straight Connector 8">
             <a:extLst>
               <a:ext uri="{FF2B5EF4-FFF2-40B4-BE49-F238E27FC236}">
-                <a16:creationId xmlns:a16="http://schemas.microsoft.com/office/drawing/2014/main" id="{D0AEC76E-7042-9460-45CF-9DBDBD7A9CEC}"/>
+                <a16:creationId xmlns:a16="http://schemas.microsoft.com/office/drawing/2014/main" id="{A9262FBC-BF7B-FA72-E4B0-5C94E183B73B}"/>
               </a:ext>
             </a:extLst>
           </p:cNvPr>
@@ -9075,7 +9075,7 @@
           <p:cNvPr id="10" name="Straight Connector 9">
             <a:extLst>
               <a:ext uri="{FF2B5EF4-FFF2-40B4-BE49-F238E27FC236}">
-                <a16:creationId xmlns:a16="http://schemas.microsoft.com/office/drawing/2014/main" id="{FE368058-F87B-3CEB-CEE5-7E5F6C9974D4}"/>
+                <a16:creationId xmlns:a16="http://schemas.microsoft.com/office/drawing/2014/main" id="{C69D89B7-EC10-7971-6941-246E62DDBC42}"/>
               </a:ext>
             </a:extLst>
           </p:cNvPr>
@@ -9116,7 +9116,7 @@
           <p:cNvPr id="11" name="TextBox 10">
             <a:extLst>
               <a:ext uri="{FF2B5EF4-FFF2-40B4-BE49-F238E27FC236}">
-                <a16:creationId xmlns:a16="http://schemas.microsoft.com/office/drawing/2014/main" id="{0F4814D6-3608-6A4A-E606-5E88912F9CE6}"/>
+                <a16:creationId xmlns:a16="http://schemas.microsoft.com/office/drawing/2014/main" id="{7EEC8892-CED5-CC54-77BC-7E69D5B84796}"/>
               </a:ext>
             </a:extLst>
           </p:cNvPr>
@@ -9156,7 +9156,7 @@
           <p:cNvPr id="12" name="Straight Connector 11">
             <a:extLst>
               <a:ext uri="{FF2B5EF4-FFF2-40B4-BE49-F238E27FC236}">
-                <a16:creationId xmlns:a16="http://schemas.microsoft.com/office/drawing/2014/main" id="{0CE1F82C-8A93-2629-ADFA-18C9C5F04341}"/>
+                <a16:creationId xmlns:a16="http://schemas.microsoft.com/office/drawing/2014/main" id="{E8BCEC26-70C3-F610-0638-903BF0D354B4}"/>
               </a:ext>
             </a:extLst>
           </p:cNvPr>
@@ -9197,7 +9197,7 @@
           <p:cNvPr id="13" name="TextBox 12">
             <a:extLst>
               <a:ext uri="{FF2B5EF4-FFF2-40B4-BE49-F238E27FC236}">
-                <a16:creationId xmlns:a16="http://schemas.microsoft.com/office/drawing/2014/main" id="{7F5A5446-F443-D975-FBEF-3BF65DD3BF1E}"/>
+                <a16:creationId xmlns:a16="http://schemas.microsoft.com/office/drawing/2014/main" id="{B5058567-4B4B-B512-C442-6ADE473048D6}"/>
               </a:ext>
             </a:extLst>
           </p:cNvPr>
@@ -9237,7 +9237,7 @@
           <p:cNvPr id="14" name="Straight Connector 13">
             <a:extLst>
               <a:ext uri="{FF2B5EF4-FFF2-40B4-BE49-F238E27FC236}">
-                <a16:creationId xmlns:a16="http://schemas.microsoft.com/office/drawing/2014/main" id="{0F844CF8-E80B-EB66-4EAB-0E78943F99A0}"/>
+                <a16:creationId xmlns:a16="http://schemas.microsoft.com/office/drawing/2014/main" id="{BDABDEB1-C735-EB0E-E7AB-15A39723CC4C}"/>
               </a:ext>
             </a:extLst>
           </p:cNvPr>
@@ -9278,7 +9278,7 @@
           <p:cNvPr id="15" name="TextBox 14">
             <a:extLst>
               <a:ext uri="{FF2B5EF4-FFF2-40B4-BE49-F238E27FC236}">
-                <a16:creationId xmlns:a16="http://schemas.microsoft.com/office/drawing/2014/main" id="{7C2DDABF-22E8-1097-91EC-A7B2727140BD}"/>
+                <a16:creationId xmlns:a16="http://schemas.microsoft.com/office/drawing/2014/main" id="{E5C76D96-1058-2D42-C71B-4C37D4B36830}"/>
               </a:ext>
             </a:extLst>
           </p:cNvPr>
@@ -9318,7 +9318,7 @@
           <p:cNvPr id="16" name="Rectangle: Rounded Corners 15">
             <a:extLst>
               <a:ext uri="{FF2B5EF4-FFF2-40B4-BE49-F238E27FC236}">
-                <a16:creationId xmlns:a16="http://schemas.microsoft.com/office/drawing/2014/main" id="{FFC98BD0-245B-A6A1-2CEB-E15CEB42B54A}"/>
+                <a16:creationId xmlns:a16="http://schemas.microsoft.com/office/drawing/2014/main" id="{2E4284F2-6AAB-FED0-769C-760D719B42BB}"/>
               </a:ext>
             </a:extLst>
           </p:cNvPr>
@@ -9386,7 +9386,7 @@
           <p:cNvPr id="17" name="TextBox 16">
             <a:extLst>
               <a:ext uri="{FF2B5EF4-FFF2-40B4-BE49-F238E27FC236}">
-                <a16:creationId xmlns:a16="http://schemas.microsoft.com/office/drawing/2014/main" id="{2727F489-05EC-9546-A5F9-BBAF7750CC98}"/>
+                <a16:creationId xmlns:a16="http://schemas.microsoft.com/office/drawing/2014/main" id="{01CDEB6B-CDEE-D7D7-AB0C-49FEAD9D1119}"/>
               </a:ext>
             </a:extLst>
           </p:cNvPr>
@@ -9425,7 +9425,7 @@
     </p:spTree>
     <p:extLst>
       <p:ext uri="{BB962C8B-B14F-4D97-AF65-F5344CB8AC3E}">
-        <p14:creationId xmlns:p14="http://schemas.microsoft.com/office/powerpoint/2010/main" val="855470593"/>
+        <p14:creationId xmlns:p14="http://schemas.microsoft.com/office/powerpoint/2010/main" val="3076735281"/>
       </p:ext>
     </p:extLst>
   </p:cSld>
@@ -9465,7 +9465,7 @@
           <p:cNvPr id="2" name="TextBox 1">
             <a:extLst>
               <a:ext uri="{FF2B5EF4-FFF2-40B4-BE49-F238E27FC236}">
-                <a16:creationId xmlns:a16="http://schemas.microsoft.com/office/drawing/2014/main" id="{99204416-7242-0F7C-D27E-A340D0F1D7C9}"/>
+                <a16:creationId xmlns:a16="http://schemas.microsoft.com/office/drawing/2014/main" id="{41CB768C-2A88-80E9-3CB1-DAC95137F8D3}"/>
               </a:ext>
             </a:extLst>
           </p:cNvPr>
@@ -9505,7 +9505,7 @@
           <p:cNvPr id="3" name="Straight Connector 2">
             <a:extLst>
               <a:ext uri="{FF2B5EF4-FFF2-40B4-BE49-F238E27FC236}">
-                <a16:creationId xmlns:a16="http://schemas.microsoft.com/office/drawing/2014/main" id="{54742C6B-B802-2213-C649-023EEE7B2A98}"/>
+                <a16:creationId xmlns:a16="http://schemas.microsoft.com/office/drawing/2014/main" id="{73E85D96-EFBE-C3F9-C1D7-7317FD31AD0C}"/>
               </a:ext>
             </a:extLst>
           </p:cNvPr>
@@ -9546,7 +9546,7 @@
           <p:cNvPr id="4" name="TextBox 3">
             <a:extLst>
               <a:ext uri="{FF2B5EF4-FFF2-40B4-BE49-F238E27FC236}">
-                <a16:creationId xmlns:a16="http://schemas.microsoft.com/office/drawing/2014/main" id="{22C884E9-5A03-D023-A39F-181334E288D5}"/>
+                <a16:creationId xmlns:a16="http://schemas.microsoft.com/office/drawing/2014/main" id="{F6039761-8BF0-25FC-D43D-2DE5FE50EC1B}"/>
               </a:ext>
             </a:extLst>
           </p:cNvPr>
@@ -9587,7 +9587,7 @@
           <p:cNvPr id="5" name="TextBox 4">
             <a:extLst>
               <a:ext uri="{FF2B5EF4-FFF2-40B4-BE49-F238E27FC236}">
-                <a16:creationId xmlns:a16="http://schemas.microsoft.com/office/drawing/2014/main" id="{5193BC62-E99C-EC11-B532-97160A476862}"/>
+                <a16:creationId xmlns:a16="http://schemas.microsoft.com/office/drawing/2014/main" id="{56C191ED-EB9D-46A1-FBE1-8A81D409E5EC}"/>
               </a:ext>
             </a:extLst>
           </p:cNvPr>
@@ -9627,7 +9627,7 @@
           <p:cNvPr id="6" name="TextBox 5">
             <a:extLst>
               <a:ext uri="{FF2B5EF4-FFF2-40B4-BE49-F238E27FC236}">
-                <a16:creationId xmlns:a16="http://schemas.microsoft.com/office/drawing/2014/main" id="{B959EBF6-A182-02FB-ECAB-1FBF82CFCC7C}"/>
+                <a16:creationId xmlns:a16="http://schemas.microsoft.com/office/drawing/2014/main" id="{3C310C6B-814A-84DA-6F12-EE884334E829}"/>
               </a:ext>
             </a:extLst>
           </p:cNvPr>
@@ -9667,7 +9667,7 @@
           <p:cNvPr id="7" name="Straight Connector 6">
             <a:extLst>
               <a:ext uri="{FF2B5EF4-FFF2-40B4-BE49-F238E27FC236}">
-                <a16:creationId xmlns:a16="http://schemas.microsoft.com/office/drawing/2014/main" id="{CB1CC6AA-BDBF-06FE-8FAB-A05BC27963A4}"/>
+                <a16:creationId xmlns:a16="http://schemas.microsoft.com/office/drawing/2014/main" id="{0AF6402D-5569-755E-BF2C-9E625BDCA0B0}"/>
               </a:ext>
             </a:extLst>
           </p:cNvPr>
@@ -9708,7 +9708,7 @@
           <p:cNvPr id="8" name="TextBox 7">
             <a:extLst>
               <a:ext uri="{FF2B5EF4-FFF2-40B4-BE49-F238E27FC236}">
-                <a16:creationId xmlns:a16="http://schemas.microsoft.com/office/drawing/2014/main" id="{65424182-6FEA-05A5-5503-BB26454D5902}"/>
+                <a16:creationId xmlns:a16="http://schemas.microsoft.com/office/drawing/2014/main" id="{4CE503E7-E895-AE65-C92C-1CD5589FEB47}"/>
               </a:ext>
             </a:extLst>
           </p:cNvPr>
@@ -9748,7 +9748,7 @@
           <p:cNvPr id="9" name="Straight Connector 8">
             <a:extLst>
               <a:ext uri="{FF2B5EF4-FFF2-40B4-BE49-F238E27FC236}">
-                <a16:creationId xmlns:a16="http://schemas.microsoft.com/office/drawing/2014/main" id="{79F297C0-9558-AE01-3F13-AF775B8EBEDE}"/>
+                <a16:creationId xmlns:a16="http://schemas.microsoft.com/office/drawing/2014/main" id="{3DC9DBB4-E832-A209-E462-B4B2DFEAB9B4}"/>
               </a:ext>
             </a:extLst>
           </p:cNvPr>
@@ -9789,7 +9789,7 @@
           <p:cNvPr id="10" name="TextBox 9">
             <a:extLst>
               <a:ext uri="{FF2B5EF4-FFF2-40B4-BE49-F238E27FC236}">
-                <a16:creationId xmlns:a16="http://schemas.microsoft.com/office/drawing/2014/main" id="{84EFB993-E3F9-4F99-9D7C-46BA6B5B1E0F}"/>
+                <a16:creationId xmlns:a16="http://schemas.microsoft.com/office/drawing/2014/main" id="{5499206B-5FA0-FFD3-0CBF-A7CC205D670F}"/>
               </a:ext>
             </a:extLst>
           </p:cNvPr>
@@ -9829,7 +9829,7 @@
           <p:cNvPr id="11" name="Straight Connector 10">
             <a:extLst>
               <a:ext uri="{FF2B5EF4-FFF2-40B4-BE49-F238E27FC236}">
-                <a16:creationId xmlns:a16="http://schemas.microsoft.com/office/drawing/2014/main" id="{6AF6D905-C1FE-8C93-E1D1-B3F906E6B556}"/>
+                <a16:creationId xmlns:a16="http://schemas.microsoft.com/office/drawing/2014/main" id="{35351E81-BB1B-FFA2-3F27-3AEA00A9C41C}"/>
               </a:ext>
             </a:extLst>
           </p:cNvPr>
@@ -9870,7 +9870,7 @@
           <p:cNvPr id="12" name="TextBox 11">
             <a:extLst>
               <a:ext uri="{FF2B5EF4-FFF2-40B4-BE49-F238E27FC236}">
-                <a16:creationId xmlns:a16="http://schemas.microsoft.com/office/drawing/2014/main" id="{A5FA8CC7-B859-82C4-3F2D-4FE2CE86D6C1}"/>
+                <a16:creationId xmlns:a16="http://schemas.microsoft.com/office/drawing/2014/main" id="{B6FA1644-F4B1-B859-B9B4-575A7593F674}"/>
               </a:ext>
             </a:extLst>
           </p:cNvPr>
@@ -9910,7 +9910,7 @@
           <p:cNvPr id="13" name="Rectangle: Rounded Corners 12">
             <a:extLst>
               <a:ext uri="{FF2B5EF4-FFF2-40B4-BE49-F238E27FC236}">
-                <a16:creationId xmlns:a16="http://schemas.microsoft.com/office/drawing/2014/main" id="{DD0A7F3A-3607-E49F-881D-A13A0145C355}"/>
+                <a16:creationId xmlns:a16="http://schemas.microsoft.com/office/drawing/2014/main" id="{4F3CEEB2-9E19-5852-09A5-72F85E6DAF7B}"/>
               </a:ext>
             </a:extLst>
           </p:cNvPr>
@@ -9961,10 +9961,10 @@
       </p:sp>
       <p:pic>
         <p:nvPicPr>
-          <p:cNvPr id="15" name="Picture 14" descr="Overview showing seven administrative locality boundaries and frozen outcomes">
-            <a:extLst>
-              <a:ext uri="{FF2B5EF4-FFF2-40B4-BE49-F238E27FC236}">
-                <a16:creationId xmlns:a16="http://schemas.microsoft.com/office/drawing/2014/main" id="{B1A150B5-39EB-4D24-0F70-7BE355517FB3}"/>
+          <p:cNvPr id="15" name="Picture 14" descr="Overview showing seven administrative locality boundaries and access to live scenarios and results">
+            <a:extLst>
+              <a:ext uri="{FF2B5EF4-FFF2-40B4-BE49-F238E27FC236}">
+                <a16:creationId xmlns:a16="http://schemas.microsoft.com/office/drawing/2014/main" id="{4241AD8C-6F2C-5414-72EC-03944A264A28}"/>
               </a:ext>
             </a:extLst>
           </p:cNvPr>
@@ -10000,7 +10000,7 @@
           <p:cNvPr id="16" name="TextBox 15">
             <a:extLst>
               <a:ext uri="{FF2B5EF4-FFF2-40B4-BE49-F238E27FC236}">
-                <a16:creationId xmlns:a16="http://schemas.microsoft.com/office/drawing/2014/main" id="{09600543-E4AA-B91F-683B-069FA38E90CF}"/>
+                <a16:creationId xmlns:a16="http://schemas.microsoft.com/office/drawing/2014/main" id="{ED3E98F3-C856-A1F9-0638-27AD5480306C}"/>
               </a:ext>
             </a:extLst>
           </p:cNvPr>
@@ -10038,7 +10038,7 @@
     </p:spTree>
     <p:extLst>
       <p:ext uri="{BB962C8B-B14F-4D97-AF65-F5344CB8AC3E}">
-        <p14:creationId xmlns:p14="http://schemas.microsoft.com/office/powerpoint/2010/main" val="1063902145"/>
+        <p14:creationId xmlns:p14="http://schemas.microsoft.com/office/powerpoint/2010/main" val="1224907482"/>
       </p:ext>
     </p:extLst>
   </p:cSld>
@@ -10078,7 +10078,7 @@
           <p:cNvPr id="2" name="TextBox 1">
             <a:extLst>
               <a:ext uri="{FF2B5EF4-FFF2-40B4-BE49-F238E27FC236}">
-                <a16:creationId xmlns:a16="http://schemas.microsoft.com/office/drawing/2014/main" id="{EB0EB5D7-D654-0BA6-72A1-298D60D1BB05}"/>
+                <a16:creationId xmlns:a16="http://schemas.microsoft.com/office/drawing/2014/main" id="{217AE73F-25A2-4421-6DAE-4E0372096210}"/>
               </a:ext>
             </a:extLst>
           </p:cNvPr>
@@ -10118,7 +10118,7 @@
           <p:cNvPr id="3" name="Straight Connector 2">
             <a:extLst>
               <a:ext uri="{FF2B5EF4-FFF2-40B4-BE49-F238E27FC236}">
-                <a16:creationId xmlns:a16="http://schemas.microsoft.com/office/drawing/2014/main" id="{C0A32BD4-31B8-59D3-42E5-A25DB4AF2B03}"/>
+                <a16:creationId xmlns:a16="http://schemas.microsoft.com/office/drawing/2014/main" id="{21EF6D61-8EE2-E45C-F1B6-0D0B27DD4D18}"/>
               </a:ext>
             </a:extLst>
           </p:cNvPr>
@@ -10159,7 +10159,7 @@
           <p:cNvPr id="4" name="TextBox 3">
             <a:extLst>
               <a:ext uri="{FF2B5EF4-FFF2-40B4-BE49-F238E27FC236}">
-                <a16:creationId xmlns:a16="http://schemas.microsoft.com/office/drawing/2014/main" id="{DBA27A3C-5EFF-D28C-D7D4-4D5F46CB3382}"/>
+                <a16:creationId xmlns:a16="http://schemas.microsoft.com/office/drawing/2014/main" id="{F76A1153-1CFA-AA63-3286-01CC0585F576}"/>
               </a:ext>
             </a:extLst>
           </p:cNvPr>
@@ -10200,7 +10200,7 @@
           <p:cNvPr id="5" name="TextBox 4">
             <a:extLst>
               <a:ext uri="{FF2B5EF4-FFF2-40B4-BE49-F238E27FC236}">
-                <a16:creationId xmlns:a16="http://schemas.microsoft.com/office/drawing/2014/main" id="{F946E41C-655A-BA90-42A6-5763AFC60AA7}"/>
+                <a16:creationId xmlns:a16="http://schemas.microsoft.com/office/drawing/2014/main" id="{CBC62509-650E-085A-F8B1-CF5A7B621398}"/>
               </a:ext>
             </a:extLst>
           </p:cNvPr>
@@ -10240,7 +10240,7 @@
           <p:cNvPr id="6" name="TextBox 5">
             <a:extLst>
               <a:ext uri="{FF2B5EF4-FFF2-40B4-BE49-F238E27FC236}">
-                <a16:creationId xmlns:a16="http://schemas.microsoft.com/office/drawing/2014/main" id="{F6615FB7-5520-BDDC-491E-8DE5A81C2BFD}"/>
+                <a16:creationId xmlns:a16="http://schemas.microsoft.com/office/drawing/2014/main" id="{518F5A19-34D5-E4A2-12B7-C54D2C89A082}"/>
               </a:ext>
             </a:extLst>
           </p:cNvPr>
@@ -10280,7 +10280,7 @@
           <p:cNvPr id="7" name="Straight Connector 6">
             <a:extLst>
               <a:ext uri="{FF2B5EF4-FFF2-40B4-BE49-F238E27FC236}">
-                <a16:creationId xmlns:a16="http://schemas.microsoft.com/office/drawing/2014/main" id="{CCF09DD9-3604-2B60-98DC-8281739034A1}"/>
+                <a16:creationId xmlns:a16="http://schemas.microsoft.com/office/drawing/2014/main" id="{1D628A75-F958-A987-DDB9-0C2DCD979DDB}"/>
               </a:ext>
             </a:extLst>
           </p:cNvPr>
@@ -10322,7 +10322,7 @@
           <p:cNvPr id="8" name="Straight Connector 7">
             <a:extLst>
               <a:ext uri="{FF2B5EF4-FFF2-40B4-BE49-F238E27FC236}">
-                <a16:creationId xmlns:a16="http://schemas.microsoft.com/office/drawing/2014/main" id="{F5E51820-9F28-E098-6645-57829F75A475}"/>
+                <a16:creationId xmlns:a16="http://schemas.microsoft.com/office/drawing/2014/main" id="{C200C004-2E4F-7173-A78E-A97271A03208}"/>
               </a:ext>
             </a:extLst>
           </p:cNvPr>
@@ -10364,7 +10364,7 @@
           <p:cNvPr id="9" name="Straight Connector 8">
             <a:extLst>
               <a:ext uri="{FF2B5EF4-FFF2-40B4-BE49-F238E27FC236}">
-                <a16:creationId xmlns:a16="http://schemas.microsoft.com/office/drawing/2014/main" id="{784F07B7-A09C-B3D6-922E-6A6BA79F8143}"/>
+                <a16:creationId xmlns:a16="http://schemas.microsoft.com/office/drawing/2014/main" id="{5309BA80-DDAA-F7C4-C3DF-4E7D3FEC2886}"/>
               </a:ext>
             </a:extLst>
           </p:cNvPr>
@@ -10406,7 +10406,7 @@
           <p:cNvPr id="10" name="Straight Connector 9">
             <a:extLst>
               <a:ext uri="{FF2B5EF4-FFF2-40B4-BE49-F238E27FC236}">
-                <a16:creationId xmlns:a16="http://schemas.microsoft.com/office/drawing/2014/main" id="{26B05703-C059-8349-17D0-520AEB3AA48E}"/>
+                <a16:creationId xmlns:a16="http://schemas.microsoft.com/office/drawing/2014/main" id="{27770EFC-9645-6E30-311C-D228669E0356}"/>
               </a:ext>
             </a:extLst>
           </p:cNvPr>
@@ -10448,7 +10448,7 @@
           <p:cNvPr id="11" name="Rectangle: Rounded Corners 10">
             <a:extLst>
               <a:ext uri="{FF2B5EF4-FFF2-40B4-BE49-F238E27FC236}">
-                <a16:creationId xmlns:a16="http://schemas.microsoft.com/office/drawing/2014/main" id="{BF95DA16-CEFF-2921-D28C-8A1613A8674D}"/>
+                <a16:creationId xmlns:a16="http://schemas.microsoft.com/office/drawing/2014/main" id="{A3C225DD-38B3-A6C0-69C4-800BBE4CF537}"/>
               </a:ext>
             </a:extLst>
           </p:cNvPr>
@@ -10516,7 +10516,7 @@
           <p:cNvPr id="12" name="TextBox 11">
             <a:extLst>
               <a:ext uri="{FF2B5EF4-FFF2-40B4-BE49-F238E27FC236}">
-                <a16:creationId xmlns:a16="http://schemas.microsoft.com/office/drawing/2014/main" id="{FDDA0CC0-6186-BA04-B7B7-BC604BB37377}"/>
+                <a16:creationId xmlns:a16="http://schemas.microsoft.com/office/drawing/2014/main" id="{A28DD350-C909-39B3-65B9-614C956B8B46}"/>
               </a:ext>
             </a:extLst>
           </p:cNvPr>
@@ -10569,7 +10569,7 @@
           <p:cNvPr id="13" name="Rectangle: Rounded Corners 12">
             <a:extLst>
               <a:ext uri="{FF2B5EF4-FFF2-40B4-BE49-F238E27FC236}">
-                <a16:creationId xmlns:a16="http://schemas.microsoft.com/office/drawing/2014/main" id="{27B03840-600A-58FF-8D92-2F98DED566E9}"/>
+                <a16:creationId xmlns:a16="http://schemas.microsoft.com/office/drawing/2014/main" id="{95E72986-AA59-6AE3-CA83-7D9AA8B38005}"/>
               </a:ext>
             </a:extLst>
           </p:cNvPr>
@@ -10637,7 +10637,7 @@
           <p:cNvPr id="14" name="TextBox 13">
             <a:extLst>
               <a:ext uri="{FF2B5EF4-FFF2-40B4-BE49-F238E27FC236}">
-                <a16:creationId xmlns:a16="http://schemas.microsoft.com/office/drawing/2014/main" id="{AA8BCA4A-1E84-A419-7E6A-26F474221F48}"/>
+                <a16:creationId xmlns:a16="http://schemas.microsoft.com/office/drawing/2014/main" id="{5CFEFECA-A04F-A6A3-D51B-45A640B98D22}"/>
               </a:ext>
             </a:extLst>
           </p:cNvPr>
@@ -10690,7 +10690,7 @@
           <p:cNvPr id="15" name="Rectangle: Rounded Corners 14">
             <a:extLst>
               <a:ext uri="{FF2B5EF4-FFF2-40B4-BE49-F238E27FC236}">
-                <a16:creationId xmlns:a16="http://schemas.microsoft.com/office/drawing/2014/main" id="{D010DAD8-256E-C686-002E-DED6BF886D20}"/>
+                <a16:creationId xmlns:a16="http://schemas.microsoft.com/office/drawing/2014/main" id="{00C9A8EF-D620-94FE-609C-D9C05FD9BA75}"/>
               </a:ext>
             </a:extLst>
           </p:cNvPr>
@@ -10758,7 +10758,7 @@
           <p:cNvPr id="16" name="TextBox 15">
             <a:extLst>
               <a:ext uri="{FF2B5EF4-FFF2-40B4-BE49-F238E27FC236}">
-                <a16:creationId xmlns:a16="http://schemas.microsoft.com/office/drawing/2014/main" id="{A9848BD2-A99A-7503-6418-CBB916C73F79}"/>
+                <a16:creationId xmlns:a16="http://schemas.microsoft.com/office/drawing/2014/main" id="{9C8B57E2-A06A-AE23-D975-6A7E25A305D8}"/>
               </a:ext>
             </a:extLst>
           </p:cNvPr>
@@ -10811,7 +10811,7 @@
           <p:cNvPr id="17" name="Rectangle: Rounded Corners 16">
             <a:extLst>
               <a:ext uri="{FF2B5EF4-FFF2-40B4-BE49-F238E27FC236}">
-                <a16:creationId xmlns:a16="http://schemas.microsoft.com/office/drawing/2014/main" id="{ED3B3D58-9F3E-D712-8EA6-9180801937B2}"/>
+                <a16:creationId xmlns:a16="http://schemas.microsoft.com/office/drawing/2014/main" id="{BF5ABEDA-386D-2A21-919E-EB811C1CA467}"/>
               </a:ext>
             </a:extLst>
           </p:cNvPr>
@@ -10879,7 +10879,7 @@
           <p:cNvPr id="18" name="TextBox 17">
             <a:extLst>
               <a:ext uri="{FF2B5EF4-FFF2-40B4-BE49-F238E27FC236}">
-                <a16:creationId xmlns:a16="http://schemas.microsoft.com/office/drawing/2014/main" id="{31DD08E6-FC90-4138-DAEE-0FFC34ADA6AE}"/>
+                <a16:creationId xmlns:a16="http://schemas.microsoft.com/office/drawing/2014/main" id="{FE0316C4-22D1-C655-E6A9-C27BBDEDAD44}"/>
               </a:ext>
             </a:extLst>
           </p:cNvPr>
@@ -10932,7 +10932,7 @@
           <p:cNvPr id="19" name="Rectangle: Rounded Corners 18">
             <a:extLst>
               <a:ext uri="{FF2B5EF4-FFF2-40B4-BE49-F238E27FC236}">
-                <a16:creationId xmlns:a16="http://schemas.microsoft.com/office/drawing/2014/main" id="{BDB397AF-B996-9268-C0FF-7A9206153EB8}"/>
+                <a16:creationId xmlns:a16="http://schemas.microsoft.com/office/drawing/2014/main" id="{F4242715-6C0C-686D-AB76-15953AC4323B}"/>
               </a:ext>
             </a:extLst>
           </p:cNvPr>
@@ -11000,7 +11000,7 @@
           <p:cNvPr id="20" name="TextBox 19">
             <a:extLst>
               <a:ext uri="{FF2B5EF4-FFF2-40B4-BE49-F238E27FC236}">
-                <a16:creationId xmlns:a16="http://schemas.microsoft.com/office/drawing/2014/main" id="{B3DD9AE8-7B93-8D62-E8A6-F4E07EEC5937}"/>
+                <a16:creationId xmlns:a16="http://schemas.microsoft.com/office/drawing/2014/main" id="{6520D4B5-E3DB-4E28-0DBA-8DCAC0C4641D}"/>
               </a:ext>
             </a:extLst>
           </p:cNvPr>
@@ -11053,7 +11053,7 @@
           <p:cNvPr id="21" name="TextBox 20">
             <a:extLst>
               <a:ext uri="{FF2B5EF4-FFF2-40B4-BE49-F238E27FC236}">
-                <a16:creationId xmlns:a16="http://schemas.microsoft.com/office/drawing/2014/main" id="{D154EC11-E536-6350-AEBF-042D9ECCCC43}"/>
+                <a16:creationId xmlns:a16="http://schemas.microsoft.com/office/drawing/2014/main" id="{77EE918D-9BCA-9D73-7BBD-C27CF9ED21B7}"/>
               </a:ext>
             </a:extLst>
           </p:cNvPr>
@@ -11093,7 +11093,7 @@
           <p:cNvPr id="22" name="Straight Connector 21">
             <a:extLst>
               <a:ext uri="{FF2B5EF4-FFF2-40B4-BE49-F238E27FC236}">
-                <a16:creationId xmlns:a16="http://schemas.microsoft.com/office/drawing/2014/main" id="{CF3089CA-7574-2E01-D9CF-1F5BCE6CA8AF}"/>
+                <a16:creationId xmlns:a16="http://schemas.microsoft.com/office/drawing/2014/main" id="{EE0A7635-8A76-CA8B-FE24-3AEE60B90775}"/>
               </a:ext>
             </a:extLst>
           </p:cNvPr>
@@ -11134,7 +11134,7 @@
           <p:cNvPr id="23" name="TextBox 22">
             <a:extLst>
               <a:ext uri="{FF2B5EF4-FFF2-40B4-BE49-F238E27FC236}">
-                <a16:creationId xmlns:a16="http://schemas.microsoft.com/office/drawing/2014/main" id="{D2BE4148-EB04-944D-32A0-C13551F6C999}"/>
+                <a16:creationId xmlns:a16="http://schemas.microsoft.com/office/drawing/2014/main" id="{5662F121-755E-EB94-1477-8348051E3ACC}"/>
               </a:ext>
             </a:extLst>
           </p:cNvPr>
@@ -11174,7 +11174,7 @@
           <p:cNvPr id="24" name="TextBox 23">
             <a:extLst>
               <a:ext uri="{FF2B5EF4-FFF2-40B4-BE49-F238E27FC236}">
-                <a16:creationId xmlns:a16="http://schemas.microsoft.com/office/drawing/2014/main" id="{D3E9E211-E367-2254-7C95-C723071594AE}"/>
+                <a16:creationId xmlns:a16="http://schemas.microsoft.com/office/drawing/2014/main" id="{AB7B63B3-93F8-7B86-81D3-4E04E0CD4AA8}"/>
               </a:ext>
             </a:extLst>
           </p:cNvPr>
@@ -11214,7 +11214,7 @@
           <p:cNvPr id="25" name="TextBox 24">
             <a:extLst>
               <a:ext uri="{FF2B5EF4-FFF2-40B4-BE49-F238E27FC236}">
-                <a16:creationId xmlns:a16="http://schemas.microsoft.com/office/drawing/2014/main" id="{CB96D79B-AD56-7097-3587-32E036A1B172}"/>
+                <a16:creationId xmlns:a16="http://schemas.microsoft.com/office/drawing/2014/main" id="{EBB51F91-0832-1990-F11A-3EF95A602F37}"/>
               </a:ext>
             </a:extLst>
           </p:cNvPr>
@@ -11252,7 +11252,7 @@
     </p:spTree>
     <p:extLst>
       <p:ext uri="{BB962C8B-B14F-4D97-AF65-F5344CB8AC3E}">
-        <p14:creationId xmlns:p14="http://schemas.microsoft.com/office/powerpoint/2010/main" val="3746362595"/>
+        <p14:creationId xmlns:p14="http://schemas.microsoft.com/office/powerpoint/2010/main" val="2084298208"/>
       </p:ext>
     </p:extLst>
   </p:cSld>
@@ -11292,7 +11292,7 @@
           <p:cNvPr id="2" name="TextBox 1">
             <a:extLst>
               <a:ext uri="{FF2B5EF4-FFF2-40B4-BE49-F238E27FC236}">
-                <a16:creationId xmlns:a16="http://schemas.microsoft.com/office/drawing/2014/main" id="{717F8CBF-7E92-410B-B3B3-6FD94473ED47}"/>
+                <a16:creationId xmlns:a16="http://schemas.microsoft.com/office/drawing/2014/main" id="{2BF94D88-438A-9742-B56B-32D83C31F7E1}"/>
               </a:ext>
             </a:extLst>
           </p:cNvPr>
@@ -11332,7 +11332,7 @@
           <p:cNvPr id="3" name="Straight Connector 2">
             <a:extLst>
               <a:ext uri="{FF2B5EF4-FFF2-40B4-BE49-F238E27FC236}">
-                <a16:creationId xmlns:a16="http://schemas.microsoft.com/office/drawing/2014/main" id="{8FA5A2E2-E334-E0D9-1DF4-C14D41D23E24}"/>
+                <a16:creationId xmlns:a16="http://schemas.microsoft.com/office/drawing/2014/main" id="{0EDF6609-A75E-7FC3-3934-13E08AD96E8B}"/>
               </a:ext>
             </a:extLst>
           </p:cNvPr>
@@ -11373,7 +11373,7 @@
           <p:cNvPr id="4" name="TextBox 3">
             <a:extLst>
               <a:ext uri="{FF2B5EF4-FFF2-40B4-BE49-F238E27FC236}">
-                <a16:creationId xmlns:a16="http://schemas.microsoft.com/office/drawing/2014/main" id="{0E1F19CA-B125-99CA-F20F-1782604AA59F}"/>
+                <a16:creationId xmlns:a16="http://schemas.microsoft.com/office/drawing/2014/main" id="{2F68AB14-5865-190E-EBFE-909113D26DE5}"/>
               </a:ext>
             </a:extLst>
           </p:cNvPr>
@@ -11414,7 +11414,7 @@
           <p:cNvPr id="5" name="TextBox 4">
             <a:extLst>
               <a:ext uri="{FF2B5EF4-FFF2-40B4-BE49-F238E27FC236}">
-                <a16:creationId xmlns:a16="http://schemas.microsoft.com/office/drawing/2014/main" id="{970B2EF0-792A-5A92-D4FA-547B3E533456}"/>
+                <a16:creationId xmlns:a16="http://schemas.microsoft.com/office/drawing/2014/main" id="{3FE98F40-66DD-3E75-2E03-D53057E66DBF}"/>
               </a:ext>
             </a:extLst>
           </p:cNvPr>
@@ -11454,7 +11454,7 @@
           <p:cNvPr id="6" name="TextBox 5">
             <a:extLst>
               <a:ext uri="{FF2B5EF4-FFF2-40B4-BE49-F238E27FC236}">
-                <a16:creationId xmlns:a16="http://schemas.microsoft.com/office/drawing/2014/main" id="{98FAAA75-CCB1-E3EA-9A7E-A8C547E37081}"/>
+                <a16:creationId xmlns:a16="http://schemas.microsoft.com/office/drawing/2014/main" id="{62473DA5-8D7E-DF28-BFD5-58E490344B1E}"/>
               </a:ext>
             </a:extLst>
           </p:cNvPr>
@@ -11494,7 +11494,7 @@
           <p:cNvPr id="7" name="Rectangle: Rounded Corners 6">
             <a:extLst>
               <a:ext uri="{FF2B5EF4-FFF2-40B4-BE49-F238E27FC236}">
-                <a16:creationId xmlns:a16="http://schemas.microsoft.com/office/drawing/2014/main" id="{15F224B3-D5E6-FEE2-A0FD-72A8BF652D25}"/>
+                <a16:creationId xmlns:a16="http://schemas.microsoft.com/office/drawing/2014/main" id="{D9220A30-C505-D41A-340C-19E1D4479AC8}"/>
               </a:ext>
             </a:extLst>
           </p:cNvPr>
@@ -11562,7 +11562,7 @@
           <p:cNvPr id="8" name="TextBox 7">
             <a:extLst>
               <a:ext uri="{FF2B5EF4-FFF2-40B4-BE49-F238E27FC236}">
-                <a16:creationId xmlns:a16="http://schemas.microsoft.com/office/drawing/2014/main" id="{9EFC3CD9-A944-A227-196C-699B0652208D}"/>
+                <a16:creationId xmlns:a16="http://schemas.microsoft.com/office/drawing/2014/main" id="{F09328A1-11B3-9C52-ED80-89FD6B9A1AB3}"/>
               </a:ext>
             </a:extLst>
           </p:cNvPr>
@@ -11603,7 +11603,7 @@
           <p:cNvPr id="9" name="TextBox 8">
             <a:extLst>
               <a:ext uri="{FF2B5EF4-FFF2-40B4-BE49-F238E27FC236}">
-                <a16:creationId xmlns:a16="http://schemas.microsoft.com/office/drawing/2014/main" id="{E19BC73B-AB2B-6202-19D1-716397757C83}"/>
+                <a16:creationId xmlns:a16="http://schemas.microsoft.com/office/drawing/2014/main" id="{A5E4E693-A130-EE94-AE3E-A011A37A1B09}"/>
               </a:ext>
             </a:extLst>
           </p:cNvPr>
@@ -11644,7 +11644,7 @@
           <p:cNvPr id="10" name="TextBox 9">
             <a:extLst>
               <a:ext uri="{FF2B5EF4-FFF2-40B4-BE49-F238E27FC236}">
-                <a16:creationId xmlns:a16="http://schemas.microsoft.com/office/drawing/2014/main" id="{8982DD5D-EB8C-2C2A-64BD-E8ADCFDA93BD}"/>
+                <a16:creationId xmlns:a16="http://schemas.microsoft.com/office/drawing/2014/main" id="{EA3C64A3-2DAB-7B62-AF1A-A3B90821D451}"/>
               </a:ext>
             </a:extLst>
           </p:cNvPr>
@@ -11685,7 +11685,7 @@
           <p:cNvPr id="11" name="TextBox 10">
             <a:extLst>
               <a:ext uri="{FF2B5EF4-FFF2-40B4-BE49-F238E27FC236}">
-                <a16:creationId xmlns:a16="http://schemas.microsoft.com/office/drawing/2014/main" id="{37BA3345-84B2-998F-1BEC-8CB3CBFF1F90}"/>
+                <a16:creationId xmlns:a16="http://schemas.microsoft.com/office/drawing/2014/main" id="{844C2233-4BE2-1BF2-00E4-EA5AC696678C}"/>
               </a:ext>
             </a:extLst>
           </p:cNvPr>
@@ -11726,7 +11726,7 @@
           <p:cNvPr id="12" name="Rectangle: Rounded Corners 11">
             <a:extLst>
               <a:ext uri="{FF2B5EF4-FFF2-40B4-BE49-F238E27FC236}">
-                <a16:creationId xmlns:a16="http://schemas.microsoft.com/office/drawing/2014/main" id="{7588B1BD-9924-3886-686F-C7B1B1F113A8}"/>
+                <a16:creationId xmlns:a16="http://schemas.microsoft.com/office/drawing/2014/main" id="{7F09CCED-935B-29C0-60AA-B0FD6C76514E}"/>
               </a:ext>
             </a:extLst>
           </p:cNvPr>
@@ -11794,7 +11794,7 @@
           <p:cNvPr id="13" name="TextBox 12">
             <a:extLst>
               <a:ext uri="{FF2B5EF4-FFF2-40B4-BE49-F238E27FC236}">
-                <a16:creationId xmlns:a16="http://schemas.microsoft.com/office/drawing/2014/main" id="{5D1914E2-A4D9-1A97-D4AC-1642557C299E}"/>
+                <a16:creationId xmlns:a16="http://schemas.microsoft.com/office/drawing/2014/main" id="{1A8326EB-08AB-B238-AF7B-B709D2D60092}"/>
               </a:ext>
             </a:extLst>
           </p:cNvPr>
@@ -11835,7 +11835,7 @@
           <p:cNvPr id="14" name="TextBox 13">
             <a:extLst>
               <a:ext uri="{FF2B5EF4-FFF2-40B4-BE49-F238E27FC236}">
-                <a16:creationId xmlns:a16="http://schemas.microsoft.com/office/drawing/2014/main" id="{3EECCA37-7F59-3AA3-AC5D-776F96EFE6C5}"/>
+                <a16:creationId xmlns:a16="http://schemas.microsoft.com/office/drawing/2014/main" id="{97B8288D-0311-3C29-F072-EAC0ABD85C90}"/>
               </a:ext>
             </a:extLst>
           </p:cNvPr>
@@ -11876,7 +11876,7 @@
           <p:cNvPr id="15" name="TextBox 14">
             <a:extLst>
               <a:ext uri="{FF2B5EF4-FFF2-40B4-BE49-F238E27FC236}">
-                <a16:creationId xmlns:a16="http://schemas.microsoft.com/office/drawing/2014/main" id="{8B447AE4-E602-BB17-125C-C89D53D910A5}"/>
+                <a16:creationId xmlns:a16="http://schemas.microsoft.com/office/drawing/2014/main" id="{3C80C3F8-BC92-5E00-CCE3-ABF449C1334F}"/>
               </a:ext>
             </a:extLst>
           </p:cNvPr>
@@ -11917,7 +11917,7 @@
           <p:cNvPr id="16" name="Rectangle: Rounded Corners 15">
             <a:extLst>
               <a:ext uri="{FF2B5EF4-FFF2-40B4-BE49-F238E27FC236}">
-                <a16:creationId xmlns:a16="http://schemas.microsoft.com/office/drawing/2014/main" id="{B50C7EBE-9EE5-6618-B8B3-DC68FA4A8CC2}"/>
+                <a16:creationId xmlns:a16="http://schemas.microsoft.com/office/drawing/2014/main" id="{DB084BE6-0784-CC88-FBB3-2C907BE11744}"/>
               </a:ext>
             </a:extLst>
           </p:cNvPr>
@@ -11985,7 +11985,7 @@
           <p:cNvPr id="17" name="TextBox 16">
             <a:extLst>
               <a:ext uri="{FF2B5EF4-FFF2-40B4-BE49-F238E27FC236}">
-                <a16:creationId xmlns:a16="http://schemas.microsoft.com/office/drawing/2014/main" id="{88E68315-F6F6-1B5B-0E67-A897D88DDE5E}"/>
+                <a16:creationId xmlns:a16="http://schemas.microsoft.com/office/drawing/2014/main" id="{31227A1D-25C9-C771-CCD0-298C290AB82C}"/>
               </a:ext>
             </a:extLst>
           </p:cNvPr>
@@ -12026,7 +12026,7 @@
           <p:cNvPr id="18" name="TextBox 17">
             <a:extLst>
               <a:ext uri="{FF2B5EF4-FFF2-40B4-BE49-F238E27FC236}">
-                <a16:creationId xmlns:a16="http://schemas.microsoft.com/office/drawing/2014/main" id="{F5C3936F-503C-BD29-B8FC-BEC0C2DD7554}"/>
+                <a16:creationId xmlns:a16="http://schemas.microsoft.com/office/drawing/2014/main" id="{FCF9C250-5103-6814-8E08-8E847B13A8FB}"/>
               </a:ext>
             </a:extLst>
           </p:cNvPr>
@@ -12067,7 +12067,7 @@
           <p:cNvPr id="19" name="Straight Connector 18">
             <a:extLst>
               <a:ext uri="{FF2B5EF4-FFF2-40B4-BE49-F238E27FC236}">
-                <a16:creationId xmlns:a16="http://schemas.microsoft.com/office/drawing/2014/main" id="{6FCB830C-D0EB-7BB4-C182-549F5D6138AA}"/>
+                <a16:creationId xmlns:a16="http://schemas.microsoft.com/office/drawing/2014/main" id="{CB940974-70C3-AD53-633C-D19922F8625C}"/>
               </a:ext>
             </a:extLst>
           </p:cNvPr>
@@ -12108,7 +12108,7 @@
           <p:cNvPr id="20" name="TextBox 19">
             <a:extLst>
               <a:ext uri="{FF2B5EF4-FFF2-40B4-BE49-F238E27FC236}">
-                <a16:creationId xmlns:a16="http://schemas.microsoft.com/office/drawing/2014/main" id="{1BCA90A0-FD13-FBD8-31F2-4BAAC70E727A}"/>
+                <a16:creationId xmlns:a16="http://schemas.microsoft.com/office/drawing/2014/main" id="{04185ADF-5D45-7727-BE0E-6D796A586636}"/>
               </a:ext>
             </a:extLst>
           </p:cNvPr>
@@ -12148,7 +12148,7 @@
           <p:cNvPr id="21" name="TextBox 20">
             <a:extLst>
               <a:ext uri="{FF2B5EF4-FFF2-40B4-BE49-F238E27FC236}">
-                <a16:creationId xmlns:a16="http://schemas.microsoft.com/office/drawing/2014/main" id="{AB4421BE-2EA1-F2FE-48BE-470801C557F3}"/>
+                <a16:creationId xmlns:a16="http://schemas.microsoft.com/office/drawing/2014/main" id="{E2191403-0302-B78A-ADA7-56CC5AB56DD2}"/>
               </a:ext>
             </a:extLst>
           </p:cNvPr>
@@ -12199,7 +12199,7 @@
           <p:cNvPr id="22" name="TextBox 21">
             <a:extLst>
               <a:ext uri="{FF2B5EF4-FFF2-40B4-BE49-F238E27FC236}">
-                <a16:creationId xmlns:a16="http://schemas.microsoft.com/office/drawing/2014/main" id="{33323739-A5DD-DD8E-5EE3-5D08706AFDFF}"/>
+                <a16:creationId xmlns:a16="http://schemas.microsoft.com/office/drawing/2014/main" id="{9C3818F1-2B26-E8A2-0F0E-75AA50137EFB}"/>
               </a:ext>
             </a:extLst>
           </p:cNvPr>
@@ -12239,7 +12239,7 @@
           <p:cNvPr id="23" name="TextBox 22">
             <a:extLst>
               <a:ext uri="{FF2B5EF4-FFF2-40B4-BE49-F238E27FC236}">
-                <a16:creationId xmlns:a16="http://schemas.microsoft.com/office/drawing/2014/main" id="{F413B688-1D3F-3BB9-5CD1-FD1846223C41}"/>
+                <a16:creationId xmlns:a16="http://schemas.microsoft.com/office/drawing/2014/main" id="{DBC02643-74E8-13EB-9DA5-45714AB53BFE}"/>
               </a:ext>
             </a:extLst>
           </p:cNvPr>
@@ -12290,7 +12290,7 @@
           <p:cNvPr id="24" name="TextBox 23">
             <a:extLst>
               <a:ext uri="{FF2B5EF4-FFF2-40B4-BE49-F238E27FC236}">
-                <a16:creationId xmlns:a16="http://schemas.microsoft.com/office/drawing/2014/main" id="{42563CD1-693A-CECD-73C2-0AD9A4AFC123}"/>
+                <a16:creationId xmlns:a16="http://schemas.microsoft.com/office/drawing/2014/main" id="{732EF02D-D184-3512-12B2-934FA02C853F}"/>
               </a:ext>
             </a:extLst>
           </p:cNvPr>
@@ -12329,7 +12329,7 @@
     </p:spTree>
     <p:extLst>
       <p:ext uri="{BB962C8B-B14F-4D97-AF65-F5344CB8AC3E}">
-        <p14:creationId xmlns:p14="http://schemas.microsoft.com/office/powerpoint/2010/main" val="2330392729"/>
+        <p14:creationId xmlns:p14="http://schemas.microsoft.com/office/powerpoint/2010/main" val="2096661561"/>
       </p:ext>
     </p:extLst>
   </p:cSld>
@@ -12369,7 +12369,7 @@
           <p:cNvPr id="2" name="TextBox 1">
             <a:extLst>
               <a:ext uri="{FF2B5EF4-FFF2-40B4-BE49-F238E27FC236}">
-                <a16:creationId xmlns:a16="http://schemas.microsoft.com/office/drawing/2014/main" id="{410E2BB3-C40F-6668-223D-88EC3A619730}"/>
+                <a16:creationId xmlns:a16="http://schemas.microsoft.com/office/drawing/2014/main" id="{CC065ECD-1772-FE7A-4813-AFD206E1A77A}"/>
               </a:ext>
             </a:extLst>
           </p:cNvPr>
@@ -12409,7 +12409,7 @@
           <p:cNvPr id="3" name="Straight Connector 2">
             <a:extLst>
               <a:ext uri="{FF2B5EF4-FFF2-40B4-BE49-F238E27FC236}">
-                <a16:creationId xmlns:a16="http://schemas.microsoft.com/office/drawing/2014/main" id="{3CA361E5-A3B9-3048-FB52-3ECBDB2E4198}"/>
+                <a16:creationId xmlns:a16="http://schemas.microsoft.com/office/drawing/2014/main" id="{C6F1BDDC-83A6-DA3C-EB8C-31F2C69A7625}"/>
               </a:ext>
             </a:extLst>
           </p:cNvPr>
@@ -12450,7 +12450,7 @@
           <p:cNvPr id="4" name="TextBox 3">
             <a:extLst>
               <a:ext uri="{FF2B5EF4-FFF2-40B4-BE49-F238E27FC236}">
-                <a16:creationId xmlns:a16="http://schemas.microsoft.com/office/drawing/2014/main" id="{6963B065-E27E-151A-2EB8-71FED9BB8B58}"/>
+                <a16:creationId xmlns:a16="http://schemas.microsoft.com/office/drawing/2014/main" id="{CD22A131-F9CF-C4BC-C2C0-0A280A359663}"/>
               </a:ext>
             </a:extLst>
           </p:cNvPr>
@@ -12491,7 +12491,7 @@
           <p:cNvPr id="5" name="TextBox 4">
             <a:extLst>
               <a:ext uri="{FF2B5EF4-FFF2-40B4-BE49-F238E27FC236}">
-                <a16:creationId xmlns:a16="http://schemas.microsoft.com/office/drawing/2014/main" id="{E53C3339-5A08-1ACD-3E70-76A4396D83E6}"/>
+                <a16:creationId xmlns:a16="http://schemas.microsoft.com/office/drawing/2014/main" id="{D025830A-5DD9-D416-D6C9-59563A4291CB}"/>
               </a:ext>
             </a:extLst>
           </p:cNvPr>
@@ -12531,7 +12531,7 @@
           <p:cNvPr id="6" name="TextBox 5">
             <a:extLst>
               <a:ext uri="{FF2B5EF4-FFF2-40B4-BE49-F238E27FC236}">
-                <a16:creationId xmlns:a16="http://schemas.microsoft.com/office/drawing/2014/main" id="{6384AB62-3080-952B-CC89-3ACD7BDFC039}"/>
+                <a16:creationId xmlns:a16="http://schemas.microsoft.com/office/drawing/2014/main" id="{9B9A7C5C-7682-CDC2-A3EE-731F9A065BDC}"/>
               </a:ext>
             </a:extLst>
           </p:cNvPr>
@@ -12571,7 +12571,7 @@
           <p:cNvPr id="7" name="Rectangle: Rounded Corners 6">
             <a:extLst>
               <a:ext uri="{FF2B5EF4-FFF2-40B4-BE49-F238E27FC236}">
-                <a16:creationId xmlns:a16="http://schemas.microsoft.com/office/drawing/2014/main" id="{17BB0207-E572-CEE7-EF5F-035DDD4BB0C3}"/>
+                <a16:creationId xmlns:a16="http://schemas.microsoft.com/office/drawing/2014/main" id="{D93E26A2-9C3A-28D1-E76B-D6634382C1AC}"/>
               </a:ext>
             </a:extLst>
           </p:cNvPr>
@@ -12625,7 +12625,7 @@
           <p:cNvPr id="8" name="TextBox 7">
             <a:extLst>
               <a:ext uri="{FF2B5EF4-FFF2-40B4-BE49-F238E27FC236}">
-                <a16:creationId xmlns:a16="http://schemas.microsoft.com/office/drawing/2014/main" id="{2F3647ED-ACE6-61B4-67AF-25423F811859}"/>
+                <a16:creationId xmlns:a16="http://schemas.microsoft.com/office/drawing/2014/main" id="{1085D930-FA7B-BFBF-2F3C-033BBBD2EE0F}"/>
               </a:ext>
             </a:extLst>
           </p:cNvPr>
@@ -12665,7 +12665,7 @@
           <p:cNvPr id="9" name="TextBox 8">
             <a:extLst>
               <a:ext uri="{FF2B5EF4-FFF2-40B4-BE49-F238E27FC236}">
-                <a16:creationId xmlns:a16="http://schemas.microsoft.com/office/drawing/2014/main" id="{C19F6136-C7C3-BAAB-8538-289EFA298875}"/>
+                <a16:creationId xmlns:a16="http://schemas.microsoft.com/office/drawing/2014/main" id="{B25B8C1C-B379-5F51-1786-02F5A6871A5F}"/>
               </a:ext>
             </a:extLst>
           </p:cNvPr>
@@ -12705,7 +12705,7 @@
           <p:cNvPr id="10" name="TextBox 9">
             <a:extLst>
               <a:ext uri="{FF2B5EF4-FFF2-40B4-BE49-F238E27FC236}">
-                <a16:creationId xmlns:a16="http://schemas.microsoft.com/office/drawing/2014/main" id="{7B02D158-04E0-AF19-81ED-12E6CF07B8F1}"/>
+                <a16:creationId xmlns:a16="http://schemas.microsoft.com/office/drawing/2014/main" id="{9C51F665-61CA-FE76-236A-4919DFE7D9DF}"/>
               </a:ext>
             </a:extLst>
           </p:cNvPr>
@@ -12745,7 +12745,7 @@
           <p:cNvPr id="11" name="TextBox 10">
             <a:extLst>
               <a:ext uri="{FF2B5EF4-FFF2-40B4-BE49-F238E27FC236}">
-                <a16:creationId xmlns:a16="http://schemas.microsoft.com/office/drawing/2014/main" id="{DCD846A1-D597-522E-435A-9C68DD2D8AAB}"/>
+                <a16:creationId xmlns:a16="http://schemas.microsoft.com/office/drawing/2014/main" id="{9A6E8FC7-9BC5-B124-A16D-B13AF544D4B3}"/>
               </a:ext>
             </a:extLst>
           </p:cNvPr>
@@ -12785,7 +12785,7 @@
           <p:cNvPr id="12" name="TextBox 11">
             <a:extLst>
               <a:ext uri="{FF2B5EF4-FFF2-40B4-BE49-F238E27FC236}">
-                <a16:creationId xmlns:a16="http://schemas.microsoft.com/office/drawing/2014/main" id="{A0257BE7-66CF-F06F-E961-E0D99F57A930}"/>
+                <a16:creationId xmlns:a16="http://schemas.microsoft.com/office/drawing/2014/main" id="{3EF79913-F6E5-2789-8FF6-9BBF557E1B62}"/>
               </a:ext>
             </a:extLst>
           </p:cNvPr>
@@ -12825,7 +12825,7 @@
           <p:cNvPr id="13" name="TextBox 12">
             <a:extLst>
               <a:ext uri="{FF2B5EF4-FFF2-40B4-BE49-F238E27FC236}">
-                <a16:creationId xmlns:a16="http://schemas.microsoft.com/office/drawing/2014/main" id="{369F7E83-A839-BD41-BD87-6FB5BF26A313}"/>
+                <a16:creationId xmlns:a16="http://schemas.microsoft.com/office/drawing/2014/main" id="{B6A98858-C209-5741-4C95-4C1979A54206}"/>
               </a:ext>
             </a:extLst>
           </p:cNvPr>
@@ -12865,7 +12865,7 @@
           <p:cNvPr id="14" name="TextBox 13">
             <a:extLst>
               <a:ext uri="{FF2B5EF4-FFF2-40B4-BE49-F238E27FC236}">
-                <a16:creationId xmlns:a16="http://schemas.microsoft.com/office/drawing/2014/main" id="{09EB2B06-B1AA-B777-BBE6-636B31C9B200}"/>
+                <a16:creationId xmlns:a16="http://schemas.microsoft.com/office/drawing/2014/main" id="{CE311A14-EACA-A32A-91F7-77C5505305C6}"/>
               </a:ext>
             </a:extLst>
           </p:cNvPr>
@@ -12905,7 +12905,7 @@
           <p:cNvPr id="15" name="Straight Connector 14">
             <a:extLst>
               <a:ext uri="{FF2B5EF4-FFF2-40B4-BE49-F238E27FC236}">
-                <a16:creationId xmlns:a16="http://schemas.microsoft.com/office/drawing/2014/main" id="{C26AC877-B5FB-4509-F6A8-39975FD3A315}"/>
+                <a16:creationId xmlns:a16="http://schemas.microsoft.com/office/drawing/2014/main" id="{81032F7C-7E13-EE19-28EC-53A26303B735}"/>
               </a:ext>
             </a:extLst>
           </p:cNvPr>
@@ -12946,7 +12946,7 @@
           <p:cNvPr id="16" name="TextBox 15">
             <a:extLst>
               <a:ext uri="{FF2B5EF4-FFF2-40B4-BE49-F238E27FC236}">
-                <a16:creationId xmlns:a16="http://schemas.microsoft.com/office/drawing/2014/main" id="{6D3559AA-DFB7-B474-1297-DB7244ED3F30}"/>
+                <a16:creationId xmlns:a16="http://schemas.microsoft.com/office/drawing/2014/main" id="{0742FCAE-2D8C-C2E7-E659-267D6DFB13B5}"/>
               </a:ext>
             </a:extLst>
           </p:cNvPr>
@@ -12986,7 +12986,7 @@
           <p:cNvPr id="17" name="Straight Connector 16">
             <a:extLst>
               <a:ext uri="{FF2B5EF4-FFF2-40B4-BE49-F238E27FC236}">
-                <a16:creationId xmlns:a16="http://schemas.microsoft.com/office/drawing/2014/main" id="{23ACEDAD-7606-F0E9-5A52-F26B03C92DE8}"/>
+                <a16:creationId xmlns:a16="http://schemas.microsoft.com/office/drawing/2014/main" id="{FB16C8A8-8DE7-673A-807C-DA6C74911E8F}"/>
               </a:ext>
             </a:extLst>
           </p:cNvPr>
@@ -13027,7 +13027,7 @@
           <p:cNvPr id="18" name="TextBox 17">
             <a:extLst>
               <a:ext uri="{FF2B5EF4-FFF2-40B4-BE49-F238E27FC236}">
-                <a16:creationId xmlns:a16="http://schemas.microsoft.com/office/drawing/2014/main" id="{69226BA2-E360-6BFC-AC6C-5082D7C79B8B}"/>
+                <a16:creationId xmlns:a16="http://schemas.microsoft.com/office/drawing/2014/main" id="{4EC3D7E4-9C37-6054-ACC0-22363B58C421}"/>
               </a:ext>
             </a:extLst>
           </p:cNvPr>
@@ -13067,7 +13067,7 @@
           <p:cNvPr id="19" name="Straight Connector 18">
             <a:extLst>
               <a:ext uri="{FF2B5EF4-FFF2-40B4-BE49-F238E27FC236}">
-                <a16:creationId xmlns:a16="http://schemas.microsoft.com/office/drawing/2014/main" id="{D1F7B5DC-6FB7-9633-9CDE-38AC577B16B3}"/>
+                <a16:creationId xmlns:a16="http://schemas.microsoft.com/office/drawing/2014/main" id="{E2EE6A77-BE5D-9C45-1F9F-405B518047A3}"/>
               </a:ext>
             </a:extLst>
           </p:cNvPr>
@@ -13108,7 +13108,7 @@
           <p:cNvPr id="20" name="TextBox 19">
             <a:extLst>
               <a:ext uri="{FF2B5EF4-FFF2-40B4-BE49-F238E27FC236}">
-                <a16:creationId xmlns:a16="http://schemas.microsoft.com/office/drawing/2014/main" id="{DC82C407-DF01-4895-2EC8-5B157771CD13}"/>
+                <a16:creationId xmlns:a16="http://schemas.microsoft.com/office/drawing/2014/main" id="{89A262BC-1779-CAC3-8C1C-984B17FA401E}"/>
               </a:ext>
             </a:extLst>
           </p:cNvPr>
@@ -13148,7 +13148,7 @@
           <p:cNvPr id="21" name="Straight Connector 20">
             <a:extLst>
               <a:ext uri="{FF2B5EF4-FFF2-40B4-BE49-F238E27FC236}">
-                <a16:creationId xmlns:a16="http://schemas.microsoft.com/office/drawing/2014/main" id="{689DDF17-8390-7F34-B15E-730073AC3144}"/>
+                <a16:creationId xmlns:a16="http://schemas.microsoft.com/office/drawing/2014/main" id="{571E58B0-8F25-957F-0AAC-7D48E000BC35}"/>
               </a:ext>
             </a:extLst>
           </p:cNvPr>
@@ -13189,7 +13189,7 @@
           <p:cNvPr id="22" name="TextBox 21">
             <a:extLst>
               <a:ext uri="{FF2B5EF4-FFF2-40B4-BE49-F238E27FC236}">
-                <a16:creationId xmlns:a16="http://schemas.microsoft.com/office/drawing/2014/main" id="{DF966BC8-4BB2-276D-151A-70D0DBE8BED1}"/>
+                <a16:creationId xmlns:a16="http://schemas.microsoft.com/office/drawing/2014/main" id="{AE0F500A-2D5C-104A-25EC-7E709272D224}"/>
               </a:ext>
             </a:extLst>
           </p:cNvPr>
@@ -13229,7 +13229,7 @@
           <p:cNvPr id="23" name="Straight Connector 22">
             <a:extLst>
               <a:ext uri="{FF2B5EF4-FFF2-40B4-BE49-F238E27FC236}">
-                <a16:creationId xmlns:a16="http://schemas.microsoft.com/office/drawing/2014/main" id="{3D8478D6-F416-58E0-0239-C9685687E5DE}"/>
+                <a16:creationId xmlns:a16="http://schemas.microsoft.com/office/drawing/2014/main" id="{BBE7BEF0-4D4F-53DE-A1D0-ABA47E03ACEA}"/>
               </a:ext>
             </a:extLst>
           </p:cNvPr>
@@ -13270,7 +13270,7 @@
           <p:cNvPr id="24" name="TextBox 23">
             <a:extLst>
               <a:ext uri="{FF2B5EF4-FFF2-40B4-BE49-F238E27FC236}">
-                <a16:creationId xmlns:a16="http://schemas.microsoft.com/office/drawing/2014/main" id="{C1CB8D0A-DF07-E72F-3B81-F8E154CA726D}"/>
+                <a16:creationId xmlns:a16="http://schemas.microsoft.com/office/drawing/2014/main" id="{BA2BF1CD-6559-5C4F-4B26-222ACE12FE06}"/>
               </a:ext>
             </a:extLst>
           </p:cNvPr>
@@ -13310,7 +13310,7 @@
           <p:cNvPr id="25" name="TextBox 24">
             <a:extLst>
               <a:ext uri="{FF2B5EF4-FFF2-40B4-BE49-F238E27FC236}">
-                <a16:creationId xmlns:a16="http://schemas.microsoft.com/office/drawing/2014/main" id="{17329D04-920C-AED8-9C75-4679607FC97A}"/>
+                <a16:creationId xmlns:a16="http://schemas.microsoft.com/office/drawing/2014/main" id="{751C6371-F240-7A8B-4484-9A00623027D3}"/>
               </a:ext>
             </a:extLst>
           </p:cNvPr>
@@ -13350,7 +13350,7 @@
           <p:cNvPr id="26" name="TextBox 25">
             <a:extLst>
               <a:ext uri="{FF2B5EF4-FFF2-40B4-BE49-F238E27FC236}">
-                <a16:creationId xmlns:a16="http://schemas.microsoft.com/office/drawing/2014/main" id="{93117975-8CCB-DBBF-87F9-0D15FF5500F4}"/>
+                <a16:creationId xmlns:a16="http://schemas.microsoft.com/office/drawing/2014/main" id="{562B998A-4A7C-C453-3E13-3CCBFC40139A}"/>
               </a:ext>
             </a:extLst>
           </p:cNvPr>
@@ -13390,7 +13390,7 @@
           <p:cNvPr id="27" name="TextBox 26">
             <a:extLst>
               <a:ext uri="{FF2B5EF4-FFF2-40B4-BE49-F238E27FC236}">
-                <a16:creationId xmlns:a16="http://schemas.microsoft.com/office/drawing/2014/main" id="{DBB03748-749C-1BD9-EF6A-A2F6B54DF20E}"/>
+                <a16:creationId xmlns:a16="http://schemas.microsoft.com/office/drawing/2014/main" id="{3EF6DDAC-8DC9-F100-F910-FB963D61FE11}"/>
               </a:ext>
             </a:extLst>
           </p:cNvPr>
@@ -13430,7 +13430,7 @@
           <p:cNvPr id="28" name="TextBox 27">
             <a:extLst>
               <a:ext uri="{FF2B5EF4-FFF2-40B4-BE49-F238E27FC236}">
-                <a16:creationId xmlns:a16="http://schemas.microsoft.com/office/drawing/2014/main" id="{D13AADB6-2188-DE52-01B8-9DF3C2B81186}"/>
+                <a16:creationId xmlns:a16="http://schemas.microsoft.com/office/drawing/2014/main" id="{CAB029B2-0BC9-AEC5-302B-349B687F5962}"/>
               </a:ext>
             </a:extLst>
           </p:cNvPr>
@@ -13470,7 +13470,7 @@
           <p:cNvPr id="29" name="TextBox 28">
             <a:extLst>
               <a:ext uri="{FF2B5EF4-FFF2-40B4-BE49-F238E27FC236}">
-                <a16:creationId xmlns:a16="http://schemas.microsoft.com/office/drawing/2014/main" id="{330E43A1-A1AE-36CF-A71D-9F60A2AA46E3}"/>
+                <a16:creationId xmlns:a16="http://schemas.microsoft.com/office/drawing/2014/main" id="{83C4EB42-BBE7-C293-4442-D8C0410F4606}"/>
               </a:ext>
             </a:extLst>
           </p:cNvPr>
@@ -13510,7 +13510,7 @@
           <p:cNvPr id="30" name="TextBox 29">
             <a:extLst>
               <a:ext uri="{FF2B5EF4-FFF2-40B4-BE49-F238E27FC236}">
-                <a16:creationId xmlns:a16="http://schemas.microsoft.com/office/drawing/2014/main" id="{FDA2A1C6-3336-1082-B873-0633F8B507C5}"/>
+                <a16:creationId xmlns:a16="http://schemas.microsoft.com/office/drawing/2014/main" id="{49035ACB-6392-31E4-6DFA-CD2A6B7F5C83}"/>
               </a:ext>
             </a:extLst>
           </p:cNvPr>
@@ -13550,7 +13550,7 @@
           <p:cNvPr id="31" name="TextBox 30">
             <a:extLst>
               <a:ext uri="{FF2B5EF4-FFF2-40B4-BE49-F238E27FC236}">
-                <a16:creationId xmlns:a16="http://schemas.microsoft.com/office/drawing/2014/main" id="{49FE8154-7C58-2A1C-8C22-223907C3536C}"/>
+                <a16:creationId xmlns:a16="http://schemas.microsoft.com/office/drawing/2014/main" id="{660F3999-1ACF-1159-6DB9-065FA6B1CE70}"/>
               </a:ext>
             </a:extLst>
           </p:cNvPr>
@@ -13590,7 +13590,7 @@
           <p:cNvPr id="32" name="TextBox 31">
             <a:extLst>
               <a:ext uri="{FF2B5EF4-FFF2-40B4-BE49-F238E27FC236}">
-                <a16:creationId xmlns:a16="http://schemas.microsoft.com/office/drawing/2014/main" id="{5575EA26-C398-82E2-4385-D3B353650863}"/>
+                <a16:creationId xmlns:a16="http://schemas.microsoft.com/office/drawing/2014/main" id="{556E0396-C785-6ECC-3F75-BA6C63F6222F}"/>
               </a:ext>
             </a:extLst>
           </p:cNvPr>
@@ -13628,7 +13628,7 @@
     </p:spTree>
     <p:extLst>
       <p:ext uri="{BB962C8B-B14F-4D97-AF65-F5344CB8AC3E}">
-        <p14:creationId xmlns:p14="http://schemas.microsoft.com/office/powerpoint/2010/main" val="3374120386"/>
+        <p14:creationId xmlns:p14="http://schemas.microsoft.com/office/powerpoint/2010/main" val="1430138670"/>
       </p:ext>
     </p:extLst>
   </p:cSld>
@@ -13668,7 +13668,7 @@
           <p:cNvPr id="2" name="TextBox 1">
             <a:extLst>
               <a:ext uri="{FF2B5EF4-FFF2-40B4-BE49-F238E27FC236}">
-                <a16:creationId xmlns:a16="http://schemas.microsoft.com/office/drawing/2014/main" id="{8D210207-1BB1-589D-2EDB-C3B437419A09}"/>
+                <a16:creationId xmlns:a16="http://schemas.microsoft.com/office/drawing/2014/main" id="{90CC6DD0-0E6B-32FE-C3C2-CF37AEA1E144}"/>
               </a:ext>
             </a:extLst>
           </p:cNvPr>
@@ -13708,7 +13708,7 @@
           <p:cNvPr id="3" name="Straight Connector 2">
             <a:extLst>
               <a:ext uri="{FF2B5EF4-FFF2-40B4-BE49-F238E27FC236}">
-                <a16:creationId xmlns:a16="http://schemas.microsoft.com/office/drawing/2014/main" id="{5B571D8F-8876-1472-7622-BA4802427768}"/>
+                <a16:creationId xmlns:a16="http://schemas.microsoft.com/office/drawing/2014/main" id="{53F94349-8C63-D745-3334-D0D1E3514E8A}"/>
               </a:ext>
             </a:extLst>
           </p:cNvPr>
@@ -13749,7 +13749,7 @@
           <p:cNvPr id="4" name="TextBox 3">
             <a:extLst>
               <a:ext uri="{FF2B5EF4-FFF2-40B4-BE49-F238E27FC236}">
-                <a16:creationId xmlns:a16="http://schemas.microsoft.com/office/drawing/2014/main" id="{58B7DCE9-340E-1802-F2AA-98884662C97F}"/>
+                <a16:creationId xmlns:a16="http://schemas.microsoft.com/office/drawing/2014/main" id="{16073F71-37FD-6757-8570-41FF1E4D492C}"/>
               </a:ext>
             </a:extLst>
           </p:cNvPr>
@@ -13790,7 +13790,7 @@
           <p:cNvPr id="5" name="TextBox 4">
             <a:extLst>
               <a:ext uri="{FF2B5EF4-FFF2-40B4-BE49-F238E27FC236}">
-                <a16:creationId xmlns:a16="http://schemas.microsoft.com/office/drawing/2014/main" id="{267FEC84-D22C-D4BC-FB55-0BE5EF2D845B}"/>
+                <a16:creationId xmlns:a16="http://schemas.microsoft.com/office/drawing/2014/main" id="{46FCF71D-F506-F820-73F3-9B20610588D7}"/>
               </a:ext>
             </a:extLst>
           </p:cNvPr>
@@ -13830,7 +13830,7 @@
           <p:cNvPr id="6" name="TextBox 5">
             <a:extLst>
               <a:ext uri="{FF2B5EF4-FFF2-40B4-BE49-F238E27FC236}">
-                <a16:creationId xmlns:a16="http://schemas.microsoft.com/office/drawing/2014/main" id="{BE72F938-3FD6-3074-1B86-7B33CC63D963}"/>
+                <a16:creationId xmlns:a16="http://schemas.microsoft.com/office/drawing/2014/main" id="{E1D7A8F6-99B2-7CBA-8432-BC37D7E2C091}"/>
               </a:ext>
             </a:extLst>
           </p:cNvPr>
@@ -13870,7 +13870,7 @@
           <p:cNvPr id="7" name="Straight Connector 6">
             <a:extLst>
               <a:ext uri="{FF2B5EF4-FFF2-40B4-BE49-F238E27FC236}">
-                <a16:creationId xmlns:a16="http://schemas.microsoft.com/office/drawing/2014/main" id="{B048DAA2-7DCE-2FF5-3380-6BE94887EA3C}"/>
+                <a16:creationId xmlns:a16="http://schemas.microsoft.com/office/drawing/2014/main" id="{3C2F729E-A9E2-B269-25EF-718F75486624}"/>
               </a:ext>
             </a:extLst>
           </p:cNvPr>
@@ -13912,7 +13912,7 @@
           <p:cNvPr id="8" name="Straight Connector 7">
             <a:extLst>
               <a:ext uri="{FF2B5EF4-FFF2-40B4-BE49-F238E27FC236}">
-                <a16:creationId xmlns:a16="http://schemas.microsoft.com/office/drawing/2014/main" id="{0AF8CDA9-E136-825A-B074-95BF68F13F0E}"/>
+                <a16:creationId xmlns:a16="http://schemas.microsoft.com/office/drawing/2014/main" id="{3404AEF4-2E46-1C03-AD8F-A74D16918414}"/>
               </a:ext>
             </a:extLst>
           </p:cNvPr>
@@ -13954,7 +13954,7 @@
           <p:cNvPr id="9" name="Rectangle: Rounded Corners 8">
             <a:extLst>
               <a:ext uri="{FF2B5EF4-FFF2-40B4-BE49-F238E27FC236}">
-                <a16:creationId xmlns:a16="http://schemas.microsoft.com/office/drawing/2014/main" id="{B4CDCCEF-7BDC-B048-9609-78E4B6E3874C}"/>
+                <a16:creationId xmlns:a16="http://schemas.microsoft.com/office/drawing/2014/main" id="{74C7F08E-DEC4-AD1F-717B-54F90564FB10}"/>
               </a:ext>
             </a:extLst>
           </p:cNvPr>
@@ -14022,7 +14022,7 @@
           <p:cNvPr id="10" name="TextBox 9">
             <a:extLst>
               <a:ext uri="{FF2B5EF4-FFF2-40B4-BE49-F238E27FC236}">
-                <a16:creationId xmlns:a16="http://schemas.microsoft.com/office/drawing/2014/main" id="{F95C935E-969E-1846-D024-6243324A8C64}"/>
+                <a16:creationId xmlns:a16="http://schemas.microsoft.com/office/drawing/2014/main" id="{7FA6E7D5-5B90-EC86-F82A-84CF6B043146}"/>
               </a:ext>
             </a:extLst>
           </p:cNvPr>
@@ -14063,7 +14063,7 @@
           <p:cNvPr id="11" name="TextBox 10">
             <a:extLst>
               <a:ext uri="{FF2B5EF4-FFF2-40B4-BE49-F238E27FC236}">
-                <a16:creationId xmlns:a16="http://schemas.microsoft.com/office/drawing/2014/main" id="{BA3758D7-1C29-786A-A1DF-62966EC517D6}"/>
+                <a16:creationId xmlns:a16="http://schemas.microsoft.com/office/drawing/2014/main" id="{19763192-B1AD-A5C4-DC63-215A51AA3D72}"/>
               </a:ext>
             </a:extLst>
           </p:cNvPr>
@@ -14134,7 +14134,7 @@
           <p:cNvPr id="12" name="Rectangle: Rounded Corners 11">
             <a:extLst>
               <a:ext uri="{FF2B5EF4-FFF2-40B4-BE49-F238E27FC236}">
-                <a16:creationId xmlns:a16="http://schemas.microsoft.com/office/drawing/2014/main" id="{A01B975D-4A04-4EAF-BF83-4ABA566BADC9}"/>
+                <a16:creationId xmlns:a16="http://schemas.microsoft.com/office/drawing/2014/main" id="{A938187B-967E-62BD-8733-BB4A23AA4734}"/>
               </a:ext>
             </a:extLst>
           </p:cNvPr>
@@ -14202,7 +14202,7 @@
           <p:cNvPr id="13" name="TextBox 12">
             <a:extLst>
               <a:ext uri="{FF2B5EF4-FFF2-40B4-BE49-F238E27FC236}">
-                <a16:creationId xmlns:a16="http://schemas.microsoft.com/office/drawing/2014/main" id="{1A76748E-E749-C07F-891E-296FFE0BCB12}"/>
+                <a16:creationId xmlns:a16="http://schemas.microsoft.com/office/drawing/2014/main" id="{0014630A-60FA-0277-4C57-50892B57458A}"/>
               </a:ext>
             </a:extLst>
           </p:cNvPr>
@@ -14243,7 +14243,7 @@
           <p:cNvPr id="14" name="TextBox 13">
             <a:extLst>
               <a:ext uri="{FF2B5EF4-FFF2-40B4-BE49-F238E27FC236}">
-                <a16:creationId xmlns:a16="http://schemas.microsoft.com/office/drawing/2014/main" id="{5AC4614E-92F6-3C3A-26EC-71835D9B9E4C}"/>
+                <a16:creationId xmlns:a16="http://schemas.microsoft.com/office/drawing/2014/main" id="{CFFD45E2-55CC-7CA8-7C36-AE0568855AC4}"/>
               </a:ext>
             </a:extLst>
           </p:cNvPr>
@@ -14296,7 +14296,7 @@
           <p:cNvPr id="15" name="Rectangle: Rounded Corners 14">
             <a:extLst>
               <a:ext uri="{FF2B5EF4-FFF2-40B4-BE49-F238E27FC236}">
-                <a16:creationId xmlns:a16="http://schemas.microsoft.com/office/drawing/2014/main" id="{A038455C-BA33-4A86-6FA6-F642FC32FB3D}"/>
+                <a16:creationId xmlns:a16="http://schemas.microsoft.com/office/drawing/2014/main" id="{D495B8D0-28DE-BAA3-DE50-F25E454A62EB}"/>
               </a:ext>
             </a:extLst>
           </p:cNvPr>
@@ -14364,7 +14364,7 @@
           <p:cNvPr id="16" name="TextBox 15">
             <a:extLst>
               <a:ext uri="{FF2B5EF4-FFF2-40B4-BE49-F238E27FC236}">
-                <a16:creationId xmlns:a16="http://schemas.microsoft.com/office/drawing/2014/main" id="{A0AB76C3-8368-61D1-6BC8-8D8518CABA7F}"/>
+                <a16:creationId xmlns:a16="http://schemas.microsoft.com/office/drawing/2014/main" id="{1DD17F47-2850-37D4-6249-1F952B7BC9AE}"/>
               </a:ext>
             </a:extLst>
           </p:cNvPr>
@@ -14405,7 +14405,7 @@
           <p:cNvPr id="17" name="TextBox 16">
             <a:extLst>
               <a:ext uri="{FF2B5EF4-FFF2-40B4-BE49-F238E27FC236}">
-                <a16:creationId xmlns:a16="http://schemas.microsoft.com/office/drawing/2014/main" id="{9436BFC8-B89A-5F58-DB54-D25BC18AEB42}"/>
+                <a16:creationId xmlns:a16="http://schemas.microsoft.com/office/drawing/2014/main" id="{153A0FE3-83FA-1C41-F4EA-C756BAC72DBD}"/>
               </a:ext>
             </a:extLst>
           </p:cNvPr>
@@ -14470,7 +14470,7 @@
           <p:cNvPr id="18" name="Straight Connector 17">
             <a:extLst>
               <a:ext uri="{FF2B5EF4-FFF2-40B4-BE49-F238E27FC236}">
-                <a16:creationId xmlns:a16="http://schemas.microsoft.com/office/drawing/2014/main" id="{D81C76B6-87C6-38D2-64BA-53BD3EC89D23}"/>
+                <a16:creationId xmlns:a16="http://schemas.microsoft.com/office/drawing/2014/main" id="{7DAB59E0-AB34-4677-B055-4911AEDD89BE}"/>
               </a:ext>
             </a:extLst>
           </p:cNvPr>
@@ -14511,7 +14511,7 @@
           <p:cNvPr id="19" name="TextBox 18">
             <a:extLst>
               <a:ext uri="{FF2B5EF4-FFF2-40B4-BE49-F238E27FC236}">
-                <a16:creationId xmlns:a16="http://schemas.microsoft.com/office/drawing/2014/main" id="{9E410136-3832-59D9-D330-A399BB86E0A8}"/>
+                <a16:creationId xmlns:a16="http://schemas.microsoft.com/office/drawing/2014/main" id="{B12F6352-674B-2BC0-B115-B2CA6B3953E1}"/>
               </a:ext>
             </a:extLst>
           </p:cNvPr>
@@ -14551,7 +14551,7 @@
           <p:cNvPr id="20" name="Straight Connector 19">
             <a:extLst>
               <a:ext uri="{FF2B5EF4-FFF2-40B4-BE49-F238E27FC236}">
-                <a16:creationId xmlns:a16="http://schemas.microsoft.com/office/drawing/2014/main" id="{C9BEDFD2-534F-1E12-58C4-E2C4BA81D039}"/>
+                <a16:creationId xmlns:a16="http://schemas.microsoft.com/office/drawing/2014/main" id="{6AD0DC0F-C47B-C5EE-B51C-C57BF99259F6}"/>
               </a:ext>
             </a:extLst>
           </p:cNvPr>
@@ -14592,7 +14592,7 @@
           <p:cNvPr id="21" name="TextBox 20">
             <a:extLst>
               <a:ext uri="{FF2B5EF4-FFF2-40B4-BE49-F238E27FC236}">
-                <a16:creationId xmlns:a16="http://schemas.microsoft.com/office/drawing/2014/main" id="{E0F36466-E1FD-B184-9E66-C8F31D6785C0}"/>
+                <a16:creationId xmlns:a16="http://schemas.microsoft.com/office/drawing/2014/main" id="{74760541-A7BC-9DAC-2A6F-680864DB729F}"/>
               </a:ext>
             </a:extLst>
           </p:cNvPr>
@@ -14632,7 +14632,7 @@
           <p:cNvPr id="22" name="Straight Connector 21">
             <a:extLst>
               <a:ext uri="{FF2B5EF4-FFF2-40B4-BE49-F238E27FC236}">
-                <a16:creationId xmlns:a16="http://schemas.microsoft.com/office/drawing/2014/main" id="{317B6041-95BF-B7B6-A33E-BF8460A127ED}"/>
+                <a16:creationId xmlns:a16="http://schemas.microsoft.com/office/drawing/2014/main" id="{ED5BE281-E955-F207-D192-A63C1DF5D563}"/>
               </a:ext>
             </a:extLst>
           </p:cNvPr>
@@ -14673,7 +14673,7 @@
           <p:cNvPr id="23" name="TextBox 22">
             <a:extLst>
               <a:ext uri="{FF2B5EF4-FFF2-40B4-BE49-F238E27FC236}">
-                <a16:creationId xmlns:a16="http://schemas.microsoft.com/office/drawing/2014/main" id="{3958E91B-C0A6-54F4-DBBF-8E45193C5C7C}"/>
+                <a16:creationId xmlns:a16="http://schemas.microsoft.com/office/drawing/2014/main" id="{1EDB6267-B57A-5A45-7A73-94E25A044B7C}"/>
               </a:ext>
             </a:extLst>
           </p:cNvPr>
@@ -14711,7 +14711,7 @@
     </p:spTree>
     <p:extLst>
       <p:ext uri="{BB962C8B-B14F-4D97-AF65-F5344CB8AC3E}">
-        <p14:creationId xmlns:p14="http://schemas.microsoft.com/office/powerpoint/2010/main" val="3272817024"/>
+        <p14:creationId xmlns:p14="http://schemas.microsoft.com/office/powerpoint/2010/main" val="1006325537"/>
       </p:ext>
     </p:extLst>
   </p:cSld>
@@ -14751,7 +14751,7 @@
           <p:cNvPr id="2" name="TextBox 1">
             <a:extLst>
               <a:ext uri="{FF2B5EF4-FFF2-40B4-BE49-F238E27FC236}">
-                <a16:creationId xmlns:a16="http://schemas.microsoft.com/office/drawing/2014/main" id="{5558EB8B-BCCF-5FC4-A993-34022F6B06A1}"/>
+                <a16:creationId xmlns:a16="http://schemas.microsoft.com/office/drawing/2014/main" id="{C39B5210-F5DA-4FEB-C12B-D6B1A48BCBD7}"/>
               </a:ext>
             </a:extLst>
           </p:cNvPr>
@@ -14791,7 +14791,7 @@
           <p:cNvPr id="3" name="Straight Connector 2">
             <a:extLst>
               <a:ext uri="{FF2B5EF4-FFF2-40B4-BE49-F238E27FC236}">
-                <a16:creationId xmlns:a16="http://schemas.microsoft.com/office/drawing/2014/main" id="{4AD1D23D-2502-16D7-6457-1E16DB531E7D}"/>
+                <a16:creationId xmlns:a16="http://schemas.microsoft.com/office/drawing/2014/main" id="{C3F8EC02-4EA3-5B4B-303E-B51A0DD23E5C}"/>
               </a:ext>
             </a:extLst>
           </p:cNvPr>
@@ -14832,7 +14832,7 @@
           <p:cNvPr id="4" name="TextBox 3">
             <a:extLst>
               <a:ext uri="{FF2B5EF4-FFF2-40B4-BE49-F238E27FC236}">
-                <a16:creationId xmlns:a16="http://schemas.microsoft.com/office/drawing/2014/main" id="{8B05AE93-E841-2736-2528-1DF7C9DFFEBD}"/>
+                <a16:creationId xmlns:a16="http://schemas.microsoft.com/office/drawing/2014/main" id="{69921F12-1135-88AE-5F1B-6A21B4B027C4}"/>
               </a:ext>
             </a:extLst>
           </p:cNvPr>
@@ -14873,7 +14873,7 @@
           <p:cNvPr id="5" name="TextBox 4">
             <a:extLst>
               <a:ext uri="{FF2B5EF4-FFF2-40B4-BE49-F238E27FC236}">
-                <a16:creationId xmlns:a16="http://schemas.microsoft.com/office/drawing/2014/main" id="{8997F13B-56E6-F18A-6328-9AA4F6CE21AE}"/>
+                <a16:creationId xmlns:a16="http://schemas.microsoft.com/office/drawing/2014/main" id="{A44F7428-A92D-7A93-8F41-E669F44335FE}"/>
               </a:ext>
             </a:extLst>
           </p:cNvPr>
@@ -14913,7 +14913,7 @@
           <p:cNvPr id="6" name="TextBox 5">
             <a:extLst>
               <a:ext uri="{FF2B5EF4-FFF2-40B4-BE49-F238E27FC236}">
-                <a16:creationId xmlns:a16="http://schemas.microsoft.com/office/drawing/2014/main" id="{77B3B7DB-12A0-E7EE-4657-27B0EF19D352}"/>
+                <a16:creationId xmlns:a16="http://schemas.microsoft.com/office/drawing/2014/main" id="{EC9483EA-FE6C-9CA9-5455-46960E79ED4E}"/>
               </a:ext>
             </a:extLst>
           </p:cNvPr>
@@ -14953,7 +14953,7 @@
           <p:cNvPr id="7" name="Rectangle: Rounded Corners 6">
             <a:extLst>
               <a:ext uri="{FF2B5EF4-FFF2-40B4-BE49-F238E27FC236}">
-                <a16:creationId xmlns:a16="http://schemas.microsoft.com/office/drawing/2014/main" id="{20874A89-54BA-934F-2376-8EBA91FC354B}"/>
+                <a16:creationId xmlns:a16="http://schemas.microsoft.com/office/drawing/2014/main" id="{F7226421-E6E3-FF82-9EF4-8502D4120EAC}"/>
               </a:ext>
             </a:extLst>
           </p:cNvPr>
@@ -15007,7 +15007,7 @@
           <p:cNvPr id="9" name="Picture 8" descr="Live Scenario page showing one shared GPU scenario and locality detail">
             <a:extLst>
               <a:ext uri="{FF2B5EF4-FFF2-40B4-BE49-F238E27FC236}">
-                <a16:creationId xmlns:a16="http://schemas.microsoft.com/office/drawing/2014/main" id="{8F2C84C4-4F42-E109-AF44-AA6BE90A01E1}"/>
+                <a16:creationId xmlns:a16="http://schemas.microsoft.com/office/drawing/2014/main" id="{73D578CE-31D4-6034-FC68-C38129BB1973}"/>
               </a:ext>
             </a:extLst>
           </p:cNvPr>
@@ -15043,7 +15043,7 @@
           <p:cNvPr id="10" name="TextBox 9">
             <a:extLst>
               <a:ext uri="{FF2B5EF4-FFF2-40B4-BE49-F238E27FC236}">
-                <a16:creationId xmlns:a16="http://schemas.microsoft.com/office/drawing/2014/main" id="{698AE357-BB4C-1AE7-BD7E-2B08D467D1E7}"/>
+                <a16:creationId xmlns:a16="http://schemas.microsoft.com/office/drawing/2014/main" id="{A8B71EA4-8E14-11DF-4AFF-7FAD4D2C5F78}"/>
               </a:ext>
             </a:extLst>
           </p:cNvPr>
@@ -15082,7 +15082,7 @@
     </p:spTree>
     <p:extLst>
       <p:ext uri="{BB962C8B-B14F-4D97-AF65-F5344CB8AC3E}">
-        <p14:creationId xmlns:p14="http://schemas.microsoft.com/office/powerpoint/2010/main" val="1588007612"/>
+        <p14:creationId xmlns:p14="http://schemas.microsoft.com/office/powerpoint/2010/main" val="153257909"/>
       </p:ext>
     </p:extLst>
   </p:cSld>
@@ -15122,7 +15122,7 @@
           <p:cNvPr id="2" name="TextBox 1">
             <a:extLst>
               <a:ext uri="{FF2B5EF4-FFF2-40B4-BE49-F238E27FC236}">
-                <a16:creationId xmlns:a16="http://schemas.microsoft.com/office/drawing/2014/main" id="{FC45EBBE-5F11-3690-BBC0-CC36F4D6BF0E}"/>
+                <a16:creationId xmlns:a16="http://schemas.microsoft.com/office/drawing/2014/main" id="{B212C33A-70D9-3BC6-1941-E107BE275108}"/>
               </a:ext>
             </a:extLst>
           </p:cNvPr>
@@ -15162,7 +15162,7 @@
           <p:cNvPr id="3" name="Straight Connector 2">
             <a:extLst>
               <a:ext uri="{FF2B5EF4-FFF2-40B4-BE49-F238E27FC236}">
-                <a16:creationId xmlns:a16="http://schemas.microsoft.com/office/drawing/2014/main" id="{D8224D32-BDC9-8D50-BBDE-BD58FE686562}"/>
+                <a16:creationId xmlns:a16="http://schemas.microsoft.com/office/drawing/2014/main" id="{01EE7F0D-3589-ACBA-890D-391F446A10B3}"/>
               </a:ext>
             </a:extLst>
           </p:cNvPr>
@@ -15203,7 +15203,7 @@
           <p:cNvPr id="4" name="TextBox 3">
             <a:extLst>
               <a:ext uri="{FF2B5EF4-FFF2-40B4-BE49-F238E27FC236}">
-                <a16:creationId xmlns:a16="http://schemas.microsoft.com/office/drawing/2014/main" id="{52A79997-F949-BCA5-94B3-732A59E91708}"/>
+                <a16:creationId xmlns:a16="http://schemas.microsoft.com/office/drawing/2014/main" id="{0D21CB3F-5C73-6D17-5E48-A76F1F95A360}"/>
               </a:ext>
             </a:extLst>
           </p:cNvPr>
@@ -15244,7 +15244,7 @@
           <p:cNvPr id="5" name="TextBox 4">
             <a:extLst>
               <a:ext uri="{FF2B5EF4-FFF2-40B4-BE49-F238E27FC236}">
-                <a16:creationId xmlns:a16="http://schemas.microsoft.com/office/drawing/2014/main" id="{5607963E-8A6D-8383-3088-A71DF6EFF29C}"/>
+                <a16:creationId xmlns:a16="http://schemas.microsoft.com/office/drawing/2014/main" id="{E2626B6A-7BD6-4202-9CA0-FB72006D18B7}"/>
               </a:ext>
             </a:extLst>
           </p:cNvPr>
@@ -15284,7 +15284,7 @@
           <p:cNvPr id="6" name="TextBox 5">
             <a:extLst>
               <a:ext uri="{FF2B5EF4-FFF2-40B4-BE49-F238E27FC236}">
-                <a16:creationId xmlns:a16="http://schemas.microsoft.com/office/drawing/2014/main" id="{59AEEA16-A0C9-4E8A-9CD3-8E70FAAF0F06}"/>
+                <a16:creationId xmlns:a16="http://schemas.microsoft.com/office/drawing/2014/main" id="{F3F73C56-2FA9-B34F-AA7C-BA67BA4D0144}"/>
               </a:ext>
             </a:extLst>
           </p:cNvPr>
@@ -15324,7 +15324,7 @@
           <p:cNvPr id="7" name="TextBox 6">
             <a:extLst>
               <a:ext uri="{FF2B5EF4-FFF2-40B4-BE49-F238E27FC236}">
-                <a16:creationId xmlns:a16="http://schemas.microsoft.com/office/drawing/2014/main" id="{5A8B9F2E-D97C-3D72-2336-291FBA547104}"/>
+                <a16:creationId xmlns:a16="http://schemas.microsoft.com/office/drawing/2014/main" id="{D467F00A-00BB-F905-49CD-6AFF16373EFB}"/>
               </a:ext>
             </a:extLst>
           </p:cNvPr>
@@ -15364,7 +15364,7 @@
           <p:cNvPr id="8" name="TextBox 7">
             <a:extLst>
               <a:ext uri="{FF2B5EF4-FFF2-40B4-BE49-F238E27FC236}">
-                <a16:creationId xmlns:a16="http://schemas.microsoft.com/office/drawing/2014/main" id="{29950C7A-C0F5-BB70-56BB-850047FA5D7E}"/>
+                <a16:creationId xmlns:a16="http://schemas.microsoft.com/office/drawing/2014/main" id="{B2ED22A3-E6A3-F608-28CA-01DC8E8D968F}"/>
               </a:ext>
             </a:extLst>
           </p:cNvPr>
@@ -15404,7 +15404,7 @@
           <p:cNvPr id="9" name="TextBox 8">
             <a:extLst>
               <a:ext uri="{FF2B5EF4-FFF2-40B4-BE49-F238E27FC236}">
-                <a16:creationId xmlns:a16="http://schemas.microsoft.com/office/drawing/2014/main" id="{B994A1EE-FC7C-695B-C5B7-1B5CFBCD5586}"/>
+                <a16:creationId xmlns:a16="http://schemas.microsoft.com/office/drawing/2014/main" id="{A2A91BBB-8B97-FB2A-FA15-4F4E7E5EEA37}"/>
               </a:ext>
             </a:extLst>
           </p:cNvPr>
@@ -15444,7 +15444,7 @@
           <p:cNvPr id="10" name="TextBox 9">
             <a:extLst>
               <a:ext uri="{FF2B5EF4-FFF2-40B4-BE49-F238E27FC236}">
-                <a16:creationId xmlns:a16="http://schemas.microsoft.com/office/drawing/2014/main" id="{EFE74E20-ED1E-927C-6A52-A968720125A3}"/>
+                <a16:creationId xmlns:a16="http://schemas.microsoft.com/office/drawing/2014/main" id="{2885EF75-E685-E0E9-539B-65F89ACBB89D}"/>
               </a:ext>
             </a:extLst>
           </p:cNvPr>
@@ -15484,7 +15484,7 @@
           <p:cNvPr id="11" name="TextBox 10">
             <a:extLst>
               <a:ext uri="{FF2B5EF4-FFF2-40B4-BE49-F238E27FC236}">
-                <a16:creationId xmlns:a16="http://schemas.microsoft.com/office/drawing/2014/main" id="{2B635157-2F9C-A7FA-CE5C-AA8FCE3A40D1}"/>
+                <a16:creationId xmlns:a16="http://schemas.microsoft.com/office/drawing/2014/main" id="{28087E6A-1F6C-FF25-4EB8-4FFA2414E654}"/>
               </a:ext>
             </a:extLst>
           </p:cNvPr>
@@ -15524,7 +15524,7 @@
           <p:cNvPr id="12" name="Rectangle 11">
             <a:extLst>
               <a:ext uri="{FF2B5EF4-FFF2-40B4-BE49-F238E27FC236}">
-                <a16:creationId xmlns:a16="http://schemas.microsoft.com/office/drawing/2014/main" id="{BC8EF1A5-48ED-57B5-A959-220BDEA5A53D}"/>
+                <a16:creationId xmlns:a16="http://schemas.microsoft.com/office/drawing/2014/main" id="{1F36CD65-A2B3-C8BA-FC99-850DA3913627}"/>
               </a:ext>
             </a:extLst>
           </p:cNvPr>
@@ -15592,7 +15592,7 @@
           <p:cNvPr id="13" name="TextBox 12">
             <a:extLst>
               <a:ext uri="{FF2B5EF4-FFF2-40B4-BE49-F238E27FC236}">
-                <a16:creationId xmlns:a16="http://schemas.microsoft.com/office/drawing/2014/main" id="{EDE35564-A21B-0190-C152-1012550DAD17}"/>
+                <a16:creationId xmlns:a16="http://schemas.microsoft.com/office/drawing/2014/main" id="{73E8A810-D2EE-590F-AEBD-11E77B8271D5}"/>
               </a:ext>
             </a:extLst>
           </p:cNvPr>
@@ -15632,7 +15632,7 @@
           <p:cNvPr id="14" name="TextBox 13">
             <a:extLst>
               <a:ext uri="{FF2B5EF4-FFF2-40B4-BE49-F238E27FC236}">
-                <a16:creationId xmlns:a16="http://schemas.microsoft.com/office/drawing/2014/main" id="{70B78FE7-4411-93EB-36AA-927FCC6A2D14}"/>
+                <a16:creationId xmlns:a16="http://schemas.microsoft.com/office/drawing/2014/main" id="{DFF5624C-44AA-604C-47E4-2C84C64E923E}"/>
               </a:ext>
             </a:extLst>
           </p:cNvPr>
@@ -15672,7 +15672,7 @@
           <p:cNvPr id="15" name="TextBox 14">
             <a:extLst>
               <a:ext uri="{FF2B5EF4-FFF2-40B4-BE49-F238E27FC236}">
-                <a16:creationId xmlns:a16="http://schemas.microsoft.com/office/drawing/2014/main" id="{2A0968A3-6E25-1B7B-78E9-FA0E328C8D6B}"/>
+                <a16:creationId xmlns:a16="http://schemas.microsoft.com/office/drawing/2014/main" id="{16056956-85C3-F45B-1190-F53947FE3A1D}"/>
               </a:ext>
             </a:extLst>
           </p:cNvPr>
@@ -15712,7 +15712,7 @@
           <p:cNvPr id="16" name="TextBox 15">
             <a:extLst>
               <a:ext uri="{FF2B5EF4-FFF2-40B4-BE49-F238E27FC236}">
-                <a16:creationId xmlns:a16="http://schemas.microsoft.com/office/drawing/2014/main" id="{F468731F-6D68-2F18-BD08-78D929CB68AF}"/>
+                <a16:creationId xmlns:a16="http://schemas.microsoft.com/office/drawing/2014/main" id="{76D1452B-2BBE-F467-8474-1DC7E2373E26}"/>
               </a:ext>
             </a:extLst>
           </p:cNvPr>
@@ -15752,7 +15752,7 @@
           <p:cNvPr id="17" name="TextBox 16">
             <a:extLst>
               <a:ext uri="{FF2B5EF4-FFF2-40B4-BE49-F238E27FC236}">
-                <a16:creationId xmlns:a16="http://schemas.microsoft.com/office/drawing/2014/main" id="{41C13E5C-8483-D98D-A2AE-CF90C9DEF6C3}"/>
+                <a16:creationId xmlns:a16="http://schemas.microsoft.com/office/drawing/2014/main" id="{43F67939-BA87-D5B7-8D11-C9397E711729}"/>
               </a:ext>
             </a:extLst>
           </p:cNvPr>
@@ -15792,7 +15792,7 @@
           <p:cNvPr id="18" name="TextBox 17">
             <a:extLst>
               <a:ext uri="{FF2B5EF4-FFF2-40B4-BE49-F238E27FC236}">
-                <a16:creationId xmlns:a16="http://schemas.microsoft.com/office/drawing/2014/main" id="{1E126041-6BE2-154F-3DE7-442723544742}"/>
+                <a16:creationId xmlns:a16="http://schemas.microsoft.com/office/drawing/2014/main" id="{4DE94EA0-9FC4-206C-1D89-00C6CFC0A1FE}"/>
               </a:ext>
             </a:extLst>
           </p:cNvPr>
@@ -15832,7 +15832,7 @@
           <p:cNvPr id="19" name="TextBox 18">
             <a:extLst>
               <a:ext uri="{FF2B5EF4-FFF2-40B4-BE49-F238E27FC236}">
-                <a16:creationId xmlns:a16="http://schemas.microsoft.com/office/drawing/2014/main" id="{AB127C8D-3F49-AEA2-1E27-4BF7A9C2F738}"/>
+                <a16:creationId xmlns:a16="http://schemas.microsoft.com/office/drawing/2014/main" id="{A9183F10-2830-3C94-8A73-C6EABC44E31E}"/>
               </a:ext>
             </a:extLst>
           </p:cNvPr>
@@ -15872,7 +15872,7 @@
           <p:cNvPr id="20" name="TextBox 19">
             <a:extLst>
               <a:ext uri="{FF2B5EF4-FFF2-40B4-BE49-F238E27FC236}">
-                <a16:creationId xmlns:a16="http://schemas.microsoft.com/office/drawing/2014/main" id="{B1194697-314F-1BBD-89D5-25CDEE3C0949}"/>
+                <a16:creationId xmlns:a16="http://schemas.microsoft.com/office/drawing/2014/main" id="{B84D921F-24D1-659D-B164-8DFBC9786079}"/>
               </a:ext>
             </a:extLst>
           </p:cNvPr>
@@ -15912,7 +15912,7 @@
           <p:cNvPr id="21" name="TextBox 20">
             <a:extLst>
               <a:ext uri="{FF2B5EF4-FFF2-40B4-BE49-F238E27FC236}">
-                <a16:creationId xmlns:a16="http://schemas.microsoft.com/office/drawing/2014/main" id="{3C3C0C23-BE99-FF59-9A54-CF5604E47B5F}"/>
+                <a16:creationId xmlns:a16="http://schemas.microsoft.com/office/drawing/2014/main" id="{BC672F92-45F1-1A25-33FB-722777835CE1}"/>
               </a:ext>
             </a:extLst>
           </p:cNvPr>
@@ -15952,7 +15952,7 @@
           <p:cNvPr id="22" name="TextBox 21">
             <a:extLst>
               <a:ext uri="{FF2B5EF4-FFF2-40B4-BE49-F238E27FC236}">
-                <a16:creationId xmlns:a16="http://schemas.microsoft.com/office/drawing/2014/main" id="{75B6973D-4F50-4DD4-D7A5-E70A0E97B928}"/>
+                <a16:creationId xmlns:a16="http://schemas.microsoft.com/office/drawing/2014/main" id="{C6FEDA27-DC82-060F-EE0B-18FE89315732}"/>
               </a:ext>
             </a:extLst>
           </p:cNvPr>
@@ -15992,7 +15992,7 @@
           <p:cNvPr id="23" name="Rectangle 22">
             <a:extLst>
               <a:ext uri="{FF2B5EF4-FFF2-40B4-BE49-F238E27FC236}">
-                <a16:creationId xmlns:a16="http://schemas.microsoft.com/office/drawing/2014/main" id="{61B941D1-669C-DC02-4A56-FE9CDD04DD00}"/>
+                <a16:creationId xmlns:a16="http://schemas.microsoft.com/office/drawing/2014/main" id="{1B2A3F1F-E604-9E1A-1372-2477A8E66255}"/>
               </a:ext>
             </a:extLst>
           </p:cNvPr>
@@ -16060,7 +16060,7 @@
           <p:cNvPr id="24" name="TextBox 23">
             <a:extLst>
               <a:ext uri="{FF2B5EF4-FFF2-40B4-BE49-F238E27FC236}">
-                <a16:creationId xmlns:a16="http://schemas.microsoft.com/office/drawing/2014/main" id="{97A82185-D944-1DC7-C4EE-2DC16E759CB1}"/>
+                <a16:creationId xmlns:a16="http://schemas.microsoft.com/office/drawing/2014/main" id="{65B050F9-74FE-51A6-822B-C49243441C43}"/>
               </a:ext>
             </a:extLst>
           </p:cNvPr>
@@ -16100,7 +16100,7 @@
           <p:cNvPr id="25" name="TextBox 24">
             <a:extLst>
               <a:ext uri="{FF2B5EF4-FFF2-40B4-BE49-F238E27FC236}">
-                <a16:creationId xmlns:a16="http://schemas.microsoft.com/office/drawing/2014/main" id="{11CDEB34-6371-84C9-63F9-11B5FC531DD0}"/>
+                <a16:creationId xmlns:a16="http://schemas.microsoft.com/office/drawing/2014/main" id="{7AB344B2-A531-1F94-AB06-A65137FAB785}"/>
               </a:ext>
             </a:extLst>
           </p:cNvPr>
@@ -16140,7 +16140,7 @@
           <p:cNvPr id="26" name="TextBox 25">
             <a:extLst>
               <a:ext uri="{FF2B5EF4-FFF2-40B4-BE49-F238E27FC236}">
-                <a16:creationId xmlns:a16="http://schemas.microsoft.com/office/drawing/2014/main" id="{D5569269-C110-5D5A-7C6D-41712AAB8C7E}"/>
+                <a16:creationId xmlns:a16="http://schemas.microsoft.com/office/drawing/2014/main" id="{1E7FB926-64E3-AA8D-2789-9F3A406ECE11}"/>
               </a:ext>
             </a:extLst>
           </p:cNvPr>
@@ -16180,7 +16180,7 @@
           <p:cNvPr id="27" name="TextBox 26">
             <a:extLst>
               <a:ext uri="{FF2B5EF4-FFF2-40B4-BE49-F238E27FC236}">
-                <a16:creationId xmlns:a16="http://schemas.microsoft.com/office/drawing/2014/main" id="{2C94A6D8-CB09-A6EC-147E-AA9629E954FD}"/>
+                <a16:creationId xmlns:a16="http://schemas.microsoft.com/office/drawing/2014/main" id="{D9530C10-3CD3-ADE9-D36E-7D9C82B96F9C}"/>
               </a:ext>
             </a:extLst>
           </p:cNvPr>
@@ -16220,7 +16220,7 @@
           <p:cNvPr id="28" name="TextBox 27">
             <a:extLst>
               <a:ext uri="{FF2B5EF4-FFF2-40B4-BE49-F238E27FC236}">
-                <a16:creationId xmlns:a16="http://schemas.microsoft.com/office/drawing/2014/main" id="{53D1FF82-E417-C985-38DA-F37F9EAACC36}"/>
+                <a16:creationId xmlns:a16="http://schemas.microsoft.com/office/drawing/2014/main" id="{A5327183-F4B6-9854-873D-4761C8B9087F}"/>
               </a:ext>
             </a:extLst>
           </p:cNvPr>
@@ -16260,7 +16260,7 @@
           <p:cNvPr id="29" name="Straight Connector 28">
             <a:extLst>
               <a:ext uri="{FF2B5EF4-FFF2-40B4-BE49-F238E27FC236}">
-                <a16:creationId xmlns:a16="http://schemas.microsoft.com/office/drawing/2014/main" id="{D45B465A-7FB4-820B-A348-6258BA472A08}"/>
+                <a16:creationId xmlns:a16="http://schemas.microsoft.com/office/drawing/2014/main" id="{2AB96E56-86A3-7822-D5EC-F0FEA268864C}"/>
               </a:ext>
             </a:extLst>
           </p:cNvPr>
@@ -16301,7 +16301,7 @@
           <p:cNvPr id="30" name="TextBox 29">
             <a:extLst>
               <a:ext uri="{FF2B5EF4-FFF2-40B4-BE49-F238E27FC236}">
-                <a16:creationId xmlns:a16="http://schemas.microsoft.com/office/drawing/2014/main" id="{67C3264D-83FC-DE6A-B46D-3BFB0526F8DD}"/>
+                <a16:creationId xmlns:a16="http://schemas.microsoft.com/office/drawing/2014/main" id="{5833C62B-878C-315B-E4DD-B5BAE29FEB27}"/>
               </a:ext>
             </a:extLst>
           </p:cNvPr>
@@ -16341,7 +16341,7 @@
           <p:cNvPr id="31" name="TextBox 30">
             <a:extLst>
               <a:ext uri="{FF2B5EF4-FFF2-40B4-BE49-F238E27FC236}">
-                <a16:creationId xmlns:a16="http://schemas.microsoft.com/office/drawing/2014/main" id="{860E62C5-D5EA-CBA0-64FD-1970FE5B2970}"/>
+                <a16:creationId xmlns:a16="http://schemas.microsoft.com/office/drawing/2014/main" id="{F8193FFB-F779-18D6-28D4-E818C8E302A7}"/>
               </a:ext>
             </a:extLst>
           </p:cNvPr>
@@ -16381,7 +16381,7 @@
           <p:cNvPr id="32" name="Rectangle: Rounded Corners 31">
             <a:extLst>
               <a:ext uri="{FF2B5EF4-FFF2-40B4-BE49-F238E27FC236}">
-                <a16:creationId xmlns:a16="http://schemas.microsoft.com/office/drawing/2014/main" id="{2F3A5632-D253-D26C-81CC-C7EB9384FD42}"/>
+                <a16:creationId xmlns:a16="http://schemas.microsoft.com/office/drawing/2014/main" id="{ED88743F-E793-7EB2-6F19-DE2B7A4DBBD0}"/>
               </a:ext>
             </a:extLst>
           </p:cNvPr>
@@ -16435,7 +16435,7 @@
           <p:cNvPr id="33" name="TextBox 32">
             <a:extLst>
               <a:ext uri="{FF2B5EF4-FFF2-40B4-BE49-F238E27FC236}">
-                <a16:creationId xmlns:a16="http://schemas.microsoft.com/office/drawing/2014/main" id="{95B25183-234C-ABB3-ADE2-7058AE9DF211}"/>
+                <a16:creationId xmlns:a16="http://schemas.microsoft.com/office/drawing/2014/main" id="{10E9B67C-1D4B-0670-30FB-34E953DA8BC8}"/>
               </a:ext>
             </a:extLst>
           </p:cNvPr>
@@ -16476,7 +16476,7 @@
           <p:cNvPr id="34" name="TextBox 33">
             <a:extLst>
               <a:ext uri="{FF2B5EF4-FFF2-40B4-BE49-F238E27FC236}">
-                <a16:creationId xmlns:a16="http://schemas.microsoft.com/office/drawing/2014/main" id="{984333B9-C1BF-72F7-26C3-5C8407EB1864}"/>
+                <a16:creationId xmlns:a16="http://schemas.microsoft.com/office/drawing/2014/main" id="{FB37BA8B-F1D7-1515-A968-DD8DE8DF2325}"/>
               </a:ext>
             </a:extLst>
           </p:cNvPr>
@@ -16515,7 +16515,7 @@
     </p:spTree>
     <p:extLst>
       <p:ext uri="{BB962C8B-B14F-4D97-AF65-F5344CB8AC3E}">
-        <p14:creationId xmlns:p14="http://schemas.microsoft.com/office/powerpoint/2010/main" val="2619035176"/>
+        <p14:creationId xmlns:p14="http://schemas.microsoft.com/office/powerpoint/2010/main" val="1156898284"/>
       </p:ext>
     </p:extLst>
   </p:cSld>
@@ -16555,7 +16555,7 @@
           <p:cNvPr id="2" name="TextBox 1">
             <a:extLst>
               <a:ext uri="{FF2B5EF4-FFF2-40B4-BE49-F238E27FC236}">
-                <a16:creationId xmlns:a16="http://schemas.microsoft.com/office/drawing/2014/main" id="{02F2289F-5D96-8F67-F470-41D0892AF958}"/>
+                <a16:creationId xmlns:a16="http://schemas.microsoft.com/office/drawing/2014/main" id="{2B66764D-CA72-04D2-5CEE-0E4005B47E2A}"/>
               </a:ext>
             </a:extLst>
           </p:cNvPr>
@@ -16595,7 +16595,7 @@
           <p:cNvPr id="3" name="Straight Connector 2">
             <a:extLst>
               <a:ext uri="{FF2B5EF4-FFF2-40B4-BE49-F238E27FC236}">
-                <a16:creationId xmlns:a16="http://schemas.microsoft.com/office/drawing/2014/main" id="{41BA6DC8-3C60-C553-4C24-43A0DC9398E7}"/>
+                <a16:creationId xmlns:a16="http://schemas.microsoft.com/office/drawing/2014/main" id="{045C2F5C-75C2-1AEC-6BE2-7B3AEB065674}"/>
               </a:ext>
             </a:extLst>
           </p:cNvPr>
@@ -16636,7 +16636,7 @@
           <p:cNvPr id="4" name="TextBox 3">
             <a:extLst>
               <a:ext uri="{FF2B5EF4-FFF2-40B4-BE49-F238E27FC236}">
-                <a16:creationId xmlns:a16="http://schemas.microsoft.com/office/drawing/2014/main" id="{C4DC51B1-A895-D9F6-779B-3EFDD7B07653}"/>
+                <a16:creationId xmlns:a16="http://schemas.microsoft.com/office/drawing/2014/main" id="{0DF05806-84A3-5B46-D22B-C3F31E9293A9}"/>
               </a:ext>
             </a:extLst>
           </p:cNvPr>
@@ -16677,7 +16677,7 @@
           <p:cNvPr id="5" name="TextBox 4">
             <a:extLst>
               <a:ext uri="{FF2B5EF4-FFF2-40B4-BE49-F238E27FC236}">
-                <a16:creationId xmlns:a16="http://schemas.microsoft.com/office/drawing/2014/main" id="{3F691468-F313-2AC7-34AC-FC044932E7B5}"/>
+                <a16:creationId xmlns:a16="http://schemas.microsoft.com/office/drawing/2014/main" id="{A5BF1126-F851-7E14-9359-1CF851A1C429}"/>
               </a:ext>
             </a:extLst>
           </p:cNvPr>
@@ -16717,7 +16717,7 @@
           <p:cNvPr id="6" name="TextBox 5">
             <a:extLst>
               <a:ext uri="{FF2B5EF4-FFF2-40B4-BE49-F238E27FC236}">
-                <a16:creationId xmlns:a16="http://schemas.microsoft.com/office/drawing/2014/main" id="{8ED930EA-4BEA-0037-9925-505452738F7E}"/>
+                <a16:creationId xmlns:a16="http://schemas.microsoft.com/office/drawing/2014/main" id="{2936C610-2B3D-0B97-6266-D3FA007ED8F6}"/>
               </a:ext>
             </a:extLst>
           </p:cNvPr>
@@ -16757,7 +16757,7 @@
           <p:cNvPr id="7" name="TextBox 6">
             <a:extLst>
               <a:ext uri="{FF2B5EF4-FFF2-40B4-BE49-F238E27FC236}">
-                <a16:creationId xmlns:a16="http://schemas.microsoft.com/office/drawing/2014/main" id="{08988387-ED45-F04F-630C-B62084C025EF}"/>
+                <a16:creationId xmlns:a16="http://schemas.microsoft.com/office/drawing/2014/main" id="{06D431E3-0E3D-DE3E-566E-B172655BE8B8}"/>
               </a:ext>
             </a:extLst>
           </p:cNvPr>
@@ -16797,7 +16797,7 @@
           <p:cNvPr id="8" name="TextBox 7">
             <a:extLst>
               <a:ext uri="{FF2B5EF4-FFF2-40B4-BE49-F238E27FC236}">
-                <a16:creationId xmlns:a16="http://schemas.microsoft.com/office/drawing/2014/main" id="{FD8667DD-86E0-717F-A292-0647D3B1EFFE}"/>
+                <a16:creationId xmlns:a16="http://schemas.microsoft.com/office/drawing/2014/main" id="{4379B0F1-2BC8-5E84-EACE-67F7B4B52D6B}"/>
               </a:ext>
             </a:extLst>
           </p:cNvPr>
@@ -16837,7 +16837,7 @@
           <p:cNvPr id="9" name="Rectangle: Rounded Corners 8">
             <a:extLst>
               <a:ext uri="{FF2B5EF4-FFF2-40B4-BE49-F238E27FC236}">
-                <a16:creationId xmlns:a16="http://schemas.microsoft.com/office/drawing/2014/main" id="{434B5E6B-858C-1E9E-CB7A-23E49900BAFD}"/>
+                <a16:creationId xmlns:a16="http://schemas.microsoft.com/office/drawing/2014/main" id="{60189D1C-9C7F-6A7F-F51E-A366A2B9CE56}"/>
               </a:ext>
             </a:extLst>
           </p:cNvPr>
@@ -16905,7 +16905,7 @@
           <p:cNvPr id="10" name="TextBox 9">
             <a:extLst>
               <a:ext uri="{FF2B5EF4-FFF2-40B4-BE49-F238E27FC236}">
-                <a16:creationId xmlns:a16="http://schemas.microsoft.com/office/drawing/2014/main" id="{758687F6-5077-8763-1583-13D373AEE1DB}"/>
+                <a16:creationId xmlns:a16="http://schemas.microsoft.com/office/drawing/2014/main" id="{160FB6FC-D84E-9EE1-E76C-6F4E9B726EF2}"/>
               </a:ext>
             </a:extLst>
           </p:cNvPr>
@@ -16946,7 +16946,7 @@
           <p:cNvPr id="11" name="TextBox 10">
             <a:extLst>
               <a:ext uri="{FF2B5EF4-FFF2-40B4-BE49-F238E27FC236}">
-                <a16:creationId xmlns:a16="http://schemas.microsoft.com/office/drawing/2014/main" id="{F65CE052-8915-CCB9-AD0A-D4834D4E3375}"/>
+                <a16:creationId xmlns:a16="http://schemas.microsoft.com/office/drawing/2014/main" id="{E1CD3CEA-31CE-5FCF-CDDF-2E7B929BB196}"/>
               </a:ext>
             </a:extLst>
           </p:cNvPr>
@@ -16987,7 +16987,7 @@
           <p:cNvPr id="12" name="Rectangle: Rounded Corners 11">
             <a:extLst>
               <a:ext uri="{FF2B5EF4-FFF2-40B4-BE49-F238E27FC236}">
-                <a16:creationId xmlns:a16="http://schemas.microsoft.com/office/drawing/2014/main" id="{81CF20A2-FB4C-9B1E-4A09-488498961996}"/>
+                <a16:creationId xmlns:a16="http://schemas.microsoft.com/office/drawing/2014/main" id="{CA0C30B6-D29E-9D81-2DDF-63BDBA47701F}"/>
               </a:ext>
             </a:extLst>
           </p:cNvPr>
@@ -17055,7 +17055,7 @@
           <p:cNvPr id="13" name="TextBox 12">
             <a:extLst>
               <a:ext uri="{FF2B5EF4-FFF2-40B4-BE49-F238E27FC236}">
-                <a16:creationId xmlns:a16="http://schemas.microsoft.com/office/drawing/2014/main" id="{5F42AAF1-2FB0-9D81-68B0-E31FC6118900}"/>
+                <a16:creationId xmlns:a16="http://schemas.microsoft.com/office/drawing/2014/main" id="{80599EBD-7BF6-CACE-FBA4-EDAF18F9A515}"/>
               </a:ext>
             </a:extLst>
           </p:cNvPr>
@@ -17096,7 +17096,7 @@
           <p:cNvPr id="14" name="TextBox 13">
             <a:extLst>
               <a:ext uri="{FF2B5EF4-FFF2-40B4-BE49-F238E27FC236}">
-                <a16:creationId xmlns:a16="http://schemas.microsoft.com/office/drawing/2014/main" id="{F434C120-E9CE-1020-546B-0AAB40E53060}"/>
+                <a16:creationId xmlns:a16="http://schemas.microsoft.com/office/drawing/2014/main" id="{9D776C5F-B47A-7850-6AD1-4012775267B7}"/>
               </a:ext>
             </a:extLst>
           </p:cNvPr>
@@ -17137,7 +17137,7 @@
           <p:cNvPr id="15" name="Rectangle: Rounded Corners 14">
             <a:extLst>
               <a:ext uri="{FF2B5EF4-FFF2-40B4-BE49-F238E27FC236}">
-                <a16:creationId xmlns:a16="http://schemas.microsoft.com/office/drawing/2014/main" id="{67E81205-374C-C351-25A8-549F17E339E0}"/>
+                <a16:creationId xmlns:a16="http://schemas.microsoft.com/office/drawing/2014/main" id="{50AE39D1-C831-657E-584F-18C0FA5DF3E9}"/>
               </a:ext>
             </a:extLst>
           </p:cNvPr>
@@ -17205,7 +17205,7 @@
           <p:cNvPr id="16" name="TextBox 15">
             <a:extLst>
               <a:ext uri="{FF2B5EF4-FFF2-40B4-BE49-F238E27FC236}">
-                <a16:creationId xmlns:a16="http://schemas.microsoft.com/office/drawing/2014/main" id="{D9A47689-1CAA-AFDD-310F-22F76ADAF80B}"/>
+                <a16:creationId xmlns:a16="http://schemas.microsoft.com/office/drawing/2014/main" id="{BE54957B-F70B-FECE-C225-36BE9AC29696}"/>
               </a:ext>
             </a:extLst>
           </p:cNvPr>
@@ -17246,7 +17246,7 @@
           <p:cNvPr id="17" name="TextBox 16">
             <a:extLst>
               <a:ext uri="{FF2B5EF4-FFF2-40B4-BE49-F238E27FC236}">
-                <a16:creationId xmlns:a16="http://schemas.microsoft.com/office/drawing/2014/main" id="{7EB5C9DF-7548-9EF6-14F9-B599C249E983}"/>
+                <a16:creationId xmlns:a16="http://schemas.microsoft.com/office/drawing/2014/main" id="{09EBF550-F7E3-083F-95AA-5673CD2CEB5E}"/>
               </a:ext>
             </a:extLst>
           </p:cNvPr>
@@ -17287,7 +17287,7 @@
           <p:cNvPr id="18" name="TextBox 17">
             <a:extLst>
               <a:ext uri="{FF2B5EF4-FFF2-40B4-BE49-F238E27FC236}">
-                <a16:creationId xmlns:a16="http://schemas.microsoft.com/office/drawing/2014/main" id="{49726E6A-4625-AACE-2432-97C5BDA7819E}"/>
+                <a16:creationId xmlns:a16="http://schemas.microsoft.com/office/drawing/2014/main" id="{C1EEA568-1F7C-4803-46DF-F62F40C57B07}"/>
               </a:ext>
             </a:extLst>
           </p:cNvPr>
@@ -17327,7 +17327,7 @@
           <p:cNvPr id="19" name="TextBox 18">
             <a:extLst>
               <a:ext uri="{FF2B5EF4-FFF2-40B4-BE49-F238E27FC236}">
-                <a16:creationId xmlns:a16="http://schemas.microsoft.com/office/drawing/2014/main" id="{1B0D7941-7584-DB21-2BC4-09A76EF0D671}"/>
+                <a16:creationId xmlns:a16="http://schemas.microsoft.com/office/drawing/2014/main" id="{7373CC13-7BBF-CD60-CA63-10C60AFF041D}"/>
               </a:ext>
             </a:extLst>
           </p:cNvPr>
@@ -17373,7 +17373,7 @@
           <p:cNvPr id="20" name="TextBox 19">
             <a:extLst>
               <a:ext uri="{FF2B5EF4-FFF2-40B4-BE49-F238E27FC236}">
-                <a16:creationId xmlns:a16="http://schemas.microsoft.com/office/drawing/2014/main" id="{CEE046EB-E763-0763-0CE4-A111AEF127E2}"/>
+                <a16:creationId xmlns:a16="http://schemas.microsoft.com/office/drawing/2014/main" id="{30410256-80A5-9D38-A497-115D7806CF77}"/>
               </a:ext>
             </a:extLst>
           </p:cNvPr>
@@ -17411,7 +17411,7 @@
     </p:spTree>
     <p:extLst>
       <p:ext uri="{BB962C8B-B14F-4D97-AF65-F5344CB8AC3E}">
-        <p14:creationId xmlns:p14="http://schemas.microsoft.com/office/powerpoint/2010/main" val="237364489"/>
+        <p14:creationId xmlns:p14="http://schemas.microsoft.com/office/powerpoint/2010/main" val="78764034"/>
       </p:ext>
     </p:extLst>
   </p:cSld>

</xml_diff>